<commit_message>
Simplify pre-setup to clone and run setup
</commit_message>
<xml_diff>
--- a/presentation/falco-libs-intro.pptx
+++ b/presentation/falco-libs-intro.pptx
@@ -2,84 +2,84 @@
 <file path=ppt/presentation.xml><?xml version="1.0" encoding="utf-8"?>
 <p:presentation xmlns:p="http://schemas.openxmlformats.org/presentationml/2006/main" embedTrueTypeFonts="1" saveSubsetFonts="0">
   <p:sldMasterIdLst>
-    <p:sldMasterId xmlns:r="http://schemas.openxmlformats.org/officeDocument/2006/relationships" id="2147483648" r:id="Rb56f5bd12f024a86"/>
-    <p:sldMasterId xmlns:r="http://schemas.openxmlformats.org/officeDocument/2006/relationships" id="2147483661" r:id="R2b8b3d3879454bec"/>
+    <p:sldMasterId xmlns:r="http://schemas.openxmlformats.org/officeDocument/2006/relationships" id="2147483648" r:id="R6d1e8ddd8f524132"/>
+    <p:sldMasterId xmlns:r="http://schemas.openxmlformats.org/officeDocument/2006/relationships" id="2147483661" r:id="R0b174aae05dd40d8"/>
   </p:sldMasterIdLst>
   <p:notesMasterIdLst>
-    <p:notesMasterId xmlns:r="http://schemas.openxmlformats.org/officeDocument/2006/relationships" r:id="Rd6216d4e1ba94bc3"/>
+    <p:notesMasterId xmlns:r="http://schemas.openxmlformats.org/officeDocument/2006/relationships" r:id="R4d7c6a8aaf774bc0"/>
   </p:notesMasterIdLst>
   <p:sldIdLst>
-    <p:sldId xmlns:r="http://schemas.openxmlformats.org/officeDocument/2006/relationships" id="256" r:id="R6a61cb0714aa41a8"/>
-    <p:sldId xmlns:r="http://schemas.openxmlformats.org/officeDocument/2006/relationships" id="257" r:id="R145c3f9168764090"/>
-    <p:sldId xmlns:r="http://schemas.openxmlformats.org/officeDocument/2006/relationships" id="258" r:id="Rad7447886d854282"/>
-    <p:sldId xmlns:r="http://schemas.openxmlformats.org/officeDocument/2006/relationships" id="259" r:id="R51c253a7e9794463"/>
-    <p:sldId xmlns:r="http://schemas.openxmlformats.org/officeDocument/2006/relationships" id="260" r:id="R02c777e7f5ff492f"/>
-    <p:sldId xmlns:r="http://schemas.openxmlformats.org/officeDocument/2006/relationships" id="261" r:id="Reb90b5326ef64ebd"/>
-    <p:sldId xmlns:r="http://schemas.openxmlformats.org/officeDocument/2006/relationships" id="262" r:id="Rdc5f02b2fda54c5f"/>
-    <p:sldId xmlns:r="http://schemas.openxmlformats.org/officeDocument/2006/relationships" id="263" r:id="R2247ab5763b448b6"/>
-    <p:sldId xmlns:r="http://schemas.openxmlformats.org/officeDocument/2006/relationships" id="264" r:id="Rc2d6c38aa3ff43df"/>
-    <p:sldId xmlns:r="http://schemas.openxmlformats.org/officeDocument/2006/relationships" id="265" r:id="R978af54719324f0e"/>
-    <p:sldId xmlns:r="http://schemas.openxmlformats.org/officeDocument/2006/relationships" id="266" r:id="R2dfb050360c54eaa"/>
-    <p:sldId xmlns:r="http://schemas.openxmlformats.org/officeDocument/2006/relationships" id="267" r:id="R957f045a11544c32"/>
-    <p:sldId xmlns:r="http://schemas.openxmlformats.org/officeDocument/2006/relationships" id="268" r:id="R7dde7e8e7e624070"/>
-    <p:sldId xmlns:r="http://schemas.openxmlformats.org/officeDocument/2006/relationships" id="269" r:id="R4549eb91efc74873"/>
-    <p:sldId xmlns:r="http://schemas.openxmlformats.org/officeDocument/2006/relationships" id="270" r:id="R878633e0b1514a1b"/>
-    <p:sldId xmlns:r="http://schemas.openxmlformats.org/officeDocument/2006/relationships" id="271" r:id="R2faa352606614bac"/>
-    <p:sldId xmlns:r="http://schemas.openxmlformats.org/officeDocument/2006/relationships" id="272" r:id="Rd62bc4d0512b4671"/>
-    <p:sldId xmlns:r="http://schemas.openxmlformats.org/officeDocument/2006/relationships" id="273" r:id="Rbaf3dfa88c4b458a"/>
-    <p:sldId xmlns:r="http://schemas.openxmlformats.org/officeDocument/2006/relationships" id="274" r:id="R33d10aa141024375"/>
-    <p:sldId xmlns:r="http://schemas.openxmlformats.org/officeDocument/2006/relationships" id="275" r:id="R3062af7737584666"/>
+    <p:sldId xmlns:r="http://schemas.openxmlformats.org/officeDocument/2006/relationships" id="256" r:id="Rc84d2982e2a04242"/>
+    <p:sldId xmlns:r="http://schemas.openxmlformats.org/officeDocument/2006/relationships" id="257" r:id="R025ce0882d2b4cfe"/>
+    <p:sldId xmlns:r="http://schemas.openxmlformats.org/officeDocument/2006/relationships" id="258" r:id="R01b102d06b6349ab"/>
+    <p:sldId xmlns:r="http://schemas.openxmlformats.org/officeDocument/2006/relationships" id="259" r:id="R187adf284557433f"/>
+    <p:sldId xmlns:r="http://schemas.openxmlformats.org/officeDocument/2006/relationships" id="260" r:id="Rc7864bd384744261"/>
+    <p:sldId xmlns:r="http://schemas.openxmlformats.org/officeDocument/2006/relationships" id="261" r:id="R3fad38a2a0a54587"/>
+    <p:sldId xmlns:r="http://schemas.openxmlformats.org/officeDocument/2006/relationships" id="262" r:id="R5ddd86170428449c"/>
+    <p:sldId xmlns:r="http://schemas.openxmlformats.org/officeDocument/2006/relationships" id="263" r:id="R7c871f8be2004167"/>
+    <p:sldId xmlns:r="http://schemas.openxmlformats.org/officeDocument/2006/relationships" id="264" r:id="R86afd6f624f047f5"/>
+    <p:sldId xmlns:r="http://schemas.openxmlformats.org/officeDocument/2006/relationships" id="265" r:id="R123cbc70863d4176"/>
+    <p:sldId xmlns:r="http://schemas.openxmlformats.org/officeDocument/2006/relationships" id="266" r:id="R5dc3baf7ea424c1f"/>
+    <p:sldId xmlns:r="http://schemas.openxmlformats.org/officeDocument/2006/relationships" id="267" r:id="R901ca2bc9dd74456"/>
+    <p:sldId xmlns:r="http://schemas.openxmlformats.org/officeDocument/2006/relationships" id="268" r:id="Re7952a4dd91a4bed"/>
+    <p:sldId xmlns:r="http://schemas.openxmlformats.org/officeDocument/2006/relationships" id="269" r:id="R2e5005ded90f4d52"/>
+    <p:sldId xmlns:r="http://schemas.openxmlformats.org/officeDocument/2006/relationships" id="270" r:id="R877f4c135d1c47dc"/>
+    <p:sldId xmlns:r="http://schemas.openxmlformats.org/officeDocument/2006/relationships" id="271" r:id="R999137ad83ba41f4"/>
+    <p:sldId xmlns:r="http://schemas.openxmlformats.org/officeDocument/2006/relationships" id="272" r:id="Ra9dca54c5ca94c02"/>
+    <p:sldId xmlns:r="http://schemas.openxmlformats.org/officeDocument/2006/relationships" id="273" r:id="R474f6dbae9564ea2"/>
+    <p:sldId xmlns:r="http://schemas.openxmlformats.org/officeDocument/2006/relationships" id="274" r:id="R76ddb242f244481a"/>
+    <p:sldId xmlns:r="http://schemas.openxmlformats.org/officeDocument/2006/relationships" id="275" r:id="R6388ff867bd34426"/>
   </p:sldIdLst>
   <p:sldSz cx="9144000" cy="5143500"/>
   <p:notesSz cx="6858000" cy="9144000"/>
   <p:embeddedFontLst>
     <p:embeddedFont>
       <p:font typeface="Roboto Mono Medium"/>
-      <p:regular xmlns:r="http://schemas.openxmlformats.org/officeDocument/2006/relationships" r:id="R81bacc9061af4d58"/>
-      <p:bold xmlns:r="http://schemas.openxmlformats.org/officeDocument/2006/relationships" r:id="R0973c8d5d88a48a4"/>
-      <p:italic xmlns:r="http://schemas.openxmlformats.org/officeDocument/2006/relationships" r:id="R806bc3a69bac4ed6"/>
-      <p:boldItalic xmlns:r="http://schemas.openxmlformats.org/officeDocument/2006/relationships" r:id="R704cc0995c7942d2"/>
+      <p:regular xmlns:r="http://schemas.openxmlformats.org/officeDocument/2006/relationships" r:id="Rf2b03e6897784050"/>
+      <p:bold xmlns:r="http://schemas.openxmlformats.org/officeDocument/2006/relationships" r:id="Re8aa632db29c4432"/>
+      <p:italic xmlns:r="http://schemas.openxmlformats.org/officeDocument/2006/relationships" r:id="R7911258dfe7d42cc"/>
+      <p:boldItalic xmlns:r="http://schemas.openxmlformats.org/officeDocument/2006/relationships" r:id="R76ed7b64e8f843eb"/>
     </p:embeddedFont>
     <p:embeddedFont>
       <p:font typeface="Inter SemiBold"/>
-      <p:regular xmlns:r="http://schemas.openxmlformats.org/officeDocument/2006/relationships" r:id="Re29c6e0cb02f4d24"/>
-      <p:bold xmlns:r="http://schemas.openxmlformats.org/officeDocument/2006/relationships" r:id="R5f02e2eb37474a2d"/>
-      <p:italic xmlns:r="http://schemas.openxmlformats.org/officeDocument/2006/relationships" r:id="R54d84be7288c4d4a"/>
-      <p:boldItalic xmlns:r="http://schemas.openxmlformats.org/officeDocument/2006/relationships" r:id="Rc49329462c824ea6"/>
+      <p:regular xmlns:r="http://schemas.openxmlformats.org/officeDocument/2006/relationships" r:id="Rf75e97740cc3416c"/>
+      <p:bold xmlns:r="http://schemas.openxmlformats.org/officeDocument/2006/relationships" r:id="R131a7b8a94224790"/>
+      <p:italic xmlns:r="http://schemas.openxmlformats.org/officeDocument/2006/relationships" r:id="R9dccd8f656a14db0"/>
+      <p:boldItalic xmlns:r="http://schemas.openxmlformats.org/officeDocument/2006/relationships" r:id="R4d64be2fbe4540fe"/>
     </p:embeddedFont>
     <p:embeddedFont>
       <p:font typeface="Montserrat Black"/>
-      <p:bold xmlns:r="http://schemas.openxmlformats.org/officeDocument/2006/relationships" r:id="Rebca71983ce94e3e"/>
-      <p:boldItalic xmlns:r="http://schemas.openxmlformats.org/officeDocument/2006/relationships" r:id="R27bba668e0ef4b7f"/>
+      <p:bold xmlns:r="http://schemas.openxmlformats.org/officeDocument/2006/relationships" r:id="R261888204471460b"/>
+      <p:boldItalic xmlns:r="http://schemas.openxmlformats.org/officeDocument/2006/relationships" r:id="R3104a03719ac49b6"/>
     </p:embeddedFont>
     <p:embeddedFont>
       <p:font typeface="Montserrat"/>
-      <p:bold xmlns:r="http://schemas.openxmlformats.org/officeDocument/2006/relationships" r:id="R358bafc2edf04fc8"/>
-      <p:boldItalic xmlns:r="http://schemas.openxmlformats.org/officeDocument/2006/relationships" r:id="Rec95301b6fa542f3"/>
+      <p:bold xmlns:r="http://schemas.openxmlformats.org/officeDocument/2006/relationships" r:id="R96346efa0c0e4e09"/>
+      <p:boldItalic xmlns:r="http://schemas.openxmlformats.org/officeDocument/2006/relationships" r:id="Ra5fc78d967ad4510"/>
     </p:embeddedFont>
     <p:embeddedFont>
       <p:font typeface="Inter"/>
-      <p:regular xmlns:r="http://schemas.openxmlformats.org/officeDocument/2006/relationships" r:id="R8803621239354553"/>
-      <p:bold xmlns:r="http://schemas.openxmlformats.org/officeDocument/2006/relationships" r:id="Ree2c254d20c846d6"/>
-      <p:italic xmlns:r="http://schemas.openxmlformats.org/officeDocument/2006/relationships" r:id="R8f30de0b6d924460"/>
-      <p:boldItalic xmlns:r="http://schemas.openxmlformats.org/officeDocument/2006/relationships" r:id="Rb7b9e9854c364f7e"/>
+      <p:regular xmlns:r="http://schemas.openxmlformats.org/officeDocument/2006/relationships" r:id="Rfff7fd6298084ead"/>
+      <p:bold xmlns:r="http://schemas.openxmlformats.org/officeDocument/2006/relationships" r:id="R42af310e5b28434a"/>
+      <p:italic xmlns:r="http://schemas.openxmlformats.org/officeDocument/2006/relationships" r:id="Rb09f28de92fb49d2"/>
+      <p:boldItalic xmlns:r="http://schemas.openxmlformats.org/officeDocument/2006/relationships" r:id="R5f2aef93150a458c"/>
     </p:embeddedFont>
     <p:embeddedFont>
       <p:font typeface="Montserrat ExtraBold"/>
-      <p:bold xmlns:r="http://schemas.openxmlformats.org/officeDocument/2006/relationships" r:id="R6382cb37f0ad4262"/>
-      <p:boldItalic xmlns:r="http://schemas.openxmlformats.org/officeDocument/2006/relationships" r:id="R45d046d105874bb2"/>
+      <p:bold xmlns:r="http://schemas.openxmlformats.org/officeDocument/2006/relationships" r:id="Rc329cce818d144b6"/>
+      <p:boldItalic xmlns:r="http://schemas.openxmlformats.org/officeDocument/2006/relationships" r:id="Ra1881ee61e0141e8"/>
     </p:embeddedFont>
     <p:embeddedFont>
       <p:font typeface="Roboto Mono"/>
-      <p:bold xmlns:r="http://schemas.openxmlformats.org/officeDocument/2006/relationships" r:id="Rc85186725f144d54"/>
-      <p:boldItalic xmlns:r="http://schemas.openxmlformats.org/officeDocument/2006/relationships" r:id="Rf863301a6439447b"/>
+      <p:bold xmlns:r="http://schemas.openxmlformats.org/officeDocument/2006/relationships" r:id="R6d8b97bc7c484d8b"/>
+      <p:boldItalic xmlns:r="http://schemas.openxmlformats.org/officeDocument/2006/relationships" r:id="Rb4ea4fa409774f99"/>
     </p:embeddedFont>
     <p:embeddedFont>
       <p:font typeface="Inter Medium"/>
-      <p:regular xmlns:r="http://schemas.openxmlformats.org/officeDocument/2006/relationships" r:id="R77243372862e4572"/>
-      <p:bold xmlns:r="http://schemas.openxmlformats.org/officeDocument/2006/relationships" r:id="R8c91ce59b2544e43"/>
-      <p:italic xmlns:r="http://schemas.openxmlformats.org/officeDocument/2006/relationships" r:id="R18dfc7d57f254259"/>
-      <p:boldItalic xmlns:r="http://schemas.openxmlformats.org/officeDocument/2006/relationships" r:id="Rbb7dd6e16ec647de"/>
+      <p:regular xmlns:r="http://schemas.openxmlformats.org/officeDocument/2006/relationships" r:id="R84888a143e4c4ec1"/>
+      <p:bold xmlns:r="http://schemas.openxmlformats.org/officeDocument/2006/relationships" r:id="R9936f43b4fc84563"/>
+      <p:italic xmlns:r="http://schemas.openxmlformats.org/officeDocument/2006/relationships" r:id="R4662df44d4ec460a"/>
+      <p:boldItalic xmlns:r="http://schemas.openxmlformats.org/officeDocument/2006/relationships" r:id="Rc144ac60595c4528"/>
     </p:embeddedFont>
   </p:embeddedFontLst>
 </p:presentation>
@@ -1424,7 +1424,7 @@
               <a:buNone/>
             </a:pPr>
             <a:r>
-              <a:t>Install Multipass from the link for your host, then run the host commands in Terminal on macOS or PowerShell on Windows. multipass shell switches you into Ubuntu. Run the remaining commands there. setup.sh installs the development tools; build.sh compiles the pinned libraries and agent. Wait for Ready, then Ctrl-C stops capture. Complete the first build before the session if possible. On Windows, enable Virtual Machine Platform and restart if the Multipass installer requests it. Sources: https://canonical.com/multipass/docs/latest/how-to-guides/install-multipass/ and https://canonical.com/multipass/docs/latest/reference/command-line-interface/launch/. Code: https://github.com/julianshalaby-perj/falco-libs-workshop.</a:t>
+              <a:t>Run the setup command for your host OS after cloning the repo. The script creates or starts the falco-lab Ubuntu VM, copies workshop code, installs dependencies, and builds the agent. Re-running setup preserves src/main.cpp in the VM. The Windows command applies its execution policy only to the new PowerShell process. On Windows, enable Virtual Machine Platform and restart if the Multipass installer requests it. Complete the first build before the workshop if possible. Sources: https://canonical.com/multipass/docs/latest/reference/command-line-interface/transfer/ and https://canonical.com/multipass/docs/latest/reference/command-line-interface/exec/.</a:t>
             </a:r>
             <a:endParaRPr/>
           </a:p>
@@ -6232,18 +6232,18 @@
   </p:cSld>
   <p:clrMap bg1="lt1" tx1="dk1" bg2="dk2" tx2="lt2" accent1="accent1" accent2="accent2" accent3="accent3" accent4="accent4" accent5="accent5" accent6="accent6" hlink="hlink" folHlink="folHlink"/>
   <p:sldLayoutIdLst>
-    <p:sldLayoutId xmlns:r="http://schemas.openxmlformats.org/officeDocument/2006/relationships" id="2147483649" r:id="R236af64321a14de6"/>
-    <p:sldLayoutId xmlns:r="http://schemas.openxmlformats.org/officeDocument/2006/relationships" id="2147483650" r:id="R1270d1021b45484e"/>
-    <p:sldLayoutId xmlns:r="http://schemas.openxmlformats.org/officeDocument/2006/relationships" id="2147483651" r:id="Re386160f11f642a7"/>
-    <p:sldLayoutId xmlns:r="http://schemas.openxmlformats.org/officeDocument/2006/relationships" id="2147483652" r:id="R85eb79a6cd9e4be5"/>
-    <p:sldLayoutId xmlns:r="http://schemas.openxmlformats.org/officeDocument/2006/relationships" id="2147483653" r:id="R5943feb7f3d747c6"/>
-    <p:sldLayoutId xmlns:r="http://schemas.openxmlformats.org/officeDocument/2006/relationships" id="2147483654" r:id="R53ce96eb259e4bf1"/>
-    <p:sldLayoutId xmlns:r="http://schemas.openxmlformats.org/officeDocument/2006/relationships" id="2147483655" r:id="R913bf553979d47ae"/>
-    <p:sldLayoutId xmlns:r="http://schemas.openxmlformats.org/officeDocument/2006/relationships" id="2147483656" r:id="Rb8aa5c9946724cc8"/>
-    <p:sldLayoutId xmlns:r="http://schemas.openxmlformats.org/officeDocument/2006/relationships" id="2147483657" r:id="R96c4edd286ed4dbe"/>
-    <p:sldLayoutId xmlns:r="http://schemas.openxmlformats.org/officeDocument/2006/relationships" id="2147483658" r:id="R02ccc52667b24ba2"/>
-    <p:sldLayoutId xmlns:r="http://schemas.openxmlformats.org/officeDocument/2006/relationships" id="2147483659" r:id="R30b21b852d4e4a6f"/>
-    <p:sldLayoutId xmlns:r="http://schemas.openxmlformats.org/officeDocument/2006/relationships" id="2147483660" r:id="R8dd50ee924824d07"/>
+    <p:sldLayoutId xmlns:r="http://schemas.openxmlformats.org/officeDocument/2006/relationships" id="2147483649" r:id="R332132589a1e40b4"/>
+    <p:sldLayoutId xmlns:r="http://schemas.openxmlformats.org/officeDocument/2006/relationships" id="2147483650" r:id="R4d4ac9faef12477f"/>
+    <p:sldLayoutId xmlns:r="http://schemas.openxmlformats.org/officeDocument/2006/relationships" id="2147483651" r:id="Rf95b168f542047a3"/>
+    <p:sldLayoutId xmlns:r="http://schemas.openxmlformats.org/officeDocument/2006/relationships" id="2147483652" r:id="R549634783fc54d40"/>
+    <p:sldLayoutId xmlns:r="http://schemas.openxmlformats.org/officeDocument/2006/relationships" id="2147483653" r:id="R5546ab44f1974f31"/>
+    <p:sldLayoutId xmlns:r="http://schemas.openxmlformats.org/officeDocument/2006/relationships" id="2147483654" r:id="R3565e223e8854e8e"/>
+    <p:sldLayoutId xmlns:r="http://schemas.openxmlformats.org/officeDocument/2006/relationships" id="2147483655" r:id="R56c4ad74f0fa4b09"/>
+    <p:sldLayoutId xmlns:r="http://schemas.openxmlformats.org/officeDocument/2006/relationships" id="2147483656" r:id="R69629e3474634b5d"/>
+    <p:sldLayoutId xmlns:r="http://schemas.openxmlformats.org/officeDocument/2006/relationships" id="2147483657" r:id="R9b7bd2cfadcb49da"/>
+    <p:sldLayoutId xmlns:r="http://schemas.openxmlformats.org/officeDocument/2006/relationships" id="2147483658" r:id="R37617df61fb34a89"/>
+    <p:sldLayoutId xmlns:r="http://schemas.openxmlformats.org/officeDocument/2006/relationships" id="2147483659" r:id="Re06c2aca604a45c0"/>
+    <p:sldLayoutId xmlns:r="http://schemas.openxmlformats.org/officeDocument/2006/relationships" id="2147483660" r:id="R4853984994254ebe"/>
   </p:sldLayoutIdLst>
   <p:hf sldNum="0" hdr="0" ftr="0" dt="0"/>
   <p:txStyles>
@@ -6928,7 +6928,7 @@
   </p:cSld>
   <p:clrMap bg1="lt1" tx1="dk1" bg2="dk2" tx2="lt2" accent1="accent1" accent2="accent2" accent3="accent3" accent4="accent4" accent5="accent5" accent6="accent6" hlink="hlink" folHlink="folHlink"/>
   <p:sldLayoutIdLst>
-    <p:sldLayoutId xmlns:r="http://schemas.openxmlformats.org/officeDocument/2006/relationships" id="2147483662" r:id="R61e623613c3246ae"/>
+    <p:sldLayoutId xmlns:r="http://schemas.openxmlformats.org/officeDocument/2006/relationships" id="2147483662" r:id="R88530e67859540e8"/>
   </p:sldLayoutIdLst>
   <p:hf sldNum="0" hdr="0" ftr="0" dt="0"/>
   <p:txStyles>
@@ -8777,7 +8777,7 @@
           <p:nvPr/>
         </p:nvPicPr>
         <p:blipFill rotWithShape="1">
-          <a:blip xmlns:r="http://schemas.openxmlformats.org/officeDocument/2006/relationships" xmlns:a="http://schemas.openxmlformats.org/drawingml/2006/main" r:embed="Rcaf5e9e873a54a0d">
+          <a:blip xmlns:r="http://schemas.openxmlformats.org/officeDocument/2006/relationships" xmlns:a="http://schemas.openxmlformats.org/drawingml/2006/main" r:embed="R428dc8771c014782">
             <a:alphaModFix/>
           </a:blip>
           <a:srcRect xmlns:a="http://schemas.openxmlformats.org/drawingml/2006/main" l="0" t="0" r="0" b="0"/>
@@ -8805,7 +8805,7 @@
           <p:nvPr/>
         </p:nvPicPr>
         <p:blipFill rotWithShape="1">
-          <a:blip xmlns:r="http://schemas.openxmlformats.org/officeDocument/2006/relationships" xmlns:a="http://schemas.openxmlformats.org/drawingml/2006/main" r:embed="Rcaf5e9e873a54a0d">
+          <a:blip xmlns:r="http://schemas.openxmlformats.org/officeDocument/2006/relationships" xmlns:a="http://schemas.openxmlformats.org/drawingml/2006/main" r:embed="R428dc8771c014782">
             <a:alphaModFix/>
           </a:blip>
           <a:srcRect xmlns:a="http://schemas.openxmlformats.org/drawingml/2006/main" l="0" t="0" r="0" b="0"/>
@@ -8833,7 +8833,7 @@
           <p:nvPr/>
         </p:nvPicPr>
         <p:blipFill rotWithShape="1">
-          <a:blip xmlns:r="http://schemas.openxmlformats.org/officeDocument/2006/relationships" xmlns:a="http://schemas.openxmlformats.org/drawingml/2006/main" r:embed="Rcaf5e9e873a54a0d">
+          <a:blip xmlns:r="http://schemas.openxmlformats.org/officeDocument/2006/relationships" xmlns:a="http://schemas.openxmlformats.org/drawingml/2006/main" r:embed="R428dc8771c014782">
             <a:alphaModFix/>
           </a:blip>
           <a:srcRect xmlns:a="http://schemas.openxmlformats.org/drawingml/2006/main" l="0" t="0" r="0" b="0"/>
@@ -8861,7 +8861,7 @@
           <p:nvPr/>
         </p:nvPicPr>
         <p:blipFill rotWithShape="1">
-          <a:blip xmlns:r="http://schemas.openxmlformats.org/officeDocument/2006/relationships" xmlns:a="http://schemas.openxmlformats.org/drawingml/2006/main" r:embed="Rcaf5e9e873a54a0d">
+          <a:blip xmlns:r="http://schemas.openxmlformats.org/officeDocument/2006/relationships" xmlns:a="http://schemas.openxmlformats.org/drawingml/2006/main" r:embed="R428dc8771c014782">
             <a:alphaModFix/>
           </a:blip>
           <a:srcRect xmlns:a="http://schemas.openxmlformats.org/drawingml/2006/main" l="0" t="0" r="0" b="0"/>
@@ -8889,7 +8889,7 @@
           <p:nvPr/>
         </p:nvPicPr>
         <p:blipFill rotWithShape="1">
-          <a:blip xmlns:r="http://schemas.openxmlformats.org/officeDocument/2006/relationships" xmlns:a="http://schemas.openxmlformats.org/drawingml/2006/main" r:embed="Rcaf5e9e873a54a0d">
+          <a:blip xmlns:r="http://schemas.openxmlformats.org/officeDocument/2006/relationships" xmlns:a="http://schemas.openxmlformats.org/drawingml/2006/main" r:embed="R428dc8771c014782">
             <a:alphaModFix/>
           </a:blip>
           <a:srcRect xmlns:a="http://schemas.openxmlformats.org/drawingml/2006/main" l="0" t="0" r="0" b="0"/>
@@ -8917,7 +8917,7 @@
           <p:nvPr/>
         </p:nvPicPr>
         <p:blipFill rotWithShape="1">
-          <a:blip xmlns:r="http://schemas.openxmlformats.org/officeDocument/2006/relationships" xmlns:a="http://schemas.openxmlformats.org/drawingml/2006/main" r:embed="Rcaf5e9e873a54a0d">
+          <a:blip xmlns:r="http://schemas.openxmlformats.org/officeDocument/2006/relationships" xmlns:a="http://schemas.openxmlformats.org/drawingml/2006/main" r:embed="R428dc8771c014782">
             <a:alphaModFix/>
           </a:blip>
           <a:srcRect xmlns:a="http://schemas.openxmlformats.org/drawingml/2006/main" l="0" t="0" r="0" b="0"/>
@@ -8945,7 +8945,7 @@
           <p:nvPr/>
         </p:nvPicPr>
         <p:blipFill rotWithShape="1">
-          <a:blip xmlns:r="http://schemas.openxmlformats.org/officeDocument/2006/relationships" xmlns:a="http://schemas.openxmlformats.org/drawingml/2006/main" r:embed="Rcaf5e9e873a54a0d">
+          <a:blip xmlns:r="http://schemas.openxmlformats.org/officeDocument/2006/relationships" xmlns:a="http://schemas.openxmlformats.org/drawingml/2006/main" r:embed="R428dc8771c014782">
             <a:alphaModFix/>
           </a:blip>
           <a:srcRect xmlns:a="http://schemas.openxmlformats.org/drawingml/2006/main" l="0" t="0" r="0" b="0"/>
@@ -8973,7 +8973,7 @@
           <p:nvPr/>
         </p:nvPicPr>
         <p:blipFill rotWithShape="1">
-          <a:blip xmlns:r="http://schemas.openxmlformats.org/officeDocument/2006/relationships" xmlns:a="http://schemas.openxmlformats.org/drawingml/2006/main" r:embed="Rcaf5e9e873a54a0d">
+          <a:blip xmlns:r="http://schemas.openxmlformats.org/officeDocument/2006/relationships" xmlns:a="http://schemas.openxmlformats.org/drawingml/2006/main" r:embed="R428dc8771c014782">
             <a:alphaModFix/>
           </a:blip>
           <a:srcRect xmlns:a="http://schemas.openxmlformats.org/drawingml/2006/main" l="0" t="0" r="0" b="0"/>
@@ -11058,7 +11058,7 @@
           <p:nvPr/>
         </p:nvPicPr>
         <p:blipFill rotWithShape="1">
-          <a:blip xmlns:r="http://schemas.openxmlformats.org/officeDocument/2006/relationships" xmlns:a="http://schemas.openxmlformats.org/drawingml/2006/main" r:embed="R68aa4fd68ed44cf8">
+          <a:blip xmlns:r="http://schemas.openxmlformats.org/officeDocument/2006/relationships" xmlns:a="http://schemas.openxmlformats.org/drawingml/2006/main" r:embed="R5e7fa0294ee345e0">
             <a:alphaModFix/>
           </a:blip>
           <a:srcRect xmlns:a="http://schemas.openxmlformats.org/drawingml/2006/main" l="0" t="0" r="0" b="0"/>
@@ -11086,7 +11086,7 @@
           <p:nvPr/>
         </p:nvPicPr>
         <p:blipFill rotWithShape="1">
-          <a:blip xmlns:r="http://schemas.openxmlformats.org/officeDocument/2006/relationships" xmlns:a="http://schemas.openxmlformats.org/drawingml/2006/main" r:embed="R68aa4fd68ed44cf8">
+          <a:blip xmlns:r="http://schemas.openxmlformats.org/officeDocument/2006/relationships" xmlns:a="http://schemas.openxmlformats.org/drawingml/2006/main" r:embed="R5e7fa0294ee345e0">
             <a:alphaModFix/>
           </a:blip>
           <a:srcRect xmlns:a="http://schemas.openxmlformats.org/drawingml/2006/main" l="0" t="0" r="0" b="0"/>
@@ -11114,7 +11114,7 @@
           <p:nvPr/>
         </p:nvPicPr>
         <p:blipFill rotWithShape="1">
-          <a:blip xmlns:r="http://schemas.openxmlformats.org/officeDocument/2006/relationships" xmlns:a="http://schemas.openxmlformats.org/drawingml/2006/main" r:embed="R68aa4fd68ed44cf8">
+          <a:blip xmlns:r="http://schemas.openxmlformats.org/officeDocument/2006/relationships" xmlns:a="http://schemas.openxmlformats.org/drawingml/2006/main" r:embed="R5e7fa0294ee345e0">
             <a:alphaModFix/>
           </a:blip>
           <a:srcRect xmlns:a="http://schemas.openxmlformats.org/drawingml/2006/main" l="0" t="0" r="0" b="0"/>
@@ -11142,7 +11142,7 @@
           <p:nvPr/>
         </p:nvPicPr>
         <p:blipFill rotWithShape="1">
-          <a:blip xmlns:r="http://schemas.openxmlformats.org/officeDocument/2006/relationships" xmlns:a="http://schemas.openxmlformats.org/drawingml/2006/main" r:embed="R68aa4fd68ed44cf8">
+          <a:blip xmlns:r="http://schemas.openxmlformats.org/officeDocument/2006/relationships" xmlns:a="http://schemas.openxmlformats.org/drawingml/2006/main" r:embed="R5e7fa0294ee345e0">
             <a:alphaModFix/>
           </a:blip>
           <a:srcRect xmlns:a="http://schemas.openxmlformats.org/drawingml/2006/main" l="0" t="0" r="0" b="0"/>
@@ -13075,7 +13075,7 @@
           <p:nvPr/>
         </p:nvPicPr>
         <p:blipFill rotWithShape="1">
-          <a:blip xmlns:r="http://schemas.openxmlformats.org/officeDocument/2006/relationships" xmlns:a="http://schemas.openxmlformats.org/drawingml/2006/main" r:embed="R32033be01c8b44ab">
+          <a:blip xmlns:r="http://schemas.openxmlformats.org/officeDocument/2006/relationships" xmlns:a="http://schemas.openxmlformats.org/drawingml/2006/main" r:embed="Re61f893f6bc842ca">
             <a:alphaModFix/>
           </a:blip>
           <a:srcRect xmlns:a="http://schemas.openxmlformats.org/drawingml/2006/main" l="0" t="0" r="0" b="0"/>
@@ -13103,7 +13103,7 @@
           <p:nvPr/>
         </p:nvPicPr>
         <p:blipFill rotWithShape="1">
-          <a:blip xmlns:r="http://schemas.openxmlformats.org/officeDocument/2006/relationships" xmlns:a="http://schemas.openxmlformats.org/drawingml/2006/main" r:embed="R32033be01c8b44ab">
+          <a:blip xmlns:r="http://schemas.openxmlformats.org/officeDocument/2006/relationships" xmlns:a="http://schemas.openxmlformats.org/drawingml/2006/main" r:embed="Re61f893f6bc842ca">
             <a:alphaModFix/>
           </a:blip>
           <a:srcRect xmlns:a="http://schemas.openxmlformats.org/drawingml/2006/main" l="0" t="0" r="0" b="0"/>
@@ -13131,7 +13131,7 @@
           <p:nvPr/>
         </p:nvPicPr>
         <p:blipFill rotWithShape="1">
-          <a:blip xmlns:r="http://schemas.openxmlformats.org/officeDocument/2006/relationships" xmlns:a="http://schemas.openxmlformats.org/drawingml/2006/main" r:embed="R32033be01c8b44ab">
+          <a:blip xmlns:r="http://schemas.openxmlformats.org/officeDocument/2006/relationships" xmlns:a="http://schemas.openxmlformats.org/drawingml/2006/main" r:embed="Re61f893f6bc842ca">
             <a:alphaModFix/>
           </a:blip>
           <a:srcRect xmlns:a="http://schemas.openxmlformats.org/drawingml/2006/main" l="0" t="0" r="0" b="0"/>
@@ -13159,7 +13159,7 @@
           <p:nvPr/>
         </p:nvPicPr>
         <p:blipFill rotWithShape="1">
-          <a:blip xmlns:r="http://schemas.openxmlformats.org/officeDocument/2006/relationships" xmlns:a="http://schemas.openxmlformats.org/drawingml/2006/main" r:embed="R32033be01c8b44ab">
+          <a:blip xmlns:r="http://schemas.openxmlformats.org/officeDocument/2006/relationships" xmlns:a="http://schemas.openxmlformats.org/drawingml/2006/main" r:embed="Re61f893f6bc842ca">
             <a:alphaModFix/>
           </a:blip>
           <a:srcRect xmlns:a="http://schemas.openxmlformats.org/drawingml/2006/main" l="0" t="0" r="0" b="0"/>
@@ -15070,7 +15070,7 @@
           <p:nvPr/>
         </p:nvPicPr>
         <p:blipFill rotWithShape="1">
-          <a:blip xmlns:r="http://schemas.openxmlformats.org/officeDocument/2006/relationships" xmlns:a="http://schemas.openxmlformats.org/drawingml/2006/main" r:embed="Ra743836a4fc64137">
+          <a:blip xmlns:r="http://schemas.openxmlformats.org/officeDocument/2006/relationships" xmlns:a="http://schemas.openxmlformats.org/drawingml/2006/main" r:embed="R1cc79fea11e44d91">
             <a:alphaModFix/>
           </a:blip>
           <a:srcRect xmlns:a="http://schemas.openxmlformats.org/drawingml/2006/main" l="0" t="0" r="0" b="0"/>
@@ -15098,7 +15098,7 @@
           <p:nvPr/>
         </p:nvPicPr>
         <p:blipFill rotWithShape="1">
-          <a:blip xmlns:r="http://schemas.openxmlformats.org/officeDocument/2006/relationships" xmlns:a="http://schemas.openxmlformats.org/drawingml/2006/main" r:embed="Ra743836a4fc64137">
+          <a:blip xmlns:r="http://schemas.openxmlformats.org/officeDocument/2006/relationships" xmlns:a="http://schemas.openxmlformats.org/drawingml/2006/main" r:embed="R1cc79fea11e44d91">
             <a:alphaModFix/>
           </a:blip>
           <a:srcRect xmlns:a="http://schemas.openxmlformats.org/drawingml/2006/main" l="0" t="0" r="0" b="0"/>
@@ -15126,7 +15126,7 @@
           <p:nvPr/>
         </p:nvPicPr>
         <p:blipFill rotWithShape="1">
-          <a:blip xmlns:r="http://schemas.openxmlformats.org/officeDocument/2006/relationships" xmlns:a="http://schemas.openxmlformats.org/drawingml/2006/main" r:embed="Ra743836a4fc64137">
+          <a:blip xmlns:r="http://schemas.openxmlformats.org/officeDocument/2006/relationships" xmlns:a="http://schemas.openxmlformats.org/drawingml/2006/main" r:embed="R1cc79fea11e44d91">
             <a:alphaModFix/>
           </a:blip>
           <a:srcRect xmlns:a="http://schemas.openxmlformats.org/drawingml/2006/main" l="0" t="0" r="0" b="0"/>
@@ -15154,7 +15154,7 @@
           <p:nvPr/>
         </p:nvPicPr>
         <p:blipFill rotWithShape="1">
-          <a:blip xmlns:r="http://schemas.openxmlformats.org/officeDocument/2006/relationships" xmlns:a="http://schemas.openxmlformats.org/drawingml/2006/main" r:embed="Ra743836a4fc64137">
+          <a:blip xmlns:r="http://schemas.openxmlformats.org/officeDocument/2006/relationships" xmlns:a="http://schemas.openxmlformats.org/drawingml/2006/main" r:embed="R1cc79fea11e44d91">
             <a:alphaModFix/>
           </a:blip>
           <a:srcRect xmlns:a="http://schemas.openxmlformats.org/drawingml/2006/main" l="0" t="0" r="0" b="0"/>
@@ -17193,7 +17193,7 @@
           <p:nvPr/>
         </p:nvPicPr>
         <p:blipFill rotWithShape="1">
-          <a:blip xmlns:r="http://schemas.openxmlformats.org/officeDocument/2006/relationships" xmlns:a="http://schemas.openxmlformats.org/drawingml/2006/main" r:embed="R0cabddfd5a11425b">
+          <a:blip xmlns:r="http://schemas.openxmlformats.org/officeDocument/2006/relationships" xmlns:a="http://schemas.openxmlformats.org/drawingml/2006/main" r:embed="R7ed2fa736f304663">
             <a:alphaModFix/>
           </a:blip>
           <a:srcRect xmlns:a="http://schemas.openxmlformats.org/drawingml/2006/main" l="0" t="0" r="0" b="0"/>
@@ -17221,7 +17221,7 @@
           <p:nvPr/>
         </p:nvPicPr>
         <p:blipFill rotWithShape="1">
-          <a:blip xmlns:r="http://schemas.openxmlformats.org/officeDocument/2006/relationships" xmlns:a="http://schemas.openxmlformats.org/drawingml/2006/main" r:embed="R0cabddfd5a11425b">
+          <a:blip xmlns:r="http://schemas.openxmlformats.org/officeDocument/2006/relationships" xmlns:a="http://schemas.openxmlformats.org/drawingml/2006/main" r:embed="R7ed2fa736f304663">
             <a:alphaModFix/>
           </a:blip>
           <a:srcRect xmlns:a="http://schemas.openxmlformats.org/drawingml/2006/main" l="0" t="0" r="0" b="0"/>
@@ -17249,7 +17249,7 @@
           <p:nvPr/>
         </p:nvPicPr>
         <p:blipFill rotWithShape="1">
-          <a:blip xmlns:r="http://schemas.openxmlformats.org/officeDocument/2006/relationships" xmlns:a="http://schemas.openxmlformats.org/drawingml/2006/main" r:embed="R0cabddfd5a11425b">
+          <a:blip xmlns:r="http://schemas.openxmlformats.org/officeDocument/2006/relationships" xmlns:a="http://schemas.openxmlformats.org/drawingml/2006/main" r:embed="R7ed2fa736f304663">
             <a:alphaModFix/>
           </a:blip>
           <a:srcRect xmlns:a="http://schemas.openxmlformats.org/drawingml/2006/main" l="0" t="0" r="0" b="0"/>
@@ -17277,7 +17277,7 @@
           <p:nvPr/>
         </p:nvPicPr>
         <p:blipFill rotWithShape="1">
-          <a:blip xmlns:r="http://schemas.openxmlformats.org/officeDocument/2006/relationships" xmlns:a="http://schemas.openxmlformats.org/drawingml/2006/main" r:embed="R0cabddfd5a11425b">
+          <a:blip xmlns:r="http://schemas.openxmlformats.org/officeDocument/2006/relationships" xmlns:a="http://schemas.openxmlformats.org/drawingml/2006/main" r:embed="R7ed2fa736f304663">
             <a:alphaModFix/>
           </a:blip>
           <a:srcRect xmlns:a="http://schemas.openxmlformats.org/drawingml/2006/main" l="0" t="0" r="0" b="0"/>
@@ -19308,7 +19308,7 @@
           <p:nvPr/>
         </p:nvPicPr>
         <p:blipFill rotWithShape="1">
-          <a:blip xmlns:r="http://schemas.openxmlformats.org/officeDocument/2006/relationships" xmlns:a="http://schemas.openxmlformats.org/drawingml/2006/main" r:embed="R0f0103bd359e4fbe">
+          <a:blip xmlns:r="http://schemas.openxmlformats.org/officeDocument/2006/relationships" xmlns:a="http://schemas.openxmlformats.org/drawingml/2006/main" r:embed="R48e061573cd049da">
             <a:alphaModFix/>
           </a:blip>
           <a:srcRect xmlns:a="http://schemas.openxmlformats.org/drawingml/2006/main" l="0" t="0" r="0" b="0"/>
@@ -19336,7 +19336,7 @@
           <p:nvPr/>
         </p:nvPicPr>
         <p:blipFill rotWithShape="1">
-          <a:blip xmlns:r="http://schemas.openxmlformats.org/officeDocument/2006/relationships" xmlns:a="http://schemas.openxmlformats.org/drawingml/2006/main" r:embed="R0f0103bd359e4fbe">
+          <a:blip xmlns:r="http://schemas.openxmlformats.org/officeDocument/2006/relationships" xmlns:a="http://schemas.openxmlformats.org/drawingml/2006/main" r:embed="R48e061573cd049da">
             <a:alphaModFix/>
           </a:blip>
           <a:srcRect xmlns:a="http://schemas.openxmlformats.org/drawingml/2006/main" l="0" t="0" r="0" b="0"/>
@@ -19364,7 +19364,7 @@
           <p:nvPr/>
         </p:nvPicPr>
         <p:blipFill rotWithShape="1">
-          <a:blip xmlns:r="http://schemas.openxmlformats.org/officeDocument/2006/relationships" xmlns:a="http://schemas.openxmlformats.org/drawingml/2006/main" r:embed="R0f0103bd359e4fbe">
+          <a:blip xmlns:r="http://schemas.openxmlformats.org/officeDocument/2006/relationships" xmlns:a="http://schemas.openxmlformats.org/drawingml/2006/main" r:embed="R48e061573cd049da">
             <a:alphaModFix/>
           </a:blip>
           <a:srcRect xmlns:a="http://schemas.openxmlformats.org/drawingml/2006/main" l="0" t="0" r="0" b="0"/>
@@ -19392,7 +19392,7 @@
           <p:nvPr/>
         </p:nvPicPr>
         <p:blipFill rotWithShape="1">
-          <a:blip xmlns:r="http://schemas.openxmlformats.org/officeDocument/2006/relationships" xmlns:a="http://schemas.openxmlformats.org/drawingml/2006/main" r:embed="R0f0103bd359e4fbe">
+          <a:blip xmlns:r="http://schemas.openxmlformats.org/officeDocument/2006/relationships" xmlns:a="http://schemas.openxmlformats.org/drawingml/2006/main" r:embed="R48e061573cd049da">
             <a:alphaModFix/>
           </a:blip>
           <a:srcRect xmlns:a="http://schemas.openxmlformats.org/drawingml/2006/main" l="0" t="0" r="0" b="0"/>
@@ -21437,7 +21437,7 @@
           <p:nvPr/>
         </p:nvPicPr>
         <p:blipFill rotWithShape="1">
-          <a:blip xmlns:r="http://schemas.openxmlformats.org/officeDocument/2006/relationships" xmlns:a="http://schemas.openxmlformats.org/drawingml/2006/main" r:embed="Rb169131778644342">
+          <a:blip xmlns:r="http://schemas.openxmlformats.org/officeDocument/2006/relationships" xmlns:a="http://schemas.openxmlformats.org/drawingml/2006/main" r:embed="R4d69e32c49224bd3">
             <a:alphaModFix/>
           </a:blip>
           <a:srcRect xmlns:a="http://schemas.openxmlformats.org/drawingml/2006/main" l="0" t="0" r="0" b="0"/>
@@ -21465,7 +21465,7 @@
           <p:nvPr/>
         </p:nvPicPr>
         <p:blipFill rotWithShape="1">
-          <a:blip xmlns:r="http://schemas.openxmlformats.org/officeDocument/2006/relationships" xmlns:a="http://schemas.openxmlformats.org/drawingml/2006/main" r:embed="Rb169131778644342">
+          <a:blip xmlns:r="http://schemas.openxmlformats.org/officeDocument/2006/relationships" xmlns:a="http://schemas.openxmlformats.org/drawingml/2006/main" r:embed="R4d69e32c49224bd3">
             <a:alphaModFix/>
           </a:blip>
           <a:srcRect xmlns:a="http://schemas.openxmlformats.org/drawingml/2006/main" l="0" t="0" r="0" b="0"/>
@@ -21493,7 +21493,7 @@
           <p:nvPr/>
         </p:nvPicPr>
         <p:blipFill rotWithShape="1">
-          <a:blip xmlns:r="http://schemas.openxmlformats.org/officeDocument/2006/relationships" xmlns:a="http://schemas.openxmlformats.org/drawingml/2006/main" r:embed="Rb169131778644342">
+          <a:blip xmlns:r="http://schemas.openxmlformats.org/officeDocument/2006/relationships" xmlns:a="http://schemas.openxmlformats.org/drawingml/2006/main" r:embed="R4d69e32c49224bd3">
             <a:alphaModFix/>
           </a:blip>
           <a:srcRect xmlns:a="http://schemas.openxmlformats.org/drawingml/2006/main" l="0" t="0" r="0" b="0"/>
@@ -21521,7 +21521,7 @@
           <p:nvPr/>
         </p:nvPicPr>
         <p:blipFill rotWithShape="1">
-          <a:blip xmlns:r="http://schemas.openxmlformats.org/officeDocument/2006/relationships" xmlns:a="http://schemas.openxmlformats.org/drawingml/2006/main" r:embed="Rb169131778644342">
+          <a:blip xmlns:r="http://schemas.openxmlformats.org/officeDocument/2006/relationships" xmlns:a="http://schemas.openxmlformats.org/drawingml/2006/main" r:embed="R4d69e32c49224bd3">
             <a:alphaModFix/>
           </a:blip>
           <a:srcRect xmlns:a="http://schemas.openxmlformats.org/drawingml/2006/main" l="0" t="0" r="0" b="0"/>
@@ -23544,7 +23544,7 @@
           <p:nvPr/>
         </p:nvPicPr>
         <p:blipFill rotWithShape="1">
-          <a:blip xmlns:r="http://schemas.openxmlformats.org/officeDocument/2006/relationships" xmlns:a="http://schemas.openxmlformats.org/drawingml/2006/main" r:embed="R6934258205ee463a">
+          <a:blip xmlns:r="http://schemas.openxmlformats.org/officeDocument/2006/relationships" xmlns:a="http://schemas.openxmlformats.org/drawingml/2006/main" r:embed="Rcc386bbb2cbc4dba">
             <a:alphaModFix/>
           </a:blip>
           <a:srcRect xmlns:a="http://schemas.openxmlformats.org/drawingml/2006/main" l="0" t="0" r="0" b="0"/>
@@ -23572,7 +23572,7 @@
           <p:nvPr/>
         </p:nvPicPr>
         <p:blipFill rotWithShape="1">
-          <a:blip xmlns:r="http://schemas.openxmlformats.org/officeDocument/2006/relationships" xmlns:a="http://schemas.openxmlformats.org/drawingml/2006/main" r:embed="R6934258205ee463a">
+          <a:blip xmlns:r="http://schemas.openxmlformats.org/officeDocument/2006/relationships" xmlns:a="http://schemas.openxmlformats.org/drawingml/2006/main" r:embed="Rcc386bbb2cbc4dba">
             <a:alphaModFix/>
           </a:blip>
           <a:srcRect xmlns:a="http://schemas.openxmlformats.org/drawingml/2006/main" l="0" t="0" r="0" b="0"/>
@@ -23600,7 +23600,7 @@
           <p:nvPr/>
         </p:nvPicPr>
         <p:blipFill rotWithShape="1">
-          <a:blip xmlns:r="http://schemas.openxmlformats.org/officeDocument/2006/relationships" xmlns:a="http://schemas.openxmlformats.org/drawingml/2006/main" r:embed="R6934258205ee463a">
+          <a:blip xmlns:r="http://schemas.openxmlformats.org/officeDocument/2006/relationships" xmlns:a="http://schemas.openxmlformats.org/drawingml/2006/main" r:embed="Rcc386bbb2cbc4dba">
             <a:alphaModFix/>
           </a:blip>
           <a:srcRect xmlns:a="http://schemas.openxmlformats.org/drawingml/2006/main" l="0" t="0" r="0" b="0"/>
@@ -23628,7 +23628,7 @@
           <p:nvPr/>
         </p:nvPicPr>
         <p:blipFill rotWithShape="1">
-          <a:blip xmlns:r="http://schemas.openxmlformats.org/officeDocument/2006/relationships" xmlns:a="http://schemas.openxmlformats.org/drawingml/2006/main" r:embed="R6934258205ee463a">
+          <a:blip xmlns:r="http://schemas.openxmlformats.org/officeDocument/2006/relationships" xmlns:a="http://schemas.openxmlformats.org/drawingml/2006/main" r:embed="Rcc386bbb2cbc4dba">
             <a:alphaModFix/>
           </a:blip>
           <a:srcRect xmlns:a="http://schemas.openxmlformats.org/drawingml/2006/main" l="0" t="0" r="0" b="0"/>
@@ -25703,7 +25703,7 @@
           <p:nvPr/>
         </p:nvPicPr>
         <p:blipFill rotWithShape="1">
-          <a:blip xmlns:r="http://schemas.openxmlformats.org/officeDocument/2006/relationships" xmlns:a="http://schemas.openxmlformats.org/drawingml/2006/main" r:embed="R7a2e1897d5f8497b">
+          <a:blip xmlns:r="http://schemas.openxmlformats.org/officeDocument/2006/relationships" xmlns:a="http://schemas.openxmlformats.org/drawingml/2006/main" r:embed="R54e8667a15b04f69">
             <a:alphaModFix/>
           </a:blip>
           <a:srcRect xmlns:a="http://schemas.openxmlformats.org/drawingml/2006/main" l="0" t="0" r="0" b="0"/>
@@ -25731,7 +25731,7 @@
           <p:nvPr/>
         </p:nvPicPr>
         <p:blipFill rotWithShape="1">
-          <a:blip xmlns:r="http://schemas.openxmlformats.org/officeDocument/2006/relationships" xmlns:a="http://schemas.openxmlformats.org/drawingml/2006/main" r:embed="R7a2e1897d5f8497b">
+          <a:blip xmlns:r="http://schemas.openxmlformats.org/officeDocument/2006/relationships" xmlns:a="http://schemas.openxmlformats.org/drawingml/2006/main" r:embed="R54e8667a15b04f69">
             <a:alphaModFix/>
           </a:blip>
           <a:srcRect xmlns:a="http://schemas.openxmlformats.org/drawingml/2006/main" l="0" t="0" r="0" b="0"/>
@@ -25759,7 +25759,7 @@
           <p:nvPr/>
         </p:nvPicPr>
         <p:blipFill rotWithShape="1">
-          <a:blip xmlns:r="http://schemas.openxmlformats.org/officeDocument/2006/relationships" xmlns:a="http://schemas.openxmlformats.org/drawingml/2006/main" r:embed="R7a2e1897d5f8497b">
+          <a:blip xmlns:r="http://schemas.openxmlformats.org/officeDocument/2006/relationships" xmlns:a="http://schemas.openxmlformats.org/drawingml/2006/main" r:embed="R54e8667a15b04f69">
             <a:alphaModFix/>
           </a:blip>
           <a:srcRect xmlns:a="http://schemas.openxmlformats.org/drawingml/2006/main" l="0" t="0" r="0" b="0"/>
@@ -25787,7 +25787,7 @@
           <p:nvPr/>
         </p:nvPicPr>
         <p:blipFill rotWithShape="1">
-          <a:blip xmlns:r="http://schemas.openxmlformats.org/officeDocument/2006/relationships" xmlns:a="http://schemas.openxmlformats.org/drawingml/2006/main" r:embed="R7a2e1897d5f8497b">
+          <a:blip xmlns:r="http://schemas.openxmlformats.org/officeDocument/2006/relationships" xmlns:a="http://schemas.openxmlformats.org/drawingml/2006/main" r:embed="R54e8667a15b04f69">
             <a:alphaModFix/>
           </a:blip>
           <a:srcRect xmlns:a="http://schemas.openxmlformats.org/drawingml/2006/main" l="0" t="0" r="0" b="0"/>
@@ -27758,7 +27758,7 @@
           <p:nvPr/>
         </p:nvPicPr>
         <p:blipFill rotWithShape="1">
-          <a:blip xmlns:r="http://schemas.openxmlformats.org/officeDocument/2006/relationships" xmlns:a="http://schemas.openxmlformats.org/drawingml/2006/main" r:embed="R350ae59a1f054a4b">
+          <a:blip xmlns:r="http://schemas.openxmlformats.org/officeDocument/2006/relationships" xmlns:a="http://schemas.openxmlformats.org/drawingml/2006/main" r:embed="Rf015fc45c68e4410">
             <a:alphaModFix/>
           </a:blip>
           <a:srcRect xmlns:a="http://schemas.openxmlformats.org/drawingml/2006/main" l="0" t="0" r="0" b="0"/>
@@ -27786,7 +27786,7 @@
           <p:nvPr/>
         </p:nvPicPr>
         <p:blipFill rotWithShape="1">
-          <a:blip xmlns:r="http://schemas.openxmlformats.org/officeDocument/2006/relationships" xmlns:a="http://schemas.openxmlformats.org/drawingml/2006/main" r:embed="R350ae59a1f054a4b">
+          <a:blip xmlns:r="http://schemas.openxmlformats.org/officeDocument/2006/relationships" xmlns:a="http://schemas.openxmlformats.org/drawingml/2006/main" r:embed="Rf015fc45c68e4410">
             <a:alphaModFix/>
           </a:blip>
           <a:srcRect xmlns:a="http://schemas.openxmlformats.org/drawingml/2006/main" l="0" t="0" r="0" b="0"/>
@@ -27814,7 +27814,7 @@
           <p:nvPr/>
         </p:nvPicPr>
         <p:blipFill rotWithShape="1">
-          <a:blip xmlns:r="http://schemas.openxmlformats.org/officeDocument/2006/relationships" xmlns:a="http://schemas.openxmlformats.org/drawingml/2006/main" r:embed="R350ae59a1f054a4b">
+          <a:blip xmlns:r="http://schemas.openxmlformats.org/officeDocument/2006/relationships" xmlns:a="http://schemas.openxmlformats.org/drawingml/2006/main" r:embed="Rf015fc45c68e4410">
             <a:alphaModFix/>
           </a:blip>
           <a:srcRect xmlns:a="http://schemas.openxmlformats.org/drawingml/2006/main" l="0" t="0" r="0" b="0"/>
@@ -27842,7 +27842,7 @@
           <p:nvPr/>
         </p:nvPicPr>
         <p:blipFill rotWithShape="1">
-          <a:blip xmlns:r="http://schemas.openxmlformats.org/officeDocument/2006/relationships" xmlns:a="http://schemas.openxmlformats.org/drawingml/2006/main" r:embed="R350ae59a1f054a4b">
+          <a:blip xmlns:r="http://schemas.openxmlformats.org/officeDocument/2006/relationships" xmlns:a="http://schemas.openxmlformats.org/drawingml/2006/main" r:embed="Rf015fc45c68e4410">
             <a:alphaModFix/>
           </a:blip>
           <a:srcRect xmlns:a="http://schemas.openxmlformats.org/drawingml/2006/main" l="0" t="0" r="0" b="0"/>
@@ -29865,7 +29865,7 @@
           <p:nvPr/>
         </p:nvPicPr>
         <p:blipFill rotWithShape="1">
-          <a:blip xmlns:r="http://schemas.openxmlformats.org/officeDocument/2006/relationships" xmlns:a="http://schemas.openxmlformats.org/drawingml/2006/main" r:embed="R2a22f1894dd94210">
+          <a:blip xmlns:r="http://schemas.openxmlformats.org/officeDocument/2006/relationships" xmlns:a="http://schemas.openxmlformats.org/drawingml/2006/main" r:embed="Rbf1d0f9f55da49b0">
             <a:alphaModFix/>
           </a:blip>
           <a:srcRect xmlns:a="http://schemas.openxmlformats.org/drawingml/2006/main" l="0" t="0" r="0" b="0"/>
@@ -29893,7 +29893,7 @@
           <p:nvPr/>
         </p:nvPicPr>
         <p:blipFill rotWithShape="1">
-          <a:blip xmlns:r="http://schemas.openxmlformats.org/officeDocument/2006/relationships" xmlns:a="http://schemas.openxmlformats.org/drawingml/2006/main" r:embed="R2a22f1894dd94210">
+          <a:blip xmlns:r="http://schemas.openxmlformats.org/officeDocument/2006/relationships" xmlns:a="http://schemas.openxmlformats.org/drawingml/2006/main" r:embed="Rbf1d0f9f55da49b0">
             <a:alphaModFix/>
           </a:blip>
           <a:srcRect xmlns:a="http://schemas.openxmlformats.org/drawingml/2006/main" l="0" t="0" r="0" b="0"/>
@@ -29921,7 +29921,7 @@
           <p:nvPr/>
         </p:nvPicPr>
         <p:blipFill rotWithShape="1">
-          <a:blip xmlns:r="http://schemas.openxmlformats.org/officeDocument/2006/relationships" xmlns:a="http://schemas.openxmlformats.org/drawingml/2006/main" r:embed="R2a22f1894dd94210">
+          <a:blip xmlns:r="http://schemas.openxmlformats.org/officeDocument/2006/relationships" xmlns:a="http://schemas.openxmlformats.org/drawingml/2006/main" r:embed="Rbf1d0f9f55da49b0">
             <a:alphaModFix/>
           </a:blip>
           <a:srcRect xmlns:a="http://schemas.openxmlformats.org/drawingml/2006/main" l="0" t="0" r="0" b="0"/>
@@ -29949,7 +29949,7 @@
           <p:nvPr/>
         </p:nvPicPr>
         <p:blipFill rotWithShape="1">
-          <a:blip xmlns:r="http://schemas.openxmlformats.org/officeDocument/2006/relationships" xmlns:a="http://schemas.openxmlformats.org/drawingml/2006/main" r:embed="R2a22f1894dd94210">
+          <a:blip xmlns:r="http://schemas.openxmlformats.org/officeDocument/2006/relationships" xmlns:a="http://schemas.openxmlformats.org/drawingml/2006/main" r:embed="Rbf1d0f9f55da49b0">
             <a:alphaModFix/>
           </a:blip>
           <a:srcRect xmlns:a="http://schemas.openxmlformats.org/drawingml/2006/main" l="0" t="0" r="0" b="0"/>
@@ -30443,7 +30443,7 @@
                 <a:ea typeface="Inter"/>
                 <a:cs typeface="Inter"/>
               </a:rPr>
-              <a:t>Install Multipass: </a:t>
+              <a:t>Install </a:t>
             </a:r>
             <a:r>
               <a:rPr sz="1500" b="0" i="0">
@@ -30453,9 +30453,9 @@
                 <a:latin typeface="Inter"/>
                 <a:ea typeface="Inter"/>
                 <a:cs typeface="Inter"/>
-                <a:hlinkClick xmlns:r="http://schemas.openxmlformats.org/officeDocument/2006/relationships" r:id="R1323b3daf03347c6"/>
+                <a:hlinkClick xmlns:r="http://schemas.openxmlformats.org/officeDocument/2006/relationships" r:id="R19646aa18e084598"/>
               </a:rPr>
-              <a:t>macOS</a:t>
+              <a:t>Git</a:t>
             </a:r>
             <a:r>
               <a:rPr sz="1500" b="0" i="0">
@@ -30466,7 +30466,7 @@
                 <a:ea typeface="Inter"/>
                 <a:cs typeface="Inter"/>
               </a:rPr>
-              <a:t> / </a:t>
+              <a:t> and </a:t>
             </a:r>
             <a:r>
               <a:rPr sz="1500" b="0" i="0">
@@ -30476,9 +30476,9 @@
                 <a:latin typeface="Inter"/>
                 <a:ea typeface="Inter"/>
                 <a:cs typeface="Inter"/>
-                <a:hlinkClick xmlns:r="http://schemas.openxmlformats.org/officeDocument/2006/relationships" r:id="R66cfdd63cc254381"/>
+                <a:hlinkClick xmlns:r="http://schemas.openxmlformats.org/officeDocument/2006/relationships" r:id="Ra2aee487e5b14083"/>
               </a:rPr>
-              <a:t>Windows</a:t>
+              <a:t>Multipass</a:t>
             </a:r>
             <a:r>
               <a:rPr sz="1500" b="0" i="0">
@@ -30489,7 +30489,7 @@
                 <a:ea typeface="Inter"/>
                 <a:cs typeface="Inter"/>
               </a:rPr>
-              <a:t>. Open Terminal or PowerShell.</a:t>
+              <a:t>. Open Terminal (Mac) or PowerShell (Windows).</a:t>
             </a:r>
           </a:p>
         </p:txBody>
@@ -30759,7 +30759,7 @@
                 <a:ea typeface="Roboto Mono"/>
                 <a:cs typeface="Roboto Mono"/>
               </a:rPr>
-              <a:t>Run these commands in order</a:t>
+              <a:t>Clone, then run setup for your OS</a:t>
             </a:r>
           </a:p>
         </p:txBody>
@@ -30858,7 +30858,7 @@
                 <a:spcPts val="0"/>
               </a:spcAft>
               <a:buNone/>
-              <a:defRPr sz="1275" b="0">
+              <a:defRPr sz="1500" b="0">
                 <a:solidFill>
                   <a:srgbClr val="00E5FF"/>
                 </a:solidFill>
@@ -30868,179 +30868,7 @@
               </a:defRPr>
             </a:pPr>
             <a:r>
-              <a:rPr sz="1275" b="0" i="0">
-                <a:solidFill>
-                  <a:srgbClr val="00E5FF"/>
-                </a:solidFill>
-                <a:latin typeface="Roboto Mono"/>
-                <a:ea typeface="Roboto Mono"/>
-                <a:cs typeface="Roboto Mono"/>
-              </a:rPr>
-              <a:t># Mac Terminal / Windows PowerShell</a:t>
-            </a:r>
-          </a:p>
-          <a:p xmlns:a="http://schemas.openxmlformats.org/drawingml/2006/main">
-            <a:pPr marL="0" indent="0" algn="l">
-              <a:spcBef>
-                <a:spcPts val="0"/>
-              </a:spcBef>
-              <a:spcAft>
-                <a:spcPts val="0"/>
-              </a:spcAft>
-              <a:buNone/>
-              <a:defRPr sz="1275" b="0">
-                <a:solidFill>
-                  <a:srgbClr val="00E5FF"/>
-                </a:solidFill>
-                <a:latin typeface="Roboto Mono"/>
-                <a:ea typeface="Roboto Mono"/>
-                <a:cs typeface="Roboto Mono"/>
-              </a:defRPr>
-            </a:pPr>
-            <a:r>
-              <a:rPr sz="1275" b="0" i="0">
-                <a:solidFill>
-                  <a:srgbClr val="00E5FF"/>
-                </a:solidFill>
-                <a:latin typeface="Roboto Mono"/>
-                <a:ea typeface="Roboto Mono"/>
-                <a:cs typeface="Roboto Mono"/>
-              </a:rPr>
-              <a:t>multipass launch 24.04 --name falco-lab --cpus 4 --memory 8G --disk 30G</a:t>
-            </a:r>
-          </a:p>
-          <a:p xmlns:a="http://schemas.openxmlformats.org/drawingml/2006/main">
-            <a:pPr marL="0" indent="0" algn="l">
-              <a:spcBef>
-                <a:spcPts val="0"/>
-              </a:spcBef>
-              <a:spcAft>
-                <a:spcPts val="0"/>
-              </a:spcAft>
-              <a:buNone/>
-              <a:defRPr sz="1275" b="0">
-                <a:solidFill>
-                  <a:srgbClr val="00E5FF"/>
-                </a:solidFill>
-                <a:latin typeface="Roboto Mono"/>
-                <a:ea typeface="Roboto Mono"/>
-                <a:cs typeface="Roboto Mono"/>
-              </a:defRPr>
-            </a:pPr>
-            <a:r>
-              <a:rPr sz="1275" b="0" i="0">
-                <a:solidFill>
-                  <a:srgbClr val="00E5FF"/>
-                </a:solidFill>
-                <a:latin typeface="Roboto Mono"/>
-                <a:ea typeface="Roboto Mono"/>
-                <a:cs typeface="Roboto Mono"/>
-              </a:rPr>
-              <a:t>multipass shell falco-lab</a:t>
-            </a:r>
-          </a:p>
-          <a:p xmlns:a="http://schemas.openxmlformats.org/drawingml/2006/main">
-            <a:pPr marL="0" indent="0">
-              <a:spcBef>
-                <a:spcPts val="0"/>
-              </a:spcBef>
-              <a:spcAft>
-                <a:spcPts val="0"/>
-              </a:spcAft>
-              <a:buNone/>
-            </a:pPr>
-            <a:r>
-              <a:rPr sz="1275" b="0" i="0">
-                <a:solidFill>
-                  <a:srgbClr val="00E5FF"/>
-                </a:solidFill>
-                <a:latin typeface="Roboto Mono"/>
-                <a:ea typeface="Roboto Mono"/>
-                <a:cs typeface="Roboto Mono"/>
-              </a:rPr>
-              <a:t/>
-            </a:r>
-          </a:p>
-          <a:p xmlns:a="http://schemas.openxmlformats.org/drawingml/2006/main">
-            <a:pPr marL="0" indent="0" algn="l">
-              <a:spcBef>
-                <a:spcPts val="0"/>
-              </a:spcBef>
-              <a:spcAft>
-                <a:spcPts val="0"/>
-              </a:spcAft>
-              <a:buNone/>
-              <a:defRPr sz="1275" b="0">
-                <a:solidFill>
-                  <a:srgbClr val="00E5FF"/>
-                </a:solidFill>
-                <a:latin typeface="Roboto Mono"/>
-                <a:ea typeface="Roboto Mono"/>
-                <a:cs typeface="Roboto Mono"/>
-              </a:defRPr>
-            </a:pPr>
-            <a:r>
-              <a:rPr sz="1275" b="0" i="0">
-                <a:solidFill>
-                  <a:srgbClr val="00E5FF"/>
-                </a:solidFill>
-                <a:latin typeface="Roboto Mono"/>
-                <a:ea typeface="Roboto Mono"/>
-                <a:cs typeface="Roboto Mono"/>
-              </a:rPr>
-              <a:t># Inside Ubuntu</a:t>
-            </a:r>
-          </a:p>
-          <a:p xmlns:a="http://schemas.openxmlformats.org/drawingml/2006/main">
-            <a:pPr marL="0" indent="0" algn="l">
-              <a:spcBef>
-                <a:spcPts val="0"/>
-              </a:spcBef>
-              <a:spcAft>
-                <a:spcPts val="0"/>
-              </a:spcAft>
-              <a:buNone/>
-              <a:defRPr sz="1275" b="0">
-                <a:solidFill>
-                  <a:srgbClr val="00E5FF"/>
-                </a:solidFill>
-                <a:latin typeface="Roboto Mono"/>
-                <a:ea typeface="Roboto Mono"/>
-                <a:cs typeface="Roboto Mono"/>
-              </a:defRPr>
-            </a:pPr>
-            <a:r>
-              <a:rPr sz="1275" b="0" i="0">
-                <a:solidFill>
-                  <a:srgbClr val="00E5FF"/>
-                </a:solidFill>
-                <a:latin typeface="Roboto Mono"/>
-                <a:ea typeface="Roboto Mono"/>
-                <a:cs typeface="Roboto Mono"/>
-              </a:rPr>
-              <a:t>sudo apt-get update &amp;&amp; sudo apt-get install -y git</a:t>
-            </a:r>
-          </a:p>
-          <a:p xmlns:a="http://schemas.openxmlformats.org/drawingml/2006/main">
-            <a:pPr marL="0" indent="0" algn="l">
-              <a:spcBef>
-                <a:spcPts val="0"/>
-              </a:spcBef>
-              <a:spcAft>
-                <a:spcPts val="0"/>
-              </a:spcAft>
-              <a:buNone/>
-              <a:defRPr sz="1275" b="0">
-                <a:solidFill>
-                  <a:srgbClr val="00E5FF"/>
-                </a:solidFill>
-                <a:latin typeface="Roboto Mono"/>
-                <a:ea typeface="Roboto Mono"/>
-                <a:cs typeface="Roboto Mono"/>
-              </a:defRPr>
-            </a:pPr>
-            <a:r>
-              <a:rPr sz="1275" b="0" i="0">
+              <a:rPr sz="1500" b="0" i="0">
                 <a:solidFill>
                   <a:srgbClr val="00E5FF"/>
                 </a:solidFill>
@@ -31060,7 +30888,7 @@
                 <a:spcPts val="0"/>
               </a:spcAft>
               <a:buNone/>
-              <a:defRPr sz="1275" b="0">
+              <a:defRPr sz="1500" b="0">
                 <a:solidFill>
                   <a:srgbClr val="00E5FF"/>
                 </a:solidFill>
@@ -31070,7 +30898,7 @@
               </a:defRPr>
             </a:pPr>
             <a:r>
-              <a:rPr sz="1275" b="0" i="0">
+              <a:rPr sz="1500" b="0" i="0">
                 <a:solidFill>
                   <a:srgbClr val="00E5FF"/>
                 </a:solidFill>
@@ -31082,6 +30910,28 @@
             </a:r>
           </a:p>
           <a:p xmlns:a="http://schemas.openxmlformats.org/drawingml/2006/main">
+            <a:pPr marL="0" indent="0">
+              <a:spcBef>
+                <a:spcPts val="0"/>
+              </a:spcBef>
+              <a:spcAft>
+                <a:spcPts val="0"/>
+              </a:spcAft>
+              <a:buNone/>
+            </a:pPr>
+            <a:r>
+              <a:rPr sz="1500" b="0" i="0">
+                <a:solidFill>
+                  <a:srgbClr val="00E5FF"/>
+                </a:solidFill>
+                <a:latin typeface="Roboto Mono"/>
+                <a:ea typeface="Roboto Mono"/>
+                <a:cs typeface="Roboto Mono"/>
+              </a:rPr>
+              <a:t/>
+            </a:r>
+          </a:p>
+          <a:p xmlns:a="http://schemas.openxmlformats.org/drawingml/2006/main">
             <a:pPr marL="0" indent="0" algn="l">
               <a:spcBef>
                 <a:spcPts val="0"/>
@@ -31090,7 +30940,7 @@
                 <a:spcPts val="0"/>
               </a:spcAft>
               <a:buNone/>
-              <a:defRPr sz="1275" b="0">
+              <a:defRPr sz="1500" b="0">
                 <a:solidFill>
                   <a:srgbClr val="00E5FF"/>
                 </a:solidFill>
@@ -31100,7 +30950,37 @@
               </a:defRPr>
             </a:pPr>
             <a:r>
-              <a:rPr sz="1275" b="0" i="0">
+              <a:rPr sz="1500" b="0" i="0">
+                <a:solidFill>
+                  <a:srgbClr val="00E5FF"/>
+                </a:solidFill>
+                <a:latin typeface="Roboto Mono"/>
+                <a:ea typeface="Roboto Mono"/>
+                <a:cs typeface="Roboto Mono"/>
+              </a:rPr>
+              <a:t># Mac</a:t>
+            </a:r>
+          </a:p>
+          <a:p xmlns:a="http://schemas.openxmlformats.org/drawingml/2006/main">
+            <a:pPr marL="0" indent="0" algn="l">
+              <a:spcBef>
+                <a:spcPts val="0"/>
+              </a:spcBef>
+              <a:spcAft>
+                <a:spcPts val="0"/>
+              </a:spcAft>
+              <a:buNone/>
+              <a:defRPr sz="1500" b="0">
+                <a:solidFill>
+                  <a:srgbClr val="00E5FF"/>
+                </a:solidFill>
+                <a:latin typeface="Roboto Mono"/>
+                <a:ea typeface="Roboto Mono"/>
+                <a:cs typeface="Roboto Mono"/>
+              </a:defRPr>
+            </a:pPr>
+            <a:r>
+              <a:rPr sz="1500" b="0" i="0">
                 <a:solidFill>
                   <a:srgbClr val="00E5FF"/>
                 </a:solidFill>
@@ -31112,6 +30992,28 @@
             </a:r>
           </a:p>
           <a:p xmlns:a="http://schemas.openxmlformats.org/drawingml/2006/main">
+            <a:pPr marL="0" indent="0">
+              <a:spcBef>
+                <a:spcPts val="0"/>
+              </a:spcBef>
+              <a:spcAft>
+                <a:spcPts val="0"/>
+              </a:spcAft>
+              <a:buNone/>
+            </a:pPr>
+            <a:r>
+              <a:rPr sz="1500" b="0" i="0">
+                <a:solidFill>
+                  <a:srgbClr val="00E5FF"/>
+                </a:solidFill>
+                <a:latin typeface="Roboto Mono"/>
+                <a:ea typeface="Roboto Mono"/>
+                <a:cs typeface="Roboto Mono"/>
+              </a:rPr>
+              <a:t/>
+            </a:r>
+          </a:p>
+          <a:p xmlns:a="http://schemas.openxmlformats.org/drawingml/2006/main">
             <a:pPr marL="0" indent="0" algn="l">
               <a:spcBef>
                 <a:spcPts val="0"/>
@@ -31120,7 +31022,7 @@
                 <a:spcPts val="0"/>
               </a:spcAft>
               <a:buNone/>
-              <a:defRPr sz="1275" b="0">
+              <a:defRPr sz="1500" b="0">
                 <a:solidFill>
                   <a:srgbClr val="00E5FF"/>
                 </a:solidFill>
@@ -31130,7 +31032,7 @@
               </a:defRPr>
             </a:pPr>
             <a:r>
-              <a:rPr sz="1275" b="0" i="0">
+              <a:rPr sz="1500" b="0" i="0">
                 <a:solidFill>
                   <a:srgbClr val="00E5FF"/>
                 </a:solidFill>
@@ -31138,7 +31040,7 @@
                 <a:ea typeface="Roboto Mono"/>
                 <a:cs typeface="Roboto Mono"/>
               </a:rPr>
-              <a:t>bash scripts/build.sh</a:t>
+              <a:t># Windows (PowerShell)</a:t>
             </a:r>
           </a:p>
           <a:p xmlns:a="http://schemas.openxmlformats.org/drawingml/2006/main">
@@ -31150,7 +31052,7 @@
                 <a:spcPts val="0"/>
               </a:spcAft>
               <a:buNone/>
-              <a:defRPr sz="1275" b="0">
+              <a:defRPr sz="1500" b="0">
                 <a:solidFill>
                   <a:srgbClr val="00E5FF"/>
                 </a:solidFill>
@@ -31160,7 +31062,7 @@
               </a:defRPr>
             </a:pPr>
             <a:r>
-              <a:rPr sz="1275" b="0" i="0">
+              <a:rPr sz="1500" b="0" i="0">
                 <a:solidFill>
                   <a:srgbClr val="00E5FF"/>
                 </a:solidFill>
@@ -31168,37 +31070,7 @@
                 <a:ea typeface="Roboto Mono"/>
                 <a:cs typeface="Roboto Mono"/>
               </a:rPr>
-              <a:t>sudo ./build/bin/workshop-agent</a:t>
-            </a:r>
-          </a:p>
-          <a:p xmlns:a="http://schemas.openxmlformats.org/drawingml/2006/main">
-            <a:pPr marL="0" indent="0" algn="l">
-              <a:spcBef>
-                <a:spcPts val="0"/>
-              </a:spcBef>
-              <a:spcAft>
-                <a:spcPts val="0"/>
-              </a:spcAft>
-              <a:buNone/>
-              <a:defRPr sz="1275" b="0">
-                <a:solidFill>
-                  <a:srgbClr val="00E5FF"/>
-                </a:solidFill>
-                <a:latin typeface="Roboto Mono"/>
-                <a:ea typeface="Roboto Mono"/>
-                <a:cs typeface="Roboto Mono"/>
-              </a:defRPr>
-            </a:pPr>
-            <a:r>
-              <a:rPr sz="1275" b="0" i="0">
-                <a:solidFill>
-                  <a:srgbClr val="00E5FF"/>
-                </a:solidFill>
-                <a:latin typeface="Roboto Mono"/>
-                <a:ea typeface="Roboto Mono"/>
-                <a:cs typeface="Roboto Mono"/>
-              </a:rPr>
-              <a:t># After Ready appears, stop with Ctrl-C.</a:t>
+              <a:t>powershell -ExecutionPolicy Bypass -File scripts/setup.ps1</a:t>
             </a:r>
           </a:p>
         </p:txBody>
@@ -31848,7 +31720,7 @@
           <p:nvPr/>
         </p:nvPicPr>
         <p:blipFill rotWithShape="1">
-          <a:blip xmlns:r="http://schemas.openxmlformats.org/officeDocument/2006/relationships" xmlns:a="http://schemas.openxmlformats.org/drawingml/2006/main" r:embed="R55ff55e0cc144fca">
+          <a:blip xmlns:r="http://schemas.openxmlformats.org/officeDocument/2006/relationships" xmlns:a="http://schemas.openxmlformats.org/drawingml/2006/main" r:embed="R30e6846361db4855">
             <a:alphaModFix/>
           </a:blip>
           <a:srcRect xmlns:a="http://schemas.openxmlformats.org/drawingml/2006/main" l="0" t="0" r="0" b="0"/>
@@ -31876,7 +31748,7 @@
           <p:nvPr/>
         </p:nvPicPr>
         <p:blipFill rotWithShape="1">
-          <a:blip xmlns:r="http://schemas.openxmlformats.org/officeDocument/2006/relationships" xmlns:a="http://schemas.openxmlformats.org/drawingml/2006/main" r:embed="R55ff55e0cc144fca">
+          <a:blip xmlns:r="http://schemas.openxmlformats.org/officeDocument/2006/relationships" xmlns:a="http://schemas.openxmlformats.org/drawingml/2006/main" r:embed="R30e6846361db4855">
             <a:alphaModFix/>
           </a:blip>
           <a:srcRect xmlns:a="http://schemas.openxmlformats.org/drawingml/2006/main" l="0" t="0" r="0" b="0"/>
@@ -31904,7 +31776,7 @@
           <p:nvPr/>
         </p:nvPicPr>
         <p:blipFill rotWithShape="1">
-          <a:blip xmlns:r="http://schemas.openxmlformats.org/officeDocument/2006/relationships" xmlns:a="http://schemas.openxmlformats.org/drawingml/2006/main" r:embed="R55ff55e0cc144fca">
+          <a:blip xmlns:r="http://schemas.openxmlformats.org/officeDocument/2006/relationships" xmlns:a="http://schemas.openxmlformats.org/drawingml/2006/main" r:embed="R30e6846361db4855">
             <a:alphaModFix/>
           </a:blip>
           <a:srcRect xmlns:a="http://schemas.openxmlformats.org/drawingml/2006/main" l="0" t="0" r="0" b="0"/>
@@ -31932,7 +31804,7 @@
           <p:nvPr/>
         </p:nvPicPr>
         <p:blipFill rotWithShape="1">
-          <a:blip xmlns:r="http://schemas.openxmlformats.org/officeDocument/2006/relationships" xmlns:a="http://schemas.openxmlformats.org/drawingml/2006/main" r:embed="R55ff55e0cc144fca">
+          <a:blip xmlns:r="http://schemas.openxmlformats.org/officeDocument/2006/relationships" xmlns:a="http://schemas.openxmlformats.org/drawingml/2006/main" r:embed="R30e6846361db4855">
             <a:alphaModFix/>
           </a:blip>
           <a:srcRect xmlns:a="http://schemas.openxmlformats.org/drawingml/2006/main" l="0" t="0" r="0" b="0"/>
@@ -33925,7 +33797,7 @@
           <p:nvPr/>
         </p:nvPicPr>
         <p:blipFill rotWithShape="1">
-          <a:blip xmlns:r="http://schemas.openxmlformats.org/officeDocument/2006/relationships" xmlns:a="http://schemas.openxmlformats.org/drawingml/2006/main" r:embed="R94378b6e7b2f4be4">
+          <a:blip xmlns:r="http://schemas.openxmlformats.org/officeDocument/2006/relationships" xmlns:a="http://schemas.openxmlformats.org/drawingml/2006/main" r:embed="R7d1b2c0209af42d5">
             <a:alphaModFix/>
           </a:blip>
           <a:srcRect xmlns:a="http://schemas.openxmlformats.org/drawingml/2006/main" l="0" t="0" r="0" b="0"/>
@@ -33953,7 +33825,7 @@
           <p:nvPr/>
         </p:nvPicPr>
         <p:blipFill rotWithShape="1">
-          <a:blip xmlns:r="http://schemas.openxmlformats.org/officeDocument/2006/relationships" xmlns:a="http://schemas.openxmlformats.org/drawingml/2006/main" r:embed="R94378b6e7b2f4be4">
+          <a:blip xmlns:r="http://schemas.openxmlformats.org/officeDocument/2006/relationships" xmlns:a="http://schemas.openxmlformats.org/drawingml/2006/main" r:embed="R7d1b2c0209af42d5">
             <a:alphaModFix/>
           </a:blip>
           <a:srcRect xmlns:a="http://schemas.openxmlformats.org/drawingml/2006/main" l="0" t="0" r="0" b="0"/>
@@ -33981,7 +33853,7 @@
           <p:nvPr/>
         </p:nvPicPr>
         <p:blipFill rotWithShape="1">
-          <a:blip xmlns:r="http://schemas.openxmlformats.org/officeDocument/2006/relationships" xmlns:a="http://schemas.openxmlformats.org/drawingml/2006/main" r:embed="R94378b6e7b2f4be4">
+          <a:blip xmlns:r="http://schemas.openxmlformats.org/officeDocument/2006/relationships" xmlns:a="http://schemas.openxmlformats.org/drawingml/2006/main" r:embed="R7d1b2c0209af42d5">
             <a:alphaModFix/>
           </a:blip>
           <a:srcRect xmlns:a="http://schemas.openxmlformats.org/drawingml/2006/main" l="0" t="0" r="0" b="0"/>
@@ -34009,7 +33881,7 @@
           <p:nvPr/>
         </p:nvPicPr>
         <p:blipFill rotWithShape="1">
-          <a:blip xmlns:r="http://schemas.openxmlformats.org/officeDocument/2006/relationships" xmlns:a="http://schemas.openxmlformats.org/drawingml/2006/main" r:embed="R94378b6e7b2f4be4">
+          <a:blip xmlns:r="http://schemas.openxmlformats.org/officeDocument/2006/relationships" xmlns:a="http://schemas.openxmlformats.org/drawingml/2006/main" r:embed="R7d1b2c0209af42d5">
             <a:alphaModFix/>
           </a:blip>
           <a:srcRect xmlns:a="http://schemas.openxmlformats.org/drawingml/2006/main" l="0" t="0" r="0" b="0"/>
@@ -36108,7 +35980,7 @@
           <p:nvPr/>
         </p:nvPicPr>
         <p:blipFill rotWithShape="1">
-          <a:blip xmlns:r="http://schemas.openxmlformats.org/officeDocument/2006/relationships" xmlns:a="http://schemas.openxmlformats.org/drawingml/2006/main" r:embed="R72933d5b4db24f1b">
+          <a:blip xmlns:r="http://schemas.openxmlformats.org/officeDocument/2006/relationships" xmlns:a="http://schemas.openxmlformats.org/drawingml/2006/main" r:embed="R437bdd349e004fb1">
             <a:alphaModFix/>
           </a:blip>
           <a:srcRect xmlns:a="http://schemas.openxmlformats.org/drawingml/2006/main" l="0" t="0" r="0" b="0"/>
@@ -36136,7 +36008,7 @@
           <p:nvPr/>
         </p:nvPicPr>
         <p:blipFill rotWithShape="1">
-          <a:blip xmlns:r="http://schemas.openxmlformats.org/officeDocument/2006/relationships" xmlns:a="http://schemas.openxmlformats.org/drawingml/2006/main" r:embed="R72933d5b4db24f1b">
+          <a:blip xmlns:r="http://schemas.openxmlformats.org/officeDocument/2006/relationships" xmlns:a="http://schemas.openxmlformats.org/drawingml/2006/main" r:embed="R437bdd349e004fb1">
             <a:alphaModFix/>
           </a:blip>
           <a:srcRect xmlns:a="http://schemas.openxmlformats.org/drawingml/2006/main" l="0" t="0" r="0" b="0"/>
@@ -36164,7 +36036,7 @@
           <p:nvPr/>
         </p:nvPicPr>
         <p:blipFill rotWithShape="1">
-          <a:blip xmlns:r="http://schemas.openxmlformats.org/officeDocument/2006/relationships" xmlns:a="http://schemas.openxmlformats.org/drawingml/2006/main" r:embed="R72933d5b4db24f1b">
+          <a:blip xmlns:r="http://schemas.openxmlformats.org/officeDocument/2006/relationships" xmlns:a="http://schemas.openxmlformats.org/drawingml/2006/main" r:embed="R437bdd349e004fb1">
             <a:alphaModFix/>
           </a:blip>
           <a:srcRect xmlns:a="http://schemas.openxmlformats.org/drawingml/2006/main" l="0" t="0" r="0" b="0"/>
@@ -36192,7 +36064,7 @@
           <p:nvPr/>
         </p:nvPicPr>
         <p:blipFill rotWithShape="1">
-          <a:blip xmlns:r="http://schemas.openxmlformats.org/officeDocument/2006/relationships" xmlns:a="http://schemas.openxmlformats.org/drawingml/2006/main" r:embed="R72933d5b4db24f1b">
+          <a:blip xmlns:r="http://schemas.openxmlformats.org/officeDocument/2006/relationships" xmlns:a="http://schemas.openxmlformats.org/drawingml/2006/main" r:embed="R437bdd349e004fb1">
             <a:alphaModFix/>
           </a:blip>
           <a:srcRect xmlns:a="http://schemas.openxmlformats.org/drawingml/2006/main" l="0" t="0" r="0" b="0"/>
@@ -38297,7 +38169,7 @@
           <p:nvPr/>
         </p:nvPicPr>
         <p:blipFill rotWithShape="1">
-          <a:blip xmlns:r="http://schemas.openxmlformats.org/officeDocument/2006/relationships" xmlns:a="http://schemas.openxmlformats.org/drawingml/2006/main" r:embed="Rc7421ea4a4fd43dd">
+          <a:blip xmlns:r="http://schemas.openxmlformats.org/officeDocument/2006/relationships" xmlns:a="http://schemas.openxmlformats.org/drawingml/2006/main" r:embed="R90b52eade17247ee">
             <a:alphaModFix/>
           </a:blip>
           <a:srcRect xmlns:a="http://schemas.openxmlformats.org/drawingml/2006/main" l="0" t="0" r="0" b="0"/>
@@ -38325,7 +38197,7 @@
           <p:nvPr/>
         </p:nvPicPr>
         <p:blipFill rotWithShape="1">
-          <a:blip xmlns:r="http://schemas.openxmlformats.org/officeDocument/2006/relationships" xmlns:a="http://schemas.openxmlformats.org/drawingml/2006/main" r:embed="Rc7421ea4a4fd43dd">
+          <a:blip xmlns:r="http://schemas.openxmlformats.org/officeDocument/2006/relationships" xmlns:a="http://schemas.openxmlformats.org/drawingml/2006/main" r:embed="R90b52eade17247ee">
             <a:alphaModFix/>
           </a:blip>
           <a:srcRect xmlns:a="http://schemas.openxmlformats.org/drawingml/2006/main" l="0" t="0" r="0" b="0"/>
@@ -38353,7 +38225,7 @@
           <p:nvPr/>
         </p:nvPicPr>
         <p:blipFill rotWithShape="1">
-          <a:blip xmlns:r="http://schemas.openxmlformats.org/officeDocument/2006/relationships" xmlns:a="http://schemas.openxmlformats.org/drawingml/2006/main" r:embed="Rc7421ea4a4fd43dd">
+          <a:blip xmlns:r="http://schemas.openxmlformats.org/officeDocument/2006/relationships" xmlns:a="http://schemas.openxmlformats.org/drawingml/2006/main" r:embed="R90b52eade17247ee">
             <a:alphaModFix/>
           </a:blip>
           <a:srcRect xmlns:a="http://schemas.openxmlformats.org/drawingml/2006/main" l="0" t="0" r="0" b="0"/>
@@ -38381,7 +38253,7 @@
           <p:nvPr/>
         </p:nvPicPr>
         <p:blipFill rotWithShape="1">
-          <a:blip xmlns:r="http://schemas.openxmlformats.org/officeDocument/2006/relationships" xmlns:a="http://schemas.openxmlformats.org/drawingml/2006/main" r:embed="Rc7421ea4a4fd43dd">
+          <a:blip xmlns:r="http://schemas.openxmlformats.org/officeDocument/2006/relationships" xmlns:a="http://schemas.openxmlformats.org/drawingml/2006/main" r:embed="R90b52eade17247ee">
             <a:alphaModFix/>
           </a:blip>
           <a:srcRect xmlns:a="http://schemas.openxmlformats.org/drawingml/2006/main" l="0" t="0" r="0" b="0"/>
@@ -40270,7 +40142,7 @@
           <p:nvPr/>
         </p:nvPicPr>
         <p:blipFill rotWithShape="1">
-          <a:blip xmlns:r="http://schemas.openxmlformats.org/officeDocument/2006/relationships" xmlns:a="http://schemas.openxmlformats.org/drawingml/2006/main" r:embed="R2b76aa5a87c846d0">
+          <a:blip xmlns:r="http://schemas.openxmlformats.org/officeDocument/2006/relationships" xmlns:a="http://schemas.openxmlformats.org/drawingml/2006/main" r:embed="Rd5713e40a2af479b">
             <a:alphaModFix/>
           </a:blip>
           <a:srcRect xmlns:a="http://schemas.openxmlformats.org/drawingml/2006/main" l="0" t="0" r="0" b="0"/>
@@ -40298,7 +40170,7 @@
           <p:nvPr/>
         </p:nvPicPr>
         <p:blipFill rotWithShape="1">
-          <a:blip xmlns:r="http://schemas.openxmlformats.org/officeDocument/2006/relationships" xmlns:a="http://schemas.openxmlformats.org/drawingml/2006/main" r:embed="R2b76aa5a87c846d0">
+          <a:blip xmlns:r="http://schemas.openxmlformats.org/officeDocument/2006/relationships" xmlns:a="http://schemas.openxmlformats.org/drawingml/2006/main" r:embed="Rd5713e40a2af479b">
             <a:alphaModFix/>
           </a:blip>
           <a:srcRect xmlns:a="http://schemas.openxmlformats.org/drawingml/2006/main" l="0" t="0" r="0" b="0"/>
@@ -40326,7 +40198,7 @@
           <p:nvPr/>
         </p:nvPicPr>
         <p:blipFill rotWithShape="1">
-          <a:blip xmlns:r="http://schemas.openxmlformats.org/officeDocument/2006/relationships" xmlns:a="http://schemas.openxmlformats.org/drawingml/2006/main" r:embed="R2b76aa5a87c846d0">
+          <a:blip xmlns:r="http://schemas.openxmlformats.org/officeDocument/2006/relationships" xmlns:a="http://schemas.openxmlformats.org/drawingml/2006/main" r:embed="Rd5713e40a2af479b">
             <a:alphaModFix/>
           </a:blip>
           <a:srcRect xmlns:a="http://schemas.openxmlformats.org/drawingml/2006/main" l="0" t="0" r="0" b="0"/>
@@ -40354,7 +40226,7 @@
           <p:nvPr/>
         </p:nvPicPr>
         <p:blipFill rotWithShape="1">
-          <a:blip xmlns:r="http://schemas.openxmlformats.org/officeDocument/2006/relationships" xmlns:a="http://schemas.openxmlformats.org/drawingml/2006/main" r:embed="R2b76aa5a87c846d0">
+          <a:blip xmlns:r="http://schemas.openxmlformats.org/officeDocument/2006/relationships" xmlns:a="http://schemas.openxmlformats.org/drawingml/2006/main" r:embed="Rd5713e40a2af479b">
             <a:alphaModFix/>
           </a:blip>
           <a:srcRect xmlns:a="http://schemas.openxmlformats.org/drawingml/2006/main" l="0" t="0" r="0" b="0"/>
@@ -41495,7 +41367,37 @@
                 <a:ea typeface="Roboto Mono"/>
                 <a:cs typeface="Roboto Mono"/>
               </a:rPr>
-              <a:t># Ubuntu terminal A</a:t>
+              <a:t># Host terminal A: enter Ubuntu</a:t>
+            </a:r>
+          </a:p>
+          <a:p xmlns:a="http://schemas.openxmlformats.org/drawingml/2006/main">
+            <a:pPr marL="0" indent="0" algn="l">
+              <a:spcBef>
+                <a:spcPts val="0"/>
+              </a:spcBef>
+              <a:spcAft>
+                <a:spcPts val="0"/>
+              </a:spcAft>
+              <a:buNone/>
+              <a:defRPr sz="1350" b="0">
+                <a:solidFill>
+                  <a:srgbClr val="00E5FF"/>
+                </a:solidFill>
+                <a:latin typeface="Roboto Mono"/>
+                <a:ea typeface="Roboto Mono"/>
+                <a:cs typeface="Roboto Mono"/>
+              </a:defRPr>
+            </a:pPr>
+            <a:r>
+              <a:rPr sz="1350" b="0" i="0">
+                <a:solidFill>
+                  <a:srgbClr val="00E5FF"/>
+                </a:solidFill>
+                <a:latin typeface="Roboto Mono"/>
+                <a:ea typeface="Roboto Mono"/>
+                <a:cs typeface="Roboto Mono"/>
+              </a:rPr>
+              <a:t>multipass shell falco-lab</a:t>
             </a:r>
           </a:p>
           <a:p xmlns:a="http://schemas.openxmlformats.org/drawingml/2006/main">
@@ -42399,7 +42301,7 @@
           <p:nvPr/>
         </p:nvPicPr>
         <p:blipFill rotWithShape="1">
-          <a:blip xmlns:r="http://schemas.openxmlformats.org/officeDocument/2006/relationships" xmlns:a="http://schemas.openxmlformats.org/drawingml/2006/main" r:embed="Ra52bbd806d3442ee">
+          <a:blip xmlns:r="http://schemas.openxmlformats.org/officeDocument/2006/relationships" xmlns:a="http://schemas.openxmlformats.org/drawingml/2006/main" r:embed="R4f2b6e7cd82242a2">
             <a:alphaModFix/>
           </a:blip>
           <a:srcRect xmlns:a="http://schemas.openxmlformats.org/drawingml/2006/main" l="0" t="0" r="0" b="0"/>
@@ -42427,7 +42329,7 @@
           <p:nvPr/>
         </p:nvPicPr>
         <p:blipFill rotWithShape="1">
-          <a:blip xmlns:r="http://schemas.openxmlformats.org/officeDocument/2006/relationships" xmlns:a="http://schemas.openxmlformats.org/drawingml/2006/main" r:embed="Ra52bbd806d3442ee">
+          <a:blip xmlns:r="http://schemas.openxmlformats.org/officeDocument/2006/relationships" xmlns:a="http://schemas.openxmlformats.org/drawingml/2006/main" r:embed="R4f2b6e7cd82242a2">
             <a:alphaModFix/>
           </a:blip>
           <a:srcRect xmlns:a="http://schemas.openxmlformats.org/drawingml/2006/main" l="0" t="0" r="0" b="0"/>
@@ -42455,7 +42357,7 @@
           <p:nvPr/>
         </p:nvPicPr>
         <p:blipFill rotWithShape="1">
-          <a:blip xmlns:r="http://schemas.openxmlformats.org/officeDocument/2006/relationships" xmlns:a="http://schemas.openxmlformats.org/drawingml/2006/main" r:embed="Ra52bbd806d3442ee">
+          <a:blip xmlns:r="http://schemas.openxmlformats.org/officeDocument/2006/relationships" xmlns:a="http://schemas.openxmlformats.org/drawingml/2006/main" r:embed="R4f2b6e7cd82242a2">
             <a:alphaModFix/>
           </a:blip>
           <a:srcRect xmlns:a="http://schemas.openxmlformats.org/drawingml/2006/main" l="0" t="0" r="0" b="0"/>
@@ -42483,7 +42385,7 @@
           <p:nvPr/>
         </p:nvPicPr>
         <p:blipFill rotWithShape="1">
-          <a:blip xmlns:r="http://schemas.openxmlformats.org/officeDocument/2006/relationships" xmlns:a="http://schemas.openxmlformats.org/drawingml/2006/main" r:embed="Ra52bbd806d3442ee">
+          <a:blip xmlns:r="http://schemas.openxmlformats.org/officeDocument/2006/relationships" xmlns:a="http://schemas.openxmlformats.org/drawingml/2006/main" r:embed="R4f2b6e7cd82242a2">
             <a:alphaModFix/>
           </a:blip>
           <a:srcRect xmlns:a="http://schemas.openxmlformats.org/drawingml/2006/main" l="0" t="0" r="0" b="0"/>
@@ -44432,7 +44334,7 @@
           <p:nvPr/>
         </p:nvPicPr>
         <p:blipFill rotWithShape="1">
-          <a:blip xmlns:r="http://schemas.openxmlformats.org/officeDocument/2006/relationships" xmlns:a="http://schemas.openxmlformats.org/drawingml/2006/main" r:embed="Ra9d9a7555eda4806">
+          <a:blip xmlns:r="http://schemas.openxmlformats.org/officeDocument/2006/relationships" xmlns:a="http://schemas.openxmlformats.org/drawingml/2006/main" r:embed="R337e4ae4f2584d29">
             <a:alphaModFix/>
           </a:blip>
           <a:srcRect xmlns:a="http://schemas.openxmlformats.org/drawingml/2006/main" l="0" t="0" r="0" b="0"/>
@@ -44460,7 +44362,7 @@
           <p:nvPr/>
         </p:nvPicPr>
         <p:blipFill rotWithShape="1">
-          <a:blip xmlns:r="http://schemas.openxmlformats.org/officeDocument/2006/relationships" xmlns:a="http://schemas.openxmlformats.org/drawingml/2006/main" r:embed="Ra9d9a7555eda4806">
+          <a:blip xmlns:r="http://schemas.openxmlformats.org/officeDocument/2006/relationships" xmlns:a="http://schemas.openxmlformats.org/drawingml/2006/main" r:embed="R337e4ae4f2584d29">
             <a:alphaModFix/>
           </a:blip>
           <a:srcRect xmlns:a="http://schemas.openxmlformats.org/drawingml/2006/main" l="0" t="0" r="0" b="0"/>
@@ -44488,7 +44390,7 @@
           <p:nvPr/>
         </p:nvPicPr>
         <p:blipFill rotWithShape="1">
-          <a:blip xmlns:r="http://schemas.openxmlformats.org/officeDocument/2006/relationships" xmlns:a="http://schemas.openxmlformats.org/drawingml/2006/main" r:embed="Ra9d9a7555eda4806">
+          <a:blip xmlns:r="http://schemas.openxmlformats.org/officeDocument/2006/relationships" xmlns:a="http://schemas.openxmlformats.org/drawingml/2006/main" r:embed="R337e4ae4f2584d29">
             <a:alphaModFix/>
           </a:blip>
           <a:srcRect xmlns:a="http://schemas.openxmlformats.org/drawingml/2006/main" l="0" t="0" r="0" b="0"/>
@@ -44516,7 +44418,7 @@
           <p:nvPr/>
         </p:nvPicPr>
         <p:blipFill rotWithShape="1">
-          <a:blip xmlns:r="http://schemas.openxmlformats.org/officeDocument/2006/relationships" xmlns:a="http://schemas.openxmlformats.org/drawingml/2006/main" r:embed="Ra9d9a7555eda4806">
+          <a:blip xmlns:r="http://schemas.openxmlformats.org/officeDocument/2006/relationships" xmlns:a="http://schemas.openxmlformats.org/drawingml/2006/main" r:embed="R337e4ae4f2584d29">
             <a:alphaModFix/>
           </a:blip>
           <a:srcRect xmlns:a="http://schemas.openxmlformats.org/drawingml/2006/main" l="0" t="0" r="0" b="0"/>
@@ -46539,7 +46441,7 @@
           <p:nvPr/>
         </p:nvPicPr>
         <p:blipFill rotWithShape="1">
-          <a:blip xmlns:r="http://schemas.openxmlformats.org/officeDocument/2006/relationships" xmlns:a="http://schemas.openxmlformats.org/drawingml/2006/main" r:embed="R9e18217bef134028">
+          <a:blip xmlns:r="http://schemas.openxmlformats.org/officeDocument/2006/relationships" xmlns:a="http://schemas.openxmlformats.org/drawingml/2006/main" r:embed="Rdcb7f41557894118">
             <a:alphaModFix/>
           </a:blip>
           <a:srcRect xmlns:a="http://schemas.openxmlformats.org/drawingml/2006/main" l="0" t="0" r="0" b="0"/>
@@ -46567,7 +46469,7 @@
           <p:nvPr/>
         </p:nvPicPr>
         <p:blipFill rotWithShape="1">
-          <a:blip xmlns:r="http://schemas.openxmlformats.org/officeDocument/2006/relationships" xmlns:a="http://schemas.openxmlformats.org/drawingml/2006/main" r:embed="R9e18217bef134028">
+          <a:blip xmlns:r="http://schemas.openxmlformats.org/officeDocument/2006/relationships" xmlns:a="http://schemas.openxmlformats.org/drawingml/2006/main" r:embed="Rdcb7f41557894118">
             <a:alphaModFix/>
           </a:blip>
           <a:srcRect xmlns:a="http://schemas.openxmlformats.org/drawingml/2006/main" l="0" t="0" r="0" b="0"/>
@@ -46595,7 +46497,7 @@
           <p:nvPr/>
         </p:nvPicPr>
         <p:blipFill rotWithShape="1">
-          <a:blip xmlns:r="http://schemas.openxmlformats.org/officeDocument/2006/relationships" xmlns:a="http://schemas.openxmlformats.org/drawingml/2006/main" r:embed="R9e18217bef134028">
+          <a:blip xmlns:r="http://schemas.openxmlformats.org/officeDocument/2006/relationships" xmlns:a="http://schemas.openxmlformats.org/drawingml/2006/main" r:embed="Rdcb7f41557894118">
             <a:alphaModFix/>
           </a:blip>
           <a:srcRect xmlns:a="http://schemas.openxmlformats.org/drawingml/2006/main" l="0" t="0" r="0" b="0"/>
@@ -46623,7 +46525,7 @@
           <p:nvPr/>
         </p:nvPicPr>
         <p:blipFill rotWithShape="1">
-          <a:blip xmlns:r="http://schemas.openxmlformats.org/officeDocument/2006/relationships" xmlns:a="http://schemas.openxmlformats.org/drawingml/2006/main" r:embed="R9e18217bef134028">
+          <a:blip xmlns:r="http://schemas.openxmlformats.org/officeDocument/2006/relationships" xmlns:a="http://schemas.openxmlformats.org/drawingml/2006/main" r:embed="Rdcb7f41557894118">
             <a:alphaModFix/>
           </a:blip>
           <a:srcRect xmlns:a="http://schemas.openxmlformats.org/drawingml/2006/main" l="0" t="0" r="0" b="0"/>
@@ -48594,7 +48496,7 @@
           <p:nvPr/>
         </p:nvPicPr>
         <p:blipFill rotWithShape="1">
-          <a:blip xmlns:r="http://schemas.openxmlformats.org/officeDocument/2006/relationships" xmlns:a="http://schemas.openxmlformats.org/drawingml/2006/main" r:embed="R38b6eddcb7f54203">
+          <a:blip xmlns:r="http://schemas.openxmlformats.org/officeDocument/2006/relationships" xmlns:a="http://schemas.openxmlformats.org/drawingml/2006/main" r:embed="R2b2080c20a3a4022">
             <a:alphaModFix/>
           </a:blip>
           <a:srcRect xmlns:a="http://schemas.openxmlformats.org/drawingml/2006/main" l="0" t="0" r="0" b="0"/>
@@ -48622,7 +48524,7 @@
           <p:nvPr/>
         </p:nvPicPr>
         <p:blipFill rotWithShape="1">
-          <a:blip xmlns:r="http://schemas.openxmlformats.org/officeDocument/2006/relationships" xmlns:a="http://schemas.openxmlformats.org/drawingml/2006/main" r:embed="R38b6eddcb7f54203">
+          <a:blip xmlns:r="http://schemas.openxmlformats.org/officeDocument/2006/relationships" xmlns:a="http://schemas.openxmlformats.org/drawingml/2006/main" r:embed="R2b2080c20a3a4022">
             <a:alphaModFix/>
           </a:blip>
           <a:srcRect xmlns:a="http://schemas.openxmlformats.org/drawingml/2006/main" l="0" t="0" r="0" b="0"/>
@@ -48650,7 +48552,7 @@
           <p:nvPr/>
         </p:nvPicPr>
         <p:blipFill rotWithShape="1">
-          <a:blip xmlns:r="http://schemas.openxmlformats.org/officeDocument/2006/relationships" xmlns:a="http://schemas.openxmlformats.org/drawingml/2006/main" r:embed="R38b6eddcb7f54203">
+          <a:blip xmlns:r="http://schemas.openxmlformats.org/officeDocument/2006/relationships" xmlns:a="http://schemas.openxmlformats.org/drawingml/2006/main" r:embed="R2b2080c20a3a4022">
             <a:alphaModFix/>
           </a:blip>
           <a:srcRect xmlns:a="http://schemas.openxmlformats.org/drawingml/2006/main" l="0" t="0" r="0" b="0"/>
@@ -48678,7 +48580,7 @@
           <p:nvPr/>
         </p:nvPicPr>
         <p:blipFill rotWithShape="1">
-          <a:blip xmlns:r="http://schemas.openxmlformats.org/officeDocument/2006/relationships" xmlns:a="http://schemas.openxmlformats.org/drawingml/2006/main" r:embed="R38b6eddcb7f54203">
+          <a:blip xmlns:r="http://schemas.openxmlformats.org/officeDocument/2006/relationships" xmlns:a="http://schemas.openxmlformats.org/drawingml/2006/main" r:embed="R2b2080c20a3a4022">
             <a:alphaModFix/>
           </a:blip>
           <a:srcRect xmlns:a="http://schemas.openxmlformats.org/drawingml/2006/main" l="0" t="0" r="0" b="0"/>

</xml_diff>

<commit_message>
Simplify pre-setup to clone and run
</commit_message>
<xml_diff>
--- a/presentation/falco-libs-intro.pptx
+++ b/presentation/falco-libs-intro.pptx
@@ -2,84 +2,84 @@
 <file path=ppt/presentation.xml><?xml version="1.0" encoding="utf-8"?>
 <p:presentation xmlns:p="http://schemas.openxmlformats.org/presentationml/2006/main" embedTrueTypeFonts="1" saveSubsetFonts="0">
   <p:sldMasterIdLst>
-    <p:sldMasterId xmlns:r="http://schemas.openxmlformats.org/officeDocument/2006/relationships" id="2147483648" r:id="R6d1e8ddd8f524132"/>
-    <p:sldMasterId xmlns:r="http://schemas.openxmlformats.org/officeDocument/2006/relationships" id="2147483661" r:id="R0b174aae05dd40d8"/>
+    <p:sldMasterId xmlns:r="http://schemas.openxmlformats.org/officeDocument/2006/relationships" id="2147483648" r:id="R25550fa8bad94c6f"/>
+    <p:sldMasterId xmlns:r="http://schemas.openxmlformats.org/officeDocument/2006/relationships" id="2147483661" r:id="R0723a6703b39482f"/>
   </p:sldMasterIdLst>
   <p:notesMasterIdLst>
-    <p:notesMasterId xmlns:r="http://schemas.openxmlformats.org/officeDocument/2006/relationships" r:id="R4d7c6a8aaf774bc0"/>
+    <p:notesMasterId xmlns:r="http://schemas.openxmlformats.org/officeDocument/2006/relationships" r:id="Re64c12cde07e4f9b"/>
   </p:notesMasterIdLst>
   <p:sldIdLst>
-    <p:sldId xmlns:r="http://schemas.openxmlformats.org/officeDocument/2006/relationships" id="256" r:id="Rc84d2982e2a04242"/>
-    <p:sldId xmlns:r="http://schemas.openxmlformats.org/officeDocument/2006/relationships" id="257" r:id="R025ce0882d2b4cfe"/>
-    <p:sldId xmlns:r="http://schemas.openxmlformats.org/officeDocument/2006/relationships" id="258" r:id="R01b102d06b6349ab"/>
-    <p:sldId xmlns:r="http://schemas.openxmlformats.org/officeDocument/2006/relationships" id="259" r:id="R187adf284557433f"/>
-    <p:sldId xmlns:r="http://schemas.openxmlformats.org/officeDocument/2006/relationships" id="260" r:id="Rc7864bd384744261"/>
-    <p:sldId xmlns:r="http://schemas.openxmlformats.org/officeDocument/2006/relationships" id="261" r:id="R3fad38a2a0a54587"/>
-    <p:sldId xmlns:r="http://schemas.openxmlformats.org/officeDocument/2006/relationships" id="262" r:id="R5ddd86170428449c"/>
-    <p:sldId xmlns:r="http://schemas.openxmlformats.org/officeDocument/2006/relationships" id="263" r:id="R7c871f8be2004167"/>
-    <p:sldId xmlns:r="http://schemas.openxmlformats.org/officeDocument/2006/relationships" id="264" r:id="R86afd6f624f047f5"/>
-    <p:sldId xmlns:r="http://schemas.openxmlformats.org/officeDocument/2006/relationships" id="265" r:id="R123cbc70863d4176"/>
-    <p:sldId xmlns:r="http://schemas.openxmlformats.org/officeDocument/2006/relationships" id="266" r:id="R5dc3baf7ea424c1f"/>
-    <p:sldId xmlns:r="http://schemas.openxmlformats.org/officeDocument/2006/relationships" id="267" r:id="R901ca2bc9dd74456"/>
-    <p:sldId xmlns:r="http://schemas.openxmlformats.org/officeDocument/2006/relationships" id="268" r:id="Re7952a4dd91a4bed"/>
-    <p:sldId xmlns:r="http://schemas.openxmlformats.org/officeDocument/2006/relationships" id="269" r:id="R2e5005ded90f4d52"/>
-    <p:sldId xmlns:r="http://schemas.openxmlformats.org/officeDocument/2006/relationships" id="270" r:id="R877f4c135d1c47dc"/>
-    <p:sldId xmlns:r="http://schemas.openxmlformats.org/officeDocument/2006/relationships" id="271" r:id="R999137ad83ba41f4"/>
-    <p:sldId xmlns:r="http://schemas.openxmlformats.org/officeDocument/2006/relationships" id="272" r:id="Ra9dca54c5ca94c02"/>
-    <p:sldId xmlns:r="http://schemas.openxmlformats.org/officeDocument/2006/relationships" id="273" r:id="R474f6dbae9564ea2"/>
-    <p:sldId xmlns:r="http://schemas.openxmlformats.org/officeDocument/2006/relationships" id="274" r:id="R76ddb242f244481a"/>
-    <p:sldId xmlns:r="http://schemas.openxmlformats.org/officeDocument/2006/relationships" id="275" r:id="R6388ff867bd34426"/>
+    <p:sldId xmlns:r="http://schemas.openxmlformats.org/officeDocument/2006/relationships" id="256" r:id="Rff6fff4690a1487d"/>
+    <p:sldId xmlns:r="http://schemas.openxmlformats.org/officeDocument/2006/relationships" id="257" r:id="R488bf42a04274575"/>
+    <p:sldId xmlns:r="http://schemas.openxmlformats.org/officeDocument/2006/relationships" id="258" r:id="R725482f17ec34565"/>
+    <p:sldId xmlns:r="http://schemas.openxmlformats.org/officeDocument/2006/relationships" id="259" r:id="Rab350e980d4d4a51"/>
+    <p:sldId xmlns:r="http://schemas.openxmlformats.org/officeDocument/2006/relationships" id="260" r:id="Rcd4b731b48be43c3"/>
+    <p:sldId xmlns:r="http://schemas.openxmlformats.org/officeDocument/2006/relationships" id="261" r:id="R14356ac4cbbc4e17"/>
+    <p:sldId xmlns:r="http://schemas.openxmlformats.org/officeDocument/2006/relationships" id="262" r:id="R0692f4f3ca1b4b8a"/>
+    <p:sldId xmlns:r="http://schemas.openxmlformats.org/officeDocument/2006/relationships" id="263" r:id="R6d0eda1cec424028"/>
+    <p:sldId xmlns:r="http://schemas.openxmlformats.org/officeDocument/2006/relationships" id="264" r:id="R503eab5341974dfa"/>
+    <p:sldId xmlns:r="http://schemas.openxmlformats.org/officeDocument/2006/relationships" id="265" r:id="Rc6ffd0fadea3435e"/>
+    <p:sldId xmlns:r="http://schemas.openxmlformats.org/officeDocument/2006/relationships" id="266" r:id="Rc5e23a61676d4822"/>
+    <p:sldId xmlns:r="http://schemas.openxmlformats.org/officeDocument/2006/relationships" id="267" r:id="R1fa896bd6c624ca1"/>
+    <p:sldId xmlns:r="http://schemas.openxmlformats.org/officeDocument/2006/relationships" id="268" r:id="R81060abddb1d40af"/>
+    <p:sldId xmlns:r="http://schemas.openxmlformats.org/officeDocument/2006/relationships" id="269" r:id="R634bf8b717544fd4"/>
+    <p:sldId xmlns:r="http://schemas.openxmlformats.org/officeDocument/2006/relationships" id="270" r:id="Re7dc157e1aae402a"/>
+    <p:sldId xmlns:r="http://schemas.openxmlformats.org/officeDocument/2006/relationships" id="271" r:id="Rdb3204923dc94aee"/>
+    <p:sldId xmlns:r="http://schemas.openxmlformats.org/officeDocument/2006/relationships" id="272" r:id="Ra23fde807e3d4fd2"/>
+    <p:sldId xmlns:r="http://schemas.openxmlformats.org/officeDocument/2006/relationships" id="273" r:id="Re03c0af45d9d4d6e"/>
+    <p:sldId xmlns:r="http://schemas.openxmlformats.org/officeDocument/2006/relationships" id="274" r:id="R1346bd4d3b22497e"/>
+    <p:sldId xmlns:r="http://schemas.openxmlformats.org/officeDocument/2006/relationships" id="275" r:id="Rde872e8a1b8d4136"/>
   </p:sldIdLst>
   <p:sldSz cx="9144000" cy="5143500"/>
   <p:notesSz cx="6858000" cy="9144000"/>
   <p:embeddedFontLst>
     <p:embeddedFont>
       <p:font typeface="Roboto Mono Medium"/>
-      <p:regular xmlns:r="http://schemas.openxmlformats.org/officeDocument/2006/relationships" r:id="Rf2b03e6897784050"/>
-      <p:bold xmlns:r="http://schemas.openxmlformats.org/officeDocument/2006/relationships" r:id="Re8aa632db29c4432"/>
-      <p:italic xmlns:r="http://schemas.openxmlformats.org/officeDocument/2006/relationships" r:id="R7911258dfe7d42cc"/>
-      <p:boldItalic xmlns:r="http://schemas.openxmlformats.org/officeDocument/2006/relationships" r:id="R76ed7b64e8f843eb"/>
+      <p:regular xmlns:r="http://schemas.openxmlformats.org/officeDocument/2006/relationships" r:id="R9ffe12f5e7d74120"/>
+      <p:bold xmlns:r="http://schemas.openxmlformats.org/officeDocument/2006/relationships" r:id="R5de9db69d2834cd1"/>
+      <p:italic xmlns:r="http://schemas.openxmlformats.org/officeDocument/2006/relationships" r:id="R3fdc39dd358e42b7"/>
+      <p:boldItalic xmlns:r="http://schemas.openxmlformats.org/officeDocument/2006/relationships" r:id="R08d15496361b46b5"/>
     </p:embeddedFont>
     <p:embeddedFont>
       <p:font typeface="Inter SemiBold"/>
-      <p:regular xmlns:r="http://schemas.openxmlformats.org/officeDocument/2006/relationships" r:id="Rf75e97740cc3416c"/>
-      <p:bold xmlns:r="http://schemas.openxmlformats.org/officeDocument/2006/relationships" r:id="R131a7b8a94224790"/>
-      <p:italic xmlns:r="http://schemas.openxmlformats.org/officeDocument/2006/relationships" r:id="R9dccd8f656a14db0"/>
-      <p:boldItalic xmlns:r="http://schemas.openxmlformats.org/officeDocument/2006/relationships" r:id="R4d64be2fbe4540fe"/>
+      <p:regular xmlns:r="http://schemas.openxmlformats.org/officeDocument/2006/relationships" r:id="R2f61c7ececc442ae"/>
+      <p:bold xmlns:r="http://schemas.openxmlformats.org/officeDocument/2006/relationships" r:id="R65afa766478f4f89"/>
+      <p:italic xmlns:r="http://schemas.openxmlformats.org/officeDocument/2006/relationships" r:id="Rc8cc8e192c684213"/>
+      <p:boldItalic xmlns:r="http://schemas.openxmlformats.org/officeDocument/2006/relationships" r:id="Rb19febd42fc54045"/>
     </p:embeddedFont>
     <p:embeddedFont>
       <p:font typeface="Montserrat Black"/>
-      <p:bold xmlns:r="http://schemas.openxmlformats.org/officeDocument/2006/relationships" r:id="R261888204471460b"/>
-      <p:boldItalic xmlns:r="http://schemas.openxmlformats.org/officeDocument/2006/relationships" r:id="R3104a03719ac49b6"/>
+      <p:bold xmlns:r="http://schemas.openxmlformats.org/officeDocument/2006/relationships" r:id="R036a79fd60af460a"/>
+      <p:boldItalic xmlns:r="http://schemas.openxmlformats.org/officeDocument/2006/relationships" r:id="R5f03f014eb684635"/>
     </p:embeddedFont>
     <p:embeddedFont>
       <p:font typeface="Montserrat"/>
-      <p:bold xmlns:r="http://schemas.openxmlformats.org/officeDocument/2006/relationships" r:id="R96346efa0c0e4e09"/>
-      <p:boldItalic xmlns:r="http://schemas.openxmlformats.org/officeDocument/2006/relationships" r:id="Ra5fc78d967ad4510"/>
+      <p:bold xmlns:r="http://schemas.openxmlformats.org/officeDocument/2006/relationships" r:id="R10ba7293b54b42af"/>
+      <p:boldItalic xmlns:r="http://schemas.openxmlformats.org/officeDocument/2006/relationships" r:id="R558ef0c49812426b"/>
     </p:embeddedFont>
     <p:embeddedFont>
       <p:font typeface="Inter"/>
-      <p:regular xmlns:r="http://schemas.openxmlformats.org/officeDocument/2006/relationships" r:id="Rfff7fd6298084ead"/>
-      <p:bold xmlns:r="http://schemas.openxmlformats.org/officeDocument/2006/relationships" r:id="R42af310e5b28434a"/>
-      <p:italic xmlns:r="http://schemas.openxmlformats.org/officeDocument/2006/relationships" r:id="Rb09f28de92fb49d2"/>
-      <p:boldItalic xmlns:r="http://schemas.openxmlformats.org/officeDocument/2006/relationships" r:id="R5f2aef93150a458c"/>
+      <p:regular xmlns:r="http://schemas.openxmlformats.org/officeDocument/2006/relationships" r:id="R9fa39ac8001c4add"/>
+      <p:bold xmlns:r="http://schemas.openxmlformats.org/officeDocument/2006/relationships" r:id="R08c70e4c40e64b9b"/>
+      <p:italic xmlns:r="http://schemas.openxmlformats.org/officeDocument/2006/relationships" r:id="R391f487c8ded4fa7"/>
+      <p:boldItalic xmlns:r="http://schemas.openxmlformats.org/officeDocument/2006/relationships" r:id="R5a28ef4aafcf4653"/>
     </p:embeddedFont>
     <p:embeddedFont>
       <p:font typeface="Montserrat ExtraBold"/>
-      <p:bold xmlns:r="http://schemas.openxmlformats.org/officeDocument/2006/relationships" r:id="Rc329cce818d144b6"/>
-      <p:boldItalic xmlns:r="http://schemas.openxmlformats.org/officeDocument/2006/relationships" r:id="Ra1881ee61e0141e8"/>
+      <p:bold xmlns:r="http://schemas.openxmlformats.org/officeDocument/2006/relationships" r:id="R87a076e0356448a7"/>
+      <p:boldItalic xmlns:r="http://schemas.openxmlformats.org/officeDocument/2006/relationships" r:id="Recf81a4a1b3646a8"/>
     </p:embeddedFont>
     <p:embeddedFont>
       <p:font typeface="Roboto Mono"/>
-      <p:bold xmlns:r="http://schemas.openxmlformats.org/officeDocument/2006/relationships" r:id="R6d8b97bc7c484d8b"/>
-      <p:boldItalic xmlns:r="http://schemas.openxmlformats.org/officeDocument/2006/relationships" r:id="Rb4ea4fa409774f99"/>
+      <p:bold xmlns:r="http://schemas.openxmlformats.org/officeDocument/2006/relationships" r:id="Ra3212bbb4caa4d69"/>
+      <p:boldItalic xmlns:r="http://schemas.openxmlformats.org/officeDocument/2006/relationships" r:id="R28b06f887eee4ce8"/>
     </p:embeddedFont>
     <p:embeddedFont>
       <p:font typeface="Inter Medium"/>
-      <p:regular xmlns:r="http://schemas.openxmlformats.org/officeDocument/2006/relationships" r:id="R84888a143e4c4ec1"/>
-      <p:bold xmlns:r="http://schemas.openxmlformats.org/officeDocument/2006/relationships" r:id="R9936f43b4fc84563"/>
-      <p:italic xmlns:r="http://schemas.openxmlformats.org/officeDocument/2006/relationships" r:id="R4662df44d4ec460a"/>
-      <p:boldItalic xmlns:r="http://schemas.openxmlformats.org/officeDocument/2006/relationships" r:id="Rc144ac60595c4528"/>
+      <p:regular xmlns:r="http://schemas.openxmlformats.org/officeDocument/2006/relationships" r:id="Rdc70d4fb5add4fb4"/>
+      <p:bold xmlns:r="http://schemas.openxmlformats.org/officeDocument/2006/relationships" r:id="R2e9b930b5dac4d4a"/>
+      <p:italic xmlns:r="http://schemas.openxmlformats.org/officeDocument/2006/relationships" r:id="Ree6cae09ca9249d1"/>
+      <p:boldItalic xmlns:r="http://schemas.openxmlformats.org/officeDocument/2006/relationships" r:id="Raf764ce428754fe7"/>
     </p:embeddedFont>
   </p:embeddedFontLst>
 </p:presentation>
@@ -1424,7 +1424,7 @@
               <a:buNone/>
             </a:pPr>
             <a:r>
-              <a:t>Run the setup command for your host OS after cloning the repo. The script creates or starts the falco-lab Ubuntu VM, copies workshop code, installs dependencies, and builds the agent. Re-running setup preserves src/main.cpp in the VM. The Windows command applies its execution policy only to the new PowerShell process. On Windows, enable Virtual Machine Platform and restart if the Multipass installer requests it. Complete the first build before the workshop if possible. Sources: https://canonical.com/multipass/docs/latest/reference/command-line-interface/transfer/ and https://canonical.com/multipass/docs/latest/reference/command-line-interface/exec/.</a:t>
+              <a:t>Run the setup command for your host OS after cloning the repo. If Multipass is missing, the script asks before downloading and running Canonical’s installer. Approve the OS administrator prompt and complete the Windows installer. If a restart is requested, reboot and rerun setup. The script creates or starts the falco-lab Ubuntu VM, copies workshop code, installs dependencies, and builds the agent. Re-running setup preserves src/main.cpp in the VM. The Windows command applies its execution policy only to the new PowerShell process. Complete the first build before the workshop if possible. Sources: https://github.com/canonical/multipass/releases/tag/v1.16.4 and https://canonical.com/multipass/docs/latest/reference/command-line-interface/transfer/.</a:t>
             </a:r>
             <a:endParaRPr/>
           </a:p>
@@ -6232,18 +6232,18 @@
   </p:cSld>
   <p:clrMap bg1="lt1" tx1="dk1" bg2="dk2" tx2="lt2" accent1="accent1" accent2="accent2" accent3="accent3" accent4="accent4" accent5="accent5" accent6="accent6" hlink="hlink" folHlink="folHlink"/>
   <p:sldLayoutIdLst>
-    <p:sldLayoutId xmlns:r="http://schemas.openxmlformats.org/officeDocument/2006/relationships" id="2147483649" r:id="R332132589a1e40b4"/>
-    <p:sldLayoutId xmlns:r="http://schemas.openxmlformats.org/officeDocument/2006/relationships" id="2147483650" r:id="R4d4ac9faef12477f"/>
-    <p:sldLayoutId xmlns:r="http://schemas.openxmlformats.org/officeDocument/2006/relationships" id="2147483651" r:id="Rf95b168f542047a3"/>
-    <p:sldLayoutId xmlns:r="http://schemas.openxmlformats.org/officeDocument/2006/relationships" id="2147483652" r:id="R549634783fc54d40"/>
-    <p:sldLayoutId xmlns:r="http://schemas.openxmlformats.org/officeDocument/2006/relationships" id="2147483653" r:id="R5546ab44f1974f31"/>
-    <p:sldLayoutId xmlns:r="http://schemas.openxmlformats.org/officeDocument/2006/relationships" id="2147483654" r:id="R3565e223e8854e8e"/>
-    <p:sldLayoutId xmlns:r="http://schemas.openxmlformats.org/officeDocument/2006/relationships" id="2147483655" r:id="R56c4ad74f0fa4b09"/>
-    <p:sldLayoutId xmlns:r="http://schemas.openxmlformats.org/officeDocument/2006/relationships" id="2147483656" r:id="R69629e3474634b5d"/>
-    <p:sldLayoutId xmlns:r="http://schemas.openxmlformats.org/officeDocument/2006/relationships" id="2147483657" r:id="R9b7bd2cfadcb49da"/>
-    <p:sldLayoutId xmlns:r="http://schemas.openxmlformats.org/officeDocument/2006/relationships" id="2147483658" r:id="R37617df61fb34a89"/>
-    <p:sldLayoutId xmlns:r="http://schemas.openxmlformats.org/officeDocument/2006/relationships" id="2147483659" r:id="Re06c2aca604a45c0"/>
-    <p:sldLayoutId xmlns:r="http://schemas.openxmlformats.org/officeDocument/2006/relationships" id="2147483660" r:id="R4853984994254ebe"/>
+    <p:sldLayoutId xmlns:r="http://schemas.openxmlformats.org/officeDocument/2006/relationships" id="2147483649" r:id="R1b97348e6fd947bf"/>
+    <p:sldLayoutId xmlns:r="http://schemas.openxmlformats.org/officeDocument/2006/relationships" id="2147483650" r:id="Refcfc1bf4dec4a12"/>
+    <p:sldLayoutId xmlns:r="http://schemas.openxmlformats.org/officeDocument/2006/relationships" id="2147483651" r:id="R4f0850a89af041c5"/>
+    <p:sldLayoutId xmlns:r="http://schemas.openxmlformats.org/officeDocument/2006/relationships" id="2147483652" r:id="R60c1f805d88847a0"/>
+    <p:sldLayoutId xmlns:r="http://schemas.openxmlformats.org/officeDocument/2006/relationships" id="2147483653" r:id="Rf48cd20369b54bfb"/>
+    <p:sldLayoutId xmlns:r="http://schemas.openxmlformats.org/officeDocument/2006/relationships" id="2147483654" r:id="R7d42deeb487e44fd"/>
+    <p:sldLayoutId xmlns:r="http://schemas.openxmlformats.org/officeDocument/2006/relationships" id="2147483655" r:id="R849abaeae9fd4dd3"/>
+    <p:sldLayoutId xmlns:r="http://schemas.openxmlformats.org/officeDocument/2006/relationships" id="2147483656" r:id="Red1255ecc628483f"/>
+    <p:sldLayoutId xmlns:r="http://schemas.openxmlformats.org/officeDocument/2006/relationships" id="2147483657" r:id="R65f7e38190c1432b"/>
+    <p:sldLayoutId xmlns:r="http://schemas.openxmlformats.org/officeDocument/2006/relationships" id="2147483658" r:id="R2b187fe31bb44186"/>
+    <p:sldLayoutId xmlns:r="http://schemas.openxmlformats.org/officeDocument/2006/relationships" id="2147483659" r:id="Ra461a24c1fa144b7"/>
+    <p:sldLayoutId xmlns:r="http://schemas.openxmlformats.org/officeDocument/2006/relationships" id="2147483660" r:id="R89e56aa8577c4ee3"/>
   </p:sldLayoutIdLst>
   <p:hf sldNum="0" hdr="0" ftr="0" dt="0"/>
   <p:txStyles>
@@ -6928,7 +6928,7 @@
   </p:cSld>
   <p:clrMap bg1="lt1" tx1="dk1" bg2="dk2" tx2="lt2" accent1="accent1" accent2="accent2" accent3="accent3" accent4="accent4" accent5="accent5" accent6="accent6" hlink="hlink" folHlink="folHlink"/>
   <p:sldLayoutIdLst>
-    <p:sldLayoutId xmlns:r="http://schemas.openxmlformats.org/officeDocument/2006/relationships" id="2147483662" r:id="R88530e67859540e8"/>
+    <p:sldLayoutId xmlns:r="http://schemas.openxmlformats.org/officeDocument/2006/relationships" id="2147483662" r:id="R9c27d10a0e8f4a72"/>
   </p:sldLayoutIdLst>
   <p:hf sldNum="0" hdr="0" ftr="0" dt="0"/>
   <p:txStyles>
@@ -8777,7 +8777,7 @@
           <p:nvPr/>
         </p:nvPicPr>
         <p:blipFill rotWithShape="1">
-          <a:blip xmlns:r="http://schemas.openxmlformats.org/officeDocument/2006/relationships" xmlns:a="http://schemas.openxmlformats.org/drawingml/2006/main" r:embed="R428dc8771c014782">
+          <a:blip xmlns:r="http://schemas.openxmlformats.org/officeDocument/2006/relationships" xmlns:a="http://schemas.openxmlformats.org/drawingml/2006/main" r:embed="Rfb311fe5c38b4ae5">
             <a:alphaModFix/>
           </a:blip>
           <a:srcRect xmlns:a="http://schemas.openxmlformats.org/drawingml/2006/main" l="0" t="0" r="0" b="0"/>
@@ -8805,7 +8805,7 @@
           <p:nvPr/>
         </p:nvPicPr>
         <p:blipFill rotWithShape="1">
-          <a:blip xmlns:r="http://schemas.openxmlformats.org/officeDocument/2006/relationships" xmlns:a="http://schemas.openxmlformats.org/drawingml/2006/main" r:embed="R428dc8771c014782">
+          <a:blip xmlns:r="http://schemas.openxmlformats.org/officeDocument/2006/relationships" xmlns:a="http://schemas.openxmlformats.org/drawingml/2006/main" r:embed="Rfb311fe5c38b4ae5">
             <a:alphaModFix/>
           </a:blip>
           <a:srcRect xmlns:a="http://schemas.openxmlformats.org/drawingml/2006/main" l="0" t="0" r="0" b="0"/>
@@ -8833,7 +8833,7 @@
           <p:nvPr/>
         </p:nvPicPr>
         <p:blipFill rotWithShape="1">
-          <a:blip xmlns:r="http://schemas.openxmlformats.org/officeDocument/2006/relationships" xmlns:a="http://schemas.openxmlformats.org/drawingml/2006/main" r:embed="R428dc8771c014782">
+          <a:blip xmlns:r="http://schemas.openxmlformats.org/officeDocument/2006/relationships" xmlns:a="http://schemas.openxmlformats.org/drawingml/2006/main" r:embed="Rfb311fe5c38b4ae5">
             <a:alphaModFix/>
           </a:blip>
           <a:srcRect xmlns:a="http://schemas.openxmlformats.org/drawingml/2006/main" l="0" t="0" r="0" b="0"/>
@@ -8861,7 +8861,7 @@
           <p:nvPr/>
         </p:nvPicPr>
         <p:blipFill rotWithShape="1">
-          <a:blip xmlns:r="http://schemas.openxmlformats.org/officeDocument/2006/relationships" xmlns:a="http://schemas.openxmlformats.org/drawingml/2006/main" r:embed="R428dc8771c014782">
+          <a:blip xmlns:r="http://schemas.openxmlformats.org/officeDocument/2006/relationships" xmlns:a="http://schemas.openxmlformats.org/drawingml/2006/main" r:embed="Rfb311fe5c38b4ae5">
             <a:alphaModFix/>
           </a:blip>
           <a:srcRect xmlns:a="http://schemas.openxmlformats.org/drawingml/2006/main" l="0" t="0" r="0" b="0"/>
@@ -8889,7 +8889,7 @@
           <p:nvPr/>
         </p:nvPicPr>
         <p:blipFill rotWithShape="1">
-          <a:blip xmlns:r="http://schemas.openxmlformats.org/officeDocument/2006/relationships" xmlns:a="http://schemas.openxmlformats.org/drawingml/2006/main" r:embed="R428dc8771c014782">
+          <a:blip xmlns:r="http://schemas.openxmlformats.org/officeDocument/2006/relationships" xmlns:a="http://schemas.openxmlformats.org/drawingml/2006/main" r:embed="Rfb311fe5c38b4ae5">
             <a:alphaModFix/>
           </a:blip>
           <a:srcRect xmlns:a="http://schemas.openxmlformats.org/drawingml/2006/main" l="0" t="0" r="0" b="0"/>
@@ -8917,7 +8917,7 @@
           <p:nvPr/>
         </p:nvPicPr>
         <p:blipFill rotWithShape="1">
-          <a:blip xmlns:r="http://schemas.openxmlformats.org/officeDocument/2006/relationships" xmlns:a="http://schemas.openxmlformats.org/drawingml/2006/main" r:embed="R428dc8771c014782">
+          <a:blip xmlns:r="http://schemas.openxmlformats.org/officeDocument/2006/relationships" xmlns:a="http://schemas.openxmlformats.org/drawingml/2006/main" r:embed="Rfb311fe5c38b4ae5">
             <a:alphaModFix/>
           </a:blip>
           <a:srcRect xmlns:a="http://schemas.openxmlformats.org/drawingml/2006/main" l="0" t="0" r="0" b="0"/>
@@ -8945,7 +8945,7 @@
           <p:nvPr/>
         </p:nvPicPr>
         <p:blipFill rotWithShape="1">
-          <a:blip xmlns:r="http://schemas.openxmlformats.org/officeDocument/2006/relationships" xmlns:a="http://schemas.openxmlformats.org/drawingml/2006/main" r:embed="R428dc8771c014782">
+          <a:blip xmlns:r="http://schemas.openxmlformats.org/officeDocument/2006/relationships" xmlns:a="http://schemas.openxmlformats.org/drawingml/2006/main" r:embed="Rfb311fe5c38b4ae5">
             <a:alphaModFix/>
           </a:blip>
           <a:srcRect xmlns:a="http://schemas.openxmlformats.org/drawingml/2006/main" l="0" t="0" r="0" b="0"/>
@@ -8973,7 +8973,7 @@
           <p:nvPr/>
         </p:nvPicPr>
         <p:blipFill rotWithShape="1">
-          <a:blip xmlns:r="http://schemas.openxmlformats.org/officeDocument/2006/relationships" xmlns:a="http://schemas.openxmlformats.org/drawingml/2006/main" r:embed="R428dc8771c014782">
+          <a:blip xmlns:r="http://schemas.openxmlformats.org/officeDocument/2006/relationships" xmlns:a="http://schemas.openxmlformats.org/drawingml/2006/main" r:embed="Rfb311fe5c38b4ae5">
             <a:alphaModFix/>
           </a:blip>
           <a:srcRect xmlns:a="http://schemas.openxmlformats.org/drawingml/2006/main" l="0" t="0" r="0" b="0"/>
@@ -11058,7 +11058,7 @@
           <p:nvPr/>
         </p:nvPicPr>
         <p:blipFill rotWithShape="1">
-          <a:blip xmlns:r="http://schemas.openxmlformats.org/officeDocument/2006/relationships" xmlns:a="http://schemas.openxmlformats.org/drawingml/2006/main" r:embed="R5e7fa0294ee345e0">
+          <a:blip xmlns:r="http://schemas.openxmlformats.org/officeDocument/2006/relationships" xmlns:a="http://schemas.openxmlformats.org/drawingml/2006/main" r:embed="R232ef03012864447">
             <a:alphaModFix/>
           </a:blip>
           <a:srcRect xmlns:a="http://schemas.openxmlformats.org/drawingml/2006/main" l="0" t="0" r="0" b="0"/>
@@ -11086,7 +11086,7 @@
           <p:nvPr/>
         </p:nvPicPr>
         <p:blipFill rotWithShape="1">
-          <a:blip xmlns:r="http://schemas.openxmlformats.org/officeDocument/2006/relationships" xmlns:a="http://schemas.openxmlformats.org/drawingml/2006/main" r:embed="R5e7fa0294ee345e0">
+          <a:blip xmlns:r="http://schemas.openxmlformats.org/officeDocument/2006/relationships" xmlns:a="http://schemas.openxmlformats.org/drawingml/2006/main" r:embed="R232ef03012864447">
             <a:alphaModFix/>
           </a:blip>
           <a:srcRect xmlns:a="http://schemas.openxmlformats.org/drawingml/2006/main" l="0" t="0" r="0" b="0"/>
@@ -11114,7 +11114,7 @@
           <p:nvPr/>
         </p:nvPicPr>
         <p:blipFill rotWithShape="1">
-          <a:blip xmlns:r="http://schemas.openxmlformats.org/officeDocument/2006/relationships" xmlns:a="http://schemas.openxmlformats.org/drawingml/2006/main" r:embed="R5e7fa0294ee345e0">
+          <a:blip xmlns:r="http://schemas.openxmlformats.org/officeDocument/2006/relationships" xmlns:a="http://schemas.openxmlformats.org/drawingml/2006/main" r:embed="R232ef03012864447">
             <a:alphaModFix/>
           </a:blip>
           <a:srcRect xmlns:a="http://schemas.openxmlformats.org/drawingml/2006/main" l="0" t="0" r="0" b="0"/>
@@ -11142,7 +11142,7 @@
           <p:nvPr/>
         </p:nvPicPr>
         <p:blipFill rotWithShape="1">
-          <a:blip xmlns:r="http://schemas.openxmlformats.org/officeDocument/2006/relationships" xmlns:a="http://schemas.openxmlformats.org/drawingml/2006/main" r:embed="R5e7fa0294ee345e0">
+          <a:blip xmlns:r="http://schemas.openxmlformats.org/officeDocument/2006/relationships" xmlns:a="http://schemas.openxmlformats.org/drawingml/2006/main" r:embed="R232ef03012864447">
             <a:alphaModFix/>
           </a:blip>
           <a:srcRect xmlns:a="http://schemas.openxmlformats.org/drawingml/2006/main" l="0" t="0" r="0" b="0"/>
@@ -13075,7 +13075,7 @@
           <p:nvPr/>
         </p:nvPicPr>
         <p:blipFill rotWithShape="1">
-          <a:blip xmlns:r="http://schemas.openxmlformats.org/officeDocument/2006/relationships" xmlns:a="http://schemas.openxmlformats.org/drawingml/2006/main" r:embed="Re61f893f6bc842ca">
+          <a:blip xmlns:r="http://schemas.openxmlformats.org/officeDocument/2006/relationships" xmlns:a="http://schemas.openxmlformats.org/drawingml/2006/main" r:embed="R2a3dea5690b9449a">
             <a:alphaModFix/>
           </a:blip>
           <a:srcRect xmlns:a="http://schemas.openxmlformats.org/drawingml/2006/main" l="0" t="0" r="0" b="0"/>
@@ -13103,7 +13103,7 @@
           <p:nvPr/>
         </p:nvPicPr>
         <p:blipFill rotWithShape="1">
-          <a:blip xmlns:r="http://schemas.openxmlformats.org/officeDocument/2006/relationships" xmlns:a="http://schemas.openxmlformats.org/drawingml/2006/main" r:embed="Re61f893f6bc842ca">
+          <a:blip xmlns:r="http://schemas.openxmlformats.org/officeDocument/2006/relationships" xmlns:a="http://schemas.openxmlformats.org/drawingml/2006/main" r:embed="R2a3dea5690b9449a">
             <a:alphaModFix/>
           </a:blip>
           <a:srcRect xmlns:a="http://schemas.openxmlformats.org/drawingml/2006/main" l="0" t="0" r="0" b="0"/>
@@ -13131,7 +13131,7 @@
           <p:nvPr/>
         </p:nvPicPr>
         <p:blipFill rotWithShape="1">
-          <a:blip xmlns:r="http://schemas.openxmlformats.org/officeDocument/2006/relationships" xmlns:a="http://schemas.openxmlformats.org/drawingml/2006/main" r:embed="Re61f893f6bc842ca">
+          <a:blip xmlns:r="http://schemas.openxmlformats.org/officeDocument/2006/relationships" xmlns:a="http://schemas.openxmlformats.org/drawingml/2006/main" r:embed="R2a3dea5690b9449a">
             <a:alphaModFix/>
           </a:blip>
           <a:srcRect xmlns:a="http://schemas.openxmlformats.org/drawingml/2006/main" l="0" t="0" r="0" b="0"/>
@@ -13159,7 +13159,7 @@
           <p:nvPr/>
         </p:nvPicPr>
         <p:blipFill rotWithShape="1">
-          <a:blip xmlns:r="http://schemas.openxmlformats.org/officeDocument/2006/relationships" xmlns:a="http://schemas.openxmlformats.org/drawingml/2006/main" r:embed="Re61f893f6bc842ca">
+          <a:blip xmlns:r="http://schemas.openxmlformats.org/officeDocument/2006/relationships" xmlns:a="http://schemas.openxmlformats.org/drawingml/2006/main" r:embed="R2a3dea5690b9449a">
             <a:alphaModFix/>
           </a:blip>
           <a:srcRect xmlns:a="http://schemas.openxmlformats.org/drawingml/2006/main" l="0" t="0" r="0" b="0"/>
@@ -15070,7 +15070,7 @@
           <p:nvPr/>
         </p:nvPicPr>
         <p:blipFill rotWithShape="1">
-          <a:blip xmlns:r="http://schemas.openxmlformats.org/officeDocument/2006/relationships" xmlns:a="http://schemas.openxmlformats.org/drawingml/2006/main" r:embed="R1cc79fea11e44d91">
+          <a:blip xmlns:r="http://schemas.openxmlformats.org/officeDocument/2006/relationships" xmlns:a="http://schemas.openxmlformats.org/drawingml/2006/main" r:embed="Re772fe9d45b34f48">
             <a:alphaModFix/>
           </a:blip>
           <a:srcRect xmlns:a="http://schemas.openxmlformats.org/drawingml/2006/main" l="0" t="0" r="0" b="0"/>
@@ -15098,7 +15098,7 @@
           <p:nvPr/>
         </p:nvPicPr>
         <p:blipFill rotWithShape="1">
-          <a:blip xmlns:r="http://schemas.openxmlformats.org/officeDocument/2006/relationships" xmlns:a="http://schemas.openxmlformats.org/drawingml/2006/main" r:embed="R1cc79fea11e44d91">
+          <a:blip xmlns:r="http://schemas.openxmlformats.org/officeDocument/2006/relationships" xmlns:a="http://schemas.openxmlformats.org/drawingml/2006/main" r:embed="Re772fe9d45b34f48">
             <a:alphaModFix/>
           </a:blip>
           <a:srcRect xmlns:a="http://schemas.openxmlformats.org/drawingml/2006/main" l="0" t="0" r="0" b="0"/>
@@ -15126,7 +15126,7 @@
           <p:nvPr/>
         </p:nvPicPr>
         <p:blipFill rotWithShape="1">
-          <a:blip xmlns:r="http://schemas.openxmlformats.org/officeDocument/2006/relationships" xmlns:a="http://schemas.openxmlformats.org/drawingml/2006/main" r:embed="R1cc79fea11e44d91">
+          <a:blip xmlns:r="http://schemas.openxmlformats.org/officeDocument/2006/relationships" xmlns:a="http://schemas.openxmlformats.org/drawingml/2006/main" r:embed="Re772fe9d45b34f48">
             <a:alphaModFix/>
           </a:blip>
           <a:srcRect xmlns:a="http://schemas.openxmlformats.org/drawingml/2006/main" l="0" t="0" r="0" b="0"/>
@@ -15154,7 +15154,7 @@
           <p:nvPr/>
         </p:nvPicPr>
         <p:blipFill rotWithShape="1">
-          <a:blip xmlns:r="http://schemas.openxmlformats.org/officeDocument/2006/relationships" xmlns:a="http://schemas.openxmlformats.org/drawingml/2006/main" r:embed="R1cc79fea11e44d91">
+          <a:blip xmlns:r="http://schemas.openxmlformats.org/officeDocument/2006/relationships" xmlns:a="http://schemas.openxmlformats.org/drawingml/2006/main" r:embed="Re772fe9d45b34f48">
             <a:alphaModFix/>
           </a:blip>
           <a:srcRect xmlns:a="http://schemas.openxmlformats.org/drawingml/2006/main" l="0" t="0" r="0" b="0"/>
@@ -17193,7 +17193,7 @@
           <p:nvPr/>
         </p:nvPicPr>
         <p:blipFill rotWithShape="1">
-          <a:blip xmlns:r="http://schemas.openxmlformats.org/officeDocument/2006/relationships" xmlns:a="http://schemas.openxmlformats.org/drawingml/2006/main" r:embed="R7ed2fa736f304663">
+          <a:blip xmlns:r="http://schemas.openxmlformats.org/officeDocument/2006/relationships" xmlns:a="http://schemas.openxmlformats.org/drawingml/2006/main" r:embed="R3ad295163aa347bc">
             <a:alphaModFix/>
           </a:blip>
           <a:srcRect xmlns:a="http://schemas.openxmlformats.org/drawingml/2006/main" l="0" t="0" r="0" b="0"/>
@@ -17221,7 +17221,7 @@
           <p:nvPr/>
         </p:nvPicPr>
         <p:blipFill rotWithShape="1">
-          <a:blip xmlns:r="http://schemas.openxmlformats.org/officeDocument/2006/relationships" xmlns:a="http://schemas.openxmlformats.org/drawingml/2006/main" r:embed="R7ed2fa736f304663">
+          <a:blip xmlns:r="http://schemas.openxmlformats.org/officeDocument/2006/relationships" xmlns:a="http://schemas.openxmlformats.org/drawingml/2006/main" r:embed="R3ad295163aa347bc">
             <a:alphaModFix/>
           </a:blip>
           <a:srcRect xmlns:a="http://schemas.openxmlformats.org/drawingml/2006/main" l="0" t="0" r="0" b="0"/>
@@ -17249,7 +17249,7 @@
           <p:nvPr/>
         </p:nvPicPr>
         <p:blipFill rotWithShape="1">
-          <a:blip xmlns:r="http://schemas.openxmlformats.org/officeDocument/2006/relationships" xmlns:a="http://schemas.openxmlformats.org/drawingml/2006/main" r:embed="R7ed2fa736f304663">
+          <a:blip xmlns:r="http://schemas.openxmlformats.org/officeDocument/2006/relationships" xmlns:a="http://schemas.openxmlformats.org/drawingml/2006/main" r:embed="R3ad295163aa347bc">
             <a:alphaModFix/>
           </a:blip>
           <a:srcRect xmlns:a="http://schemas.openxmlformats.org/drawingml/2006/main" l="0" t="0" r="0" b="0"/>
@@ -17277,7 +17277,7 @@
           <p:nvPr/>
         </p:nvPicPr>
         <p:blipFill rotWithShape="1">
-          <a:blip xmlns:r="http://schemas.openxmlformats.org/officeDocument/2006/relationships" xmlns:a="http://schemas.openxmlformats.org/drawingml/2006/main" r:embed="R7ed2fa736f304663">
+          <a:blip xmlns:r="http://schemas.openxmlformats.org/officeDocument/2006/relationships" xmlns:a="http://schemas.openxmlformats.org/drawingml/2006/main" r:embed="R3ad295163aa347bc">
             <a:alphaModFix/>
           </a:blip>
           <a:srcRect xmlns:a="http://schemas.openxmlformats.org/drawingml/2006/main" l="0" t="0" r="0" b="0"/>
@@ -19308,7 +19308,7 @@
           <p:nvPr/>
         </p:nvPicPr>
         <p:blipFill rotWithShape="1">
-          <a:blip xmlns:r="http://schemas.openxmlformats.org/officeDocument/2006/relationships" xmlns:a="http://schemas.openxmlformats.org/drawingml/2006/main" r:embed="R48e061573cd049da">
+          <a:blip xmlns:r="http://schemas.openxmlformats.org/officeDocument/2006/relationships" xmlns:a="http://schemas.openxmlformats.org/drawingml/2006/main" r:embed="R1c5edd4bde4a4bf8">
             <a:alphaModFix/>
           </a:blip>
           <a:srcRect xmlns:a="http://schemas.openxmlformats.org/drawingml/2006/main" l="0" t="0" r="0" b="0"/>
@@ -19336,7 +19336,7 @@
           <p:nvPr/>
         </p:nvPicPr>
         <p:blipFill rotWithShape="1">
-          <a:blip xmlns:r="http://schemas.openxmlformats.org/officeDocument/2006/relationships" xmlns:a="http://schemas.openxmlformats.org/drawingml/2006/main" r:embed="R48e061573cd049da">
+          <a:blip xmlns:r="http://schemas.openxmlformats.org/officeDocument/2006/relationships" xmlns:a="http://schemas.openxmlformats.org/drawingml/2006/main" r:embed="R1c5edd4bde4a4bf8">
             <a:alphaModFix/>
           </a:blip>
           <a:srcRect xmlns:a="http://schemas.openxmlformats.org/drawingml/2006/main" l="0" t="0" r="0" b="0"/>
@@ -19364,7 +19364,7 @@
           <p:nvPr/>
         </p:nvPicPr>
         <p:blipFill rotWithShape="1">
-          <a:blip xmlns:r="http://schemas.openxmlformats.org/officeDocument/2006/relationships" xmlns:a="http://schemas.openxmlformats.org/drawingml/2006/main" r:embed="R48e061573cd049da">
+          <a:blip xmlns:r="http://schemas.openxmlformats.org/officeDocument/2006/relationships" xmlns:a="http://schemas.openxmlformats.org/drawingml/2006/main" r:embed="R1c5edd4bde4a4bf8">
             <a:alphaModFix/>
           </a:blip>
           <a:srcRect xmlns:a="http://schemas.openxmlformats.org/drawingml/2006/main" l="0" t="0" r="0" b="0"/>
@@ -19392,7 +19392,7 @@
           <p:nvPr/>
         </p:nvPicPr>
         <p:blipFill rotWithShape="1">
-          <a:blip xmlns:r="http://schemas.openxmlformats.org/officeDocument/2006/relationships" xmlns:a="http://schemas.openxmlformats.org/drawingml/2006/main" r:embed="R48e061573cd049da">
+          <a:blip xmlns:r="http://schemas.openxmlformats.org/officeDocument/2006/relationships" xmlns:a="http://schemas.openxmlformats.org/drawingml/2006/main" r:embed="R1c5edd4bde4a4bf8">
             <a:alphaModFix/>
           </a:blip>
           <a:srcRect xmlns:a="http://schemas.openxmlformats.org/drawingml/2006/main" l="0" t="0" r="0" b="0"/>
@@ -21437,7 +21437,7 @@
           <p:nvPr/>
         </p:nvPicPr>
         <p:blipFill rotWithShape="1">
-          <a:blip xmlns:r="http://schemas.openxmlformats.org/officeDocument/2006/relationships" xmlns:a="http://schemas.openxmlformats.org/drawingml/2006/main" r:embed="R4d69e32c49224bd3">
+          <a:blip xmlns:r="http://schemas.openxmlformats.org/officeDocument/2006/relationships" xmlns:a="http://schemas.openxmlformats.org/drawingml/2006/main" r:embed="R8e5f5891a27c4e94">
             <a:alphaModFix/>
           </a:blip>
           <a:srcRect xmlns:a="http://schemas.openxmlformats.org/drawingml/2006/main" l="0" t="0" r="0" b="0"/>
@@ -21465,7 +21465,7 @@
           <p:nvPr/>
         </p:nvPicPr>
         <p:blipFill rotWithShape="1">
-          <a:blip xmlns:r="http://schemas.openxmlformats.org/officeDocument/2006/relationships" xmlns:a="http://schemas.openxmlformats.org/drawingml/2006/main" r:embed="R4d69e32c49224bd3">
+          <a:blip xmlns:r="http://schemas.openxmlformats.org/officeDocument/2006/relationships" xmlns:a="http://schemas.openxmlformats.org/drawingml/2006/main" r:embed="R8e5f5891a27c4e94">
             <a:alphaModFix/>
           </a:blip>
           <a:srcRect xmlns:a="http://schemas.openxmlformats.org/drawingml/2006/main" l="0" t="0" r="0" b="0"/>
@@ -21493,7 +21493,7 @@
           <p:nvPr/>
         </p:nvPicPr>
         <p:blipFill rotWithShape="1">
-          <a:blip xmlns:r="http://schemas.openxmlformats.org/officeDocument/2006/relationships" xmlns:a="http://schemas.openxmlformats.org/drawingml/2006/main" r:embed="R4d69e32c49224bd3">
+          <a:blip xmlns:r="http://schemas.openxmlformats.org/officeDocument/2006/relationships" xmlns:a="http://schemas.openxmlformats.org/drawingml/2006/main" r:embed="R8e5f5891a27c4e94">
             <a:alphaModFix/>
           </a:blip>
           <a:srcRect xmlns:a="http://schemas.openxmlformats.org/drawingml/2006/main" l="0" t="0" r="0" b="0"/>
@@ -21521,7 +21521,7 @@
           <p:nvPr/>
         </p:nvPicPr>
         <p:blipFill rotWithShape="1">
-          <a:blip xmlns:r="http://schemas.openxmlformats.org/officeDocument/2006/relationships" xmlns:a="http://schemas.openxmlformats.org/drawingml/2006/main" r:embed="R4d69e32c49224bd3">
+          <a:blip xmlns:r="http://schemas.openxmlformats.org/officeDocument/2006/relationships" xmlns:a="http://schemas.openxmlformats.org/drawingml/2006/main" r:embed="R8e5f5891a27c4e94">
             <a:alphaModFix/>
           </a:blip>
           <a:srcRect xmlns:a="http://schemas.openxmlformats.org/drawingml/2006/main" l="0" t="0" r="0" b="0"/>
@@ -23544,7 +23544,7 @@
           <p:nvPr/>
         </p:nvPicPr>
         <p:blipFill rotWithShape="1">
-          <a:blip xmlns:r="http://schemas.openxmlformats.org/officeDocument/2006/relationships" xmlns:a="http://schemas.openxmlformats.org/drawingml/2006/main" r:embed="Rcc386bbb2cbc4dba">
+          <a:blip xmlns:r="http://schemas.openxmlformats.org/officeDocument/2006/relationships" xmlns:a="http://schemas.openxmlformats.org/drawingml/2006/main" r:embed="R1b459493194a42c9">
             <a:alphaModFix/>
           </a:blip>
           <a:srcRect xmlns:a="http://schemas.openxmlformats.org/drawingml/2006/main" l="0" t="0" r="0" b="0"/>
@@ -23572,7 +23572,7 @@
           <p:nvPr/>
         </p:nvPicPr>
         <p:blipFill rotWithShape="1">
-          <a:blip xmlns:r="http://schemas.openxmlformats.org/officeDocument/2006/relationships" xmlns:a="http://schemas.openxmlformats.org/drawingml/2006/main" r:embed="Rcc386bbb2cbc4dba">
+          <a:blip xmlns:r="http://schemas.openxmlformats.org/officeDocument/2006/relationships" xmlns:a="http://schemas.openxmlformats.org/drawingml/2006/main" r:embed="R1b459493194a42c9">
             <a:alphaModFix/>
           </a:blip>
           <a:srcRect xmlns:a="http://schemas.openxmlformats.org/drawingml/2006/main" l="0" t="0" r="0" b="0"/>
@@ -23600,7 +23600,7 @@
           <p:nvPr/>
         </p:nvPicPr>
         <p:blipFill rotWithShape="1">
-          <a:blip xmlns:r="http://schemas.openxmlformats.org/officeDocument/2006/relationships" xmlns:a="http://schemas.openxmlformats.org/drawingml/2006/main" r:embed="Rcc386bbb2cbc4dba">
+          <a:blip xmlns:r="http://schemas.openxmlformats.org/officeDocument/2006/relationships" xmlns:a="http://schemas.openxmlformats.org/drawingml/2006/main" r:embed="R1b459493194a42c9">
             <a:alphaModFix/>
           </a:blip>
           <a:srcRect xmlns:a="http://schemas.openxmlformats.org/drawingml/2006/main" l="0" t="0" r="0" b="0"/>
@@ -23628,7 +23628,7 @@
           <p:nvPr/>
         </p:nvPicPr>
         <p:blipFill rotWithShape="1">
-          <a:blip xmlns:r="http://schemas.openxmlformats.org/officeDocument/2006/relationships" xmlns:a="http://schemas.openxmlformats.org/drawingml/2006/main" r:embed="Rcc386bbb2cbc4dba">
+          <a:blip xmlns:r="http://schemas.openxmlformats.org/officeDocument/2006/relationships" xmlns:a="http://schemas.openxmlformats.org/drawingml/2006/main" r:embed="R1b459493194a42c9">
             <a:alphaModFix/>
           </a:blip>
           <a:srcRect xmlns:a="http://schemas.openxmlformats.org/drawingml/2006/main" l="0" t="0" r="0" b="0"/>
@@ -25703,7 +25703,7 @@
           <p:nvPr/>
         </p:nvPicPr>
         <p:blipFill rotWithShape="1">
-          <a:blip xmlns:r="http://schemas.openxmlformats.org/officeDocument/2006/relationships" xmlns:a="http://schemas.openxmlformats.org/drawingml/2006/main" r:embed="R54e8667a15b04f69">
+          <a:blip xmlns:r="http://schemas.openxmlformats.org/officeDocument/2006/relationships" xmlns:a="http://schemas.openxmlformats.org/drawingml/2006/main" r:embed="R44018fe83a5e4d90">
             <a:alphaModFix/>
           </a:blip>
           <a:srcRect xmlns:a="http://schemas.openxmlformats.org/drawingml/2006/main" l="0" t="0" r="0" b="0"/>
@@ -25731,7 +25731,7 @@
           <p:nvPr/>
         </p:nvPicPr>
         <p:blipFill rotWithShape="1">
-          <a:blip xmlns:r="http://schemas.openxmlformats.org/officeDocument/2006/relationships" xmlns:a="http://schemas.openxmlformats.org/drawingml/2006/main" r:embed="R54e8667a15b04f69">
+          <a:blip xmlns:r="http://schemas.openxmlformats.org/officeDocument/2006/relationships" xmlns:a="http://schemas.openxmlformats.org/drawingml/2006/main" r:embed="R44018fe83a5e4d90">
             <a:alphaModFix/>
           </a:blip>
           <a:srcRect xmlns:a="http://schemas.openxmlformats.org/drawingml/2006/main" l="0" t="0" r="0" b="0"/>
@@ -25759,7 +25759,7 @@
           <p:nvPr/>
         </p:nvPicPr>
         <p:blipFill rotWithShape="1">
-          <a:blip xmlns:r="http://schemas.openxmlformats.org/officeDocument/2006/relationships" xmlns:a="http://schemas.openxmlformats.org/drawingml/2006/main" r:embed="R54e8667a15b04f69">
+          <a:blip xmlns:r="http://schemas.openxmlformats.org/officeDocument/2006/relationships" xmlns:a="http://schemas.openxmlformats.org/drawingml/2006/main" r:embed="R44018fe83a5e4d90">
             <a:alphaModFix/>
           </a:blip>
           <a:srcRect xmlns:a="http://schemas.openxmlformats.org/drawingml/2006/main" l="0" t="0" r="0" b="0"/>
@@ -25787,7 +25787,7 @@
           <p:nvPr/>
         </p:nvPicPr>
         <p:blipFill rotWithShape="1">
-          <a:blip xmlns:r="http://schemas.openxmlformats.org/officeDocument/2006/relationships" xmlns:a="http://schemas.openxmlformats.org/drawingml/2006/main" r:embed="R54e8667a15b04f69">
+          <a:blip xmlns:r="http://schemas.openxmlformats.org/officeDocument/2006/relationships" xmlns:a="http://schemas.openxmlformats.org/drawingml/2006/main" r:embed="R44018fe83a5e4d90">
             <a:alphaModFix/>
           </a:blip>
           <a:srcRect xmlns:a="http://schemas.openxmlformats.org/drawingml/2006/main" l="0" t="0" r="0" b="0"/>
@@ -27758,7 +27758,7 @@
           <p:nvPr/>
         </p:nvPicPr>
         <p:blipFill rotWithShape="1">
-          <a:blip xmlns:r="http://schemas.openxmlformats.org/officeDocument/2006/relationships" xmlns:a="http://schemas.openxmlformats.org/drawingml/2006/main" r:embed="Rf015fc45c68e4410">
+          <a:blip xmlns:r="http://schemas.openxmlformats.org/officeDocument/2006/relationships" xmlns:a="http://schemas.openxmlformats.org/drawingml/2006/main" r:embed="R0bd4c2ec647b410c">
             <a:alphaModFix/>
           </a:blip>
           <a:srcRect xmlns:a="http://schemas.openxmlformats.org/drawingml/2006/main" l="0" t="0" r="0" b="0"/>
@@ -27786,7 +27786,7 @@
           <p:nvPr/>
         </p:nvPicPr>
         <p:blipFill rotWithShape="1">
-          <a:blip xmlns:r="http://schemas.openxmlformats.org/officeDocument/2006/relationships" xmlns:a="http://schemas.openxmlformats.org/drawingml/2006/main" r:embed="Rf015fc45c68e4410">
+          <a:blip xmlns:r="http://schemas.openxmlformats.org/officeDocument/2006/relationships" xmlns:a="http://schemas.openxmlformats.org/drawingml/2006/main" r:embed="R0bd4c2ec647b410c">
             <a:alphaModFix/>
           </a:blip>
           <a:srcRect xmlns:a="http://schemas.openxmlformats.org/drawingml/2006/main" l="0" t="0" r="0" b="0"/>
@@ -27814,7 +27814,7 @@
           <p:nvPr/>
         </p:nvPicPr>
         <p:blipFill rotWithShape="1">
-          <a:blip xmlns:r="http://schemas.openxmlformats.org/officeDocument/2006/relationships" xmlns:a="http://schemas.openxmlformats.org/drawingml/2006/main" r:embed="Rf015fc45c68e4410">
+          <a:blip xmlns:r="http://schemas.openxmlformats.org/officeDocument/2006/relationships" xmlns:a="http://schemas.openxmlformats.org/drawingml/2006/main" r:embed="R0bd4c2ec647b410c">
             <a:alphaModFix/>
           </a:blip>
           <a:srcRect xmlns:a="http://schemas.openxmlformats.org/drawingml/2006/main" l="0" t="0" r="0" b="0"/>
@@ -27842,7 +27842,7 @@
           <p:nvPr/>
         </p:nvPicPr>
         <p:blipFill rotWithShape="1">
-          <a:blip xmlns:r="http://schemas.openxmlformats.org/officeDocument/2006/relationships" xmlns:a="http://schemas.openxmlformats.org/drawingml/2006/main" r:embed="Rf015fc45c68e4410">
+          <a:blip xmlns:r="http://schemas.openxmlformats.org/officeDocument/2006/relationships" xmlns:a="http://schemas.openxmlformats.org/drawingml/2006/main" r:embed="R0bd4c2ec647b410c">
             <a:alphaModFix/>
           </a:blip>
           <a:srcRect xmlns:a="http://schemas.openxmlformats.org/drawingml/2006/main" l="0" t="0" r="0" b="0"/>
@@ -29865,7 +29865,7 @@
           <p:nvPr/>
         </p:nvPicPr>
         <p:blipFill rotWithShape="1">
-          <a:blip xmlns:r="http://schemas.openxmlformats.org/officeDocument/2006/relationships" xmlns:a="http://schemas.openxmlformats.org/drawingml/2006/main" r:embed="Rbf1d0f9f55da49b0">
+          <a:blip xmlns:r="http://schemas.openxmlformats.org/officeDocument/2006/relationships" xmlns:a="http://schemas.openxmlformats.org/drawingml/2006/main" r:embed="Rd9a6c98932174222">
             <a:alphaModFix/>
           </a:blip>
           <a:srcRect xmlns:a="http://schemas.openxmlformats.org/drawingml/2006/main" l="0" t="0" r="0" b="0"/>
@@ -29893,7 +29893,7 @@
           <p:nvPr/>
         </p:nvPicPr>
         <p:blipFill rotWithShape="1">
-          <a:blip xmlns:r="http://schemas.openxmlformats.org/officeDocument/2006/relationships" xmlns:a="http://schemas.openxmlformats.org/drawingml/2006/main" r:embed="Rbf1d0f9f55da49b0">
+          <a:blip xmlns:r="http://schemas.openxmlformats.org/officeDocument/2006/relationships" xmlns:a="http://schemas.openxmlformats.org/drawingml/2006/main" r:embed="Rd9a6c98932174222">
             <a:alphaModFix/>
           </a:blip>
           <a:srcRect xmlns:a="http://schemas.openxmlformats.org/drawingml/2006/main" l="0" t="0" r="0" b="0"/>
@@ -29921,7 +29921,7 @@
           <p:nvPr/>
         </p:nvPicPr>
         <p:blipFill rotWithShape="1">
-          <a:blip xmlns:r="http://schemas.openxmlformats.org/officeDocument/2006/relationships" xmlns:a="http://schemas.openxmlformats.org/drawingml/2006/main" r:embed="Rbf1d0f9f55da49b0">
+          <a:blip xmlns:r="http://schemas.openxmlformats.org/officeDocument/2006/relationships" xmlns:a="http://schemas.openxmlformats.org/drawingml/2006/main" r:embed="Rd9a6c98932174222">
             <a:alphaModFix/>
           </a:blip>
           <a:srcRect xmlns:a="http://schemas.openxmlformats.org/drawingml/2006/main" l="0" t="0" r="0" b="0"/>
@@ -29949,7 +29949,7 @@
           <p:nvPr/>
         </p:nvPicPr>
         <p:blipFill rotWithShape="1">
-          <a:blip xmlns:r="http://schemas.openxmlformats.org/officeDocument/2006/relationships" xmlns:a="http://schemas.openxmlformats.org/drawingml/2006/main" r:embed="Rbf1d0f9f55da49b0">
+          <a:blip xmlns:r="http://schemas.openxmlformats.org/officeDocument/2006/relationships" xmlns:a="http://schemas.openxmlformats.org/drawingml/2006/main" r:embed="Rd9a6c98932174222">
             <a:alphaModFix/>
           </a:blip>
           <a:srcRect xmlns:a="http://schemas.openxmlformats.org/drawingml/2006/main" l="0" t="0" r="0" b="0"/>
@@ -30443,53 +30443,7 @@
                 <a:ea typeface="Inter"/>
                 <a:cs typeface="Inter"/>
               </a:rPr>
-              <a:t>Install </a:t>
-            </a:r>
-            <a:r>
-              <a:rPr sz="1500" b="0" i="0">
-                <a:solidFill>
-                  <a:srgbClr val="4A5568"/>
-                </a:solidFill>
-                <a:latin typeface="Inter"/>
-                <a:ea typeface="Inter"/>
-                <a:cs typeface="Inter"/>
-                <a:hlinkClick xmlns:r="http://schemas.openxmlformats.org/officeDocument/2006/relationships" r:id="R19646aa18e084598"/>
-              </a:rPr>
-              <a:t>Git</a:t>
-            </a:r>
-            <a:r>
-              <a:rPr sz="1500" b="0" i="0">
-                <a:solidFill>
-                  <a:srgbClr val="4A5568"/>
-                </a:solidFill>
-                <a:latin typeface="Inter"/>
-                <a:ea typeface="Inter"/>
-                <a:cs typeface="Inter"/>
-              </a:rPr>
-              <a:t> and </a:t>
-            </a:r>
-            <a:r>
-              <a:rPr sz="1500" b="0" i="0">
-                <a:solidFill>
-                  <a:srgbClr val="4A5568"/>
-                </a:solidFill>
-                <a:latin typeface="Inter"/>
-                <a:ea typeface="Inter"/>
-                <a:cs typeface="Inter"/>
-                <a:hlinkClick xmlns:r="http://schemas.openxmlformats.org/officeDocument/2006/relationships" r:id="Ra2aee487e5b14083"/>
-              </a:rPr>
-              <a:t>Multipass</a:t>
-            </a:r>
-            <a:r>
-              <a:rPr sz="1500" b="0" i="0">
-                <a:solidFill>
-                  <a:srgbClr val="4A5568"/>
-                </a:solidFill>
-                <a:latin typeface="Inter"/>
-                <a:ea typeface="Inter"/>
-                <a:cs typeface="Inter"/>
-              </a:rPr>
-              <a:t>. Open Terminal (Mac) or PowerShell (Windows).</a:t>
+              <a:t>Open Terminal (Mac) or PowerShell (Windows).</a:t>
             </a:r>
           </a:p>
         </p:txBody>
@@ -31720,7 +31674,7 @@
           <p:nvPr/>
         </p:nvPicPr>
         <p:blipFill rotWithShape="1">
-          <a:blip xmlns:r="http://schemas.openxmlformats.org/officeDocument/2006/relationships" xmlns:a="http://schemas.openxmlformats.org/drawingml/2006/main" r:embed="R30e6846361db4855">
+          <a:blip xmlns:r="http://schemas.openxmlformats.org/officeDocument/2006/relationships" xmlns:a="http://schemas.openxmlformats.org/drawingml/2006/main" r:embed="R7cc477393cc94056">
             <a:alphaModFix/>
           </a:blip>
           <a:srcRect xmlns:a="http://schemas.openxmlformats.org/drawingml/2006/main" l="0" t="0" r="0" b="0"/>
@@ -31748,7 +31702,7 @@
           <p:nvPr/>
         </p:nvPicPr>
         <p:blipFill rotWithShape="1">
-          <a:blip xmlns:r="http://schemas.openxmlformats.org/officeDocument/2006/relationships" xmlns:a="http://schemas.openxmlformats.org/drawingml/2006/main" r:embed="R30e6846361db4855">
+          <a:blip xmlns:r="http://schemas.openxmlformats.org/officeDocument/2006/relationships" xmlns:a="http://schemas.openxmlformats.org/drawingml/2006/main" r:embed="R7cc477393cc94056">
             <a:alphaModFix/>
           </a:blip>
           <a:srcRect xmlns:a="http://schemas.openxmlformats.org/drawingml/2006/main" l="0" t="0" r="0" b="0"/>
@@ -31776,7 +31730,7 @@
           <p:nvPr/>
         </p:nvPicPr>
         <p:blipFill rotWithShape="1">
-          <a:blip xmlns:r="http://schemas.openxmlformats.org/officeDocument/2006/relationships" xmlns:a="http://schemas.openxmlformats.org/drawingml/2006/main" r:embed="R30e6846361db4855">
+          <a:blip xmlns:r="http://schemas.openxmlformats.org/officeDocument/2006/relationships" xmlns:a="http://schemas.openxmlformats.org/drawingml/2006/main" r:embed="R7cc477393cc94056">
             <a:alphaModFix/>
           </a:blip>
           <a:srcRect xmlns:a="http://schemas.openxmlformats.org/drawingml/2006/main" l="0" t="0" r="0" b="0"/>
@@ -31804,7 +31758,7 @@
           <p:nvPr/>
         </p:nvPicPr>
         <p:blipFill rotWithShape="1">
-          <a:blip xmlns:r="http://schemas.openxmlformats.org/officeDocument/2006/relationships" xmlns:a="http://schemas.openxmlformats.org/drawingml/2006/main" r:embed="R30e6846361db4855">
+          <a:blip xmlns:r="http://schemas.openxmlformats.org/officeDocument/2006/relationships" xmlns:a="http://schemas.openxmlformats.org/drawingml/2006/main" r:embed="R7cc477393cc94056">
             <a:alphaModFix/>
           </a:blip>
           <a:srcRect xmlns:a="http://schemas.openxmlformats.org/drawingml/2006/main" l="0" t="0" r="0" b="0"/>
@@ -33797,7 +33751,7 @@
           <p:nvPr/>
         </p:nvPicPr>
         <p:blipFill rotWithShape="1">
-          <a:blip xmlns:r="http://schemas.openxmlformats.org/officeDocument/2006/relationships" xmlns:a="http://schemas.openxmlformats.org/drawingml/2006/main" r:embed="R7d1b2c0209af42d5">
+          <a:blip xmlns:r="http://schemas.openxmlformats.org/officeDocument/2006/relationships" xmlns:a="http://schemas.openxmlformats.org/drawingml/2006/main" r:embed="R15c741dd241945cd">
             <a:alphaModFix/>
           </a:blip>
           <a:srcRect xmlns:a="http://schemas.openxmlformats.org/drawingml/2006/main" l="0" t="0" r="0" b="0"/>
@@ -33825,7 +33779,7 @@
           <p:nvPr/>
         </p:nvPicPr>
         <p:blipFill rotWithShape="1">
-          <a:blip xmlns:r="http://schemas.openxmlformats.org/officeDocument/2006/relationships" xmlns:a="http://schemas.openxmlformats.org/drawingml/2006/main" r:embed="R7d1b2c0209af42d5">
+          <a:blip xmlns:r="http://schemas.openxmlformats.org/officeDocument/2006/relationships" xmlns:a="http://schemas.openxmlformats.org/drawingml/2006/main" r:embed="R15c741dd241945cd">
             <a:alphaModFix/>
           </a:blip>
           <a:srcRect xmlns:a="http://schemas.openxmlformats.org/drawingml/2006/main" l="0" t="0" r="0" b="0"/>
@@ -33853,7 +33807,7 @@
           <p:nvPr/>
         </p:nvPicPr>
         <p:blipFill rotWithShape="1">
-          <a:blip xmlns:r="http://schemas.openxmlformats.org/officeDocument/2006/relationships" xmlns:a="http://schemas.openxmlformats.org/drawingml/2006/main" r:embed="R7d1b2c0209af42d5">
+          <a:blip xmlns:r="http://schemas.openxmlformats.org/officeDocument/2006/relationships" xmlns:a="http://schemas.openxmlformats.org/drawingml/2006/main" r:embed="R15c741dd241945cd">
             <a:alphaModFix/>
           </a:blip>
           <a:srcRect xmlns:a="http://schemas.openxmlformats.org/drawingml/2006/main" l="0" t="0" r="0" b="0"/>
@@ -33881,7 +33835,7 @@
           <p:nvPr/>
         </p:nvPicPr>
         <p:blipFill rotWithShape="1">
-          <a:blip xmlns:r="http://schemas.openxmlformats.org/officeDocument/2006/relationships" xmlns:a="http://schemas.openxmlformats.org/drawingml/2006/main" r:embed="R7d1b2c0209af42d5">
+          <a:blip xmlns:r="http://schemas.openxmlformats.org/officeDocument/2006/relationships" xmlns:a="http://schemas.openxmlformats.org/drawingml/2006/main" r:embed="R15c741dd241945cd">
             <a:alphaModFix/>
           </a:blip>
           <a:srcRect xmlns:a="http://schemas.openxmlformats.org/drawingml/2006/main" l="0" t="0" r="0" b="0"/>
@@ -35980,7 +35934,7 @@
           <p:nvPr/>
         </p:nvPicPr>
         <p:blipFill rotWithShape="1">
-          <a:blip xmlns:r="http://schemas.openxmlformats.org/officeDocument/2006/relationships" xmlns:a="http://schemas.openxmlformats.org/drawingml/2006/main" r:embed="R437bdd349e004fb1">
+          <a:blip xmlns:r="http://schemas.openxmlformats.org/officeDocument/2006/relationships" xmlns:a="http://schemas.openxmlformats.org/drawingml/2006/main" r:embed="Rfc5dda1da739400e">
             <a:alphaModFix/>
           </a:blip>
           <a:srcRect xmlns:a="http://schemas.openxmlformats.org/drawingml/2006/main" l="0" t="0" r="0" b="0"/>
@@ -36008,7 +35962,7 @@
           <p:nvPr/>
         </p:nvPicPr>
         <p:blipFill rotWithShape="1">
-          <a:blip xmlns:r="http://schemas.openxmlformats.org/officeDocument/2006/relationships" xmlns:a="http://schemas.openxmlformats.org/drawingml/2006/main" r:embed="R437bdd349e004fb1">
+          <a:blip xmlns:r="http://schemas.openxmlformats.org/officeDocument/2006/relationships" xmlns:a="http://schemas.openxmlformats.org/drawingml/2006/main" r:embed="Rfc5dda1da739400e">
             <a:alphaModFix/>
           </a:blip>
           <a:srcRect xmlns:a="http://schemas.openxmlformats.org/drawingml/2006/main" l="0" t="0" r="0" b="0"/>
@@ -36036,7 +35990,7 @@
           <p:nvPr/>
         </p:nvPicPr>
         <p:blipFill rotWithShape="1">
-          <a:blip xmlns:r="http://schemas.openxmlformats.org/officeDocument/2006/relationships" xmlns:a="http://schemas.openxmlformats.org/drawingml/2006/main" r:embed="R437bdd349e004fb1">
+          <a:blip xmlns:r="http://schemas.openxmlformats.org/officeDocument/2006/relationships" xmlns:a="http://schemas.openxmlformats.org/drawingml/2006/main" r:embed="Rfc5dda1da739400e">
             <a:alphaModFix/>
           </a:blip>
           <a:srcRect xmlns:a="http://schemas.openxmlformats.org/drawingml/2006/main" l="0" t="0" r="0" b="0"/>
@@ -36064,7 +36018,7 @@
           <p:nvPr/>
         </p:nvPicPr>
         <p:blipFill rotWithShape="1">
-          <a:blip xmlns:r="http://schemas.openxmlformats.org/officeDocument/2006/relationships" xmlns:a="http://schemas.openxmlformats.org/drawingml/2006/main" r:embed="R437bdd349e004fb1">
+          <a:blip xmlns:r="http://schemas.openxmlformats.org/officeDocument/2006/relationships" xmlns:a="http://schemas.openxmlformats.org/drawingml/2006/main" r:embed="Rfc5dda1da739400e">
             <a:alphaModFix/>
           </a:blip>
           <a:srcRect xmlns:a="http://schemas.openxmlformats.org/drawingml/2006/main" l="0" t="0" r="0" b="0"/>
@@ -38169,7 +38123,7 @@
           <p:nvPr/>
         </p:nvPicPr>
         <p:blipFill rotWithShape="1">
-          <a:blip xmlns:r="http://schemas.openxmlformats.org/officeDocument/2006/relationships" xmlns:a="http://schemas.openxmlformats.org/drawingml/2006/main" r:embed="R90b52eade17247ee">
+          <a:blip xmlns:r="http://schemas.openxmlformats.org/officeDocument/2006/relationships" xmlns:a="http://schemas.openxmlformats.org/drawingml/2006/main" r:embed="R1926e78c12ab463f">
             <a:alphaModFix/>
           </a:blip>
           <a:srcRect xmlns:a="http://schemas.openxmlformats.org/drawingml/2006/main" l="0" t="0" r="0" b="0"/>
@@ -38197,7 +38151,7 @@
           <p:nvPr/>
         </p:nvPicPr>
         <p:blipFill rotWithShape="1">
-          <a:blip xmlns:r="http://schemas.openxmlformats.org/officeDocument/2006/relationships" xmlns:a="http://schemas.openxmlformats.org/drawingml/2006/main" r:embed="R90b52eade17247ee">
+          <a:blip xmlns:r="http://schemas.openxmlformats.org/officeDocument/2006/relationships" xmlns:a="http://schemas.openxmlformats.org/drawingml/2006/main" r:embed="R1926e78c12ab463f">
             <a:alphaModFix/>
           </a:blip>
           <a:srcRect xmlns:a="http://schemas.openxmlformats.org/drawingml/2006/main" l="0" t="0" r="0" b="0"/>
@@ -38225,7 +38179,7 @@
           <p:nvPr/>
         </p:nvPicPr>
         <p:blipFill rotWithShape="1">
-          <a:blip xmlns:r="http://schemas.openxmlformats.org/officeDocument/2006/relationships" xmlns:a="http://schemas.openxmlformats.org/drawingml/2006/main" r:embed="R90b52eade17247ee">
+          <a:blip xmlns:r="http://schemas.openxmlformats.org/officeDocument/2006/relationships" xmlns:a="http://schemas.openxmlformats.org/drawingml/2006/main" r:embed="R1926e78c12ab463f">
             <a:alphaModFix/>
           </a:blip>
           <a:srcRect xmlns:a="http://schemas.openxmlformats.org/drawingml/2006/main" l="0" t="0" r="0" b="0"/>
@@ -38253,7 +38207,7 @@
           <p:nvPr/>
         </p:nvPicPr>
         <p:blipFill rotWithShape="1">
-          <a:blip xmlns:r="http://schemas.openxmlformats.org/officeDocument/2006/relationships" xmlns:a="http://schemas.openxmlformats.org/drawingml/2006/main" r:embed="R90b52eade17247ee">
+          <a:blip xmlns:r="http://schemas.openxmlformats.org/officeDocument/2006/relationships" xmlns:a="http://schemas.openxmlformats.org/drawingml/2006/main" r:embed="R1926e78c12ab463f">
             <a:alphaModFix/>
           </a:blip>
           <a:srcRect xmlns:a="http://schemas.openxmlformats.org/drawingml/2006/main" l="0" t="0" r="0" b="0"/>
@@ -40142,7 +40096,7 @@
           <p:nvPr/>
         </p:nvPicPr>
         <p:blipFill rotWithShape="1">
-          <a:blip xmlns:r="http://schemas.openxmlformats.org/officeDocument/2006/relationships" xmlns:a="http://schemas.openxmlformats.org/drawingml/2006/main" r:embed="Rd5713e40a2af479b">
+          <a:blip xmlns:r="http://schemas.openxmlformats.org/officeDocument/2006/relationships" xmlns:a="http://schemas.openxmlformats.org/drawingml/2006/main" r:embed="R678734f102474f6e">
             <a:alphaModFix/>
           </a:blip>
           <a:srcRect xmlns:a="http://schemas.openxmlformats.org/drawingml/2006/main" l="0" t="0" r="0" b="0"/>
@@ -40170,7 +40124,7 @@
           <p:nvPr/>
         </p:nvPicPr>
         <p:blipFill rotWithShape="1">
-          <a:blip xmlns:r="http://schemas.openxmlformats.org/officeDocument/2006/relationships" xmlns:a="http://schemas.openxmlformats.org/drawingml/2006/main" r:embed="Rd5713e40a2af479b">
+          <a:blip xmlns:r="http://schemas.openxmlformats.org/officeDocument/2006/relationships" xmlns:a="http://schemas.openxmlformats.org/drawingml/2006/main" r:embed="R678734f102474f6e">
             <a:alphaModFix/>
           </a:blip>
           <a:srcRect xmlns:a="http://schemas.openxmlformats.org/drawingml/2006/main" l="0" t="0" r="0" b="0"/>
@@ -40198,7 +40152,7 @@
           <p:nvPr/>
         </p:nvPicPr>
         <p:blipFill rotWithShape="1">
-          <a:blip xmlns:r="http://schemas.openxmlformats.org/officeDocument/2006/relationships" xmlns:a="http://schemas.openxmlformats.org/drawingml/2006/main" r:embed="Rd5713e40a2af479b">
+          <a:blip xmlns:r="http://schemas.openxmlformats.org/officeDocument/2006/relationships" xmlns:a="http://schemas.openxmlformats.org/drawingml/2006/main" r:embed="R678734f102474f6e">
             <a:alphaModFix/>
           </a:blip>
           <a:srcRect xmlns:a="http://schemas.openxmlformats.org/drawingml/2006/main" l="0" t="0" r="0" b="0"/>
@@ -40226,7 +40180,7 @@
           <p:nvPr/>
         </p:nvPicPr>
         <p:blipFill rotWithShape="1">
-          <a:blip xmlns:r="http://schemas.openxmlformats.org/officeDocument/2006/relationships" xmlns:a="http://schemas.openxmlformats.org/drawingml/2006/main" r:embed="Rd5713e40a2af479b">
+          <a:blip xmlns:r="http://schemas.openxmlformats.org/officeDocument/2006/relationships" xmlns:a="http://schemas.openxmlformats.org/drawingml/2006/main" r:embed="R678734f102474f6e">
             <a:alphaModFix/>
           </a:blip>
           <a:srcRect xmlns:a="http://schemas.openxmlformats.org/drawingml/2006/main" l="0" t="0" r="0" b="0"/>
@@ -42301,7 +42255,7 @@
           <p:nvPr/>
         </p:nvPicPr>
         <p:blipFill rotWithShape="1">
-          <a:blip xmlns:r="http://schemas.openxmlformats.org/officeDocument/2006/relationships" xmlns:a="http://schemas.openxmlformats.org/drawingml/2006/main" r:embed="R4f2b6e7cd82242a2">
+          <a:blip xmlns:r="http://schemas.openxmlformats.org/officeDocument/2006/relationships" xmlns:a="http://schemas.openxmlformats.org/drawingml/2006/main" r:embed="Rc2853ddb7d32405a">
             <a:alphaModFix/>
           </a:blip>
           <a:srcRect xmlns:a="http://schemas.openxmlformats.org/drawingml/2006/main" l="0" t="0" r="0" b="0"/>
@@ -42329,7 +42283,7 @@
           <p:nvPr/>
         </p:nvPicPr>
         <p:blipFill rotWithShape="1">
-          <a:blip xmlns:r="http://schemas.openxmlformats.org/officeDocument/2006/relationships" xmlns:a="http://schemas.openxmlformats.org/drawingml/2006/main" r:embed="R4f2b6e7cd82242a2">
+          <a:blip xmlns:r="http://schemas.openxmlformats.org/officeDocument/2006/relationships" xmlns:a="http://schemas.openxmlformats.org/drawingml/2006/main" r:embed="Rc2853ddb7d32405a">
             <a:alphaModFix/>
           </a:blip>
           <a:srcRect xmlns:a="http://schemas.openxmlformats.org/drawingml/2006/main" l="0" t="0" r="0" b="0"/>
@@ -42357,7 +42311,7 @@
           <p:nvPr/>
         </p:nvPicPr>
         <p:blipFill rotWithShape="1">
-          <a:blip xmlns:r="http://schemas.openxmlformats.org/officeDocument/2006/relationships" xmlns:a="http://schemas.openxmlformats.org/drawingml/2006/main" r:embed="R4f2b6e7cd82242a2">
+          <a:blip xmlns:r="http://schemas.openxmlformats.org/officeDocument/2006/relationships" xmlns:a="http://schemas.openxmlformats.org/drawingml/2006/main" r:embed="Rc2853ddb7d32405a">
             <a:alphaModFix/>
           </a:blip>
           <a:srcRect xmlns:a="http://schemas.openxmlformats.org/drawingml/2006/main" l="0" t="0" r="0" b="0"/>
@@ -42385,7 +42339,7 @@
           <p:nvPr/>
         </p:nvPicPr>
         <p:blipFill rotWithShape="1">
-          <a:blip xmlns:r="http://schemas.openxmlformats.org/officeDocument/2006/relationships" xmlns:a="http://schemas.openxmlformats.org/drawingml/2006/main" r:embed="R4f2b6e7cd82242a2">
+          <a:blip xmlns:r="http://schemas.openxmlformats.org/officeDocument/2006/relationships" xmlns:a="http://schemas.openxmlformats.org/drawingml/2006/main" r:embed="Rc2853ddb7d32405a">
             <a:alphaModFix/>
           </a:blip>
           <a:srcRect xmlns:a="http://schemas.openxmlformats.org/drawingml/2006/main" l="0" t="0" r="0" b="0"/>
@@ -44334,7 +44288,7 @@
           <p:nvPr/>
         </p:nvPicPr>
         <p:blipFill rotWithShape="1">
-          <a:blip xmlns:r="http://schemas.openxmlformats.org/officeDocument/2006/relationships" xmlns:a="http://schemas.openxmlformats.org/drawingml/2006/main" r:embed="R337e4ae4f2584d29">
+          <a:blip xmlns:r="http://schemas.openxmlformats.org/officeDocument/2006/relationships" xmlns:a="http://schemas.openxmlformats.org/drawingml/2006/main" r:embed="Rf0b04cfe45984542">
             <a:alphaModFix/>
           </a:blip>
           <a:srcRect xmlns:a="http://schemas.openxmlformats.org/drawingml/2006/main" l="0" t="0" r="0" b="0"/>
@@ -44362,7 +44316,7 @@
           <p:nvPr/>
         </p:nvPicPr>
         <p:blipFill rotWithShape="1">
-          <a:blip xmlns:r="http://schemas.openxmlformats.org/officeDocument/2006/relationships" xmlns:a="http://schemas.openxmlformats.org/drawingml/2006/main" r:embed="R337e4ae4f2584d29">
+          <a:blip xmlns:r="http://schemas.openxmlformats.org/officeDocument/2006/relationships" xmlns:a="http://schemas.openxmlformats.org/drawingml/2006/main" r:embed="Rf0b04cfe45984542">
             <a:alphaModFix/>
           </a:blip>
           <a:srcRect xmlns:a="http://schemas.openxmlformats.org/drawingml/2006/main" l="0" t="0" r="0" b="0"/>
@@ -44390,7 +44344,7 @@
           <p:nvPr/>
         </p:nvPicPr>
         <p:blipFill rotWithShape="1">
-          <a:blip xmlns:r="http://schemas.openxmlformats.org/officeDocument/2006/relationships" xmlns:a="http://schemas.openxmlformats.org/drawingml/2006/main" r:embed="R337e4ae4f2584d29">
+          <a:blip xmlns:r="http://schemas.openxmlformats.org/officeDocument/2006/relationships" xmlns:a="http://schemas.openxmlformats.org/drawingml/2006/main" r:embed="Rf0b04cfe45984542">
             <a:alphaModFix/>
           </a:blip>
           <a:srcRect xmlns:a="http://schemas.openxmlformats.org/drawingml/2006/main" l="0" t="0" r="0" b="0"/>
@@ -44418,7 +44372,7 @@
           <p:nvPr/>
         </p:nvPicPr>
         <p:blipFill rotWithShape="1">
-          <a:blip xmlns:r="http://schemas.openxmlformats.org/officeDocument/2006/relationships" xmlns:a="http://schemas.openxmlformats.org/drawingml/2006/main" r:embed="R337e4ae4f2584d29">
+          <a:blip xmlns:r="http://schemas.openxmlformats.org/officeDocument/2006/relationships" xmlns:a="http://schemas.openxmlformats.org/drawingml/2006/main" r:embed="Rf0b04cfe45984542">
             <a:alphaModFix/>
           </a:blip>
           <a:srcRect xmlns:a="http://schemas.openxmlformats.org/drawingml/2006/main" l="0" t="0" r="0" b="0"/>
@@ -46441,7 +46395,7 @@
           <p:nvPr/>
         </p:nvPicPr>
         <p:blipFill rotWithShape="1">
-          <a:blip xmlns:r="http://schemas.openxmlformats.org/officeDocument/2006/relationships" xmlns:a="http://schemas.openxmlformats.org/drawingml/2006/main" r:embed="Rdcb7f41557894118">
+          <a:blip xmlns:r="http://schemas.openxmlformats.org/officeDocument/2006/relationships" xmlns:a="http://schemas.openxmlformats.org/drawingml/2006/main" r:embed="Re3e4acb822ad4c13">
             <a:alphaModFix/>
           </a:blip>
           <a:srcRect xmlns:a="http://schemas.openxmlformats.org/drawingml/2006/main" l="0" t="0" r="0" b="0"/>
@@ -46469,7 +46423,7 @@
           <p:nvPr/>
         </p:nvPicPr>
         <p:blipFill rotWithShape="1">
-          <a:blip xmlns:r="http://schemas.openxmlformats.org/officeDocument/2006/relationships" xmlns:a="http://schemas.openxmlformats.org/drawingml/2006/main" r:embed="Rdcb7f41557894118">
+          <a:blip xmlns:r="http://schemas.openxmlformats.org/officeDocument/2006/relationships" xmlns:a="http://schemas.openxmlformats.org/drawingml/2006/main" r:embed="Re3e4acb822ad4c13">
             <a:alphaModFix/>
           </a:blip>
           <a:srcRect xmlns:a="http://schemas.openxmlformats.org/drawingml/2006/main" l="0" t="0" r="0" b="0"/>
@@ -46497,7 +46451,7 @@
           <p:nvPr/>
         </p:nvPicPr>
         <p:blipFill rotWithShape="1">
-          <a:blip xmlns:r="http://schemas.openxmlformats.org/officeDocument/2006/relationships" xmlns:a="http://schemas.openxmlformats.org/drawingml/2006/main" r:embed="Rdcb7f41557894118">
+          <a:blip xmlns:r="http://schemas.openxmlformats.org/officeDocument/2006/relationships" xmlns:a="http://schemas.openxmlformats.org/drawingml/2006/main" r:embed="Re3e4acb822ad4c13">
             <a:alphaModFix/>
           </a:blip>
           <a:srcRect xmlns:a="http://schemas.openxmlformats.org/drawingml/2006/main" l="0" t="0" r="0" b="0"/>
@@ -46525,7 +46479,7 @@
           <p:nvPr/>
         </p:nvPicPr>
         <p:blipFill rotWithShape="1">
-          <a:blip xmlns:r="http://schemas.openxmlformats.org/officeDocument/2006/relationships" xmlns:a="http://schemas.openxmlformats.org/drawingml/2006/main" r:embed="Rdcb7f41557894118">
+          <a:blip xmlns:r="http://schemas.openxmlformats.org/officeDocument/2006/relationships" xmlns:a="http://schemas.openxmlformats.org/drawingml/2006/main" r:embed="Re3e4acb822ad4c13">
             <a:alphaModFix/>
           </a:blip>
           <a:srcRect xmlns:a="http://schemas.openxmlformats.org/drawingml/2006/main" l="0" t="0" r="0" b="0"/>
@@ -48496,7 +48450,7 @@
           <p:nvPr/>
         </p:nvPicPr>
         <p:blipFill rotWithShape="1">
-          <a:blip xmlns:r="http://schemas.openxmlformats.org/officeDocument/2006/relationships" xmlns:a="http://schemas.openxmlformats.org/drawingml/2006/main" r:embed="R2b2080c20a3a4022">
+          <a:blip xmlns:r="http://schemas.openxmlformats.org/officeDocument/2006/relationships" xmlns:a="http://schemas.openxmlformats.org/drawingml/2006/main" r:embed="Rd84c4e9fa2d547d7">
             <a:alphaModFix/>
           </a:blip>
           <a:srcRect xmlns:a="http://schemas.openxmlformats.org/drawingml/2006/main" l="0" t="0" r="0" b="0"/>
@@ -48524,7 +48478,7 @@
           <p:nvPr/>
         </p:nvPicPr>
         <p:blipFill rotWithShape="1">
-          <a:blip xmlns:r="http://schemas.openxmlformats.org/officeDocument/2006/relationships" xmlns:a="http://schemas.openxmlformats.org/drawingml/2006/main" r:embed="R2b2080c20a3a4022">
+          <a:blip xmlns:r="http://schemas.openxmlformats.org/officeDocument/2006/relationships" xmlns:a="http://schemas.openxmlformats.org/drawingml/2006/main" r:embed="Rd84c4e9fa2d547d7">
             <a:alphaModFix/>
           </a:blip>
           <a:srcRect xmlns:a="http://schemas.openxmlformats.org/drawingml/2006/main" l="0" t="0" r="0" b="0"/>
@@ -48552,7 +48506,7 @@
           <p:nvPr/>
         </p:nvPicPr>
         <p:blipFill rotWithShape="1">
-          <a:blip xmlns:r="http://schemas.openxmlformats.org/officeDocument/2006/relationships" xmlns:a="http://schemas.openxmlformats.org/drawingml/2006/main" r:embed="R2b2080c20a3a4022">
+          <a:blip xmlns:r="http://schemas.openxmlformats.org/officeDocument/2006/relationships" xmlns:a="http://schemas.openxmlformats.org/drawingml/2006/main" r:embed="Rd84c4e9fa2d547d7">
             <a:alphaModFix/>
           </a:blip>
           <a:srcRect xmlns:a="http://schemas.openxmlformats.org/drawingml/2006/main" l="0" t="0" r="0" b="0"/>
@@ -48580,7 +48534,7 @@
           <p:nvPr/>
         </p:nvPicPr>
         <p:blipFill rotWithShape="1">
-          <a:blip xmlns:r="http://schemas.openxmlformats.org/officeDocument/2006/relationships" xmlns:a="http://schemas.openxmlformats.org/drawingml/2006/main" r:embed="R2b2080c20a3a4022">
+          <a:blip xmlns:r="http://schemas.openxmlformats.org/officeDocument/2006/relationships" xmlns:a="http://schemas.openxmlformats.org/drawingml/2006/main" r:embed="Rd84c4e9fa2d547d7">
             <a:alphaModFix/>
           </a:blip>
           <a:srcRect xmlns:a="http://schemas.openxmlformats.org/drawingml/2006/main" l="0" t="0" r="0" b="0"/>

</xml_diff>

<commit_message>
Update slides for consolidated setup scripts
</commit_message>
<xml_diff>
--- a/presentation/falco-libs-intro.pptx
+++ b/presentation/falco-libs-intro.pptx
@@ -2,84 +2,84 @@
 <file path=ppt/presentation.xml><?xml version="1.0" encoding="utf-8"?>
 <p:presentation xmlns:p="http://schemas.openxmlformats.org/presentationml/2006/main" embedTrueTypeFonts="1" saveSubsetFonts="0">
   <p:sldMasterIdLst>
-    <p:sldMasterId xmlns:r="http://schemas.openxmlformats.org/officeDocument/2006/relationships" id="2147483648" r:id="R25550fa8bad94c6f"/>
-    <p:sldMasterId xmlns:r="http://schemas.openxmlformats.org/officeDocument/2006/relationships" id="2147483661" r:id="R0723a6703b39482f"/>
+    <p:sldMasterId xmlns:r="http://schemas.openxmlformats.org/officeDocument/2006/relationships" id="2147483648" r:id="R372b47265870493c"/>
+    <p:sldMasterId xmlns:r="http://schemas.openxmlformats.org/officeDocument/2006/relationships" id="2147483661" r:id="R32b91cf846b44437"/>
   </p:sldMasterIdLst>
   <p:notesMasterIdLst>
-    <p:notesMasterId xmlns:r="http://schemas.openxmlformats.org/officeDocument/2006/relationships" r:id="Re64c12cde07e4f9b"/>
+    <p:notesMasterId xmlns:r="http://schemas.openxmlformats.org/officeDocument/2006/relationships" r:id="R7b3a9848904d4b17"/>
   </p:notesMasterIdLst>
   <p:sldIdLst>
-    <p:sldId xmlns:r="http://schemas.openxmlformats.org/officeDocument/2006/relationships" id="256" r:id="Rff6fff4690a1487d"/>
-    <p:sldId xmlns:r="http://schemas.openxmlformats.org/officeDocument/2006/relationships" id="257" r:id="R488bf42a04274575"/>
-    <p:sldId xmlns:r="http://schemas.openxmlformats.org/officeDocument/2006/relationships" id="258" r:id="R725482f17ec34565"/>
-    <p:sldId xmlns:r="http://schemas.openxmlformats.org/officeDocument/2006/relationships" id="259" r:id="Rab350e980d4d4a51"/>
-    <p:sldId xmlns:r="http://schemas.openxmlformats.org/officeDocument/2006/relationships" id="260" r:id="Rcd4b731b48be43c3"/>
-    <p:sldId xmlns:r="http://schemas.openxmlformats.org/officeDocument/2006/relationships" id="261" r:id="R14356ac4cbbc4e17"/>
-    <p:sldId xmlns:r="http://schemas.openxmlformats.org/officeDocument/2006/relationships" id="262" r:id="R0692f4f3ca1b4b8a"/>
-    <p:sldId xmlns:r="http://schemas.openxmlformats.org/officeDocument/2006/relationships" id="263" r:id="R6d0eda1cec424028"/>
-    <p:sldId xmlns:r="http://schemas.openxmlformats.org/officeDocument/2006/relationships" id="264" r:id="R503eab5341974dfa"/>
-    <p:sldId xmlns:r="http://schemas.openxmlformats.org/officeDocument/2006/relationships" id="265" r:id="Rc6ffd0fadea3435e"/>
-    <p:sldId xmlns:r="http://schemas.openxmlformats.org/officeDocument/2006/relationships" id="266" r:id="Rc5e23a61676d4822"/>
-    <p:sldId xmlns:r="http://schemas.openxmlformats.org/officeDocument/2006/relationships" id="267" r:id="R1fa896bd6c624ca1"/>
-    <p:sldId xmlns:r="http://schemas.openxmlformats.org/officeDocument/2006/relationships" id="268" r:id="R81060abddb1d40af"/>
-    <p:sldId xmlns:r="http://schemas.openxmlformats.org/officeDocument/2006/relationships" id="269" r:id="R634bf8b717544fd4"/>
-    <p:sldId xmlns:r="http://schemas.openxmlformats.org/officeDocument/2006/relationships" id="270" r:id="Re7dc157e1aae402a"/>
-    <p:sldId xmlns:r="http://schemas.openxmlformats.org/officeDocument/2006/relationships" id="271" r:id="Rdb3204923dc94aee"/>
-    <p:sldId xmlns:r="http://schemas.openxmlformats.org/officeDocument/2006/relationships" id="272" r:id="Ra23fde807e3d4fd2"/>
-    <p:sldId xmlns:r="http://schemas.openxmlformats.org/officeDocument/2006/relationships" id="273" r:id="Re03c0af45d9d4d6e"/>
-    <p:sldId xmlns:r="http://schemas.openxmlformats.org/officeDocument/2006/relationships" id="274" r:id="R1346bd4d3b22497e"/>
-    <p:sldId xmlns:r="http://schemas.openxmlformats.org/officeDocument/2006/relationships" id="275" r:id="Rde872e8a1b8d4136"/>
+    <p:sldId xmlns:r="http://schemas.openxmlformats.org/officeDocument/2006/relationships" id="256" r:id="Rfe1bfff882204de8"/>
+    <p:sldId xmlns:r="http://schemas.openxmlformats.org/officeDocument/2006/relationships" id="257" r:id="R2388ec90cfa0458f"/>
+    <p:sldId xmlns:r="http://schemas.openxmlformats.org/officeDocument/2006/relationships" id="258" r:id="Re1c593b95d144611"/>
+    <p:sldId xmlns:r="http://schemas.openxmlformats.org/officeDocument/2006/relationships" id="259" r:id="R3a7d99bcf1cd45f0"/>
+    <p:sldId xmlns:r="http://schemas.openxmlformats.org/officeDocument/2006/relationships" id="260" r:id="R274bf64606bb4e64"/>
+    <p:sldId xmlns:r="http://schemas.openxmlformats.org/officeDocument/2006/relationships" id="261" r:id="R6db98e9b44b1490f"/>
+    <p:sldId xmlns:r="http://schemas.openxmlformats.org/officeDocument/2006/relationships" id="262" r:id="R4340c97c625d4fc5"/>
+    <p:sldId xmlns:r="http://schemas.openxmlformats.org/officeDocument/2006/relationships" id="263" r:id="R8f2873c8eb954753"/>
+    <p:sldId xmlns:r="http://schemas.openxmlformats.org/officeDocument/2006/relationships" id="264" r:id="R4a71dd4ac1f34115"/>
+    <p:sldId xmlns:r="http://schemas.openxmlformats.org/officeDocument/2006/relationships" id="265" r:id="R75aee97ab9014c5e"/>
+    <p:sldId xmlns:r="http://schemas.openxmlformats.org/officeDocument/2006/relationships" id="266" r:id="R7d554791f9fd444a"/>
+    <p:sldId xmlns:r="http://schemas.openxmlformats.org/officeDocument/2006/relationships" id="267" r:id="R8d8e103b758f4bc9"/>
+    <p:sldId xmlns:r="http://schemas.openxmlformats.org/officeDocument/2006/relationships" id="268" r:id="R1c80790e0a424abd"/>
+    <p:sldId xmlns:r="http://schemas.openxmlformats.org/officeDocument/2006/relationships" id="269" r:id="Rfddf5e37a5b64e8a"/>
+    <p:sldId xmlns:r="http://schemas.openxmlformats.org/officeDocument/2006/relationships" id="270" r:id="R7f35b51a211e4d4a"/>
+    <p:sldId xmlns:r="http://schemas.openxmlformats.org/officeDocument/2006/relationships" id="271" r:id="R32515a1304b64941"/>
+    <p:sldId xmlns:r="http://schemas.openxmlformats.org/officeDocument/2006/relationships" id="272" r:id="Rd077c5549e9e492d"/>
+    <p:sldId xmlns:r="http://schemas.openxmlformats.org/officeDocument/2006/relationships" id="273" r:id="R4d52e578f77d4f67"/>
+    <p:sldId xmlns:r="http://schemas.openxmlformats.org/officeDocument/2006/relationships" id="274" r:id="R486026c2eb264fd7"/>
+    <p:sldId xmlns:r="http://schemas.openxmlformats.org/officeDocument/2006/relationships" id="275" r:id="R95f875fb19d948fb"/>
   </p:sldIdLst>
   <p:sldSz cx="9144000" cy="5143500"/>
   <p:notesSz cx="6858000" cy="9144000"/>
   <p:embeddedFontLst>
     <p:embeddedFont>
       <p:font typeface="Roboto Mono Medium"/>
-      <p:regular xmlns:r="http://schemas.openxmlformats.org/officeDocument/2006/relationships" r:id="R9ffe12f5e7d74120"/>
-      <p:bold xmlns:r="http://schemas.openxmlformats.org/officeDocument/2006/relationships" r:id="R5de9db69d2834cd1"/>
-      <p:italic xmlns:r="http://schemas.openxmlformats.org/officeDocument/2006/relationships" r:id="R3fdc39dd358e42b7"/>
-      <p:boldItalic xmlns:r="http://schemas.openxmlformats.org/officeDocument/2006/relationships" r:id="R08d15496361b46b5"/>
+      <p:regular xmlns:r="http://schemas.openxmlformats.org/officeDocument/2006/relationships" r:id="R52f0f372bc9c405e"/>
+      <p:bold xmlns:r="http://schemas.openxmlformats.org/officeDocument/2006/relationships" r:id="R095bf56a96824202"/>
+      <p:italic xmlns:r="http://schemas.openxmlformats.org/officeDocument/2006/relationships" r:id="Rfa9426f5e91f42a9"/>
+      <p:boldItalic xmlns:r="http://schemas.openxmlformats.org/officeDocument/2006/relationships" r:id="R064b63cceea449d0"/>
     </p:embeddedFont>
     <p:embeddedFont>
       <p:font typeface="Inter SemiBold"/>
-      <p:regular xmlns:r="http://schemas.openxmlformats.org/officeDocument/2006/relationships" r:id="R2f61c7ececc442ae"/>
-      <p:bold xmlns:r="http://schemas.openxmlformats.org/officeDocument/2006/relationships" r:id="R65afa766478f4f89"/>
-      <p:italic xmlns:r="http://schemas.openxmlformats.org/officeDocument/2006/relationships" r:id="Rc8cc8e192c684213"/>
-      <p:boldItalic xmlns:r="http://schemas.openxmlformats.org/officeDocument/2006/relationships" r:id="Rb19febd42fc54045"/>
+      <p:regular xmlns:r="http://schemas.openxmlformats.org/officeDocument/2006/relationships" r:id="R8191f555a9874104"/>
+      <p:bold xmlns:r="http://schemas.openxmlformats.org/officeDocument/2006/relationships" r:id="R3afe2aa501ad413e"/>
+      <p:italic xmlns:r="http://schemas.openxmlformats.org/officeDocument/2006/relationships" r:id="R1e79c5020bdc4733"/>
+      <p:boldItalic xmlns:r="http://schemas.openxmlformats.org/officeDocument/2006/relationships" r:id="R6844424bf804486d"/>
     </p:embeddedFont>
     <p:embeddedFont>
       <p:font typeface="Montserrat Black"/>
-      <p:bold xmlns:r="http://schemas.openxmlformats.org/officeDocument/2006/relationships" r:id="R036a79fd60af460a"/>
-      <p:boldItalic xmlns:r="http://schemas.openxmlformats.org/officeDocument/2006/relationships" r:id="R5f03f014eb684635"/>
+      <p:bold xmlns:r="http://schemas.openxmlformats.org/officeDocument/2006/relationships" r:id="R5656a95fc5fa4cda"/>
+      <p:boldItalic xmlns:r="http://schemas.openxmlformats.org/officeDocument/2006/relationships" r:id="R59595c2aed0b4db1"/>
     </p:embeddedFont>
     <p:embeddedFont>
       <p:font typeface="Montserrat"/>
-      <p:bold xmlns:r="http://schemas.openxmlformats.org/officeDocument/2006/relationships" r:id="R10ba7293b54b42af"/>
-      <p:boldItalic xmlns:r="http://schemas.openxmlformats.org/officeDocument/2006/relationships" r:id="R558ef0c49812426b"/>
+      <p:bold xmlns:r="http://schemas.openxmlformats.org/officeDocument/2006/relationships" r:id="R298b19d93393431c"/>
+      <p:boldItalic xmlns:r="http://schemas.openxmlformats.org/officeDocument/2006/relationships" r:id="R04b3f481ea394bef"/>
     </p:embeddedFont>
     <p:embeddedFont>
       <p:font typeface="Inter"/>
-      <p:regular xmlns:r="http://schemas.openxmlformats.org/officeDocument/2006/relationships" r:id="R9fa39ac8001c4add"/>
-      <p:bold xmlns:r="http://schemas.openxmlformats.org/officeDocument/2006/relationships" r:id="R08c70e4c40e64b9b"/>
-      <p:italic xmlns:r="http://schemas.openxmlformats.org/officeDocument/2006/relationships" r:id="R391f487c8ded4fa7"/>
-      <p:boldItalic xmlns:r="http://schemas.openxmlformats.org/officeDocument/2006/relationships" r:id="R5a28ef4aafcf4653"/>
+      <p:regular xmlns:r="http://schemas.openxmlformats.org/officeDocument/2006/relationships" r:id="Rdc6cff8b0381433c"/>
+      <p:bold xmlns:r="http://schemas.openxmlformats.org/officeDocument/2006/relationships" r:id="R03cc777fb084447d"/>
+      <p:italic xmlns:r="http://schemas.openxmlformats.org/officeDocument/2006/relationships" r:id="R51b3b1b91a32487e"/>
+      <p:boldItalic xmlns:r="http://schemas.openxmlformats.org/officeDocument/2006/relationships" r:id="R36bc1ea8913a44df"/>
     </p:embeddedFont>
     <p:embeddedFont>
       <p:font typeface="Montserrat ExtraBold"/>
-      <p:bold xmlns:r="http://schemas.openxmlformats.org/officeDocument/2006/relationships" r:id="R87a076e0356448a7"/>
-      <p:boldItalic xmlns:r="http://schemas.openxmlformats.org/officeDocument/2006/relationships" r:id="Recf81a4a1b3646a8"/>
+      <p:bold xmlns:r="http://schemas.openxmlformats.org/officeDocument/2006/relationships" r:id="Re12a9112073645c4"/>
+      <p:boldItalic xmlns:r="http://schemas.openxmlformats.org/officeDocument/2006/relationships" r:id="Rc73aa3f576f1455d"/>
     </p:embeddedFont>
     <p:embeddedFont>
       <p:font typeface="Roboto Mono"/>
-      <p:bold xmlns:r="http://schemas.openxmlformats.org/officeDocument/2006/relationships" r:id="Ra3212bbb4caa4d69"/>
-      <p:boldItalic xmlns:r="http://schemas.openxmlformats.org/officeDocument/2006/relationships" r:id="R28b06f887eee4ce8"/>
+      <p:bold xmlns:r="http://schemas.openxmlformats.org/officeDocument/2006/relationships" r:id="Ra4d19d4950754a89"/>
+      <p:boldItalic xmlns:r="http://schemas.openxmlformats.org/officeDocument/2006/relationships" r:id="R86a0b231f9434856"/>
     </p:embeddedFont>
     <p:embeddedFont>
       <p:font typeface="Inter Medium"/>
-      <p:regular xmlns:r="http://schemas.openxmlformats.org/officeDocument/2006/relationships" r:id="Rdc70d4fb5add4fb4"/>
-      <p:bold xmlns:r="http://schemas.openxmlformats.org/officeDocument/2006/relationships" r:id="R2e9b930b5dac4d4a"/>
-      <p:italic xmlns:r="http://schemas.openxmlformats.org/officeDocument/2006/relationships" r:id="Ree6cae09ca9249d1"/>
-      <p:boldItalic xmlns:r="http://schemas.openxmlformats.org/officeDocument/2006/relationships" r:id="Raf764ce428754fe7"/>
+      <p:regular xmlns:r="http://schemas.openxmlformats.org/officeDocument/2006/relationships" r:id="Rfaaef9a486e5406c"/>
+      <p:bold xmlns:r="http://schemas.openxmlformats.org/officeDocument/2006/relationships" r:id="R43368dab09854fa4"/>
+      <p:italic xmlns:r="http://schemas.openxmlformats.org/officeDocument/2006/relationships" r:id="R48100cbb48f94112"/>
+      <p:boldItalic xmlns:r="http://schemas.openxmlformats.org/officeDocument/2006/relationships" r:id="Re9e3b04551294035"/>
     </p:embeddedFont>
   </p:embeddedFontLst>
 </p:presentation>
@@ -6232,18 +6232,18 @@
   </p:cSld>
   <p:clrMap bg1="lt1" tx1="dk1" bg2="dk2" tx2="lt2" accent1="accent1" accent2="accent2" accent3="accent3" accent4="accent4" accent5="accent5" accent6="accent6" hlink="hlink" folHlink="folHlink"/>
   <p:sldLayoutIdLst>
-    <p:sldLayoutId xmlns:r="http://schemas.openxmlformats.org/officeDocument/2006/relationships" id="2147483649" r:id="R1b97348e6fd947bf"/>
-    <p:sldLayoutId xmlns:r="http://schemas.openxmlformats.org/officeDocument/2006/relationships" id="2147483650" r:id="Refcfc1bf4dec4a12"/>
-    <p:sldLayoutId xmlns:r="http://schemas.openxmlformats.org/officeDocument/2006/relationships" id="2147483651" r:id="R4f0850a89af041c5"/>
-    <p:sldLayoutId xmlns:r="http://schemas.openxmlformats.org/officeDocument/2006/relationships" id="2147483652" r:id="R60c1f805d88847a0"/>
-    <p:sldLayoutId xmlns:r="http://schemas.openxmlformats.org/officeDocument/2006/relationships" id="2147483653" r:id="Rf48cd20369b54bfb"/>
-    <p:sldLayoutId xmlns:r="http://schemas.openxmlformats.org/officeDocument/2006/relationships" id="2147483654" r:id="R7d42deeb487e44fd"/>
-    <p:sldLayoutId xmlns:r="http://schemas.openxmlformats.org/officeDocument/2006/relationships" id="2147483655" r:id="R849abaeae9fd4dd3"/>
-    <p:sldLayoutId xmlns:r="http://schemas.openxmlformats.org/officeDocument/2006/relationships" id="2147483656" r:id="Red1255ecc628483f"/>
-    <p:sldLayoutId xmlns:r="http://schemas.openxmlformats.org/officeDocument/2006/relationships" id="2147483657" r:id="R65f7e38190c1432b"/>
-    <p:sldLayoutId xmlns:r="http://schemas.openxmlformats.org/officeDocument/2006/relationships" id="2147483658" r:id="R2b187fe31bb44186"/>
-    <p:sldLayoutId xmlns:r="http://schemas.openxmlformats.org/officeDocument/2006/relationships" id="2147483659" r:id="Ra461a24c1fa144b7"/>
-    <p:sldLayoutId xmlns:r="http://schemas.openxmlformats.org/officeDocument/2006/relationships" id="2147483660" r:id="R89e56aa8577c4ee3"/>
+    <p:sldLayoutId xmlns:r="http://schemas.openxmlformats.org/officeDocument/2006/relationships" id="2147483649" r:id="R07f6dadd33904ed1"/>
+    <p:sldLayoutId xmlns:r="http://schemas.openxmlformats.org/officeDocument/2006/relationships" id="2147483650" r:id="Rd629cca7ff54415e"/>
+    <p:sldLayoutId xmlns:r="http://schemas.openxmlformats.org/officeDocument/2006/relationships" id="2147483651" r:id="Rdb714286a3f44b6f"/>
+    <p:sldLayoutId xmlns:r="http://schemas.openxmlformats.org/officeDocument/2006/relationships" id="2147483652" r:id="Rc52b07c6fade4586"/>
+    <p:sldLayoutId xmlns:r="http://schemas.openxmlformats.org/officeDocument/2006/relationships" id="2147483653" r:id="Rde62b98edd2b436d"/>
+    <p:sldLayoutId xmlns:r="http://schemas.openxmlformats.org/officeDocument/2006/relationships" id="2147483654" r:id="R44dac82055ef428c"/>
+    <p:sldLayoutId xmlns:r="http://schemas.openxmlformats.org/officeDocument/2006/relationships" id="2147483655" r:id="Rfb49ede80ce540aa"/>
+    <p:sldLayoutId xmlns:r="http://schemas.openxmlformats.org/officeDocument/2006/relationships" id="2147483656" r:id="R6a23eba4848346e4"/>
+    <p:sldLayoutId xmlns:r="http://schemas.openxmlformats.org/officeDocument/2006/relationships" id="2147483657" r:id="Ra2362fb8659a430d"/>
+    <p:sldLayoutId xmlns:r="http://schemas.openxmlformats.org/officeDocument/2006/relationships" id="2147483658" r:id="R467db0c5753d4c5e"/>
+    <p:sldLayoutId xmlns:r="http://schemas.openxmlformats.org/officeDocument/2006/relationships" id="2147483659" r:id="R90145611936846f9"/>
+    <p:sldLayoutId xmlns:r="http://schemas.openxmlformats.org/officeDocument/2006/relationships" id="2147483660" r:id="Rb333e2746d4f497e"/>
   </p:sldLayoutIdLst>
   <p:hf sldNum="0" hdr="0" ftr="0" dt="0"/>
   <p:txStyles>
@@ -6928,7 +6928,7 @@
   </p:cSld>
   <p:clrMap bg1="lt1" tx1="dk1" bg2="dk2" tx2="lt2" accent1="accent1" accent2="accent2" accent3="accent3" accent4="accent4" accent5="accent5" accent6="accent6" hlink="hlink" folHlink="folHlink"/>
   <p:sldLayoutIdLst>
-    <p:sldLayoutId xmlns:r="http://schemas.openxmlformats.org/officeDocument/2006/relationships" id="2147483662" r:id="R9c27d10a0e8f4a72"/>
+    <p:sldLayoutId xmlns:r="http://schemas.openxmlformats.org/officeDocument/2006/relationships" id="2147483662" r:id="R37b8526add59452d"/>
   </p:sldLayoutIdLst>
   <p:hf sldNum="0" hdr="0" ftr="0" dt="0"/>
   <p:txStyles>
@@ -8777,7 +8777,7 @@
           <p:nvPr/>
         </p:nvPicPr>
         <p:blipFill rotWithShape="1">
-          <a:blip xmlns:r="http://schemas.openxmlformats.org/officeDocument/2006/relationships" xmlns:a="http://schemas.openxmlformats.org/drawingml/2006/main" r:embed="Rfb311fe5c38b4ae5">
+          <a:blip xmlns:r="http://schemas.openxmlformats.org/officeDocument/2006/relationships" xmlns:a="http://schemas.openxmlformats.org/drawingml/2006/main" r:embed="R4ee8073bc2914e8b">
             <a:alphaModFix/>
           </a:blip>
           <a:srcRect xmlns:a="http://schemas.openxmlformats.org/drawingml/2006/main" l="0" t="0" r="0" b="0"/>
@@ -8805,7 +8805,7 @@
           <p:nvPr/>
         </p:nvPicPr>
         <p:blipFill rotWithShape="1">
-          <a:blip xmlns:r="http://schemas.openxmlformats.org/officeDocument/2006/relationships" xmlns:a="http://schemas.openxmlformats.org/drawingml/2006/main" r:embed="Rfb311fe5c38b4ae5">
+          <a:blip xmlns:r="http://schemas.openxmlformats.org/officeDocument/2006/relationships" xmlns:a="http://schemas.openxmlformats.org/drawingml/2006/main" r:embed="R4ee8073bc2914e8b">
             <a:alphaModFix/>
           </a:blip>
           <a:srcRect xmlns:a="http://schemas.openxmlformats.org/drawingml/2006/main" l="0" t="0" r="0" b="0"/>
@@ -8833,7 +8833,7 @@
           <p:nvPr/>
         </p:nvPicPr>
         <p:blipFill rotWithShape="1">
-          <a:blip xmlns:r="http://schemas.openxmlformats.org/officeDocument/2006/relationships" xmlns:a="http://schemas.openxmlformats.org/drawingml/2006/main" r:embed="Rfb311fe5c38b4ae5">
+          <a:blip xmlns:r="http://schemas.openxmlformats.org/officeDocument/2006/relationships" xmlns:a="http://schemas.openxmlformats.org/drawingml/2006/main" r:embed="R4ee8073bc2914e8b">
             <a:alphaModFix/>
           </a:blip>
           <a:srcRect xmlns:a="http://schemas.openxmlformats.org/drawingml/2006/main" l="0" t="0" r="0" b="0"/>
@@ -8861,7 +8861,7 @@
           <p:nvPr/>
         </p:nvPicPr>
         <p:blipFill rotWithShape="1">
-          <a:blip xmlns:r="http://schemas.openxmlformats.org/officeDocument/2006/relationships" xmlns:a="http://schemas.openxmlformats.org/drawingml/2006/main" r:embed="Rfb311fe5c38b4ae5">
+          <a:blip xmlns:r="http://schemas.openxmlformats.org/officeDocument/2006/relationships" xmlns:a="http://schemas.openxmlformats.org/drawingml/2006/main" r:embed="R4ee8073bc2914e8b">
             <a:alphaModFix/>
           </a:blip>
           <a:srcRect xmlns:a="http://schemas.openxmlformats.org/drawingml/2006/main" l="0" t="0" r="0" b="0"/>
@@ -8889,7 +8889,7 @@
           <p:nvPr/>
         </p:nvPicPr>
         <p:blipFill rotWithShape="1">
-          <a:blip xmlns:r="http://schemas.openxmlformats.org/officeDocument/2006/relationships" xmlns:a="http://schemas.openxmlformats.org/drawingml/2006/main" r:embed="Rfb311fe5c38b4ae5">
+          <a:blip xmlns:r="http://schemas.openxmlformats.org/officeDocument/2006/relationships" xmlns:a="http://schemas.openxmlformats.org/drawingml/2006/main" r:embed="R4ee8073bc2914e8b">
             <a:alphaModFix/>
           </a:blip>
           <a:srcRect xmlns:a="http://schemas.openxmlformats.org/drawingml/2006/main" l="0" t="0" r="0" b="0"/>
@@ -8917,7 +8917,7 @@
           <p:nvPr/>
         </p:nvPicPr>
         <p:blipFill rotWithShape="1">
-          <a:blip xmlns:r="http://schemas.openxmlformats.org/officeDocument/2006/relationships" xmlns:a="http://schemas.openxmlformats.org/drawingml/2006/main" r:embed="Rfb311fe5c38b4ae5">
+          <a:blip xmlns:r="http://schemas.openxmlformats.org/officeDocument/2006/relationships" xmlns:a="http://schemas.openxmlformats.org/drawingml/2006/main" r:embed="R4ee8073bc2914e8b">
             <a:alphaModFix/>
           </a:blip>
           <a:srcRect xmlns:a="http://schemas.openxmlformats.org/drawingml/2006/main" l="0" t="0" r="0" b="0"/>
@@ -8945,7 +8945,7 @@
           <p:nvPr/>
         </p:nvPicPr>
         <p:blipFill rotWithShape="1">
-          <a:blip xmlns:r="http://schemas.openxmlformats.org/officeDocument/2006/relationships" xmlns:a="http://schemas.openxmlformats.org/drawingml/2006/main" r:embed="Rfb311fe5c38b4ae5">
+          <a:blip xmlns:r="http://schemas.openxmlformats.org/officeDocument/2006/relationships" xmlns:a="http://schemas.openxmlformats.org/drawingml/2006/main" r:embed="R4ee8073bc2914e8b">
             <a:alphaModFix/>
           </a:blip>
           <a:srcRect xmlns:a="http://schemas.openxmlformats.org/drawingml/2006/main" l="0" t="0" r="0" b="0"/>
@@ -8973,7 +8973,7 @@
           <p:nvPr/>
         </p:nvPicPr>
         <p:blipFill rotWithShape="1">
-          <a:blip xmlns:r="http://schemas.openxmlformats.org/officeDocument/2006/relationships" xmlns:a="http://schemas.openxmlformats.org/drawingml/2006/main" r:embed="Rfb311fe5c38b4ae5">
+          <a:blip xmlns:r="http://schemas.openxmlformats.org/officeDocument/2006/relationships" xmlns:a="http://schemas.openxmlformats.org/drawingml/2006/main" r:embed="R4ee8073bc2914e8b">
             <a:alphaModFix/>
           </a:blip>
           <a:srcRect xmlns:a="http://schemas.openxmlformats.org/drawingml/2006/main" l="0" t="0" r="0" b="0"/>
@@ -10378,7 +10378,8 @@
                 <a:ea typeface="Roboto Mono"/>
                 <a:cs typeface="Roboto Mono"/>
               </a:rPr>
-              <a:t>bash scripts/build.sh</a:t>
+              <a:t>cmake --build build \
+  --target workshop-agent -j 1</a:t>
             </a:r>
           </a:p>
           <a:p xmlns:a="http://schemas.openxmlformats.org/drawingml/2006/main">
@@ -11058,7 +11059,7 @@
           <p:nvPr/>
         </p:nvPicPr>
         <p:blipFill rotWithShape="1">
-          <a:blip xmlns:r="http://schemas.openxmlformats.org/officeDocument/2006/relationships" xmlns:a="http://schemas.openxmlformats.org/drawingml/2006/main" r:embed="R232ef03012864447">
+          <a:blip xmlns:r="http://schemas.openxmlformats.org/officeDocument/2006/relationships" xmlns:a="http://schemas.openxmlformats.org/drawingml/2006/main" r:embed="Rd66e1124790b45de">
             <a:alphaModFix/>
           </a:blip>
           <a:srcRect xmlns:a="http://schemas.openxmlformats.org/drawingml/2006/main" l="0" t="0" r="0" b="0"/>
@@ -11086,7 +11087,7 @@
           <p:nvPr/>
         </p:nvPicPr>
         <p:blipFill rotWithShape="1">
-          <a:blip xmlns:r="http://schemas.openxmlformats.org/officeDocument/2006/relationships" xmlns:a="http://schemas.openxmlformats.org/drawingml/2006/main" r:embed="R232ef03012864447">
+          <a:blip xmlns:r="http://schemas.openxmlformats.org/officeDocument/2006/relationships" xmlns:a="http://schemas.openxmlformats.org/drawingml/2006/main" r:embed="Rd66e1124790b45de">
             <a:alphaModFix/>
           </a:blip>
           <a:srcRect xmlns:a="http://schemas.openxmlformats.org/drawingml/2006/main" l="0" t="0" r="0" b="0"/>
@@ -11114,7 +11115,7 @@
           <p:nvPr/>
         </p:nvPicPr>
         <p:blipFill rotWithShape="1">
-          <a:blip xmlns:r="http://schemas.openxmlformats.org/officeDocument/2006/relationships" xmlns:a="http://schemas.openxmlformats.org/drawingml/2006/main" r:embed="R232ef03012864447">
+          <a:blip xmlns:r="http://schemas.openxmlformats.org/officeDocument/2006/relationships" xmlns:a="http://schemas.openxmlformats.org/drawingml/2006/main" r:embed="Rd66e1124790b45de">
             <a:alphaModFix/>
           </a:blip>
           <a:srcRect xmlns:a="http://schemas.openxmlformats.org/drawingml/2006/main" l="0" t="0" r="0" b="0"/>
@@ -11142,7 +11143,7 @@
           <p:nvPr/>
         </p:nvPicPr>
         <p:blipFill rotWithShape="1">
-          <a:blip xmlns:r="http://schemas.openxmlformats.org/officeDocument/2006/relationships" xmlns:a="http://schemas.openxmlformats.org/drawingml/2006/main" r:embed="R232ef03012864447">
+          <a:blip xmlns:r="http://schemas.openxmlformats.org/officeDocument/2006/relationships" xmlns:a="http://schemas.openxmlformats.org/drawingml/2006/main" r:embed="Rd66e1124790b45de">
             <a:alphaModFix/>
           </a:blip>
           <a:srcRect xmlns:a="http://schemas.openxmlformats.org/drawingml/2006/main" l="0" t="0" r="0" b="0"/>
@@ -13075,7 +13076,7 @@
           <p:nvPr/>
         </p:nvPicPr>
         <p:blipFill rotWithShape="1">
-          <a:blip xmlns:r="http://schemas.openxmlformats.org/officeDocument/2006/relationships" xmlns:a="http://schemas.openxmlformats.org/drawingml/2006/main" r:embed="R2a3dea5690b9449a">
+          <a:blip xmlns:r="http://schemas.openxmlformats.org/officeDocument/2006/relationships" xmlns:a="http://schemas.openxmlformats.org/drawingml/2006/main" r:embed="Rc4c7dc48bc674abf">
             <a:alphaModFix/>
           </a:blip>
           <a:srcRect xmlns:a="http://schemas.openxmlformats.org/drawingml/2006/main" l="0" t="0" r="0" b="0"/>
@@ -13103,7 +13104,7 @@
           <p:nvPr/>
         </p:nvPicPr>
         <p:blipFill rotWithShape="1">
-          <a:blip xmlns:r="http://schemas.openxmlformats.org/officeDocument/2006/relationships" xmlns:a="http://schemas.openxmlformats.org/drawingml/2006/main" r:embed="R2a3dea5690b9449a">
+          <a:blip xmlns:r="http://schemas.openxmlformats.org/officeDocument/2006/relationships" xmlns:a="http://schemas.openxmlformats.org/drawingml/2006/main" r:embed="Rc4c7dc48bc674abf">
             <a:alphaModFix/>
           </a:blip>
           <a:srcRect xmlns:a="http://schemas.openxmlformats.org/drawingml/2006/main" l="0" t="0" r="0" b="0"/>
@@ -13131,7 +13132,7 @@
           <p:nvPr/>
         </p:nvPicPr>
         <p:blipFill rotWithShape="1">
-          <a:blip xmlns:r="http://schemas.openxmlformats.org/officeDocument/2006/relationships" xmlns:a="http://schemas.openxmlformats.org/drawingml/2006/main" r:embed="R2a3dea5690b9449a">
+          <a:blip xmlns:r="http://schemas.openxmlformats.org/officeDocument/2006/relationships" xmlns:a="http://schemas.openxmlformats.org/drawingml/2006/main" r:embed="Rc4c7dc48bc674abf">
             <a:alphaModFix/>
           </a:blip>
           <a:srcRect xmlns:a="http://schemas.openxmlformats.org/drawingml/2006/main" l="0" t="0" r="0" b="0"/>
@@ -13159,7 +13160,7 @@
           <p:nvPr/>
         </p:nvPicPr>
         <p:blipFill rotWithShape="1">
-          <a:blip xmlns:r="http://schemas.openxmlformats.org/officeDocument/2006/relationships" xmlns:a="http://schemas.openxmlformats.org/drawingml/2006/main" r:embed="R2a3dea5690b9449a">
+          <a:blip xmlns:r="http://schemas.openxmlformats.org/officeDocument/2006/relationships" xmlns:a="http://schemas.openxmlformats.org/drawingml/2006/main" r:embed="Rc4c7dc48bc674abf">
             <a:alphaModFix/>
           </a:blip>
           <a:srcRect xmlns:a="http://schemas.openxmlformats.org/drawingml/2006/main" l="0" t="0" r="0" b="0"/>
@@ -15070,7 +15071,7 @@
           <p:nvPr/>
         </p:nvPicPr>
         <p:blipFill rotWithShape="1">
-          <a:blip xmlns:r="http://schemas.openxmlformats.org/officeDocument/2006/relationships" xmlns:a="http://schemas.openxmlformats.org/drawingml/2006/main" r:embed="Re772fe9d45b34f48">
+          <a:blip xmlns:r="http://schemas.openxmlformats.org/officeDocument/2006/relationships" xmlns:a="http://schemas.openxmlformats.org/drawingml/2006/main" r:embed="Re63a3fb1327945f6">
             <a:alphaModFix/>
           </a:blip>
           <a:srcRect xmlns:a="http://schemas.openxmlformats.org/drawingml/2006/main" l="0" t="0" r="0" b="0"/>
@@ -15098,7 +15099,7 @@
           <p:nvPr/>
         </p:nvPicPr>
         <p:blipFill rotWithShape="1">
-          <a:blip xmlns:r="http://schemas.openxmlformats.org/officeDocument/2006/relationships" xmlns:a="http://schemas.openxmlformats.org/drawingml/2006/main" r:embed="Re772fe9d45b34f48">
+          <a:blip xmlns:r="http://schemas.openxmlformats.org/officeDocument/2006/relationships" xmlns:a="http://schemas.openxmlformats.org/drawingml/2006/main" r:embed="Re63a3fb1327945f6">
             <a:alphaModFix/>
           </a:blip>
           <a:srcRect xmlns:a="http://schemas.openxmlformats.org/drawingml/2006/main" l="0" t="0" r="0" b="0"/>
@@ -15126,7 +15127,7 @@
           <p:nvPr/>
         </p:nvPicPr>
         <p:blipFill rotWithShape="1">
-          <a:blip xmlns:r="http://schemas.openxmlformats.org/officeDocument/2006/relationships" xmlns:a="http://schemas.openxmlformats.org/drawingml/2006/main" r:embed="Re772fe9d45b34f48">
+          <a:blip xmlns:r="http://schemas.openxmlformats.org/officeDocument/2006/relationships" xmlns:a="http://schemas.openxmlformats.org/drawingml/2006/main" r:embed="Re63a3fb1327945f6">
             <a:alphaModFix/>
           </a:blip>
           <a:srcRect xmlns:a="http://schemas.openxmlformats.org/drawingml/2006/main" l="0" t="0" r="0" b="0"/>
@@ -15154,7 +15155,7 @@
           <p:nvPr/>
         </p:nvPicPr>
         <p:blipFill rotWithShape="1">
-          <a:blip xmlns:r="http://schemas.openxmlformats.org/officeDocument/2006/relationships" xmlns:a="http://schemas.openxmlformats.org/drawingml/2006/main" r:embed="Re772fe9d45b34f48">
+          <a:blip xmlns:r="http://schemas.openxmlformats.org/officeDocument/2006/relationships" xmlns:a="http://schemas.openxmlformats.org/drawingml/2006/main" r:embed="Re63a3fb1327945f6">
             <a:alphaModFix/>
           </a:blip>
           <a:srcRect xmlns:a="http://schemas.openxmlformats.org/drawingml/2006/main" l="0" t="0" r="0" b="0"/>
@@ -17193,7 +17194,7 @@
           <p:nvPr/>
         </p:nvPicPr>
         <p:blipFill rotWithShape="1">
-          <a:blip xmlns:r="http://schemas.openxmlformats.org/officeDocument/2006/relationships" xmlns:a="http://schemas.openxmlformats.org/drawingml/2006/main" r:embed="R3ad295163aa347bc">
+          <a:blip xmlns:r="http://schemas.openxmlformats.org/officeDocument/2006/relationships" xmlns:a="http://schemas.openxmlformats.org/drawingml/2006/main" r:embed="R6b995ae953064d0f">
             <a:alphaModFix/>
           </a:blip>
           <a:srcRect xmlns:a="http://schemas.openxmlformats.org/drawingml/2006/main" l="0" t="0" r="0" b="0"/>
@@ -17221,7 +17222,7 @@
           <p:nvPr/>
         </p:nvPicPr>
         <p:blipFill rotWithShape="1">
-          <a:blip xmlns:r="http://schemas.openxmlformats.org/officeDocument/2006/relationships" xmlns:a="http://schemas.openxmlformats.org/drawingml/2006/main" r:embed="R3ad295163aa347bc">
+          <a:blip xmlns:r="http://schemas.openxmlformats.org/officeDocument/2006/relationships" xmlns:a="http://schemas.openxmlformats.org/drawingml/2006/main" r:embed="R6b995ae953064d0f">
             <a:alphaModFix/>
           </a:blip>
           <a:srcRect xmlns:a="http://schemas.openxmlformats.org/drawingml/2006/main" l="0" t="0" r="0" b="0"/>
@@ -17249,7 +17250,7 @@
           <p:nvPr/>
         </p:nvPicPr>
         <p:blipFill rotWithShape="1">
-          <a:blip xmlns:r="http://schemas.openxmlformats.org/officeDocument/2006/relationships" xmlns:a="http://schemas.openxmlformats.org/drawingml/2006/main" r:embed="R3ad295163aa347bc">
+          <a:blip xmlns:r="http://schemas.openxmlformats.org/officeDocument/2006/relationships" xmlns:a="http://schemas.openxmlformats.org/drawingml/2006/main" r:embed="R6b995ae953064d0f">
             <a:alphaModFix/>
           </a:blip>
           <a:srcRect xmlns:a="http://schemas.openxmlformats.org/drawingml/2006/main" l="0" t="0" r="0" b="0"/>
@@ -17277,7 +17278,7 @@
           <p:nvPr/>
         </p:nvPicPr>
         <p:blipFill rotWithShape="1">
-          <a:blip xmlns:r="http://schemas.openxmlformats.org/officeDocument/2006/relationships" xmlns:a="http://schemas.openxmlformats.org/drawingml/2006/main" r:embed="R3ad295163aa347bc">
+          <a:blip xmlns:r="http://schemas.openxmlformats.org/officeDocument/2006/relationships" xmlns:a="http://schemas.openxmlformats.org/drawingml/2006/main" r:embed="R6b995ae953064d0f">
             <a:alphaModFix/>
           </a:blip>
           <a:srcRect xmlns:a="http://schemas.openxmlformats.org/drawingml/2006/main" l="0" t="0" r="0" b="0"/>
@@ -19308,7 +19309,7 @@
           <p:nvPr/>
         </p:nvPicPr>
         <p:blipFill rotWithShape="1">
-          <a:blip xmlns:r="http://schemas.openxmlformats.org/officeDocument/2006/relationships" xmlns:a="http://schemas.openxmlformats.org/drawingml/2006/main" r:embed="R1c5edd4bde4a4bf8">
+          <a:blip xmlns:r="http://schemas.openxmlformats.org/officeDocument/2006/relationships" xmlns:a="http://schemas.openxmlformats.org/drawingml/2006/main" r:embed="R12b1d40ea2274877">
             <a:alphaModFix/>
           </a:blip>
           <a:srcRect xmlns:a="http://schemas.openxmlformats.org/drawingml/2006/main" l="0" t="0" r="0" b="0"/>
@@ -19336,7 +19337,7 @@
           <p:nvPr/>
         </p:nvPicPr>
         <p:blipFill rotWithShape="1">
-          <a:blip xmlns:r="http://schemas.openxmlformats.org/officeDocument/2006/relationships" xmlns:a="http://schemas.openxmlformats.org/drawingml/2006/main" r:embed="R1c5edd4bde4a4bf8">
+          <a:blip xmlns:r="http://schemas.openxmlformats.org/officeDocument/2006/relationships" xmlns:a="http://schemas.openxmlformats.org/drawingml/2006/main" r:embed="R12b1d40ea2274877">
             <a:alphaModFix/>
           </a:blip>
           <a:srcRect xmlns:a="http://schemas.openxmlformats.org/drawingml/2006/main" l="0" t="0" r="0" b="0"/>
@@ -19364,7 +19365,7 @@
           <p:nvPr/>
         </p:nvPicPr>
         <p:blipFill rotWithShape="1">
-          <a:blip xmlns:r="http://schemas.openxmlformats.org/officeDocument/2006/relationships" xmlns:a="http://schemas.openxmlformats.org/drawingml/2006/main" r:embed="R1c5edd4bde4a4bf8">
+          <a:blip xmlns:r="http://schemas.openxmlformats.org/officeDocument/2006/relationships" xmlns:a="http://schemas.openxmlformats.org/drawingml/2006/main" r:embed="R12b1d40ea2274877">
             <a:alphaModFix/>
           </a:blip>
           <a:srcRect xmlns:a="http://schemas.openxmlformats.org/drawingml/2006/main" l="0" t="0" r="0" b="0"/>
@@ -19392,7 +19393,7 @@
           <p:nvPr/>
         </p:nvPicPr>
         <p:blipFill rotWithShape="1">
-          <a:blip xmlns:r="http://schemas.openxmlformats.org/officeDocument/2006/relationships" xmlns:a="http://schemas.openxmlformats.org/drawingml/2006/main" r:embed="R1c5edd4bde4a4bf8">
+          <a:blip xmlns:r="http://schemas.openxmlformats.org/officeDocument/2006/relationships" xmlns:a="http://schemas.openxmlformats.org/drawingml/2006/main" r:embed="R12b1d40ea2274877">
             <a:alphaModFix/>
           </a:blip>
           <a:srcRect xmlns:a="http://schemas.openxmlformats.org/drawingml/2006/main" l="0" t="0" r="0" b="0"/>
@@ -20563,7 +20564,8 @@
                 <a:ea typeface="Roboto Mono"/>
                 <a:cs typeface="Roboto Mono"/>
               </a:rPr>
-              <a:t>bash scripts/build.sh</a:t>
+              <a:t>cmake --build build \
+  --target workshop-agent -j 1</a:t>
             </a:r>
           </a:p>
           <a:p xmlns:a="http://schemas.openxmlformats.org/drawingml/2006/main">
@@ -21437,7 +21439,7 @@
           <p:nvPr/>
         </p:nvPicPr>
         <p:blipFill rotWithShape="1">
-          <a:blip xmlns:r="http://schemas.openxmlformats.org/officeDocument/2006/relationships" xmlns:a="http://schemas.openxmlformats.org/drawingml/2006/main" r:embed="R8e5f5891a27c4e94">
+          <a:blip xmlns:r="http://schemas.openxmlformats.org/officeDocument/2006/relationships" xmlns:a="http://schemas.openxmlformats.org/drawingml/2006/main" r:embed="R4fc4c60071824597">
             <a:alphaModFix/>
           </a:blip>
           <a:srcRect xmlns:a="http://schemas.openxmlformats.org/drawingml/2006/main" l="0" t="0" r="0" b="0"/>
@@ -21465,7 +21467,7 @@
           <p:nvPr/>
         </p:nvPicPr>
         <p:blipFill rotWithShape="1">
-          <a:blip xmlns:r="http://schemas.openxmlformats.org/officeDocument/2006/relationships" xmlns:a="http://schemas.openxmlformats.org/drawingml/2006/main" r:embed="R8e5f5891a27c4e94">
+          <a:blip xmlns:r="http://schemas.openxmlformats.org/officeDocument/2006/relationships" xmlns:a="http://schemas.openxmlformats.org/drawingml/2006/main" r:embed="R4fc4c60071824597">
             <a:alphaModFix/>
           </a:blip>
           <a:srcRect xmlns:a="http://schemas.openxmlformats.org/drawingml/2006/main" l="0" t="0" r="0" b="0"/>
@@ -21493,7 +21495,7 @@
           <p:nvPr/>
         </p:nvPicPr>
         <p:blipFill rotWithShape="1">
-          <a:blip xmlns:r="http://schemas.openxmlformats.org/officeDocument/2006/relationships" xmlns:a="http://schemas.openxmlformats.org/drawingml/2006/main" r:embed="R8e5f5891a27c4e94">
+          <a:blip xmlns:r="http://schemas.openxmlformats.org/officeDocument/2006/relationships" xmlns:a="http://schemas.openxmlformats.org/drawingml/2006/main" r:embed="R4fc4c60071824597">
             <a:alphaModFix/>
           </a:blip>
           <a:srcRect xmlns:a="http://schemas.openxmlformats.org/drawingml/2006/main" l="0" t="0" r="0" b="0"/>
@@ -21521,7 +21523,7 @@
           <p:nvPr/>
         </p:nvPicPr>
         <p:blipFill rotWithShape="1">
-          <a:blip xmlns:r="http://schemas.openxmlformats.org/officeDocument/2006/relationships" xmlns:a="http://schemas.openxmlformats.org/drawingml/2006/main" r:embed="R8e5f5891a27c4e94">
+          <a:blip xmlns:r="http://schemas.openxmlformats.org/officeDocument/2006/relationships" xmlns:a="http://schemas.openxmlformats.org/drawingml/2006/main" r:embed="R4fc4c60071824597">
             <a:alphaModFix/>
           </a:blip>
           <a:srcRect xmlns:a="http://schemas.openxmlformats.org/drawingml/2006/main" l="0" t="0" r="0" b="0"/>
@@ -23544,7 +23546,7 @@
           <p:nvPr/>
         </p:nvPicPr>
         <p:blipFill rotWithShape="1">
-          <a:blip xmlns:r="http://schemas.openxmlformats.org/officeDocument/2006/relationships" xmlns:a="http://schemas.openxmlformats.org/drawingml/2006/main" r:embed="R1b459493194a42c9">
+          <a:blip xmlns:r="http://schemas.openxmlformats.org/officeDocument/2006/relationships" xmlns:a="http://schemas.openxmlformats.org/drawingml/2006/main" r:embed="Rbe4b57f38ce6499d">
             <a:alphaModFix/>
           </a:blip>
           <a:srcRect xmlns:a="http://schemas.openxmlformats.org/drawingml/2006/main" l="0" t="0" r="0" b="0"/>
@@ -23572,7 +23574,7 @@
           <p:nvPr/>
         </p:nvPicPr>
         <p:blipFill rotWithShape="1">
-          <a:blip xmlns:r="http://schemas.openxmlformats.org/officeDocument/2006/relationships" xmlns:a="http://schemas.openxmlformats.org/drawingml/2006/main" r:embed="R1b459493194a42c9">
+          <a:blip xmlns:r="http://schemas.openxmlformats.org/officeDocument/2006/relationships" xmlns:a="http://schemas.openxmlformats.org/drawingml/2006/main" r:embed="Rbe4b57f38ce6499d">
             <a:alphaModFix/>
           </a:blip>
           <a:srcRect xmlns:a="http://schemas.openxmlformats.org/drawingml/2006/main" l="0" t="0" r="0" b="0"/>
@@ -23600,7 +23602,7 @@
           <p:nvPr/>
         </p:nvPicPr>
         <p:blipFill rotWithShape="1">
-          <a:blip xmlns:r="http://schemas.openxmlformats.org/officeDocument/2006/relationships" xmlns:a="http://schemas.openxmlformats.org/drawingml/2006/main" r:embed="R1b459493194a42c9">
+          <a:blip xmlns:r="http://schemas.openxmlformats.org/officeDocument/2006/relationships" xmlns:a="http://schemas.openxmlformats.org/drawingml/2006/main" r:embed="Rbe4b57f38ce6499d">
             <a:alphaModFix/>
           </a:blip>
           <a:srcRect xmlns:a="http://schemas.openxmlformats.org/drawingml/2006/main" l="0" t="0" r="0" b="0"/>
@@ -23628,7 +23630,7 @@
           <p:nvPr/>
         </p:nvPicPr>
         <p:blipFill rotWithShape="1">
-          <a:blip xmlns:r="http://schemas.openxmlformats.org/officeDocument/2006/relationships" xmlns:a="http://schemas.openxmlformats.org/drawingml/2006/main" r:embed="R1b459493194a42c9">
+          <a:blip xmlns:r="http://schemas.openxmlformats.org/officeDocument/2006/relationships" xmlns:a="http://schemas.openxmlformats.org/drawingml/2006/main" r:embed="Rbe4b57f38ce6499d">
             <a:alphaModFix/>
           </a:blip>
           <a:srcRect xmlns:a="http://schemas.openxmlformats.org/drawingml/2006/main" l="0" t="0" r="0" b="0"/>
@@ -25703,7 +25705,7 @@
           <p:nvPr/>
         </p:nvPicPr>
         <p:blipFill rotWithShape="1">
-          <a:blip xmlns:r="http://schemas.openxmlformats.org/officeDocument/2006/relationships" xmlns:a="http://schemas.openxmlformats.org/drawingml/2006/main" r:embed="R44018fe83a5e4d90">
+          <a:blip xmlns:r="http://schemas.openxmlformats.org/officeDocument/2006/relationships" xmlns:a="http://schemas.openxmlformats.org/drawingml/2006/main" r:embed="R42d6119b0ead41d8">
             <a:alphaModFix/>
           </a:blip>
           <a:srcRect xmlns:a="http://schemas.openxmlformats.org/drawingml/2006/main" l="0" t="0" r="0" b="0"/>
@@ -25731,7 +25733,7 @@
           <p:nvPr/>
         </p:nvPicPr>
         <p:blipFill rotWithShape="1">
-          <a:blip xmlns:r="http://schemas.openxmlformats.org/officeDocument/2006/relationships" xmlns:a="http://schemas.openxmlformats.org/drawingml/2006/main" r:embed="R44018fe83a5e4d90">
+          <a:blip xmlns:r="http://schemas.openxmlformats.org/officeDocument/2006/relationships" xmlns:a="http://schemas.openxmlformats.org/drawingml/2006/main" r:embed="R42d6119b0ead41d8">
             <a:alphaModFix/>
           </a:blip>
           <a:srcRect xmlns:a="http://schemas.openxmlformats.org/drawingml/2006/main" l="0" t="0" r="0" b="0"/>
@@ -25759,7 +25761,7 @@
           <p:nvPr/>
         </p:nvPicPr>
         <p:blipFill rotWithShape="1">
-          <a:blip xmlns:r="http://schemas.openxmlformats.org/officeDocument/2006/relationships" xmlns:a="http://schemas.openxmlformats.org/drawingml/2006/main" r:embed="R44018fe83a5e4d90">
+          <a:blip xmlns:r="http://schemas.openxmlformats.org/officeDocument/2006/relationships" xmlns:a="http://schemas.openxmlformats.org/drawingml/2006/main" r:embed="R42d6119b0ead41d8">
             <a:alphaModFix/>
           </a:blip>
           <a:srcRect xmlns:a="http://schemas.openxmlformats.org/drawingml/2006/main" l="0" t="0" r="0" b="0"/>
@@ -25787,7 +25789,7 @@
           <p:nvPr/>
         </p:nvPicPr>
         <p:blipFill rotWithShape="1">
-          <a:blip xmlns:r="http://schemas.openxmlformats.org/officeDocument/2006/relationships" xmlns:a="http://schemas.openxmlformats.org/drawingml/2006/main" r:embed="R44018fe83a5e4d90">
+          <a:blip xmlns:r="http://schemas.openxmlformats.org/officeDocument/2006/relationships" xmlns:a="http://schemas.openxmlformats.org/drawingml/2006/main" r:embed="R42d6119b0ead41d8">
             <a:alphaModFix/>
           </a:blip>
           <a:srcRect xmlns:a="http://schemas.openxmlformats.org/drawingml/2006/main" l="0" t="0" r="0" b="0"/>
@@ -26858,7 +26860,7 @@
                 <a:spcPts val="0"/>
               </a:spcAft>
               <a:buNone/>
-              <a:defRPr sz="1350" b="0">
+              <a:defRPr sz="1350">
                 <a:solidFill>
                   <a:srgbClr val="00E5FF"/>
                 </a:solidFill>
@@ -26888,7 +26890,7 @@
                 <a:spcPts val="0"/>
               </a:spcAft>
               <a:buNone/>
-              <a:defRPr sz="1350" b="0">
+              <a:defRPr sz="1350">
                 <a:solidFill>
                   <a:srgbClr val="00E5FF"/>
                 </a:solidFill>
@@ -26918,7 +26920,7 @@
                 <a:spcPts val="0"/>
               </a:spcAft>
               <a:buNone/>
-              <a:defRPr sz="1350" b="0">
+              <a:defRPr sz="1350">
                 <a:solidFill>
                   <a:srgbClr val="00E5FF"/>
                 </a:solidFill>
@@ -26948,7 +26950,7 @@
                 <a:spcPts val="0"/>
               </a:spcAft>
               <a:buNone/>
-              <a:defRPr sz="1350" b="0">
+              <a:defRPr sz="1350">
                 <a:solidFill>
                   <a:srgbClr val="00E5FF"/>
                 </a:solidFill>
@@ -26978,7 +26980,7 @@
                 <a:spcPts val="0"/>
               </a:spcAft>
               <a:buNone/>
-              <a:defRPr sz="1350" b="0">
+              <a:defRPr sz="1350">
                 <a:solidFill>
                   <a:srgbClr val="00E5FF"/>
                 </a:solidFill>
@@ -27030,7 +27032,7 @@
                 <a:spcPts val="0"/>
               </a:spcAft>
               <a:buNone/>
-              <a:defRPr sz="1350" b="0">
+              <a:defRPr sz="1350">
                 <a:solidFill>
                   <a:srgbClr val="00E5FF"/>
                 </a:solidFill>
@@ -27048,67 +27050,7 @@
                 <a:ea typeface="Roboto Mono"/>
                 <a:cs typeface="Roboto Mono"/>
               </a:rPr>
-              <a:t># Re-enter the VM after reboot</a:t>
-            </a:r>
-          </a:p>
-          <a:p xmlns:a="http://schemas.openxmlformats.org/drawingml/2006/main">
-            <a:pPr marL="0" indent="0" algn="l">
-              <a:spcBef>
-                <a:spcPts val="0"/>
-              </a:spcBef>
-              <a:spcAft>
-                <a:spcPts val="0"/>
-              </a:spcAft>
-              <a:buNone/>
-              <a:defRPr sz="1350" b="0">
-                <a:solidFill>
-                  <a:srgbClr val="00E5FF"/>
-                </a:solidFill>
-                <a:latin typeface="Roboto Mono"/>
-                <a:ea typeface="Roboto Mono"/>
-                <a:cs typeface="Roboto Mono"/>
-              </a:defRPr>
-            </a:pPr>
-            <a:r>
-              <a:rPr sz="1350" b="0" i="0">
-                <a:solidFill>
-                  <a:srgbClr val="00E5FF"/>
-                </a:solidFill>
-                <a:latin typeface="Roboto Mono"/>
-                <a:ea typeface="Roboto Mono"/>
-                <a:cs typeface="Roboto Mono"/>
-              </a:rPr>
-              <a:t>cd ~/falco-libs-workshop</a:t>
-            </a:r>
-          </a:p>
-          <a:p xmlns:a="http://schemas.openxmlformats.org/drawingml/2006/main">
-            <a:pPr marL="0" indent="0" algn="l">
-              <a:spcBef>
-                <a:spcPts val="0"/>
-              </a:spcBef>
-              <a:spcAft>
-                <a:spcPts val="0"/>
-              </a:spcAft>
-              <a:buNone/>
-              <a:defRPr sz="1350" b="0">
-                <a:solidFill>
-                  <a:srgbClr val="00E5FF"/>
-                </a:solidFill>
-                <a:latin typeface="Roboto Mono"/>
-                <a:ea typeface="Roboto Mono"/>
-                <a:cs typeface="Roboto Mono"/>
-              </a:defRPr>
-            </a:pPr>
-            <a:r>
-              <a:rPr sz="1350" b="0" i="0">
-                <a:solidFill>
-                  <a:srgbClr val="00E5FF"/>
-                </a:solidFill>
-                <a:latin typeface="Roboto Mono"/>
-                <a:ea typeface="Roboto Mono"/>
-                <a:cs typeface="Roboto Mono"/>
-              </a:rPr>
-              <a:t>bash scripts/setup.sh</a:t>
+              <a:t># After reboot, rerun setup on your host</a:t>
             </a:r>
           </a:p>
         </p:txBody>
@@ -27758,7 +27700,7 @@
           <p:nvPr/>
         </p:nvPicPr>
         <p:blipFill rotWithShape="1">
-          <a:blip xmlns:r="http://schemas.openxmlformats.org/officeDocument/2006/relationships" xmlns:a="http://schemas.openxmlformats.org/drawingml/2006/main" r:embed="R0bd4c2ec647b410c">
+          <a:blip xmlns:r="http://schemas.openxmlformats.org/officeDocument/2006/relationships" xmlns:a="http://schemas.openxmlformats.org/drawingml/2006/main" r:embed="Ra5498fa332674325">
             <a:alphaModFix/>
           </a:blip>
           <a:srcRect xmlns:a="http://schemas.openxmlformats.org/drawingml/2006/main" l="0" t="0" r="0" b="0"/>
@@ -27786,7 +27728,7 @@
           <p:nvPr/>
         </p:nvPicPr>
         <p:blipFill rotWithShape="1">
-          <a:blip xmlns:r="http://schemas.openxmlformats.org/officeDocument/2006/relationships" xmlns:a="http://schemas.openxmlformats.org/drawingml/2006/main" r:embed="R0bd4c2ec647b410c">
+          <a:blip xmlns:r="http://schemas.openxmlformats.org/officeDocument/2006/relationships" xmlns:a="http://schemas.openxmlformats.org/drawingml/2006/main" r:embed="Ra5498fa332674325">
             <a:alphaModFix/>
           </a:blip>
           <a:srcRect xmlns:a="http://schemas.openxmlformats.org/drawingml/2006/main" l="0" t="0" r="0" b="0"/>
@@ -27814,7 +27756,7 @@
           <p:nvPr/>
         </p:nvPicPr>
         <p:blipFill rotWithShape="1">
-          <a:blip xmlns:r="http://schemas.openxmlformats.org/officeDocument/2006/relationships" xmlns:a="http://schemas.openxmlformats.org/drawingml/2006/main" r:embed="R0bd4c2ec647b410c">
+          <a:blip xmlns:r="http://schemas.openxmlformats.org/officeDocument/2006/relationships" xmlns:a="http://schemas.openxmlformats.org/drawingml/2006/main" r:embed="Ra5498fa332674325">
             <a:alphaModFix/>
           </a:blip>
           <a:srcRect xmlns:a="http://schemas.openxmlformats.org/drawingml/2006/main" l="0" t="0" r="0" b="0"/>
@@ -27842,7 +27784,7 @@
           <p:nvPr/>
         </p:nvPicPr>
         <p:blipFill rotWithShape="1">
-          <a:blip xmlns:r="http://schemas.openxmlformats.org/officeDocument/2006/relationships" xmlns:a="http://schemas.openxmlformats.org/drawingml/2006/main" r:embed="R0bd4c2ec647b410c">
+          <a:blip xmlns:r="http://schemas.openxmlformats.org/officeDocument/2006/relationships" xmlns:a="http://schemas.openxmlformats.org/drawingml/2006/main" r:embed="Ra5498fa332674325">
             <a:alphaModFix/>
           </a:blip>
           <a:srcRect xmlns:a="http://schemas.openxmlformats.org/drawingml/2006/main" l="0" t="0" r="0" b="0"/>
@@ -29865,7 +29807,7 @@
           <p:nvPr/>
         </p:nvPicPr>
         <p:blipFill rotWithShape="1">
-          <a:blip xmlns:r="http://schemas.openxmlformats.org/officeDocument/2006/relationships" xmlns:a="http://schemas.openxmlformats.org/drawingml/2006/main" r:embed="Rd9a6c98932174222">
+          <a:blip xmlns:r="http://schemas.openxmlformats.org/officeDocument/2006/relationships" xmlns:a="http://schemas.openxmlformats.org/drawingml/2006/main" r:embed="R3616de12b6814957">
             <a:alphaModFix/>
           </a:blip>
           <a:srcRect xmlns:a="http://schemas.openxmlformats.org/drawingml/2006/main" l="0" t="0" r="0" b="0"/>
@@ -29893,7 +29835,7 @@
           <p:nvPr/>
         </p:nvPicPr>
         <p:blipFill rotWithShape="1">
-          <a:blip xmlns:r="http://schemas.openxmlformats.org/officeDocument/2006/relationships" xmlns:a="http://schemas.openxmlformats.org/drawingml/2006/main" r:embed="Rd9a6c98932174222">
+          <a:blip xmlns:r="http://schemas.openxmlformats.org/officeDocument/2006/relationships" xmlns:a="http://schemas.openxmlformats.org/drawingml/2006/main" r:embed="R3616de12b6814957">
             <a:alphaModFix/>
           </a:blip>
           <a:srcRect xmlns:a="http://schemas.openxmlformats.org/drawingml/2006/main" l="0" t="0" r="0" b="0"/>
@@ -29921,7 +29863,7 @@
           <p:nvPr/>
         </p:nvPicPr>
         <p:blipFill rotWithShape="1">
-          <a:blip xmlns:r="http://schemas.openxmlformats.org/officeDocument/2006/relationships" xmlns:a="http://schemas.openxmlformats.org/drawingml/2006/main" r:embed="Rd9a6c98932174222">
+          <a:blip xmlns:r="http://schemas.openxmlformats.org/officeDocument/2006/relationships" xmlns:a="http://schemas.openxmlformats.org/drawingml/2006/main" r:embed="R3616de12b6814957">
             <a:alphaModFix/>
           </a:blip>
           <a:srcRect xmlns:a="http://schemas.openxmlformats.org/drawingml/2006/main" l="0" t="0" r="0" b="0"/>
@@ -29949,7 +29891,7 @@
           <p:nvPr/>
         </p:nvPicPr>
         <p:blipFill rotWithShape="1">
-          <a:blip xmlns:r="http://schemas.openxmlformats.org/officeDocument/2006/relationships" xmlns:a="http://schemas.openxmlformats.org/drawingml/2006/main" r:embed="Rd9a6c98932174222">
+          <a:blip xmlns:r="http://schemas.openxmlformats.org/officeDocument/2006/relationships" xmlns:a="http://schemas.openxmlformats.org/drawingml/2006/main" r:embed="R3616de12b6814957">
             <a:alphaModFix/>
           </a:blip>
           <a:srcRect xmlns:a="http://schemas.openxmlformats.org/drawingml/2006/main" l="0" t="0" r="0" b="0"/>
@@ -30942,7 +30884,18 @@
                 <a:ea typeface="Roboto Mono"/>
                 <a:cs typeface="Roboto Mono"/>
               </a:rPr>
-              <a:t>bash scripts/setup.sh</a:t>
+              <a:t>bash </a:t>
+            </a:r>
+            <a:r>
+              <a:rPr sz="1500" b="0" i="0">
+                <a:solidFill>
+                  <a:srgbClr val="00E5FF"/>
+                </a:solidFill>
+                <a:latin typeface="Roboto Mono"/>
+                <a:ea typeface="Roboto Mono"/>
+                <a:cs typeface="Roboto Mono"/>
+              </a:rPr>
+              <a:t>scripts/setup-mac.sh</a:t>
             </a:r>
           </a:p>
           <a:p xmlns:a="http://schemas.openxmlformats.org/drawingml/2006/main">
@@ -31024,7 +30977,18 @@
                 <a:ea typeface="Roboto Mono"/>
                 <a:cs typeface="Roboto Mono"/>
               </a:rPr>
-              <a:t>powershell -ExecutionPolicy Bypass -File scripts/setup.ps1</a:t>
+              <a:t>powershell -ExecutionPolicy Bypass -File </a:t>
+            </a:r>
+            <a:r>
+              <a:rPr sz="1500" b="0" i="0">
+                <a:solidFill>
+                  <a:srgbClr val="00E5FF"/>
+                </a:solidFill>
+                <a:latin typeface="Roboto Mono"/>
+                <a:ea typeface="Roboto Mono"/>
+                <a:cs typeface="Roboto Mono"/>
+              </a:rPr>
+              <a:t>scripts/setup-windows.ps1</a:t>
             </a:r>
           </a:p>
         </p:txBody>
@@ -31674,7 +31638,7 @@
           <p:nvPr/>
         </p:nvPicPr>
         <p:blipFill rotWithShape="1">
-          <a:blip xmlns:r="http://schemas.openxmlformats.org/officeDocument/2006/relationships" xmlns:a="http://schemas.openxmlformats.org/drawingml/2006/main" r:embed="R7cc477393cc94056">
+          <a:blip xmlns:r="http://schemas.openxmlformats.org/officeDocument/2006/relationships" xmlns:a="http://schemas.openxmlformats.org/drawingml/2006/main" r:embed="R63559234f162473b">
             <a:alphaModFix/>
           </a:blip>
           <a:srcRect xmlns:a="http://schemas.openxmlformats.org/drawingml/2006/main" l="0" t="0" r="0" b="0"/>
@@ -31702,7 +31666,7 @@
           <p:nvPr/>
         </p:nvPicPr>
         <p:blipFill rotWithShape="1">
-          <a:blip xmlns:r="http://schemas.openxmlformats.org/officeDocument/2006/relationships" xmlns:a="http://schemas.openxmlformats.org/drawingml/2006/main" r:embed="R7cc477393cc94056">
+          <a:blip xmlns:r="http://schemas.openxmlformats.org/officeDocument/2006/relationships" xmlns:a="http://schemas.openxmlformats.org/drawingml/2006/main" r:embed="R63559234f162473b">
             <a:alphaModFix/>
           </a:blip>
           <a:srcRect xmlns:a="http://schemas.openxmlformats.org/drawingml/2006/main" l="0" t="0" r="0" b="0"/>
@@ -31730,7 +31694,7 @@
           <p:nvPr/>
         </p:nvPicPr>
         <p:blipFill rotWithShape="1">
-          <a:blip xmlns:r="http://schemas.openxmlformats.org/officeDocument/2006/relationships" xmlns:a="http://schemas.openxmlformats.org/drawingml/2006/main" r:embed="R7cc477393cc94056">
+          <a:blip xmlns:r="http://schemas.openxmlformats.org/officeDocument/2006/relationships" xmlns:a="http://schemas.openxmlformats.org/drawingml/2006/main" r:embed="R63559234f162473b">
             <a:alphaModFix/>
           </a:blip>
           <a:srcRect xmlns:a="http://schemas.openxmlformats.org/drawingml/2006/main" l="0" t="0" r="0" b="0"/>
@@ -31758,7 +31722,7 @@
           <p:nvPr/>
         </p:nvPicPr>
         <p:blipFill rotWithShape="1">
-          <a:blip xmlns:r="http://schemas.openxmlformats.org/officeDocument/2006/relationships" xmlns:a="http://schemas.openxmlformats.org/drawingml/2006/main" r:embed="R7cc477393cc94056">
+          <a:blip xmlns:r="http://schemas.openxmlformats.org/officeDocument/2006/relationships" xmlns:a="http://schemas.openxmlformats.org/drawingml/2006/main" r:embed="R63559234f162473b">
             <a:alphaModFix/>
           </a:blip>
           <a:srcRect xmlns:a="http://schemas.openxmlformats.org/drawingml/2006/main" l="0" t="0" r="0" b="0"/>
@@ -33751,7 +33715,7 @@
           <p:nvPr/>
         </p:nvPicPr>
         <p:blipFill rotWithShape="1">
-          <a:blip xmlns:r="http://schemas.openxmlformats.org/officeDocument/2006/relationships" xmlns:a="http://schemas.openxmlformats.org/drawingml/2006/main" r:embed="R15c741dd241945cd">
+          <a:blip xmlns:r="http://schemas.openxmlformats.org/officeDocument/2006/relationships" xmlns:a="http://schemas.openxmlformats.org/drawingml/2006/main" r:embed="R7b97e23ba81c442e">
             <a:alphaModFix/>
           </a:blip>
           <a:srcRect xmlns:a="http://schemas.openxmlformats.org/drawingml/2006/main" l="0" t="0" r="0" b="0"/>
@@ -33779,7 +33743,7 @@
           <p:nvPr/>
         </p:nvPicPr>
         <p:blipFill rotWithShape="1">
-          <a:blip xmlns:r="http://schemas.openxmlformats.org/officeDocument/2006/relationships" xmlns:a="http://schemas.openxmlformats.org/drawingml/2006/main" r:embed="R15c741dd241945cd">
+          <a:blip xmlns:r="http://schemas.openxmlformats.org/officeDocument/2006/relationships" xmlns:a="http://schemas.openxmlformats.org/drawingml/2006/main" r:embed="R7b97e23ba81c442e">
             <a:alphaModFix/>
           </a:blip>
           <a:srcRect xmlns:a="http://schemas.openxmlformats.org/drawingml/2006/main" l="0" t="0" r="0" b="0"/>
@@ -33807,7 +33771,7 @@
           <p:nvPr/>
         </p:nvPicPr>
         <p:blipFill rotWithShape="1">
-          <a:blip xmlns:r="http://schemas.openxmlformats.org/officeDocument/2006/relationships" xmlns:a="http://schemas.openxmlformats.org/drawingml/2006/main" r:embed="R15c741dd241945cd">
+          <a:blip xmlns:r="http://schemas.openxmlformats.org/officeDocument/2006/relationships" xmlns:a="http://schemas.openxmlformats.org/drawingml/2006/main" r:embed="R7b97e23ba81c442e">
             <a:alphaModFix/>
           </a:blip>
           <a:srcRect xmlns:a="http://schemas.openxmlformats.org/drawingml/2006/main" l="0" t="0" r="0" b="0"/>
@@ -33835,7 +33799,7 @@
           <p:nvPr/>
         </p:nvPicPr>
         <p:blipFill rotWithShape="1">
-          <a:blip xmlns:r="http://schemas.openxmlformats.org/officeDocument/2006/relationships" xmlns:a="http://schemas.openxmlformats.org/drawingml/2006/main" r:embed="R15c741dd241945cd">
+          <a:blip xmlns:r="http://schemas.openxmlformats.org/officeDocument/2006/relationships" xmlns:a="http://schemas.openxmlformats.org/drawingml/2006/main" r:embed="R7b97e23ba81c442e">
             <a:alphaModFix/>
           </a:blip>
           <a:srcRect xmlns:a="http://schemas.openxmlformats.org/drawingml/2006/main" l="0" t="0" r="0" b="0"/>
@@ -35934,7 +35898,7 @@
           <p:nvPr/>
         </p:nvPicPr>
         <p:blipFill rotWithShape="1">
-          <a:blip xmlns:r="http://schemas.openxmlformats.org/officeDocument/2006/relationships" xmlns:a="http://schemas.openxmlformats.org/drawingml/2006/main" r:embed="Rfc5dda1da739400e">
+          <a:blip xmlns:r="http://schemas.openxmlformats.org/officeDocument/2006/relationships" xmlns:a="http://schemas.openxmlformats.org/drawingml/2006/main" r:embed="R4ec42d01480941c0">
             <a:alphaModFix/>
           </a:blip>
           <a:srcRect xmlns:a="http://schemas.openxmlformats.org/drawingml/2006/main" l="0" t="0" r="0" b="0"/>
@@ -35962,7 +35926,7 @@
           <p:nvPr/>
         </p:nvPicPr>
         <p:blipFill rotWithShape="1">
-          <a:blip xmlns:r="http://schemas.openxmlformats.org/officeDocument/2006/relationships" xmlns:a="http://schemas.openxmlformats.org/drawingml/2006/main" r:embed="Rfc5dda1da739400e">
+          <a:blip xmlns:r="http://schemas.openxmlformats.org/officeDocument/2006/relationships" xmlns:a="http://schemas.openxmlformats.org/drawingml/2006/main" r:embed="R4ec42d01480941c0">
             <a:alphaModFix/>
           </a:blip>
           <a:srcRect xmlns:a="http://schemas.openxmlformats.org/drawingml/2006/main" l="0" t="0" r="0" b="0"/>
@@ -35990,7 +35954,7 @@
           <p:nvPr/>
         </p:nvPicPr>
         <p:blipFill rotWithShape="1">
-          <a:blip xmlns:r="http://schemas.openxmlformats.org/officeDocument/2006/relationships" xmlns:a="http://schemas.openxmlformats.org/drawingml/2006/main" r:embed="Rfc5dda1da739400e">
+          <a:blip xmlns:r="http://schemas.openxmlformats.org/officeDocument/2006/relationships" xmlns:a="http://schemas.openxmlformats.org/drawingml/2006/main" r:embed="R4ec42d01480941c0">
             <a:alphaModFix/>
           </a:blip>
           <a:srcRect xmlns:a="http://schemas.openxmlformats.org/drawingml/2006/main" l="0" t="0" r="0" b="0"/>
@@ -36018,7 +35982,7 @@
           <p:nvPr/>
         </p:nvPicPr>
         <p:blipFill rotWithShape="1">
-          <a:blip xmlns:r="http://schemas.openxmlformats.org/officeDocument/2006/relationships" xmlns:a="http://schemas.openxmlformats.org/drawingml/2006/main" r:embed="Rfc5dda1da739400e">
+          <a:blip xmlns:r="http://schemas.openxmlformats.org/officeDocument/2006/relationships" xmlns:a="http://schemas.openxmlformats.org/drawingml/2006/main" r:embed="R4ec42d01480941c0">
             <a:alphaModFix/>
           </a:blip>
           <a:srcRect xmlns:a="http://schemas.openxmlformats.org/drawingml/2006/main" l="0" t="0" r="0" b="0"/>
@@ -38123,7 +38087,7 @@
           <p:nvPr/>
         </p:nvPicPr>
         <p:blipFill rotWithShape="1">
-          <a:blip xmlns:r="http://schemas.openxmlformats.org/officeDocument/2006/relationships" xmlns:a="http://schemas.openxmlformats.org/drawingml/2006/main" r:embed="R1926e78c12ab463f">
+          <a:blip xmlns:r="http://schemas.openxmlformats.org/officeDocument/2006/relationships" xmlns:a="http://schemas.openxmlformats.org/drawingml/2006/main" r:embed="Ra7c84a4de2a249ee">
             <a:alphaModFix/>
           </a:blip>
           <a:srcRect xmlns:a="http://schemas.openxmlformats.org/drawingml/2006/main" l="0" t="0" r="0" b="0"/>
@@ -38151,7 +38115,7 @@
           <p:nvPr/>
         </p:nvPicPr>
         <p:blipFill rotWithShape="1">
-          <a:blip xmlns:r="http://schemas.openxmlformats.org/officeDocument/2006/relationships" xmlns:a="http://schemas.openxmlformats.org/drawingml/2006/main" r:embed="R1926e78c12ab463f">
+          <a:blip xmlns:r="http://schemas.openxmlformats.org/officeDocument/2006/relationships" xmlns:a="http://schemas.openxmlformats.org/drawingml/2006/main" r:embed="Ra7c84a4de2a249ee">
             <a:alphaModFix/>
           </a:blip>
           <a:srcRect xmlns:a="http://schemas.openxmlformats.org/drawingml/2006/main" l="0" t="0" r="0" b="0"/>
@@ -38179,7 +38143,7 @@
           <p:nvPr/>
         </p:nvPicPr>
         <p:blipFill rotWithShape="1">
-          <a:blip xmlns:r="http://schemas.openxmlformats.org/officeDocument/2006/relationships" xmlns:a="http://schemas.openxmlformats.org/drawingml/2006/main" r:embed="R1926e78c12ab463f">
+          <a:blip xmlns:r="http://schemas.openxmlformats.org/officeDocument/2006/relationships" xmlns:a="http://schemas.openxmlformats.org/drawingml/2006/main" r:embed="Ra7c84a4de2a249ee">
             <a:alphaModFix/>
           </a:blip>
           <a:srcRect xmlns:a="http://schemas.openxmlformats.org/drawingml/2006/main" l="0" t="0" r="0" b="0"/>
@@ -38207,7 +38171,7 @@
           <p:nvPr/>
         </p:nvPicPr>
         <p:blipFill rotWithShape="1">
-          <a:blip xmlns:r="http://schemas.openxmlformats.org/officeDocument/2006/relationships" xmlns:a="http://schemas.openxmlformats.org/drawingml/2006/main" r:embed="R1926e78c12ab463f">
+          <a:blip xmlns:r="http://schemas.openxmlformats.org/officeDocument/2006/relationships" xmlns:a="http://schemas.openxmlformats.org/drawingml/2006/main" r:embed="Ra7c84a4de2a249ee">
             <a:alphaModFix/>
           </a:blip>
           <a:srcRect xmlns:a="http://schemas.openxmlformats.org/drawingml/2006/main" l="0" t="0" r="0" b="0"/>
@@ -40096,7 +40060,7 @@
           <p:nvPr/>
         </p:nvPicPr>
         <p:blipFill rotWithShape="1">
-          <a:blip xmlns:r="http://schemas.openxmlformats.org/officeDocument/2006/relationships" xmlns:a="http://schemas.openxmlformats.org/drawingml/2006/main" r:embed="R678734f102474f6e">
+          <a:blip xmlns:r="http://schemas.openxmlformats.org/officeDocument/2006/relationships" xmlns:a="http://schemas.openxmlformats.org/drawingml/2006/main" r:embed="Rc5383f88bcf24fd3">
             <a:alphaModFix/>
           </a:blip>
           <a:srcRect xmlns:a="http://schemas.openxmlformats.org/drawingml/2006/main" l="0" t="0" r="0" b="0"/>
@@ -40124,7 +40088,7 @@
           <p:nvPr/>
         </p:nvPicPr>
         <p:blipFill rotWithShape="1">
-          <a:blip xmlns:r="http://schemas.openxmlformats.org/officeDocument/2006/relationships" xmlns:a="http://schemas.openxmlformats.org/drawingml/2006/main" r:embed="R678734f102474f6e">
+          <a:blip xmlns:r="http://schemas.openxmlformats.org/officeDocument/2006/relationships" xmlns:a="http://schemas.openxmlformats.org/drawingml/2006/main" r:embed="Rc5383f88bcf24fd3">
             <a:alphaModFix/>
           </a:blip>
           <a:srcRect xmlns:a="http://schemas.openxmlformats.org/drawingml/2006/main" l="0" t="0" r="0" b="0"/>
@@ -40152,7 +40116,7 @@
           <p:nvPr/>
         </p:nvPicPr>
         <p:blipFill rotWithShape="1">
-          <a:blip xmlns:r="http://schemas.openxmlformats.org/officeDocument/2006/relationships" xmlns:a="http://schemas.openxmlformats.org/drawingml/2006/main" r:embed="R678734f102474f6e">
+          <a:blip xmlns:r="http://schemas.openxmlformats.org/officeDocument/2006/relationships" xmlns:a="http://schemas.openxmlformats.org/drawingml/2006/main" r:embed="Rc5383f88bcf24fd3">
             <a:alphaModFix/>
           </a:blip>
           <a:srcRect xmlns:a="http://schemas.openxmlformats.org/drawingml/2006/main" l="0" t="0" r="0" b="0"/>
@@ -40180,7 +40144,7 @@
           <p:nvPr/>
         </p:nvPicPr>
         <p:blipFill rotWithShape="1">
-          <a:blip xmlns:r="http://schemas.openxmlformats.org/officeDocument/2006/relationships" xmlns:a="http://schemas.openxmlformats.org/drawingml/2006/main" r:embed="R678734f102474f6e">
+          <a:blip xmlns:r="http://schemas.openxmlformats.org/officeDocument/2006/relationships" xmlns:a="http://schemas.openxmlformats.org/drawingml/2006/main" r:embed="Rc5383f88bcf24fd3">
             <a:alphaModFix/>
           </a:blip>
           <a:srcRect xmlns:a="http://schemas.openxmlformats.org/drawingml/2006/main" l="0" t="0" r="0" b="0"/>
@@ -42255,7 +42219,7 @@
           <p:nvPr/>
         </p:nvPicPr>
         <p:blipFill rotWithShape="1">
-          <a:blip xmlns:r="http://schemas.openxmlformats.org/officeDocument/2006/relationships" xmlns:a="http://schemas.openxmlformats.org/drawingml/2006/main" r:embed="Rc2853ddb7d32405a">
+          <a:blip xmlns:r="http://schemas.openxmlformats.org/officeDocument/2006/relationships" xmlns:a="http://schemas.openxmlformats.org/drawingml/2006/main" r:embed="Rcda88d649f224303">
             <a:alphaModFix/>
           </a:blip>
           <a:srcRect xmlns:a="http://schemas.openxmlformats.org/drawingml/2006/main" l="0" t="0" r="0" b="0"/>
@@ -42283,7 +42247,7 @@
           <p:nvPr/>
         </p:nvPicPr>
         <p:blipFill rotWithShape="1">
-          <a:blip xmlns:r="http://schemas.openxmlformats.org/officeDocument/2006/relationships" xmlns:a="http://schemas.openxmlformats.org/drawingml/2006/main" r:embed="Rc2853ddb7d32405a">
+          <a:blip xmlns:r="http://schemas.openxmlformats.org/officeDocument/2006/relationships" xmlns:a="http://schemas.openxmlformats.org/drawingml/2006/main" r:embed="Rcda88d649f224303">
             <a:alphaModFix/>
           </a:blip>
           <a:srcRect xmlns:a="http://schemas.openxmlformats.org/drawingml/2006/main" l="0" t="0" r="0" b="0"/>
@@ -42311,7 +42275,7 @@
           <p:nvPr/>
         </p:nvPicPr>
         <p:blipFill rotWithShape="1">
-          <a:blip xmlns:r="http://schemas.openxmlformats.org/officeDocument/2006/relationships" xmlns:a="http://schemas.openxmlformats.org/drawingml/2006/main" r:embed="Rc2853ddb7d32405a">
+          <a:blip xmlns:r="http://schemas.openxmlformats.org/officeDocument/2006/relationships" xmlns:a="http://schemas.openxmlformats.org/drawingml/2006/main" r:embed="Rcda88d649f224303">
             <a:alphaModFix/>
           </a:blip>
           <a:srcRect xmlns:a="http://schemas.openxmlformats.org/drawingml/2006/main" l="0" t="0" r="0" b="0"/>
@@ -42339,7 +42303,7 @@
           <p:nvPr/>
         </p:nvPicPr>
         <p:blipFill rotWithShape="1">
-          <a:blip xmlns:r="http://schemas.openxmlformats.org/officeDocument/2006/relationships" xmlns:a="http://schemas.openxmlformats.org/drawingml/2006/main" r:embed="Rc2853ddb7d32405a">
+          <a:blip xmlns:r="http://schemas.openxmlformats.org/officeDocument/2006/relationships" xmlns:a="http://schemas.openxmlformats.org/drawingml/2006/main" r:embed="Rcda88d649f224303">
             <a:alphaModFix/>
           </a:blip>
           <a:srcRect xmlns:a="http://schemas.openxmlformats.org/drawingml/2006/main" l="0" t="0" r="0" b="0"/>
@@ -44288,7 +44252,7 @@
           <p:nvPr/>
         </p:nvPicPr>
         <p:blipFill rotWithShape="1">
-          <a:blip xmlns:r="http://schemas.openxmlformats.org/officeDocument/2006/relationships" xmlns:a="http://schemas.openxmlformats.org/drawingml/2006/main" r:embed="Rf0b04cfe45984542">
+          <a:blip xmlns:r="http://schemas.openxmlformats.org/officeDocument/2006/relationships" xmlns:a="http://schemas.openxmlformats.org/drawingml/2006/main" r:embed="Radbffef0bcf9409d">
             <a:alphaModFix/>
           </a:blip>
           <a:srcRect xmlns:a="http://schemas.openxmlformats.org/drawingml/2006/main" l="0" t="0" r="0" b="0"/>
@@ -44316,7 +44280,7 @@
           <p:nvPr/>
         </p:nvPicPr>
         <p:blipFill rotWithShape="1">
-          <a:blip xmlns:r="http://schemas.openxmlformats.org/officeDocument/2006/relationships" xmlns:a="http://schemas.openxmlformats.org/drawingml/2006/main" r:embed="Rf0b04cfe45984542">
+          <a:blip xmlns:r="http://schemas.openxmlformats.org/officeDocument/2006/relationships" xmlns:a="http://schemas.openxmlformats.org/drawingml/2006/main" r:embed="Radbffef0bcf9409d">
             <a:alphaModFix/>
           </a:blip>
           <a:srcRect xmlns:a="http://schemas.openxmlformats.org/drawingml/2006/main" l="0" t="0" r="0" b="0"/>
@@ -44344,7 +44308,7 @@
           <p:nvPr/>
         </p:nvPicPr>
         <p:blipFill rotWithShape="1">
-          <a:blip xmlns:r="http://schemas.openxmlformats.org/officeDocument/2006/relationships" xmlns:a="http://schemas.openxmlformats.org/drawingml/2006/main" r:embed="Rf0b04cfe45984542">
+          <a:blip xmlns:r="http://schemas.openxmlformats.org/officeDocument/2006/relationships" xmlns:a="http://schemas.openxmlformats.org/drawingml/2006/main" r:embed="Radbffef0bcf9409d">
             <a:alphaModFix/>
           </a:blip>
           <a:srcRect xmlns:a="http://schemas.openxmlformats.org/drawingml/2006/main" l="0" t="0" r="0" b="0"/>
@@ -44372,7 +44336,7 @@
           <p:nvPr/>
         </p:nvPicPr>
         <p:blipFill rotWithShape="1">
-          <a:blip xmlns:r="http://schemas.openxmlformats.org/officeDocument/2006/relationships" xmlns:a="http://schemas.openxmlformats.org/drawingml/2006/main" r:embed="Rf0b04cfe45984542">
+          <a:blip xmlns:r="http://schemas.openxmlformats.org/officeDocument/2006/relationships" xmlns:a="http://schemas.openxmlformats.org/drawingml/2006/main" r:embed="Radbffef0bcf9409d">
             <a:alphaModFix/>
           </a:blip>
           <a:srcRect xmlns:a="http://schemas.openxmlformats.org/drawingml/2006/main" l="0" t="0" r="0" b="0"/>
@@ -46395,7 +46359,7 @@
           <p:nvPr/>
         </p:nvPicPr>
         <p:blipFill rotWithShape="1">
-          <a:blip xmlns:r="http://schemas.openxmlformats.org/officeDocument/2006/relationships" xmlns:a="http://schemas.openxmlformats.org/drawingml/2006/main" r:embed="Re3e4acb822ad4c13">
+          <a:blip xmlns:r="http://schemas.openxmlformats.org/officeDocument/2006/relationships" xmlns:a="http://schemas.openxmlformats.org/drawingml/2006/main" r:embed="Re734f0a1d0ee492d">
             <a:alphaModFix/>
           </a:blip>
           <a:srcRect xmlns:a="http://schemas.openxmlformats.org/drawingml/2006/main" l="0" t="0" r="0" b="0"/>
@@ -46423,7 +46387,7 @@
           <p:nvPr/>
         </p:nvPicPr>
         <p:blipFill rotWithShape="1">
-          <a:blip xmlns:r="http://schemas.openxmlformats.org/officeDocument/2006/relationships" xmlns:a="http://schemas.openxmlformats.org/drawingml/2006/main" r:embed="Re3e4acb822ad4c13">
+          <a:blip xmlns:r="http://schemas.openxmlformats.org/officeDocument/2006/relationships" xmlns:a="http://schemas.openxmlformats.org/drawingml/2006/main" r:embed="Re734f0a1d0ee492d">
             <a:alphaModFix/>
           </a:blip>
           <a:srcRect xmlns:a="http://schemas.openxmlformats.org/drawingml/2006/main" l="0" t="0" r="0" b="0"/>
@@ -46451,7 +46415,7 @@
           <p:nvPr/>
         </p:nvPicPr>
         <p:blipFill rotWithShape="1">
-          <a:blip xmlns:r="http://schemas.openxmlformats.org/officeDocument/2006/relationships" xmlns:a="http://schemas.openxmlformats.org/drawingml/2006/main" r:embed="Re3e4acb822ad4c13">
+          <a:blip xmlns:r="http://schemas.openxmlformats.org/officeDocument/2006/relationships" xmlns:a="http://schemas.openxmlformats.org/drawingml/2006/main" r:embed="Re734f0a1d0ee492d">
             <a:alphaModFix/>
           </a:blip>
           <a:srcRect xmlns:a="http://schemas.openxmlformats.org/drawingml/2006/main" l="0" t="0" r="0" b="0"/>
@@ -46479,7 +46443,7 @@
           <p:nvPr/>
         </p:nvPicPr>
         <p:blipFill rotWithShape="1">
-          <a:blip xmlns:r="http://schemas.openxmlformats.org/officeDocument/2006/relationships" xmlns:a="http://schemas.openxmlformats.org/drawingml/2006/main" r:embed="Re3e4acb822ad4c13">
+          <a:blip xmlns:r="http://schemas.openxmlformats.org/officeDocument/2006/relationships" xmlns:a="http://schemas.openxmlformats.org/drawingml/2006/main" r:embed="Re734f0a1d0ee492d">
             <a:alphaModFix/>
           </a:blip>
           <a:srcRect xmlns:a="http://schemas.openxmlformats.org/drawingml/2006/main" l="0" t="0" r="0" b="0"/>
@@ -48450,7 +48414,7 @@
           <p:nvPr/>
         </p:nvPicPr>
         <p:blipFill rotWithShape="1">
-          <a:blip xmlns:r="http://schemas.openxmlformats.org/officeDocument/2006/relationships" xmlns:a="http://schemas.openxmlformats.org/drawingml/2006/main" r:embed="Rd84c4e9fa2d547d7">
+          <a:blip xmlns:r="http://schemas.openxmlformats.org/officeDocument/2006/relationships" xmlns:a="http://schemas.openxmlformats.org/drawingml/2006/main" r:embed="Rb307fd05f0de4575">
             <a:alphaModFix/>
           </a:blip>
           <a:srcRect xmlns:a="http://schemas.openxmlformats.org/drawingml/2006/main" l="0" t="0" r="0" b="0"/>
@@ -48478,7 +48442,7 @@
           <p:nvPr/>
         </p:nvPicPr>
         <p:blipFill rotWithShape="1">
-          <a:blip xmlns:r="http://schemas.openxmlformats.org/officeDocument/2006/relationships" xmlns:a="http://schemas.openxmlformats.org/drawingml/2006/main" r:embed="Rd84c4e9fa2d547d7">
+          <a:blip xmlns:r="http://schemas.openxmlformats.org/officeDocument/2006/relationships" xmlns:a="http://schemas.openxmlformats.org/drawingml/2006/main" r:embed="Rb307fd05f0de4575">
             <a:alphaModFix/>
           </a:blip>
           <a:srcRect xmlns:a="http://schemas.openxmlformats.org/drawingml/2006/main" l="0" t="0" r="0" b="0"/>
@@ -48506,7 +48470,7 @@
           <p:nvPr/>
         </p:nvPicPr>
         <p:blipFill rotWithShape="1">
-          <a:blip xmlns:r="http://schemas.openxmlformats.org/officeDocument/2006/relationships" xmlns:a="http://schemas.openxmlformats.org/drawingml/2006/main" r:embed="Rd84c4e9fa2d547d7">
+          <a:blip xmlns:r="http://schemas.openxmlformats.org/officeDocument/2006/relationships" xmlns:a="http://schemas.openxmlformats.org/drawingml/2006/main" r:embed="Rb307fd05f0de4575">
             <a:alphaModFix/>
           </a:blip>
           <a:srcRect xmlns:a="http://schemas.openxmlformats.org/drawingml/2006/main" l="0" t="0" r="0" b="0"/>
@@ -48534,7 +48498,7 @@
           <p:nvPr/>
         </p:nvPicPr>
         <p:blipFill rotWithShape="1">
-          <a:blip xmlns:r="http://schemas.openxmlformats.org/officeDocument/2006/relationships" xmlns:a="http://schemas.openxmlformats.org/drawingml/2006/main" r:embed="Rd84c4e9fa2d547d7">
+          <a:blip xmlns:r="http://schemas.openxmlformats.org/officeDocument/2006/relationships" xmlns:a="http://schemas.openxmlformats.org/drawingml/2006/main" r:embed="Rb307fd05f0de4575">
             <a:alphaModFix/>
           </a:blip>
           <a:srcRect xmlns:a="http://schemas.openxmlformats.org/drawingml/2006/main" l="0" t="0" r="0" b="0"/>

</xml_diff>

<commit_message>
Replace manual editing instructions with step commands
</commit_message>
<xml_diff>
--- a/presentation/falco-libs-intro.pptx
+++ b/presentation/falco-libs-intro.pptx
@@ -2,76 +2,76 @@
 <file path=ppt/presentation.xml><?xml version="1.0" encoding="utf-8"?>
 <p:presentation xmlns:p="http://schemas.openxmlformats.org/presentationml/2006/main" embedTrueTypeFonts="1" saveSubsetFonts="0">
   <p:sldMasterIdLst>
-    <p:sldMasterId xmlns:r="http://schemas.openxmlformats.org/officeDocument/2006/relationships" id="2147483648" r:id="R3ffab56b91e34795"/>
-    <p:sldMasterId xmlns:r="http://schemas.openxmlformats.org/officeDocument/2006/relationships" id="2147483661" r:id="R6adbee609ad04b35"/>
+    <p:sldMasterId xmlns:r="http://schemas.openxmlformats.org/officeDocument/2006/relationships" id="2147483648" r:id="R30544e4e025b4228"/>
+    <p:sldMasterId xmlns:r="http://schemas.openxmlformats.org/officeDocument/2006/relationships" id="2147483661" r:id="R7d6f5434dcf2429a"/>
   </p:sldMasterIdLst>
   <p:notesMasterIdLst>
-    <p:notesMasterId xmlns:r="http://schemas.openxmlformats.org/officeDocument/2006/relationships" r:id="R9c7131dd8ec84a93"/>
+    <p:notesMasterId xmlns:r="http://schemas.openxmlformats.org/officeDocument/2006/relationships" r:id="Re51ceba7e6c8434e"/>
   </p:notesMasterIdLst>
   <p:sldIdLst>
-    <p:sldId xmlns:r="http://schemas.openxmlformats.org/officeDocument/2006/relationships" id="256" r:id="R8128cdd8eba94dcd"/>
-    <p:sldId xmlns:r="http://schemas.openxmlformats.org/officeDocument/2006/relationships" id="257" r:id="R57f25c63a8474d17"/>
-    <p:sldId xmlns:r="http://schemas.openxmlformats.org/officeDocument/2006/relationships" id="258" r:id="R5bc5a39e447d4158"/>
-    <p:sldId xmlns:r="http://schemas.openxmlformats.org/officeDocument/2006/relationships" id="259" r:id="R08695ae390b54ef9"/>
-    <p:sldId xmlns:r="http://schemas.openxmlformats.org/officeDocument/2006/relationships" id="260" r:id="Rc805662d7f05470a"/>
-    <p:sldId xmlns:r="http://schemas.openxmlformats.org/officeDocument/2006/relationships" id="261" r:id="Rc76442566bd14975"/>
-    <p:sldId xmlns:r="http://schemas.openxmlformats.org/officeDocument/2006/relationships" id="262" r:id="R4acbbceafa9b4415"/>
-    <p:sldId xmlns:r="http://schemas.openxmlformats.org/officeDocument/2006/relationships" id="263" r:id="R604b11208d28493f"/>
-    <p:sldId xmlns:r="http://schemas.openxmlformats.org/officeDocument/2006/relationships" id="264" r:id="Ra17678f7bf04449a"/>
-    <p:sldId xmlns:r="http://schemas.openxmlformats.org/officeDocument/2006/relationships" id="265" r:id="R8391584addf74832"/>
-    <p:sldId xmlns:r="http://schemas.openxmlformats.org/officeDocument/2006/relationships" id="266" r:id="R053fa73f40104787"/>
-    <p:sldId xmlns:r="http://schemas.openxmlformats.org/officeDocument/2006/relationships" id="267" r:id="Re7bb11619bf34ecf"/>
+    <p:sldId xmlns:r="http://schemas.openxmlformats.org/officeDocument/2006/relationships" id="256" r:id="Ra6fc1dddceaa4c73"/>
+    <p:sldId xmlns:r="http://schemas.openxmlformats.org/officeDocument/2006/relationships" id="257" r:id="R2ab3aebef75243f9"/>
+    <p:sldId xmlns:r="http://schemas.openxmlformats.org/officeDocument/2006/relationships" id="258" r:id="R4ed4e8c76dfc4962"/>
+    <p:sldId xmlns:r="http://schemas.openxmlformats.org/officeDocument/2006/relationships" id="259" r:id="Re4c858ae67d54fd9"/>
+    <p:sldId xmlns:r="http://schemas.openxmlformats.org/officeDocument/2006/relationships" id="260" r:id="R830d8a0389084f43"/>
+    <p:sldId xmlns:r="http://schemas.openxmlformats.org/officeDocument/2006/relationships" id="261" r:id="R790bd84c1d354b65"/>
+    <p:sldId xmlns:r="http://schemas.openxmlformats.org/officeDocument/2006/relationships" id="262" r:id="Rc45348cc941e4c58"/>
+    <p:sldId xmlns:r="http://schemas.openxmlformats.org/officeDocument/2006/relationships" id="263" r:id="R06bd5315dce145f4"/>
+    <p:sldId xmlns:r="http://schemas.openxmlformats.org/officeDocument/2006/relationships" id="264" r:id="Ra7fa815be90c4739"/>
+    <p:sldId xmlns:r="http://schemas.openxmlformats.org/officeDocument/2006/relationships" id="265" r:id="Rd76cb6b8c73c4325"/>
+    <p:sldId xmlns:r="http://schemas.openxmlformats.org/officeDocument/2006/relationships" id="266" r:id="Ra85b8d472ca942c5"/>
+    <p:sldId xmlns:r="http://schemas.openxmlformats.org/officeDocument/2006/relationships" id="267" r:id="R833ee0ac12de43a6"/>
   </p:sldIdLst>
   <p:sldSz cx="9144000" cy="5143500"/>
   <p:notesSz cx="6858000" cy="9144000"/>
   <p:embeddedFontLst>
     <p:embeddedFont>
       <p:font typeface="Roboto Mono Medium"/>
-      <p:regular xmlns:r="http://schemas.openxmlformats.org/officeDocument/2006/relationships" r:id="Rb2ca6fde6ca0435a"/>
-      <p:bold xmlns:r="http://schemas.openxmlformats.org/officeDocument/2006/relationships" r:id="R43172c88ee4b4bb4"/>
-      <p:italic xmlns:r="http://schemas.openxmlformats.org/officeDocument/2006/relationships" r:id="R1b68e9ce85bc4850"/>
-      <p:boldItalic xmlns:r="http://schemas.openxmlformats.org/officeDocument/2006/relationships" r:id="Re0b3b1bba54a4a1f"/>
+      <p:regular xmlns:r="http://schemas.openxmlformats.org/officeDocument/2006/relationships" r:id="R3d1e3f9a8f7f4095"/>
+      <p:bold xmlns:r="http://schemas.openxmlformats.org/officeDocument/2006/relationships" r:id="R3657adb79e92498f"/>
+      <p:italic xmlns:r="http://schemas.openxmlformats.org/officeDocument/2006/relationships" r:id="R09a97f94df784faf"/>
+      <p:boldItalic xmlns:r="http://schemas.openxmlformats.org/officeDocument/2006/relationships" r:id="Rc69f112042854958"/>
     </p:embeddedFont>
     <p:embeddedFont>
       <p:font typeface="Inter SemiBold"/>
-      <p:regular xmlns:r="http://schemas.openxmlformats.org/officeDocument/2006/relationships" r:id="Rcbb2b54a24794222"/>
-      <p:bold xmlns:r="http://schemas.openxmlformats.org/officeDocument/2006/relationships" r:id="Rf98b3ae310bc479f"/>
-      <p:italic xmlns:r="http://schemas.openxmlformats.org/officeDocument/2006/relationships" r:id="Rd91055dfffd549ff"/>
-      <p:boldItalic xmlns:r="http://schemas.openxmlformats.org/officeDocument/2006/relationships" r:id="Recc346ee37874a2e"/>
+      <p:regular xmlns:r="http://schemas.openxmlformats.org/officeDocument/2006/relationships" r:id="R4bb76ff7a19d4225"/>
+      <p:bold xmlns:r="http://schemas.openxmlformats.org/officeDocument/2006/relationships" r:id="Rb510d45d58d04e4e"/>
+      <p:italic xmlns:r="http://schemas.openxmlformats.org/officeDocument/2006/relationships" r:id="R8949635c59644de2"/>
+      <p:boldItalic xmlns:r="http://schemas.openxmlformats.org/officeDocument/2006/relationships" r:id="R6da069ed33884222"/>
     </p:embeddedFont>
     <p:embeddedFont>
       <p:font typeface="Montserrat Black"/>
-      <p:bold xmlns:r="http://schemas.openxmlformats.org/officeDocument/2006/relationships" r:id="R10af1b3fe6f14e14"/>
-      <p:boldItalic xmlns:r="http://schemas.openxmlformats.org/officeDocument/2006/relationships" r:id="Rd21d38204fa842bb"/>
+      <p:bold xmlns:r="http://schemas.openxmlformats.org/officeDocument/2006/relationships" r:id="R7273b3cf0b8346f6"/>
+      <p:boldItalic xmlns:r="http://schemas.openxmlformats.org/officeDocument/2006/relationships" r:id="Rbd4a5c888a134e8b"/>
     </p:embeddedFont>
     <p:embeddedFont>
       <p:font typeface="Montserrat"/>
-      <p:bold xmlns:r="http://schemas.openxmlformats.org/officeDocument/2006/relationships" r:id="R276930f823de4c56"/>
-      <p:boldItalic xmlns:r="http://schemas.openxmlformats.org/officeDocument/2006/relationships" r:id="R56da61f797ed4cfe"/>
+      <p:bold xmlns:r="http://schemas.openxmlformats.org/officeDocument/2006/relationships" r:id="R43e4587ac019459b"/>
+      <p:boldItalic xmlns:r="http://schemas.openxmlformats.org/officeDocument/2006/relationships" r:id="Rea0232c405b54b73"/>
     </p:embeddedFont>
     <p:embeddedFont>
       <p:font typeface="Inter"/>
-      <p:regular xmlns:r="http://schemas.openxmlformats.org/officeDocument/2006/relationships" r:id="R70757fec6cf74db9"/>
-      <p:bold xmlns:r="http://schemas.openxmlformats.org/officeDocument/2006/relationships" r:id="R76d85249abad4c5f"/>
-      <p:italic xmlns:r="http://schemas.openxmlformats.org/officeDocument/2006/relationships" r:id="R788d3aeb6c3a49f1"/>
-      <p:boldItalic xmlns:r="http://schemas.openxmlformats.org/officeDocument/2006/relationships" r:id="Rafec1b9258ac47b2"/>
+      <p:regular xmlns:r="http://schemas.openxmlformats.org/officeDocument/2006/relationships" r:id="Rc5d329fb311744fc"/>
+      <p:bold xmlns:r="http://schemas.openxmlformats.org/officeDocument/2006/relationships" r:id="R6565329590844af7"/>
+      <p:italic xmlns:r="http://schemas.openxmlformats.org/officeDocument/2006/relationships" r:id="R831ccf4e91cd4234"/>
+      <p:boldItalic xmlns:r="http://schemas.openxmlformats.org/officeDocument/2006/relationships" r:id="R952aefb262244a41"/>
     </p:embeddedFont>
     <p:embeddedFont>
       <p:font typeface="Montserrat ExtraBold"/>
-      <p:bold xmlns:r="http://schemas.openxmlformats.org/officeDocument/2006/relationships" r:id="R928f060101e34e0d"/>
-      <p:boldItalic xmlns:r="http://schemas.openxmlformats.org/officeDocument/2006/relationships" r:id="Rf6dc642a278d42c1"/>
+      <p:bold xmlns:r="http://schemas.openxmlformats.org/officeDocument/2006/relationships" r:id="Raf1974a297a442b6"/>
+      <p:boldItalic xmlns:r="http://schemas.openxmlformats.org/officeDocument/2006/relationships" r:id="R402d95e4a7864285"/>
     </p:embeddedFont>
     <p:embeddedFont>
       <p:font typeface="Roboto Mono"/>
-      <p:bold xmlns:r="http://schemas.openxmlformats.org/officeDocument/2006/relationships" r:id="R151c6ecae18f4f1f"/>
-      <p:boldItalic xmlns:r="http://schemas.openxmlformats.org/officeDocument/2006/relationships" r:id="Rb918963d914b4682"/>
+      <p:bold xmlns:r="http://schemas.openxmlformats.org/officeDocument/2006/relationships" r:id="R769d9f5621764dc9"/>
+      <p:boldItalic xmlns:r="http://schemas.openxmlformats.org/officeDocument/2006/relationships" r:id="R822ce61896f04bab"/>
     </p:embeddedFont>
     <p:embeddedFont>
       <p:font typeface="Inter Medium"/>
-      <p:regular xmlns:r="http://schemas.openxmlformats.org/officeDocument/2006/relationships" r:id="R1b129bb65158465d"/>
-      <p:bold xmlns:r="http://schemas.openxmlformats.org/officeDocument/2006/relationships" r:id="Rde6706d600f548b8"/>
-      <p:italic xmlns:r="http://schemas.openxmlformats.org/officeDocument/2006/relationships" r:id="R73b9646f4542432e"/>
-      <p:boldItalic xmlns:r="http://schemas.openxmlformats.org/officeDocument/2006/relationships" r:id="R5d1b88b040304664"/>
+      <p:regular xmlns:r="http://schemas.openxmlformats.org/officeDocument/2006/relationships" r:id="R6d78892617be404e"/>
+      <p:bold xmlns:r="http://schemas.openxmlformats.org/officeDocument/2006/relationships" r:id="Rb4cdb389213c4084"/>
+      <p:italic xmlns:r="http://schemas.openxmlformats.org/officeDocument/2006/relationships" r:id="Rc5986b7d128544df"/>
+      <p:boldItalic xmlns:r="http://schemas.openxmlformats.org/officeDocument/2006/relationships" r:id="Rf0c4455c650d4895"/>
     </p:embeddedFont>
   </p:embeddedFontLst>
 </p:presentation>
@@ -696,7 +696,7 @@
               <a:buNone/>
             </a:pPr>
             <a:r>
-              <a:t>The output is illustrative, not a promise of one event. The completed collector is the starter with all three snippets applied. Process execution exit events can include failed calls; this workshop does not add success-only conditions or detection logic.</a:t>
+              <a:t>The output is illustrative, not a promise of one event. Step 3 includes all previous additions and works without running steps 1 and 2 first. It overwrites main.cpp, rebuilds, and starts capture. Process execution exit events can include failed calls; this workshop does not add success-only conditions or detection logic.</a:t>
             </a:r>
             <a:endParaRPr/>
           </a:p>
@@ -776,7 +776,7 @@
               <a:buNone/>
             </a:pPr>
             <a:r>
-              <a:t>Troubleshooting: run the collector with sudo inside Ubuntu. If build/bin/workshop-agent does not exist, rerun the host setup script. It preserves existing source edits. If Multipass commands are missing immediately after installation, reopen the host terminal. Setup waits for the Ubuntu image catalog before launch. Windows setup has not been rehearsed here. Code and snippets: https://github.com/julianshalaby-perj/falco-libs-workshop</a:t>
+              <a:t>Troubleshooting: run the collector with sudo inside Ubuntu. If build/bin/workshop-agent does not exist, rerun the host setup script. It preserves existing source edits. If Multipass commands are missing immediately after installation, reopen the host terminal. Setup waits for the Ubuntu image catalog before launch. Windows setup has not been rehearsed here. Code and step scripts: https://github.com/julianshalaby-perj/falco-libs-workshop</a:t>
             </a:r>
             <a:endParaRPr/>
           </a:p>
@@ -936,7 +936,7 @@
               <a:buNone/>
             </a:pPr>
             <a:r>
-              <a:t>Setup is optional for attendees who prefer to watch. The scripts offer to install Multipass, create an Ubuntu 24.04 VM, copy the starter and snippets, install dependencies, and build the starter. Complete setup before the session if possible because the first library build takes time. Follow OS administrator prompts and any Windows restart request. Sources: https://github.com/canonical/multipass/releases/tag/v1.16.4 and https://github.com/julianshalaby-perj/falco-libs-workshop</a:t>
+              <a:t>Setup is optional for attendees who prefer to watch. The scripts offer to install Multipass, create an Ubuntu 24.04 VM, copy the starter and step scripts, install dependencies, and build the starter. Complete setup before the session if possible because the first library build takes time. Follow OS administrator prompts and any Windows restart request. Sources: https://github.com/canonical/multipass/releases/tag/v1.16.4 and https://github.com/julianshalaby-perj/falco-libs-workshop</a:t>
             </a:r>
             <a:endParaRPr/>
           </a:p>
@@ -1016,7 +1016,7 @@
               <a:buNone/>
             </a:pPr>
             <a:r>
-              <a:t>From this point, all editor, build, and collector commands run inside Ubuntu. The collector attaches to the VM kernel from inside the VM. It does not remotely attach to a VM or monitor the Mac/Windows kernel.</a:t>
+              <a:t>From this point, all step-script and collector commands run inside Ubuntu. The collector attaches to the VM kernel from inside the VM. It does not remotely attach to a VM or monitor the Mac/Windows kernel.</a:t>
             </a:r>
             <a:endParaRPr/>
           </a:p>
@@ -1176,7 +1176,7 @@
               <a:buNone/>
             </a:pPr>
             <a:r>
-              <a:t>Copy each snippet into the marked location. The files in snippets/ are not separate compilation units and are not automatically included. In nano, Ctrl-O then Enter saves; Ctrl-X exits. Stop any previous capture before rebuilding. The first library build is part of setup; subsequent builds change only the application.</a:t>
+              <a:t>Run these commands inside Ubuntu, without sudo. Each script writes the full source from its embedded code block, builds the application, then requests sudo for a ten-second capture. It overwrites any edits to main.cpp. Do not start the next script until the previous capture stops. The first library build happens during setup; these scripts rebuild the application.</a:t>
             </a:r>
             <a:endParaRPr/>
           </a:p>
@@ -1256,7 +1256,7 @@
               <a:buNone/>
             </a:pPr>
             <a:r>
-              <a:t>Paste the complete file once, including the result handling shown on the next slide. This slide splits the long deadline expression for readability. The repo snippet has the same behavior. next() uses an inspector-owned event pointer. Consume its contents before calling next() again. Source: https://github.com/falcosecurity/libs/blob/e72873882967cdd86b8753eca09ea3e9f91ccd4a/userspace/libsinsp/sinsp.h</a:t>
+              <a:t>The step script installs this code automatically. The next slide shows the rest of the loop. The deadline expression is split for readability. next() uses an inspector-owned event pointer. Consume its contents before calling next() again. Source: https://github.com/falcosecurity/libs/blob/e72873882967cdd86b8753eca09ea3e9f91ccd4a/userspace/libsinsp/sinsp.h</a:t>
             </a:r>
             <a:endParaRPr/>
           </a:p>
@@ -1336,7 +1336,7 @@
               <a:buNone/>
             </a:pPr>
             <a:r>
-              <a:t>This continues the same snippet. The count is events delivered successfully to this application, not a count of all syscalls on the machine. This first unfiltered run sees background activity. Run /usr/bin/id in terminal B if desired. SCAP_EOF is included for correct status handling; a live stream normally ends because the ten-second deadline expires. Source: https://github.com/falcosecurity/libs/blob/e72873882967cdd86b8753eca09ea3e9f91ccd4a/userspace/libsinsp/sinsp.h</a:t>
+              <a:t>This continues the code installed by step 1. The count is events delivered successfully to this application, not a count of all syscalls on the machine. This first unfiltered run sees background activity. Run /usr/bin/id in terminal B if desired. SCAP_EOF is included for correct status handling; a live stream normally ends because the ten-second deadline expires. Source: https://github.com/falcosecurity/libs/blob/e72873882967cdd86b8753eca09ea3e9f91ccd4a/userspace/libsinsp/sinsp.h</a:t>
             </a:r>
             <a:endParaRPr/>
           </a:p>
@@ -5584,18 +5584,18 @@
   </p:cSld>
   <p:clrMap bg1="lt1" tx1="dk1" bg2="dk2" tx2="lt2" accent1="accent1" accent2="accent2" accent3="accent3" accent4="accent4" accent5="accent5" accent6="accent6" hlink="hlink" folHlink="folHlink"/>
   <p:sldLayoutIdLst>
-    <p:sldLayoutId xmlns:r="http://schemas.openxmlformats.org/officeDocument/2006/relationships" id="2147483649" r:id="R1f80f51af75242a9"/>
-    <p:sldLayoutId xmlns:r="http://schemas.openxmlformats.org/officeDocument/2006/relationships" id="2147483650" r:id="Rb8e6ae5b82b341bd"/>
-    <p:sldLayoutId xmlns:r="http://schemas.openxmlformats.org/officeDocument/2006/relationships" id="2147483651" r:id="R32e576bb10f747fa"/>
-    <p:sldLayoutId xmlns:r="http://schemas.openxmlformats.org/officeDocument/2006/relationships" id="2147483652" r:id="Rd48fd4736de34cc1"/>
-    <p:sldLayoutId xmlns:r="http://schemas.openxmlformats.org/officeDocument/2006/relationships" id="2147483653" r:id="R784b2936ca604c25"/>
-    <p:sldLayoutId xmlns:r="http://schemas.openxmlformats.org/officeDocument/2006/relationships" id="2147483654" r:id="R6057988f958a4131"/>
-    <p:sldLayoutId xmlns:r="http://schemas.openxmlformats.org/officeDocument/2006/relationships" id="2147483655" r:id="R616aba6046ad4648"/>
-    <p:sldLayoutId xmlns:r="http://schemas.openxmlformats.org/officeDocument/2006/relationships" id="2147483656" r:id="R0968ab67b1f84e26"/>
-    <p:sldLayoutId xmlns:r="http://schemas.openxmlformats.org/officeDocument/2006/relationships" id="2147483657" r:id="Rd5ced1ac651b4e68"/>
-    <p:sldLayoutId xmlns:r="http://schemas.openxmlformats.org/officeDocument/2006/relationships" id="2147483658" r:id="R1ae917696056499a"/>
-    <p:sldLayoutId xmlns:r="http://schemas.openxmlformats.org/officeDocument/2006/relationships" id="2147483659" r:id="R930957c2878540ea"/>
-    <p:sldLayoutId xmlns:r="http://schemas.openxmlformats.org/officeDocument/2006/relationships" id="2147483660" r:id="Rb7392ca448bc4e7d"/>
+    <p:sldLayoutId xmlns:r="http://schemas.openxmlformats.org/officeDocument/2006/relationships" id="2147483649" r:id="R5fb106863a8345b8"/>
+    <p:sldLayoutId xmlns:r="http://schemas.openxmlformats.org/officeDocument/2006/relationships" id="2147483650" r:id="Rbac6ac8561644251"/>
+    <p:sldLayoutId xmlns:r="http://schemas.openxmlformats.org/officeDocument/2006/relationships" id="2147483651" r:id="R6faa74a75da54123"/>
+    <p:sldLayoutId xmlns:r="http://schemas.openxmlformats.org/officeDocument/2006/relationships" id="2147483652" r:id="R080e7ed6b2384a34"/>
+    <p:sldLayoutId xmlns:r="http://schemas.openxmlformats.org/officeDocument/2006/relationships" id="2147483653" r:id="R800c65db7adf4f0a"/>
+    <p:sldLayoutId xmlns:r="http://schemas.openxmlformats.org/officeDocument/2006/relationships" id="2147483654" r:id="R3218214672554d4d"/>
+    <p:sldLayoutId xmlns:r="http://schemas.openxmlformats.org/officeDocument/2006/relationships" id="2147483655" r:id="Rc428ca4a21d94b77"/>
+    <p:sldLayoutId xmlns:r="http://schemas.openxmlformats.org/officeDocument/2006/relationships" id="2147483656" r:id="R0f213642a275474d"/>
+    <p:sldLayoutId xmlns:r="http://schemas.openxmlformats.org/officeDocument/2006/relationships" id="2147483657" r:id="R41c27b0b5e2047e8"/>
+    <p:sldLayoutId xmlns:r="http://schemas.openxmlformats.org/officeDocument/2006/relationships" id="2147483658" r:id="R9c53fa797e6a4715"/>
+    <p:sldLayoutId xmlns:r="http://schemas.openxmlformats.org/officeDocument/2006/relationships" id="2147483659" r:id="R510e66d437b4494c"/>
+    <p:sldLayoutId xmlns:r="http://schemas.openxmlformats.org/officeDocument/2006/relationships" id="2147483660" r:id="Rabe987e9c41d4b24"/>
   </p:sldLayoutIdLst>
   <p:hf sldNum="0" hdr="0" ftr="0" dt="0"/>
   <p:txStyles>
@@ -6280,7 +6280,7 @@
   </p:cSld>
   <p:clrMap bg1="lt1" tx1="dk1" bg2="dk2" tx2="lt2" accent1="accent1" accent2="accent2" accent3="accent3" accent4="accent4" accent5="accent5" accent6="accent6" hlink="hlink" folHlink="folHlink"/>
   <p:sldLayoutIdLst>
-    <p:sldLayoutId xmlns:r="http://schemas.openxmlformats.org/officeDocument/2006/relationships" id="2147483662" r:id="R965b7d708e3d4cf7"/>
+    <p:sldLayoutId xmlns:r="http://schemas.openxmlformats.org/officeDocument/2006/relationships" id="2147483662" r:id="R9d185dda1c90404f"/>
   </p:sldLayoutIdLst>
   <p:hf sldNum="0" hdr="0" ftr="0" dt="0"/>
   <p:txStyles>
@@ -8129,7 +8129,7 @@
           <p:nvPr/>
         </p:nvPicPr>
         <p:blipFill rotWithShape="1">
-          <a:blip xmlns:r="http://schemas.openxmlformats.org/officeDocument/2006/relationships" xmlns:a="http://schemas.openxmlformats.org/drawingml/2006/main" r:embed="Rca90263a30c74b50">
+          <a:blip xmlns:r="http://schemas.openxmlformats.org/officeDocument/2006/relationships" xmlns:a="http://schemas.openxmlformats.org/drawingml/2006/main" r:embed="Re44ca803def649bc">
             <a:alphaModFix/>
           </a:blip>
           <a:srcRect xmlns:a="http://schemas.openxmlformats.org/drawingml/2006/main" l="0" t="0" r="0" b="0"/>
@@ -8157,7 +8157,7 @@
           <p:nvPr/>
         </p:nvPicPr>
         <p:blipFill rotWithShape="1">
-          <a:blip xmlns:r="http://schemas.openxmlformats.org/officeDocument/2006/relationships" xmlns:a="http://schemas.openxmlformats.org/drawingml/2006/main" r:embed="Rca90263a30c74b50">
+          <a:blip xmlns:r="http://schemas.openxmlformats.org/officeDocument/2006/relationships" xmlns:a="http://schemas.openxmlformats.org/drawingml/2006/main" r:embed="Re44ca803def649bc">
             <a:alphaModFix/>
           </a:blip>
           <a:srcRect xmlns:a="http://schemas.openxmlformats.org/drawingml/2006/main" l="0" t="0" r="0" b="0"/>
@@ -8185,7 +8185,7 @@
           <p:nvPr/>
         </p:nvPicPr>
         <p:blipFill rotWithShape="1">
-          <a:blip xmlns:r="http://schemas.openxmlformats.org/officeDocument/2006/relationships" xmlns:a="http://schemas.openxmlformats.org/drawingml/2006/main" r:embed="Rca90263a30c74b50">
+          <a:blip xmlns:r="http://schemas.openxmlformats.org/officeDocument/2006/relationships" xmlns:a="http://schemas.openxmlformats.org/drawingml/2006/main" r:embed="Re44ca803def649bc">
             <a:alphaModFix/>
           </a:blip>
           <a:srcRect xmlns:a="http://schemas.openxmlformats.org/drawingml/2006/main" l="0" t="0" r="0" b="0"/>
@@ -8213,7 +8213,7 @@
           <p:nvPr/>
         </p:nvPicPr>
         <p:blipFill rotWithShape="1">
-          <a:blip xmlns:r="http://schemas.openxmlformats.org/officeDocument/2006/relationships" xmlns:a="http://schemas.openxmlformats.org/drawingml/2006/main" r:embed="Rca90263a30c74b50">
+          <a:blip xmlns:r="http://schemas.openxmlformats.org/officeDocument/2006/relationships" xmlns:a="http://schemas.openxmlformats.org/drawingml/2006/main" r:embed="Re44ca803def649bc">
             <a:alphaModFix/>
           </a:blip>
           <a:srcRect xmlns:a="http://schemas.openxmlformats.org/drawingml/2006/main" l="0" t="0" r="0" b="0"/>
@@ -8241,7 +8241,7 @@
           <p:nvPr/>
         </p:nvPicPr>
         <p:blipFill rotWithShape="1">
-          <a:blip xmlns:r="http://schemas.openxmlformats.org/officeDocument/2006/relationships" xmlns:a="http://schemas.openxmlformats.org/drawingml/2006/main" r:embed="Rca90263a30c74b50">
+          <a:blip xmlns:r="http://schemas.openxmlformats.org/officeDocument/2006/relationships" xmlns:a="http://schemas.openxmlformats.org/drawingml/2006/main" r:embed="Re44ca803def649bc">
             <a:alphaModFix/>
           </a:blip>
           <a:srcRect xmlns:a="http://schemas.openxmlformats.org/drawingml/2006/main" l="0" t="0" r="0" b="0"/>
@@ -8269,7 +8269,7 @@
           <p:nvPr/>
         </p:nvPicPr>
         <p:blipFill rotWithShape="1">
-          <a:blip xmlns:r="http://schemas.openxmlformats.org/officeDocument/2006/relationships" xmlns:a="http://schemas.openxmlformats.org/drawingml/2006/main" r:embed="Rca90263a30c74b50">
+          <a:blip xmlns:r="http://schemas.openxmlformats.org/officeDocument/2006/relationships" xmlns:a="http://schemas.openxmlformats.org/drawingml/2006/main" r:embed="Re44ca803def649bc">
             <a:alphaModFix/>
           </a:blip>
           <a:srcRect xmlns:a="http://schemas.openxmlformats.org/drawingml/2006/main" l="0" t="0" r="0" b="0"/>
@@ -8297,7 +8297,7 @@
           <p:nvPr/>
         </p:nvPicPr>
         <p:blipFill rotWithShape="1">
-          <a:blip xmlns:r="http://schemas.openxmlformats.org/officeDocument/2006/relationships" xmlns:a="http://schemas.openxmlformats.org/drawingml/2006/main" r:embed="Rca90263a30c74b50">
+          <a:blip xmlns:r="http://schemas.openxmlformats.org/officeDocument/2006/relationships" xmlns:a="http://schemas.openxmlformats.org/drawingml/2006/main" r:embed="Re44ca803def649bc">
             <a:alphaModFix/>
           </a:blip>
           <a:srcRect xmlns:a="http://schemas.openxmlformats.org/drawingml/2006/main" l="0" t="0" r="0" b="0"/>
@@ -8325,7 +8325,7 @@
           <p:nvPr/>
         </p:nvPicPr>
         <p:blipFill rotWithShape="1">
-          <a:blip xmlns:r="http://schemas.openxmlformats.org/officeDocument/2006/relationships" xmlns:a="http://schemas.openxmlformats.org/drawingml/2006/main" r:embed="Rca90263a30c74b50">
+          <a:blip xmlns:r="http://schemas.openxmlformats.org/officeDocument/2006/relationships" xmlns:a="http://schemas.openxmlformats.org/drawingml/2006/main" r:embed="Re44ca803def649bc">
             <a:alphaModFix/>
           </a:blip>
           <a:srcRect xmlns:a="http://schemas.openxmlformats.org/drawingml/2006/main" l="0" t="0" r="0" b="0"/>
@@ -9097,7 +9097,7 @@
                 <a:ea typeface="Inter"/>
                 <a:cs typeface="Inter"/>
               </a:rPr>
-              <a:t>Paste snippet 03 at STEP 3 inside the read loop.</a:t>
+              <a:t>Run bash steps/step-3.sh in A.</a:t>
             </a:r>
           </a:p>
           <a:p xmlns:a="http://schemas.openxmlformats.org/drawingml/2006/main">
@@ -9149,7 +9149,7 @@
                 <a:ea typeface="Inter"/>
                 <a:cs typeface="Inter"/>
               </a:rPr>
-              <a:t>libsinsp supplies the process context.</a:t>
+              <a:t>The script adds process context to the read loop.</a:t>
             </a:r>
           </a:p>
           <a:p xmlns:a="http://schemas.openxmlformats.org/drawingml/2006/main">
@@ -9201,7 +9201,7 @@
                 <a:ea typeface="Inter"/>
                 <a:cs typeface="Inter"/>
               </a:rPr>
-              <a:t>Rebuild, run, and execute id in B again.</a:t>
+              <a:t>Run id in B again during capture.</a:t>
             </a:r>
           </a:p>
         </p:txBody>
@@ -9471,7 +9471,7 @@
                 <a:ea typeface="Roboto Mono"/>
                 <a:cs typeface="Roboto Mono"/>
               </a:rPr>
-              <a:t>snippets/03-process-context.cpp</a:t>
+              <a:t>Step 3: context added to main.cpp</a:t>
             </a:r>
           </a:p>
         </p:txBody>
@@ -10448,7 +10448,7 @@
           <p:nvPr/>
         </p:nvPicPr>
         <p:blipFill rotWithShape="1">
-          <a:blip xmlns:r="http://schemas.openxmlformats.org/officeDocument/2006/relationships" xmlns:a="http://schemas.openxmlformats.org/drawingml/2006/main" r:embed="Rcd57be2aa7534af6">
+          <a:blip xmlns:r="http://schemas.openxmlformats.org/officeDocument/2006/relationships" xmlns:a="http://schemas.openxmlformats.org/drawingml/2006/main" r:embed="R5261efca8f4c439f">
             <a:alphaModFix/>
           </a:blip>
           <a:srcRect xmlns:a="http://schemas.openxmlformats.org/drawingml/2006/main" l="0" t="0" r="0" b="0"/>
@@ -10476,7 +10476,7 @@
           <p:nvPr/>
         </p:nvPicPr>
         <p:blipFill rotWithShape="1">
-          <a:blip xmlns:r="http://schemas.openxmlformats.org/officeDocument/2006/relationships" xmlns:a="http://schemas.openxmlformats.org/drawingml/2006/main" r:embed="Rcd57be2aa7534af6">
+          <a:blip xmlns:r="http://schemas.openxmlformats.org/officeDocument/2006/relationships" xmlns:a="http://schemas.openxmlformats.org/drawingml/2006/main" r:embed="R5261efca8f4c439f">
             <a:alphaModFix/>
           </a:blip>
           <a:srcRect xmlns:a="http://schemas.openxmlformats.org/drawingml/2006/main" l="0" t="0" r="0" b="0"/>
@@ -10504,7 +10504,7 @@
           <p:nvPr/>
         </p:nvPicPr>
         <p:blipFill rotWithShape="1">
-          <a:blip xmlns:r="http://schemas.openxmlformats.org/officeDocument/2006/relationships" xmlns:a="http://schemas.openxmlformats.org/drawingml/2006/main" r:embed="Rcd57be2aa7534af6">
+          <a:blip xmlns:r="http://schemas.openxmlformats.org/officeDocument/2006/relationships" xmlns:a="http://schemas.openxmlformats.org/drawingml/2006/main" r:embed="R5261efca8f4c439f">
             <a:alphaModFix/>
           </a:blip>
           <a:srcRect xmlns:a="http://schemas.openxmlformats.org/drawingml/2006/main" l="0" t="0" r="0" b="0"/>
@@ -10532,7 +10532,7 @@
           <p:nvPr/>
         </p:nvPicPr>
         <p:blipFill rotWithShape="1">
-          <a:blip xmlns:r="http://schemas.openxmlformats.org/officeDocument/2006/relationships" xmlns:a="http://schemas.openxmlformats.org/drawingml/2006/main" r:embed="Rcd57be2aa7534af6">
+          <a:blip xmlns:r="http://schemas.openxmlformats.org/officeDocument/2006/relationships" xmlns:a="http://schemas.openxmlformats.org/drawingml/2006/main" r:embed="R5261efca8f4c439f">
             <a:alphaModFix/>
           </a:blip>
           <a:srcRect xmlns:a="http://schemas.openxmlformats.org/drawingml/2006/main" l="0" t="0" r="0" b="0"/>
@@ -11286,7 +11286,7 @@
                 <a:ea typeface="Inter"/>
                 <a:cs typeface="Inter"/>
               </a:rPr>
-              <a:t>The finished file is available if you want to skip the edits.</a:t>
+              <a:t>Step 3 installs the complete collector.</a:t>
             </a:r>
           </a:p>
         </p:txBody>
@@ -11815,7 +11815,7 @@
                 <a:ea typeface="Roboto Mono"/>
                 <a:cs typeface="Roboto Mono"/>
               </a:rPr>
-              <a:t># Optional: use the completed file</a:t>
+              <a:t># Run the finished version directly</a:t>
             </a:r>
           </a:p>
           <a:p xmlns:a="http://schemas.openxmlformats.org/drawingml/2006/main">
@@ -11845,7 +11845,29 @@
                 <a:ea typeface="Roboto Mono"/>
                 <a:cs typeface="Roboto Mono"/>
               </a:rPr>
-              <a:t>cp snippets/finished.cpp src/main.cpp</a:t>
+              <a:t>bash steps/step-3.sh</a:t>
+            </a:r>
+          </a:p>
+          <a:p xmlns:a="http://schemas.openxmlformats.org/drawingml/2006/main">
+            <a:pPr marL="0" indent="0">
+              <a:spcBef>
+                <a:spcPts val="0"/>
+              </a:spcBef>
+              <a:spcAft>
+                <a:spcPts val="0"/>
+              </a:spcAft>
+              <a:buNone/>
+            </a:pPr>
+            <a:r>
+              <a:rPr sz="1350" b="0" i="0">
+                <a:solidFill>
+                  <a:srgbClr val="00E5FF"/>
+                </a:solidFill>
+                <a:latin typeface="Roboto Mono"/>
+                <a:ea typeface="Roboto Mono"/>
+                <a:cs typeface="Roboto Mono"/>
+              </a:rPr>
+              <a:t/>
             </a:r>
           </a:p>
           <a:p xmlns:a="http://schemas.openxmlformats.org/drawingml/2006/main">
@@ -11875,7 +11897,7 @@
                 <a:ea typeface="Roboto Mono"/>
                 <a:cs typeface="Roboto Mono"/>
               </a:rPr>
-              <a:t>cmake --build build \</a:t>
+              <a:t># Inspect its code</a:t>
             </a:r>
           </a:p>
           <a:p xmlns:a="http://schemas.openxmlformats.org/drawingml/2006/main">
@@ -11905,37 +11927,7 @@
                 <a:ea typeface="Roboto Mono"/>
                 <a:cs typeface="Roboto Mono"/>
               </a:rPr>
-              <a:t>  --target workshop-agent -j 1</a:t>
-            </a:r>
-          </a:p>
-          <a:p xmlns:a="http://schemas.openxmlformats.org/drawingml/2006/main">
-            <a:pPr marL="0" indent="0" algn="l">
-              <a:spcBef>
-                <a:spcPts val="0"/>
-              </a:spcBef>
-              <a:spcAft>
-                <a:spcPts val="0"/>
-              </a:spcAft>
-              <a:buNone/>
-              <a:defRPr sz="1350" b="0">
-                <a:solidFill>
-                  <a:srgbClr val="00E5FF"/>
-                </a:solidFill>
-                <a:latin typeface="Roboto Mono"/>
-                <a:ea typeface="Roboto Mono"/>
-                <a:cs typeface="Roboto Mono"/>
-              </a:defRPr>
-            </a:pPr>
-            <a:r>
-              <a:rPr sz="1350" b="0" i="0">
-                <a:solidFill>
-                  <a:srgbClr val="00E5FF"/>
-                </a:solidFill>
-                <a:latin typeface="Roboto Mono"/>
-                <a:ea typeface="Roboto Mono"/>
-                <a:cs typeface="Roboto Mono"/>
-              </a:rPr>
-              <a:t>sudo ./build/bin/workshop-agent</a:t>
+              <a:t>cat src/main.cpp</a:t>
             </a:r>
           </a:p>
         </p:txBody>
@@ -12585,7 +12577,7 @@
           <p:nvPr/>
         </p:nvPicPr>
         <p:blipFill rotWithShape="1">
-          <a:blip xmlns:r="http://schemas.openxmlformats.org/officeDocument/2006/relationships" xmlns:a="http://schemas.openxmlformats.org/drawingml/2006/main" r:embed="R7f60388aa3de4d5a">
+          <a:blip xmlns:r="http://schemas.openxmlformats.org/officeDocument/2006/relationships" xmlns:a="http://schemas.openxmlformats.org/drawingml/2006/main" r:embed="R3c5846c17df84bd3">
             <a:alphaModFix/>
           </a:blip>
           <a:srcRect xmlns:a="http://schemas.openxmlformats.org/drawingml/2006/main" l="0" t="0" r="0" b="0"/>
@@ -12613,7 +12605,7 @@
           <p:nvPr/>
         </p:nvPicPr>
         <p:blipFill rotWithShape="1">
-          <a:blip xmlns:r="http://schemas.openxmlformats.org/officeDocument/2006/relationships" xmlns:a="http://schemas.openxmlformats.org/drawingml/2006/main" r:embed="R7f60388aa3de4d5a">
+          <a:blip xmlns:r="http://schemas.openxmlformats.org/officeDocument/2006/relationships" xmlns:a="http://schemas.openxmlformats.org/drawingml/2006/main" r:embed="R3c5846c17df84bd3">
             <a:alphaModFix/>
           </a:blip>
           <a:srcRect xmlns:a="http://schemas.openxmlformats.org/drawingml/2006/main" l="0" t="0" r="0" b="0"/>
@@ -12641,7 +12633,7 @@
           <p:nvPr/>
         </p:nvPicPr>
         <p:blipFill rotWithShape="1">
-          <a:blip xmlns:r="http://schemas.openxmlformats.org/officeDocument/2006/relationships" xmlns:a="http://schemas.openxmlformats.org/drawingml/2006/main" r:embed="R7f60388aa3de4d5a">
+          <a:blip xmlns:r="http://schemas.openxmlformats.org/officeDocument/2006/relationships" xmlns:a="http://schemas.openxmlformats.org/drawingml/2006/main" r:embed="R3c5846c17df84bd3">
             <a:alphaModFix/>
           </a:blip>
           <a:srcRect xmlns:a="http://schemas.openxmlformats.org/drawingml/2006/main" l="0" t="0" r="0" b="0"/>
@@ -12669,7 +12661,7 @@
           <p:nvPr/>
         </p:nvPicPr>
         <p:blipFill rotWithShape="1">
-          <a:blip xmlns:r="http://schemas.openxmlformats.org/officeDocument/2006/relationships" xmlns:a="http://schemas.openxmlformats.org/drawingml/2006/main" r:embed="R7f60388aa3de4d5a">
+          <a:blip xmlns:r="http://schemas.openxmlformats.org/officeDocument/2006/relationships" xmlns:a="http://schemas.openxmlformats.org/drawingml/2006/main" r:embed="R3c5846c17df84bd3">
             <a:alphaModFix/>
           </a:blip>
           <a:srcRect xmlns:a="http://schemas.openxmlformats.org/drawingml/2006/main" l="0" t="0" r="0" b="0"/>
@@ -14520,7 +14512,7 @@
           <p:nvPr/>
         </p:nvPicPr>
         <p:blipFill rotWithShape="1">
-          <a:blip xmlns:r="http://schemas.openxmlformats.org/officeDocument/2006/relationships" xmlns:a="http://schemas.openxmlformats.org/drawingml/2006/main" r:embed="R54b9605d863149df">
+          <a:blip xmlns:r="http://schemas.openxmlformats.org/officeDocument/2006/relationships" xmlns:a="http://schemas.openxmlformats.org/drawingml/2006/main" r:embed="R1e528c83a7db42cc">
             <a:alphaModFix/>
           </a:blip>
           <a:srcRect xmlns:a="http://schemas.openxmlformats.org/drawingml/2006/main" l="0" t="0" r="0" b="0"/>
@@ -14548,7 +14540,7 @@
           <p:nvPr/>
         </p:nvPicPr>
         <p:blipFill rotWithShape="1">
-          <a:blip xmlns:r="http://schemas.openxmlformats.org/officeDocument/2006/relationships" xmlns:a="http://schemas.openxmlformats.org/drawingml/2006/main" r:embed="R54b9605d863149df">
+          <a:blip xmlns:r="http://schemas.openxmlformats.org/officeDocument/2006/relationships" xmlns:a="http://schemas.openxmlformats.org/drawingml/2006/main" r:embed="R1e528c83a7db42cc">
             <a:alphaModFix/>
           </a:blip>
           <a:srcRect xmlns:a="http://schemas.openxmlformats.org/drawingml/2006/main" l="0" t="0" r="0" b="0"/>
@@ -14576,7 +14568,7 @@
           <p:nvPr/>
         </p:nvPicPr>
         <p:blipFill rotWithShape="1">
-          <a:blip xmlns:r="http://schemas.openxmlformats.org/officeDocument/2006/relationships" xmlns:a="http://schemas.openxmlformats.org/drawingml/2006/main" r:embed="R54b9605d863149df">
+          <a:blip xmlns:r="http://schemas.openxmlformats.org/officeDocument/2006/relationships" xmlns:a="http://schemas.openxmlformats.org/drawingml/2006/main" r:embed="R1e528c83a7db42cc">
             <a:alphaModFix/>
           </a:blip>
           <a:srcRect xmlns:a="http://schemas.openxmlformats.org/drawingml/2006/main" l="0" t="0" r="0" b="0"/>
@@ -14604,7 +14596,7 @@
           <p:nvPr/>
         </p:nvPicPr>
         <p:blipFill rotWithShape="1">
-          <a:blip xmlns:r="http://schemas.openxmlformats.org/officeDocument/2006/relationships" xmlns:a="http://schemas.openxmlformats.org/drawingml/2006/main" r:embed="R54b9605d863149df">
+          <a:blip xmlns:r="http://schemas.openxmlformats.org/officeDocument/2006/relationships" xmlns:a="http://schemas.openxmlformats.org/drawingml/2006/main" r:embed="R1e528c83a7db42cc">
             <a:alphaModFix/>
           </a:blip>
           <a:srcRect xmlns:a="http://schemas.openxmlformats.org/drawingml/2006/main" l="0" t="0" r="0" b="0"/>
@@ -16499,7 +16491,7 @@
           <p:nvPr/>
         </p:nvPicPr>
         <p:blipFill rotWithShape="1">
-          <a:blip xmlns:r="http://schemas.openxmlformats.org/officeDocument/2006/relationships" xmlns:a="http://schemas.openxmlformats.org/drawingml/2006/main" r:embed="R72bf826f7cd146c9">
+          <a:blip xmlns:r="http://schemas.openxmlformats.org/officeDocument/2006/relationships" xmlns:a="http://schemas.openxmlformats.org/drawingml/2006/main" r:embed="R8eacb407f5104737">
             <a:alphaModFix/>
           </a:blip>
           <a:srcRect xmlns:a="http://schemas.openxmlformats.org/drawingml/2006/main" l="0" t="0" r="0" b="0"/>
@@ -16527,7 +16519,7 @@
           <p:nvPr/>
         </p:nvPicPr>
         <p:blipFill rotWithShape="1">
-          <a:blip xmlns:r="http://schemas.openxmlformats.org/officeDocument/2006/relationships" xmlns:a="http://schemas.openxmlformats.org/drawingml/2006/main" r:embed="R72bf826f7cd146c9">
+          <a:blip xmlns:r="http://schemas.openxmlformats.org/officeDocument/2006/relationships" xmlns:a="http://schemas.openxmlformats.org/drawingml/2006/main" r:embed="R8eacb407f5104737">
             <a:alphaModFix/>
           </a:blip>
           <a:srcRect xmlns:a="http://schemas.openxmlformats.org/drawingml/2006/main" l="0" t="0" r="0" b="0"/>
@@ -16555,7 +16547,7 @@
           <p:nvPr/>
         </p:nvPicPr>
         <p:blipFill rotWithShape="1">
-          <a:blip xmlns:r="http://schemas.openxmlformats.org/officeDocument/2006/relationships" xmlns:a="http://schemas.openxmlformats.org/drawingml/2006/main" r:embed="R72bf826f7cd146c9">
+          <a:blip xmlns:r="http://schemas.openxmlformats.org/officeDocument/2006/relationships" xmlns:a="http://schemas.openxmlformats.org/drawingml/2006/main" r:embed="R8eacb407f5104737">
             <a:alphaModFix/>
           </a:blip>
           <a:srcRect xmlns:a="http://schemas.openxmlformats.org/drawingml/2006/main" l="0" t="0" r="0" b="0"/>
@@ -16583,7 +16575,7 @@
           <p:nvPr/>
         </p:nvPicPr>
         <p:blipFill rotWithShape="1">
-          <a:blip xmlns:r="http://schemas.openxmlformats.org/officeDocument/2006/relationships" xmlns:a="http://schemas.openxmlformats.org/drawingml/2006/main" r:embed="R72bf826f7cd146c9">
+          <a:blip xmlns:r="http://schemas.openxmlformats.org/officeDocument/2006/relationships" xmlns:a="http://schemas.openxmlformats.org/drawingml/2006/main" r:embed="R8eacb407f5104737">
             <a:alphaModFix/>
           </a:blip>
           <a:srcRect xmlns:a="http://schemas.openxmlformats.org/drawingml/2006/main" l="0" t="0" r="0" b="0"/>
@@ -18323,7 +18315,7 @@
           <p:nvPr/>
         </p:nvPicPr>
         <p:blipFill rotWithShape="1">
-          <a:blip xmlns:r="http://schemas.openxmlformats.org/officeDocument/2006/relationships" xmlns:a="http://schemas.openxmlformats.org/drawingml/2006/main" r:embed="Ra56da29092b34283">
+          <a:blip xmlns:r="http://schemas.openxmlformats.org/officeDocument/2006/relationships" xmlns:a="http://schemas.openxmlformats.org/drawingml/2006/main" r:embed="Rc3df1a860cba448a">
             <a:alphaModFix/>
           </a:blip>
           <a:srcRect xmlns:a="http://schemas.openxmlformats.org/drawingml/2006/main" l="0" t="0" r="0" b="0"/>
@@ -18351,7 +18343,7 @@
           <p:nvPr/>
         </p:nvPicPr>
         <p:blipFill rotWithShape="1">
-          <a:blip xmlns:r="http://schemas.openxmlformats.org/officeDocument/2006/relationships" xmlns:a="http://schemas.openxmlformats.org/drawingml/2006/main" r:embed="Ra56da29092b34283">
+          <a:blip xmlns:r="http://schemas.openxmlformats.org/officeDocument/2006/relationships" xmlns:a="http://schemas.openxmlformats.org/drawingml/2006/main" r:embed="Rc3df1a860cba448a">
             <a:alphaModFix/>
           </a:blip>
           <a:srcRect xmlns:a="http://schemas.openxmlformats.org/drawingml/2006/main" l="0" t="0" r="0" b="0"/>
@@ -18379,7 +18371,7 @@
           <p:nvPr/>
         </p:nvPicPr>
         <p:blipFill rotWithShape="1">
-          <a:blip xmlns:r="http://schemas.openxmlformats.org/officeDocument/2006/relationships" xmlns:a="http://schemas.openxmlformats.org/drawingml/2006/main" r:embed="Ra56da29092b34283">
+          <a:blip xmlns:r="http://schemas.openxmlformats.org/officeDocument/2006/relationships" xmlns:a="http://schemas.openxmlformats.org/drawingml/2006/main" r:embed="Rc3df1a860cba448a">
             <a:alphaModFix/>
           </a:blip>
           <a:srcRect xmlns:a="http://schemas.openxmlformats.org/drawingml/2006/main" l="0" t="0" r="0" b="0"/>
@@ -18407,7 +18399,7 @@
           <p:nvPr/>
         </p:nvPicPr>
         <p:blipFill rotWithShape="1">
-          <a:blip xmlns:r="http://schemas.openxmlformats.org/officeDocument/2006/relationships" xmlns:a="http://schemas.openxmlformats.org/drawingml/2006/main" r:embed="Ra56da29092b34283">
+          <a:blip xmlns:r="http://schemas.openxmlformats.org/officeDocument/2006/relationships" xmlns:a="http://schemas.openxmlformats.org/drawingml/2006/main" r:embed="Rc3df1a860cba448a">
             <a:alphaModFix/>
           </a:blip>
           <a:srcRect xmlns:a="http://schemas.openxmlformats.org/drawingml/2006/main" l="0" t="0" r="0" b="0"/>
@@ -19109,7 +19101,7 @@
                 <a:ea typeface="Inter"/>
                 <a:cs typeface="Inter"/>
               </a:rPr>
-              <a:t>A: edit, build, and run the collector.</a:t>
+              <a:t>A: run the numbered step scripts.</a:t>
             </a:r>
           </a:p>
           <a:p xmlns:a="http://schemas.openxmlformats.org/drawingml/2006/main">
@@ -20370,7 +20362,7 @@
           <p:nvPr/>
         </p:nvPicPr>
         <p:blipFill rotWithShape="1">
-          <a:blip xmlns:r="http://schemas.openxmlformats.org/officeDocument/2006/relationships" xmlns:a="http://schemas.openxmlformats.org/drawingml/2006/main" r:embed="R27869277c50148ce">
+          <a:blip xmlns:r="http://schemas.openxmlformats.org/officeDocument/2006/relationships" xmlns:a="http://schemas.openxmlformats.org/drawingml/2006/main" r:embed="R08cf9c65991141c7">
             <a:alphaModFix/>
           </a:blip>
           <a:srcRect xmlns:a="http://schemas.openxmlformats.org/drawingml/2006/main" l="0" t="0" r="0" b="0"/>
@@ -20398,7 +20390,7 @@
           <p:nvPr/>
         </p:nvPicPr>
         <p:blipFill rotWithShape="1">
-          <a:blip xmlns:r="http://schemas.openxmlformats.org/officeDocument/2006/relationships" xmlns:a="http://schemas.openxmlformats.org/drawingml/2006/main" r:embed="R27869277c50148ce">
+          <a:blip xmlns:r="http://schemas.openxmlformats.org/officeDocument/2006/relationships" xmlns:a="http://schemas.openxmlformats.org/drawingml/2006/main" r:embed="R08cf9c65991141c7">
             <a:alphaModFix/>
           </a:blip>
           <a:srcRect xmlns:a="http://schemas.openxmlformats.org/drawingml/2006/main" l="0" t="0" r="0" b="0"/>
@@ -20426,7 +20418,7 @@
           <p:nvPr/>
         </p:nvPicPr>
         <p:blipFill rotWithShape="1">
-          <a:blip xmlns:r="http://schemas.openxmlformats.org/officeDocument/2006/relationships" xmlns:a="http://schemas.openxmlformats.org/drawingml/2006/main" r:embed="R27869277c50148ce">
+          <a:blip xmlns:r="http://schemas.openxmlformats.org/officeDocument/2006/relationships" xmlns:a="http://schemas.openxmlformats.org/drawingml/2006/main" r:embed="R08cf9c65991141c7">
             <a:alphaModFix/>
           </a:blip>
           <a:srcRect xmlns:a="http://schemas.openxmlformats.org/drawingml/2006/main" l="0" t="0" r="0" b="0"/>
@@ -20454,7 +20446,7 @@
           <p:nvPr/>
         </p:nvPicPr>
         <p:blipFill rotWithShape="1">
-          <a:blip xmlns:r="http://schemas.openxmlformats.org/officeDocument/2006/relationships" xmlns:a="http://schemas.openxmlformats.org/drawingml/2006/main" r:embed="R27869277c50148ce">
+          <a:blip xmlns:r="http://schemas.openxmlformats.org/officeDocument/2006/relationships" xmlns:a="http://schemas.openxmlformats.org/drawingml/2006/main" r:embed="R08cf9c65991141c7">
             <a:alphaModFix/>
           </a:blip>
           <a:srcRect xmlns:a="http://schemas.openxmlformats.org/drawingml/2006/main" l="0" t="0" r="0" b="0"/>
@@ -22499,7 +22491,7 @@
           <p:nvPr/>
         </p:nvPicPr>
         <p:blipFill rotWithShape="1">
-          <a:blip xmlns:r="http://schemas.openxmlformats.org/officeDocument/2006/relationships" xmlns:a="http://schemas.openxmlformats.org/drawingml/2006/main" r:embed="R18ea002da3574501">
+          <a:blip xmlns:r="http://schemas.openxmlformats.org/officeDocument/2006/relationships" xmlns:a="http://schemas.openxmlformats.org/drawingml/2006/main" r:embed="R69825bd9c9614397">
             <a:alphaModFix/>
           </a:blip>
           <a:srcRect xmlns:a="http://schemas.openxmlformats.org/drawingml/2006/main" l="0" t="0" r="0" b="0"/>
@@ -22527,7 +22519,7 @@
           <p:nvPr/>
         </p:nvPicPr>
         <p:blipFill rotWithShape="1">
-          <a:blip xmlns:r="http://schemas.openxmlformats.org/officeDocument/2006/relationships" xmlns:a="http://schemas.openxmlformats.org/drawingml/2006/main" r:embed="R18ea002da3574501">
+          <a:blip xmlns:r="http://schemas.openxmlformats.org/officeDocument/2006/relationships" xmlns:a="http://schemas.openxmlformats.org/drawingml/2006/main" r:embed="R69825bd9c9614397">
             <a:alphaModFix/>
           </a:blip>
           <a:srcRect xmlns:a="http://schemas.openxmlformats.org/drawingml/2006/main" l="0" t="0" r="0" b="0"/>
@@ -22555,7 +22547,7 @@
           <p:nvPr/>
         </p:nvPicPr>
         <p:blipFill rotWithShape="1">
-          <a:blip xmlns:r="http://schemas.openxmlformats.org/officeDocument/2006/relationships" xmlns:a="http://schemas.openxmlformats.org/drawingml/2006/main" r:embed="R18ea002da3574501">
+          <a:blip xmlns:r="http://schemas.openxmlformats.org/officeDocument/2006/relationships" xmlns:a="http://schemas.openxmlformats.org/drawingml/2006/main" r:embed="R69825bd9c9614397">
             <a:alphaModFix/>
           </a:blip>
           <a:srcRect xmlns:a="http://schemas.openxmlformats.org/drawingml/2006/main" l="0" t="0" r="0" b="0"/>
@@ -22583,7 +22575,7 @@
           <p:nvPr/>
         </p:nvPicPr>
         <p:blipFill rotWithShape="1">
-          <a:blip xmlns:r="http://schemas.openxmlformats.org/officeDocument/2006/relationships" xmlns:a="http://schemas.openxmlformats.org/drawingml/2006/main" r:embed="R18ea002da3574501">
+          <a:blip xmlns:r="http://schemas.openxmlformats.org/officeDocument/2006/relationships" xmlns:a="http://schemas.openxmlformats.org/drawingml/2006/main" r:embed="R69825bd9c9614397">
             <a:alphaModFix/>
           </a:blip>
           <a:srcRect xmlns:a="http://schemas.openxmlformats.org/drawingml/2006/main" l="0" t="0" r="0" b="0"/>
@@ -23013,7 +23005,7 @@
                 <a:ea typeface="Montserrat"/>
                 <a:cs typeface="Montserrat"/>
               </a:rPr>
-              <a:t>Edit, build, run</a:t>
+              <a:t>Step commands</a:t>
             </a:r>
           </a:p>
         </p:txBody>
@@ -23181,7 +23173,7 @@
                 <a:ea typeface="Inter"/>
                 <a:cs typeface="Inter"/>
               </a:rPr>
-              <a:t>Each numbered file is a snippet to paste into src/main.cpp.</a:t>
+              <a:t>Each script replaces main.cpp, rebuilds, and starts capture.</a:t>
             </a:r>
           </a:p>
           <a:p xmlns:a="http://schemas.openxmlformats.org/drawingml/2006/main">
@@ -23233,7 +23225,7 @@
                 <a:ea typeface="Inter"/>
                 <a:cs typeface="Inter"/>
               </a:rPr>
-              <a:t>The STEP comments mark its location.</a:t>
+              <a:t>Comment blocks mark what changed.</a:t>
             </a:r>
           </a:p>
           <a:p xmlns:a="http://schemas.openxmlformats.org/drawingml/2006/main">
@@ -23285,7 +23277,7 @@
                 <a:ea typeface="Inter"/>
                 <a:cs typeface="Inter"/>
               </a:rPr>
-              <a:t>After every edit, rebuild and run again.</a:t>
+              <a:t>Each step includes the earlier steps. You can rerun it or skip ahead.</a:t>
             </a:r>
           </a:p>
         </p:txBody>
@@ -23672,7 +23664,7 @@
                 <a:ea typeface="Roboto Mono"/>
                 <a:cs typeface="Roboto Mono"/>
               </a:rPr>
-              <a:t># View the snippet, then edit main.cpp</a:t>
+              <a:t># Run one step when we reach it</a:t>
             </a:r>
           </a:p>
           <a:p xmlns:a="http://schemas.openxmlformats.org/drawingml/2006/main">
@@ -23702,7 +23694,29 @@
                 <a:ea typeface="Roboto Mono"/>
                 <a:cs typeface="Roboto Mono"/>
               </a:rPr>
-              <a:t>cat snippets/01-read-events.cpp</a:t>
+              <a:t>bash steps/step-1.sh</a:t>
+            </a:r>
+          </a:p>
+          <a:p xmlns:a="http://schemas.openxmlformats.org/drawingml/2006/main">
+            <a:pPr marL="0" indent="0">
+              <a:spcBef>
+                <a:spcPts val="0"/>
+              </a:spcBef>
+              <a:spcAft>
+                <a:spcPts val="0"/>
+              </a:spcAft>
+              <a:buNone/>
+            </a:pPr>
+            <a:r>
+              <a:rPr sz="1350" b="0" i="0">
+                <a:solidFill>
+                  <a:srgbClr val="00E5FF"/>
+                </a:solidFill>
+                <a:latin typeface="Roboto Mono"/>
+                <a:ea typeface="Roboto Mono"/>
+                <a:cs typeface="Roboto Mono"/>
+              </a:rPr>
+              <a:t/>
             </a:r>
           </a:p>
           <a:p xmlns:a="http://schemas.openxmlformats.org/drawingml/2006/main">
@@ -23732,7 +23746,7 @@
                 <a:ea typeface="Roboto Mono"/>
                 <a:cs typeface="Roboto Mono"/>
               </a:rPr>
-              <a:t>nano src/main.cpp</a:t>
+              <a:t>bash steps/step-2.sh</a:t>
             </a:r>
           </a:p>
           <a:p xmlns:a="http://schemas.openxmlformats.org/drawingml/2006/main">
@@ -23784,7 +23798,29 @@
                 <a:ea typeface="Roboto Mono"/>
                 <a:cs typeface="Roboto Mono"/>
               </a:rPr>
-              <a:t># Rebuild after every change</a:t>
+              <a:t>bash steps/step-3.sh</a:t>
+            </a:r>
+          </a:p>
+          <a:p xmlns:a="http://schemas.openxmlformats.org/drawingml/2006/main">
+            <a:pPr marL="0" indent="0">
+              <a:spcBef>
+                <a:spcPts val="0"/>
+              </a:spcBef>
+              <a:spcAft>
+                <a:spcPts val="0"/>
+              </a:spcAft>
+              <a:buNone/>
+            </a:pPr>
+            <a:r>
+              <a:rPr sz="1350" b="0" i="0">
+                <a:solidFill>
+                  <a:srgbClr val="00E5FF"/>
+                </a:solidFill>
+                <a:latin typeface="Roboto Mono"/>
+                <a:ea typeface="Roboto Mono"/>
+                <a:cs typeface="Roboto Mono"/>
+              </a:rPr>
+              <a:t/>
             </a:r>
           </a:p>
           <a:p xmlns:a="http://schemas.openxmlformats.org/drawingml/2006/main">
@@ -23814,7 +23850,7 @@
                 <a:ea typeface="Roboto Mono"/>
                 <a:cs typeface="Roboto Mono"/>
               </a:rPr>
-              <a:t>cmake --build build \</a:t>
+              <a:t># View the resulting code anytime</a:t>
             </a:r>
           </a:p>
           <a:p xmlns:a="http://schemas.openxmlformats.org/drawingml/2006/main">
@@ -23844,59 +23880,7 @@
                 <a:ea typeface="Roboto Mono"/>
                 <a:cs typeface="Roboto Mono"/>
               </a:rPr>
-              <a:t>  --target workshop-agent -j 1</a:t>
-            </a:r>
-          </a:p>
-          <a:p xmlns:a="http://schemas.openxmlformats.org/drawingml/2006/main">
-            <a:pPr marL="0" indent="0">
-              <a:spcBef>
-                <a:spcPts val="0"/>
-              </a:spcBef>
-              <a:spcAft>
-                <a:spcPts val="0"/>
-              </a:spcAft>
-              <a:buNone/>
-            </a:pPr>
-            <a:r>
-              <a:rPr sz="1350" b="0" i="0">
-                <a:solidFill>
-                  <a:srgbClr val="00E5FF"/>
-                </a:solidFill>
-                <a:latin typeface="Roboto Mono"/>
-                <a:ea typeface="Roboto Mono"/>
-                <a:cs typeface="Roboto Mono"/>
-              </a:rPr>
-              <a:t/>
-            </a:r>
-          </a:p>
-          <a:p xmlns:a="http://schemas.openxmlformats.org/drawingml/2006/main">
-            <a:pPr marL="0" indent="0" algn="l">
-              <a:spcBef>
-                <a:spcPts val="0"/>
-              </a:spcBef>
-              <a:spcAft>
-                <a:spcPts val="0"/>
-              </a:spcAft>
-              <a:buNone/>
-              <a:defRPr sz="1350" b="0">
-                <a:solidFill>
-                  <a:srgbClr val="00E5FF"/>
-                </a:solidFill>
-                <a:latin typeface="Roboto Mono"/>
-                <a:ea typeface="Roboto Mono"/>
-                <a:cs typeface="Roboto Mono"/>
-              </a:defRPr>
-            </a:pPr>
-            <a:r>
-              <a:rPr sz="1350" b="0" i="0">
-                <a:solidFill>
-                  <a:srgbClr val="00E5FF"/>
-                </a:solidFill>
-                <a:latin typeface="Roboto Mono"/>
-                <a:ea typeface="Roboto Mono"/>
-                <a:cs typeface="Roboto Mono"/>
-              </a:rPr>
-              <a:t>sudo ./build/bin/workshop-agent</a:t>
+              <a:t>cat src/main.cpp</a:t>
             </a:r>
           </a:p>
         </p:txBody>
@@ -24546,7 +24530,7 @@
           <p:nvPr/>
         </p:nvPicPr>
         <p:blipFill rotWithShape="1">
-          <a:blip xmlns:r="http://schemas.openxmlformats.org/officeDocument/2006/relationships" xmlns:a="http://schemas.openxmlformats.org/drawingml/2006/main" r:embed="Re60e8251d44547e3">
+          <a:blip xmlns:r="http://schemas.openxmlformats.org/officeDocument/2006/relationships" xmlns:a="http://schemas.openxmlformats.org/drawingml/2006/main" r:embed="R42df99f778c84dff">
             <a:alphaModFix/>
           </a:blip>
           <a:srcRect xmlns:a="http://schemas.openxmlformats.org/drawingml/2006/main" l="0" t="0" r="0" b="0"/>
@@ -24574,7 +24558,7 @@
           <p:nvPr/>
         </p:nvPicPr>
         <p:blipFill rotWithShape="1">
-          <a:blip xmlns:r="http://schemas.openxmlformats.org/officeDocument/2006/relationships" xmlns:a="http://schemas.openxmlformats.org/drawingml/2006/main" r:embed="Re60e8251d44547e3">
+          <a:blip xmlns:r="http://schemas.openxmlformats.org/officeDocument/2006/relationships" xmlns:a="http://schemas.openxmlformats.org/drawingml/2006/main" r:embed="R42df99f778c84dff">
             <a:alphaModFix/>
           </a:blip>
           <a:srcRect xmlns:a="http://schemas.openxmlformats.org/drawingml/2006/main" l="0" t="0" r="0" b="0"/>
@@ -24602,7 +24586,7 @@
           <p:nvPr/>
         </p:nvPicPr>
         <p:blipFill rotWithShape="1">
-          <a:blip xmlns:r="http://schemas.openxmlformats.org/officeDocument/2006/relationships" xmlns:a="http://schemas.openxmlformats.org/drawingml/2006/main" r:embed="Re60e8251d44547e3">
+          <a:blip xmlns:r="http://schemas.openxmlformats.org/officeDocument/2006/relationships" xmlns:a="http://schemas.openxmlformats.org/drawingml/2006/main" r:embed="R42df99f778c84dff">
             <a:alphaModFix/>
           </a:blip>
           <a:srcRect xmlns:a="http://schemas.openxmlformats.org/drawingml/2006/main" l="0" t="0" r="0" b="0"/>
@@ -24630,7 +24614,7 @@
           <p:nvPr/>
         </p:nvPicPr>
         <p:blipFill rotWithShape="1">
-          <a:blip xmlns:r="http://schemas.openxmlformats.org/officeDocument/2006/relationships" xmlns:a="http://schemas.openxmlformats.org/drawingml/2006/main" r:embed="Re60e8251d44547e3">
+          <a:blip xmlns:r="http://schemas.openxmlformats.org/officeDocument/2006/relationships" xmlns:a="http://schemas.openxmlformats.org/drawingml/2006/main" r:embed="R42df99f778c84dff">
             <a:alphaModFix/>
           </a:blip>
           <a:srcRect xmlns:a="http://schemas.openxmlformats.org/drawingml/2006/main" l="0" t="0" r="0" b="0"/>
@@ -25228,7 +25212,59 @@
                 <a:ea typeface="Inter"/>
                 <a:cs typeface="Inter"/>
               </a:rPr>
-              <a:t>Replace the two lines inside STEP 1 with the entire first snippet.</a:t>
+              <a:t>Run bash steps/step-1.sh in A.</a:t>
+            </a:r>
+          </a:p>
+          <a:p xmlns:a="http://schemas.openxmlformats.org/drawingml/2006/main">
+            <a:pPr marL="0" indent="0">
+              <a:spcBef>
+                <a:spcPts val="0"/>
+              </a:spcBef>
+              <a:spcAft>
+                <a:spcPts val="0"/>
+              </a:spcAft>
+              <a:buNone/>
+            </a:pPr>
+            <a:r>
+              <a:rPr sz="1500" b="0" i="0">
+                <a:solidFill>
+                  <a:srgbClr val="4A5568"/>
+                </a:solidFill>
+                <a:latin typeface="Inter"/>
+                <a:ea typeface="Inter"/>
+                <a:cs typeface="Inter"/>
+              </a:rPr>
+              <a:t/>
+            </a:r>
+          </a:p>
+          <a:p xmlns:a="http://schemas.openxmlformats.org/drawingml/2006/main">
+            <a:pPr marL="0" indent="0" algn="l">
+              <a:spcBef>
+                <a:spcPts val="0"/>
+              </a:spcBef>
+              <a:spcAft>
+                <a:spcPts val="0"/>
+              </a:spcAft>
+              <a:buNone/>
+              <a:defRPr sz="1500" b="0">
+                <a:solidFill>
+                  <a:srgbClr val="4A5568"/>
+                </a:solidFill>
+                <a:latin typeface="Inter"/>
+                <a:ea typeface="Inter"/>
+                <a:cs typeface="Inter"/>
+              </a:defRPr>
+            </a:pPr>
+            <a:r>
+              <a:rPr sz="1500" b="0" i="0">
+                <a:solidFill>
+                  <a:srgbClr val="4A5568"/>
+                </a:solidFill>
+                <a:latin typeface="Inter"/>
+                <a:ea typeface="Inter"/>
+                <a:cs typeface="Inter"/>
+              </a:rPr>
+              <a:t>It adds the read loop and starts a ten-second capture.</a:t>
             </a:r>
           </a:p>
           <a:p xmlns:a="http://schemas.openxmlformats.org/drawingml/2006/main">
@@ -25283,58 +25319,6 @@
               <a:t>next() returns an event or a status.</a:t>
             </a:r>
           </a:p>
-          <a:p xmlns:a="http://schemas.openxmlformats.org/drawingml/2006/main">
-            <a:pPr marL="0" indent="0">
-              <a:spcBef>
-                <a:spcPts val="0"/>
-              </a:spcBef>
-              <a:spcAft>
-                <a:spcPts val="0"/>
-              </a:spcAft>
-              <a:buNone/>
-            </a:pPr>
-            <a:r>
-              <a:rPr sz="1500" b="0" i="0">
-                <a:solidFill>
-                  <a:srgbClr val="4A5568"/>
-                </a:solidFill>
-                <a:latin typeface="Inter"/>
-                <a:ea typeface="Inter"/>
-                <a:cs typeface="Inter"/>
-              </a:rPr>
-              <a:t/>
-            </a:r>
-          </a:p>
-          <a:p xmlns:a="http://schemas.openxmlformats.org/drawingml/2006/main">
-            <a:pPr marL="0" indent="0" algn="l">
-              <a:spcBef>
-                <a:spcPts val="0"/>
-              </a:spcBef>
-              <a:spcAft>
-                <a:spcPts val="0"/>
-              </a:spcAft>
-              <a:buNone/>
-              <a:defRPr sz="1500" b="0">
-                <a:solidFill>
-                  <a:srgbClr val="4A5568"/>
-                </a:solidFill>
-                <a:latin typeface="Inter"/>
-                <a:ea typeface="Inter"/>
-                <a:cs typeface="Inter"/>
-              </a:defRPr>
-            </a:pPr>
-            <a:r>
-              <a:rPr sz="1500" b="0" i="0">
-                <a:solidFill>
-                  <a:srgbClr val="4A5568"/>
-                </a:solidFill>
-                <a:latin typeface="Inter"/>
-                <a:ea typeface="Inter"/>
-                <a:cs typeface="Inter"/>
-              </a:rPr>
-              <a:t>Run for ten seconds, then stop.</a:t>
-            </a:r>
-          </a:p>
         </p:txBody>
       </p:sp>
       <p:sp>
@@ -25602,7 +25586,7 @@
                 <a:ea typeface="Roboto Mono"/>
                 <a:cs typeface="Roboto Mono"/>
               </a:rPr>
-              <a:t>snippets/01-read-events.cpp (first half)</a:t>
+              <a:t>Step 1: generated main.cpp (first half)</a:t>
             </a:r>
           </a:p>
         </p:txBody>
@@ -26609,7 +26593,7 @@
           <p:nvPr/>
         </p:nvPicPr>
         <p:blipFill rotWithShape="1">
-          <a:blip xmlns:r="http://schemas.openxmlformats.org/officeDocument/2006/relationships" xmlns:a="http://schemas.openxmlformats.org/drawingml/2006/main" r:embed="R15de43250081407b">
+          <a:blip xmlns:r="http://schemas.openxmlformats.org/officeDocument/2006/relationships" xmlns:a="http://schemas.openxmlformats.org/drawingml/2006/main" r:embed="R2b022930dbbd4bcd">
             <a:alphaModFix/>
           </a:blip>
           <a:srcRect xmlns:a="http://schemas.openxmlformats.org/drawingml/2006/main" l="0" t="0" r="0" b="0"/>
@@ -26637,7 +26621,7 @@
           <p:nvPr/>
         </p:nvPicPr>
         <p:blipFill rotWithShape="1">
-          <a:blip xmlns:r="http://schemas.openxmlformats.org/officeDocument/2006/relationships" xmlns:a="http://schemas.openxmlformats.org/drawingml/2006/main" r:embed="R15de43250081407b">
+          <a:blip xmlns:r="http://schemas.openxmlformats.org/officeDocument/2006/relationships" xmlns:a="http://schemas.openxmlformats.org/drawingml/2006/main" r:embed="R2b022930dbbd4bcd">
             <a:alphaModFix/>
           </a:blip>
           <a:srcRect xmlns:a="http://schemas.openxmlformats.org/drawingml/2006/main" l="0" t="0" r="0" b="0"/>
@@ -26665,7 +26649,7 @@
           <p:nvPr/>
         </p:nvPicPr>
         <p:blipFill rotWithShape="1">
-          <a:blip xmlns:r="http://schemas.openxmlformats.org/officeDocument/2006/relationships" xmlns:a="http://schemas.openxmlformats.org/drawingml/2006/main" r:embed="R15de43250081407b">
+          <a:blip xmlns:r="http://schemas.openxmlformats.org/officeDocument/2006/relationships" xmlns:a="http://schemas.openxmlformats.org/drawingml/2006/main" r:embed="R2b022930dbbd4bcd">
             <a:alphaModFix/>
           </a:blip>
           <a:srcRect xmlns:a="http://schemas.openxmlformats.org/drawingml/2006/main" l="0" t="0" r="0" b="0"/>
@@ -26693,7 +26677,7 @@
           <p:nvPr/>
         </p:nvPicPr>
         <p:blipFill rotWithShape="1">
-          <a:blip xmlns:r="http://schemas.openxmlformats.org/officeDocument/2006/relationships" xmlns:a="http://schemas.openxmlformats.org/drawingml/2006/main" r:embed="R15de43250081407b">
+          <a:blip xmlns:r="http://schemas.openxmlformats.org/officeDocument/2006/relationships" xmlns:a="http://schemas.openxmlformats.org/drawingml/2006/main" r:embed="R2b022930dbbd4bcd">
             <a:alphaModFix/>
           </a:blip>
           <a:srcRect xmlns:a="http://schemas.openxmlformats.org/drawingml/2006/main" l="0" t="0" r="0" b="0"/>
@@ -27395,7 +27379,7 @@
                 <a:ea typeface="Inter"/>
                 <a:cs typeface="Inter"/>
               </a:rPr>
-              <a:t>Rebuild and run. The event count varies with VM activity.</a:t>
+              <a:t>The script prints the count when capture ends. It varies with VM activity.</a:t>
             </a:r>
           </a:p>
         </p:txBody>
@@ -27665,7 +27649,7 @@
                 <a:ea typeface="Roboto Mono"/>
                 <a:cs typeface="Roboto Mono"/>
               </a:rPr>
-              <a:t>snippets/01-read-events.cpp (continued)</a:t>
+              <a:t>Step 1: generated main.cpp (continued)</a:t>
             </a:r>
           </a:p>
         </p:txBody>
@@ -28822,7 +28806,7 @@
           <p:nvPr/>
         </p:nvPicPr>
         <p:blipFill rotWithShape="1">
-          <a:blip xmlns:r="http://schemas.openxmlformats.org/officeDocument/2006/relationships" xmlns:a="http://schemas.openxmlformats.org/drawingml/2006/main" r:embed="Rdafb1ccecef84d86">
+          <a:blip xmlns:r="http://schemas.openxmlformats.org/officeDocument/2006/relationships" xmlns:a="http://schemas.openxmlformats.org/drawingml/2006/main" r:embed="R283b331cd9a04a82">
             <a:alphaModFix/>
           </a:blip>
           <a:srcRect xmlns:a="http://schemas.openxmlformats.org/drawingml/2006/main" l="0" t="0" r="0" b="0"/>
@@ -28850,7 +28834,7 @@
           <p:nvPr/>
         </p:nvPicPr>
         <p:blipFill rotWithShape="1">
-          <a:blip xmlns:r="http://schemas.openxmlformats.org/officeDocument/2006/relationships" xmlns:a="http://schemas.openxmlformats.org/drawingml/2006/main" r:embed="Rdafb1ccecef84d86">
+          <a:blip xmlns:r="http://schemas.openxmlformats.org/officeDocument/2006/relationships" xmlns:a="http://schemas.openxmlformats.org/drawingml/2006/main" r:embed="R283b331cd9a04a82">
             <a:alphaModFix/>
           </a:blip>
           <a:srcRect xmlns:a="http://schemas.openxmlformats.org/drawingml/2006/main" l="0" t="0" r="0" b="0"/>
@@ -28878,7 +28862,7 @@
           <p:nvPr/>
         </p:nvPicPr>
         <p:blipFill rotWithShape="1">
-          <a:blip xmlns:r="http://schemas.openxmlformats.org/officeDocument/2006/relationships" xmlns:a="http://schemas.openxmlformats.org/drawingml/2006/main" r:embed="Rdafb1ccecef84d86">
+          <a:blip xmlns:r="http://schemas.openxmlformats.org/officeDocument/2006/relationships" xmlns:a="http://schemas.openxmlformats.org/drawingml/2006/main" r:embed="R283b331cd9a04a82">
             <a:alphaModFix/>
           </a:blip>
           <a:srcRect xmlns:a="http://schemas.openxmlformats.org/drawingml/2006/main" l="0" t="0" r="0" b="0"/>
@@ -28906,7 +28890,7 @@
           <p:nvPr/>
         </p:nvPicPr>
         <p:blipFill rotWithShape="1">
-          <a:blip xmlns:r="http://schemas.openxmlformats.org/officeDocument/2006/relationships" xmlns:a="http://schemas.openxmlformats.org/drawingml/2006/main" r:embed="Rdafb1ccecef84d86">
+          <a:blip xmlns:r="http://schemas.openxmlformats.org/officeDocument/2006/relationships" xmlns:a="http://schemas.openxmlformats.org/drawingml/2006/main" r:embed="R283b331cd9a04a82">
             <a:alphaModFix/>
           </a:blip>
           <a:srcRect xmlns:a="http://schemas.openxmlformats.org/drawingml/2006/main" l="0" t="0" r="0" b="0"/>
@@ -29504,7 +29488,7 @@
                 <a:ea typeface="Inter"/>
                 <a:cs typeface="Inter"/>
               </a:rPr>
-              <a:t>Paste snippet 02 at STEP 2, before open_modern_bpf().</a:t>
+              <a:t>Run bash steps/step-2.sh in A.</a:t>
             </a:r>
           </a:p>
           <a:p xmlns:a="http://schemas.openxmlformats.org/drawingml/2006/main">
@@ -29556,7 +29540,7 @@
                 <a:ea typeface="Inter"/>
                 <a:cs typeface="Inter"/>
               </a:rPr>
-              <a:t>Rebuild and run in A. Run id in B during capture.</a:t>
+              <a:t>The script adds this filter before opening capture. Run id in B.</a:t>
             </a:r>
           </a:p>
           <a:p xmlns:a="http://schemas.openxmlformats.org/drawingml/2006/main">
@@ -29878,7 +29862,7 @@
                 <a:ea typeface="Roboto Mono"/>
                 <a:cs typeface="Roboto Mono"/>
               </a:rPr>
-              <a:t>snippets/02-filter-execs.cpp</a:t>
+              <a:t>Step 2: filter added to main.cpp</a:t>
             </a:r>
           </a:p>
         </p:txBody>
@@ -30787,7 +30771,7 @@
           <p:nvPr/>
         </p:nvPicPr>
         <p:blipFill rotWithShape="1">
-          <a:blip xmlns:r="http://schemas.openxmlformats.org/officeDocument/2006/relationships" xmlns:a="http://schemas.openxmlformats.org/drawingml/2006/main" r:embed="Rc041e55ff5854b3d">
+          <a:blip xmlns:r="http://schemas.openxmlformats.org/officeDocument/2006/relationships" xmlns:a="http://schemas.openxmlformats.org/drawingml/2006/main" r:embed="R07ce3871c4374989">
             <a:alphaModFix/>
           </a:blip>
           <a:srcRect xmlns:a="http://schemas.openxmlformats.org/drawingml/2006/main" l="0" t="0" r="0" b="0"/>
@@ -30815,7 +30799,7 @@
           <p:nvPr/>
         </p:nvPicPr>
         <p:blipFill rotWithShape="1">
-          <a:blip xmlns:r="http://schemas.openxmlformats.org/officeDocument/2006/relationships" xmlns:a="http://schemas.openxmlformats.org/drawingml/2006/main" r:embed="Rc041e55ff5854b3d">
+          <a:blip xmlns:r="http://schemas.openxmlformats.org/officeDocument/2006/relationships" xmlns:a="http://schemas.openxmlformats.org/drawingml/2006/main" r:embed="R07ce3871c4374989">
             <a:alphaModFix/>
           </a:blip>
           <a:srcRect xmlns:a="http://schemas.openxmlformats.org/drawingml/2006/main" l="0" t="0" r="0" b="0"/>
@@ -30843,7 +30827,7 @@
           <p:nvPr/>
         </p:nvPicPr>
         <p:blipFill rotWithShape="1">
-          <a:blip xmlns:r="http://schemas.openxmlformats.org/officeDocument/2006/relationships" xmlns:a="http://schemas.openxmlformats.org/drawingml/2006/main" r:embed="Rc041e55ff5854b3d">
+          <a:blip xmlns:r="http://schemas.openxmlformats.org/officeDocument/2006/relationships" xmlns:a="http://schemas.openxmlformats.org/drawingml/2006/main" r:embed="R07ce3871c4374989">
             <a:alphaModFix/>
           </a:blip>
           <a:srcRect xmlns:a="http://schemas.openxmlformats.org/drawingml/2006/main" l="0" t="0" r="0" b="0"/>
@@ -30871,7 +30855,7 @@
           <p:nvPr/>
         </p:nvPicPr>
         <p:blipFill rotWithShape="1">
-          <a:blip xmlns:r="http://schemas.openxmlformats.org/officeDocument/2006/relationships" xmlns:a="http://schemas.openxmlformats.org/drawingml/2006/main" r:embed="Rc041e55ff5854b3d">
+          <a:blip xmlns:r="http://schemas.openxmlformats.org/officeDocument/2006/relationships" xmlns:a="http://schemas.openxmlformats.org/drawingml/2006/main" r:embed="R07ce3871c4374989">
             <a:alphaModFix/>
           </a:blip>
           <a:srcRect xmlns:a="http://schemas.openxmlformats.org/drawingml/2006/main" l="0" t="0" r="0" b="0"/>

</xml_diff>

<commit_message>
Teach source creation as step 1 and renumber collector stages
</commit_message>
<xml_diff>
--- a/presentation/falco-libs-intro.pptx
+++ b/presentation/falco-libs-intro.pptx
@@ -2,78 +2,78 @@
 <file path=ppt/presentation.xml><?xml version="1.0" encoding="utf-8"?>
 <p:presentation xmlns:p="http://schemas.openxmlformats.org/presentationml/2006/main" embedTrueTypeFonts="1" saveSubsetFonts="0">
   <p:sldMasterIdLst>
-    <p:sldMasterId xmlns:r="http://schemas.openxmlformats.org/officeDocument/2006/relationships" id="2147483648" r:id="R0cf0ccbdb5734b33"/>
-    <p:sldMasterId xmlns:r="http://schemas.openxmlformats.org/officeDocument/2006/relationships" id="2147483661" r:id="Rde9ac0e24373468a"/>
+    <p:sldMasterId xmlns:r="http://schemas.openxmlformats.org/officeDocument/2006/relationships" id="2147483648" r:id="R1a74041c82b04bff"/>
+    <p:sldMasterId xmlns:r="http://schemas.openxmlformats.org/officeDocument/2006/relationships" id="2147483661" r:id="Rfd454f2858564707"/>
   </p:sldMasterIdLst>
   <p:notesMasterIdLst>
-    <p:notesMasterId xmlns:r="http://schemas.openxmlformats.org/officeDocument/2006/relationships" r:id="R5100ee2cb42e4ab6"/>
+    <p:notesMasterId xmlns:r="http://schemas.openxmlformats.org/officeDocument/2006/relationships" r:id="R77138ea446ff4fc6"/>
   </p:notesMasterIdLst>
   <p:sldIdLst>
-    <p:sldId xmlns:r="http://schemas.openxmlformats.org/officeDocument/2006/relationships" id="256" r:id="Rce63cb6e59d94a36"/>
-    <p:sldId xmlns:r="http://schemas.openxmlformats.org/officeDocument/2006/relationships" id="257" r:id="R9eca07538e9146e1"/>
-    <p:sldId xmlns:r="http://schemas.openxmlformats.org/officeDocument/2006/relationships" id="258" r:id="R34bb19dbd45a4bfe"/>
-    <p:sldId xmlns:r="http://schemas.openxmlformats.org/officeDocument/2006/relationships" id="259" r:id="Rd4028b1828d74881"/>
-    <p:sldId xmlns:r="http://schemas.openxmlformats.org/officeDocument/2006/relationships" id="260" r:id="R1f772d8b2c534df1"/>
-    <p:sldId xmlns:r="http://schemas.openxmlformats.org/officeDocument/2006/relationships" id="261" r:id="Rcaad99c211e9496a"/>
-    <p:sldId xmlns:r="http://schemas.openxmlformats.org/officeDocument/2006/relationships" id="262" r:id="R652719b50dc04442"/>
-    <p:sldId xmlns:r="http://schemas.openxmlformats.org/officeDocument/2006/relationships" id="263" r:id="R9562cd40aeb34c3d"/>
-    <p:sldId xmlns:r="http://schemas.openxmlformats.org/officeDocument/2006/relationships" id="264" r:id="Ree29a836fb734215"/>
-    <p:sldId xmlns:r="http://schemas.openxmlformats.org/officeDocument/2006/relationships" id="265" r:id="R268ef9318abf4cf6"/>
-    <p:sldId xmlns:r="http://schemas.openxmlformats.org/officeDocument/2006/relationships" id="266" r:id="Re37e6beee0d64c4a"/>
-    <p:sldId xmlns:r="http://schemas.openxmlformats.org/officeDocument/2006/relationships" id="267" r:id="R6ecfb45007bf4046"/>
-    <p:sldId xmlns:r="http://schemas.openxmlformats.org/officeDocument/2006/relationships" id="268" r:id="Rc998883555df412f"/>
-    <p:sldId xmlns:r="http://schemas.openxmlformats.org/officeDocument/2006/relationships" id="269" r:id="R693b82a8c9034263"/>
+    <p:sldId xmlns:r="http://schemas.openxmlformats.org/officeDocument/2006/relationships" id="256" r:id="R123442ac5ed14fd4"/>
+    <p:sldId xmlns:r="http://schemas.openxmlformats.org/officeDocument/2006/relationships" id="257" r:id="R3abdf1d23abf4110"/>
+    <p:sldId xmlns:r="http://schemas.openxmlformats.org/officeDocument/2006/relationships" id="258" r:id="R54a9786f950048d7"/>
+    <p:sldId xmlns:r="http://schemas.openxmlformats.org/officeDocument/2006/relationships" id="259" r:id="R65330656e42f4a7c"/>
+    <p:sldId xmlns:r="http://schemas.openxmlformats.org/officeDocument/2006/relationships" id="260" r:id="R789069fe78084e15"/>
+    <p:sldId xmlns:r="http://schemas.openxmlformats.org/officeDocument/2006/relationships" id="261" r:id="R8d1c9e67263c43fc"/>
+    <p:sldId xmlns:r="http://schemas.openxmlformats.org/officeDocument/2006/relationships" id="262" r:id="R2347659f600f4d69"/>
+    <p:sldId xmlns:r="http://schemas.openxmlformats.org/officeDocument/2006/relationships" id="263" r:id="Raf8b46cb40a646e2"/>
+    <p:sldId xmlns:r="http://schemas.openxmlformats.org/officeDocument/2006/relationships" id="264" r:id="R9df0a48163bc4cb1"/>
+    <p:sldId xmlns:r="http://schemas.openxmlformats.org/officeDocument/2006/relationships" id="265" r:id="R42804f201269452a"/>
+    <p:sldId xmlns:r="http://schemas.openxmlformats.org/officeDocument/2006/relationships" id="266" r:id="Rfb17d82f59174cd1"/>
+    <p:sldId xmlns:r="http://schemas.openxmlformats.org/officeDocument/2006/relationships" id="267" r:id="R58f97af4d7674a81"/>
+    <p:sldId xmlns:r="http://schemas.openxmlformats.org/officeDocument/2006/relationships" id="268" r:id="R5d15564073af4544"/>
+    <p:sldId xmlns:r="http://schemas.openxmlformats.org/officeDocument/2006/relationships" id="269" r:id="Rfed72b8f603c4224"/>
   </p:sldIdLst>
   <p:sldSz cx="9144000" cy="5143500"/>
   <p:notesSz cx="6858000" cy="9144000"/>
   <p:embeddedFontLst>
     <p:embeddedFont>
       <p:font typeface="Roboto Mono Medium"/>
-      <p:regular xmlns:r="http://schemas.openxmlformats.org/officeDocument/2006/relationships" r:id="R529de12c09264b4f"/>
-      <p:bold xmlns:r="http://schemas.openxmlformats.org/officeDocument/2006/relationships" r:id="Rc6fe1a57964b4986"/>
-      <p:italic xmlns:r="http://schemas.openxmlformats.org/officeDocument/2006/relationships" r:id="R951de331aa43409f"/>
-      <p:boldItalic xmlns:r="http://schemas.openxmlformats.org/officeDocument/2006/relationships" r:id="R3fe5b44032214e4a"/>
+      <p:regular xmlns:r="http://schemas.openxmlformats.org/officeDocument/2006/relationships" r:id="R159fd1757c964a9d"/>
+      <p:bold xmlns:r="http://schemas.openxmlformats.org/officeDocument/2006/relationships" r:id="R3333c45f01094e72"/>
+      <p:italic xmlns:r="http://schemas.openxmlformats.org/officeDocument/2006/relationships" r:id="Rbc5cc931275c46ae"/>
+      <p:boldItalic xmlns:r="http://schemas.openxmlformats.org/officeDocument/2006/relationships" r:id="R25018da0979e41f6"/>
     </p:embeddedFont>
     <p:embeddedFont>
       <p:font typeface="Inter SemiBold"/>
-      <p:regular xmlns:r="http://schemas.openxmlformats.org/officeDocument/2006/relationships" r:id="R6377bed165e74bec"/>
-      <p:bold xmlns:r="http://schemas.openxmlformats.org/officeDocument/2006/relationships" r:id="R345c868d4eec4461"/>
-      <p:italic xmlns:r="http://schemas.openxmlformats.org/officeDocument/2006/relationships" r:id="Rcefcb07132f44311"/>
-      <p:boldItalic xmlns:r="http://schemas.openxmlformats.org/officeDocument/2006/relationships" r:id="Rcfcfee655c854bd6"/>
+      <p:regular xmlns:r="http://schemas.openxmlformats.org/officeDocument/2006/relationships" r:id="R36fc131abdb9407e"/>
+      <p:bold xmlns:r="http://schemas.openxmlformats.org/officeDocument/2006/relationships" r:id="R50c03a2e79c44929"/>
+      <p:italic xmlns:r="http://schemas.openxmlformats.org/officeDocument/2006/relationships" r:id="R7885fcf086f048f3"/>
+      <p:boldItalic xmlns:r="http://schemas.openxmlformats.org/officeDocument/2006/relationships" r:id="R22ea339a9e994cc7"/>
     </p:embeddedFont>
     <p:embeddedFont>
       <p:font typeface="Montserrat Black"/>
-      <p:bold xmlns:r="http://schemas.openxmlformats.org/officeDocument/2006/relationships" r:id="Ra36e3f84b8ef4561"/>
-      <p:boldItalic xmlns:r="http://schemas.openxmlformats.org/officeDocument/2006/relationships" r:id="R6b75c632471f48c2"/>
+      <p:bold xmlns:r="http://schemas.openxmlformats.org/officeDocument/2006/relationships" r:id="R6e745717fbcf48c0"/>
+      <p:boldItalic xmlns:r="http://schemas.openxmlformats.org/officeDocument/2006/relationships" r:id="Re371eb8183ef40a7"/>
     </p:embeddedFont>
     <p:embeddedFont>
       <p:font typeface="Montserrat"/>
-      <p:bold xmlns:r="http://schemas.openxmlformats.org/officeDocument/2006/relationships" r:id="Reb771964796049fe"/>
-      <p:boldItalic xmlns:r="http://schemas.openxmlformats.org/officeDocument/2006/relationships" r:id="R0cd14b0bb30641df"/>
+      <p:bold xmlns:r="http://schemas.openxmlformats.org/officeDocument/2006/relationships" r:id="R99abc8a758b84c7a"/>
+      <p:boldItalic xmlns:r="http://schemas.openxmlformats.org/officeDocument/2006/relationships" r:id="R58c3adf13597472c"/>
     </p:embeddedFont>
     <p:embeddedFont>
       <p:font typeface="Inter"/>
-      <p:regular xmlns:r="http://schemas.openxmlformats.org/officeDocument/2006/relationships" r:id="R7fb9fe4512a14fcb"/>
-      <p:bold xmlns:r="http://schemas.openxmlformats.org/officeDocument/2006/relationships" r:id="R89393affc96c4669"/>
-      <p:italic xmlns:r="http://schemas.openxmlformats.org/officeDocument/2006/relationships" r:id="Rd5f1f1f287084e37"/>
-      <p:boldItalic xmlns:r="http://schemas.openxmlformats.org/officeDocument/2006/relationships" r:id="Rc6aa35d45115468d"/>
+      <p:regular xmlns:r="http://schemas.openxmlformats.org/officeDocument/2006/relationships" r:id="R2e2fe00560b34acd"/>
+      <p:bold xmlns:r="http://schemas.openxmlformats.org/officeDocument/2006/relationships" r:id="R539f7204d7d34c44"/>
+      <p:italic xmlns:r="http://schemas.openxmlformats.org/officeDocument/2006/relationships" r:id="R3135c6421d9e478e"/>
+      <p:boldItalic xmlns:r="http://schemas.openxmlformats.org/officeDocument/2006/relationships" r:id="R576b1dc01d354147"/>
     </p:embeddedFont>
     <p:embeddedFont>
       <p:font typeface="Montserrat ExtraBold"/>
-      <p:bold xmlns:r="http://schemas.openxmlformats.org/officeDocument/2006/relationships" r:id="R8ffc088a6bbd43b4"/>
-      <p:boldItalic xmlns:r="http://schemas.openxmlformats.org/officeDocument/2006/relationships" r:id="Rc46bd2fbbde74adf"/>
+      <p:bold xmlns:r="http://schemas.openxmlformats.org/officeDocument/2006/relationships" r:id="Re2039992fe8741c5"/>
+      <p:boldItalic xmlns:r="http://schemas.openxmlformats.org/officeDocument/2006/relationships" r:id="R54a462cb1ee740c9"/>
     </p:embeddedFont>
     <p:embeddedFont>
       <p:font typeface="Roboto Mono"/>
-      <p:bold xmlns:r="http://schemas.openxmlformats.org/officeDocument/2006/relationships" r:id="R87c0c40e97dc4fc5"/>
-      <p:boldItalic xmlns:r="http://schemas.openxmlformats.org/officeDocument/2006/relationships" r:id="Rf7905a6b613e4345"/>
+      <p:bold xmlns:r="http://schemas.openxmlformats.org/officeDocument/2006/relationships" r:id="R23432d4e7a3147bb"/>
+      <p:boldItalic xmlns:r="http://schemas.openxmlformats.org/officeDocument/2006/relationships" r:id="Rea46297634914cd0"/>
     </p:embeddedFont>
     <p:embeddedFont>
       <p:font typeface="Inter Medium"/>
-      <p:regular xmlns:r="http://schemas.openxmlformats.org/officeDocument/2006/relationships" r:id="R152f9c3febe8474f"/>
-      <p:bold xmlns:r="http://schemas.openxmlformats.org/officeDocument/2006/relationships" r:id="Rf61ef535a271416e"/>
-      <p:italic xmlns:r="http://schemas.openxmlformats.org/officeDocument/2006/relationships" r:id="R6a2682c72338416e"/>
-      <p:boldItalic xmlns:r="http://schemas.openxmlformats.org/officeDocument/2006/relationships" r:id="R16d7f8f3455a4e18"/>
+      <p:regular xmlns:r="http://schemas.openxmlformats.org/officeDocument/2006/relationships" r:id="Rb507909efdea4083"/>
+      <p:bold xmlns:r="http://schemas.openxmlformats.org/officeDocument/2006/relationships" r:id="R0de15c14218e40c5"/>
+      <p:italic xmlns:r="http://schemas.openxmlformats.org/officeDocument/2006/relationships" r:id="R0bd916fd9df24da5"/>
+      <p:boldItalic xmlns:r="http://schemas.openxmlformats.org/officeDocument/2006/relationships" r:id="R80a65d413215445b"/>
     </p:embeddedFont>
   </p:embeddedFontLst>
 </p:presentation>
@@ -618,7 +618,7 @@
               <a:buNone/>
             </a:pPr>
             <a:r>
-              <a:t>This continues the code installed by step 1. The count is events delivered successfully to this application, not a count of all syscalls on the machine. This first unfiltered run sees background activity. Run /usr/bin/id in terminal B if desired. SCAP_EOF is included for correct status handling; a live stream normally ends because the ten-second deadline expires. Source: https://github.com/falcosecurity/libs/blob/e72873882967cdd86b8753eca09ea3e9f91ccd4a/userspace/libsinsp/sinsp.h</a:t>
+              <a:t>This continues the code installed by step 2. The count is events delivered successfully to this application, not a count of all syscalls on the machine. This first unfiltered run sees background activity. Run /usr/bin/id in terminal B if desired. SCAP_EOF is included for correct status handling; a live stream normally ends because the ten-second deadline expires. Source: https://github.com/falcosecurity/libs/blob/e72873882967cdd86b8753eca09ea3e9f91ccd4a/userspace/libsinsp/sinsp.h</a:t>
             </a:r>
             <a:endParaRPr/>
           </a:p>
@@ -858,7 +858,7 @@
               <a:buNone/>
             </a:pPr>
             <a:r>
-              <a:t>The output is illustrative, not a promise of one event. Step 3 includes all previous additions and works without running steps 1 and 2 first. It overwrites main.cpp, rebuilds, and starts capture. Process execution exit events can include failed calls; this workshop does not add success-only conditions or detection logic.</a:t>
+              <a:t>The output is illustrative, not a promise of one event. Step 4 includes all previous additions and works without running steps 1 and 2 first. It overwrites main.cpp, rebuilds, and starts capture. Process execution exit events can include failed calls; this workshop does not add success-only conditions or detection logic.</a:t>
             </a:r>
             <a:endParaRPr/>
           </a:p>
@@ -938,7 +938,7 @@
               <a:buNone/>
             </a:pPr>
             <a:r>
-              <a:t>Troubleshooting: run the collector with sudo inside Ubuntu. If build/bin/workshop-agent does not exist, rerun the host setup script. It preserves existing source edits. If Multipass commands are missing immediately after installation, reopen the host terminal. Setup waits for the Ubuntu image catalog before launch. Windows setup has not been rehearsed here. Code and step scripts: https://github.com/julianshalaby-perj/falco-libs-workshop</a:t>
+              <a:t>Troubleshooting: run the collector with sudo inside Ubuntu. Setup prepares the libraries. The numbered scripts create and build the collector. Rerun the desired step if its binary is missing. If Multipass commands are missing immediately after installation, reopen the host terminal. Setup waits for the Ubuntu image catalog before launch. Windows setup has not been rehearsed here. Code and step scripts: https://github.com/julianshalaby-perj/falco-libs-workshop</a:t>
             </a:r>
             <a:endParaRPr/>
           </a:p>
@@ -1098,7 +1098,7 @@
               <a:buNone/>
             </a:pPr>
             <a:r>
-              <a:t>Optional Mac setup. Run only your platform’s setup script. It offers to install Multipass, creates Ubuntu 24.04, copies the starter, installs dependencies, and builds the starter. Approve the installer administrator prompt. After setup, keep terminal A on the host to run the platform step scripts. Open terminal B inside Ubuntu. Complete the first build before the workshop if possible. Sources: https://github.com/canonical/multipass/releases/tag/v1.16.4 and https://github.com/julianshalaby-perj/falco-libs-workshop</a:t>
+              <a:t>Optional Mac setup. Run only your platform’s setup script. It offers to install Multipass, creates Ubuntu 24.04, installs dependencies, and builds the Falco libraries. It creates no collector source files. Step 1 creates them. Approve the installer administrator prompt. After setup, keep terminal A on the host to run the platform step scripts. Open terminal B inside Ubuntu. Complete the first build before the workshop if possible. Sources: https://github.com/canonical/multipass/releases/tag/v1.16.4 and https://github.com/julianshalaby-perj/falco-libs-workshop</a:t>
             </a:r>
             <a:endParaRPr/>
           </a:p>
@@ -1178,7 +1178,7 @@
               <a:buNone/>
             </a:pPr>
             <a:r>
-              <a:t>Optional Windows setup. Run only your platform’s setup script. It offers to install Multipass, creates Ubuntu 24.04, copies the starter, installs dependencies, and builds the starter. Approve the installer administrator prompt. If Windows requests a restart, reboot and rerun the command. After setup, keep terminal A on the host to run the platform step scripts. Open terminal B inside Ubuntu. Complete the first build before the workshop if possible. Sources: https://github.com/canonical/multipass/releases/tag/v1.16.4 and https://github.com/julianshalaby-perj/falco-libs-workshop</a:t>
+              <a:t>Optional Windows setup. Run only your platform’s setup script. It offers to install Multipass, creates Ubuntu 24.04, installs dependencies, and builds the Falco libraries. It creates no collector source files. Step 1 creates them. Approve the installer administrator prompt. If Windows requests a restart, reboot and rerun the command. After setup, keep terminal A on the host to run the platform step scripts. Open terminal B inside Ubuntu. Complete the first build before the workshop if possible. Sources: https://github.com/canonical/multipass/releases/tag/v1.16.4 and https://github.com/julianshalaby-perj/falco-libs-workshop</a:t>
             </a:r>
             <a:endParaRPr/>
           </a:p>
@@ -1258,7 +1258,7 @@
               <a:buNone/>
             </a:pPr>
             <a:r>
-              <a:t>Terminal A stays on the host. Each platform step script sends its embedded source into the VM, builds it, and runs the collector there. Terminal B stays inside Ubuntu. All monitoring happens inside the VM.</a:t>
+              <a:t>Terminal A stays on the host. Each platform step script creates the source files locally, copies them into the VM, builds them, and runs the collector there. Terminal B stays inside Ubuntu. All monitoring happens inside the VM.</a:t>
             </a:r>
             <a:endParaRPr/>
           </a:p>
@@ -1338,7 +1338,7 @@
               <a:buNone/>
             </a:pPr>
             <a:r>
-              <a:t>This is an excerpt of the starter. The actual status line says Attached to the Ubuntu kernel. A successful open/start is what demonstrates attachment. Keep this first run brief: no next() loop drains the buffers yet. Press Enter for a clean stop. Source: https://github.com/falcosecurity/libs/blob/e72873882967cdd86b8753eca09ea3e9f91ccd4a/userspace/libsinsp/sinsp.h</a:t>
+              <a:t>Run from the Mac repo folder in terminal A, one step at a time. Each script writes src/main.cpp and src/CMakeLists.txt locally, copies them to Ubuntu, and builds and runs the application. Step 1 attaches and stops immediately. Steps 2 through 4 capture for ten seconds. Comment blocks mark additions. Existing edits to these two files are overwritten locally and in the VM. Steps include all earlier changes and can be rerun or skipped. During steps 2 through 4, run /usr/bin/id in VM terminal B after Attached appears in A.</a:t>
             </a:r>
             <a:endParaRPr/>
           </a:p>
@@ -1418,7 +1418,7 @@
               <a:buNone/>
             </a:pPr>
             <a:r>
-              <a:t>Run from the Mac repo folder in terminal A, one step at a time. Each script replaces src/main.cpp inside Ubuntu with the complete next version, rebuilds the application, and captures for ten seconds. Comment blocks mark additions. Existing edits to the VM source are overwritten. The host starter source stays unchanged. Steps include all earlier changes and can be rerun or skipped. Run /usr/bin/id in VM terminal B after Attached appears in A.</a:t>
+              <a:t>Run from the Windows repo folder in terminal A, one step at a time. Each script writes src/main.cpp and src/CMakeLists.txt locally, copies them to Ubuntu, and builds and runs the application. Step 1 attaches and stops immediately. Steps 2 through 4 capture for ten seconds. Comment blocks mark additions. Existing edits to these two files are overwritten locally and in the VM. Steps include all earlier changes and can be rerun or skipped. During steps 2 through 4, run /usr/bin/id in VM terminal B after Attached appears in A.</a:t>
             </a:r>
             <a:endParaRPr/>
           </a:p>
@@ -1498,7 +1498,7 @@
               <a:buNone/>
             </a:pPr>
             <a:r>
-              <a:t>Run from the Windows repo folder in terminal A, one step at a time. Each script replaces src/main.cpp inside Ubuntu with the complete next version, rebuilds the application, and captures for ten seconds. Comment blocks mark additions. Existing edits to the VM source are overwritten. The host starter source stays unchanged. Steps include all earlier changes and can be rerun or skipped. Run /usr/bin/id in VM terminal B after Attached appears in A.</a:t>
+              <a:t>The repository begins without collector source files. Step 1 creates the source directory and both files locally and copies them into Ubuntu. The full CMake file also sets C++17 and the output directory. The full main function handles exceptions and prints Attached to the Ubuntu kernel, then Capture stopped. No waiting for Enter or manual source editing is needed. The script runs the collector automatically. Source: https://github.com/falcosecurity/libs/blob/e72873882967cdd86b8753eca09ea3e9f91ccd4a/userspace/libsinsp/sinsp.h</a:t>
             </a:r>
             <a:endParaRPr/>
           </a:p>
@@ -5746,18 +5746,18 @@
   </p:cSld>
   <p:clrMap bg1="lt1" tx1="dk1" bg2="dk2" tx2="lt2" accent1="accent1" accent2="accent2" accent3="accent3" accent4="accent4" accent5="accent5" accent6="accent6" hlink="hlink" folHlink="folHlink"/>
   <p:sldLayoutIdLst>
-    <p:sldLayoutId xmlns:r="http://schemas.openxmlformats.org/officeDocument/2006/relationships" id="2147483649" r:id="R903267fce3224848"/>
-    <p:sldLayoutId xmlns:r="http://schemas.openxmlformats.org/officeDocument/2006/relationships" id="2147483650" r:id="R9565726b043147ff"/>
-    <p:sldLayoutId xmlns:r="http://schemas.openxmlformats.org/officeDocument/2006/relationships" id="2147483651" r:id="R4026b502f5374a95"/>
-    <p:sldLayoutId xmlns:r="http://schemas.openxmlformats.org/officeDocument/2006/relationships" id="2147483652" r:id="R36227e9527494989"/>
-    <p:sldLayoutId xmlns:r="http://schemas.openxmlformats.org/officeDocument/2006/relationships" id="2147483653" r:id="R15c93e57a5a640cd"/>
-    <p:sldLayoutId xmlns:r="http://schemas.openxmlformats.org/officeDocument/2006/relationships" id="2147483654" r:id="R374be7eafb344507"/>
-    <p:sldLayoutId xmlns:r="http://schemas.openxmlformats.org/officeDocument/2006/relationships" id="2147483655" r:id="R8577294423af43bb"/>
-    <p:sldLayoutId xmlns:r="http://schemas.openxmlformats.org/officeDocument/2006/relationships" id="2147483656" r:id="Rd795c1f7b83f4bd3"/>
-    <p:sldLayoutId xmlns:r="http://schemas.openxmlformats.org/officeDocument/2006/relationships" id="2147483657" r:id="R38b2aa4ea0f74ef7"/>
-    <p:sldLayoutId xmlns:r="http://schemas.openxmlformats.org/officeDocument/2006/relationships" id="2147483658" r:id="R8e184def5b144075"/>
-    <p:sldLayoutId xmlns:r="http://schemas.openxmlformats.org/officeDocument/2006/relationships" id="2147483659" r:id="Re9d8b25726164b2c"/>
-    <p:sldLayoutId xmlns:r="http://schemas.openxmlformats.org/officeDocument/2006/relationships" id="2147483660" r:id="Rf70add6ab2d04508"/>
+    <p:sldLayoutId xmlns:r="http://schemas.openxmlformats.org/officeDocument/2006/relationships" id="2147483649" r:id="R463c6712946c4d6a"/>
+    <p:sldLayoutId xmlns:r="http://schemas.openxmlformats.org/officeDocument/2006/relationships" id="2147483650" r:id="Ra8d04446e15a49f2"/>
+    <p:sldLayoutId xmlns:r="http://schemas.openxmlformats.org/officeDocument/2006/relationships" id="2147483651" r:id="R84fd8ad1791844bd"/>
+    <p:sldLayoutId xmlns:r="http://schemas.openxmlformats.org/officeDocument/2006/relationships" id="2147483652" r:id="Rdc87cbb5342341f7"/>
+    <p:sldLayoutId xmlns:r="http://schemas.openxmlformats.org/officeDocument/2006/relationships" id="2147483653" r:id="Reb99180b88b041e1"/>
+    <p:sldLayoutId xmlns:r="http://schemas.openxmlformats.org/officeDocument/2006/relationships" id="2147483654" r:id="R948abdc3a23e4e74"/>
+    <p:sldLayoutId xmlns:r="http://schemas.openxmlformats.org/officeDocument/2006/relationships" id="2147483655" r:id="R4a5872f04a6849cc"/>
+    <p:sldLayoutId xmlns:r="http://schemas.openxmlformats.org/officeDocument/2006/relationships" id="2147483656" r:id="R1bc874233496402f"/>
+    <p:sldLayoutId xmlns:r="http://schemas.openxmlformats.org/officeDocument/2006/relationships" id="2147483657" r:id="R1c1309029f274d14"/>
+    <p:sldLayoutId xmlns:r="http://schemas.openxmlformats.org/officeDocument/2006/relationships" id="2147483658" r:id="Rf6efb3858afc46d3"/>
+    <p:sldLayoutId xmlns:r="http://schemas.openxmlformats.org/officeDocument/2006/relationships" id="2147483659" r:id="R9f1a083709d649dc"/>
+    <p:sldLayoutId xmlns:r="http://schemas.openxmlformats.org/officeDocument/2006/relationships" id="2147483660" r:id="Re09ba15bdefd49be"/>
   </p:sldLayoutIdLst>
   <p:hf sldNum="0" hdr="0" ftr="0" dt="0"/>
   <p:txStyles>
@@ -6442,7 +6442,7 @@
   </p:cSld>
   <p:clrMap bg1="lt1" tx1="dk1" bg2="dk2" tx2="lt2" accent1="accent1" accent2="accent2" accent3="accent3" accent4="accent4" accent5="accent5" accent6="accent6" hlink="hlink" folHlink="folHlink"/>
   <p:sldLayoutIdLst>
-    <p:sldLayoutId xmlns:r="http://schemas.openxmlformats.org/officeDocument/2006/relationships" id="2147483662" r:id="R7045e06605f74a88"/>
+    <p:sldLayoutId xmlns:r="http://schemas.openxmlformats.org/officeDocument/2006/relationships" id="2147483662" r:id="Reb1add45ec6e4494"/>
   </p:sldLayoutIdLst>
   <p:hf sldNum="0" hdr="0" ftr="0" dt="0"/>
   <p:txStyles>
@@ -8291,7 +8291,7 @@
           <p:nvPr/>
         </p:nvPicPr>
         <p:blipFill rotWithShape="1">
-          <a:blip xmlns:r="http://schemas.openxmlformats.org/officeDocument/2006/relationships" xmlns:a="http://schemas.openxmlformats.org/drawingml/2006/main" r:embed="R4856c5e067044fae">
+          <a:blip xmlns:r="http://schemas.openxmlformats.org/officeDocument/2006/relationships" xmlns:a="http://schemas.openxmlformats.org/drawingml/2006/main" r:embed="R2b26c8b851f24fc4">
             <a:alphaModFix/>
           </a:blip>
           <a:srcRect xmlns:a="http://schemas.openxmlformats.org/drawingml/2006/main" l="0" t="0" r="0" b="0"/>
@@ -8319,7 +8319,7 @@
           <p:nvPr/>
         </p:nvPicPr>
         <p:blipFill rotWithShape="1">
-          <a:blip xmlns:r="http://schemas.openxmlformats.org/officeDocument/2006/relationships" xmlns:a="http://schemas.openxmlformats.org/drawingml/2006/main" r:embed="R4856c5e067044fae">
+          <a:blip xmlns:r="http://schemas.openxmlformats.org/officeDocument/2006/relationships" xmlns:a="http://schemas.openxmlformats.org/drawingml/2006/main" r:embed="R2b26c8b851f24fc4">
             <a:alphaModFix/>
           </a:blip>
           <a:srcRect xmlns:a="http://schemas.openxmlformats.org/drawingml/2006/main" l="0" t="0" r="0" b="0"/>
@@ -8347,7 +8347,7 @@
           <p:nvPr/>
         </p:nvPicPr>
         <p:blipFill rotWithShape="1">
-          <a:blip xmlns:r="http://schemas.openxmlformats.org/officeDocument/2006/relationships" xmlns:a="http://schemas.openxmlformats.org/drawingml/2006/main" r:embed="R4856c5e067044fae">
+          <a:blip xmlns:r="http://schemas.openxmlformats.org/officeDocument/2006/relationships" xmlns:a="http://schemas.openxmlformats.org/drawingml/2006/main" r:embed="R2b26c8b851f24fc4">
             <a:alphaModFix/>
           </a:blip>
           <a:srcRect xmlns:a="http://schemas.openxmlformats.org/drawingml/2006/main" l="0" t="0" r="0" b="0"/>
@@ -8375,7 +8375,7 @@
           <p:nvPr/>
         </p:nvPicPr>
         <p:blipFill rotWithShape="1">
-          <a:blip xmlns:r="http://schemas.openxmlformats.org/officeDocument/2006/relationships" xmlns:a="http://schemas.openxmlformats.org/drawingml/2006/main" r:embed="R4856c5e067044fae">
+          <a:blip xmlns:r="http://schemas.openxmlformats.org/officeDocument/2006/relationships" xmlns:a="http://schemas.openxmlformats.org/drawingml/2006/main" r:embed="R2b26c8b851f24fc4">
             <a:alphaModFix/>
           </a:blip>
           <a:srcRect xmlns:a="http://schemas.openxmlformats.org/drawingml/2006/main" l="0" t="0" r="0" b="0"/>
@@ -8403,7 +8403,7 @@
           <p:nvPr/>
         </p:nvPicPr>
         <p:blipFill rotWithShape="1">
-          <a:blip xmlns:r="http://schemas.openxmlformats.org/officeDocument/2006/relationships" xmlns:a="http://schemas.openxmlformats.org/drawingml/2006/main" r:embed="R4856c5e067044fae">
+          <a:blip xmlns:r="http://schemas.openxmlformats.org/officeDocument/2006/relationships" xmlns:a="http://schemas.openxmlformats.org/drawingml/2006/main" r:embed="R2b26c8b851f24fc4">
             <a:alphaModFix/>
           </a:blip>
           <a:srcRect xmlns:a="http://schemas.openxmlformats.org/drawingml/2006/main" l="0" t="0" r="0" b="0"/>
@@ -8431,7 +8431,7 @@
           <p:nvPr/>
         </p:nvPicPr>
         <p:blipFill rotWithShape="1">
-          <a:blip xmlns:r="http://schemas.openxmlformats.org/officeDocument/2006/relationships" xmlns:a="http://schemas.openxmlformats.org/drawingml/2006/main" r:embed="R4856c5e067044fae">
+          <a:blip xmlns:r="http://schemas.openxmlformats.org/officeDocument/2006/relationships" xmlns:a="http://schemas.openxmlformats.org/drawingml/2006/main" r:embed="R2b26c8b851f24fc4">
             <a:alphaModFix/>
           </a:blip>
           <a:srcRect xmlns:a="http://schemas.openxmlformats.org/drawingml/2006/main" l="0" t="0" r="0" b="0"/>
@@ -8459,7 +8459,7 @@
           <p:nvPr/>
         </p:nvPicPr>
         <p:blipFill rotWithShape="1">
-          <a:blip xmlns:r="http://schemas.openxmlformats.org/officeDocument/2006/relationships" xmlns:a="http://schemas.openxmlformats.org/drawingml/2006/main" r:embed="R4856c5e067044fae">
+          <a:blip xmlns:r="http://schemas.openxmlformats.org/officeDocument/2006/relationships" xmlns:a="http://schemas.openxmlformats.org/drawingml/2006/main" r:embed="R2b26c8b851f24fc4">
             <a:alphaModFix/>
           </a:blip>
           <a:srcRect xmlns:a="http://schemas.openxmlformats.org/drawingml/2006/main" l="0" t="0" r="0" b="0"/>
@@ -8487,7 +8487,7 @@
           <p:nvPr/>
         </p:nvPicPr>
         <p:blipFill rotWithShape="1">
-          <a:blip xmlns:r="http://schemas.openxmlformats.org/officeDocument/2006/relationships" xmlns:a="http://schemas.openxmlformats.org/drawingml/2006/main" r:embed="R4856c5e067044fae">
+          <a:blip xmlns:r="http://schemas.openxmlformats.org/officeDocument/2006/relationships" xmlns:a="http://schemas.openxmlformats.org/drawingml/2006/main" r:embed="R2b26c8b851f24fc4">
             <a:alphaModFix/>
           </a:blip>
           <a:srcRect xmlns:a="http://schemas.openxmlformats.org/drawingml/2006/main" l="0" t="0" r="0" b="0"/>
@@ -9091,7 +9091,7 @@
                 <a:ea typeface="Montserrat"/>
                 <a:cs typeface="Montserrat"/>
               </a:rPr>
-              <a:t>Step 1: Count the returned events</a:t>
+              <a:t>Step 2: Count the returned events</a:t>
             </a:r>
           </a:p>
         </p:txBody>
@@ -9633,7 +9633,7 @@
                 <a:ea typeface="Roboto Mono"/>
                 <a:cs typeface="Roboto Mono"/>
               </a:rPr>
-              <a:t>Step 1: generated main.cpp (continued)</a:t>
+              <a:t>Step 2: generated main.cpp (continued)</a:t>
             </a:r>
           </a:p>
         </p:txBody>
@@ -10050,7 +10050,7 @@
                 <a:ea typeface="Roboto Mono"/>
                 <a:cs typeface="Roboto Mono"/>
               </a:rPr>
-              <a:t>    // STEP 3 goes here later.</a:t>
+              <a:t>    // STEP 4 goes here later.</a:t>
             </a:r>
           </a:p>
           <a:p xmlns:a="http://schemas.openxmlformats.org/drawingml/2006/main">
@@ -10790,7 +10790,7 @@
           <p:nvPr/>
         </p:nvPicPr>
         <p:blipFill rotWithShape="1">
-          <a:blip xmlns:r="http://schemas.openxmlformats.org/officeDocument/2006/relationships" xmlns:a="http://schemas.openxmlformats.org/drawingml/2006/main" r:embed="R81ecdfbcf15d44e7">
+          <a:blip xmlns:r="http://schemas.openxmlformats.org/officeDocument/2006/relationships" xmlns:a="http://schemas.openxmlformats.org/drawingml/2006/main" r:embed="Rb19d1905c50a4192">
             <a:alphaModFix/>
           </a:blip>
           <a:srcRect xmlns:a="http://schemas.openxmlformats.org/drawingml/2006/main" l="0" t="0" r="0" b="0"/>
@@ -10818,7 +10818,7 @@
           <p:nvPr/>
         </p:nvPicPr>
         <p:blipFill rotWithShape="1">
-          <a:blip xmlns:r="http://schemas.openxmlformats.org/officeDocument/2006/relationships" xmlns:a="http://schemas.openxmlformats.org/drawingml/2006/main" r:embed="R81ecdfbcf15d44e7">
+          <a:blip xmlns:r="http://schemas.openxmlformats.org/officeDocument/2006/relationships" xmlns:a="http://schemas.openxmlformats.org/drawingml/2006/main" r:embed="Rb19d1905c50a4192">
             <a:alphaModFix/>
           </a:blip>
           <a:srcRect xmlns:a="http://schemas.openxmlformats.org/drawingml/2006/main" l="0" t="0" r="0" b="0"/>
@@ -10846,7 +10846,7 @@
           <p:nvPr/>
         </p:nvPicPr>
         <p:blipFill rotWithShape="1">
-          <a:blip xmlns:r="http://schemas.openxmlformats.org/officeDocument/2006/relationships" xmlns:a="http://schemas.openxmlformats.org/drawingml/2006/main" r:embed="R81ecdfbcf15d44e7">
+          <a:blip xmlns:r="http://schemas.openxmlformats.org/officeDocument/2006/relationships" xmlns:a="http://schemas.openxmlformats.org/drawingml/2006/main" r:embed="Rb19d1905c50a4192">
             <a:alphaModFix/>
           </a:blip>
           <a:srcRect xmlns:a="http://schemas.openxmlformats.org/drawingml/2006/main" l="0" t="0" r="0" b="0"/>
@@ -10874,7 +10874,7 @@
           <p:nvPr/>
         </p:nvPicPr>
         <p:blipFill rotWithShape="1">
-          <a:blip xmlns:r="http://schemas.openxmlformats.org/officeDocument/2006/relationships" xmlns:a="http://schemas.openxmlformats.org/drawingml/2006/main" r:embed="R81ecdfbcf15d44e7">
+          <a:blip xmlns:r="http://schemas.openxmlformats.org/officeDocument/2006/relationships" xmlns:a="http://schemas.openxmlformats.org/drawingml/2006/main" r:embed="Rb19d1905c50a4192">
             <a:alphaModFix/>
           </a:blip>
           <a:srcRect xmlns:a="http://schemas.openxmlformats.org/drawingml/2006/main" l="0" t="0" r="0" b="0"/>
@@ -11304,7 +11304,7 @@
                 <a:ea typeface="Montserrat"/>
                 <a:cs typeface="Montserrat"/>
               </a:rPr>
-              <a:t>Step 2: Keep process executions</a:t>
+              <a:t>Step 3: Keep process executions</a:t>
             </a:r>
           </a:p>
         </p:txBody>
@@ -11472,7 +11472,7 @@
                 <a:ea typeface="Inter"/>
                 <a:cs typeface="Inter"/>
               </a:rPr>
-              <a:t>Run step 2 in terminal A.</a:t>
+              <a:t>Run step 3 in terminal A.</a:t>
             </a:r>
           </a:p>
           <a:p xmlns:a="http://schemas.openxmlformats.org/drawingml/2006/main">
@@ -11846,7 +11846,7 @@
                 <a:ea typeface="Roboto Mono"/>
                 <a:cs typeface="Roboto Mono"/>
               </a:rPr>
-              <a:t>Step 2: filter added to main.cpp</a:t>
+              <a:t>Step 3: filter added to main.cpp</a:t>
             </a:r>
           </a:p>
         </p:txBody>
@@ -12755,7 +12755,7 @@
           <p:nvPr/>
         </p:nvPicPr>
         <p:blipFill rotWithShape="1">
-          <a:blip xmlns:r="http://schemas.openxmlformats.org/officeDocument/2006/relationships" xmlns:a="http://schemas.openxmlformats.org/drawingml/2006/main" r:embed="R37a4271ef4b74d72">
+          <a:blip xmlns:r="http://schemas.openxmlformats.org/officeDocument/2006/relationships" xmlns:a="http://schemas.openxmlformats.org/drawingml/2006/main" r:embed="R9ad106ea1b4b4def">
             <a:alphaModFix/>
           </a:blip>
           <a:srcRect xmlns:a="http://schemas.openxmlformats.org/drawingml/2006/main" l="0" t="0" r="0" b="0"/>
@@ -12783,7 +12783,7 @@
           <p:nvPr/>
         </p:nvPicPr>
         <p:blipFill rotWithShape="1">
-          <a:blip xmlns:r="http://schemas.openxmlformats.org/officeDocument/2006/relationships" xmlns:a="http://schemas.openxmlformats.org/drawingml/2006/main" r:embed="R37a4271ef4b74d72">
+          <a:blip xmlns:r="http://schemas.openxmlformats.org/officeDocument/2006/relationships" xmlns:a="http://schemas.openxmlformats.org/drawingml/2006/main" r:embed="R9ad106ea1b4b4def">
             <a:alphaModFix/>
           </a:blip>
           <a:srcRect xmlns:a="http://schemas.openxmlformats.org/drawingml/2006/main" l="0" t="0" r="0" b="0"/>
@@ -12811,7 +12811,7 @@
           <p:nvPr/>
         </p:nvPicPr>
         <p:blipFill rotWithShape="1">
-          <a:blip xmlns:r="http://schemas.openxmlformats.org/officeDocument/2006/relationships" xmlns:a="http://schemas.openxmlformats.org/drawingml/2006/main" r:embed="R37a4271ef4b74d72">
+          <a:blip xmlns:r="http://schemas.openxmlformats.org/officeDocument/2006/relationships" xmlns:a="http://schemas.openxmlformats.org/drawingml/2006/main" r:embed="R9ad106ea1b4b4def">
             <a:alphaModFix/>
           </a:blip>
           <a:srcRect xmlns:a="http://schemas.openxmlformats.org/drawingml/2006/main" l="0" t="0" r="0" b="0"/>
@@ -12839,7 +12839,7 @@
           <p:nvPr/>
         </p:nvPicPr>
         <p:blipFill rotWithShape="1">
-          <a:blip xmlns:r="http://schemas.openxmlformats.org/officeDocument/2006/relationships" xmlns:a="http://schemas.openxmlformats.org/drawingml/2006/main" r:embed="R37a4271ef4b74d72">
+          <a:blip xmlns:r="http://schemas.openxmlformats.org/officeDocument/2006/relationships" xmlns:a="http://schemas.openxmlformats.org/drawingml/2006/main" r:embed="R9ad106ea1b4b4def">
             <a:alphaModFix/>
           </a:blip>
           <a:srcRect xmlns:a="http://schemas.openxmlformats.org/drawingml/2006/main" l="0" t="0" r="0" b="0"/>
@@ -13269,7 +13269,7 @@
                 <a:ea typeface="Montserrat"/>
                 <a:cs typeface="Montserrat"/>
               </a:rPr>
-              <a:t>Step 3: Add process context</a:t>
+              <a:t>Step 4: Add process context</a:t>
             </a:r>
           </a:p>
         </p:txBody>
@@ -13437,7 +13437,7 @@
                 <a:ea typeface="Inter"/>
                 <a:cs typeface="Inter"/>
               </a:rPr>
-              <a:t>Run step 3 in terminal A.</a:t>
+              <a:t>Run step 4 in terminal A.</a:t>
             </a:r>
           </a:p>
           <a:p xmlns:a="http://schemas.openxmlformats.org/drawingml/2006/main">
@@ -13811,7 +13811,7 @@
                 <a:ea typeface="Roboto Mono"/>
                 <a:cs typeface="Roboto Mono"/>
               </a:rPr>
-              <a:t>Step 3: context added to main.cpp</a:t>
+              <a:t>Step 4: context added to main.cpp</a:t>
             </a:r>
           </a:p>
         </p:txBody>
@@ -14788,7 +14788,7 @@
           <p:nvPr/>
         </p:nvPicPr>
         <p:blipFill rotWithShape="1">
-          <a:blip xmlns:r="http://schemas.openxmlformats.org/officeDocument/2006/relationships" xmlns:a="http://schemas.openxmlformats.org/drawingml/2006/main" r:embed="R99697c4bbb4f4abc">
+          <a:blip xmlns:r="http://schemas.openxmlformats.org/officeDocument/2006/relationships" xmlns:a="http://schemas.openxmlformats.org/drawingml/2006/main" r:embed="R2647ac204c2643e7">
             <a:alphaModFix/>
           </a:blip>
           <a:srcRect xmlns:a="http://schemas.openxmlformats.org/drawingml/2006/main" l="0" t="0" r="0" b="0"/>
@@ -14816,7 +14816,7 @@
           <p:nvPr/>
         </p:nvPicPr>
         <p:blipFill rotWithShape="1">
-          <a:blip xmlns:r="http://schemas.openxmlformats.org/officeDocument/2006/relationships" xmlns:a="http://schemas.openxmlformats.org/drawingml/2006/main" r:embed="R99697c4bbb4f4abc">
+          <a:blip xmlns:r="http://schemas.openxmlformats.org/officeDocument/2006/relationships" xmlns:a="http://schemas.openxmlformats.org/drawingml/2006/main" r:embed="R2647ac204c2643e7">
             <a:alphaModFix/>
           </a:blip>
           <a:srcRect xmlns:a="http://schemas.openxmlformats.org/drawingml/2006/main" l="0" t="0" r="0" b="0"/>
@@ -14844,7 +14844,7 @@
           <p:nvPr/>
         </p:nvPicPr>
         <p:blipFill rotWithShape="1">
-          <a:blip xmlns:r="http://schemas.openxmlformats.org/officeDocument/2006/relationships" xmlns:a="http://schemas.openxmlformats.org/drawingml/2006/main" r:embed="R99697c4bbb4f4abc">
+          <a:blip xmlns:r="http://schemas.openxmlformats.org/officeDocument/2006/relationships" xmlns:a="http://schemas.openxmlformats.org/drawingml/2006/main" r:embed="R2647ac204c2643e7">
             <a:alphaModFix/>
           </a:blip>
           <a:srcRect xmlns:a="http://schemas.openxmlformats.org/drawingml/2006/main" l="0" t="0" r="0" b="0"/>
@@ -14872,7 +14872,7 @@
           <p:nvPr/>
         </p:nvPicPr>
         <p:blipFill rotWithShape="1">
-          <a:blip xmlns:r="http://schemas.openxmlformats.org/officeDocument/2006/relationships" xmlns:a="http://schemas.openxmlformats.org/drawingml/2006/main" r:embed="R99697c4bbb4f4abc">
+          <a:blip xmlns:r="http://schemas.openxmlformats.org/officeDocument/2006/relationships" xmlns:a="http://schemas.openxmlformats.org/drawingml/2006/main" r:embed="R2647ac204c2643e7">
             <a:alphaModFix/>
           </a:blip>
           <a:srcRect xmlns:a="http://schemas.openxmlformats.org/drawingml/2006/main" l="0" t="0" r="0" b="0"/>
@@ -15626,7 +15626,7 @@
                 <a:ea typeface="Inter"/>
                 <a:cs typeface="Inter"/>
               </a:rPr>
-              <a:t>Step 3 installs the complete collector.</a:t>
+              <a:t>Step 4 installs the complete collector.</a:t>
             </a:r>
           </a:p>
         </p:txBody>
@@ -16835,7 +16835,7 @@
           <p:nvPr/>
         </p:nvPicPr>
         <p:blipFill rotWithShape="1">
-          <a:blip xmlns:r="http://schemas.openxmlformats.org/officeDocument/2006/relationships" xmlns:a="http://schemas.openxmlformats.org/drawingml/2006/main" r:embed="Re5acb40a72df46ff">
+          <a:blip xmlns:r="http://schemas.openxmlformats.org/officeDocument/2006/relationships" xmlns:a="http://schemas.openxmlformats.org/drawingml/2006/main" r:embed="Rd6fd567145f048ef">
             <a:alphaModFix/>
           </a:blip>
           <a:srcRect xmlns:a="http://schemas.openxmlformats.org/drawingml/2006/main" l="0" t="0" r="0" b="0"/>
@@ -16863,7 +16863,7 @@
           <p:nvPr/>
         </p:nvPicPr>
         <p:blipFill rotWithShape="1">
-          <a:blip xmlns:r="http://schemas.openxmlformats.org/officeDocument/2006/relationships" xmlns:a="http://schemas.openxmlformats.org/drawingml/2006/main" r:embed="Re5acb40a72df46ff">
+          <a:blip xmlns:r="http://schemas.openxmlformats.org/officeDocument/2006/relationships" xmlns:a="http://schemas.openxmlformats.org/drawingml/2006/main" r:embed="Rd6fd567145f048ef">
             <a:alphaModFix/>
           </a:blip>
           <a:srcRect xmlns:a="http://schemas.openxmlformats.org/drawingml/2006/main" l="0" t="0" r="0" b="0"/>
@@ -16891,7 +16891,7 @@
           <p:nvPr/>
         </p:nvPicPr>
         <p:blipFill rotWithShape="1">
-          <a:blip xmlns:r="http://schemas.openxmlformats.org/officeDocument/2006/relationships" xmlns:a="http://schemas.openxmlformats.org/drawingml/2006/main" r:embed="Re5acb40a72df46ff">
+          <a:blip xmlns:r="http://schemas.openxmlformats.org/officeDocument/2006/relationships" xmlns:a="http://schemas.openxmlformats.org/drawingml/2006/main" r:embed="Rd6fd567145f048ef">
             <a:alphaModFix/>
           </a:blip>
           <a:srcRect xmlns:a="http://schemas.openxmlformats.org/drawingml/2006/main" l="0" t="0" r="0" b="0"/>
@@ -16919,7 +16919,7 @@
           <p:nvPr/>
         </p:nvPicPr>
         <p:blipFill rotWithShape="1">
-          <a:blip xmlns:r="http://schemas.openxmlformats.org/officeDocument/2006/relationships" xmlns:a="http://schemas.openxmlformats.org/drawingml/2006/main" r:embed="Re5acb40a72df46ff">
+          <a:blip xmlns:r="http://schemas.openxmlformats.org/officeDocument/2006/relationships" xmlns:a="http://schemas.openxmlformats.org/drawingml/2006/main" r:embed="Rd6fd567145f048ef">
             <a:alphaModFix/>
           </a:blip>
           <a:srcRect xmlns:a="http://schemas.openxmlformats.org/drawingml/2006/main" l="0" t="0" r="0" b="0"/>
@@ -18770,7 +18770,7 @@
           <p:nvPr/>
         </p:nvPicPr>
         <p:blipFill rotWithShape="1">
-          <a:blip xmlns:r="http://schemas.openxmlformats.org/officeDocument/2006/relationships" xmlns:a="http://schemas.openxmlformats.org/drawingml/2006/main" r:embed="R2cc2d5b2d46d44d2">
+          <a:blip xmlns:r="http://schemas.openxmlformats.org/officeDocument/2006/relationships" xmlns:a="http://schemas.openxmlformats.org/drawingml/2006/main" r:embed="R77e57a7775a54c45">
             <a:alphaModFix/>
           </a:blip>
           <a:srcRect xmlns:a="http://schemas.openxmlformats.org/drawingml/2006/main" l="0" t="0" r="0" b="0"/>
@@ -18798,7 +18798,7 @@
           <p:nvPr/>
         </p:nvPicPr>
         <p:blipFill rotWithShape="1">
-          <a:blip xmlns:r="http://schemas.openxmlformats.org/officeDocument/2006/relationships" xmlns:a="http://schemas.openxmlformats.org/drawingml/2006/main" r:embed="R2cc2d5b2d46d44d2">
+          <a:blip xmlns:r="http://schemas.openxmlformats.org/officeDocument/2006/relationships" xmlns:a="http://schemas.openxmlformats.org/drawingml/2006/main" r:embed="R77e57a7775a54c45">
             <a:alphaModFix/>
           </a:blip>
           <a:srcRect xmlns:a="http://schemas.openxmlformats.org/drawingml/2006/main" l="0" t="0" r="0" b="0"/>
@@ -18826,7 +18826,7 @@
           <p:nvPr/>
         </p:nvPicPr>
         <p:blipFill rotWithShape="1">
-          <a:blip xmlns:r="http://schemas.openxmlformats.org/officeDocument/2006/relationships" xmlns:a="http://schemas.openxmlformats.org/drawingml/2006/main" r:embed="R2cc2d5b2d46d44d2">
+          <a:blip xmlns:r="http://schemas.openxmlformats.org/officeDocument/2006/relationships" xmlns:a="http://schemas.openxmlformats.org/drawingml/2006/main" r:embed="R77e57a7775a54c45">
             <a:alphaModFix/>
           </a:blip>
           <a:srcRect xmlns:a="http://schemas.openxmlformats.org/drawingml/2006/main" l="0" t="0" r="0" b="0"/>
@@ -18854,7 +18854,7 @@
           <p:nvPr/>
         </p:nvPicPr>
         <p:blipFill rotWithShape="1">
-          <a:blip xmlns:r="http://schemas.openxmlformats.org/officeDocument/2006/relationships" xmlns:a="http://schemas.openxmlformats.org/drawingml/2006/main" r:embed="R2cc2d5b2d46d44d2">
+          <a:blip xmlns:r="http://schemas.openxmlformats.org/officeDocument/2006/relationships" xmlns:a="http://schemas.openxmlformats.org/drawingml/2006/main" r:embed="R77e57a7775a54c45">
             <a:alphaModFix/>
           </a:blip>
           <a:srcRect xmlns:a="http://schemas.openxmlformats.org/drawingml/2006/main" l="0" t="0" r="0" b="0"/>
@@ -19943,7 +19943,7 @@
                 <a:ea typeface="Roboto Mono"/>
                 <a:cs typeface="Roboto Mono"/>
               </a:rPr>
-              <a:t>0  Attach and wait</a:t>
+              <a:t>1  Create src/ and attach</a:t>
             </a:r>
           </a:p>
           <a:p xmlns:a="http://schemas.openxmlformats.org/drawingml/2006/main">
@@ -19995,7 +19995,7 @@
                 <a:ea typeface="Roboto Mono"/>
                 <a:cs typeface="Roboto Mono"/>
               </a:rPr>
-              <a:t>1  Read and count events</a:t>
+              <a:t>2  Read and count events</a:t>
             </a:r>
           </a:p>
           <a:p xmlns:a="http://schemas.openxmlformats.org/drawingml/2006/main">
@@ -20047,7 +20047,7 @@
                 <a:ea typeface="Roboto Mono"/>
                 <a:cs typeface="Roboto Mono"/>
               </a:rPr>
-              <a:t>2  Keep process executions</a:t>
+              <a:t>3  Keep process executions</a:t>
             </a:r>
           </a:p>
           <a:p xmlns:a="http://schemas.openxmlformats.org/drawingml/2006/main">
@@ -20099,7 +20099,7 @@
                 <a:ea typeface="Roboto Mono"/>
                 <a:cs typeface="Roboto Mono"/>
               </a:rPr>
-              <a:t>3  Add process name and PID</a:t>
+              <a:t>4  Add process name and PID</a:t>
             </a:r>
           </a:p>
         </p:txBody>
@@ -20749,7 +20749,7 @@
           <p:nvPr/>
         </p:nvPicPr>
         <p:blipFill rotWithShape="1">
-          <a:blip xmlns:r="http://schemas.openxmlformats.org/officeDocument/2006/relationships" xmlns:a="http://schemas.openxmlformats.org/drawingml/2006/main" r:embed="R131ddba7fe4d4602">
+          <a:blip xmlns:r="http://schemas.openxmlformats.org/officeDocument/2006/relationships" xmlns:a="http://schemas.openxmlformats.org/drawingml/2006/main" r:embed="R6becd55c02f244a0">
             <a:alphaModFix/>
           </a:blip>
           <a:srcRect xmlns:a="http://schemas.openxmlformats.org/drawingml/2006/main" l="0" t="0" r="0" b="0"/>
@@ -20777,7 +20777,7 @@
           <p:nvPr/>
         </p:nvPicPr>
         <p:blipFill rotWithShape="1">
-          <a:blip xmlns:r="http://schemas.openxmlformats.org/officeDocument/2006/relationships" xmlns:a="http://schemas.openxmlformats.org/drawingml/2006/main" r:embed="R131ddba7fe4d4602">
+          <a:blip xmlns:r="http://schemas.openxmlformats.org/officeDocument/2006/relationships" xmlns:a="http://schemas.openxmlformats.org/drawingml/2006/main" r:embed="R6becd55c02f244a0">
             <a:alphaModFix/>
           </a:blip>
           <a:srcRect xmlns:a="http://schemas.openxmlformats.org/drawingml/2006/main" l="0" t="0" r="0" b="0"/>
@@ -20805,7 +20805,7 @@
           <p:nvPr/>
         </p:nvPicPr>
         <p:blipFill rotWithShape="1">
-          <a:blip xmlns:r="http://schemas.openxmlformats.org/officeDocument/2006/relationships" xmlns:a="http://schemas.openxmlformats.org/drawingml/2006/main" r:embed="R131ddba7fe4d4602">
+          <a:blip xmlns:r="http://schemas.openxmlformats.org/officeDocument/2006/relationships" xmlns:a="http://schemas.openxmlformats.org/drawingml/2006/main" r:embed="R6becd55c02f244a0">
             <a:alphaModFix/>
           </a:blip>
           <a:srcRect xmlns:a="http://schemas.openxmlformats.org/drawingml/2006/main" l="0" t="0" r="0" b="0"/>
@@ -20833,7 +20833,7 @@
           <p:nvPr/>
         </p:nvPicPr>
         <p:blipFill rotWithShape="1">
-          <a:blip xmlns:r="http://schemas.openxmlformats.org/officeDocument/2006/relationships" xmlns:a="http://schemas.openxmlformats.org/drawingml/2006/main" r:embed="R131ddba7fe4d4602">
+          <a:blip xmlns:r="http://schemas.openxmlformats.org/officeDocument/2006/relationships" xmlns:a="http://schemas.openxmlformats.org/drawingml/2006/main" r:embed="R6becd55c02f244a0">
             <a:alphaModFix/>
           </a:blip>
           <a:srcRect xmlns:a="http://schemas.openxmlformats.org/drawingml/2006/main" l="0" t="0" r="0" b="0"/>
@@ -22446,7 +22446,7 @@
           <p:nvPr/>
         </p:nvPicPr>
         <p:blipFill rotWithShape="1">
-          <a:blip xmlns:r="http://schemas.openxmlformats.org/officeDocument/2006/relationships" xmlns:a="http://schemas.openxmlformats.org/drawingml/2006/main" r:embed="Rd8247b3d0c694b06">
+          <a:blip xmlns:r="http://schemas.openxmlformats.org/officeDocument/2006/relationships" xmlns:a="http://schemas.openxmlformats.org/drawingml/2006/main" r:embed="Rb8b09f40538a403d">
             <a:alphaModFix/>
           </a:blip>
           <a:srcRect xmlns:a="http://schemas.openxmlformats.org/drawingml/2006/main" l="0" t="0" r="0" b="0"/>
@@ -22474,7 +22474,7 @@
           <p:nvPr/>
         </p:nvPicPr>
         <p:blipFill rotWithShape="1">
-          <a:blip xmlns:r="http://schemas.openxmlformats.org/officeDocument/2006/relationships" xmlns:a="http://schemas.openxmlformats.org/drawingml/2006/main" r:embed="Rd8247b3d0c694b06">
+          <a:blip xmlns:r="http://schemas.openxmlformats.org/officeDocument/2006/relationships" xmlns:a="http://schemas.openxmlformats.org/drawingml/2006/main" r:embed="Rb8b09f40538a403d">
             <a:alphaModFix/>
           </a:blip>
           <a:srcRect xmlns:a="http://schemas.openxmlformats.org/drawingml/2006/main" l="0" t="0" r="0" b="0"/>
@@ -22502,7 +22502,7 @@
           <p:nvPr/>
         </p:nvPicPr>
         <p:blipFill rotWithShape="1">
-          <a:blip xmlns:r="http://schemas.openxmlformats.org/officeDocument/2006/relationships" xmlns:a="http://schemas.openxmlformats.org/drawingml/2006/main" r:embed="Rd8247b3d0c694b06">
+          <a:blip xmlns:r="http://schemas.openxmlformats.org/officeDocument/2006/relationships" xmlns:a="http://schemas.openxmlformats.org/drawingml/2006/main" r:embed="Rb8b09f40538a403d">
             <a:alphaModFix/>
           </a:blip>
           <a:srcRect xmlns:a="http://schemas.openxmlformats.org/drawingml/2006/main" l="0" t="0" r="0" b="0"/>
@@ -22530,7 +22530,7 @@
           <p:nvPr/>
         </p:nvPicPr>
         <p:blipFill rotWithShape="1">
-          <a:blip xmlns:r="http://schemas.openxmlformats.org/officeDocument/2006/relationships" xmlns:a="http://schemas.openxmlformats.org/drawingml/2006/main" r:embed="Rd8247b3d0c694b06">
+          <a:blip xmlns:r="http://schemas.openxmlformats.org/officeDocument/2006/relationships" xmlns:a="http://schemas.openxmlformats.org/drawingml/2006/main" r:embed="Rb8b09f40538a403d">
             <a:alphaModFix/>
           </a:blip>
           <a:srcRect xmlns:a="http://schemas.openxmlformats.org/drawingml/2006/main" l="0" t="0" r="0" b="0"/>
@@ -24143,7 +24143,7 @@
           <p:nvPr/>
         </p:nvPicPr>
         <p:blipFill rotWithShape="1">
-          <a:blip xmlns:r="http://schemas.openxmlformats.org/officeDocument/2006/relationships" xmlns:a="http://schemas.openxmlformats.org/drawingml/2006/main" r:embed="R66e9717124da4973">
+          <a:blip xmlns:r="http://schemas.openxmlformats.org/officeDocument/2006/relationships" xmlns:a="http://schemas.openxmlformats.org/drawingml/2006/main" r:embed="R53b13d0774ba4afb">
             <a:alphaModFix/>
           </a:blip>
           <a:srcRect xmlns:a="http://schemas.openxmlformats.org/drawingml/2006/main" l="0" t="0" r="0" b="0"/>
@@ -24171,7 +24171,7 @@
           <p:nvPr/>
         </p:nvPicPr>
         <p:blipFill rotWithShape="1">
-          <a:blip xmlns:r="http://schemas.openxmlformats.org/officeDocument/2006/relationships" xmlns:a="http://schemas.openxmlformats.org/drawingml/2006/main" r:embed="R66e9717124da4973">
+          <a:blip xmlns:r="http://schemas.openxmlformats.org/officeDocument/2006/relationships" xmlns:a="http://schemas.openxmlformats.org/drawingml/2006/main" r:embed="R53b13d0774ba4afb">
             <a:alphaModFix/>
           </a:blip>
           <a:srcRect xmlns:a="http://schemas.openxmlformats.org/drawingml/2006/main" l="0" t="0" r="0" b="0"/>
@@ -24199,7 +24199,7 @@
           <p:nvPr/>
         </p:nvPicPr>
         <p:blipFill rotWithShape="1">
-          <a:blip xmlns:r="http://schemas.openxmlformats.org/officeDocument/2006/relationships" xmlns:a="http://schemas.openxmlformats.org/drawingml/2006/main" r:embed="R66e9717124da4973">
+          <a:blip xmlns:r="http://schemas.openxmlformats.org/officeDocument/2006/relationships" xmlns:a="http://schemas.openxmlformats.org/drawingml/2006/main" r:embed="R53b13d0774ba4afb">
             <a:alphaModFix/>
           </a:blip>
           <a:srcRect xmlns:a="http://schemas.openxmlformats.org/drawingml/2006/main" l="0" t="0" r="0" b="0"/>
@@ -24227,7 +24227,7 @@
           <p:nvPr/>
         </p:nvPicPr>
         <p:blipFill rotWithShape="1">
-          <a:blip xmlns:r="http://schemas.openxmlformats.org/officeDocument/2006/relationships" xmlns:a="http://schemas.openxmlformats.org/drawingml/2006/main" r:embed="R66e9717124da4973">
+          <a:blip xmlns:r="http://schemas.openxmlformats.org/officeDocument/2006/relationships" xmlns:a="http://schemas.openxmlformats.org/drawingml/2006/main" r:embed="R53b13d0774ba4afb">
             <a:alphaModFix/>
           </a:blip>
           <a:srcRect xmlns:a="http://schemas.openxmlformats.org/drawingml/2006/main" l="0" t="0" r="0" b="0"/>
@@ -25346,7 +25346,7 @@
                 <a:ea typeface="Roboto Mono"/>
                 <a:cs typeface="Roboto Mono"/>
               </a:rPr>
-              <a:t># During each step’s capture</a:t>
+              <a:t># During steps 2–4</a:t>
             </a:r>
           </a:p>
           <a:p xmlns:a="http://schemas.openxmlformats.org/drawingml/2006/main">
@@ -26026,7 +26026,7 @@
           <p:nvPr/>
         </p:nvPicPr>
         <p:blipFill rotWithShape="1">
-          <a:blip xmlns:r="http://schemas.openxmlformats.org/officeDocument/2006/relationships" xmlns:a="http://schemas.openxmlformats.org/drawingml/2006/main" r:embed="R3c5868ba7d3a4f46">
+          <a:blip xmlns:r="http://schemas.openxmlformats.org/officeDocument/2006/relationships" xmlns:a="http://schemas.openxmlformats.org/drawingml/2006/main" r:embed="R6c73447341df4dbf">
             <a:alphaModFix/>
           </a:blip>
           <a:srcRect xmlns:a="http://schemas.openxmlformats.org/drawingml/2006/main" l="0" t="0" r="0" b="0"/>
@@ -26054,7 +26054,7 @@
           <p:nvPr/>
         </p:nvPicPr>
         <p:blipFill rotWithShape="1">
-          <a:blip xmlns:r="http://schemas.openxmlformats.org/officeDocument/2006/relationships" xmlns:a="http://schemas.openxmlformats.org/drawingml/2006/main" r:embed="R3c5868ba7d3a4f46">
+          <a:blip xmlns:r="http://schemas.openxmlformats.org/officeDocument/2006/relationships" xmlns:a="http://schemas.openxmlformats.org/drawingml/2006/main" r:embed="R6c73447341df4dbf">
             <a:alphaModFix/>
           </a:blip>
           <a:srcRect xmlns:a="http://schemas.openxmlformats.org/drawingml/2006/main" l="0" t="0" r="0" b="0"/>
@@ -26082,7 +26082,7 @@
           <p:nvPr/>
         </p:nvPicPr>
         <p:blipFill rotWithShape="1">
-          <a:blip xmlns:r="http://schemas.openxmlformats.org/officeDocument/2006/relationships" xmlns:a="http://schemas.openxmlformats.org/drawingml/2006/main" r:embed="R3c5868ba7d3a4f46">
+          <a:blip xmlns:r="http://schemas.openxmlformats.org/officeDocument/2006/relationships" xmlns:a="http://schemas.openxmlformats.org/drawingml/2006/main" r:embed="R6c73447341df4dbf">
             <a:alphaModFix/>
           </a:blip>
           <a:srcRect xmlns:a="http://schemas.openxmlformats.org/drawingml/2006/main" l="0" t="0" r="0" b="0"/>
@@ -26110,7 +26110,7 @@
           <p:nvPr/>
         </p:nvPicPr>
         <p:blipFill rotWithShape="1">
-          <a:blip xmlns:r="http://schemas.openxmlformats.org/officeDocument/2006/relationships" xmlns:a="http://schemas.openxmlformats.org/drawingml/2006/main" r:embed="R3c5868ba7d3a4f46">
+          <a:blip xmlns:r="http://schemas.openxmlformats.org/officeDocument/2006/relationships" xmlns:a="http://schemas.openxmlformats.org/drawingml/2006/main" r:embed="R6c73447341df4dbf">
             <a:alphaModFix/>
           </a:blip>
           <a:srcRect xmlns:a="http://schemas.openxmlformats.org/drawingml/2006/main" l="0" t="0" r="0" b="0"/>
@@ -26540,17 +26540,17 @@
                 <a:ea typeface="Montserrat"/>
                 <a:cs typeface="Montserrat"/>
               </a:rPr>
-              <a:t>Step 0: Attach</a:t>
-            </a:r>
-          </a:p>
-        </p:txBody>
-      </p:sp>
-      <p:sp>
-        <p:nvSpPr>
-          <p:cNvPr id="604" name="Google Shape;604;p30">
-            <a:extLst xmlns:a="http://schemas.openxmlformats.org/drawingml/2006/main">
-              <a:ext uri="{FF2B5EF4-FFF2-40B4-BE49-F238E27FC236}">
-                <a16:creationId xmlns:a16="http://schemas.microsoft.com/office/drawing/2014/main" id="{CB1389F3-AE35-44FF-B13C-8FDB3606FAB8}"/>
+              <a:t>Mac steps</a:t>
+            </a:r>
+          </a:p>
+        </p:txBody>
+      </p:sp>
+      <p:sp>
+        <p:nvSpPr>
+          <p:cNvPr id="606" name="Google Shape;606;p30">
+            <a:extLst xmlns:a="http://schemas.openxmlformats.org/drawingml/2006/main">
+              <a:ext uri="{FF2B5EF4-FFF2-40B4-BE49-F238E27FC236}">
+                <a16:creationId xmlns:a16="http://schemas.microsoft.com/office/drawing/2014/main" id="{49F9CDAA-5631-4822-9E9D-8ECDA15ACED4}"/>
               </a:ext>
             </a:extLst>
           </p:cNvPr>
@@ -26561,112 +26561,8 @@
         </p:nvSpPr>
         <p:spPr>
           <a:xfrm xmlns:a="http://schemas.openxmlformats.org/drawingml/2006/main">
-            <a:off x="304800" y="1219200"/>
-            <a:ext cx="3013500" cy="3410100"/>
-          </a:xfrm>
-          <a:prstGeom xmlns:a="http://schemas.openxmlformats.org/drawingml/2006/main" prst="roundRect">
-            <a:avLst>
-              <a:gd name="adj" fmla="val 1117"/>
-            </a:avLst>
-          </a:prstGeom>
-          <a:solidFill xmlns:a="http://schemas.openxmlformats.org/drawingml/2006/main">
-            <a:srgbClr val="F4F7F6"/>
-          </a:solidFill>
-          <a:ln xmlns:a="http://schemas.openxmlformats.org/drawingml/2006/main">
-            <a:noFill/>
-          </a:ln>
-        </p:spPr>
-        <p:txBody>
-          <a:bodyPr xmlns:a="http://schemas.openxmlformats.org/drawingml/2006/main" spcFirstLastPara="1" wrap="square" lIns="0" tIns="0" rIns="0" bIns="0" anchor="ctr">
-            <a:noAutofit/>
-          </a:bodyPr>
-          <a:lstStyle xmlns:a="http://schemas.openxmlformats.org/drawingml/2006/main"/>
-          <a:p xmlns:a="http://schemas.openxmlformats.org/drawingml/2006/main">
-            <a:pPr marL="0" lvl="0" indent="0" algn="l">
-              <a:spcBef>
-                <a:spcPts val="0"/>
-              </a:spcBef>
-              <a:spcAft>
-                <a:spcPts val="0"/>
-              </a:spcAft>
-              <a:buNone/>
-            </a:pPr>
-            <a:r>
-              <a:t/>
-            </a:r>
-            <a:endParaRPr/>
-          </a:p>
-        </p:txBody>
-      </p:sp>
-      <p:sp>
-        <p:nvSpPr>
-          <p:cNvPr id="605" name="Google Shape;605;p30">
-            <a:extLst xmlns:a="http://schemas.openxmlformats.org/drawingml/2006/main">
-              <a:ext uri="{FF2B5EF4-FFF2-40B4-BE49-F238E27FC236}">
-                <a16:creationId xmlns:a16="http://schemas.microsoft.com/office/drawing/2014/main" id="{196A3D5B-A6C4-49B2-8ABC-B5CEE75009B4}"/>
-              </a:ext>
-            </a:extLst>
-          </p:cNvPr>
-          <p:cNvSpPr>
-            <a:spLocks xmlns:a="http://schemas.openxmlformats.org/drawingml/2006/main" noGrp="1"/>
-          </p:cNvSpPr>
-          <p:nvPr/>
-        </p:nvSpPr>
-        <p:spPr>
-          <a:xfrm xmlns:a="http://schemas.openxmlformats.org/drawingml/2006/main">
-            <a:off x="304800" y="1219200"/>
-            <a:ext cx="38100" cy="3410100"/>
-          </a:xfrm>
-          <a:prstGeom xmlns:a="http://schemas.openxmlformats.org/drawingml/2006/main" prst="rect">
-            <a:avLst/>
-          </a:prstGeom>
-          <a:solidFill xmlns:a="http://schemas.openxmlformats.org/drawingml/2006/main">
-            <a:srgbClr val="FF4D4D"/>
-          </a:solidFill>
-          <a:ln xmlns:a="http://schemas.openxmlformats.org/drawingml/2006/main">
-            <a:noFill/>
-          </a:ln>
-        </p:spPr>
-        <p:txBody>
-          <a:bodyPr xmlns:a="http://schemas.openxmlformats.org/drawingml/2006/main" spcFirstLastPara="1" wrap="square" lIns="0" tIns="0" rIns="0" bIns="0" anchor="ctr">
-            <a:noAutofit/>
-          </a:bodyPr>
-          <a:lstStyle xmlns:a="http://schemas.openxmlformats.org/drawingml/2006/main"/>
-          <a:p xmlns:a="http://schemas.openxmlformats.org/drawingml/2006/main">
-            <a:pPr marL="0" lvl="0" indent="0" algn="l">
-              <a:spcBef>
-                <a:spcPts val="0"/>
-              </a:spcBef>
-              <a:spcAft>
-                <a:spcPts val="0"/>
-              </a:spcAft>
-              <a:buNone/>
-            </a:pPr>
-            <a:r>
-              <a:t/>
-            </a:r>
-            <a:endParaRPr/>
-          </a:p>
-        </p:txBody>
-      </p:sp>
-      <p:sp>
-        <p:nvSpPr>
-          <p:cNvPr id="606" name="Google Shape;606;p30">
-            <a:extLst xmlns:a="http://schemas.openxmlformats.org/drawingml/2006/main">
-              <a:ext uri="{FF2B5EF4-FFF2-40B4-BE49-F238E27FC236}">
-                <a16:creationId xmlns:a16="http://schemas.microsoft.com/office/drawing/2014/main" id="{49F9CDAA-5631-4822-9E9D-8ECDA15ACED4}"/>
-              </a:ext>
-            </a:extLst>
-          </p:cNvPr>
-          <p:cNvSpPr>
-            <a:spLocks xmlns:a="http://schemas.openxmlformats.org/drawingml/2006/main" noGrp="1"/>
-          </p:cNvSpPr>
-          <p:nvPr/>
-        </p:nvSpPr>
-        <p:spPr>
-          <a:xfrm xmlns:a="http://schemas.openxmlformats.org/drawingml/2006/main">
-            <a:off x="571500" y="1447800"/>
-            <a:ext cx="2569500" cy="2952900"/>
+            <a:off x="457200" y="1200150"/>
+            <a:ext cx="8229600" cy="342900"/>
           </a:xfrm>
           <a:prstGeom xmlns:a="http://schemas.openxmlformats.org/drawingml/2006/main" prst="rect">
             <a:avLst/>
@@ -26708,111 +26604,7 @@
                 <a:ea typeface="Inter"/>
                 <a:cs typeface="Inter"/>
               </a:rPr>
-              <a:t>The starter opens the modern eBPF engine through libsinsp and libscap.</a:t>
-            </a:r>
-          </a:p>
-          <a:p xmlns:a="http://schemas.openxmlformats.org/drawingml/2006/main">
-            <a:pPr marL="0" indent="0">
-              <a:spcBef>
-                <a:spcPts val="0"/>
-              </a:spcBef>
-              <a:spcAft>
-                <a:spcPts val="0"/>
-              </a:spcAft>
-              <a:buNone/>
-            </a:pPr>
-            <a:r>
-              <a:rPr sz="1500" b="0" i="0">
-                <a:solidFill>
-                  <a:srgbClr val="4A5568"/>
-                </a:solidFill>
-                <a:latin typeface="Inter"/>
-                <a:ea typeface="Inter"/>
-                <a:cs typeface="Inter"/>
-              </a:rPr>
-              <a:t/>
-            </a:r>
-          </a:p>
-          <a:p xmlns:a="http://schemas.openxmlformats.org/drawingml/2006/main">
-            <a:pPr marL="0" indent="0" algn="l">
-              <a:spcBef>
-                <a:spcPts val="0"/>
-              </a:spcBef>
-              <a:spcAft>
-                <a:spcPts val="0"/>
-              </a:spcAft>
-              <a:buNone/>
-              <a:defRPr sz="1500" b="0">
-                <a:solidFill>
-                  <a:srgbClr val="4A5568"/>
-                </a:solidFill>
-                <a:latin typeface="Inter"/>
-                <a:ea typeface="Inter"/>
-                <a:cs typeface="Inter"/>
-              </a:defRPr>
-            </a:pPr>
-            <a:r>
-              <a:rPr sz="1500" b="0" i="0">
-                <a:solidFill>
-                  <a:srgbClr val="4A5568"/>
-                </a:solidFill>
-                <a:latin typeface="Inter"/>
-                <a:ea typeface="Inter"/>
-                <a:cs typeface="Inter"/>
-              </a:rPr>
-              <a:t>It attaches but does not read events yet.</a:t>
-            </a:r>
-          </a:p>
-          <a:p xmlns:a="http://schemas.openxmlformats.org/drawingml/2006/main">
-            <a:pPr marL="0" indent="0">
-              <a:spcBef>
-                <a:spcPts val="0"/>
-              </a:spcBef>
-              <a:spcAft>
-                <a:spcPts val="0"/>
-              </a:spcAft>
-              <a:buNone/>
-            </a:pPr>
-            <a:r>
-              <a:rPr sz="1500" b="0" i="0">
-                <a:solidFill>
-                  <a:srgbClr val="4A5568"/>
-                </a:solidFill>
-                <a:latin typeface="Inter"/>
-                <a:ea typeface="Inter"/>
-                <a:cs typeface="Inter"/>
-              </a:rPr>
-              <a:t/>
-            </a:r>
-          </a:p>
-          <a:p xmlns:a="http://schemas.openxmlformats.org/drawingml/2006/main">
-            <a:pPr marL="0" indent="0" algn="l">
-              <a:spcBef>
-                <a:spcPts val="0"/>
-              </a:spcBef>
-              <a:spcAft>
-                <a:spcPts val="0"/>
-              </a:spcAft>
-              <a:buNone/>
-              <a:defRPr sz="1500" b="0">
-                <a:solidFill>
-                  <a:srgbClr val="4A5568"/>
-                </a:solidFill>
-                <a:latin typeface="Inter"/>
-                <a:ea typeface="Inter"/>
-                <a:cs typeface="Inter"/>
-              </a:defRPr>
-            </a:pPr>
-            <a:r>
-              <a:rPr sz="1500" b="0" i="0">
-                <a:solidFill>
-                  <a:srgbClr val="4A5568"/>
-                </a:solidFill>
-                <a:latin typeface="Inter"/>
-                <a:ea typeface="Inter"/>
-                <a:cs typeface="Inter"/>
-              </a:rPr>
-              <a:t>Run it in B, then press Enter to stop.</a:t>
+              <a:t>Terminal A: run each step when we reach it.</a:t>
             </a:r>
           </a:p>
         </p:txBody>
@@ -26833,8 +26625,8 @@
         </p:nvSpPr>
         <p:spPr>
           <a:xfrm xmlns:a="http://schemas.openxmlformats.org/drawingml/2006/main">
-            <a:off x="3482825" y="1219200"/>
-            <a:ext cx="5356500" cy="3410100"/>
+            <a:off x="304800" y="1657350"/>
+            <a:ext cx="8534400" cy="3009900"/>
           </a:xfrm>
           <a:prstGeom xmlns:a="http://schemas.openxmlformats.org/drawingml/2006/main" prst="roundRect">
             <a:avLst>
@@ -26886,7 +26678,7 @@
         </p:nvSpPr>
         <p:spPr>
           <a:xfrm xmlns:a="http://schemas.openxmlformats.org/drawingml/2006/main" rot="0" flipH="0" flipV="0">
-            <a:off x="3774125" y="1409700"/>
+            <a:off x="495300" y="1809750"/>
             <a:ext cx="114300" cy="114300"/>
           </a:xfrm>
           <a:prstGeom xmlns:a="http://schemas.openxmlformats.org/drawingml/2006/main" prst="ellipse">
@@ -26937,7 +26729,7 @@
         </p:nvSpPr>
         <p:spPr>
           <a:xfrm xmlns:a="http://schemas.openxmlformats.org/drawingml/2006/main" rot="0" flipH="0" flipV="0">
-            <a:off x="3945575" y="1409700"/>
+            <a:off x="666750" y="1809750"/>
             <a:ext cx="114300" cy="114300"/>
           </a:xfrm>
           <a:prstGeom xmlns:a="http://schemas.openxmlformats.org/drawingml/2006/main" prst="ellipse">
@@ -26988,7 +26780,7 @@
         </p:nvSpPr>
         <p:spPr>
           <a:xfrm xmlns:a="http://schemas.openxmlformats.org/drawingml/2006/main" rot="0" flipH="0" flipV="0">
-            <a:off x="4117025" y="1409700"/>
+            <a:off x="838200" y="1809750"/>
             <a:ext cx="114300" cy="114300"/>
           </a:xfrm>
           <a:prstGeom xmlns:a="http://schemas.openxmlformats.org/drawingml/2006/main" prst="ellipse">
@@ -27039,8 +26831,8 @@
         </p:nvSpPr>
         <p:spPr>
           <a:xfrm xmlns:a="http://schemas.openxmlformats.org/drawingml/2006/main">
-            <a:off x="4394700" y="1352550"/>
-            <a:ext cx="2806200" cy="228600"/>
+            <a:off x="1123950" y="1762125"/>
+            <a:ext cx="6667500" cy="228600"/>
           </a:xfrm>
           <a:prstGeom xmlns:a="http://schemas.openxmlformats.org/drawingml/2006/main" prst="rect">
             <a:avLst/>
@@ -27082,7 +26874,7 @@
                 <a:ea typeface="Roboto Mono"/>
                 <a:cs typeface="Roboto Mono"/>
               </a:rPr>
-              <a:t>src/main.cpp — already provided</a:t>
+              <a:t>Mac: Terminal in the repo folder</a:t>
             </a:r>
           </a:p>
         </p:txBody>
@@ -27103,8 +26895,8 @@
         </p:nvSpPr>
         <p:spPr>
           <a:xfrm xmlns:a="http://schemas.openxmlformats.org/drawingml/2006/main">
-            <a:off x="4457700" y="1638300"/>
-            <a:ext cx="4381500" cy="9600"/>
+            <a:off x="495300" y="2019300"/>
+            <a:ext cx="8153400" cy="9525"/>
           </a:xfrm>
           <a:prstGeom xmlns:a="http://schemas.openxmlformats.org/drawingml/2006/main" prst="rect">
             <a:avLst/>
@@ -27156,8 +26948,8 @@
         </p:nvSpPr>
         <p:spPr>
           <a:xfrm xmlns:a="http://schemas.openxmlformats.org/drawingml/2006/main">
-            <a:off x="3774125" y="1828800"/>
-            <a:ext cx="4836600" cy="2571900"/>
+            <a:off x="495300" y="2152650"/>
+            <a:ext cx="8153400" cy="2400300"/>
           </a:xfrm>
           <a:prstGeom xmlns:a="http://schemas.openxmlformats.org/drawingml/2006/main" prst="rect">
             <a:avLst/>
@@ -27181,7 +26973,7 @@
                 <a:spcPts val="0"/>
               </a:spcAft>
               <a:buNone/>
-              <a:defRPr sz="1350" b="0">
+              <a:defRPr sz="1500" b="0">
                 <a:solidFill>
                   <a:srgbClr val="00E5FF"/>
                 </a:solidFill>
@@ -27191,7 +26983,7 @@
               </a:defRPr>
             </a:pPr>
             <a:r>
-              <a:rPr sz="1350" b="0" i="0">
+              <a:rPr sz="1500" b="0" i="0">
                 <a:solidFill>
                   <a:srgbClr val="00E5FF"/>
                 </a:solidFill>
@@ -27199,7 +26991,29 @@
                 <a:ea typeface="Roboto Mono"/>
                 <a:cs typeface="Roboto Mono"/>
               </a:rPr>
-              <a:t>sinsp inspector;</a:t>
+              <a:t>bash scripts/mac/step-1.sh</a:t>
+            </a:r>
+          </a:p>
+          <a:p xmlns:a="http://schemas.openxmlformats.org/drawingml/2006/main">
+            <a:pPr marL="0" indent="0">
+              <a:spcBef>
+                <a:spcPts val="0"/>
+              </a:spcBef>
+              <a:spcAft>
+                <a:spcPts val="0"/>
+              </a:spcAft>
+              <a:buNone/>
+            </a:pPr>
+            <a:r>
+              <a:rPr sz="1500" b="0" i="0">
+                <a:solidFill>
+                  <a:srgbClr val="00E5FF"/>
+                </a:solidFill>
+                <a:latin typeface="Roboto Mono"/>
+                <a:ea typeface="Roboto Mono"/>
+                <a:cs typeface="Roboto Mono"/>
+              </a:rPr>
+              <a:t/>
             </a:r>
           </a:p>
           <a:p xmlns:a="http://schemas.openxmlformats.org/drawingml/2006/main">
@@ -27211,7 +27025,7 @@
                 <a:spcPts val="0"/>
               </a:spcAft>
               <a:buNone/>
-              <a:defRPr sz="1350" b="0">
+              <a:defRPr sz="1500" b="0">
                 <a:solidFill>
                   <a:srgbClr val="00E5FF"/>
                 </a:solidFill>
@@ -27221,7 +27035,7 @@
               </a:defRPr>
             </a:pPr>
             <a:r>
-              <a:rPr sz="1350" b="0" i="0">
+              <a:rPr sz="1500" b="0" i="0">
                 <a:solidFill>
                   <a:srgbClr val="00E5FF"/>
                 </a:solidFill>
@@ -27229,7 +27043,29 @@
                 <a:ea typeface="Roboto Mono"/>
                 <a:cs typeface="Roboto Mono"/>
               </a:rPr>
-              <a:t>inspector.open_modern_bpf();</a:t>
+              <a:t>bash scripts/mac/step-2.sh</a:t>
+            </a:r>
+          </a:p>
+          <a:p xmlns:a="http://schemas.openxmlformats.org/drawingml/2006/main">
+            <a:pPr marL="0" indent="0">
+              <a:spcBef>
+                <a:spcPts val="0"/>
+              </a:spcBef>
+              <a:spcAft>
+                <a:spcPts val="0"/>
+              </a:spcAft>
+              <a:buNone/>
+            </a:pPr>
+            <a:r>
+              <a:rPr sz="1500" b="0" i="0">
+                <a:solidFill>
+                  <a:srgbClr val="00E5FF"/>
+                </a:solidFill>
+                <a:latin typeface="Roboto Mono"/>
+                <a:ea typeface="Roboto Mono"/>
+                <a:cs typeface="Roboto Mono"/>
+              </a:rPr>
+              <a:t/>
             </a:r>
           </a:p>
           <a:p xmlns:a="http://schemas.openxmlformats.org/drawingml/2006/main">
@@ -27241,7 +27077,7 @@
                 <a:spcPts val="0"/>
               </a:spcAft>
               <a:buNone/>
-              <a:defRPr sz="1350" b="0">
+              <a:defRPr sz="1500" b="0">
                 <a:solidFill>
                   <a:srgbClr val="00E5FF"/>
                 </a:solidFill>
@@ -27251,7 +27087,7 @@
               </a:defRPr>
             </a:pPr>
             <a:r>
-              <a:rPr sz="1350" b="0" i="0">
+              <a:rPr sz="1500" b="0" i="0">
                 <a:solidFill>
                   <a:srgbClr val="00E5FF"/>
                 </a:solidFill>
@@ -27259,7 +27095,7 @@
                 <a:ea typeface="Roboto Mono"/>
                 <a:cs typeface="Roboto Mono"/>
               </a:rPr>
-              <a:t>inspector.start_capture();</a:t>
+              <a:t>bash scripts/mac/step-3.sh</a:t>
             </a:r>
           </a:p>
           <a:p xmlns:a="http://schemas.openxmlformats.org/drawingml/2006/main">
@@ -27273,7 +27109,7 @@
               <a:buNone/>
             </a:pPr>
             <a:r>
-              <a:rPr sz="1350" b="0" i="0">
+              <a:rPr sz="1500" b="0" i="0">
                 <a:solidFill>
                   <a:srgbClr val="00E5FF"/>
                 </a:solidFill>
@@ -27293,7 +27129,7 @@
                 <a:spcPts val="0"/>
               </a:spcAft>
               <a:buNone/>
-              <a:defRPr sz="1350" b="0">
+              <a:defRPr sz="1500" b="0">
                 <a:solidFill>
                   <a:srgbClr val="00E5FF"/>
                 </a:solidFill>
@@ -27303,7 +27139,7 @@
               </a:defRPr>
             </a:pPr>
             <a:r>
-              <a:rPr sz="1350" b="0" i="0">
+              <a:rPr sz="1500" b="0" i="0">
                 <a:solidFill>
                   <a:srgbClr val="00E5FF"/>
                 </a:solidFill>
@@ -27311,201 +27147,7 @@
                 <a:ea typeface="Roboto Mono"/>
                 <a:cs typeface="Roboto Mono"/>
               </a:rPr>
-              <a:t>std::cout &lt;&lt; "Attached." &lt;&lt; std::endl;</a:t>
-            </a:r>
-          </a:p>
-          <a:p xmlns:a="http://schemas.openxmlformats.org/drawingml/2006/main">
-            <a:pPr marL="0" indent="0" algn="l">
-              <a:spcBef>
-                <a:spcPts val="0"/>
-              </a:spcBef>
-              <a:spcAft>
-                <a:spcPts val="0"/>
-              </a:spcAft>
-              <a:buNone/>
-              <a:defRPr sz="1350" b="0">
-                <a:solidFill>
-                  <a:srgbClr val="00E5FF"/>
-                </a:solidFill>
-                <a:latin typeface="Roboto Mono"/>
-                <a:ea typeface="Roboto Mono"/>
-                <a:cs typeface="Roboto Mono"/>
-              </a:defRPr>
-            </a:pPr>
-            <a:r>
-              <a:rPr sz="1350" b="0" i="0">
-                <a:solidFill>
-                  <a:srgbClr val="00E5FF"/>
-                </a:solidFill>
-                <a:latin typeface="Roboto Mono"/>
-                <a:ea typeface="Roboto Mono"/>
-                <a:cs typeface="Roboto Mono"/>
-              </a:rPr>
-              <a:t>std::cin.get();</a:t>
-            </a:r>
-          </a:p>
-          <a:p xmlns:a="http://schemas.openxmlformats.org/drawingml/2006/main">
-            <a:pPr marL="0" indent="0">
-              <a:spcBef>
-                <a:spcPts val="0"/>
-              </a:spcBef>
-              <a:spcAft>
-                <a:spcPts val="0"/>
-              </a:spcAft>
-              <a:buNone/>
-            </a:pPr>
-            <a:r>
-              <a:rPr sz="1350" b="0" i="0">
-                <a:solidFill>
-                  <a:srgbClr val="00E5FF"/>
-                </a:solidFill>
-                <a:latin typeface="Roboto Mono"/>
-                <a:ea typeface="Roboto Mono"/>
-                <a:cs typeface="Roboto Mono"/>
-              </a:rPr>
-              <a:t/>
-            </a:r>
-          </a:p>
-          <a:p xmlns:a="http://schemas.openxmlformats.org/drawingml/2006/main">
-            <a:pPr marL="0" indent="0" algn="l">
-              <a:spcBef>
-                <a:spcPts val="0"/>
-              </a:spcBef>
-              <a:spcAft>
-                <a:spcPts val="0"/>
-              </a:spcAft>
-              <a:buNone/>
-              <a:defRPr sz="1350" b="0">
-                <a:solidFill>
-                  <a:srgbClr val="00E5FF"/>
-                </a:solidFill>
-                <a:latin typeface="Roboto Mono"/>
-                <a:ea typeface="Roboto Mono"/>
-                <a:cs typeface="Roboto Mono"/>
-              </a:defRPr>
-            </a:pPr>
-            <a:r>
-              <a:rPr sz="1350" b="0" i="0">
-                <a:solidFill>
-                  <a:srgbClr val="00E5FF"/>
-                </a:solidFill>
-                <a:latin typeface="Roboto Mono"/>
-                <a:ea typeface="Roboto Mono"/>
-                <a:cs typeface="Roboto Mono"/>
-              </a:rPr>
-              <a:t>inspector.stop_capture();</a:t>
-            </a:r>
-          </a:p>
-          <a:p xmlns:a="http://schemas.openxmlformats.org/drawingml/2006/main">
-            <a:pPr marL="0" indent="0" algn="l">
-              <a:spcBef>
-                <a:spcPts val="0"/>
-              </a:spcBef>
-              <a:spcAft>
-                <a:spcPts val="0"/>
-              </a:spcAft>
-              <a:buNone/>
-              <a:defRPr sz="1350" b="0">
-                <a:solidFill>
-                  <a:srgbClr val="00E5FF"/>
-                </a:solidFill>
-                <a:latin typeface="Roboto Mono"/>
-                <a:ea typeface="Roboto Mono"/>
-                <a:cs typeface="Roboto Mono"/>
-              </a:defRPr>
-            </a:pPr>
-            <a:r>
-              <a:rPr sz="1350" b="0" i="0">
-                <a:solidFill>
-                  <a:srgbClr val="00E5FF"/>
-                </a:solidFill>
-                <a:latin typeface="Roboto Mono"/>
-                <a:ea typeface="Roboto Mono"/>
-                <a:cs typeface="Roboto Mono"/>
-              </a:rPr>
-              <a:t>inspector.close();</a:t>
-            </a:r>
-          </a:p>
-          <a:p xmlns:a="http://schemas.openxmlformats.org/drawingml/2006/main">
-            <a:pPr marL="0" indent="0">
-              <a:spcBef>
-                <a:spcPts val="0"/>
-              </a:spcBef>
-              <a:spcAft>
-                <a:spcPts val="0"/>
-              </a:spcAft>
-              <a:buNone/>
-            </a:pPr>
-            <a:r>
-              <a:rPr sz="1350" b="0" i="0">
-                <a:solidFill>
-                  <a:srgbClr val="00E5FF"/>
-                </a:solidFill>
-                <a:latin typeface="Roboto Mono"/>
-                <a:ea typeface="Roboto Mono"/>
-                <a:cs typeface="Roboto Mono"/>
-              </a:rPr>
-              <a:t/>
-            </a:r>
-          </a:p>
-          <a:p xmlns:a="http://schemas.openxmlformats.org/drawingml/2006/main">
-            <a:pPr marL="0" indent="0" algn="l">
-              <a:spcBef>
-                <a:spcPts val="0"/>
-              </a:spcBef>
-              <a:spcAft>
-                <a:spcPts val="0"/>
-              </a:spcAft>
-              <a:buNone/>
-              <a:defRPr sz="1350" b="0">
-                <a:solidFill>
-                  <a:srgbClr val="00E5FF"/>
-                </a:solidFill>
-                <a:latin typeface="Roboto Mono"/>
-                <a:ea typeface="Roboto Mono"/>
-                <a:cs typeface="Roboto Mono"/>
-              </a:defRPr>
-            </a:pPr>
-            <a:r>
-              <a:rPr sz="1350" b="0" i="0">
-                <a:solidFill>
-                  <a:srgbClr val="00E5FF"/>
-                </a:solidFill>
-                <a:latin typeface="Roboto Mono"/>
-                <a:ea typeface="Roboto Mono"/>
-                <a:cs typeface="Roboto Mono"/>
-              </a:rPr>
-              <a:t># VM terminal B</a:t>
-            </a:r>
-          </a:p>
-          <a:p xmlns:a="http://schemas.openxmlformats.org/drawingml/2006/main">
-            <a:pPr marL="0" indent="0" algn="l">
-              <a:spcBef>
-                <a:spcPts val="0"/>
-              </a:spcBef>
-              <a:spcAft>
-                <a:spcPts val="0"/>
-              </a:spcAft>
-              <a:buNone/>
-              <a:defRPr sz="1350" b="0">
-                <a:solidFill>
-                  <a:srgbClr val="00E5FF"/>
-                </a:solidFill>
-                <a:latin typeface="Roboto Mono"/>
-                <a:ea typeface="Roboto Mono"/>
-                <a:cs typeface="Roboto Mono"/>
-              </a:defRPr>
-            </a:pPr>
-            <a:r>
-              <a:rPr sz="1350" b="0" i="0">
-                <a:solidFill>
-                  <a:srgbClr val="00E5FF"/>
-                </a:solidFill>
-                <a:latin typeface="Roboto Mono"/>
-                <a:ea typeface="Roboto Mono"/>
-                <a:cs typeface="Roboto Mono"/>
-              </a:rPr>
-              <a:t>sudo ./build/bin/workshop-agent</a:t>
+              <a:t>bash scripts/mac/step-4.sh</a:t>
             </a:r>
           </a:p>
         </p:txBody>
@@ -28148,14 +27790,14 @@
       </p:sp>
       <p:pic>
         <p:nvPicPr>
-          <p:cNvPr id="665" name="Google Shape;628;p30"/>
+          <p:cNvPr id="663" name="Google Shape;628;p30"/>
           <p:cNvPicPr>
             <a:picLocks xmlns:a="http://schemas.openxmlformats.org/drawingml/2006/main" noChangeAspect="1"/>
           </p:cNvPicPr>
           <p:nvPr/>
         </p:nvPicPr>
         <p:blipFill rotWithShape="1">
-          <a:blip xmlns:r="http://schemas.openxmlformats.org/officeDocument/2006/relationships" xmlns:a="http://schemas.openxmlformats.org/drawingml/2006/main" r:embed="R60460b80174548e4">
+          <a:blip xmlns:r="http://schemas.openxmlformats.org/officeDocument/2006/relationships" xmlns:a="http://schemas.openxmlformats.org/drawingml/2006/main" r:embed="R04ecfb2ad1794182">
             <a:alphaModFix/>
           </a:blip>
           <a:srcRect xmlns:a="http://schemas.openxmlformats.org/drawingml/2006/main" l="0" t="0" r="0" b="0"/>
@@ -28176,14 +27818,14 @@
       </p:pic>
       <p:pic>
         <p:nvPicPr>
-          <p:cNvPr id="666" name="Google Shape;629;p30"/>
+          <p:cNvPr id="664" name="Google Shape;629;p30"/>
           <p:cNvPicPr>
             <a:picLocks xmlns:a="http://schemas.openxmlformats.org/drawingml/2006/main" noChangeAspect="1"/>
           </p:cNvPicPr>
           <p:nvPr/>
         </p:nvPicPr>
         <p:blipFill rotWithShape="1">
-          <a:blip xmlns:r="http://schemas.openxmlformats.org/officeDocument/2006/relationships" xmlns:a="http://schemas.openxmlformats.org/drawingml/2006/main" r:embed="R60460b80174548e4">
+          <a:blip xmlns:r="http://schemas.openxmlformats.org/officeDocument/2006/relationships" xmlns:a="http://schemas.openxmlformats.org/drawingml/2006/main" r:embed="R04ecfb2ad1794182">
             <a:alphaModFix/>
           </a:blip>
           <a:srcRect xmlns:a="http://schemas.openxmlformats.org/drawingml/2006/main" l="0" t="0" r="0" b="0"/>
@@ -28204,14 +27846,14 @@
       </p:pic>
       <p:pic>
         <p:nvPicPr>
-          <p:cNvPr id="667" name="Google Shape;630;p30"/>
+          <p:cNvPr id="665" name="Google Shape;630;p30"/>
           <p:cNvPicPr>
             <a:picLocks xmlns:a="http://schemas.openxmlformats.org/drawingml/2006/main" noChangeAspect="1"/>
           </p:cNvPicPr>
           <p:nvPr/>
         </p:nvPicPr>
         <p:blipFill rotWithShape="1">
-          <a:blip xmlns:r="http://schemas.openxmlformats.org/officeDocument/2006/relationships" xmlns:a="http://schemas.openxmlformats.org/drawingml/2006/main" r:embed="R60460b80174548e4">
+          <a:blip xmlns:r="http://schemas.openxmlformats.org/officeDocument/2006/relationships" xmlns:a="http://schemas.openxmlformats.org/drawingml/2006/main" r:embed="R04ecfb2ad1794182">
             <a:alphaModFix/>
           </a:blip>
           <a:srcRect xmlns:a="http://schemas.openxmlformats.org/drawingml/2006/main" l="0" t="0" r="0" b="0"/>
@@ -28232,14 +27874,14 @@
       </p:pic>
       <p:pic>
         <p:nvPicPr>
-          <p:cNvPr id="668" name="Google Shape;631;p30"/>
+          <p:cNvPr id="666" name="Google Shape;631;p30"/>
           <p:cNvPicPr>
             <a:picLocks xmlns:a="http://schemas.openxmlformats.org/drawingml/2006/main" noChangeAspect="1"/>
           </p:cNvPicPr>
           <p:nvPr/>
         </p:nvPicPr>
         <p:blipFill rotWithShape="1">
-          <a:blip xmlns:r="http://schemas.openxmlformats.org/officeDocument/2006/relationships" xmlns:a="http://schemas.openxmlformats.org/drawingml/2006/main" r:embed="R60460b80174548e4">
+          <a:blip xmlns:r="http://schemas.openxmlformats.org/officeDocument/2006/relationships" xmlns:a="http://schemas.openxmlformats.org/drawingml/2006/main" r:embed="R04ecfb2ad1794182">
             <a:alphaModFix/>
           </a:blip>
           <a:srcRect xmlns:a="http://schemas.openxmlformats.org/drawingml/2006/main" l="0" t="0" r="0" b="0"/>
@@ -28669,7 +28311,7 @@
                 <a:ea typeface="Montserrat"/>
                 <a:cs typeface="Montserrat"/>
               </a:rPr>
-              <a:t>Mac steps</a:t>
+              <a:t>Windows steps</a:t>
             </a:r>
           </a:p>
         </p:txBody>
@@ -29003,7 +28645,7 @@
                 <a:ea typeface="Roboto Mono"/>
                 <a:cs typeface="Roboto Mono"/>
               </a:rPr>
-              <a:t>Mac: Terminal in the repo folder</a:t>
+              <a:t>Windows: PowerShell in the repo folder</a:t>
             </a:r>
           </a:p>
         </p:txBody>
@@ -29120,7 +28762,7 @@
                 <a:ea typeface="Roboto Mono"/>
                 <a:cs typeface="Roboto Mono"/>
               </a:rPr>
-              <a:t>bash scripts/mac/step-1.sh</a:t>
+              <a:t>powershell -ExecutionPolicy Bypass -File scripts/windows/step-1.ps1</a:t>
             </a:r>
           </a:p>
           <a:p xmlns:a="http://schemas.openxmlformats.org/drawingml/2006/main">
@@ -29172,7 +28814,7 @@
                 <a:ea typeface="Roboto Mono"/>
                 <a:cs typeface="Roboto Mono"/>
               </a:rPr>
-              <a:t>bash scripts/mac/step-2.sh</a:t>
+              <a:t>powershell -ExecutionPolicy Bypass -File scripts/windows/step-2.ps1</a:t>
             </a:r>
           </a:p>
           <a:p xmlns:a="http://schemas.openxmlformats.org/drawingml/2006/main">
@@ -29224,7 +28866,59 @@
                 <a:ea typeface="Roboto Mono"/>
                 <a:cs typeface="Roboto Mono"/>
               </a:rPr>
-              <a:t>bash scripts/mac/step-3.sh</a:t>
+              <a:t>powershell -ExecutionPolicy Bypass -File scripts/windows/step-3.ps1</a:t>
+            </a:r>
+          </a:p>
+          <a:p xmlns:a="http://schemas.openxmlformats.org/drawingml/2006/main">
+            <a:pPr marL="0" indent="0">
+              <a:spcBef>
+                <a:spcPts val="0"/>
+              </a:spcBef>
+              <a:spcAft>
+                <a:spcPts val="0"/>
+              </a:spcAft>
+              <a:buNone/>
+            </a:pPr>
+            <a:r>
+              <a:rPr sz="1500" b="0" i="0">
+                <a:solidFill>
+                  <a:srgbClr val="00E5FF"/>
+                </a:solidFill>
+                <a:latin typeface="Roboto Mono"/>
+                <a:ea typeface="Roboto Mono"/>
+                <a:cs typeface="Roboto Mono"/>
+              </a:rPr>
+              <a:t/>
+            </a:r>
+          </a:p>
+          <a:p xmlns:a="http://schemas.openxmlformats.org/drawingml/2006/main">
+            <a:pPr marL="0" indent="0" algn="l">
+              <a:spcBef>
+                <a:spcPts val="0"/>
+              </a:spcBef>
+              <a:spcAft>
+                <a:spcPts val="0"/>
+              </a:spcAft>
+              <a:buNone/>
+              <a:defRPr sz="1500" b="0">
+                <a:solidFill>
+                  <a:srgbClr val="00E5FF"/>
+                </a:solidFill>
+                <a:latin typeface="Roboto Mono"/>
+                <a:ea typeface="Roboto Mono"/>
+                <a:cs typeface="Roboto Mono"/>
+              </a:defRPr>
+            </a:pPr>
+            <a:r>
+              <a:rPr sz="1500" b="0" i="0">
+                <a:solidFill>
+                  <a:srgbClr val="00E5FF"/>
+                </a:solidFill>
+                <a:latin typeface="Roboto Mono"/>
+                <a:ea typeface="Roboto Mono"/>
+                <a:cs typeface="Roboto Mono"/>
+              </a:rPr>
+              <a:t>powershell -ExecutionPolicy Bypass -File scripts/windows/step-4.ps1</a:t>
             </a:r>
           </a:p>
         </p:txBody>
@@ -29874,7 +29568,7 @@
           <p:nvPr/>
         </p:nvPicPr>
         <p:blipFill rotWithShape="1">
-          <a:blip xmlns:r="http://schemas.openxmlformats.org/officeDocument/2006/relationships" xmlns:a="http://schemas.openxmlformats.org/drawingml/2006/main" r:embed="Rb6dfbb3458974940">
+          <a:blip xmlns:r="http://schemas.openxmlformats.org/officeDocument/2006/relationships" xmlns:a="http://schemas.openxmlformats.org/drawingml/2006/main" r:embed="R0082e0bb41e24eca">
             <a:alphaModFix/>
           </a:blip>
           <a:srcRect xmlns:a="http://schemas.openxmlformats.org/drawingml/2006/main" l="0" t="0" r="0" b="0"/>
@@ -29902,7 +29596,7 @@
           <p:nvPr/>
         </p:nvPicPr>
         <p:blipFill rotWithShape="1">
-          <a:blip xmlns:r="http://schemas.openxmlformats.org/officeDocument/2006/relationships" xmlns:a="http://schemas.openxmlformats.org/drawingml/2006/main" r:embed="Rb6dfbb3458974940">
+          <a:blip xmlns:r="http://schemas.openxmlformats.org/officeDocument/2006/relationships" xmlns:a="http://schemas.openxmlformats.org/drawingml/2006/main" r:embed="R0082e0bb41e24eca">
             <a:alphaModFix/>
           </a:blip>
           <a:srcRect xmlns:a="http://schemas.openxmlformats.org/drawingml/2006/main" l="0" t="0" r="0" b="0"/>
@@ -29930,7 +29624,7 @@
           <p:nvPr/>
         </p:nvPicPr>
         <p:blipFill rotWithShape="1">
-          <a:blip xmlns:r="http://schemas.openxmlformats.org/officeDocument/2006/relationships" xmlns:a="http://schemas.openxmlformats.org/drawingml/2006/main" r:embed="Rb6dfbb3458974940">
+          <a:blip xmlns:r="http://schemas.openxmlformats.org/officeDocument/2006/relationships" xmlns:a="http://schemas.openxmlformats.org/drawingml/2006/main" r:embed="R0082e0bb41e24eca">
             <a:alphaModFix/>
           </a:blip>
           <a:srcRect xmlns:a="http://schemas.openxmlformats.org/drawingml/2006/main" l="0" t="0" r="0" b="0"/>
@@ -29958,7 +29652,7 @@
           <p:nvPr/>
         </p:nvPicPr>
         <p:blipFill rotWithShape="1">
-          <a:blip xmlns:r="http://schemas.openxmlformats.org/officeDocument/2006/relationships" xmlns:a="http://schemas.openxmlformats.org/drawingml/2006/main" r:embed="Rb6dfbb3458974940">
+          <a:blip xmlns:r="http://schemas.openxmlformats.org/officeDocument/2006/relationships" xmlns:a="http://schemas.openxmlformats.org/drawingml/2006/main" r:embed="R0082e0bb41e24eca">
             <a:alphaModFix/>
           </a:blip>
           <a:srcRect xmlns:a="http://schemas.openxmlformats.org/drawingml/2006/main" l="0" t="0" r="0" b="0"/>
@@ -30388,8 +30082,112 @@
                 <a:ea typeface="Montserrat"/>
                 <a:cs typeface="Montserrat"/>
               </a:rPr>
-              <a:t>Windows steps</a:t>
-            </a:r>
+              <a:t>Step 1: Create the collector</a:t>
+            </a:r>
+          </a:p>
+        </p:txBody>
+      </p:sp>
+      <p:sp>
+        <p:nvSpPr>
+          <p:cNvPr id="604" name="Google Shape;604;p30">
+            <a:extLst xmlns:a="http://schemas.openxmlformats.org/drawingml/2006/main">
+              <a:ext uri="{FF2B5EF4-FFF2-40B4-BE49-F238E27FC236}">
+                <a16:creationId xmlns:a16="http://schemas.microsoft.com/office/drawing/2014/main" id="{CB1389F3-AE35-44FF-B13C-8FDB3606FAB8}"/>
+              </a:ext>
+            </a:extLst>
+          </p:cNvPr>
+          <p:cNvSpPr>
+            <a:spLocks xmlns:a="http://schemas.openxmlformats.org/drawingml/2006/main" noGrp="1"/>
+          </p:cNvSpPr>
+          <p:nvPr/>
+        </p:nvSpPr>
+        <p:spPr>
+          <a:xfrm xmlns:a="http://schemas.openxmlformats.org/drawingml/2006/main">
+            <a:off x="304800" y="1219200"/>
+            <a:ext cx="3013500" cy="3410100"/>
+          </a:xfrm>
+          <a:prstGeom xmlns:a="http://schemas.openxmlformats.org/drawingml/2006/main" prst="roundRect">
+            <a:avLst>
+              <a:gd name="adj" fmla="val 1117"/>
+            </a:avLst>
+          </a:prstGeom>
+          <a:solidFill xmlns:a="http://schemas.openxmlformats.org/drawingml/2006/main">
+            <a:srgbClr val="F4F7F6"/>
+          </a:solidFill>
+          <a:ln xmlns:a="http://schemas.openxmlformats.org/drawingml/2006/main">
+            <a:noFill/>
+          </a:ln>
+        </p:spPr>
+        <p:txBody>
+          <a:bodyPr xmlns:a="http://schemas.openxmlformats.org/drawingml/2006/main" spcFirstLastPara="1" wrap="square" lIns="0" tIns="0" rIns="0" bIns="0" anchor="ctr">
+            <a:noAutofit/>
+          </a:bodyPr>
+          <a:lstStyle xmlns:a="http://schemas.openxmlformats.org/drawingml/2006/main"/>
+          <a:p xmlns:a="http://schemas.openxmlformats.org/drawingml/2006/main">
+            <a:pPr marL="0" lvl="0" indent="0" algn="l">
+              <a:spcBef>
+                <a:spcPts val="0"/>
+              </a:spcBef>
+              <a:spcAft>
+                <a:spcPts val="0"/>
+              </a:spcAft>
+              <a:buNone/>
+            </a:pPr>
+            <a:r>
+              <a:t/>
+            </a:r>
+            <a:endParaRPr/>
+          </a:p>
+        </p:txBody>
+      </p:sp>
+      <p:sp>
+        <p:nvSpPr>
+          <p:cNvPr id="605" name="Google Shape;605;p30">
+            <a:extLst xmlns:a="http://schemas.openxmlformats.org/drawingml/2006/main">
+              <a:ext uri="{FF2B5EF4-FFF2-40B4-BE49-F238E27FC236}">
+                <a16:creationId xmlns:a16="http://schemas.microsoft.com/office/drawing/2014/main" id="{196A3D5B-A6C4-49B2-8ABC-B5CEE75009B4}"/>
+              </a:ext>
+            </a:extLst>
+          </p:cNvPr>
+          <p:cNvSpPr>
+            <a:spLocks xmlns:a="http://schemas.openxmlformats.org/drawingml/2006/main" noGrp="1"/>
+          </p:cNvSpPr>
+          <p:nvPr/>
+        </p:nvSpPr>
+        <p:spPr>
+          <a:xfrm xmlns:a="http://schemas.openxmlformats.org/drawingml/2006/main">
+            <a:off x="304800" y="1219200"/>
+            <a:ext cx="38100" cy="3410100"/>
+          </a:xfrm>
+          <a:prstGeom xmlns:a="http://schemas.openxmlformats.org/drawingml/2006/main" prst="rect">
+            <a:avLst/>
+          </a:prstGeom>
+          <a:solidFill xmlns:a="http://schemas.openxmlformats.org/drawingml/2006/main">
+            <a:srgbClr val="FF4D4D"/>
+          </a:solidFill>
+          <a:ln xmlns:a="http://schemas.openxmlformats.org/drawingml/2006/main">
+            <a:noFill/>
+          </a:ln>
+        </p:spPr>
+        <p:txBody>
+          <a:bodyPr xmlns:a="http://schemas.openxmlformats.org/drawingml/2006/main" spcFirstLastPara="1" wrap="square" lIns="0" tIns="0" rIns="0" bIns="0" anchor="ctr">
+            <a:noAutofit/>
+          </a:bodyPr>
+          <a:lstStyle xmlns:a="http://schemas.openxmlformats.org/drawingml/2006/main"/>
+          <a:p xmlns:a="http://schemas.openxmlformats.org/drawingml/2006/main">
+            <a:pPr marL="0" lvl="0" indent="0" algn="l">
+              <a:spcBef>
+                <a:spcPts val="0"/>
+              </a:spcBef>
+              <a:spcAft>
+                <a:spcPts val="0"/>
+              </a:spcAft>
+              <a:buNone/>
+            </a:pPr>
+            <a:r>
+              <a:t/>
+            </a:r>
+            <a:endParaRPr/>
           </a:p>
         </p:txBody>
       </p:sp>
@@ -30409,8 +30207,8 @@
         </p:nvSpPr>
         <p:spPr>
           <a:xfrm xmlns:a="http://schemas.openxmlformats.org/drawingml/2006/main">
-            <a:off x="457200" y="1200150"/>
-            <a:ext cx="8229600" cy="342900"/>
+            <a:off x="571500" y="1447800"/>
+            <a:ext cx="2569500" cy="2952900"/>
           </a:xfrm>
           <a:prstGeom xmlns:a="http://schemas.openxmlformats.org/drawingml/2006/main" prst="rect">
             <a:avLst/>
@@ -30452,7 +30250,111 @@
                 <a:ea typeface="Inter"/>
                 <a:cs typeface="Inter"/>
               </a:rPr>
-              <a:t>Terminal A: run each step when we reach it.</a:t>
+              <a:t>Run step 1 in terminal A.</a:t>
+            </a:r>
+          </a:p>
+          <a:p xmlns:a="http://schemas.openxmlformats.org/drawingml/2006/main">
+            <a:pPr marL="0" indent="0">
+              <a:spcBef>
+                <a:spcPts val="0"/>
+              </a:spcBef>
+              <a:spcAft>
+                <a:spcPts val="0"/>
+              </a:spcAft>
+              <a:buNone/>
+            </a:pPr>
+            <a:r>
+              <a:rPr sz="1500" b="0" i="0">
+                <a:solidFill>
+                  <a:srgbClr val="4A5568"/>
+                </a:solidFill>
+                <a:latin typeface="Inter"/>
+                <a:ea typeface="Inter"/>
+                <a:cs typeface="Inter"/>
+              </a:rPr>
+              <a:t/>
+            </a:r>
+          </a:p>
+          <a:p xmlns:a="http://schemas.openxmlformats.org/drawingml/2006/main">
+            <a:pPr marL="0" indent="0" algn="l">
+              <a:spcBef>
+                <a:spcPts val="0"/>
+              </a:spcBef>
+              <a:spcAft>
+                <a:spcPts val="0"/>
+              </a:spcAft>
+              <a:buNone/>
+              <a:defRPr sz="1500" b="0">
+                <a:solidFill>
+                  <a:srgbClr val="4A5568"/>
+                </a:solidFill>
+                <a:latin typeface="Inter"/>
+                <a:ea typeface="Inter"/>
+                <a:cs typeface="Inter"/>
+              </a:defRPr>
+            </a:pPr>
+            <a:r>
+              <a:rPr sz="1500" b="0" i="0">
+                <a:solidFill>
+                  <a:srgbClr val="4A5568"/>
+                </a:solidFill>
+                <a:latin typeface="Inter"/>
+                <a:ea typeface="Inter"/>
+                <a:cs typeface="Inter"/>
+              </a:rPr>
+              <a:t>It creates src/main.cpp and src/CMakeLists.txt on your laptop, then builds them in Ubuntu.</a:t>
+            </a:r>
+          </a:p>
+          <a:p xmlns:a="http://schemas.openxmlformats.org/drawingml/2006/main">
+            <a:pPr marL="0" indent="0">
+              <a:spcBef>
+                <a:spcPts val="0"/>
+              </a:spcBef>
+              <a:spcAft>
+                <a:spcPts val="0"/>
+              </a:spcAft>
+              <a:buNone/>
+            </a:pPr>
+            <a:r>
+              <a:rPr sz="1500" b="0" i="0">
+                <a:solidFill>
+                  <a:srgbClr val="4A5568"/>
+                </a:solidFill>
+                <a:latin typeface="Inter"/>
+                <a:ea typeface="Inter"/>
+                <a:cs typeface="Inter"/>
+              </a:rPr>
+              <a:t/>
+            </a:r>
+          </a:p>
+          <a:p xmlns:a="http://schemas.openxmlformats.org/drawingml/2006/main">
+            <a:pPr marL="0" indent="0" algn="l">
+              <a:spcBef>
+                <a:spcPts val="0"/>
+              </a:spcBef>
+              <a:spcAft>
+                <a:spcPts val="0"/>
+              </a:spcAft>
+              <a:buNone/>
+              <a:defRPr sz="1500" b="0">
+                <a:solidFill>
+                  <a:srgbClr val="4A5568"/>
+                </a:solidFill>
+                <a:latin typeface="Inter"/>
+                <a:ea typeface="Inter"/>
+                <a:cs typeface="Inter"/>
+              </a:defRPr>
+            </a:pPr>
+            <a:r>
+              <a:rPr sz="1500" b="0" i="0">
+                <a:solidFill>
+                  <a:srgbClr val="4A5568"/>
+                </a:solidFill>
+                <a:latin typeface="Inter"/>
+                <a:ea typeface="Inter"/>
+                <a:cs typeface="Inter"/>
+              </a:rPr>
+              <a:t>The collector attaches and stops. It does not read events yet.</a:t>
             </a:r>
           </a:p>
         </p:txBody>
@@ -30473,8 +30375,8 @@
         </p:nvSpPr>
         <p:spPr>
           <a:xfrm xmlns:a="http://schemas.openxmlformats.org/drawingml/2006/main">
-            <a:off x="304800" y="1657350"/>
-            <a:ext cx="8534400" cy="3009900"/>
+            <a:off x="3482825" y="1219200"/>
+            <a:ext cx="5356500" cy="3410100"/>
           </a:xfrm>
           <a:prstGeom xmlns:a="http://schemas.openxmlformats.org/drawingml/2006/main" prst="roundRect">
             <a:avLst>
@@ -30526,7 +30428,7 @@
         </p:nvSpPr>
         <p:spPr>
           <a:xfrm xmlns:a="http://schemas.openxmlformats.org/drawingml/2006/main" rot="0" flipH="0" flipV="0">
-            <a:off x="495300" y="1809750"/>
+            <a:off x="3774125" y="1409700"/>
             <a:ext cx="114300" cy="114300"/>
           </a:xfrm>
           <a:prstGeom xmlns:a="http://schemas.openxmlformats.org/drawingml/2006/main" prst="ellipse">
@@ -30577,7 +30479,7 @@
         </p:nvSpPr>
         <p:spPr>
           <a:xfrm xmlns:a="http://schemas.openxmlformats.org/drawingml/2006/main" rot="0" flipH="0" flipV="0">
-            <a:off x="666750" y="1809750"/>
+            <a:off x="3945575" y="1409700"/>
             <a:ext cx="114300" cy="114300"/>
           </a:xfrm>
           <a:prstGeom xmlns:a="http://schemas.openxmlformats.org/drawingml/2006/main" prst="ellipse">
@@ -30628,7 +30530,7 @@
         </p:nvSpPr>
         <p:spPr>
           <a:xfrm xmlns:a="http://schemas.openxmlformats.org/drawingml/2006/main" rot="0" flipH="0" flipV="0">
-            <a:off x="838200" y="1809750"/>
+            <a:off x="4117025" y="1409700"/>
             <a:ext cx="114300" cy="114300"/>
           </a:xfrm>
           <a:prstGeom xmlns:a="http://schemas.openxmlformats.org/drawingml/2006/main" prst="ellipse">
@@ -30679,8 +30581,8 @@
         </p:nvSpPr>
         <p:spPr>
           <a:xfrm xmlns:a="http://schemas.openxmlformats.org/drawingml/2006/main">
-            <a:off x="1123950" y="1762125"/>
-            <a:ext cx="6667500" cy="228600"/>
+            <a:off x="4394700" y="1352550"/>
+            <a:ext cx="2806200" cy="228600"/>
           </a:xfrm>
           <a:prstGeom xmlns:a="http://schemas.openxmlformats.org/drawingml/2006/main" prst="rect">
             <a:avLst/>
@@ -30722,7 +30624,7 @@
                 <a:ea typeface="Roboto Mono"/>
                 <a:cs typeface="Roboto Mono"/>
               </a:rPr>
-              <a:t>Windows: PowerShell in the repo folder</a:t>
+              <a:t>The two new files (excerpts)</a:t>
             </a:r>
           </a:p>
         </p:txBody>
@@ -30743,8 +30645,8 @@
         </p:nvSpPr>
         <p:spPr>
           <a:xfrm xmlns:a="http://schemas.openxmlformats.org/drawingml/2006/main">
-            <a:off x="495300" y="2019300"/>
-            <a:ext cx="8153400" cy="9525"/>
+            <a:off x="4457700" y="1638300"/>
+            <a:ext cx="4381500" cy="9600"/>
           </a:xfrm>
           <a:prstGeom xmlns:a="http://schemas.openxmlformats.org/drawingml/2006/main" prst="rect">
             <a:avLst/>
@@ -30796,8 +30698,8 @@
         </p:nvSpPr>
         <p:spPr>
           <a:xfrm xmlns:a="http://schemas.openxmlformats.org/drawingml/2006/main">
-            <a:off x="495300" y="2152650"/>
-            <a:ext cx="8153400" cy="2400300"/>
+            <a:off x="3774125" y="1828800"/>
+            <a:ext cx="4836600" cy="2571900"/>
           </a:xfrm>
           <a:prstGeom xmlns:a="http://schemas.openxmlformats.org/drawingml/2006/main" prst="rect">
             <a:avLst/>
@@ -30821,7 +30723,7 @@
                 <a:spcPts val="0"/>
               </a:spcAft>
               <a:buNone/>
-              <a:defRPr sz="1500" b="0">
+              <a:defRPr sz="1350" b="0">
                 <a:solidFill>
                   <a:srgbClr val="00E5FF"/>
                 </a:solidFill>
@@ -30831,7 +30733,7 @@
               </a:defRPr>
             </a:pPr>
             <a:r>
-              <a:rPr sz="1500" b="0" i="0">
+              <a:rPr sz="1350" b="0" i="0">
                 <a:solidFill>
                   <a:srgbClr val="00E5FF"/>
                 </a:solidFill>
@@ -30839,21 +30741,29 @@
                 <a:ea typeface="Roboto Mono"/>
                 <a:cs typeface="Roboto Mono"/>
               </a:rPr>
-              <a:t>powershell -ExecutionPolicy Bypass -File scripts/windows/step-1.ps1</a:t>
-            </a:r>
-          </a:p>
-          <a:p xmlns:a="http://schemas.openxmlformats.org/drawingml/2006/main">
-            <a:pPr marL="0" indent="0">
-              <a:spcBef>
-                <a:spcPts val="0"/>
-              </a:spcBef>
-              <a:spcAft>
-                <a:spcPts val="0"/>
-              </a:spcAft>
-              <a:buNone/>
-            </a:pPr>
-            <a:r>
-              <a:rPr sz="1500" b="0" i="0">
+              <a:t># src/CMakeLists.txt</a:t>
+            </a:r>
+          </a:p>
+          <a:p xmlns:a="http://schemas.openxmlformats.org/drawingml/2006/main">
+            <a:pPr marL="0" indent="0" algn="l">
+              <a:spcBef>
+                <a:spcPts val="0"/>
+              </a:spcBef>
+              <a:spcAft>
+                <a:spcPts val="0"/>
+              </a:spcAft>
+              <a:buNone/>
+              <a:defRPr sz="1350" b="0">
+                <a:solidFill>
+                  <a:srgbClr val="00E5FF"/>
+                </a:solidFill>
+                <a:latin typeface="Roboto Mono"/>
+                <a:ea typeface="Roboto Mono"/>
+                <a:cs typeface="Roboto Mono"/>
+              </a:defRPr>
+            </a:pPr>
+            <a:r>
+              <a:rPr sz="1350" b="0" i="0">
                 <a:solidFill>
                   <a:srgbClr val="00E5FF"/>
                 </a:solidFill>
@@ -30861,7 +30771,7 @@
                 <a:ea typeface="Roboto Mono"/>
                 <a:cs typeface="Roboto Mono"/>
               </a:rPr>
-              <a:t/>
+              <a:t>add_executable(workshop-agent main.cpp)</a:t>
             </a:r>
           </a:p>
           <a:p xmlns:a="http://schemas.openxmlformats.org/drawingml/2006/main">
@@ -30873,7 +30783,7 @@
                 <a:spcPts val="0"/>
               </a:spcAft>
               <a:buNone/>
-              <a:defRPr sz="1500" b="0">
+              <a:defRPr sz="1350" b="0">
                 <a:solidFill>
                   <a:srgbClr val="00E5FF"/>
                 </a:solidFill>
@@ -30883,7 +30793,7 @@
               </a:defRPr>
             </a:pPr>
             <a:r>
-              <a:rPr sz="1500" b="0" i="0">
+              <a:rPr sz="1350" b="0" i="0">
                 <a:solidFill>
                   <a:srgbClr val="00E5FF"/>
                 </a:solidFill>
@@ -30891,7 +30801,7 @@
                 <a:ea typeface="Roboto Mono"/>
                 <a:cs typeface="Roboto Mono"/>
               </a:rPr>
-              <a:t>powershell -ExecutionPolicy Bypass -File scripts/windows/step-2.ps1</a:t>
+              <a:t>target_link_libraries(workshop-agent sinsp)</a:t>
             </a:r>
           </a:p>
           <a:p xmlns:a="http://schemas.openxmlformats.org/drawingml/2006/main">
@@ -30905,7 +30815,7 @@
               <a:buNone/>
             </a:pPr>
             <a:r>
-              <a:rPr sz="1500" b="0" i="0">
+              <a:rPr sz="1350" b="0" i="0">
                 <a:solidFill>
                   <a:srgbClr val="00E5FF"/>
                 </a:solidFill>
@@ -30925,7 +30835,7 @@
                 <a:spcPts val="0"/>
               </a:spcAft>
               <a:buNone/>
-              <a:defRPr sz="1500" b="0">
+              <a:defRPr sz="1350" b="0">
                 <a:solidFill>
                   <a:srgbClr val="00E5FF"/>
                 </a:solidFill>
@@ -30935,7 +30845,7 @@
               </a:defRPr>
             </a:pPr>
             <a:r>
-              <a:rPr sz="1500" b="0" i="0">
+              <a:rPr sz="1350" b="0" i="0">
                 <a:solidFill>
                   <a:srgbClr val="00E5FF"/>
                 </a:solidFill>
@@ -30943,7 +30853,187 @@
                 <a:ea typeface="Roboto Mono"/>
                 <a:cs typeface="Roboto Mono"/>
               </a:rPr>
-              <a:t>powershell -ExecutionPolicy Bypass -File scripts/windows/step-3.ps1</a:t>
+              <a:t>// src/main.cpp, inside main()</a:t>
+            </a:r>
+          </a:p>
+          <a:p xmlns:a="http://schemas.openxmlformats.org/drawingml/2006/main">
+            <a:pPr marL="0" indent="0" algn="l">
+              <a:spcBef>
+                <a:spcPts val="0"/>
+              </a:spcBef>
+              <a:spcAft>
+                <a:spcPts val="0"/>
+              </a:spcAft>
+              <a:buNone/>
+              <a:defRPr sz="1350" b="0">
+                <a:solidFill>
+                  <a:srgbClr val="00E5FF"/>
+                </a:solidFill>
+                <a:latin typeface="Roboto Mono"/>
+                <a:ea typeface="Roboto Mono"/>
+                <a:cs typeface="Roboto Mono"/>
+              </a:defRPr>
+            </a:pPr>
+            <a:r>
+              <a:rPr sz="1350" b="0" i="0">
+                <a:solidFill>
+                  <a:srgbClr val="00E5FF"/>
+                </a:solidFill>
+                <a:latin typeface="Roboto Mono"/>
+                <a:ea typeface="Roboto Mono"/>
+                <a:cs typeface="Roboto Mono"/>
+              </a:rPr>
+              <a:t>sinsp inspector;</a:t>
+            </a:r>
+          </a:p>
+          <a:p xmlns:a="http://schemas.openxmlformats.org/drawingml/2006/main">
+            <a:pPr marL="0" indent="0" algn="l">
+              <a:spcBef>
+                <a:spcPts val="0"/>
+              </a:spcBef>
+              <a:spcAft>
+                <a:spcPts val="0"/>
+              </a:spcAft>
+              <a:buNone/>
+              <a:defRPr sz="1350" b="0">
+                <a:solidFill>
+                  <a:srgbClr val="00E5FF"/>
+                </a:solidFill>
+                <a:latin typeface="Roboto Mono"/>
+                <a:ea typeface="Roboto Mono"/>
+                <a:cs typeface="Roboto Mono"/>
+              </a:defRPr>
+            </a:pPr>
+            <a:r>
+              <a:rPr sz="1350" b="0" i="0">
+                <a:solidFill>
+                  <a:srgbClr val="00E5FF"/>
+                </a:solidFill>
+                <a:latin typeface="Roboto Mono"/>
+                <a:ea typeface="Roboto Mono"/>
+                <a:cs typeface="Roboto Mono"/>
+              </a:rPr>
+              <a:t>inspector.open_modern_bpf();</a:t>
+            </a:r>
+          </a:p>
+          <a:p xmlns:a="http://schemas.openxmlformats.org/drawingml/2006/main">
+            <a:pPr marL="0" indent="0" algn="l">
+              <a:spcBef>
+                <a:spcPts val="0"/>
+              </a:spcBef>
+              <a:spcAft>
+                <a:spcPts val="0"/>
+              </a:spcAft>
+              <a:buNone/>
+              <a:defRPr sz="1350" b="0">
+                <a:solidFill>
+                  <a:srgbClr val="00E5FF"/>
+                </a:solidFill>
+                <a:latin typeface="Roboto Mono"/>
+                <a:ea typeface="Roboto Mono"/>
+                <a:cs typeface="Roboto Mono"/>
+              </a:defRPr>
+            </a:pPr>
+            <a:r>
+              <a:rPr sz="1350" b="0" i="0">
+                <a:solidFill>
+                  <a:srgbClr val="00E5FF"/>
+                </a:solidFill>
+                <a:latin typeface="Roboto Mono"/>
+                <a:ea typeface="Roboto Mono"/>
+                <a:cs typeface="Roboto Mono"/>
+              </a:rPr>
+              <a:t>inspector.start_capture();</a:t>
+            </a:r>
+          </a:p>
+          <a:p xmlns:a="http://schemas.openxmlformats.org/drawingml/2006/main">
+            <a:pPr marL="0" indent="0" algn="l">
+              <a:spcBef>
+                <a:spcPts val="0"/>
+              </a:spcBef>
+              <a:spcAft>
+                <a:spcPts val="0"/>
+              </a:spcAft>
+              <a:buNone/>
+              <a:defRPr sz="1350" b="0">
+                <a:solidFill>
+                  <a:srgbClr val="00E5FF"/>
+                </a:solidFill>
+                <a:latin typeface="Roboto Mono"/>
+                <a:ea typeface="Roboto Mono"/>
+                <a:cs typeface="Roboto Mono"/>
+              </a:defRPr>
+            </a:pPr>
+            <a:r>
+              <a:rPr sz="1350" b="0" i="0">
+                <a:solidFill>
+                  <a:srgbClr val="00E5FF"/>
+                </a:solidFill>
+                <a:latin typeface="Roboto Mono"/>
+                <a:ea typeface="Roboto Mono"/>
+                <a:cs typeface="Roboto Mono"/>
+              </a:rPr>
+              <a:t>std::cout &lt;&lt; "Attached." &lt;&lt; std::endl;</a:t>
+            </a:r>
+          </a:p>
+          <a:p xmlns:a="http://schemas.openxmlformats.org/drawingml/2006/main">
+            <a:pPr marL="0" indent="0" algn="l">
+              <a:spcBef>
+                <a:spcPts val="0"/>
+              </a:spcBef>
+              <a:spcAft>
+                <a:spcPts val="0"/>
+              </a:spcAft>
+              <a:buNone/>
+              <a:defRPr sz="1350" b="0">
+                <a:solidFill>
+                  <a:srgbClr val="00E5FF"/>
+                </a:solidFill>
+                <a:latin typeface="Roboto Mono"/>
+                <a:ea typeface="Roboto Mono"/>
+                <a:cs typeface="Roboto Mono"/>
+              </a:defRPr>
+            </a:pPr>
+            <a:r>
+              <a:rPr sz="1350" b="0" i="0">
+                <a:solidFill>
+                  <a:srgbClr val="00E5FF"/>
+                </a:solidFill>
+                <a:latin typeface="Roboto Mono"/>
+                <a:ea typeface="Roboto Mono"/>
+                <a:cs typeface="Roboto Mono"/>
+              </a:rPr>
+              <a:t>inspector.stop_capture();</a:t>
+            </a:r>
+          </a:p>
+          <a:p xmlns:a="http://schemas.openxmlformats.org/drawingml/2006/main">
+            <a:pPr marL="0" indent="0" algn="l">
+              <a:spcBef>
+                <a:spcPts val="0"/>
+              </a:spcBef>
+              <a:spcAft>
+                <a:spcPts val="0"/>
+              </a:spcAft>
+              <a:buNone/>
+              <a:defRPr sz="1350" b="0">
+                <a:solidFill>
+                  <a:srgbClr val="00E5FF"/>
+                </a:solidFill>
+                <a:latin typeface="Roboto Mono"/>
+                <a:ea typeface="Roboto Mono"/>
+                <a:cs typeface="Roboto Mono"/>
+              </a:defRPr>
+            </a:pPr>
+            <a:r>
+              <a:rPr sz="1350" b="0" i="0">
+                <a:solidFill>
+                  <a:srgbClr val="00E5FF"/>
+                </a:solidFill>
+                <a:latin typeface="Roboto Mono"/>
+                <a:ea typeface="Roboto Mono"/>
+                <a:cs typeface="Roboto Mono"/>
+              </a:rPr>
+              <a:t>inspector.close();</a:t>
             </a:r>
           </a:p>
         </p:txBody>
@@ -31586,14 +31676,14 @@
       </p:sp>
       <p:pic>
         <p:nvPicPr>
-          <p:cNvPr id="663" name="Google Shape;628;p30"/>
+          <p:cNvPr id="665" name="Google Shape;628;p30"/>
           <p:cNvPicPr>
             <a:picLocks xmlns:a="http://schemas.openxmlformats.org/drawingml/2006/main" noChangeAspect="1"/>
           </p:cNvPicPr>
           <p:nvPr/>
         </p:nvPicPr>
         <p:blipFill rotWithShape="1">
-          <a:blip xmlns:r="http://schemas.openxmlformats.org/officeDocument/2006/relationships" xmlns:a="http://schemas.openxmlformats.org/drawingml/2006/main" r:embed="R1ad9e91d09c24a64">
+          <a:blip xmlns:r="http://schemas.openxmlformats.org/officeDocument/2006/relationships" xmlns:a="http://schemas.openxmlformats.org/drawingml/2006/main" r:embed="R2c5b7ed6c7894b05">
             <a:alphaModFix/>
           </a:blip>
           <a:srcRect xmlns:a="http://schemas.openxmlformats.org/drawingml/2006/main" l="0" t="0" r="0" b="0"/>
@@ -31614,14 +31704,14 @@
       </p:pic>
       <p:pic>
         <p:nvPicPr>
-          <p:cNvPr id="664" name="Google Shape;629;p30"/>
+          <p:cNvPr id="666" name="Google Shape;629;p30"/>
           <p:cNvPicPr>
             <a:picLocks xmlns:a="http://schemas.openxmlformats.org/drawingml/2006/main" noChangeAspect="1"/>
           </p:cNvPicPr>
           <p:nvPr/>
         </p:nvPicPr>
         <p:blipFill rotWithShape="1">
-          <a:blip xmlns:r="http://schemas.openxmlformats.org/officeDocument/2006/relationships" xmlns:a="http://schemas.openxmlformats.org/drawingml/2006/main" r:embed="R1ad9e91d09c24a64">
+          <a:blip xmlns:r="http://schemas.openxmlformats.org/officeDocument/2006/relationships" xmlns:a="http://schemas.openxmlformats.org/drawingml/2006/main" r:embed="R2c5b7ed6c7894b05">
             <a:alphaModFix/>
           </a:blip>
           <a:srcRect xmlns:a="http://schemas.openxmlformats.org/drawingml/2006/main" l="0" t="0" r="0" b="0"/>
@@ -31642,14 +31732,14 @@
       </p:pic>
       <p:pic>
         <p:nvPicPr>
-          <p:cNvPr id="665" name="Google Shape;630;p30"/>
+          <p:cNvPr id="667" name="Google Shape;630;p30"/>
           <p:cNvPicPr>
             <a:picLocks xmlns:a="http://schemas.openxmlformats.org/drawingml/2006/main" noChangeAspect="1"/>
           </p:cNvPicPr>
           <p:nvPr/>
         </p:nvPicPr>
         <p:blipFill rotWithShape="1">
-          <a:blip xmlns:r="http://schemas.openxmlformats.org/officeDocument/2006/relationships" xmlns:a="http://schemas.openxmlformats.org/drawingml/2006/main" r:embed="R1ad9e91d09c24a64">
+          <a:blip xmlns:r="http://schemas.openxmlformats.org/officeDocument/2006/relationships" xmlns:a="http://schemas.openxmlformats.org/drawingml/2006/main" r:embed="R2c5b7ed6c7894b05">
             <a:alphaModFix/>
           </a:blip>
           <a:srcRect xmlns:a="http://schemas.openxmlformats.org/drawingml/2006/main" l="0" t="0" r="0" b="0"/>
@@ -31670,14 +31760,14 @@
       </p:pic>
       <p:pic>
         <p:nvPicPr>
-          <p:cNvPr id="666" name="Google Shape;631;p30"/>
+          <p:cNvPr id="668" name="Google Shape;631;p30"/>
           <p:cNvPicPr>
             <a:picLocks xmlns:a="http://schemas.openxmlformats.org/drawingml/2006/main" noChangeAspect="1"/>
           </p:cNvPicPr>
           <p:nvPr/>
         </p:nvPicPr>
         <p:blipFill rotWithShape="1">
-          <a:blip xmlns:r="http://schemas.openxmlformats.org/officeDocument/2006/relationships" xmlns:a="http://schemas.openxmlformats.org/drawingml/2006/main" r:embed="R1ad9e91d09c24a64">
+          <a:blip xmlns:r="http://schemas.openxmlformats.org/officeDocument/2006/relationships" xmlns:a="http://schemas.openxmlformats.org/drawingml/2006/main" r:embed="R2c5b7ed6c7894b05">
             <a:alphaModFix/>
           </a:blip>
           <a:srcRect xmlns:a="http://schemas.openxmlformats.org/drawingml/2006/main" l="0" t="0" r="0" b="0"/>
@@ -32107,7 +32197,7 @@
                 <a:ea typeface="Montserrat"/>
                 <a:cs typeface="Montserrat"/>
               </a:rPr>
-              <a:t>Step 1: Read events</a:t>
+              <a:t>Step 2: Read events</a:t>
             </a:r>
           </a:p>
         </p:txBody>
@@ -32275,7 +32365,7 @@
                 <a:ea typeface="Inter"/>
                 <a:cs typeface="Inter"/>
               </a:rPr>
-              <a:t>Run step 1 in terminal A.</a:t>
+              <a:t>Run step 2 in terminal A.</a:t>
             </a:r>
           </a:p>
           <a:p xmlns:a="http://schemas.openxmlformats.org/drawingml/2006/main">
@@ -32649,7 +32739,7 @@
                 <a:ea typeface="Roboto Mono"/>
                 <a:cs typeface="Roboto Mono"/>
               </a:rPr>
-              <a:t>Step 1: generated main.cpp (first half)</a:t>
+              <a:t>Step 2: generated main.cpp (first half)</a:t>
             </a:r>
           </a:p>
         </p:txBody>
@@ -33656,7 +33746,7 @@
           <p:nvPr/>
         </p:nvPicPr>
         <p:blipFill rotWithShape="1">
-          <a:blip xmlns:r="http://schemas.openxmlformats.org/officeDocument/2006/relationships" xmlns:a="http://schemas.openxmlformats.org/drawingml/2006/main" r:embed="Rdfeb145412214df6">
+          <a:blip xmlns:r="http://schemas.openxmlformats.org/officeDocument/2006/relationships" xmlns:a="http://schemas.openxmlformats.org/drawingml/2006/main" r:embed="Rfaaa9e74fc7c4b7d">
             <a:alphaModFix/>
           </a:blip>
           <a:srcRect xmlns:a="http://schemas.openxmlformats.org/drawingml/2006/main" l="0" t="0" r="0" b="0"/>
@@ -33684,7 +33774,7 @@
           <p:nvPr/>
         </p:nvPicPr>
         <p:blipFill rotWithShape="1">
-          <a:blip xmlns:r="http://schemas.openxmlformats.org/officeDocument/2006/relationships" xmlns:a="http://schemas.openxmlformats.org/drawingml/2006/main" r:embed="Rdfeb145412214df6">
+          <a:blip xmlns:r="http://schemas.openxmlformats.org/officeDocument/2006/relationships" xmlns:a="http://schemas.openxmlformats.org/drawingml/2006/main" r:embed="Rfaaa9e74fc7c4b7d">
             <a:alphaModFix/>
           </a:blip>
           <a:srcRect xmlns:a="http://schemas.openxmlformats.org/drawingml/2006/main" l="0" t="0" r="0" b="0"/>
@@ -33712,7 +33802,7 @@
           <p:nvPr/>
         </p:nvPicPr>
         <p:blipFill rotWithShape="1">
-          <a:blip xmlns:r="http://schemas.openxmlformats.org/officeDocument/2006/relationships" xmlns:a="http://schemas.openxmlformats.org/drawingml/2006/main" r:embed="Rdfeb145412214df6">
+          <a:blip xmlns:r="http://schemas.openxmlformats.org/officeDocument/2006/relationships" xmlns:a="http://schemas.openxmlformats.org/drawingml/2006/main" r:embed="Rfaaa9e74fc7c4b7d">
             <a:alphaModFix/>
           </a:blip>
           <a:srcRect xmlns:a="http://schemas.openxmlformats.org/drawingml/2006/main" l="0" t="0" r="0" b="0"/>
@@ -33740,7 +33830,7 @@
           <p:nvPr/>
         </p:nvPicPr>
         <p:blipFill rotWithShape="1">
-          <a:blip xmlns:r="http://schemas.openxmlformats.org/officeDocument/2006/relationships" xmlns:a="http://schemas.openxmlformats.org/drawingml/2006/main" r:embed="Rdfeb145412214df6">
+          <a:blip xmlns:r="http://schemas.openxmlformats.org/officeDocument/2006/relationships" xmlns:a="http://schemas.openxmlformats.org/drawingml/2006/main" r:embed="Rfaaa9e74fc7c4b7d">
             <a:alphaModFix/>
           </a:blip>
           <a:srcRect xmlns:a="http://schemas.openxmlformats.org/drawingml/2006/main" l="0" t="0" r="0" b="0"/>

</xml_diff>

<commit_message>
Show separate rebuild and capture command after each step
</commit_message>
<xml_diff>
--- a/presentation/falco-libs-intro.pptx
+++ b/presentation/falco-libs-intro.pptx
@@ -2,78 +2,78 @@
 <file path=ppt/presentation.xml><?xml version="1.0" encoding="utf-8"?>
 <p:presentation xmlns:p="http://schemas.openxmlformats.org/presentationml/2006/main" embedTrueTypeFonts="1" saveSubsetFonts="0">
   <p:sldMasterIdLst>
-    <p:sldMasterId xmlns:r="http://schemas.openxmlformats.org/officeDocument/2006/relationships" id="2147483648" r:id="R1a74041c82b04bff"/>
-    <p:sldMasterId xmlns:r="http://schemas.openxmlformats.org/officeDocument/2006/relationships" id="2147483661" r:id="Rfd454f2858564707"/>
+    <p:sldMasterId xmlns:r="http://schemas.openxmlformats.org/officeDocument/2006/relationships" id="2147483648" r:id="Rcb4602f825e845d7"/>
+    <p:sldMasterId xmlns:r="http://schemas.openxmlformats.org/officeDocument/2006/relationships" id="2147483661" r:id="R32e88365e0674a66"/>
   </p:sldMasterIdLst>
   <p:notesMasterIdLst>
-    <p:notesMasterId xmlns:r="http://schemas.openxmlformats.org/officeDocument/2006/relationships" r:id="R77138ea446ff4fc6"/>
+    <p:notesMasterId xmlns:r="http://schemas.openxmlformats.org/officeDocument/2006/relationships" r:id="R86acd9d6e8dc49a7"/>
   </p:notesMasterIdLst>
   <p:sldIdLst>
-    <p:sldId xmlns:r="http://schemas.openxmlformats.org/officeDocument/2006/relationships" id="256" r:id="R123442ac5ed14fd4"/>
-    <p:sldId xmlns:r="http://schemas.openxmlformats.org/officeDocument/2006/relationships" id="257" r:id="R3abdf1d23abf4110"/>
-    <p:sldId xmlns:r="http://schemas.openxmlformats.org/officeDocument/2006/relationships" id="258" r:id="R54a9786f950048d7"/>
-    <p:sldId xmlns:r="http://schemas.openxmlformats.org/officeDocument/2006/relationships" id="259" r:id="R65330656e42f4a7c"/>
-    <p:sldId xmlns:r="http://schemas.openxmlformats.org/officeDocument/2006/relationships" id="260" r:id="R789069fe78084e15"/>
-    <p:sldId xmlns:r="http://schemas.openxmlformats.org/officeDocument/2006/relationships" id="261" r:id="R8d1c9e67263c43fc"/>
-    <p:sldId xmlns:r="http://schemas.openxmlformats.org/officeDocument/2006/relationships" id="262" r:id="R2347659f600f4d69"/>
-    <p:sldId xmlns:r="http://schemas.openxmlformats.org/officeDocument/2006/relationships" id="263" r:id="Raf8b46cb40a646e2"/>
-    <p:sldId xmlns:r="http://schemas.openxmlformats.org/officeDocument/2006/relationships" id="264" r:id="R9df0a48163bc4cb1"/>
-    <p:sldId xmlns:r="http://schemas.openxmlformats.org/officeDocument/2006/relationships" id="265" r:id="R42804f201269452a"/>
-    <p:sldId xmlns:r="http://schemas.openxmlformats.org/officeDocument/2006/relationships" id="266" r:id="Rfb17d82f59174cd1"/>
-    <p:sldId xmlns:r="http://schemas.openxmlformats.org/officeDocument/2006/relationships" id="267" r:id="R58f97af4d7674a81"/>
-    <p:sldId xmlns:r="http://schemas.openxmlformats.org/officeDocument/2006/relationships" id="268" r:id="R5d15564073af4544"/>
-    <p:sldId xmlns:r="http://schemas.openxmlformats.org/officeDocument/2006/relationships" id="269" r:id="Rfed72b8f603c4224"/>
+    <p:sldId xmlns:r="http://schemas.openxmlformats.org/officeDocument/2006/relationships" id="256" r:id="R280a5c9b54f348ec"/>
+    <p:sldId xmlns:r="http://schemas.openxmlformats.org/officeDocument/2006/relationships" id="257" r:id="Rf913a9382d0e4fa7"/>
+    <p:sldId xmlns:r="http://schemas.openxmlformats.org/officeDocument/2006/relationships" id="258" r:id="R509bb99a68074d1f"/>
+    <p:sldId xmlns:r="http://schemas.openxmlformats.org/officeDocument/2006/relationships" id="259" r:id="R4c48cea4fb63438f"/>
+    <p:sldId xmlns:r="http://schemas.openxmlformats.org/officeDocument/2006/relationships" id="260" r:id="Rd6834c89ab034bd0"/>
+    <p:sldId xmlns:r="http://schemas.openxmlformats.org/officeDocument/2006/relationships" id="261" r:id="R0053cc89718a4d69"/>
+    <p:sldId xmlns:r="http://schemas.openxmlformats.org/officeDocument/2006/relationships" id="262" r:id="R8e668eada55f479f"/>
+    <p:sldId xmlns:r="http://schemas.openxmlformats.org/officeDocument/2006/relationships" id="263" r:id="R4b7661e06a6c40ec"/>
+    <p:sldId xmlns:r="http://schemas.openxmlformats.org/officeDocument/2006/relationships" id="264" r:id="Rbad44ea6cd6240b9"/>
+    <p:sldId xmlns:r="http://schemas.openxmlformats.org/officeDocument/2006/relationships" id="265" r:id="R721345be95cd426c"/>
+    <p:sldId xmlns:r="http://schemas.openxmlformats.org/officeDocument/2006/relationships" id="266" r:id="R8e6639bc7a594c79"/>
+    <p:sldId xmlns:r="http://schemas.openxmlformats.org/officeDocument/2006/relationships" id="267" r:id="R704a881438914800"/>
+    <p:sldId xmlns:r="http://schemas.openxmlformats.org/officeDocument/2006/relationships" id="268" r:id="Rc08b5a94eec945fa"/>
+    <p:sldId xmlns:r="http://schemas.openxmlformats.org/officeDocument/2006/relationships" id="269" r:id="Ra7408d412db74b15"/>
   </p:sldIdLst>
   <p:sldSz cx="9144000" cy="5143500"/>
   <p:notesSz cx="6858000" cy="9144000"/>
   <p:embeddedFontLst>
     <p:embeddedFont>
       <p:font typeface="Roboto Mono Medium"/>
-      <p:regular xmlns:r="http://schemas.openxmlformats.org/officeDocument/2006/relationships" r:id="R159fd1757c964a9d"/>
-      <p:bold xmlns:r="http://schemas.openxmlformats.org/officeDocument/2006/relationships" r:id="R3333c45f01094e72"/>
-      <p:italic xmlns:r="http://schemas.openxmlformats.org/officeDocument/2006/relationships" r:id="Rbc5cc931275c46ae"/>
-      <p:boldItalic xmlns:r="http://schemas.openxmlformats.org/officeDocument/2006/relationships" r:id="R25018da0979e41f6"/>
+      <p:regular xmlns:r="http://schemas.openxmlformats.org/officeDocument/2006/relationships" r:id="R17c04bb3d1f449b3"/>
+      <p:bold xmlns:r="http://schemas.openxmlformats.org/officeDocument/2006/relationships" r:id="R2cd957607d7c4172"/>
+      <p:italic xmlns:r="http://schemas.openxmlformats.org/officeDocument/2006/relationships" r:id="R9691da502e384301"/>
+      <p:boldItalic xmlns:r="http://schemas.openxmlformats.org/officeDocument/2006/relationships" r:id="R5bb70e7eaf1b4afa"/>
     </p:embeddedFont>
     <p:embeddedFont>
       <p:font typeface="Inter SemiBold"/>
-      <p:regular xmlns:r="http://schemas.openxmlformats.org/officeDocument/2006/relationships" r:id="R36fc131abdb9407e"/>
-      <p:bold xmlns:r="http://schemas.openxmlformats.org/officeDocument/2006/relationships" r:id="R50c03a2e79c44929"/>
-      <p:italic xmlns:r="http://schemas.openxmlformats.org/officeDocument/2006/relationships" r:id="R7885fcf086f048f3"/>
-      <p:boldItalic xmlns:r="http://schemas.openxmlformats.org/officeDocument/2006/relationships" r:id="R22ea339a9e994cc7"/>
+      <p:regular xmlns:r="http://schemas.openxmlformats.org/officeDocument/2006/relationships" r:id="R4dc8e88ae4564ce2"/>
+      <p:bold xmlns:r="http://schemas.openxmlformats.org/officeDocument/2006/relationships" r:id="Rf0fd0272c3904f9b"/>
+      <p:italic xmlns:r="http://schemas.openxmlformats.org/officeDocument/2006/relationships" r:id="R935a9e04cd04458d"/>
+      <p:boldItalic xmlns:r="http://schemas.openxmlformats.org/officeDocument/2006/relationships" r:id="R3a8231fc19f04964"/>
     </p:embeddedFont>
     <p:embeddedFont>
       <p:font typeface="Montserrat Black"/>
-      <p:bold xmlns:r="http://schemas.openxmlformats.org/officeDocument/2006/relationships" r:id="R6e745717fbcf48c0"/>
-      <p:boldItalic xmlns:r="http://schemas.openxmlformats.org/officeDocument/2006/relationships" r:id="Re371eb8183ef40a7"/>
+      <p:bold xmlns:r="http://schemas.openxmlformats.org/officeDocument/2006/relationships" r:id="R7622d28712ce4dd8"/>
+      <p:boldItalic xmlns:r="http://schemas.openxmlformats.org/officeDocument/2006/relationships" r:id="R803cc275e6e244b0"/>
     </p:embeddedFont>
     <p:embeddedFont>
       <p:font typeface="Montserrat"/>
-      <p:bold xmlns:r="http://schemas.openxmlformats.org/officeDocument/2006/relationships" r:id="R99abc8a758b84c7a"/>
-      <p:boldItalic xmlns:r="http://schemas.openxmlformats.org/officeDocument/2006/relationships" r:id="R58c3adf13597472c"/>
+      <p:bold xmlns:r="http://schemas.openxmlformats.org/officeDocument/2006/relationships" r:id="R290f2f9c3ff6494b"/>
+      <p:boldItalic xmlns:r="http://schemas.openxmlformats.org/officeDocument/2006/relationships" r:id="R26815565b6424906"/>
     </p:embeddedFont>
     <p:embeddedFont>
       <p:font typeface="Inter"/>
-      <p:regular xmlns:r="http://schemas.openxmlformats.org/officeDocument/2006/relationships" r:id="R2e2fe00560b34acd"/>
-      <p:bold xmlns:r="http://schemas.openxmlformats.org/officeDocument/2006/relationships" r:id="R539f7204d7d34c44"/>
-      <p:italic xmlns:r="http://schemas.openxmlformats.org/officeDocument/2006/relationships" r:id="R3135c6421d9e478e"/>
-      <p:boldItalic xmlns:r="http://schemas.openxmlformats.org/officeDocument/2006/relationships" r:id="R576b1dc01d354147"/>
+      <p:regular xmlns:r="http://schemas.openxmlformats.org/officeDocument/2006/relationships" r:id="R551ba18fd7984269"/>
+      <p:bold xmlns:r="http://schemas.openxmlformats.org/officeDocument/2006/relationships" r:id="Reaca3a9057044923"/>
+      <p:italic xmlns:r="http://schemas.openxmlformats.org/officeDocument/2006/relationships" r:id="Rf7c391b0fe55452a"/>
+      <p:boldItalic xmlns:r="http://schemas.openxmlformats.org/officeDocument/2006/relationships" r:id="Rd2773a98fd454ca7"/>
     </p:embeddedFont>
     <p:embeddedFont>
       <p:font typeface="Montserrat ExtraBold"/>
-      <p:bold xmlns:r="http://schemas.openxmlformats.org/officeDocument/2006/relationships" r:id="Re2039992fe8741c5"/>
-      <p:boldItalic xmlns:r="http://schemas.openxmlformats.org/officeDocument/2006/relationships" r:id="R54a462cb1ee740c9"/>
+      <p:bold xmlns:r="http://schemas.openxmlformats.org/officeDocument/2006/relationships" r:id="Rd1e6634c87d544d7"/>
+      <p:boldItalic xmlns:r="http://schemas.openxmlformats.org/officeDocument/2006/relationships" r:id="Rcc036fb17d8f4b65"/>
     </p:embeddedFont>
     <p:embeddedFont>
       <p:font typeface="Roboto Mono"/>
-      <p:bold xmlns:r="http://schemas.openxmlformats.org/officeDocument/2006/relationships" r:id="R23432d4e7a3147bb"/>
-      <p:boldItalic xmlns:r="http://schemas.openxmlformats.org/officeDocument/2006/relationships" r:id="Rea46297634914cd0"/>
+      <p:bold xmlns:r="http://schemas.openxmlformats.org/officeDocument/2006/relationships" r:id="Rcc5607f31a8347ea"/>
+      <p:boldItalic xmlns:r="http://schemas.openxmlformats.org/officeDocument/2006/relationships" r:id="Rfd9713cb60dd4998"/>
     </p:embeddedFont>
     <p:embeddedFont>
       <p:font typeface="Inter Medium"/>
-      <p:regular xmlns:r="http://schemas.openxmlformats.org/officeDocument/2006/relationships" r:id="Rb507909efdea4083"/>
-      <p:bold xmlns:r="http://schemas.openxmlformats.org/officeDocument/2006/relationships" r:id="R0de15c14218e40c5"/>
-      <p:italic xmlns:r="http://schemas.openxmlformats.org/officeDocument/2006/relationships" r:id="R0bd916fd9df24da5"/>
-      <p:boldItalic xmlns:r="http://schemas.openxmlformats.org/officeDocument/2006/relationships" r:id="R80a65d413215445b"/>
+      <p:regular xmlns:r="http://schemas.openxmlformats.org/officeDocument/2006/relationships" r:id="R92f6fab7a95b4c18"/>
+      <p:bold xmlns:r="http://schemas.openxmlformats.org/officeDocument/2006/relationships" r:id="R7b37d296c38b4838"/>
+      <p:italic xmlns:r="http://schemas.openxmlformats.org/officeDocument/2006/relationships" r:id="Rb619c17261b94e47"/>
+      <p:boldItalic xmlns:r="http://schemas.openxmlformats.org/officeDocument/2006/relationships" r:id="R8b308fce00bf4e96"/>
     </p:embeddedFont>
   </p:embeddedFontLst>
 </p:presentation>
@@ -858,7 +858,7 @@
               <a:buNone/>
             </a:pPr>
             <a:r>
-              <a:t>The output is illustrative, not a promise of one event. Step 4 includes all previous additions and works without running steps 1 and 2 first. It overwrites main.cpp, rebuilds, and starts capture. Process execution exit events can include failed calls; this workshop does not add success-only conditions or detection logic.</a:t>
+              <a:t>The output is illustrative, not a promise of one event. Step 4 includes all previous additions and works without running steps 1 and 2 first. Step scripts overwrite main.cpp and CMakeLists.txt locally. Run then rebuilds and captures, saving output to logs/latest.log. Process execution exit events can include failed calls; this workshop does not add success-only conditions or detection logic.</a:t>
             </a:r>
             <a:endParaRPr/>
           </a:p>
@@ -938,7 +938,7 @@
               <a:buNone/>
             </a:pPr>
             <a:r>
-              <a:t>Troubleshooting: run the collector with sudo inside Ubuntu. Setup prepares the libraries. The numbered scripts create and build the collector. Rerun the desired step if its binary is missing. If Multipass commands are missing immediately after installation, reopen the host terminal. Setup waits for the Ubuntu image catalog before launch. Windows setup has not been rehearsed here. Code and step scripts: https://github.com/julianshalaby-perj/falco-libs-workshop</a:t>
+              <a:t>Troubleshooting: run the collector with sudo inside Ubuntu. Setup prepares the libraries. The numbered scripts create the collector source. Run builds and starts it. Before source exists, run prints No agent yet. Run step 1. If Multipass commands are missing immediately after installation, reopen the host terminal. Setup waits for the Ubuntu image catalog before launch. Windows setup has not been rehearsed here. Code and step scripts: https://github.com/julianshalaby-perj/falco-libs-workshop</a:t>
             </a:r>
             <a:endParaRPr/>
           </a:p>
@@ -1258,7 +1258,7 @@
               <a:buNone/>
             </a:pPr>
             <a:r>
-              <a:t>Terminal A stays on the host. Each platform step script creates the source files locally, copies them into the VM, builds them, and runs the collector there. Terminal B stays inside Ubuntu. All monitoring happens inside the VM.</a:t>
+              <a:t>Terminal A stays on the host. Each step script creates source files locally. The run script copies the current files into the VM, rebuilds, and runs the agent for ten seconds. Output is displayed live and saved to logs/latest.log on the laptop. Each run replaces the previous log. The agent stops; the VM remains available. Terminal B stays inside Ubuntu. All monitoring happens inside the VM.</a:t>
             </a:r>
             <a:endParaRPr/>
           </a:p>
@@ -1338,7 +1338,7 @@
               <a:buNone/>
             </a:pPr>
             <a:r>
-              <a:t>Run from the Mac repo folder in terminal A, one step at a time. Each script writes src/main.cpp and src/CMakeLists.txt locally, copies them to Ubuntu, and builds and runs the application. Step 1 attaches and stops immediately. Steps 2 through 4 capture for ten seconds. Comment blocks mark additions. Existing edits to these two files are overwritten locally and in the VM. Steps include all earlier changes and can be rerun or skipped. During steps 2 through 4, run /usr/bin/id in VM terminal B after Attached appears in A.</a:t>
+              <a:t>Run from the Mac repo folder in terminal A, one step at a time. Each step script writes src/main.cpp and src/CMakeLists.txt locally. Run copies them to Ubuntu, rebuilds, starts a fresh ten-second agent run, displays output, and saves logs/latest.log locally. The agent stops and the VM remains running. Comment blocks mark additions. Step scripts replace local edits. Run copies those current files into the VM. Steps include all earlier changes and can be rerun or skipped. During steps 2 through 4, run /usr/bin/id in VM terminal B after Attached appears in A.</a:t>
             </a:r>
             <a:endParaRPr/>
           </a:p>
@@ -1418,7 +1418,7 @@
               <a:buNone/>
             </a:pPr>
             <a:r>
-              <a:t>Run from the Windows repo folder in terminal A, one step at a time. Each script writes src/main.cpp and src/CMakeLists.txt locally, copies them to Ubuntu, and builds and runs the application. Step 1 attaches and stops immediately. Steps 2 through 4 capture for ten seconds. Comment blocks mark additions. Existing edits to these two files are overwritten locally and in the VM. Steps include all earlier changes and can be rerun or skipped. During steps 2 through 4, run /usr/bin/id in VM terminal B after Attached appears in A.</a:t>
+              <a:t>Run from the Windows repo folder in terminal A, one step at a time. Each step script writes src/main.cpp and src/CMakeLists.txt locally. Run copies them to Ubuntu, rebuilds, starts a fresh ten-second agent run, displays output, and saves logs/latest.log locally. The agent stops and the VM remains running. Comment blocks mark additions. Step scripts replace local edits. Run copies those current files into the VM. Steps include all earlier changes and can be rerun or skipped. During steps 2 through 4, run /usr/bin/id in VM terminal B after Attached appears in A.</a:t>
             </a:r>
             <a:endParaRPr/>
           </a:p>
@@ -1498,7 +1498,7 @@
               <a:buNone/>
             </a:pPr>
             <a:r>
-              <a:t>The repository begins without collector source files. Step 1 creates the source directory and both files locally and copies them into Ubuntu. The full CMake file also sets C++17 and the output directory. The full main function handles exceptions and prints Attached to the Ubuntu kernel, then Capture stopped. No waiting for Enter or manual source editing is needed. The script runs the collector automatically. Source: https://github.com/falcosecurity/libs/blob/e72873882967cdd86b8753eca09ea3e9f91ccd4a/userspace/libsinsp/sinsp.h</a:t>
+              <a:t>The repository begins without collector source files. Step 1 creates the source directory and both files locally. Run copies them into Ubuntu and rebuilds. The full CMake file also sets C++17 and the output directory. The full main function handles exceptions and prints Attached to the Ubuntu kernel, then Capture stopped. No Enter key or manual editing is needed. The separate run script starts the collector. This initial stage waits ten seconds without draining events; the next stage adds the read loop. Source: https://github.com/falcosecurity/libs/blob/e72873882967cdd86b8753eca09ea3e9f91ccd4a/userspace/libsinsp/sinsp.h</a:t>
             </a:r>
             <a:endParaRPr/>
           </a:p>
@@ -5746,18 +5746,18 @@
   </p:cSld>
   <p:clrMap bg1="lt1" tx1="dk1" bg2="dk2" tx2="lt2" accent1="accent1" accent2="accent2" accent3="accent3" accent4="accent4" accent5="accent5" accent6="accent6" hlink="hlink" folHlink="folHlink"/>
   <p:sldLayoutIdLst>
-    <p:sldLayoutId xmlns:r="http://schemas.openxmlformats.org/officeDocument/2006/relationships" id="2147483649" r:id="R463c6712946c4d6a"/>
-    <p:sldLayoutId xmlns:r="http://schemas.openxmlformats.org/officeDocument/2006/relationships" id="2147483650" r:id="Ra8d04446e15a49f2"/>
-    <p:sldLayoutId xmlns:r="http://schemas.openxmlformats.org/officeDocument/2006/relationships" id="2147483651" r:id="R84fd8ad1791844bd"/>
-    <p:sldLayoutId xmlns:r="http://schemas.openxmlformats.org/officeDocument/2006/relationships" id="2147483652" r:id="Rdc87cbb5342341f7"/>
-    <p:sldLayoutId xmlns:r="http://schemas.openxmlformats.org/officeDocument/2006/relationships" id="2147483653" r:id="Reb99180b88b041e1"/>
-    <p:sldLayoutId xmlns:r="http://schemas.openxmlformats.org/officeDocument/2006/relationships" id="2147483654" r:id="R948abdc3a23e4e74"/>
-    <p:sldLayoutId xmlns:r="http://schemas.openxmlformats.org/officeDocument/2006/relationships" id="2147483655" r:id="R4a5872f04a6849cc"/>
-    <p:sldLayoutId xmlns:r="http://schemas.openxmlformats.org/officeDocument/2006/relationships" id="2147483656" r:id="R1bc874233496402f"/>
-    <p:sldLayoutId xmlns:r="http://schemas.openxmlformats.org/officeDocument/2006/relationships" id="2147483657" r:id="R1c1309029f274d14"/>
-    <p:sldLayoutId xmlns:r="http://schemas.openxmlformats.org/officeDocument/2006/relationships" id="2147483658" r:id="Rf6efb3858afc46d3"/>
-    <p:sldLayoutId xmlns:r="http://schemas.openxmlformats.org/officeDocument/2006/relationships" id="2147483659" r:id="R9f1a083709d649dc"/>
-    <p:sldLayoutId xmlns:r="http://schemas.openxmlformats.org/officeDocument/2006/relationships" id="2147483660" r:id="Re09ba15bdefd49be"/>
+    <p:sldLayoutId xmlns:r="http://schemas.openxmlformats.org/officeDocument/2006/relationships" id="2147483649" r:id="R98d02b6524f1450c"/>
+    <p:sldLayoutId xmlns:r="http://schemas.openxmlformats.org/officeDocument/2006/relationships" id="2147483650" r:id="R9f1182c37b874c1f"/>
+    <p:sldLayoutId xmlns:r="http://schemas.openxmlformats.org/officeDocument/2006/relationships" id="2147483651" r:id="R17a2593d46ee4e2e"/>
+    <p:sldLayoutId xmlns:r="http://schemas.openxmlformats.org/officeDocument/2006/relationships" id="2147483652" r:id="R66a1843d551248fd"/>
+    <p:sldLayoutId xmlns:r="http://schemas.openxmlformats.org/officeDocument/2006/relationships" id="2147483653" r:id="R1b67c90ccaf84156"/>
+    <p:sldLayoutId xmlns:r="http://schemas.openxmlformats.org/officeDocument/2006/relationships" id="2147483654" r:id="Rd263b31a3a144f51"/>
+    <p:sldLayoutId xmlns:r="http://schemas.openxmlformats.org/officeDocument/2006/relationships" id="2147483655" r:id="Rc4e0bc754cba48d1"/>
+    <p:sldLayoutId xmlns:r="http://schemas.openxmlformats.org/officeDocument/2006/relationships" id="2147483656" r:id="Rfa49b878cdaa44ce"/>
+    <p:sldLayoutId xmlns:r="http://schemas.openxmlformats.org/officeDocument/2006/relationships" id="2147483657" r:id="Rdbad6586d90d47c9"/>
+    <p:sldLayoutId xmlns:r="http://schemas.openxmlformats.org/officeDocument/2006/relationships" id="2147483658" r:id="R773af3cbb1594ea3"/>
+    <p:sldLayoutId xmlns:r="http://schemas.openxmlformats.org/officeDocument/2006/relationships" id="2147483659" r:id="R033593e79f544c9d"/>
+    <p:sldLayoutId xmlns:r="http://schemas.openxmlformats.org/officeDocument/2006/relationships" id="2147483660" r:id="Rc757a4d90c894650"/>
   </p:sldLayoutIdLst>
   <p:hf sldNum="0" hdr="0" ftr="0" dt="0"/>
   <p:txStyles>
@@ -6442,7 +6442,7 @@
   </p:cSld>
   <p:clrMap bg1="lt1" tx1="dk1" bg2="dk2" tx2="lt2" accent1="accent1" accent2="accent2" accent3="accent3" accent4="accent4" accent5="accent5" accent6="accent6" hlink="hlink" folHlink="folHlink"/>
   <p:sldLayoutIdLst>
-    <p:sldLayoutId xmlns:r="http://schemas.openxmlformats.org/officeDocument/2006/relationships" id="2147483662" r:id="Reb1add45ec6e4494"/>
+    <p:sldLayoutId xmlns:r="http://schemas.openxmlformats.org/officeDocument/2006/relationships" id="2147483662" r:id="Re603025a70824be6"/>
   </p:sldLayoutIdLst>
   <p:hf sldNum="0" hdr="0" ftr="0" dt="0"/>
   <p:txStyles>
@@ -8291,7 +8291,7 @@
           <p:nvPr/>
         </p:nvPicPr>
         <p:blipFill rotWithShape="1">
-          <a:blip xmlns:r="http://schemas.openxmlformats.org/officeDocument/2006/relationships" xmlns:a="http://schemas.openxmlformats.org/drawingml/2006/main" r:embed="R2b26c8b851f24fc4">
+          <a:blip xmlns:r="http://schemas.openxmlformats.org/officeDocument/2006/relationships" xmlns:a="http://schemas.openxmlformats.org/drawingml/2006/main" r:embed="R3a2d468da5c4462d">
             <a:alphaModFix/>
           </a:blip>
           <a:srcRect xmlns:a="http://schemas.openxmlformats.org/drawingml/2006/main" l="0" t="0" r="0" b="0"/>
@@ -8319,7 +8319,7 @@
           <p:nvPr/>
         </p:nvPicPr>
         <p:blipFill rotWithShape="1">
-          <a:blip xmlns:r="http://schemas.openxmlformats.org/officeDocument/2006/relationships" xmlns:a="http://schemas.openxmlformats.org/drawingml/2006/main" r:embed="R2b26c8b851f24fc4">
+          <a:blip xmlns:r="http://schemas.openxmlformats.org/officeDocument/2006/relationships" xmlns:a="http://schemas.openxmlformats.org/drawingml/2006/main" r:embed="R3a2d468da5c4462d">
             <a:alphaModFix/>
           </a:blip>
           <a:srcRect xmlns:a="http://schemas.openxmlformats.org/drawingml/2006/main" l="0" t="0" r="0" b="0"/>
@@ -8347,7 +8347,7 @@
           <p:nvPr/>
         </p:nvPicPr>
         <p:blipFill rotWithShape="1">
-          <a:blip xmlns:r="http://schemas.openxmlformats.org/officeDocument/2006/relationships" xmlns:a="http://schemas.openxmlformats.org/drawingml/2006/main" r:embed="R2b26c8b851f24fc4">
+          <a:blip xmlns:r="http://schemas.openxmlformats.org/officeDocument/2006/relationships" xmlns:a="http://schemas.openxmlformats.org/drawingml/2006/main" r:embed="R3a2d468da5c4462d">
             <a:alphaModFix/>
           </a:blip>
           <a:srcRect xmlns:a="http://schemas.openxmlformats.org/drawingml/2006/main" l="0" t="0" r="0" b="0"/>
@@ -8375,7 +8375,7 @@
           <p:nvPr/>
         </p:nvPicPr>
         <p:blipFill rotWithShape="1">
-          <a:blip xmlns:r="http://schemas.openxmlformats.org/officeDocument/2006/relationships" xmlns:a="http://schemas.openxmlformats.org/drawingml/2006/main" r:embed="R2b26c8b851f24fc4">
+          <a:blip xmlns:r="http://schemas.openxmlformats.org/officeDocument/2006/relationships" xmlns:a="http://schemas.openxmlformats.org/drawingml/2006/main" r:embed="R3a2d468da5c4462d">
             <a:alphaModFix/>
           </a:blip>
           <a:srcRect xmlns:a="http://schemas.openxmlformats.org/drawingml/2006/main" l="0" t="0" r="0" b="0"/>
@@ -8403,7 +8403,7 @@
           <p:nvPr/>
         </p:nvPicPr>
         <p:blipFill rotWithShape="1">
-          <a:blip xmlns:r="http://schemas.openxmlformats.org/officeDocument/2006/relationships" xmlns:a="http://schemas.openxmlformats.org/drawingml/2006/main" r:embed="R2b26c8b851f24fc4">
+          <a:blip xmlns:r="http://schemas.openxmlformats.org/officeDocument/2006/relationships" xmlns:a="http://schemas.openxmlformats.org/drawingml/2006/main" r:embed="R3a2d468da5c4462d">
             <a:alphaModFix/>
           </a:blip>
           <a:srcRect xmlns:a="http://schemas.openxmlformats.org/drawingml/2006/main" l="0" t="0" r="0" b="0"/>
@@ -8431,7 +8431,7 @@
           <p:nvPr/>
         </p:nvPicPr>
         <p:blipFill rotWithShape="1">
-          <a:blip xmlns:r="http://schemas.openxmlformats.org/officeDocument/2006/relationships" xmlns:a="http://schemas.openxmlformats.org/drawingml/2006/main" r:embed="R2b26c8b851f24fc4">
+          <a:blip xmlns:r="http://schemas.openxmlformats.org/officeDocument/2006/relationships" xmlns:a="http://schemas.openxmlformats.org/drawingml/2006/main" r:embed="R3a2d468da5c4462d">
             <a:alphaModFix/>
           </a:blip>
           <a:srcRect xmlns:a="http://schemas.openxmlformats.org/drawingml/2006/main" l="0" t="0" r="0" b="0"/>
@@ -8459,7 +8459,7 @@
           <p:nvPr/>
         </p:nvPicPr>
         <p:blipFill rotWithShape="1">
-          <a:blip xmlns:r="http://schemas.openxmlformats.org/officeDocument/2006/relationships" xmlns:a="http://schemas.openxmlformats.org/drawingml/2006/main" r:embed="R2b26c8b851f24fc4">
+          <a:blip xmlns:r="http://schemas.openxmlformats.org/officeDocument/2006/relationships" xmlns:a="http://schemas.openxmlformats.org/drawingml/2006/main" r:embed="R3a2d468da5c4462d">
             <a:alphaModFix/>
           </a:blip>
           <a:srcRect xmlns:a="http://schemas.openxmlformats.org/drawingml/2006/main" l="0" t="0" r="0" b="0"/>
@@ -8487,7 +8487,7 @@
           <p:nvPr/>
         </p:nvPicPr>
         <p:blipFill rotWithShape="1">
-          <a:blip xmlns:r="http://schemas.openxmlformats.org/officeDocument/2006/relationships" xmlns:a="http://schemas.openxmlformats.org/drawingml/2006/main" r:embed="R2b26c8b851f24fc4">
+          <a:blip xmlns:r="http://schemas.openxmlformats.org/officeDocument/2006/relationships" xmlns:a="http://schemas.openxmlformats.org/drawingml/2006/main" r:embed="R3a2d468da5c4462d">
             <a:alphaModFix/>
           </a:blip>
           <a:srcRect xmlns:a="http://schemas.openxmlformats.org/drawingml/2006/main" l="0" t="0" r="0" b="0"/>
@@ -9363,7 +9363,7 @@
                 <a:ea typeface="Inter"/>
                 <a:cs typeface="Inter"/>
               </a:rPr>
-              <a:t>The script prints the count when capture ends. It varies with VM activity.</a:t>
+              <a:t>The agent prints the count when capture ends. It varies with VM activity.</a:t>
             </a:r>
           </a:p>
         </p:txBody>
@@ -10790,7 +10790,7 @@
           <p:nvPr/>
         </p:nvPicPr>
         <p:blipFill rotWithShape="1">
-          <a:blip xmlns:r="http://schemas.openxmlformats.org/officeDocument/2006/relationships" xmlns:a="http://schemas.openxmlformats.org/drawingml/2006/main" r:embed="Rb19d1905c50a4192">
+          <a:blip xmlns:r="http://schemas.openxmlformats.org/officeDocument/2006/relationships" xmlns:a="http://schemas.openxmlformats.org/drawingml/2006/main" r:embed="R7dd61178228a4ca4">
             <a:alphaModFix/>
           </a:blip>
           <a:srcRect xmlns:a="http://schemas.openxmlformats.org/drawingml/2006/main" l="0" t="0" r="0" b="0"/>
@@ -10818,7 +10818,7 @@
           <p:nvPr/>
         </p:nvPicPr>
         <p:blipFill rotWithShape="1">
-          <a:blip xmlns:r="http://schemas.openxmlformats.org/officeDocument/2006/relationships" xmlns:a="http://schemas.openxmlformats.org/drawingml/2006/main" r:embed="Rb19d1905c50a4192">
+          <a:blip xmlns:r="http://schemas.openxmlformats.org/officeDocument/2006/relationships" xmlns:a="http://schemas.openxmlformats.org/drawingml/2006/main" r:embed="R7dd61178228a4ca4">
             <a:alphaModFix/>
           </a:blip>
           <a:srcRect xmlns:a="http://schemas.openxmlformats.org/drawingml/2006/main" l="0" t="0" r="0" b="0"/>
@@ -10846,7 +10846,7 @@
           <p:nvPr/>
         </p:nvPicPr>
         <p:blipFill rotWithShape="1">
-          <a:blip xmlns:r="http://schemas.openxmlformats.org/officeDocument/2006/relationships" xmlns:a="http://schemas.openxmlformats.org/drawingml/2006/main" r:embed="Rb19d1905c50a4192">
+          <a:blip xmlns:r="http://schemas.openxmlformats.org/officeDocument/2006/relationships" xmlns:a="http://schemas.openxmlformats.org/drawingml/2006/main" r:embed="R7dd61178228a4ca4">
             <a:alphaModFix/>
           </a:blip>
           <a:srcRect xmlns:a="http://schemas.openxmlformats.org/drawingml/2006/main" l="0" t="0" r="0" b="0"/>
@@ -10874,7 +10874,7 @@
           <p:nvPr/>
         </p:nvPicPr>
         <p:blipFill rotWithShape="1">
-          <a:blip xmlns:r="http://schemas.openxmlformats.org/officeDocument/2006/relationships" xmlns:a="http://schemas.openxmlformats.org/drawingml/2006/main" r:embed="Rb19d1905c50a4192">
+          <a:blip xmlns:r="http://schemas.openxmlformats.org/officeDocument/2006/relationships" xmlns:a="http://schemas.openxmlformats.org/drawingml/2006/main" r:embed="R7dd61178228a4ca4">
             <a:alphaModFix/>
           </a:blip>
           <a:srcRect xmlns:a="http://schemas.openxmlformats.org/drawingml/2006/main" l="0" t="0" r="0" b="0"/>
@@ -11472,7 +11472,7 @@
                 <a:ea typeface="Inter"/>
                 <a:cs typeface="Inter"/>
               </a:rPr>
-              <a:t>Run step 3 in terminal A.</a:t>
+              <a:t>Run step 3, then run in terminal A.</a:t>
             </a:r>
           </a:p>
           <a:p xmlns:a="http://schemas.openxmlformats.org/drawingml/2006/main">
@@ -12755,7 +12755,7 @@
           <p:nvPr/>
         </p:nvPicPr>
         <p:blipFill rotWithShape="1">
-          <a:blip xmlns:r="http://schemas.openxmlformats.org/officeDocument/2006/relationships" xmlns:a="http://schemas.openxmlformats.org/drawingml/2006/main" r:embed="R9ad106ea1b4b4def">
+          <a:blip xmlns:r="http://schemas.openxmlformats.org/officeDocument/2006/relationships" xmlns:a="http://schemas.openxmlformats.org/drawingml/2006/main" r:embed="R7de6af14fb1541a0">
             <a:alphaModFix/>
           </a:blip>
           <a:srcRect xmlns:a="http://schemas.openxmlformats.org/drawingml/2006/main" l="0" t="0" r="0" b="0"/>
@@ -12783,7 +12783,7 @@
           <p:nvPr/>
         </p:nvPicPr>
         <p:blipFill rotWithShape="1">
-          <a:blip xmlns:r="http://schemas.openxmlformats.org/officeDocument/2006/relationships" xmlns:a="http://schemas.openxmlformats.org/drawingml/2006/main" r:embed="R9ad106ea1b4b4def">
+          <a:blip xmlns:r="http://schemas.openxmlformats.org/officeDocument/2006/relationships" xmlns:a="http://schemas.openxmlformats.org/drawingml/2006/main" r:embed="R7de6af14fb1541a0">
             <a:alphaModFix/>
           </a:blip>
           <a:srcRect xmlns:a="http://schemas.openxmlformats.org/drawingml/2006/main" l="0" t="0" r="0" b="0"/>
@@ -12811,7 +12811,7 @@
           <p:nvPr/>
         </p:nvPicPr>
         <p:blipFill rotWithShape="1">
-          <a:blip xmlns:r="http://schemas.openxmlformats.org/officeDocument/2006/relationships" xmlns:a="http://schemas.openxmlformats.org/drawingml/2006/main" r:embed="R9ad106ea1b4b4def">
+          <a:blip xmlns:r="http://schemas.openxmlformats.org/officeDocument/2006/relationships" xmlns:a="http://schemas.openxmlformats.org/drawingml/2006/main" r:embed="R7de6af14fb1541a0">
             <a:alphaModFix/>
           </a:blip>
           <a:srcRect xmlns:a="http://schemas.openxmlformats.org/drawingml/2006/main" l="0" t="0" r="0" b="0"/>
@@ -12839,7 +12839,7 @@
           <p:nvPr/>
         </p:nvPicPr>
         <p:blipFill rotWithShape="1">
-          <a:blip xmlns:r="http://schemas.openxmlformats.org/officeDocument/2006/relationships" xmlns:a="http://schemas.openxmlformats.org/drawingml/2006/main" r:embed="R9ad106ea1b4b4def">
+          <a:blip xmlns:r="http://schemas.openxmlformats.org/officeDocument/2006/relationships" xmlns:a="http://schemas.openxmlformats.org/drawingml/2006/main" r:embed="R7de6af14fb1541a0">
             <a:alphaModFix/>
           </a:blip>
           <a:srcRect xmlns:a="http://schemas.openxmlformats.org/drawingml/2006/main" l="0" t="0" r="0" b="0"/>
@@ -13437,7 +13437,7 @@
                 <a:ea typeface="Inter"/>
                 <a:cs typeface="Inter"/>
               </a:rPr>
-              <a:t>Run step 4 in terminal A.</a:t>
+              <a:t>Run step 4, then run in terminal A.</a:t>
             </a:r>
           </a:p>
           <a:p xmlns:a="http://schemas.openxmlformats.org/drawingml/2006/main">
@@ -14788,7 +14788,7 @@
           <p:nvPr/>
         </p:nvPicPr>
         <p:blipFill rotWithShape="1">
-          <a:blip xmlns:r="http://schemas.openxmlformats.org/officeDocument/2006/relationships" xmlns:a="http://schemas.openxmlformats.org/drawingml/2006/main" r:embed="R2647ac204c2643e7">
+          <a:blip xmlns:r="http://schemas.openxmlformats.org/officeDocument/2006/relationships" xmlns:a="http://schemas.openxmlformats.org/drawingml/2006/main" r:embed="R69e4c9c209b74d79">
             <a:alphaModFix/>
           </a:blip>
           <a:srcRect xmlns:a="http://schemas.openxmlformats.org/drawingml/2006/main" l="0" t="0" r="0" b="0"/>
@@ -14816,7 +14816,7 @@
           <p:nvPr/>
         </p:nvPicPr>
         <p:blipFill rotWithShape="1">
-          <a:blip xmlns:r="http://schemas.openxmlformats.org/officeDocument/2006/relationships" xmlns:a="http://schemas.openxmlformats.org/drawingml/2006/main" r:embed="R2647ac204c2643e7">
+          <a:blip xmlns:r="http://schemas.openxmlformats.org/officeDocument/2006/relationships" xmlns:a="http://schemas.openxmlformats.org/drawingml/2006/main" r:embed="R69e4c9c209b74d79">
             <a:alphaModFix/>
           </a:blip>
           <a:srcRect xmlns:a="http://schemas.openxmlformats.org/drawingml/2006/main" l="0" t="0" r="0" b="0"/>
@@ -14844,7 +14844,7 @@
           <p:nvPr/>
         </p:nvPicPr>
         <p:blipFill rotWithShape="1">
-          <a:blip xmlns:r="http://schemas.openxmlformats.org/officeDocument/2006/relationships" xmlns:a="http://schemas.openxmlformats.org/drawingml/2006/main" r:embed="R2647ac204c2643e7">
+          <a:blip xmlns:r="http://schemas.openxmlformats.org/officeDocument/2006/relationships" xmlns:a="http://schemas.openxmlformats.org/drawingml/2006/main" r:embed="R69e4c9c209b74d79">
             <a:alphaModFix/>
           </a:blip>
           <a:srcRect xmlns:a="http://schemas.openxmlformats.org/drawingml/2006/main" l="0" t="0" r="0" b="0"/>
@@ -14872,7 +14872,7 @@
           <p:nvPr/>
         </p:nvPicPr>
         <p:blipFill rotWithShape="1">
-          <a:blip xmlns:r="http://schemas.openxmlformats.org/officeDocument/2006/relationships" xmlns:a="http://schemas.openxmlformats.org/drawingml/2006/main" r:embed="R2647ac204c2643e7">
+          <a:blip xmlns:r="http://schemas.openxmlformats.org/officeDocument/2006/relationships" xmlns:a="http://schemas.openxmlformats.org/drawingml/2006/main" r:embed="R69e4c9c209b74d79">
             <a:alphaModFix/>
           </a:blip>
           <a:srcRect xmlns:a="http://schemas.openxmlformats.org/drawingml/2006/main" l="0" t="0" r="0" b="0"/>
@@ -15626,7 +15626,7 @@
                 <a:ea typeface="Inter"/>
                 <a:cs typeface="Inter"/>
               </a:rPr>
-              <a:t>Step 4 installs the complete collector.</a:t>
+              <a:t>Step 4 writes the complete collector. Run rebuilds and captures.</a:t>
             </a:r>
           </a:p>
         </p:txBody>
@@ -16155,7 +16155,7 @@
                 <a:ea typeface="Roboto Mono"/>
                 <a:cs typeface="Roboto Mono"/>
               </a:rPr>
-              <a:t># Inspect its code in VM terminal B</a:t>
+              <a:t># Saved on your laptop</a:t>
             </a:r>
           </a:p>
           <a:p xmlns:a="http://schemas.openxmlformats.org/drawingml/2006/main">
@@ -16185,7 +16185,7 @@
                 <a:ea typeface="Roboto Mono"/>
                 <a:cs typeface="Roboto Mono"/>
               </a:rPr>
-              <a:t>cat src/main.cpp</a:t>
+              <a:t>logs/latest.log</a:t>
             </a:r>
           </a:p>
         </p:txBody>
@@ -16835,7 +16835,7 @@
           <p:nvPr/>
         </p:nvPicPr>
         <p:blipFill rotWithShape="1">
-          <a:blip xmlns:r="http://schemas.openxmlformats.org/officeDocument/2006/relationships" xmlns:a="http://schemas.openxmlformats.org/drawingml/2006/main" r:embed="Rd6fd567145f048ef">
+          <a:blip xmlns:r="http://schemas.openxmlformats.org/officeDocument/2006/relationships" xmlns:a="http://schemas.openxmlformats.org/drawingml/2006/main" r:embed="R44f2767bd7e7418a">
             <a:alphaModFix/>
           </a:blip>
           <a:srcRect xmlns:a="http://schemas.openxmlformats.org/drawingml/2006/main" l="0" t="0" r="0" b="0"/>
@@ -16863,7 +16863,7 @@
           <p:nvPr/>
         </p:nvPicPr>
         <p:blipFill rotWithShape="1">
-          <a:blip xmlns:r="http://schemas.openxmlformats.org/officeDocument/2006/relationships" xmlns:a="http://schemas.openxmlformats.org/drawingml/2006/main" r:embed="Rd6fd567145f048ef">
+          <a:blip xmlns:r="http://schemas.openxmlformats.org/officeDocument/2006/relationships" xmlns:a="http://schemas.openxmlformats.org/drawingml/2006/main" r:embed="R44f2767bd7e7418a">
             <a:alphaModFix/>
           </a:blip>
           <a:srcRect xmlns:a="http://schemas.openxmlformats.org/drawingml/2006/main" l="0" t="0" r="0" b="0"/>
@@ -16891,7 +16891,7 @@
           <p:nvPr/>
         </p:nvPicPr>
         <p:blipFill rotWithShape="1">
-          <a:blip xmlns:r="http://schemas.openxmlformats.org/officeDocument/2006/relationships" xmlns:a="http://schemas.openxmlformats.org/drawingml/2006/main" r:embed="Rd6fd567145f048ef">
+          <a:blip xmlns:r="http://schemas.openxmlformats.org/officeDocument/2006/relationships" xmlns:a="http://schemas.openxmlformats.org/drawingml/2006/main" r:embed="R44f2767bd7e7418a">
             <a:alphaModFix/>
           </a:blip>
           <a:srcRect xmlns:a="http://schemas.openxmlformats.org/drawingml/2006/main" l="0" t="0" r="0" b="0"/>
@@ -16919,7 +16919,7 @@
           <p:nvPr/>
         </p:nvPicPr>
         <p:blipFill rotWithShape="1">
-          <a:blip xmlns:r="http://schemas.openxmlformats.org/officeDocument/2006/relationships" xmlns:a="http://schemas.openxmlformats.org/drawingml/2006/main" r:embed="Rd6fd567145f048ef">
+          <a:blip xmlns:r="http://schemas.openxmlformats.org/officeDocument/2006/relationships" xmlns:a="http://schemas.openxmlformats.org/drawingml/2006/main" r:embed="R44f2767bd7e7418a">
             <a:alphaModFix/>
           </a:blip>
           <a:srcRect xmlns:a="http://schemas.openxmlformats.org/drawingml/2006/main" l="0" t="0" r="0" b="0"/>
@@ -18770,7 +18770,7 @@
           <p:nvPr/>
         </p:nvPicPr>
         <p:blipFill rotWithShape="1">
-          <a:blip xmlns:r="http://schemas.openxmlformats.org/officeDocument/2006/relationships" xmlns:a="http://schemas.openxmlformats.org/drawingml/2006/main" r:embed="R77e57a7775a54c45">
+          <a:blip xmlns:r="http://schemas.openxmlformats.org/officeDocument/2006/relationships" xmlns:a="http://schemas.openxmlformats.org/drawingml/2006/main" r:embed="R14cdab6cde694c15">
             <a:alphaModFix/>
           </a:blip>
           <a:srcRect xmlns:a="http://schemas.openxmlformats.org/drawingml/2006/main" l="0" t="0" r="0" b="0"/>
@@ -18798,7 +18798,7 @@
           <p:nvPr/>
         </p:nvPicPr>
         <p:blipFill rotWithShape="1">
-          <a:blip xmlns:r="http://schemas.openxmlformats.org/officeDocument/2006/relationships" xmlns:a="http://schemas.openxmlformats.org/drawingml/2006/main" r:embed="R77e57a7775a54c45">
+          <a:blip xmlns:r="http://schemas.openxmlformats.org/officeDocument/2006/relationships" xmlns:a="http://schemas.openxmlformats.org/drawingml/2006/main" r:embed="R14cdab6cde694c15">
             <a:alphaModFix/>
           </a:blip>
           <a:srcRect xmlns:a="http://schemas.openxmlformats.org/drawingml/2006/main" l="0" t="0" r="0" b="0"/>
@@ -18826,7 +18826,7 @@
           <p:nvPr/>
         </p:nvPicPr>
         <p:blipFill rotWithShape="1">
-          <a:blip xmlns:r="http://schemas.openxmlformats.org/officeDocument/2006/relationships" xmlns:a="http://schemas.openxmlformats.org/drawingml/2006/main" r:embed="R77e57a7775a54c45">
+          <a:blip xmlns:r="http://schemas.openxmlformats.org/officeDocument/2006/relationships" xmlns:a="http://schemas.openxmlformats.org/drawingml/2006/main" r:embed="R14cdab6cde694c15">
             <a:alphaModFix/>
           </a:blip>
           <a:srcRect xmlns:a="http://schemas.openxmlformats.org/drawingml/2006/main" l="0" t="0" r="0" b="0"/>
@@ -18854,7 +18854,7 @@
           <p:nvPr/>
         </p:nvPicPr>
         <p:blipFill rotWithShape="1">
-          <a:blip xmlns:r="http://schemas.openxmlformats.org/officeDocument/2006/relationships" xmlns:a="http://schemas.openxmlformats.org/drawingml/2006/main" r:embed="R77e57a7775a54c45">
+          <a:blip xmlns:r="http://schemas.openxmlformats.org/officeDocument/2006/relationships" xmlns:a="http://schemas.openxmlformats.org/drawingml/2006/main" r:embed="R14cdab6cde694c15">
             <a:alphaModFix/>
           </a:blip>
           <a:srcRect xmlns:a="http://schemas.openxmlformats.org/drawingml/2006/main" l="0" t="0" r="0" b="0"/>
@@ -19943,7 +19943,7 @@
                 <a:ea typeface="Roboto Mono"/>
                 <a:cs typeface="Roboto Mono"/>
               </a:rPr>
-              <a:t>1  Create src/ and attach</a:t>
+              <a:t>1  Create the barebones source</a:t>
             </a:r>
           </a:p>
           <a:p xmlns:a="http://schemas.openxmlformats.org/drawingml/2006/main">
@@ -20749,7 +20749,7 @@
           <p:nvPr/>
         </p:nvPicPr>
         <p:blipFill rotWithShape="1">
-          <a:blip xmlns:r="http://schemas.openxmlformats.org/officeDocument/2006/relationships" xmlns:a="http://schemas.openxmlformats.org/drawingml/2006/main" r:embed="R6becd55c02f244a0">
+          <a:blip xmlns:r="http://schemas.openxmlformats.org/officeDocument/2006/relationships" xmlns:a="http://schemas.openxmlformats.org/drawingml/2006/main" r:embed="R26837cc320c047c9">
             <a:alphaModFix/>
           </a:blip>
           <a:srcRect xmlns:a="http://schemas.openxmlformats.org/drawingml/2006/main" l="0" t="0" r="0" b="0"/>
@@ -20777,7 +20777,7 @@
           <p:nvPr/>
         </p:nvPicPr>
         <p:blipFill rotWithShape="1">
-          <a:blip xmlns:r="http://schemas.openxmlformats.org/officeDocument/2006/relationships" xmlns:a="http://schemas.openxmlformats.org/drawingml/2006/main" r:embed="R6becd55c02f244a0">
+          <a:blip xmlns:r="http://schemas.openxmlformats.org/officeDocument/2006/relationships" xmlns:a="http://schemas.openxmlformats.org/drawingml/2006/main" r:embed="R26837cc320c047c9">
             <a:alphaModFix/>
           </a:blip>
           <a:srcRect xmlns:a="http://schemas.openxmlformats.org/drawingml/2006/main" l="0" t="0" r="0" b="0"/>
@@ -20805,7 +20805,7 @@
           <p:nvPr/>
         </p:nvPicPr>
         <p:blipFill rotWithShape="1">
-          <a:blip xmlns:r="http://schemas.openxmlformats.org/officeDocument/2006/relationships" xmlns:a="http://schemas.openxmlformats.org/drawingml/2006/main" r:embed="R6becd55c02f244a0">
+          <a:blip xmlns:r="http://schemas.openxmlformats.org/officeDocument/2006/relationships" xmlns:a="http://schemas.openxmlformats.org/drawingml/2006/main" r:embed="R26837cc320c047c9">
             <a:alphaModFix/>
           </a:blip>
           <a:srcRect xmlns:a="http://schemas.openxmlformats.org/drawingml/2006/main" l="0" t="0" r="0" b="0"/>
@@ -20833,7 +20833,7 @@
           <p:nvPr/>
         </p:nvPicPr>
         <p:blipFill rotWithShape="1">
-          <a:blip xmlns:r="http://schemas.openxmlformats.org/officeDocument/2006/relationships" xmlns:a="http://schemas.openxmlformats.org/drawingml/2006/main" r:embed="R6becd55c02f244a0">
+          <a:blip xmlns:r="http://schemas.openxmlformats.org/officeDocument/2006/relationships" xmlns:a="http://schemas.openxmlformats.org/drawingml/2006/main" r:embed="R26837cc320c047c9">
             <a:alphaModFix/>
           </a:blip>
           <a:srcRect xmlns:a="http://schemas.openxmlformats.org/drawingml/2006/main" l="0" t="0" r="0" b="0"/>
@@ -22446,7 +22446,7 @@
           <p:nvPr/>
         </p:nvPicPr>
         <p:blipFill rotWithShape="1">
-          <a:blip xmlns:r="http://schemas.openxmlformats.org/officeDocument/2006/relationships" xmlns:a="http://schemas.openxmlformats.org/drawingml/2006/main" r:embed="Rb8b09f40538a403d">
+          <a:blip xmlns:r="http://schemas.openxmlformats.org/officeDocument/2006/relationships" xmlns:a="http://schemas.openxmlformats.org/drawingml/2006/main" r:embed="R8fa8a24efb3a44cc">
             <a:alphaModFix/>
           </a:blip>
           <a:srcRect xmlns:a="http://schemas.openxmlformats.org/drawingml/2006/main" l="0" t="0" r="0" b="0"/>
@@ -22474,7 +22474,7 @@
           <p:nvPr/>
         </p:nvPicPr>
         <p:blipFill rotWithShape="1">
-          <a:blip xmlns:r="http://schemas.openxmlformats.org/officeDocument/2006/relationships" xmlns:a="http://schemas.openxmlformats.org/drawingml/2006/main" r:embed="Rb8b09f40538a403d">
+          <a:blip xmlns:r="http://schemas.openxmlformats.org/officeDocument/2006/relationships" xmlns:a="http://schemas.openxmlformats.org/drawingml/2006/main" r:embed="R8fa8a24efb3a44cc">
             <a:alphaModFix/>
           </a:blip>
           <a:srcRect xmlns:a="http://schemas.openxmlformats.org/drawingml/2006/main" l="0" t="0" r="0" b="0"/>
@@ -22502,7 +22502,7 @@
           <p:nvPr/>
         </p:nvPicPr>
         <p:blipFill rotWithShape="1">
-          <a:blip xmlns:r="http://schemas.openxmlformats.org/officeDocument/2006/relationships" xmlns:a="http://schemas.openxmlformats.org/drawingml/2006/main" r:embed="Rb8b09f40538a403d">
+          <a:blip xmlns:r="http://schemas.openxmlformats.org/officeDocument/2006/relationships" xmlns:a="http://schemas.openxmlformats.org/drawingml/2006/main" r:embed="R8fa8a24efb3a44cc">
             <a:alphaModFix/>
           </a:blip>
           <a:srcRect xmlns:a="http://schemas.openxmlformats.org/drawingml/2006/main" l="0" t="0" r="0" b="0"/>
@@ -22530,7 +22530,7 @@
           <p:nvPr/>
         </p:nvPicPr>
         <p:blipFill rotWithShape="1">
-          <a:blip xmlns:r="http://schemas.openxmlformats.org/officeDocument/2006/relationships" xmlns:a="http://schemas.openxmlformats.org/drawingml/2006/main" r:embed="Rb8b09f40538a403d">
+          <a:blip xmlns:r="http://schemas.openxmlformats.org/officeDocument/2006/relationships" xmlns:a="http://schemas.openxmlformats.org/drawingml/2006/main" r:embed="R8fa8a24efb3a44cc">
             <a:alphaModFix/>
           </a:blip>
           <a:srcRect xmlns:a="http://schemas.openxmlformats.org/drawingml/2006/main" l="0" t="0" r="0" b="0"/>
@@ -24143,7 +24143,7 @@
           <p:nvPr/>
         </p:nvPicPr>
         <p:blipFill rotWithShape="1">
-          <a:blip xmlns:r="http://schemas.openxmlformats.org/officeDocument/2006/relationships" xmlns:a="http://schemas.openxmlformats.org/drawingml/2006/main" r:embed="R53b13d0774ba4afb">
+          <a:blip xmlns:r="http://schemas.openxmlformats.org/officeDocument/2006/relationships" xmlns:a="http://schemas.openxmlformats.org/drawingml/2006/main" r:embed="Rc1f4b05def794898">
             <a:alphaModFix/>
           </a:blip>
           <a:srcRect xmlns:a="http://schemas.openxmlformats.org/drawingml/2006/main" l="0" t="0" r="0" b="0"/>
@@ -24171,7 +24171,7 @@
           <p:nvPr/>
         </p:nvPicPr>
         <p:blipFill rotWithShape="1">
-          <a:blip xmlns:r="http://schemas.openxmlformats.org/officeDocument/2006/relationships" xmlns:a="http://schemas.openxmlformats.org/drawingml/2006/main" r:embed="R53b13d0774ba4afb">
+          <a:blip xmlns:r="http://schemas.openxmlformats.org/officeDocument/2006/relationships" xmlns:a="http://schemas.openxmlformats.org/drawingml/2006/main" r:embed="Rc1f4b05def794898">
             <a:alphaModFix/>
           </a:blip>
           <a:srcRect xmlns:a="http://schemas.openxmlformats.org/drawingml/2006/main" l="0" t="0" r="0" b="0"/>
@@ -24199,7 +24199,7 @@
           <p:nvPr/>
         </p:nvPicPr>
         <p:blipFill rotWithShape="1">
-          <a:blip xmlns:r="http://schemas.openxmlformats.org/officeDocument/2006/relationships" xmlns:a="http://schemas.openxmlformats.org/drawingml/2006/main" r:embed="R53b13d0774ba4afb">
+          <a:blip xmlns:r="http://schemas.openxmlformats.org/officeDocument/2006/relationships" xmlns:a="http://schemas.openxmlformats.org/drawingml/2006/main" r:embed="Rc1f4b05def794898">
             <a:alphaModFix/>
           </a:blip>
           <a:srcRect xmlns:a="http://schemas.openxmlformats.org/drawingml/2006/main" l="0" t="0" r="0" b="0"/>
@@ -24227,7 +24227,7 @@
           <p:nvPr/>
         </p:nvPicPr>
         <p:blipFill rotWithShape="1">
-          <a:blip xmlns:r="http://schemas.openxmlformats.org/officeDocument/2006/relationships" xmlns:a="http://schemas.openxmlformats.org/drawingml/2006/main" r:embed="R53b13d0774ba4afb">
+          <a:blip xmlns:r="http://schemas.openxmlformats.org/officeDocument/2006/relationships" xmlns:a="http://schemas.openxmlformats.org/drawingml/2006/main" r:embed="Rc1f4b05def794898">
             <a:alphaModFix/>
           </a:blip>
           <a:srcRect xmlns:a="http://schemas.openxmlformats.org/drawingml/2006/main" l="0" t="0" r="0" b="0"/>
@@ -24825,7 +24825,7 @@
                 <a:ea typeface="Inter"/>
                 <a:cs typeface="Inter"/>
               </a:rPr>
-              <a:t>A: keep your Mac or Windows terminal in the repo folder. Run your platform’s step scripts here.</a:t>
+              <a:t>A: keep your Mac or Windows terminal in the repo folder. Run your platform’s step and run scripts here.</a:t>
             </a:r>
           </a:p>
           <a:p xmlns:a="http://schemas.openxmlformats.org/drawingml/2006/main">
@@ -26026,7 +26026,7 @@
           <p:nvPr/>
         </p:nvPicPr>
         <p:blipFill rotWithShape="1">
-          <a:blip xmlns:r="http://schemas.openxmlformats.org/officeDocument/2006/relationships" xmlns:a="http://schemas.openxmlformats.org/drawingml/2006/main" r:embed="R6c73447341df4dbf">
+          <a:blip xmlns:r="http://schemas.openxmlformats.org/officeDocument/2006/relationships" xmlns:a="http://schemas.openxmlformats.org/drawingml/2006/main" r:embed="R27c6ce2808ad42b7">
             <a:alphaModFix/>
           </a:blip>
           <a:srcRect xmlns:a="http://schemas.openxmlformats.org/drawingml/2006/main" l="0" t="0" r="0" b="0"/>
@@ -26054,7 +26054,7 @@
           <p:nvPr/>
         </p:nvPicPr>
         <p:blipFill rotWithShape="1">
-          <a:blip xmlns:r="http://schemas.openxmlformats.org/officeDocument/2006/relationships" xmlns:a="http://schemas.openxmlformats.org/drawingml/2006/main" r:embed="R6c73447341df4dbf">
+          <a:blip xmlns:r="http://schemas.openxmlformats.org/officeDocument/2006/relationships" xmlns:a="http://schemas.openxmlformats.org/drawingml/2006/main" r:embed="R27c6ce2808ad42b7">
             <a:alphaModFix/>
           </a:blip>
           <a:srcRect xmlns:a="http://schemas.openxmlformats.org/drawingml/2006/main" l="0" t="0" r="0" b="0"/>
@@ -26082,7 +26082,7 @@
           <p:nvPr/>
         </p:nvPicPr>
         <p:blipFill rotWithShape="1">
-          <a:blip xmlns:r="http://schemas.openxmlformats.org/officeDocument/2006/relationships" xmlns:a="http://schemas.openxmlformats.org/drawingml/2006/main" r:embed="R6c73447341df4dbf">
+          <a:blip xmlns:r="http://schemas.openxmlformats.org/officeDocument/2006/relationships" xmlns:a="http://schemas.openxmlformats.org/drawingml/2006/main" r:embed="R27c6ce2808ad42b7">
             <a:alphaModFix/>
           </a:blip>
           <a:srcRect xmlns:a="http://schemas.openxmlformats.org/drawingml/2006/main" l="0" t="0" r="0" b="0"/>
@@ -26110,7 +26110,7 @@
           <p:nvPr/>
         </p:nvPicPr>
         <p:blipFill rotWithShape="1">
-          <a:blip xmlns:r="http://schemas.openxmlformats.org/officeDocument/2006/relationships" xmlns:a="http://schemas.openxmlformats.org/drawingml/2006/main" r:embed="R6c73447341df4dbf">
+          <a:blip xmlns:r="http://schemas.openxmlformats.org/officeDocument/2006/relationships" xmlns:a="http://schemas.openxmlformats.org/drawingml/2006/main" r:embed="R27c6ce2808ad42b7">
             <a:alphaModFix/>
           </a:blip>
           <a:srcRect xmlns:a="http://schemas.openxmlformats.org/drawingml/2006/main" l="0" t="0" r="0" b="0"/>
@@ -26604,7 +26604,7 @@
                 <a:ea typeface="Inter"/>
                 <a:cs typeface="Inter"/>
               </a:rPr>
-              <a:t>Terminal A: run each step when we reach it.</a:t>
+              <a:t>Terminal A: apply a step, then rebuild and capture.</a:t>
             </a:r>
           </a:p>
         </p:txBody>
@@ -26995,14 +26995,22 @@
             </a:r>
           </a:p>
           <a:p xmlns:a="http://schemas.openxmlformats.org/drawingml/2006/main">
-            <a:pPr marL="0" indent="0">
-              <a:spcBef>
-                <a:spcPts val="0"/>
-              </a:spcBef>
-              <a:spcAft>
-                <a:spcPts val="0"/>
-              </a:spcAft>
-              <a:buNone/>
+            <a:pPr marL="0" indent="0" algn="l">
+              <a:spcBef>
+                <a:spcPts val="0"/>
+              </a:spcBef>
+              <a:spcAft>
+                <a:spcPts val="0"/>
+              </a:spcAft>
+              <a:buNone/>
+              <a:defRPr sz="1500" b="0">
+                <a:solidFill>
+                  <a:srgbClr val="00E5FF"/>
+                </a:solidFill>
+                <a:latin typeface="Roboto Mono"/>
+                <a:ea typeface="Roboto Mono"/>
+                <a:cs typeface="Roboto Mono"/>
+              </a:defRPr>
             </a:pPr>
             <a:r>
               <a:rPr sz="1500" b="0" i="0">
@@ -27013,7 +27021,7 @@
                 <a:ea typeface="Roboto Mono"/>
                 <a:cs typeface="Roboto Mono"/>
               </a:rPr>
-              <a:t/>
+              <a:t>bash scripts/mac/run.sh</a:t>
             </a:r>
           </a:p>
           <a:p xmlns:a="http://schemas.openxmlformats.org/drawingml/2006/main">
@@ -27047,14 +27055,22 @@
             </a:r>
           </a:p>
           <a:p xmlns:a="http://schemas.openxmlformats.org/drawingml/2006/main">
-            <a:pPr marL="0" indent="0">
-              <a:spcBef>
-                <a:spcPts val="0"/>
-              </a:spcBef>
-              <a:spcAft>
-                <a:spcPts val="0"/>
-              </a:spcAft>
-              <a:buNone/>
+            <a:pPr marL="0" indent="0" algn="l">
+              <a:spcBef>
+                <a:spcPts val="0"/>
+              </a:spcBef>
+              <a:spcAft>
+                <a:spcPts val="0"/>
+              </a:spcAft>
+              <a:buNone/>
+              <a:defRPr sz="1500" b="0">
+                <a:solidFill>
+                  <a:srgbClr val="00E5FF"/>
+                </a:solidFill>
+                <a:latin typeface="Roboto Mono"/>
+                <a:ea typeface="Roboto Mono"/>
+                <a:cs typeface="Roboto Mono"/>
+              </a:defRPr>
             </a:pPr>
             <a:r>
               <a:rPr sz="1500" b="0" i="0">
@@ -27065,7 +27081,7 @@
                 <a:ea typeface="Roboto Mono"/>
                 <a:cs typeface="Roboto Mono"/>
               </a:rPr>
-              <a:t/>
+              <a:t>bash scripts/mac/run.sh</a:t>
             </a:r>
           </a:p>
           <a:p xmlns:a="http://schemas.openxmlformats.org/drawingml/2006/main">
@@ -27099,14 +27115,22 @@
             </a:r>
           </a:p>
           <a:p xmlns:a="http://schemas.openxmlformats.org/drawingml/2006/main">
-            <a:pPr marL="0" indent="0">
-              <a:spcBef>
-                <a:spcPts val="0"/>
-              </a:spcBef>
-              <a:spcAft>
-                <a:spcPts val="0"/>
-              </a:spcAft>
-              <a:buNone/>
+            <a:pPr marL="0" indent="0" algn="l">
+              <a:spcBef>
+                <a:spcPts val="0"/>
+              </a:spcBef>
+              <a:spcAft>
+                <a:spcPts val="0"/>
+              </a:spcAft>
+              <a:buNone/>
+              <a:defRPr sz="1500" b="0">
+                <a:solidFill>
+                  <a:srgbClr val="00E5FF"/>
+                </a:solidFill>
+                <a:latin typeface="Roboto Mono"/>
+                <a:ea typeface="Roboto Mono"/>
+                <a:cs typeface="Roboto Mono"/>
+              </a:defRPr>
             </a:pPr>
             <a:r>
               <a:rPr sz="1500" b="0" i="0">
@@ -27117,7 +27141,7 @@
                 <a:ea typeface="Roboto Mono"/>
                 <a:cs typeface="Roboto Mono"/>
               </a:rPr>
-              <a:t/>
+              <a:t>bash scripts/mac/run.sh</a:t>
             </a:r>
           </a:p>
           <a:p xmlns:a="http://schemas.openxmlformats.org/drawingml/2006/main">
@@ -27148,6 +27172,36 @@
                 <a:cs typeface="Roboto Mono"/>
               </a:rPr>
               <a:t>bash scripts/mac/step-4.sh</a:t>
+            </a:r>
+          </a:p>
+          <a:p xmlns:a="http://schemas.openxmlformats.org/drawingml/2006/main">
+            <a:pPr marL="0" indent="0" algn="l">
+              <a:spcBef>
+                <a:spcPts val="0"/>
+              </a:spcBef>
+              <a:spcAft>
+                <a:spcPts val="0"/>
+              </a:spcAft>
+              <a:buNone/>
+              <a:defRPr sz="1500" b="0">
+                <a:solidFill>
+                  <a:srgbClr val="00E5FF"/>
+                </a:solidFill>
+                <a:latin typeface="Roboto Mono"/>
+                <a:ea typeface="Roboto Mono"/>
+                <a:cs typeface="Roboto Mono"/>
+              </a:defRPr>
+            </a:pPr>
+            <a:r>
+              <a:rPr sz="1500" b="0" i="0">
+                <a:solidFill>
+                  <a:srgbClr val="00E5FF"/>
+                </a:solidFill>
+                <a:latin typeface="Roboto Mono"/>
+                <a:ea typeface="Roboto Mono"/>
+                <a:cs typeface="Roboto Mono"/>
+              </a:rPr>
+              <a:t>bash scripts/mac/run.sh</a:t>
             </a:r>
           </a:p>
         </p:txBody>
@@ -27797,7 +27851,7 @@
           <p:nvPr/>
         </p:nvPicPr>
         <p:blipFill rotWithShape="1">
-          <a:blip xmlns:r="http://schemas.openxmlformats.org/officeDocument/2006/relationships" xmlns:a="http://schemas.openxmlformats.org/drawingml/2006/main" r:embed="R04ecfb2ad1794182">
+          <a:blip xmlns:r="http://schemas.openxmlformats.org/officeDocument/2006/relationships" xmlns:a="http://schemas.openxmlformats.org/drawingml/2006/main" r:embed="R19b8944e211540a2">
             <a:alphaModFix/>
           </a:blip>
           <a:srcRect xmlns:a="http://schemas.openxmlformats.org/drawingml/2006/main" l="0" t="0" r="0" b="0"/>
@@ -27825,7 +27879,7 @@
           <p:nvPr/>
         </p:nvPicPr>
         <p:blipFill rotWithShape="1">
-          <a:blip xmlns:r="http://schemas.openxmlformats.org/officeDocument/2006/relationships" xmlns:a="http://schemas.openxmlformats.org/drawingml/2006/main" r:embed="R04ecfb2ad1794182">
+          <a:blip xmlns:r="http://schemas.openxmlformats.org/officeDocument/2006/relationships" xmlns:a="http://schemas.openxmlformats.org/drawingml/2006/main" r:embed="R19b8944e211540a2">
             <a:alphaModFix/>
           </a:blip>
           <a:srcRect xmlns:a="http://schemas.openxmlformats.org/drawingml/2006/main" l="0" t="0" r="0" b="0"/>
@@ -27853,7 +27907,7 @@
           <p:nvPr/>
         </p:nvPicPr>
         <p:blipFill rotWithShape="1">
-          <a:blip xmlns:r="http://schemas.openxmlformats.org/officeDocument/2006/relationships" xmlns:a="http://schemas.openxmlformats.org/drawingml/2006/main" r:embed="R04ecfb2ad1794182">
+          <a:blip xmlns:r="http://schemas.openxmlformats.org/officeDocument/2006/relationships" xmlns:a="http://schemas.openxmlformats.org/drawingml/2006/main" r:embed="R19b8944e211540a2">
             <a:alphaModFix/>
           </a:blip>
           <a:srcRect xmlns:a="http://schemas.openxmlformats.org/drawingml/2006/main" l="0" t="0" r="0" b="0"/>
@@ -27881,7 +27935,7 @@
           <p:nvPr/>
         </p:nvPicPr>
         <p:blipFill rotWithShape="1">
-          <a:blip xmlns:r="http://schemas.openxmlformats.org/officeDocument/2006/relationships" xmlns:a="http://schemas.openxmlformats.org/drawingml/2006/main" r:embed="R04ecfb2ad1794182">
+          <a:blip xmlns:r="http://schemas.openxmlformats.org/officeDocument/2006/relationships" xmlns:a="http://schemas.openxmlformats.org/drawingml/2006/main" r:embed="R19b8944e211540a2">
             <a:alphaModFix/>
           </a:blip>
           <a:srcRect xmlns:a="http://schemas.openxmlformats.org/drawingml/2006/main" l="0" t="0" r="0" b="0"/>
@@ -28375,7 +28429,7 @@
                 <a:ea typeface="Inter"/>
                 <a:cs typeface="Inter"/>
               </a:rPr>
-              <a:t>Terminal A: run each step when we reach it.</a:t>
+              <a:t>Terminal A: apply a step, then rebuild and capture.</a:t>
             </a:r>
           </a:p>
         </p:txBody>
@@ -28766,14 +28820,22 @@
             </a:r>
           </a:p>
           <a:p xmlns:a="http://schemas.openxmlformats.org/drawingml/2006/main">
-            <a:pPr marL="0" indent="0">
-              <a:spcBef>
-                <a:spcPts val="0"/>
-              </a:spcBef>
-              <a:spcAft>
-                <a:spcPts val="0"/>
-              </a:spcAft>
-              <a:buNone/>
+            <a:pPr marL="0" indent="0" algn="l">
+              <a:spcBef>
+                <a:spcPts val="0"/>
+              </a:spcBef>
+              <a:spcAft>
+                <a:spcPts val="0"/>
+              </a:spcAft>
+              <a:buNone/>
+              <a:defRPr sz="1500" b="0">
+                <a:solidFill>
+                  <a:srgbClr val="00E5FF"/>
+                </a:solidFill>
+                <a:latin typeface="Roboto Mono"/>
+                <a:ea typeface="Roboto Mono"/>
+                <a:cs typeface="Roboto Mono"/>
+              </a:defRPr>
             </a:pPr>
             <a:r>
               <a:rPr sz="1500" b="0" i="0">
@@ -28784,7 +28846,7 @@
                 <a:ea typeface="Roboto Mono"/>
                 <a:cs typeface="Roboto Mono"/>
               </a:rPr>
-              <a:t/>
+              <a:t>powershell -ExecutionPolicy Bypass -File scripts/windows/run.ps1</a:t>
             </a:r>
           </a:p>
           <a:p xmlns:a="http://schemas.openxmlformats.org/drawingml/2006/main">
@@ -28818,14 +28880,22 @@
             </a:r>
           </a:p>
           <a:p xmlns:a="http://schemas.openxmlformats.org/drawingml/2006/main">
-            <a:pPr marL="0" indent="0">
-              <a:spcBef>
-                <a:spcPts val="0"/>
-              </a:spcBef>
-              <a:spcAft>
-                <a:spcPts val="0"/>
-              </a:spcAft>
-              <a:buNone/>
+            <a:pPr marL="0" indent="0" algn="l">
+              <a:spcBef>
+                <a:spcPts val="0"/>
+              </a:spcBef>
+              <a:spcAft>
+                <a:spcPts val="0"/>
+              </a:spcAft>
+              <a:buNone/>
+              <a:defRPr sz="1500" b="0">
+                <a:solidFill>
+                  <a:srgbClr val="00E5FF"/>
+                </a:solidFill>
+                <a:latin typeface="Roboto Mono"/>
+                <a:ea typeface="Roboto Mono"/>
+                <a:cs typeface="Roboto Mono"/>
+              </a:defRPr>
             </a:pPr>
             <a:r>
               <a:rPr sz="1500" b="0" i="0">
@@ -28836,7 +28906,7 @@
                 <a:ea typeface="Roboto Mono"/>
                 <a:cs typeface="Roboto Mono"/>
               </a:rPr>
-              <a:t/>
+              <a:t>powershell -ExecutionPolicy Bypass -File scripts/windows/run.ps1</a:t>
             </a:r>
           </a:p>
           <a:p xmlns:a="http://schemas.openxmlformats.org/drawingml/2006/main">
@@ -28870,14 +28940,22 @@
             </a:r>
           </a:p>
           <a:p xmlns:a="http://schemas.openxmlformats.org/drawingml/2006/main">
-            <a:pPr marL="0" indent="0">
-              <a:spcBef>
-                <a:spcPts val="0"/>
-              </a:spcBef>
-              <a:spcAft>
-                <a:spcPts val="0"/>
-              </a:spcAft>
-              <a:buNone/>
+            <a:pPr marL="0" indent="0" algn="l">
+              <a:spcBef>
+                <a:spcPts val="0"/>
+              </a:spcBef>
+              <a:spcAft>
+                <a:spcPts val="0"/>
+              </a:spcAft>
+              <a:buNone/>
+              <a:defRPr sz="1500" b="0">
+                <a:solidFill>
+                  <a:srgbClr val="00E5FF"/>
+                </a:solidFill>
+                <a:latin typeface="Roboto Mono"/>
+                <a:ea typeface="Roboto Mono"/>
+                <a:cs typeface="Roboto Mono"/>
+              </a:defRPr>
             </a:pPr>
             <a:r>
               <a:rPr sz="1500" b="0" i="0">
@@ -28888,7 +28966,7 @@
                 <a:ea typeface="Roboto Mono"/>
                 <a:cs typeface="Roboto Mono"/>
               </a:rPr>
-              <a:t/>
+              <a:t>powershell -ExecutionPolicy Bypass -File scripts/windows/run.ps1</a:t>
             </a:r>
           </a:p>
           <a:p xmlns:a="http://schemas.openxmlformats.org/drawingml/2006/main">
@@ -28919,6 +28997,36 @@
                 <a:cs typeface="Roboto Mono"/>
               </a:rPr>
               <a:t>powershell -ExecutionPolicy Bypass -File scripts/windows/step-4.ps1</a:t>
+            </a:r>
+          </a:p>
+          <a:p xmlns:a="http://schemas.openxmlformats.org/drawingml/2006/main">
+            <a:pPr marL="0" indent="0" algn="l">
+              <a:spcBef>
+                <a:spcPts val="0"/>
+              </a:spcBef>
+              <a:spcAft>
+                <a:spcPts val="0"/>
+              </a:spcAft>
+              <a:buNone/>
+              <a:defRPr sz="1500" b="0">
+                <a:solidFill>
+                  <a:srgbClr val="00E5FF"/>
+                </a:solidFill>
+                <a:latin typeface="Roboto Mono"/>
+                <a:ea typeface="Roboto Mono"/>
+                <a:cs typeface="Roboto Mono"/>
+              </a:defRPr>
+            </a:pPr>
+            <a:r>
+              <a:rPr sz="1500" b="0" i="0">
+                <a:solidFill>
+                  <a:srgbClr val="00E5FF"/>
+                </a:solidFill>
+                <a:latin typeface="Roboto Mono"/>
+                <a:ea typeface="Roboto Mono"/>
+                <a:cs typeface="Roboto Mono"/>
+              </a:rPr>
+              <a:t>powershell -ExecutionPolicy Bypass -File scripts/windows/run.ps1</a:t>
             </a:r>
           </a:p>
         </p:txBody>
@@ -29568,7 +29676,7 @@
           <p:nvPr/>
         </p:nvPicPr>
         <p:blipFill rotWithShape="1">
-          <a:blip xmlns:r="http://schemas.openxmlformats.org/officeDocument/2006/relationships" xmlns:a="http://schemas.openxmlformats.org/drawingml/2006/main" r:embed="R0082e0bb41e24eca">
+          <a:blip xmlns:r="http://schemas.openxmlformats.org/officeDocument/2006/relationships" xmlns:a="http://schemas.openxmlformats.org/drawingml/2006/main" r:embed="R44d2cf2f5e1347a8">
             <a:alphaModFix/>
           </a:blip>
           <a:srcRect xmlns:a="http://schemas.openxmlformats.org/drawingml/2006/main" l="0" t="0" r="0" b="0"/>
@@ -29596,7 +29704,7 @@
           <p:nvPr/>
         </p:nvPicPr>
         <p:blipFill rotWithShape="1">
-          <a:blip xmlns:r="http://schemas.openxmlformats.org/officeDocument/2006/relationships" xmlns:a="http://schemas.openxmlformats.org/drawingml/2006/main" r:embed="R0082e0bb41e24eca">
+          <a:blip xmlns:r="http://schemas.openxmlformats.org/officeDocument/2006/relationships" xmlns:a="http://schemas.openxmlformats.org/drawingml/2006/main" r:embed="R44d2cf2f5e1347a8">
             <a:alphaModFix/>
           </a:blip>
           <a:srcRect xmlns:a="http://schemas.openxmlformats.org/drawingml/2006/main" l="0" t="0" r="0" b="0"/>
@@ -29624,7 +29732,7 @@
           <p:nvPr/>
         </p:nvPicPr>
         <p:blipFill rotWithShape="1">
-          <a:blip xmlns:r="http://schemas.openxmlformats.org/officeDocument/2006/relationships" xmlns:a="http://schemas.openxmlformats.org/drawingml/2006/main" r:embed="R0082e0bb41e24eca">
+          <a:blip xmlns:r="http://schemas.openxmlformats.org/officeDocument/2006/relationships" xmlns:a="http://schemas.openxmlformats.org/drawingml/2006/main" r:embed="R44d2cf2f5e1347a8">
             <a:alphaModFix/>
           </a:blip>
           <a:srcRect xmlns:a="http://schemas.openxmlformats.org/drawingml/2006/main" l="0" t="0" r="0" b="0"/>
@@ -29652,7 +29760,7 @@
           <p:nvPr/>
         </p:nvPicPr>
         <p:blipFill rotWithShape="1">
-          <a:blip xmlns:r="http://schemas.openxmlformats.org/officeDocument/2006/relationships" xmlns:a="http://schemas.openxmlformats.org/drawingml/2006/main" r:embed="R0082e0bb41e24eca">
+          <a:blip xmlns:r="http://schemas.openxmlformats.org/officeDocument/2006/relationships" xmlns:a="http://schemas.openxmlformats.org/drawingml/2006/main" r:embed="R44d2cf2f5e1347a8">
             <a:alphaModFix/>
           </a:blip>
           <a:srcRect xmlns:a="http://schemas.openxmlformats.org/drawingml/2006/main" l="0" t="0" r="0" b="0"/>
@@ -30250,7 +30358,7 @@
                 <a:ea typeface="Inter"/>
                 <a:cs typeface="Inter"/>
               </a:rPr>
-              <a:t>Run step 1 in terminal A.</a:t>
+              <a:t>Run step 1, then run in terminal A.</a:t>
             </a:r>
           </a:p>
           <a:p xmlns:a="http://schemas.openxmlformats.org/drawingml/2006/main">
@@ -30302,7 +30410,7 @@
                 <a:ea typeface="Inter"/>
                 <a:cs typeface="Inter"/>
               </a:rPr>
-              <a:t>It creates src/main.cpp and src/CMakeLists.txt on your laptop, then builds them in Ubuntu.</a:t>
+              <a:t>Step 1 creates src/main.cpp and src/CMakeLists.txt locally. The run script builds them in Ubuntu.</a:t>
             </a:r>
           </a:p>
           <a:p xmlns:a="http://schemas.openxmlformats.org/drawingml/2006/main">
@@ -30354,7 +30462,7 @@
                 <a:ea typeface="Inter"/>
                 <a:cs typeface="Inter"/>
               </a:rPr>
-              <a:t>The collector attaches and stops. It does not read events yet.</a:t>
+              <a:t>It attaches for ten seconds, then stops. It does not read events yet.</a:t>
             </a:r>
           </a:p>
         </p:txBody>
@@ -30974,6 +31082,66 @@
                 <a:cs typeface="Roboto Mono"/>
               </a:rPr>
               <a:t>std::cout &lt;&lt; "Attached." &lt;&lt; std::endl;</a:t>
+            </a:r>
+          </a:p>
+          <a:p xmlns:a="http://schemas.openxmlformats.org/drawingml/2006/main">
+            <a:pPr marL="0" indent="0" algn="l">
+              <a:spcBef>
+                <a:spcPts val="0"/>
+              </a:spcBef>
+              <a:spcAft>
+                <a:spcPts val="0"/>
+              </a:spcAft>
+              <a:buNone/>
+              <a:defRPr sz="1350" b="0">
+                <a:solidFill>
+                  <a:srgbClr val="00E5FF"/>
+                </a:solidFill>
+                <a:latin typeface="Roboto Mono"/>
+                <a:ea typeface="Roboto Mono"/>
+                <a:cs typeface="Roboto Mono"/>
+              </a:defRPr>
+            </a:pPr>
+            <a:r>
+              <a:rPr sz="1350" b="0" i="0">
+                <a:solidFill>
+                  <a:srgbClr val="00E5FF"/>
+                </a:solidFill>
+                <a:latin typeface="Roboto Mono"/>
+                <a:ea typeface="Roboto Mono"/>
+                <a:cs typeface="Roboto Mono"/>
+              </a:rPr>
+              <a:t>std::this_thread::sleep_for(</a:t>
+            </a:r>
+          </a:p>
+          <a:p xmlns:a="http://schemas.openxmlformats.org/drawingml/2006/main">
+            <a:pPr marL="0" indent="0" algn="l">
+              <a:spcBef>
+                <a:spcPts val="0"/>
+              </a:spcBef>
+              <a:spcAft>
+                <a:spcPts val="0"/>
+              </a:spcAft>
+              <a:buNone/>
+              <a:defRPr sz="1350" b="0">
+                <a:solidFill>
+                  <a:srgbClr val="00E5FF"/>
+                </a:solidFill>
+                <a:latin typeface="Roboto Mono"/>
+                <a:ea typeface="Roboto Mono"/>
+                <a:cs typeface="Roboto Mono"/>
+              </a:defRPr>
+            </a:pPr>
+            <a:r>
+              <a:rPr sz="1350" b="0" i="0">
+                <a:solidFill>
+                  <a:srgbClr val="00E5FF"/>
+                </a:solidFill>
+                <a:latin typeface="Roboto Mono"/>
+                <a:ea typeface="Roboto Mono"/>
+                <a:cs typeface="Roboto Mono"/>
+              </a:rPr>
+              <a:t>    std::chrono::seconds(10));</a:t>
             </a:r>
           </a:p>
           <a:p xmlns:a="http://schemas.openxmlformats.org/drawingml/2006/main">
@@ -31683,7 +31851,7 @@
           <p:nvPr/>
         </p:nvPicPr>
         <p:blipFill rotWithShape="1">
-          <a:blip xmlns:r="http://schemas.openxmlformats.org/officeDocument/2006/relationships" xmlns:a="http://schemas.openxmlformats.org/drawingml/2006/main" r:embed="R2c5b7ed6c7894b05">
+          <a:blip xmlns:r="http://schemas.openxmlformats.org/officeDocument/2006/relationships" xmlns:a="http://schemas.openxmlformats.org/drawingml/2006/main" r:embed="Ra0bb4fee1d494946">
             <a:alphaModFix/>
           </a:blip>
           <a:srcRect xmlns:a="http://schemas.openxmlformats.org/drawingml/2006/main" l="0" t="0" r="0" b="0"/>
@@ -31711,7 +31879,7 @@
           <p:nvPr/>
         </p:nvPicPr>
         <p:blipFill rotWithShape="1">
-          <a:blip xmlns:r="http://schemas.openxmlformats.org/officeDocument/2006/relationships" xmlns:a="http://schemas.openxmlformats.org/drawingml/2006/main" r:embed="R2c5b7ed6c7894b05">
+          <a:blip xmlns:r="http://schemas.openxmlformats.org/officeDocument/2006/relationships" xmlns:a="http://schemas.openxmlformats.org/drawingml/2006/main" r:embed="Ra0bb4fee1d494946">
             <a:alphaModFix/>
           </a:blip>
           <a:srcRect xmlns:a="http://schemas.openxmlformats.org/drawingml/2006/main" l="0" t="0" r="0" b="0"/>
@@ -31739,7 +31907,7 @@
           <p:nvPr/>
         </p:nvPicPr>
         <p:blipFill rotWithShape="1">
-          <a:blip xmlns:r="http://schemas.openxmlformats.org/officeDocument/2006/relationships" xmlns:a="http://schemas.openxmlformats.org/drawingml/2006/main" r:embed="R2c5b7ed6c7894b05">
+          <a:blip xmlns:r="http://schemas.openxmlformats.org/officeDocument/2006/relationships" xmlns:a="http://schemas.openxmlformats.org/drawingml/2006/main" r:embed="Ra0bb4fee1d494946">
             <a:alphaModFix/>
           </a:blip>
           <a:srcRect xmlns:a="http://schemas.openxmlformats.org/drawingml/2006/main" l="0" t="0" r="0" b="0"/>
@@ -31767,7 +31935,7 @@
           <p:nvPr/>
         </p:nvPicPr>
         <p:blipFill rotWithShape="1">
-          <a:blip xmlns:r="http://schemas.openxmlformats.org/officeDocument/2006/relationships" xmlns:a="http://schemas.openxmlformats.org/drawingml/2006/main" r:embed="R2c5b7ed6c7894b05">
+          <a:blip xmlns:r="http://schemas.openxmlformats.org/officeDocument/2006/relationships" xmlns:a="http://schemas.openxmlformats.org/drawingml/2006/main" r:embed="Ra0bb4fee1d494946">
             <a:alphaModFix/>
           </a:blip>
           <a:srcRect xmlns:a="http://schemas.openxmlformats.org/drawingml/2006/main" l="0" t="0" r="0" b="0"/>
@@ -32365,7 +32533,7 @@
                 <a:ea typeface="Inter"/>
                 <a:cs typeface="Inter"/>
               </a:rPr>
-              <a:t>Run step 2 in terminal A.</a:t>
+              <a:t>Run step 2, then run in terminal A.</a:t>
             </a:r>
           </a:p>
           <a:p xmlns:a="http://schemas.openxmlformats.org/drawingml/2006/main">
@@ -32417,7 +32585,7 @@
                 <a:ea typeface="Inter"/>
                 <a:cs typeface="Inter"/>
               </a:rPr>
-              <a:t>It adds the read loop and starts a ten-second capture.</a:t>
+              <a:t>Step 2 adds the read loop. Run starts a ten-second capture.</a:t>
             </a:r>
           </a:p>
           <a:p xmlns:a="http://schemas.openxmlformats.org/drawingml/2006/main">
@@ -33746,7 +33914,7 @@
           <p:nvPr/>
         </p:nvPicPr>
         <p:blipFill rotWithShape="1">
-          <a:blip xmlns:r="http://schemas.openxmlformats.org/officeDocument/2006/relationships" xmlns:a="http://schemas.openxmlformats.org/drawingml/2006/main" r:embed="Rfaaa9e74fc7c4b7d">
+          <a:blip xmlns:r="http://schemas.openxmlformats.org/officeDocument/2006/relationships" xmlns:a="http://schemas.openxmlformats.org/drawingml/2006/main" r:embed="R169be8fad3ba439f">
             <a:alphaModFix/>
           </a:blip>
           <a:srcRect xmlns:a="http://schemas.openxmlformats.org/drawingml/2006/main" l="0" t="0" r="0" b="0"/>
@@ -33774,7 +33942,7 @@
           <p:nvPr/>
         </p:nvPicPr>
         <p:blipFill rotWithShape="1">
-          <a:blip xmlns:r="http://schemas.openxmlformats.org/officeDocument/2006/relationships" xmlns:a="http://schemas.openxmlformats.org/drawingml/2006/main" r:embed="Rfaaa9e74fc7c4b7d">
+          <a:blip xmlns:r="http://schemas.openxmlformats.org/officeDocument/2006/relationships" xmlns:a="http://schemas.openxmlformats.org/drawingml/2006/main" r:embed="R169be8fad3ba439f">
             <a:alphaModFix/>
           </a:blip>
           <a:srcRect xmlns:a="http://schemas.openxmlformats.org/drawingml/2006/main" l="0" t="0" r="0" b="0"/>
@@ -33802,7 +33970,7 @@
           <p:nvPr/>
         </p:nvPicPr>
         <p:blipFill rotWithShape="1">
-          <a:blip xmlns:r="http://schemas.openxmlformats.org/officeDocument/2006/relationships" xmlns:a="http://schemas.openxmlformats.org/drawingml/2006/main" r:embed="Rfaaa9e74fc7c4b7d">
+          <a:blip xmlns:r="http://schemas.openxmlformats.org/officeDocument/2006/relationships" xmlns:a="http://schemas.openxmlformats.org/drawingml/2006/main" r:embed="R169be8fad3ba439f">
             <a:alphaModFix/>
           </a:blip>
           <a:srcRect xmlns:a="http://schemas.openxmlformats.org/drawingml/2006/main" l="0" t="0" r="0" b="0"/>
@@ -33830,7 +33998,7 @@
           <p:nvPr/>
         </p:nvPicPr>
         <p:blipFill rotWithShape="1">
-          <a:blip xmlns:r="http://schemas.openxmlformats.org/officeDocument/2006/relationships" xmlns:a="http://schemas.openxmlformats.org/drawingml/2006/main" r:embed="Rfaaa9e74fc7c4b7d">
+          <a:blip xmlns:r="http://schemas.openxmlformats.org/officeDocument/2006/relationships" xmlns:a="http://schemas.openxmlformats.org/drawingml/2006/main" r:embed="R169be8fad3ba439f">
             <a:alphaModFix/>
           </a:blip>
           <a:srcRect xmlns:a="http://schemas.openxmlformats.org/drawingml/2006/main" l="0" t="0" r="0" b="0"/>

</xml_diff>

<commit_message>
Simplify slides to one terminal and explain each capture stage
</commit_message>
<xml_diff>
--- a/presentation/falco-libs-intro.pptx
+++ b/presentation/falco-libs-intro.pptx
@@ -2,78 +2,78 @@
 <file path=ppt/presentation.xml><?xml version="1.0" encoding="utf-8"?>
 <p:presentation xmlns:p="http://schemas.openxmlformats.org/presentationml/2006/main" embedTrueTypeFonts="1" saveSubsetFonts="0">
   <p:sldMasterIdLst>
-    <p:sldMasterId xmlns:r="http://schemas.openxmlformats.org/officeDocument/2006/relationships" id="2147483648" r:id="Rcb4602f825e845d7"/>
-    <p:sldMasterId xmlns:r="http://schemas.openxmlformats.org/officeDocument/2006/relationships" id="2147483661" r:id="R32e88365e0674a66"/>
+    <p:sldMasterId xmlns:r="http://schemas.openxmlformats.org/officeDocument/2006/relationships" id="2147483648" r:id="Rd85cd16d91f14c55"/>
+    <p:sldMasterId xmlns:r="http://schemas.openxmlformats.org/officeDocument/2006/relationships" id="2147483661" r:id="R0d11a653496d47d3"/>
   </p:sldMasterIdLst>
   <p:notesMasterIdLst>
-    <p:notesMasterId xmlns:r="http://schemas.openxmlformats.org/officeDocument/2006/relationships" r:id="R86acd9d6e8dc49a7"/>
+    <p:notesMasterId xmlns:r="http://schemas.openxmlformats.org/officeDocument/2006/relationships" r:id="R4b8a3ccd23344cf8"/>
   </p:notesMasterIdLst>
   <p:sldIdLst>
-    <p:sldId xmlns:r="http://schemas.openxmlformats.org/officeDocument/2006/relationships" id="256" r:id="R280a5c9b54f348ec"/>
-    <p:sldId xmlns:r="http://schemas.openxmlformats.org/officeDocument/2006/relationships" id="257" r:id="Rf913a9382d0e4fa7"/>
-    <p:sldId xmlns:r="http://schemas.openxmlformats.org/officeDocument/2006/relationships" id="258" r:id="R509bb99a68074d1f"/>
-    <p:sldId xmlns:r="http://schemas.openxmlformats.org/officeDocument/2006/relationships" id="259" r:id="R4c48cea4fb63438f"/>
-    <p:sldId xmlns:r="http://schemas.openxmlformats.org/officeDocument/2006/relationships" id="260" r:id="Rd6834c89ab034bd0"/>
-    <p:sldId xmlns:r="http://schemas.openxmlformats.org/officeDocument/2006/relationships" id="261" r:id="R0053cc89718a4d69"/>
-    <p:sldId xmlns:r="http://schemas.openxmlformats.org/officeDocument/2006/relationships" id="262" r:id="R8e668eada55f479f"/>
-    <p:sldId xmlns:r="http://schemas.openxmlformats.org/officeDocument/2006/relationships" id="263" r:id="R4b7661e06a6c40ec"/>
-    <p:sldId xmlns:r="http://schemas.openxmlformats.org/officeDocument/2006/relationships" id="264" r:id="Rbad44ea6cd6240b9"/>
-    <p:sldId xmlns:r="http://schemas.openxmlformats.org/officeDocument/2006/relationships" id="265" r:id="R721345be95cd426c"/>
-    <p:sldId xmlns:r="http://schemas.openxmlformats.org/officeDocument/2006/relationships" id="266" r:id="R8e6639bc7a594c79"/>
-    <p:sldId xmlns:r="http://schemas.openxmlformats.org/officeDocument/2006/relationships" id="267" r:id="R704a881438914800"/>
-    <p:sldId xmlns:r="http://schemas.openxmlformats.org/officeDocument/2006/relationships" id="268" r:id="Rc08b5a94eec945fa"/>
-    <p:sldId xmlns:r="http://schemas.openxmlformats.org/officeDocument/2006/relationships" id="269" r:id="Ra7408d412db74b15"/>
+    <p:sldId xmlns:r="http://schemas.openxmlformats.org/officeDocument/2006/relationships" id="256" r:id="Rb0b47d9ef90e4170"/>
+    <p:sldId xmlns:r="http://schemas.openxmlformats.org/officeDocument/2006/relationships" id="257" r:id="R1be6fe2d45fb427e"/>
+    <p:sldId xmlns:r="http://schemas.openxmlformats.org/officeDocument/2006/relationships" id="258" r:id="R59880a81ab3444f8"/>
+    <p:sldId xmlns:r="http://schemas.openxmlformats.org/officeDocument/2006/relationships" id="259" r:id="Rfe07b76f99034a1f"/>
+    <p:sldId xmlns:r="http://schemas.openxmlformats.org/officeDocument/2006/relationships" id="260" r:id="Rff2de941d79847ea"/>
+    <p:sldId xmlns:r="http://schemas.openxmlformats.org/officeDocument/2006/relationships" id="261" r:id="Reab64a419eee4339"/>
+    <p:sldId xmlns:r="http://schemas.openxmlformats.org/officeDocument/2006/relationships" id="262" r:id="R1e2064110b3c40bc"/>
+    <p:sldId xmlns:r="http://schemas.openxmlformats.org/officeDocument/2006/relationships" id="263" r:id="Rb922d8afbd9848bc"/>
+    <p:sldId xmlns:r="http://schemas.openxmlformats.org/officeDocument/2006/relationships" id="264" r:id="Ref54e281e5d74b71"/>
+    <p:sldId xmlns:r="http://schemas.openxmlformats.org/officeDocument/2006/relationships" id="265" r:id="R4a1f63489d7240ff"/>
+    <p:sldId xmlns:r="http://schemas.openxmlformats.org/officeDocument/2006/relationships" id="266" r:id="Rd6da56e5d90840b4"/>
+    <p:sldId xmlns:r="http://schemas.openxmlformats.org/officeDocument/2006/relationships" id="267" r:id="R010f647577bd4174"/>
+    <p:sldId xmlns:r="http://schemas.openxmlformats.org/officeDocument/2006/relationships" id="268" r:id="R1dc9809c155e4951"/>
+    <p:sldId xmlns:r="http://schemas.openxmlformats.org/officeDocument/2006/relationships" id="269" r:id="R07c86e6f4b9a4e90"/>
   </p:sldIdLst>
   <p:sldSz cx="9144000" cy="5143500"/>
   <p:notesSz cx="6858000" cy="9144000"/>
   <p:embeddedFontLst>
     <p:embeddedFont>
       <p:font typeface="Roboto Mono Medium"/>
-      <p:regular xmlns:r="http://schemas.openxmlformats.org/officeDocument/2006/relationships" r:id="R17c04bb3d1f449b3"/>
-      <p:bold xmlns:r="http://schemas.openxmlformats.org/officeDocument/2006/relationships" r:id="R2cd957607d7c4172"/>
-      <p:italic xmlns:r="http://schemas.openxmlformats.org/officeDocument/2006/relationships" r:id="R9691da502e384301"/>
-      <p:boldItalic xmlns:r="http://schemas.openxmlformats.org/officeDocument/2006/relationships" r:id="R5bb70e7eaf1b4afa"/>
+      <p:regular xmlns:r="http://schemas.openxmlformats.org/officeDocument/2006/relationships" r:id="Re09040c686f042f1"/>
+      <p:bold xmlns:r="http://schemas.openxmlformats.org/officeDocument/2006/relationships" r:id="R0960b0c89f4340e8"/>
+      <p:italic xmlns:r="http://schemas.openxmlformats.org/officeDocument/2006/relationships" r:id="Rf27f2a5031f54034"/>
+      <p:boldItalic xmlns:r="http://schemas.openxmlformats.org/officeDocument/2006/relationships" r:id="R3ece3d2a58974aec"/>
     </p:embeddedFont>
     <p:embeddedFont>
       <p:font typeface="Inter SemiBold"/>
-      <p:regular xmlns:r="http://schemas.openxmlformats.org/officeDocument/2006/relationships" r:id="R4dc8e88ae4564ce2"/>
-      <p:bold xmlns:r="http://schemas.openxmlformats.org/officeDocument/2006/relationships" r:id="Rf0fd0272c3904f9b"/>
-      <p:italic xmlns:r="http://schemas.openxmlformats.org/officeDocument/2006/relationships" r:id="R935a9e04cd04458d"/>
-      <p:boldItalic xmlns:r="http://schemas.openxmlformats.org/officeDocument/2006/relationships" r:id="R3a8231fc19f04964"/>
+      <p:regular xmlns:r="http://schemas.openxmlformats.org/officeDocument/2006/relationships" r:id="R4c9f8d2352344e67"/>
+      <p:bold xmlns:r="http://schemas.openxmlformats.org/officeDocument/2006/relationships" r:id="R68b6dc238ced4dcb"/>
+      <p:italic xmlns:r="http://schemas.openxmlformats.org/officeDocument/2006/relationships" r:id="R011034475262435a"/>
+      <p:boldItalic xmlns:r="http://schemas.openxmlformats.org/officeDocument/2006/relationships" r:id="R0e6c2be2ee204c72"/>
     </p:embeddedFont>
     <p:embeddedFont>
       <p:font typeface="Montserrat Black"/>
-      <p:bold xmlns:r="http://schemas.openxmlformats.org/officeDocument/2006/relationships" r:id="R7622d28712ce4dd8"/>
-      <p:boldItalic xmlns:r="http://schemas.openxmlformats.org/officeDocument/2006/relationships" r:id="R803cc275e6e244b0"/>
+      <p:bold xmlns:r="http://schemas.openxmlformats.org/officeDocument/2006/relationships" r:id="Rd3b426f8e1c847e7"/>
+      <p:boldItalic xmlns:r="http://schemas.openxmlformats.org/officeDocument/2006/relationships" r:id="R369dcff0a2ae4a76"/>
     </p:embeddedFont>
     <p:embeddedFont>
       <p:font typeface="Montserrat"/>
-      <p:bold xmlns:r="http://schemas.openxmlformats.org/officeDocument/2006/relationships" r:id="R290f2f9c3ff6494b"/>
-      <p:boldItalic xmlns:r="http://schemas.openxmlformats.org/officeDocument/2006/relationships" r:id="R26815565b6424906"/>
+      <p:bold xmlns:r="http://schemas.openxmlformats.org/officeDocument/2006/relationships" r:id="Re8b8f48dcea64ee4"/>
+      <p:boldItalic xmlns:r="http://schemas.openxmlformats.org/officeDocument/2006/relationships" r:id="Re698ef650f5045eb"/>
     </p:embeddedFont>
     <p:embeddedFont>
       <p:font typeface="Inter"/>
-      <p:regular xmlns:r="http://schemas.openxmlformats.org/officeDocument/2006/relationships" r:id="R551ba18fd7984269"/>
-      <p:bold xmlns:r="http://schemas.openxmlformats.org/officeDocument/2006/relationships" r:id="Reaca3a9057044923"/>
-      <p:italic xmlns:r="http://schemas.openxmlformats.org/officeDocument/2006/relationships" r:id="Rf7c391b0fe55452a"/>
-      <p:boldItalic xmlns:r="http://schemas.openxmlformats.org/officeDocument/2006/relationships" r:id="Rd2773a98fd454ca7"/>
+      <p:regular xmlns:r="http://schemas.openxmlformats.org/officeDocument/2006/relationships" r:id="Rb6ae8508a10444d8"/>
+      <p:bold xmlns:r="http://schemas.openxmlformats.org/officeDocument/2006/relationships" r:id="R9c5110cc03f24d53"/>
+      <p:italic xmlns:r="http://schemas.openxmlformats.org/officeDocument/2006/relationships" r:id="Re7c7a11c2268481e"/>
+      <p:boldItalic xmlns:r="http://schemas.openxmlformats.org/officeDocument/2006/relationships" r:id="Rfa7a3b0fd0a74084"/>
     </p:embeddedFont>
     <p:embeddedFont>
       <p:font typeface="Montserrat ExtraBold"/>
-      <p:bold xmlns:r="http://schemas.openxmlformats.org/officeDocument/2006/relationships" r:id="Rd1e6634c87d544d7"/>
-      <p:boldItalic xmlns:r="http://schemas.openxmlformats.org/officeDocument/2006/relationships" r:id="Rcc036fb17d8f4b65"/>
+      <p:bold xmlns:r="http://schemas.openxmlformats.org/officeDocument/2006/relationships" r:id="R8cad0c3452014342"/>
+      <p:boldItalic xmlns:r="http://schemas.openxmlformats.org/officeDocument/2006/relationships" r:id="Rdbf1b5a140bd41d9"/>
     </p:embeddedFont>
     <p:embeddedFont>
       <p:font typeface="Roboto Mono"/>
-      <p:bold xmlns:r="http://schemas.openxmlformats.org/officeDocument/2006/relationships" r:id="Rcc5607f31a8347ea"/>
-      <p:boldItalic xmlns:r="http://schemas.openxmlformats.org/officeDocument/2006/relationships" r:id="Rfd9713cb60dd4998"/>
+      <p:bold xmlns:r="http://schemas.openxmlformats.org/officeDocument/2006/relationships" r:id="R687e21569cbe4b1f"/>
+      <p:boldItalic xmlns:r="http://schemas.openxmlformats.org/officeDocument/2006/relationships" r:id="R3fb55581869245fd"/>
     </p:embeddedFont>
     <p:embeddedFont>
       <p:font typeface="Inter Medium"/>
-      <p:regular xmlns:r="http://schemas.openxmlformats.org/officeDocument/2006/relationships" r:id="R92f6fab7a95b4c18"/>
-      <p:bold xmlns:r="http://schemas.openxmlformats.org/officeDocument/2006/relationships" r:id="R7b37d296c38b4838"/>
-      <p:italic xmlns:r="http://schemas.openxmlformats.org/officeDocument/2006/relationships" r:id="Rb619c17261b94e47"/>
-      <p:boldItalic xmlns:r="http://schemas.openxmlformats.org/officeDocument/2006/relationships" r:id="R8b308fce00bf4e96"/>
+      <p:regular xmlns:r="http://schemas.openxmlformats.org/officeDocument/2006/relationships" r:id="Rce996f5bfad94027"/>
+      <p:bold xmlns:r="http://schemas.openxmlformats.org/officeDocument/2006/relationships" r:id="R62d1214259a44dd1"/>
+      <p:italic xmlns:r="http://schemas.openxmlformats.org/officeDocument/2006/relationships" r:id="R98ef55768df9498f"/>
+      <p:boldItalic xmlns:r="http://schemas.openxmlformats.org/officeDocument/2006/relationships" r:id="R29f00211f75e4240"/>
     </p:embeddedFont>
   </p:embeddedFontLst>
 </p:presentation>
@@ -618,7 +618,7 @@
               <a:buNone/>
             </a:pPr>
             <a:r>
-              <a:t>This continues the code installed by step 2. The count is events delivered successfully to this application, not a count of all syscalls on the machine. This first unfiltered run sees background activity. Run /usr/bin/id in terminal B if desired. SCAP_EOF is included for correct status handling; a live stream normally ends because the ten-second deadline expires. Source: https://github.com/falcosecurity/libs/blob/e72873882967cdd86b8753eca09ea3e9f91ccd4a/userspace/libsinsp/sinsp.h</a:t>
+              <a:t>This continues the code installed by step 2. The count is events delivered successfully to this application, not a count of all syscalls on the machine. This first unfiltered run sees background activity. The runner automatically executes /usr/bin/id after attachment. The generated agent also explains that individual events are not printed yet. This slide abbreviates the summary string to fit. SCAP_EOF is included for correct status handling; a live stream normally ends because the ten-second deadline expires. Source: https://github.com/falcosecurity/libs/blob/e72873882967cdd86b8753eca09ea3e9f91ccd4a/userspace/libsinsp/sinsp.h</a:t>
             </a:r>
             <a:endParaRPr/>
           </a:p>
@@ -938,7 +938,7 @@
               <a:buNone/>
             </a:pPr>
             <a:r>
-              <a:t>Troubleshooting: run the collector with sudo inside Ubuntu. Setup prepares the libraries. The numbered scripts create the collector source. Run builds and starts it. Before source exists, run prints No agent yet. Run step 1. If Multipass commands are missing immediately after installation, reopen the host terminal. Setup waits for the Ubuntu image catalog before launch. Windows setup has not been rehearsed here. Code and step scripts: https://github.com/julianshalaby-perj/falco-libs-workshop</a:t>
+              <a:t>The run script handles sudo inside Ubuntu automatically. Setup prepares the libraries. The numbered scripts create the collector source. Run builds and starts it. Before source exists, run prints No agent yet. Run step 1. If Multipass commands are missing immediately after installation, reopen the host terminal. Setup waits for the Ubuntu image catalog before launch. Windows PowerShell parsing and source generation have passed native checks. The full Windows Multipass workflow still needs a rehearsal. Code and step scripts: https://github.com/julianshalaby-perj/falco-libs-workshop</a:t>
             </a:r>
             <a:endParaRPr/>
           </a:p>
@@ -1098,7 +1098,7 @@
               <a:buNone/>
             </a:pPr>
             <a:r>
-              <a:t>Optional Mac setup. Run only your platform’s setup script. It offers to install Multipass, creates Ubuntu 24.04, installs dependencies, and builds the Falco libraries. It creates no collector source files. Step 1 creates them. Approve the installer administrator prompt. After setup, keep terminal A on the host to run the platform step scripts. Open terminal B inside Ubuntu. Complete the first build before the workshop if possible. Sources: https://github.com/canonical/multipass/releases/tag/v1.16.4 and https://github.com/julianshalaby-perj/falco-libs-workshop</a:t>
+              <a:t>Optional Mac setup. Run only your platform’s setup script. It offers to install Multipass, creates Ubuntu 24.04, installs dependencies, and builds the Falco libraries. It creates no collector source files. Step 1 creates them. Approve the installer administrator prompt. After setup, stay in the same host terminal for all commands. The runner generates activity inside Ubuntu automatically. Complete the first build before the workshop if possible. Sources: https://github.com/canonical/multipass/releases/tag/v1.16.4 and https://github.com/julianshalaby-perj/falco-libs-workshop</a:t>
             </a:r>
             <a:endParaRPr/>
           </a:p>
@@ -1178,7 +1178,7 @@
               <a:buNone/>
             </a:pPr>
             <a:r>
-              <a:t>Optional Windows setup. Run only your platform’s setup script. It offers to install Multipass, creates Ubuntu 24.04, installs dependencies, and builds the Falco libraries. It creates no collector source files. Step 1 creates them. Approve the installer administrator prompt. If Windows requests a restart, reboot and rerun the command. After setup, keep terminal A on the host to run the platform step scripts. Open terminal B inside Ubuntu. Complete the first build before the workshop if possible. Sources: https://github.com/canonical/multipass/releases/tag/v1.16.4 and https://github.com/julianshalaby-perj/falco-libs-workshop</a:t>
+              <a:t>Optional Windows setup. Run only your platform’s setup script. It offers to install Multipass, creates Ubuntu 24.04, installs dependencies, and builds the Falco libraries. It creates no collector source files. Step 1 creates them. Approve the installer administrator prompt. If Windows requests a restart, reboot and rerun the command. After setup, stay in the same host terminal for all commands. The runner generates activity inside Ubuntu automatically. Complete the first build before the workshop if possible. Sources: https://github.com/canonical/multipass/releases/tag/v1.16.4 and https://github.com/julianshalaby-perj/falco-libs-workshop</a:t>
             </a:r>
             <a:endParaRPr/>
           </a:p>
@@ -1258,7 +1258,7 @@
               <a:buNone/>
             </a:pPr>
             <a:r>
-              <a:t>Terminal A stays on the host. Each step script creates source files locally. The run script copies the current files into the VM, rebuilds, and runs the agent for ten seconds. Output is displayed live and saved to logs/latest.log on the laptop. Each run replaces the previous log. The agent stops; the VM remains available. Terminal B stays inside Ubuntu. All monitoring happens inside the VM.</a:t>
+              <a:t>No VM shell or second terminal is needed. Run starts or reuses the VM, copies source, rebuilds, and starts the collector. After the collector reports attachment, the runner executes /usr/bin/id inside Ubuntu automatically. It waits for capture to finish, then prints and saves the output. Successful build output is hidden; build failures are displayed. The VM stays available for the next run.</a:t>
             </a:r>
             <a:endParaRPr/>
           </a:p>
@@ -1338,7 +1338,7 @@
               <a:buNone/>
             </a:pPr>
             <a:r>
-              <a:t>Run from the Mac repo folder in terminal A, one step at a time. Each step script writes src/main.cpp and src/CMakeLists.txt locally. Run copies them to Ubuntu, rebuilds, starts a fresh ten-second agent run, displays output, and saves logs/latest.log locally. The agent stops and the VM remains running. Comment blocks mark additions. Step scripts replace local edits. Run copies those current files into the VM. Steps include all earlier changes and can be rerun or skipped. During steps 2 through 4, run /usr/bin/id in VM terminal B after Attached appears in A.</a:t>
+              <a:t>Run from the Mac repo folder in the same host terminal, one step at a time. Each step script writes src/main.cpp and src/CMakeLists.txt locally. Run copies them to Ubuntu, rebuilds, starts a fresh ten-second agent run, generates example activity, then displays output and saves logs/latest.log locally. The agent stops and the VM remains running. Comment blocks mark additions. Step scripts replace local edits. Run copies those current files into the VM. Steps include all earlier changes and can be rerun or skipped. Run executes /usr/bin/id inside Ubuntu automatically after attachment. No second terminal or VM shell is needed.</a:t>
             </a:r>
             <a:endParaRPr/>
           </a:p>
@@ -1418,7 +1418,7 @@
               <a:buNone/>
             </a:pPr>
             <a:r>
-              <a:t>Run from the Windows repo folder in terminal A, one step at a time. Each step script writes src/main.cpp and src/CMakeLists.txt locally. Run copies them to Ubuntu, rebuilds, starts a fresh ten-second agent run, displays output, and saves logs/latest.log locally. The agent stops and the VM remains running. Comment blocks mark additions. Step scripts replace local edits. Run copies those current files into the VM. Steps include all earlier changes and can be rerun or skipped. During steps 2 through 4, run /usr/bin/id in VM terminal B after Attached appears in A.</a:t>
+              <a:t>Run from the Windows repo folder in the same host terminal, one step at a time. Each step script writes src/main.cpp and src/CMakeLists.txt locally. Run copies them to Ubuntu, rebuilds, starts a fresh ten-second agent run, generates example activity, then displays output and saves logs/latest.log locally. The agent stops and the VM remains running. Comment blocks mark additions. Step scripts replace local edits. Run copies those current files into the VM. Steps include all earlier changes and can be rerun or skipped. Run executes /usr/bin/id inside Ubuntu automatically after attachment. No second terminal or VM shell is needed.</a:t>
             </a:r>
             <a:endParaRPr/>
           </a:p>
@@ -5746,18 +5746,18 @@
   </p:cSld>
   <p:clrMap bg1="lt1" tx1="dk1" bg2="dk2" tx2="lt2" accent1="accent1" accent2="accent2" accent3="accent3" accent4="accent4" accent5="accent5" accent6="accent6" hlink="hlink" folHlink="folHlink"/>
   <p:sldLayoutIdLst>
-    <p:sldLayoutId xmlns:r="http://schemas.openxmlformats.org/officeDocument/2006/relationships" id="2147483649" r:id="R98d02b6524f1450c"/>
-    <p:sldLayoutId xmlns:r="http://schemas.openxmlformats.org/officeDocument/2006/relationships" id="2147483650" r:id="R9f1182c37b874c1f"/>
-    <p:sldLayoutId xmlns:r="http://schemas.openxmlformats.org/officeDocument/2006/relationships" id="2147483651" r:id="R17a2593d46ee4e2e"/>
-    <p:sldLayoutId xmlns:r="http://schemas.openxmlformats.org/officeDocument/2006/relationships" id="2147483652" r:id="R66a1843d551248fd"/>
-    <p:sldLayoutId xmlns:r="http://schemas.openxmlformats.org/officeDocument/2006/relationships" id="2147483653" r:id="R1b67c90ccaf84156"/>
-    <p:sldLayoutId xmlns:r="http://schemas.openxmlformats.org/officeDocument/2006/relationships" id="2147483654" r:id="Rd263b31a3a144f51"/>
-    <p:sldLayoutId xmlns:r="http://schemas.openxmlformats.org/officeDocument/2006/relationships" id="2147483655" r:id="Rc4e0bc754cba48d1"/>
-    <p:sldLayoutId xmlns:r="http://schemas.openxmlformats.org/officeDocument/2006/relationships" id="2147483656" r:id="Rfa49b878cdaa44ce"/>
-    <p:sldLayoutId xmlns:r="http://schemas.openxmlformats.org/officeDocument/2006/relationships" id="2147483657" r:id="Rdbad6586d90d47c9"/>
-    <p:sldLayoutId xmlns:r="http://schemas.openxmlformats.org/officeDocument/2006/relationships" id="2147483658" r:id="R773af3cbb1594ea3"/>
-    <p:sldLayoutId xmlns:r="http://schemas.openxmlformats.org/officeDocument/2006/relationships" id="2147483659" r:id="R033593e79f544c9d"/>
-    <p:sldLayoutId xmlns:r="http://schemas.openxmlformats.org/officeDocument/2006/relationships" id="2147483660" r:id="Rc757a4d90c894650"/>
+    <p:sldLayoutId xmlns:r="http://schemas.openxmlformats.org/officeDocument/2006/relationships" id="2147483649" r:id="Ra616ffce37244e1b"/>
+    <p:sldLayoutId xmlns:r="http://schemas.openxmlformats.org/officeDocument/2006/relationships" id="2147483650" r:id="R2a514a03a9824031"/>
+    <p:sldLayoutId xmlns:r="http://schemas.openxmlformats.org/officeDocument/2006/relationships" id="2147483651" r:id="Ra7db9a43b147454d"/>
+    <p:sldLayoutId xmlns:r="http://schemas.openxmlformats.org/officeDocument/2006/relationships" id="2147483652" r:id="R8ddcb0953c874eef"/>
+    <p:sldLayoutId xmlns:r="http://schemas.openxmlformats.org/officeDocument/2006/relationships" id="2147483653" r:id="R383f74551a804eab"/>
+    <p:sldLayoutId xmlns:r="http://schemas.openxmlformats.org/officeDocument/2006/relationships" id="2147483654" r:id="Re4add2688e784cea"/>
+    <p:sldLayoutId xmlns:r="http://schemas.openxmlformats.org/officeDocument/2006/relationships" id="2147483655" r:id="R301c9059649c45c4"/>
+    <p:sldLayoutId xmlns:r="http://schemas.openxmlformats.org/officeDocument/2006/relationships" id="2147483656" r:id="Re8e84c9b78c14be9"/>
+    <p:sldLayoutId xmlns:r="http://schemas.openxmlformats.org/officeDocument/2006/relationships" id="2147483657" r:id="R7a6eb87855584b05"/>
+    <p:sldLayoutId xmlns:r="http://schemas.openxmlformats.org/officeDocument/2006/relationships" id="2147483658" r:id="Rdb1a6bc8c807424b"/>
+    <p:sldLayoutId xmlns:r="http://schemas.openxmlformats.org/officeDocument/2006/relationships" id="2147483659" r:id="R6a6d504dce4c4bab"/>
+    <p:sldLayoutId xmlns:r="http://schemas.openxmlformats.org/officeDocument/2006/relationships" id="2147483660" r:id="R386de4c90e3c4090"/>
   </p:sldLayoutIdLst>
   <p:hf sldNum="0" hdr="0" ftr="0" dt="0"/>
   <p:txStyles>
@@ -6442,7 +6442,7 @@
   </p:cSld>
   <p:clrMap bg1="lt1" tx1="dk1" bg2="dk2" tx2="lt2" accent1="accent1" accent2="accent2" accent3="accent3" accent4="accent4" accent5="accent5" accent6="accent6" hlink="hlink" folHlink="folHlink"/>
   <p:sldLayoutIdLst>
-    <p:sldLayoutId xmlns:r="http://schemas.openxmlformats.org/officeDocument/2006/relationships" id="2147483662" r:id="Re603025a70824be6"/>
+    <p:sldLayoutId xmlns:r="http://schemas.openxmlformats.org/officeDocument/2006/relationships" id="2147483662" r:id="R12f422d90ebb4a68"/>
   </p:sldLayoutIdLst>
   <p:hf sldNum="0" hdr="0" ftr="0" dt="0"/>
   <p:txStyles>
@@ -8291,7 +8291,7 @@
           <p:nvPr/>
         </p:nvPicPr>
         <p:blipFill rotWithShape="1">
-          <a:blip xmlns:r="http://schemas.openxmlformats.org/officeDocument/2006/relationships" xmlns:a="http://schemas.openxmlformats.org/drawingml/2006/main" r:embed="R3a2d468da5c4462d">
+          <a:blip xmlns:r="http://schemas.openxmlformats.org/officeDocument/2006/relationships" xmlns:a="http://schemas.openxmlformats.org/drawingml/2006/main" r:embed="R21981d91f6bd4191">
             <a:alphaModFix/>
           </a:blip>
           <a:srcRect xmlns:a="http://schemas.openxmlformats.org/drawingml/2006/main" l="0" t="0" r="0" b="0"/>
@@ -8319,7 +8319,7 @@
           <p:nvPr/>
         </p:nvPicPr>
         <p:blipFill rotWithShape="1">
-          <a:blip xmlns:r="http://schemas.openxmlformats.org/officeDocument/2006/relationships" xmlns:a="http://schemas.openxmlformats.org/drawingml/2006/main" r:embed="R3a2d468da5c4462d">
+          <a:blip xmlns:r="http://schemas.openxmlformats.org/officeDocument/2006/relationships" xmlns:a="http://schemas.openxmlformats.org/drawingml/2006/main" r:embed="R21981d91f6bd4191">
             <a:alphaModFix/>
           </a:blip>
           <a:srcRect xmlns:a="http://schemas.openxmlformats.org/drawingml/2006/main" l="0" t="0" r="0" b="0"/>
@@ -8347,7 +8347,7 @@
           <p:nvPr/>
         </p:nvPicPr>
         <p:blipFill rotWithShape="1">
-          <a:blip xmlns:r="http://schemas.openxmlformats.org/officeDocument/2006/relationships" xmlns:a="http://schemas.openxmlformats.org/drawingml/2006/main" r:embed="R3a2d468da5c4462d">
+          <a:blip xmlns:r="http://schemas.openxmlformats.org/officeDocument/2006/relationships" xmlns:a="http://schemas.openxmlformats.org/drawingml/2006/main" r:embed="R21981d91f6bd4191">
             <a:alphaModFix/>
           </a:blip>
           <a:srcRect xmlns:a="http://schemas.openxmlformats.org/drawingml/2006/main" l="0" t="0" r="0" b="0"/>
@@ -8375,7 +8375,7 @@
           <p:nvPr/>
         </p:nvPicPr>
         <p:blipFill rotWithShape="1">
-          <a:blip xmlns:r="http://schemas.openxmlformats.org/officeDocument/2006/relationships" xmlns:a="http://schemas.openxmlformats.org/drawingml/2006/main" r:embed="R3a2d468da5c4462d">
+          <a:blip xmlns:r="http://schemas.openxmlformats.org/officeDocument/2006/relationships" xmlns:a="http://schemas.openxmlformats.org/drawingml/2006/main" r:embed="R21981d91f6bd4191">
             <a:alphaModFix/>
           </a:blip>
           <a:srcRect xmlns:a="http://schemas.openxmlformats.org/drawingml/2006/main" l="0" t="0" r="0" b="0"/>
@@ -8403,7 +8403,7 @@
           <p:nvPr/>
         </p:nvPicPr>
         <p:blipFill rotWithShape="1">
-          <a:blip xmlns:r="http://schemas.openxmlformats.org/officeDocument/2006/relationships" xmlns:a="http://schemas.openxmlformats.org/drawingml/2006/main" r:embed="R3a2d468da5c4462d">
+          <a:blip xmlns:r="http://schemas.openxmlformats.org/officeDocument/2006/relationships" xmlns:a="http://schemas.openxmlformats.org/drawingml/2006/main" r:embed="R21981d91f6bd4191">
             <a:alphaModFix/>
           </a:blip>
           <a:srcRect xmlns:a="http://schemas.openxmlformats.org/drawingml/2006/main" l="0" t="0" r="0" b="0"/>
@@ -8431,7 +8431,7 @@
           <p:nvPr/>
         </p:nvPicPr>
         <p:blipFill rotWithShape="1">
-          <a:blip xmlns:r="http://schemas.openxmlformats.org/officeDocument/2006/relationships" xmlns:a="http://schemas.openxmlformats.org/drawingml/2006/main" r:embed="R3a2d468da5c4462d">
+          <a:blip xmlns:r="http://schemas.openxmlformats.org/officeDocument/2006/relationships" xmlns:a="http://schemas.openxmlformats.org/drawingml/2006/main" r:embed="R21981d91f6bd4191">
             <a:alphaModFix/>
           </a:blip>
           <a:srcRect xmlns:a="http://schemas.openxmlformats.org/drawingml/2006/main" l="0" t="0" r="0" b="0"/>
@@ -8459,7 +8459,7 @@
           <p:nvPr/>
         </p:nvPicPr>
         <p:blipFill rotWithShape="1">
-          <a:blip xmlns:r="http://schemas.openxmlformats.org/officeDocument/2006/relationships" xmlns:a="http://schemas.openxmlformats.org/drawingml/2006/main" r:embed="R3a2d468da5c4462d">
+          <a:blip xmlns:r="http://schemas.openxmlformats.org/officeDocument/2006/relationships" xmlns:a="http://schemas.openxmlformats.org/drawingml/2006/main" r:embed="R21981d91f6bd4191">
             <a:alphaModFix/>
           </a:blip>
           <a:srcRect xmlns:a="http://schemas.openxmlformats.org/drawingml/2006/main" l="0" t="0" r="0" b="0"/>
@@ -8487,7 +8487,7 @@
           <p:nvPr/>
         </p:nvPicPr>
         <p:blipFill rotWithShape="1">
-          <a:blip xmlns:r="http://schemas.openxmlformats.org/officeDocument/2006/relationships" xmlns:a="http://schemas.openxmlformats.org/drawingml/2006/main" r:embed="R3a2d468da5c4462d">
+          <a:blip xmlns:r="http://schemas.openxmlformats.org/officeDocument/2006/relationships" xmlns:a="http://schemas.openxmlformats.org/drawingml/2006/main" r:embed="R21981d91f6bd4191">
             <a:alphaModFix/>
           </a:blip>
           <a:srcRect xmlns:a="http://schemas.openxmlformats.org/drawingml/2006/main" l="0" t="0" r="0" b="0"/>
@@ -9363,7 +9363,7 @@
                 <a:ea typeface="Inter"/>
                 <a:cs typeface="Inter"/>
               </a:rPr>
-              <a:t>The agent prints the count when capture ends. It varies with VM activity.</a:t>
+              <a:t>Events reach user space. This step prints only their count, not each event.</a:t>
             </a:r>
           </a:p>
         </p:txBody>
@@ -10110,7 +10110,7 @@
                 <a:ea typeface="Roboto Mono"/>
                 <a:cs typeface="Roboto Mono"/>
               </a:rPr>
-              <a:t>std::cout &lt;&lt; "Received " &lt;&lt; received</a:t>
+              <a:t>std::cout &lt;&lt; "Read " &lt;&lt; received</a:t>
             </a:r>
           </a:p>
           <a:p xmlns:a="http://schemas.openxmlformats.org/drawingml/2006/main">
@@ -10140,7 +10140,37 @@
                 <a:ea typeface="Roboto Mono"/>
                 <a:cs typeface="Roboto Mono"/>
               </a:rPr>
-              <a:t>          &lt;&lt; " events." &lt;&lt; std::endl;</a:t>
+              <a:t>          &lt;&lt; " events into user space."</a:t>
+            </a:r>
+          </a:p>
+          <a:p xmlns:a="http://schemas.openxmlformats.org/drawingml/2006/main">
+            <a:pPr marL="0" indent="0" algn="l">
+              <a:spcBef>
+                <a:spcPts val="0"/>
+              </a:spcBef>
+              <a:spcAft>
+                <a:spcPts val="0"/>
+              </a:spcAft>
+              <a:buNone/>
+              <a:defRPr sz="1200" b="0">
+                <a:solidFill>
+                  <a:srgbClr val="00E5FF"/>
+                </a:solidFill>
+                <a:latin typeface="Roboto Mono"/>
+                <a:ea typeface="Roboto Mono"/>
+                <a:cs typeface="Roboto Mono"/>
+              </a:defRPr>
+            </a:pPr>
+            <a:r>
+              <a:rPr sz="1200" b="0" i="0">
+                <a:solidFill>
+                  <a:srgbClr val="00E5FF"/>
+                </a:solidFill>
+                <a:latin typeface="Roboto Mono"/>
+                <a:ea typeface="Roboto Mono"/>
+                <a:cs typeface="Roboto Mono"/>
+              </a:rPr>
+              <a:t>          &lt;&lt; std::endl;</a:t>
             </a:r>
           </a:p>
         </p:txBody>
@@ -10790,7 +10820,7 @@
           <p:nvPr/>
         </p:nvPicPr>
         <p:blipFill rotWithShape="1">
-          <a:blip xmlns:r="http://schemas.openxmlformats.org/officeDocument/2006/relationships" xmlns:a="http://schemas.openxmlformats.org/drawingml/2006/main" r:embed="R7dd61178228a4ca4">
+          <a:blip xmlns:r="http://schemas.openxmlformats.org/officeDocument/2006/relationships" xmlns:a="http://schemas.openxmlformats.org/drawingml/2006/main" r:embed="R1a5093503f3946c1">
             <a:alphaModFix/>
           </a:blip>
           <a:srcRect xmlns:a="http://schemas.openxmlformats.org/drawingml/2006/main" l="0" t="0" r="0" b="0"/>
@@ -10818,7 +10848,7 @@
           <p:nvPr/>
         </p:nvPicPr>
         <p:blipFill rotWithShape="1">
-          <a:blip xmlns:r="http://schemas.openxmlformats.org/officeDocument/2006/relationships" xmlns:a="http://schemas.openxmlformats.org/drawingml/2006/main" r:embed="R7dd61178228a4ca4">
+          <a:blip xmlns:r="http://schemas.openxmlformats.org/officeDocument/2006/relationships" xmlns:a="http://schemas.openxmlformats.org/drawingml/2006/main" r:embed="R1a5093503f3946c1">
             <a:alphaModFix/>
           </a:blip>
           <a:srcRect xmlns:a="http://schemas.openxmlformats.org/drawingml/2006/main" l="0" t="0" r="0" b="0"/>
@@ -10846,7 +10876,7 @@
           <p:nvPr/>
         </p:nvPicPr>
         <p:blipFill rotWithShape="1">
-          <a:blip xmlns:r="http://schemas.openxmlformats.org/officeDocument/2006/relationships" xmlns:a="http://schemas.openxmlformats.org/drawingml/2006/main" r:embed="R7dd61178228a4ca4">
+          <a:blip xmlns:r="http://schemas.openxmlformats.org/officeDocument/2006/relationships" xmlns:a="http://schemas.openxmlformats.org/drawingml/2006/main" r:embed="R1a5093503f3946c1">
             <a:alphaModFix/>
           </a:blip>
           <a:srcRect xmlns:a="http://schemas.openxmlformats.org/drawingml/2006/main" l="0" t="0" r="0" b="0"/>
@@ -10874,7 +10904,7 @@
           <p:nvPr/>
         </p:nvPicPr>
         <p:blipFill rotWithShape="1">
-          <a:blip xmlns:r="http://schemas.openxmlformats.org/officeDocument/2006/relationships" xmlns:a="http://schemas.openxmlformats.org/drawingml/2006/main" r:embed="R7dd61178228a4ca4">
+          <a:blip xmlns:r="http://schemas.openxmlformats.org/officeDocument/2006/relationships" xmlns:a="http://schemas.openxmlformats.org/drawingml/2006/main" r:embed="R1a5093503f3946c1">
             <a:alphaModFix/>
           </a:blip>
           <a:srcRect xmlns:a="http://schemas.openxmlformats.org/drawingml/2006/main" l="0" t="0" r="0" b="0"/>
@@ -11472,7 +11502,7 @@
                 <a:ea typeface="Inter"/>
                 <a:cs typeface="Inter"/>
               </a:rPr>
-              <a:t>Run step 3, then run in terminal A.</a:t>
+              <a:t>Run step 3, then run.</a:t>
             </a:r>
           </a:p>
           <a:p xmlns:a="http://schemas.openxmlformats.org/drawingml/2006/main">
@@ -11524,7 +11554,7 @@
                 <a:ea typeface="Inter"/>
                 <a:cs typeface="Inter"/>
               </a:rPr>
-              <a:t>The script adds this filter before opening capture. Run id in B.</a:t>
+              <a:t>The script adds this filter before capture. Example activity runs automatically.</a:t>
             </a:r>
           </a:p>
           <a:p xmlns:a="http://schemas.openxmlformats.org/drawingml/2006/main">
@@ -12075,7 +12105,7 @@
                 <a:ea typeface="Roboto Mono"/>
                 <a:cs typeface="Roboto Mono"/>
               </a:rPr>
-              <a:t># During capture, in VM terminal B</a:t>
+              <a:t>// The runner generates activity</a:t>
             </a:r>
           </a:p>
           <a:p xmlns:a="http://schemas.openxmlformats.org/drawingml/2006/main">
@@ -12105,7 +12135,7 @@
                 <a:ea typeface="Roboto Mono"/>
                 <a:cs typeface="Roboto Mono"/>
               </a:rPr>
-              <a:t>/usr/bin/id</a:t>
+              <a:t>// inside Ubuntu automatically.</a:t>
             </a:r>
           </a:p>
         </p:txBody>
@@ -12755,7 +12785,7 @@
           <p:nvPr/>
         </p:nvPicPr>
         <p:blipFill rotWithShape="1">
-          <a:blip xmlns:r="http://schemas.openxmlformats.org/officeDocument/2006/relationships" xmlns:a="http://schemas.openxmlformats.org/drawingml/2006/main" r:embed="R7de6af14fb1541a0">
+          <a:blip xmlns:r="http://schemas.openxmlformats.org/officeDocument/2006/relationships" xmlns:a="http://schemas.openxmlformats.org/drawingml/2006/main" r:embed="R075c5b9751044f64">
             <a:alphaModFix/>
           </a:blip>
           <a:srcRect xmlns:a="http://schemas.openxmlformats.org/drawingml/2006/main" l="0" t="0" r="0" b="0"/>
@@ -12783,7 +12813,7 @@
           <p:nvPr/>
         </p:nvPicPr>
         <p:blipFill rotWithShape="1">
-          <a:blip xmlns:r="http://schemas.openxmlformats.org/officeDocument/2006/relationships" xmlns:a="http://schemas.openxmlformats.org/drawingml/2006/main" r:embed="R7de6af14fb1541a0">
+          <a:blip xmlns:r="http://schemas.openxmlformats.org/officeDocument/2006/relationships" xmlns:a="http://schemas.openxmlformats.org/drawingml/2006/main" r:embed="R075c5b9751044f64">
             <a:alphaModFix/>
           </a:blip>
           <a:srcRect xmlns:a="http://schemas.openxmlformats.org/drawingml/2006/main" l="0" t="0" r="0" b="0"/>
@@ -12811,7 +12841,7 @@
           <p:nvPr/>
         </p:nvPicPr>
         <p:blipFill rotWithShape="1">
-          <a:blip xmlns:r="http://schemas.openxmlformats.org/officeDocument/2006/relationships" xmlns:a="http://schemas.openxmlformats.org/drawingml/2006/main" r:embed="R7de6af14fb1541a0">
+          <a:blip xmlns:r="http://schemas.openxmlformats.org/officeDocument/2006/relationships" xmlns:a="http://schemas.openxmlformats.org/drawingml/2006/main" r:embed="R075c5b9751044f64">
             <a:alphaModFix/>
           </a:blip>
           <a:srcRect xmlns:a="http://schemas.openxmlformats.org/drawingml/2006/main" l="0" t="0" r="0" b="0"/>
@@ -12839,7 +12869,7 @@
           <p:nvPr/>
         </p:nvPicPr>
         <p:blipFill rotWithShape="1">
-          <a:blip xmlns:r="http://schemas.openxmlformats.org/officeDocument/2006/relationships" xmlns:a="http://schemas.openxmlformats.org/drawingml/2006/main" r:embed="R7de6af14fb1541a0">
+          <a:blip xmlns:r="http://schemas.openxmlformats.org/officeDocument/2006/relationships" xmlns:a="http://schemas.openxmlformats.org/drawingml/2006/main" r:embed="R075c5b9751044f64">
             <a:alphaModFix/>
           </a:blip>
           <a:srcRect xmlns:a="http://schemas.openxmlformats.org/drawingml/2006/main" l="0" t="0" r="0" b="0"/>
@@ -13437,7 +13467,7 @@
                 <a:ea typeface="Inter"/>
                 <a:cs typeface="Inter"/>
               </a:rPr>
-              <a:t>Run step 4, then run in terminal A.</a:t>
+              <a:t>Run step 4, then run.</a:t>
             </a:r>
           </a:p>
           <a:p xmlns:a="http://schemas.openxmlformats.org/drawingml/2006/main">
@@ -13541,7 +13571,7 @@
                 <a:ea typeface="Inter"/>
                 <a:cs typeface="Inter"/>
               </a:rPr>
-              <a:t>Run id in B again during capture.</a:t>
+              <a:t>Look for an execution with name=id.</a:t>
             </a:r>
           </a:p>
         </p:txBody>
@@ -14788,7 +14818,7 @@
           <p:nvPr/>
         </p:nvPicPr>
         <p:blipFill rotWithShape="1">
-          <a:blip xmlns:r="http://schemas.openxmlformats.org/officeDocument/2006/relationships" xmlns:a="http://schemas.openxmlformats.org/drawingml/2006/main" r:embed="R69e4c9c209b74d79">
+          <a:blip xmlns:r="http://schemas.openxmlformats.org/officeDocument/2006/relationships" xmlns:a="http://schemas.openxmlformats.org/drawingml/2006/main" r:embed="R0c423fc47597443e">
             <a:alphaModFix/>
           </a:blip>
           <a:srcRect xmlns:a="http://schemas.openxmlformats.org/drawingml/2006/main" l="0" t="0" r="0" b="0"/>
@@ -14816,7 +14846,7 @@
           <p:nvPr/>
         </p:nvPicPr>
         <p:blipFill rotWithShape="1">
-          <a:blip xmlns:r="http://schemas.openxmlformats.org/officeDocument/2006/relationships" xmlns:a="http://schemas.openxmlformats.org/drawingml/2006/main" r:embed="R69e4c9c209b74d79">
+          <a:blip xmlns:r="http://schemas.openxmlformats.org/officeDocument/2006/relationships" xmlns:a="http://schemas.openxmlformats.org/drawingml/2006/main" r:embed="R0c423fc47597443e">
             <a:alphaModFix/>
           </a:blip>
           <a:srcRect xmlns:a="http://schemas.openxmlformats.org/drawingml/2006/main" l="0" t="0" r="0" b="0"/>
@@ -14844,7 +14874,7 @@
           <p:nvPr/>
         </p:nvPicPr>
         <p:blipFill rotWithShape="1">
-          <a:blip xmlns:r="http://schemas.openxmlformats.org/officeDocument/2006/relationships" xmlns:a="http://schemas.openxmlformats.org/drawingml/2006/main" r:embed="R69e4c9c209b74d79">
+          <a:blip xmlns:r="http://schemas.openxmlformats.org/officeDocument/2006/relationships" xmlns:a="http://schemas.openxmlformats.org/drawingml/2006/main" r:embed="R0c423fc47597443e">
             <a:alphaModFix/>
           </a:blip>
           <a:srcRect xmlns:a="http://schemas.openxmlformats.org/drawingml/2006/main" l="0" t="0" r="0" b="0"/>
@@ -14872,7 +14902,7 @@
           <p:nvPr/>
         </p:nvPicPr>
         <p:blipFill rotWithShape="1">
-          <a:blip xmlns:r="http://schemas.openxmlformats.org/officeDocument/2006/relationships" xmlns:a="http://schemas.openxmlformats.org/drawingml/2006/main" r:embed="R69e4c9c209b74d79">
+          <a:blip xmlns:r="http://schemas.openxmlformats.org/officeDocument/2006/relationships" xmlns:a="http://schemas.openxmlformats.org/drawingml/2006/main" r:embed="R0c423fc47597443e">
             <a:alphaModFix/>
           </a:blip>
           <a:srcRect xmlns:a="http://schemas.openxmlformats.org/drawingml/2006/main" l="0" t="0" r="0" b="0"/>
@@ -16073,7 +16103,7 @@
                 <a:ea typeface="Roboto Mono"/>
                 <a:cs typeface="Roboto Mono"/>
               </a:rPr>
-              <a:t>Received 1 events.</a:t>
+              <a:t>Read 1 process-execution events.</a:t>
             </a:r>
           </a:p>
           <a:p xmlns:a="http://schemas.openxmlformats.org/drawingml/2006/main">
@@ -16835,7 +16865,7 @@
           <p:nvPr/>
         </p:nvPicPr>
         <p:blipFill rotWithShape="1">
-          <a:blip xmlns:r="http://schemas.openxmlformats.org/officeDocument/2006/relationships" xmlns:a="http://schemas.openxmlformats.org/drawingml/2006/main" r:embed="R44f2767bd7e7418a">
+          <a:blip xmlns:r="http://schemas.openxmlformats.org/officeDocument/2006/relationships" xmlns:a="http://schemas.openxmlformats.org/drawingml/2006/main" r:embed="R29e197c21410438d">
             <a:alphaModFix/>
           </a:blip>
           <a:srcRect xmlns:a="http://schemas.openxmlformats.org/drawingml/2006/main" l="0" t="0" r="0" b="0"/>
@@ -16863,7 +16893,7 @@
           <p:nvPr/>
         </p:nvPicPr>
         <p:blipFill rotWithShape="1">
-          <a:blip xmlns:r="http://schemas.openxmlformats.org/officeDocument/2006/relationships" xmlns:a="http://schemas.openxmlformats.org/drawingml/2006/main" r:embed="R44f2767bd7e7418a">
+          <a:blip xmlns:r="http://schemas.openxmlformats.org/officeDocument/2006/relationships" xmlns:a="http://schemas.openxmlformats.org/drawingml/2006/main" r:embed="R29e197c21410438d">
             <a:alphaModFix/>
           </a:blip>
           <a:srcRect xmlns:a="http://schemas.openxmlformats.org/drawingml/2006/main" l="0" t="0" r="0" b="0"/>
@@ -16891,7 +16921,7 @@
           <p:nvPr/>
         </p:nvPicPr>
         <p:blipFill rotWithShape="1">
-          <a:blip xmlns:r="http://schemas.openxmlformats.org/officeDocument/2006/relationships" xmlns:a="http://schemas.openxmlformats.org/drawingml/2006/main" r:embed="R44f2767bd7e7418a">
+          <a:blip xmlns:r="http://schemas.openxmlformats.org/officeDocument/2006/relationships" xmlns:a="http://schemas.openxmlformats.org/drawingml/2006/main" r:embed="R29e197c21410438d">
             <a:alphaModFix/>
           </a:blip>
           <a:srcRect xmlns:a="http://schemas.openxmlformats.org/drawingml/2006/main" l="0" t="0" r="0" b="0"/>
@@ -16919,7 +16949,7 @@
           <p:nvPr/>
         </p:nvPicPr>
         <p:blipFill rotWithShape="1">
-          <a:blip xmlns:r="http://schemas.openxmlformats.org/officeDocument/2006/relationships" xmlns:a="http://schemas.openxmlformats.org/drawingml/2006/main" r:embed="R44f2767bd7e7418a">
+          <a:blip xmlns:r="http://schemas.openxmlformats.org/officeDocument/2006/relationships" xmlns:a="http://schemas.openxmlformats.org/drawingml/2006/main" r:embed="R29e197c21410438d">
             <a:alphaModFix/>
           </a:blip>
           <a:srcRect xmlns:a="http://schemas.openxmlformats.org/drawingml/2006/main" l="0" t="0" r="0" b="0"/>
@@ -18060,7 +18090,7 @@
                 <a:ea typeface="Roboto Mono"/>
                 <a:cs typeface="Roboto Mono"/>
               </a:rPr>
-              <a:t># Next time</a:t>
+              <a:t># Next time, use your run script.</a:t>
             </a:r>
           </a:p>
           <a:p xmlns:a="http://schemas.openxmlformats.org/drawingml/2006/main">
@@ -18090,37 +18120,7 @@
                 <a:ea typeface="Roboto Mono"/>
                 <a:cs typeface="Roboto Mono"/>
               </a:rPr>
-              <a:t>multipass start falco-lab</a:t>
-            </a:r>
-          </a:p>
-          <a:p xmlns:a="http://schemas.openxmlformats.org/drawingml/2006/main">
-            <a:pPr marL="0" indent="0" algn="l">
-              <a:spcBef>
-                <a:spcPts val="0"/>
-              </a:spcBef>
-              <a:spcAft>
-                <a:spcPts val="0"/>
-              </a:spcAft>
-              <a:buNone/>
-              <a:defRPr sz="1350" b="0">
-                <a:solidFill>
-                  <a:srgbClr val="00E5FF"/>
-                </a:solidFill>
-                <a:latin typeface="Roboto Mono"/>
-                <a:ea typeface="Roboto Mono"/>
-                <a:cs typeface="Roboto Mono"/>
-              </a:defRPr>
-            </a:pPr>
-            <a:r>
-              <a:rPr sz="1350" b="0" i="0">
-                <a:solidFill>
-                  <a:srgbClr val="00E5FF"/>
-                </a:solidFill>
-                <a:latin typeface="Roboto Mono"/>
-                <a:ea typeface="Roboto Mono"/>
-                <a:cs typeface="Roboto Mono"/>
-              </a:rPr>
-              <a:t>multipass shell falco-lab</a:t>
+              <a:t># It starts the VM automatically.</a:t>
             </a:r>
           </a:p>
         </p:txBody>
@@ -18770,7 +18770,7 @@
           <p:nvPr/>
         </p:nvPicPr>
         <p:blipFill rotWithShape="1">
-          <a:blip xmlns:r="http://schemas.openxmlformats.org/officeDocument/2006/relationships" xmlns:a="http://schemas.openxmlformats.org/drawingml/2006/main" r:embed="R14cdab6cde694c15">
+          <a:blip xmlns:r="http://schemas.openxmlformats.org/officeDocument/2006/relationships" xmlns:a="http://schemas.openxmlformats.org/drawingml/2006/main" r:embed="Re3d7ef4c27834462">
             <a:alphaModFix/>
           </a:blip>
           <a:srcRect xmlns:a="http://schemas.openxmlformats.org/drawingml/2006/main" l="0" t="0" r="0" b="0"/>
@@ -18798,7 +18798,7 @@
           <p:nvPr/>
         </p:nvPicPr>
         <p:blipFill rotWithShape="1">
-          <a:blip xmlns:r="http://schemas.openxmlformats.org/officeDocument/2006/relationships" xmlns:a="http://schemas.openxmlformats.org/drawingml/2006/main" r:embed="R14cdab6cde694c15">
+          <a:blip xmlns:r="http://schemas.openxmlformats.org/officeDocument/2006/relationships" xmlns:a="http://schemas.openxmlformats.org/drawingml/2006/main" r:embed="Re3d7ef4c27834462">
             <a:alphaModFix/>
           </a:blip>
           <a:srcRect xmlns:a="http://schemas.openxmlformats.org/drawingml/2006/main" l="0" t="0" r="0" b="0"/>
@@ -18826,7 +18826,7 @@
           <p:nvPr/>
         </p:nvPicPr>
         <p:blipFill rotWithShape="1">
-          <a:blip xmlns:r="http://schemas.openxmlformats.org/officeDocument/2006/relationships" xmlns:a="http://schemas.openxmlformats.org/drawingml/2006/main" r:embed="R14cdab6cde694c15">
+          <a:blip xmlns:r="http://schemas.openxmlformats.org/officeDocument/2006/relationships" xmlns:a="http://schemas.openxmlformats.org/drawingml/2006/main" r:embed="Re3d7ef4c27834462">
             <a:alphaModFix/>
           </a:blip>
           <a:srcRect xmlns:a="http://schemas.openxmlformats.org/drawingml/2006/main" l="0" t="0" r="0" b="0"/>
@@ -18854,7 +18854,7 @@
           <p:nvPr/>
         </p:nvPicPr>
         <p:blipFill rotWithShape="1">
-          <a:blip xmlns:r="http://schemas.openxmlformats.org/officeDocument/2006/relationships" xmlns:a="http://schemas.openxmlformats.org/drawingml/2006/main" r:embed="R14cdab6cde694c15">
+          <a:blip xmlns:r="http://schemas.openxmlformats.org/officeDocument/2006/relationships" xmlns:a="http://schemas.openxmlformats.org/drawingml/2006/main" r:embed="Re3d7ef4c27834462">
             <a:alphaModFix/>
           </a:blip>
           <a:srcRect xmlns:a="http://schemas.openxmlformats.org/drawingml/2006/main" l="0" t="0" r="0" b="0"/>
@@ -20749,7 +20749,7 @@
           <p:nvPr/>
         </p:nvPicPr>
         <p:blipFill rotWithShape="1">
-          <a:blip xmlns:r="http://schemas.openxmlformats.org/officeDocument/2006/relationships" xmlns:a="http://schemas.openxmlformats.org/drawingml/2006/main" r:embed="R26837cc320c047c9">
+          <a:blip xmlns:r="http://schemas.openxmlformats.org/officeDocument/2006/relationships" xmlns:a="http://schemas.openxmlformats.org/drawingml/2006/main" r:embed="R3935b39f8ea14c5b">
             <a:alphaModFix/>
           </a:blip>
           <a:srcRect xmlns:a="http://schemas.openxmlformats.org/drawingml/2006/main" l="0" t="0" r="0" b="0"/>
@@ -20777,7 +20777,7 @@
           <p:nvPr/>
         </p:nvPicPr>
         <p:blipFill rotWithShape="1">
-          <a:blip xmlns:r="http://schemas.openxmlformats.org/officeDocument/2006/relationships" xmlns:a="http://schemas.openxmlformats.org/drawingml/2006/main" r:embed="R26837cc320c047c9">
+          <a:blip xmlns:r="http://schemas.openxmlformats.org/officeDocument/2006/relationships" xmlns:a="http://schemas.openxmlformats.org/drawingml/2006/main" r:embed="R3935b39f8ea14c5b">
             <a:alphaModFix/>
           </a:blip>
           <a:srcRect xmlns:a="http://schemas.openxmlformats.org/drawingml/2006/main" l="0" t="0" r="0" b="0"/>
@@ -20805,7 +20805,7 @@
           <p:nvPr/>
         </p:nvPicPr>
         <p:blipFill rotWithShape="1">
-          <a:blip xmlns:r="http://schemas.openxmlformats.org/officeDocument/2006/relationships" xmlns:a="http://schemas.openxmlformats.org/drawingml/2006/main" r:embed="R26837cc320c047c9">
+          <a:blip xmlns:r="http://schemas.openxmlformats.org/officeDocument/2006/relationships" xmlns:a="http://schemas.openxmlformats.org/drawingml/2006/main" r:embed="R3935b39f8ea14c5b">
             <a:alphaModFix/>
           </a:blip>
           <a:srcRect xmlns:a="http://schemas.openxmlformats.org/drawingml/2006/main" l="0" t="0" r="0" b="0"/>
@@ -20833,7 +20833,7 @@
           <p:nvPr/>
         </p:nvPicPr>
         <p:blipFill rotWithShape="1">
-          <a:blip xmlns:r="http://schemas.openxmlformats.org/officeDocument/2006/relationships" xmlns:a="http://schemas.openxmlformats.org/drawingml/2006/main" r:embed="R26837cc320c047c9">
+          <a:blip xmlns:r="http://schemas.openxmlformats.org/officeDocument/2006/relationships" xmlns:a="http://schemas.openxmlformats.org/drawingml/2006/main" r:embed="R3935b39f8ea14c5b">
             <a:alphaModFix/>
           </a:blip>
           <a:srcRect xmlns:a="http://schemas.openxmlformats.org/drawingml/2006/main" l="0" t="0" r="0" b="0"/>
@@ -22446,7 +22446,7 @@
           <p:nvPr/>
         </p:nvPicPr>
         <p:blipFill rotWithShape="1">
-          <a:blip xmlns:r="http://schemas.openxmlformats.org/officeDocument/2006/relationships" xmlns:a="http://schemas.openxmlformats.org/drawingml/2006/main" r:embed="R8fa8a24efb3a44cc">
+          <a:blip xmlns:r="http://schemas.openxmlformats.org/officeDocument/2006/relationships" xmlns:a="http://schemas.openxmlformats.org/drawingml/2006/main" r:embed="Racd6ce8735d943ed">
             <a:alphaModFix/>
           </a:blip>
           <a:srcRect xmlns:a="http://schemas.openxmlformats.org/drawingml/2006/main" l="0" t="0" r="0" b="0"/>
@@ -22474,7 +22474,7 @@
           <p:nvPr/>
         </p:nvPicPr>
         <p:blipFill rotWithShape="1">
-          <a:blip xmlns:r="http://schemas.openxmlformats.org/officeDocument/2006/relationships" xmlns:a="http://schemas.openxmlformats.org/drawingml/2006/main" r:embed="R8fa8a24efb3a44cc">
+          <a:blip xmlns:r="http://schemas.openxmlformats.org/officeDocument/2006/relationships" xmlns:a="http://schemas.openxmlformats.org/drawingml/2006/main" r:embed="Racd6ce8735d943ed">
             <a:alphaModFix/>
           </a:blip>
           <a:srcRect xmlns:a="http://schemas.openxmlformats.org/drawingml/2006/main" l="0" t="0" r="0" b="0"/>
@@ -22502,7 +22502,7 @@
           <p:nvPr/>
         </p:nvPicPr>
         <p:blipFill rotWithShape="1">
-          <a:blip xmlns:r="http://schemas.openxmlformats.org/officeDocument/2006/relationships" xmlns:a="http://schemas.openxmlformats.org/drawingml/2006/main" r:embed="R8fa8a24efb3a44cc">
+          <a:blip xmlns:r="http://schemas.openxmlformats.org/officeDocument/2006/relationships" xmlns:a="http://schemas.openxmlformats.org/drawingml/2006/main" r:embed="Racd6ce8735d943ed">
             <a:alphaModFix/>
           </a:blip>
           <a:srcRect xmlns:a="http://schemas.openxmlformats.org/drawingml/2006/main" l="0" t="0" r="0" b="0"/>
@@ -22530,7 +22530,7 @@
           <p:nvPr/>
         </p:nvPicPr>
         <p:blipFill rotWithShape="1">
-          <a:blip xmlns:r="http://schemas.openxmlformats.org/officeDocument/2006/relationships" xmlns:a="http://schemas.openxmlformats.org/drawingml/2006/main" r:embed="R8fa8a24efb3a44cc">
+          <a:blip xmlns:r="http://schemas.openxmlformats.org/officeDocument/2006/relationships" xmlns:a="http://schemas.openxmlformats.org/drawingml/2006/main" r:embed="Racd6ce8735d943ed">
             <a:alphaModFix/>
           </a:blip>
           <a:srcRect xmlns:a="http://schemas.openxmlformats.org/drawingml/2006/main" l="0" t="0" r="0" b="0"/>
@@ -24143,7 +24143,7 @@
           <p:nvPr/>
         </p:nvPicPr>
         <p:blipFill rotWithShape="1">
-          <a:blip xmlns:r="http://schemas.openxmlformats.org/officeDocument/2006/relationships" xmlns:a="http://schemas.openxmlformats.org/drawingml/2006/main" r:embed="Rc1f4b05def794898">
+          <a:blip xmlns:r="http://schemas.openxmlformats.org/officeDocument/2006/relationships" xmlns:a="http://schemas.openxmlformats.org/drawingml/2006/main" r:embed="R22c76fe324b447f9">
             <a:alphaModFix/>
           </a:blip>
           <a:srcRect xmlns:a="http://schemas.openxmlformats.org/drawingml/2006/main" l="0" t="0" r="0" b="0"/>
@@ -24171,7 +24171,7 @@
           <p:nvPr/>
         </p:nvPicPr>
         <p:blipFill rotWithShape="1">
-          <a:blip xmlns:r="http://schemas.openxmlformats.org/officeDocument/2006/relationships" xmlns:a="http://schemas.openxmlformats.org/drawingml/2006/main" r:embed="Rc1f4b05def794898">
+          <a:blip xmlns:r="http://schemas.openxmlformats.org/officeDocument/2006/relationships" xmlns:a="http://schemas.openxmlformats.org/drawingml/2006/main" r:embed="R22c76fe324b447f9">
             <a:alphaModFix/>
           </a:blip>
           <a:srcRect xmlns:a="http://schemas.openxmlformats.org/drawingml/2006/main" l="0" t="0" r="0" b="0"/>
@@ -24199,7 +24199,7 @@
           <p:nvPr/>
         </p:nvPicPr>
         <p:blipFill rotWithShape="1">
-          <a:blip xmlns:r="http://schemas.openxmlformats.org/officeDocument/2006/relationships" xmlns:a="http://schemas.openxmlformats.org/drawingml/2006/main" r:embed="Rc1f4b05def794898">
+          <a:blip xmlns:r="http://schemas.openxmlformats.org/officeDocument/2006/relationships" xmlns:a="http://schemas.openxmlformats.org/drawingml/2006/main" r:embed="R22c76fe324b447f9">
             <a:alphaModFix/>
           </a:blip>
           <a:srcRect xmlns:a="http://schemas.openxmlformats.org/drawingml/2006/main" l="0" t="0" r="0" b="0"/>
@@ -24227,7 +24227,7 @@
           <p:nvPr/>
         </p:nvPicPr>
         <p:blipFill rotWithShape="1">
-          <a:blip xmlns:r="http://schemas.openxmlformats.org/officeDocument/2006/relationships" xmlns:a="http://schemas.openxmlformats.org/drawingml/2006/main" r:embed="Rc1f4b05def794898">
+          <a:blip xmlns:r="http://schemas.openxmlformats.org/officeDocument/2006/relationships" xmlns:a="http://schemas.openxmlformats.org/drawingml/2006/main" r:embed="R22c76fe324b447f9">
             <a:alphaModFix/>
           </a:blip>
           <a:srcRect xmlns:a="http://schemas.openxmlformats.org/drawingml/2006/main" l="0" t="0" r="0" b="0"/>
@@ -24657,7 +24657,7 @@
                 <a:ea typeface="Montserrat"/>
                 <a:cs typeface="Montserrat"/>
               </a:rPr>
-              <a:t>Two terminals</a:t>
+              <a:t>One terminal</a:t>
             </a:r>
           </a:p>
         </p:txBody>
@@ -24825,7 +24825,7 @@
                 <a:ea typeface="Inter"/>
                 <a:cs typeface="Inter"/>
               </a:rPr>
-              <a:t>A: keep your Mac or Windows terminal in the repo folder. Run your platform’s step and run scripts here.</a:t>
+              <a:t>Stay in your Mac terminal or Windows PowerShell.</a:t>
             </a:r>
           </a:p>
           <a:p xmlns:a="http://schemas.openxmlformats.org/drawingml/2006/main">
@@ -24877,7 +24877,59 @@
                 <a:ea typeface="Inter"/>
                 <a:cs typeface="Inter"/>
               </a:rPr>
-              <a:t>B: open a second terminal and enter Ubuntu. Run commands for the collector to observe.</a:t>
+              <a:t>Apply a step, then run.</a:t>
+            </a:r>
+          </a:p>
+          <a:p xmlns:a="http://schemas.openxmlformats.org/drawingml/2006/main">
+            <a:pPr marL="0" indent="0">
+              <a:spcBef>
+                <a:spcPts val="0"/>
+              </a:spcBef>
+              <a:spcAft>
+                <a:spcPts val="0"/>
+              </a:spcAft>
+              <a:buNone/>
+            </a:pPr>
+            <a:r>
+              <a:rPr sz="1500" b="0" i="0">
+                <a:solidFill>
+                  <a:srgbClr val="4A5568"/>
+                </a:solidFill>
+                <a:latin typeface="Inter"/>
+                <a:ea typeface="Inter"/>
+                <a:cs typeface="Inter"/>
+              </a:rPr>
+              <a:t/>
+            </a:r>
+          </a:p>
+          <a:p xmlns:a="http://schemas.openxmlformats.org/drawingml/2006/main">
+            <a:pPr marL="0" indent="0" algn="l">
+              <a:spcBef>
+                <a:spcPts val="0"/>
+              </a:spcBef>
+              <a:spcAft>
+                <a:spcPts val="0"/>
+              </a:spcAft>
+              <a:buNone/>
+              <a:defRPr sz="1500" b="0">
+                <a:solidFill>
+                  <a:srgbClr val="4A5568"/>
+                </a:solidFill>
+                <a:latin typeface="Inter"/>
+                <a:ea typeface="Inter"/>
+                <a:cs typeface="Inter"/>
+              </a:defRPr>
+            </a:pPr>
+            <a:r>
+              <a:rPr sz="1500" b="0" i="0">
+                <a:solidFill>
+                  <a:srgbClr val="4A5568"/>
+                </a:solidFill>
+                <a:latin typeface="Inter"/>
+                <a:ea typeface="Inter"/>
+                <a:cs typeface="Inter"/>
+              </a:rPr>
+              <a:t>The scripts handle Ubuntu and generate example activity automatically.</a:t>
             </a:r>
           </a:p>
         </p:txBody>
@@ -25147,7 +25199,7 @@
                 <a:ea typeface="Roboto Mono"/>
                 <a:cs typeface="Roboto Mono"/>
               </a:rPr>
-              <a:t>Terminal B: enter Ubuntu</a:t>
+              <a:t>Every run</a:t>
             </a:r>
           </a:p>
         </p:txBody>
@@ -25264,7 +25316,29 @@
                 <a:ea typeface="Roboto Mono"/>
                 <a:cs typeface="Roboto Mono"/>
               </a:rPr>
-              <a:t>multipass shell falco-lab</a:t>
+              <a:t>Rebuild the current source</a:t>
+            </a:r>
+          </a:p>
+          <a:p xmlns:a="http://schemas.openxmlformats.org/drawingml/2006/main">
+            <a:pPr marL="0" indent="0">
+              <a:spcBef>
+                <a:spcPts val="0"/>
+              </a:spcBef>
+              <a:spcAft>
+                <a:spcPts val="0"/>
+              </a:spcAft>
+              <a:buNone/>
+            </a:pPr>
+            <a:r>
+              <a:rPr sz="1350" b="0" i="0">
+                <a:solidFill>
+                  <a:srgbClr val="00E5FF"/>
+                </a:solidFill>
+                <a:latin typeface="Roboto Mono"/>
+                <a:ea typeface="Roboto Mono"/>
+                <a:cs typeface="Roboto Mono"/>
+              </a:rPr>
+              <a:t/>
             </a:r>
           </a:p>
           <a:p xmlns:a="http://schemas.openxmlformats.org/drawingml/2006/main">
@@ -25294,7 +25368,7 @@
                 <a:ea typeface="Roboto Mono"/>
                 <a:cs typeface="Roboto Mono"/>
               </a:rPr>
-              <a:t>cd ~/falco-libs-workshop</a:t>
+              <a:t>Run for ten seconds</a:t>
             </a:r>
           </a:p>
           <a:p xmlns:a="http://schemas.openxmlformats.org/drawingml/2006/main">
@@ -25346,7 +25420,29 @@
                 <a:ea typeface="Roboto Mono"/>
                 <a:cs typeface="Roboto Mono"/>
               </a:rPr>
-              <a:t># During steps 2–4</a:t>
+              <a:t>Show the result and stop the agent</a:t>
+            </a:r>
+          </a:p>
+          <a:p xmlns:a="http://schemas.openxmlformats.org/drawingml/2006/main">
+            <a:pPr marL="0" indent="0">
+              <a:spcBef>
+                <a:spcPts val="0"/>
+              </a:spcBef>
+              <a:spcAft>
+                <a:spcPts val="0"/>
+              </a:spcAft>
+              <a:buNone/>
+            </a:pPr>
+            <a:r>
+              <a:rPr sz="1350" b="0" i="0">
+                <a:solidFill>
+                  <a:srgbClr val="00E5FF"/>
+                </a:solidFill>
+                <a:latin typeface="Roboto Mono"/>
+                <a:ea typeface="Roboto Mono"/>
+                <a:cs typeface="Roboto Mono"/>
+              </a:rPr>
+              <a:t/>
             </a:r>
           </a:p>
           <a:p xmlns:a="http://schemas.openxmlformats.org/drawingml/2006/main">
@@ -25376,7 +25472,7 @@
                 <a:ea typeface="Roboto Mono"/>
                 <a:cs typeface="Roboto Mono"/>
               </a:rPr>
-              <a:t>/usr/bin/id</a:t>
+              <a:t>Save output to logs/latest.log</a:t>
             </a:r>
           </a:p>
         </p:txBody>
@@ -26026,7 +26122,7 @@
           <p:nvPr/>
         </p:nvPicPr>
         <p:blipFill rotWithShape="1">
-          <a:blip xmlns:r="http://schemas.openxmlformats.org/officeDocument/2006/relationships" xmlns:a="http://schemas.openxmlformats.org/drawingml/2006/main" r:embed="R27c6ce2808ad42b7">
+          <a:blip xmlns:r="http://schemas.openxmlformats.org/officeDocument/2006/relationships" xmlns:a="http://schemas.openxmlformats.org/drawingml/2006/main" r:embed="R922725c62fc34ad2">
             <a:alphaModFix/>
           </a:blip>
           <a:srcRect xmlns:a="http://schemas.openxmlformats.org/drawingml/2006/main" l="0" t="0" r="0" b="0"/>
@@ -26054,7 +26150,7 @@
           <p:nvPr/>
         </p:nvPicPr>
         <p:blipFill rotWithShape="1">
-          <a:blip xmlns:r="http://schemas.openxmlformats.org/officeDocument/2006/relationships" xmlns:a="http://schemas.openxmlformats.org/drawingml/2006/main" r:embed="R27c6ce2808ad42b7">
+          <a:blip xmlns:r="http://schemas.openxmlformats.org/officeDocument/2006/relationships" xmlns:a="http://schemas.openxmlformats.org/drawingml/2006/main" r:embed="R922725c62fc34ad2">
             <a:alphaModFix/>
           </a:blip>
           <a:srcRect xmlns:a="http://schemas.openxmlformats.org/drawingml/2006/main" l="0" t="0" r="0" b="0"/>
@@ -26082,7 +26178,7 @@
           <p:nvPr/>
         </p:nvPicPr>
         <p:blipFill rotWithShape="1">
-          <a:blip xmlns:r="http://schemas.openxmlformats.org/officeDocument/2006/relationships" xmlns:a="http://schemas.openxmlformats.org/drawingml/2006/main" r:embed="R27c6ce2808ad42b7">
+          <a:blip xmlns:r="http://schemas.openxmlformats.org/officeDocument/2006/relationships" xmlns:a="http://schemas.openxmlformats.org/drawingml/2006/main" r:embed="R922725c62fc34ad2">
             <a:alphaModFix/>
           </a:blip>
           <a:srcRect xmlns:a="http://schemas.openxmlformats.org/drawingml/2006/main" l="0" t="0" r="0" b="0"/>
@@ -26110,7 +26206,7 @@
           <p:nvPr/>
         </p:nvPicPr>
         <p:blipFill rotWithShape="1">
-          <a:blip xmlns:r="http://schemas.openxmlformats.org/officeDocument/2006/relationships" xmlns:a="http://schemas.openxmlformats.org/drawingml/2006/main" r:embed="R27c6ce2808ad42b7">
+          <a:blip xmlns:r="http://schemas.openxmlformats.org/officeDocument/2006/relationships" xmlns:a="http://schemas.openxmlformats.org/drawingml/2006/main" r:embed="R922725c62fc34ad2">
             <a:alphaModFix/>
           </a:blip>
           <a:srcRect xmlns:a="http://schemas.openxmlformats.org/drawingml/2006/main" l="0" t="0" r="0" b="0"/>
@@ -26604,7 +26700,7 @@
                 <a:ea typeface="Inter"/>
                 <a:cs typeface="Inter"/>
               </a:rPr>
-              <a:t>Terminal A: apply a step, then rebuild and capture.</a:t>
+              <a:t>One terminal: apply a step, then run.</a:t>
             </a:r>
           </a:p>
         </p:txBody>
@@ -27851,7 +27947,7 @@
           <p:nvPr/>
         </p:nvPicPr>
         <p:blipFill rotWithShape="1">
-          <a:blip xmlns:r="http://schemas.openxmlformats.org/officeDocument/2006/relationships" xmlns:a="http://schemas.openxmlformats.org/drawingml/2006/main" r:embed="R19b8944e211540a2">
+          <a:blip xmlns:r="http://schemas.openxmlformats.org/officeDocument/2006/relationships" xmlns:a="http://schemas.openxmlformats.org/drawingml/2006/main" r:embed="R16f604880191416a">
             <a:alphaModFix/>
           </a:blip>
           <a:srcRect xmlns:a="http://schemas.openxmlformats.org/drawingml/2006/main" l="0" t="0" r="0" b="0"/>
@@ -27879,7 +27975,7 @@
           <p:nvPr/>
         </p:nvPicPr>
         <p:blipFill rotWithShape="1">
-          <a:blip xmlns:r="http://schemas.openxmlformats.org/officeDocument/2006/relationships" xmlns:a="http://schemas.openxmlformats.org/drawingml/2006/main" r:embed="R19b8944e211540a2">
+          <a:blip xmlns:r="http://schemas.openxmlformats.org/officeDocument/2006/relationships" xmlns:a="http://schemas.openxmlformats.org/drawingml/2006/main" r:embed="R16f604880191416a">
             <a:alphaModFix/>
           </a:blip>
           <a:srcRect xmlns:a="http://schemas.openxmlformats.org/drawingml/2006/main" l="0" t="0" r="0" b="0"/>
@@ -27907,7 +28003,7 @@
           <p:nvPr/>
         </p:nvPicPr>
         <p:blipFill rotWithShape="1">
-          <a:blip xmlns:r="http://schemas.openxmlformats.org/officeDocument/2006/relationships" xmlns:a="http://schemas.openxmlformats.org/drawingml/2006/main" r:embed="R19b8944e211540a2">
+          <a:blip xmlns:r="http://schemas.openxmlformats.org/officeDocument/2006/relationships" xmlns:a="http://schemas.openxmlformats.org/drawingml/2006/main" r:embed="R16f604880191416a">
             <a:alphaModFix/>
           </a:blip>
           <a:srcRect xmlns:a="http://schemas.openxmlformats.org/drawingml/2006/main" l="0" t="0" r="0" b="0"/>
@@ -27935,7 +28031,7 @@
           <p:nvPr/>
         </p:nvPicPr>
         <p:blipFill rotWithShape="1">
-          <a:blip xmlns:r="http://schemas.openxmlformats.org/officeDocument/2006/relationships" xmlns:a="http://schemas.openxmlformats.org/drawingml/2006/main" r:embed="R19b8944e211540a2">
+          <a:blip xmlns:r="http://schemas.openxmlformats.org/officeDocument/2006/relationships" xmlns:a="http://schemas.openxmlformats.org/drawingml/2006/main" r:embed="R16f604880191416a">
             <a:alphaModFix/>
           </a:blip>
           <a:srcRect xmlns:a="http://schemas.openxmlformats.org/drawingml/2006/main" l="0" t="0" r="0" b="0"/>
@@ -28429,7 +28525,7 @@
                 <a:ea typeface="Inter"/>
                 <a:cs typeface="Inter"/>
               </a:rPr>
-              <a:t>Terminal A: apply a step, then rebuild and capture.</a:t>
+              <a:t>One terminal: apply a step, then run.</a:t>
             </a:r>
           </a:p>
         </p:txBody>
@@ -29676,7 +29772,7 @@
           <p:nvPr/>
         </p:nvPicPr>
         <p:blipFill rotWithShape="1">
-          <a:blip xmlns:r="http://schemas.openxmlformats.org/officeDocument/2006/relationships" xmlns:a="http://schemas.openxmlformats.org/drawingml/2006/main" r:embed="R44d2cf2f5e1347a8">
+          <a:blip xmlns:r="http://schemas.openxmlformats.org/officeDocument/2006/relationships" xmlns:a="http://schemas.openxmlformats.org/drawingml/2006/main" r:embed="Ra65a966efd6f41b4">
             <a:alphaModFix/>
           </a:blip>
           <a:srcRect xmlns:a="http://schemas.openxmlformats.org/drawingml/2006/main" l="0" t="0" r="0" b="0"/>
@@ -29704,7 +29800,7 @@
           <p:nvPr/>
         </p:nvPicPr>
         <p:blipFill rotWithShape="1">
-          <a:blip xmlns:r="http://schemas.openxmlformats.org/officeDocument/2006/relationships" xmlns:a="http://schemas.openxmlformats.org/drawingml/2006/main" r:embed="R44d2cf2f5e1347a8">
+          <a:blip xmlns:r="http://schemas.openxmlformats.org/officeDocument/2006/relationships" xmlns:a="http://schemas.openxmlformats.org/drawingml/2006/main" r:embed="Ra65a966efd6f41b4">
             <a:alphaModFix/>
           </a:blip>
           <a:srcRect xmlns:a="http://schemas.openxmlformats.org/drawingml/2006/main" l="0" t="0" r="0" b="0"/>
@@ -29732,7 +29828,7 @@
           <p:nvPr/>
         </p:nvPicPr>
         <p:blipFill rotWithShape="1">
-          <a:blip xmlns:r="http://schemas.openxmlformats.org/officeDocument/2006/relationships" xmlns:a="http://schemas.openxmlformats.org/drawingml/2006/main" r:embed="R44d2cf2f5e1347a8">
+          <a:blip xmlns:r="http://schemas.openxmlformats.org/officeDocument/2006/relationships" xmlns:a="http://schemas.openxmlformats.org/drawingml/2006/main" r:embed="Ra65a966efd6f41b4">
             <a:alphaModFix/>
           </a:blip>
           <a:srcRect xmlns:a="http://schemas.openxmlformats.org/drawingml/2006/main" l="0" t="0" r="0" b="0"/>
@@ -29760,7 +29856,7 @@
           <p:nvPr/>
         </p:nvPicPr>
         <p:blipFill rotWithShape="1">
-          <a:blip xmlns:r="http://schemas.openxmlformats.org/officeDocument/2006/relationships" xmlns:a="http://schemas.openxmlformats.org/drawingml/2006/main" r:embed="R44d2cf2f5e1347a8">
+          <a:blip xmlns:r="http://schemas.openxmlformats.org/officeDocument/2006/relationships" xmlns:a="http://schemas.openxmlformats.org/drawingml/2006/main" r:embed="Ra65a966efd6f41b4">
             <a:alphaModFix/>
           </a:blip>
           <a:srcRect xmlns:a="http://schemas.openxmlformats.org/drawingml/2006/main" l="0" t="0" r="0" b="0"/>
@@ -30358,7 +30454,7 @@
                 <a:ea typeface="Inter"/>
                 <a:cs typeface="Inter"/>
               </a:rPr>
-              <a:t>Run step 1, then run in terminal A.</a:t>
+              <a:t>Run step 1, then run.</a:t>
             </a:r>
           </a:p>
           <a:p xmlns:a="http://schemas.openxmlformats.org/drawingml/2006/main">
@@ -31851,7 +31947,7 @@
           <p:nvPr/>
         </p:nvPicPr>
         <p:blipFill rotWithShape="1">
-          <a:blip xmlns:r="http://schemas.openxmlformats.org/officeDocument/2006/relationships" xmlns:a="http://schemas.openxmlformats.org/drawingml/2006/main" r:embed="Ra0bb4fee1d494946">
+          <a:blip xmlns:r="http://schemas.openxmlformats.org/officeDocument/2006/relationships" xmlns:a="http://schemas.openxmlformats.org/drawingml/2006/main" r:embed="R73909c2681a5438d">
             <a:alphaModFix/>
           </a:blip>
           <a:srcRect xmlns:a="http://schemas.openxmlformats.org/drawingml/2006/main" l="0" t="0" r="0" b="0"/>
@@ -31879,7 +31975,7 @@
           <p:nvPr/>
         </p:nvPicPr>
         <p:blipFill rotWithShape="1">
-          <a:blip xmlns:r="http://schemas.openxmlformats.org/officeDocument/2006/relationships" xmlns:a="http://schemas.openxmlformats.org/drawingml/2006/main" r:embed="Ra0bb4fee1d494946">
+          <a:blip xmlns:r="http://schemas.openxmlformats.org/officeDocument/2006/relationships" xmlns:a="http://schemas.openxmlformats.org/drawingml/2006/main" r:embed="R73909c2681a5438d">
             <a:alphaModFix/>
           </a:blip>
           <a:srcRect xmlns:a="http://schemas.openxmlformats.org/drawingml/2006/main" l="0" t="0" r="0" b="0"/>
@@ -31907,7 +32003,7 @@
           <p:nvPr/>
         </p:nvPicPr>
         <p:blipFill rotWithShape="1">
-          <a:blip xmlns:r="http://schemas.openxmlformats.org/officeDocument/2006/relationships" xmlns:a="http://schemas.openxmlformats.org/drawingml/2006/main" r:embed="Ra0bb4fee1d494946">
+          <a:blip xmlns:r="http://schemas.openxmlformats.org/officeDocument/2006/relationships" xmlns:a="http://schemas.openxmlformats.org/drawingml/2006/main" r:embed="R73909c2681a5438d">
             <a:alphaModFix/>
           </a:blip>
           <a:srcRect xmlns:a="http://schemas.openxmlformats.org/drawingml/2006/main" l="0" t="0" r="0" b="0"/>
@@ -31935,7 +32031,7 @@
           <p:nvPr/>
         </p:nvPicPr>
         <p:blipFill rotWithShape="1">
-          <a:blip xmlns:r="http://schemas.openxmlformats.org/officeDocument/2006/relationships" xmlns:a="http://schemas.openxmlformats.org/drawingml/2006/main" r:embed="Ra0bb4fee1d494946">
+          <a:blip xmlns:r="http://schemas.openxmlformats.org/officeDocument/2006/relationships" xmlns:a="http://schemas.openxmlformats.org/drawingml/2006/main" r:embed="R73909c2681a5438d">
             <a:alphaModFix/>
           </a:blip>
           <a:srcRect xmlns:a="http://schemas.openxmlformats.org/drawingml/2006/main" l="0" t="0" r="0" b="0"/>
@@ -32533,7 +32629,7 @@
                 <a:ea typeface="Inter"/>
                 <a:cs typeface="Inter"/>
               </a:rPr>
-              <a:t>Run step 2, then run in terminal A.</a:t>
+              <a:t>Run step 2, then run.</a:t>
             </a:r>
           </a:p>
           <a:p xmlns:a="http://schemas.openxmlformats.org/drawingml/2006/main">
@@ -33914,7 +34010,7 @@
           <p:nvPr/>
         </p:nvPicPr>
         <p:blipFill rotWithShape="1">
-          <a:blip xmlns:r="http://schemas.openxmlformats.org/officeDocument/2006/relationships" xmlns:a="http://schemas.openxmlformats.org/drawingml/2006/main" r:embed="R169be8fad3ba439f">
+          <a:blip xmlns:r="http://schemas.openxmlformats.org/officeDocument/2006/relationships" xmlns:a="http://schemas.openxmlformats.org/drawingml/2006/main" r:embed="Rbf390aaed5564de1">
             <a:alphaModFix/>
           </a:blip>
           <a:srcRect xmlns:a="http://schemas.openxmlformats.org/drawingml/2006/main" l="0" t="0" r="0" b="0"/>
@@ -33942,7 +34038,7 @@
           <p:nvPr/>
         </p:nvPicPr>
         <p:blipFill rotWithShape="1">
-          <a:blip xmlns:r="http://schemas.openxmlformats.org/officeDocument/2006/relationships" xmlns:a="http://schemas.openxmlformats.org/drawingml/2006/main" r:embed="R169be8fad3ba439f">
+          <a:blip xmlns:r="http://schemas.openxmlformats.org/officeDocument/2006/relationships" xmlns:a="http://schemas.openxmlformats.org/drawingml/2006/main" r:embed="Rbf390aaed5564de1">
             <a:alphaModFix/>
           </a:blip>
           <a:srcRect xmlns:a="http://schemas.openxmlformats.org/drawingml/2006/main" l="0" t="0" r="0" b="0"/>
@@ -33970,7 +34066,7 @@
           <p:nvPr/>
         </p:nvPicPr>
         <p:blipFill rotWithShape="1">
-          <a:blip xmlns:r="http://schemas.openxmlformats.org/officeDocument/2006/relationships" xmlns:a="http://schemas.openxmlformats.org/drawingml/2006/main" r:embed="R169be8fad3ba439f">
+          <a:blip xmlns:r="http://schemas.openxmlformats.org/officeDocument/2006/relationships" xmlns:a="http://schemas.openxmlformats.org/drawingml/2006/main" r:embed="Rbf390aaed5564de1">
             <a:alphaModFix/>
           </a:blip>
           <a:srcRect xmlns:a="http://schemas.openxmlformats.org/drawingml/2006/main" l="0" t="0" r="0" b="0"/>
@@ -33998,7 +34094,7 @@
           <p:nvPr/>
         </p:nvPicPr>
         <p:blipFill rotWithShape="1">
-          <a:blip xmlns:r="http://schemas.openxmlformats.org/officeDocument/2006/relationships" xmlns:a="http://schemas.openxmlformats.org/drawingml/2006/main" r:embed="R169be8fad3ba439f">
+          <a:blip xmlns:r="http://schemas.openxmlformats.org/officeDocument/2006/relationships" xmlns:a="http://schemas.openxmlformats.org/drawingml/2006/main" r:embed="Rbf390aaed5564de1">
             <a:alphaModFix/>
           </a:blip>
           <a:srcRect xmlns:a="http://schemas.openxmlformats.org/drawingml/2006/main" l="0" t="0" r="0" b="0"/>

</xml_diff>

<commit_message>
Teach event printing before filtering in the workshop slides
</commit_message>
<xml_diff>
--- a/presentation/falco-libs-intro.pptx
+++ b/presentation/falco-libs-intro.pptx
@@ -2,78 +2,78 @@
 <file path=ppt/presentation.xml><?xml version="1.0" encoding="utf-8"?>
 <p:presentation xmlns:p="http://schemas.openxmlformats.org/presentationml/2006/main" embedTrueTypeFonts="1" saveSubsetFonts="0">
   <p:sldMasterIdLst>
-    <p:sldMasterId xmlns:r="http://schemas.openxmlformats.org/officeDocument/2006/relationships" id="2147483648" r:id="Rd85cd16d91f14c55"/>
-    <p:sldMasterId xmlns:r="http://schemas.openxmlformats.org/officeDocument/2006/relationships" id="2147483661" r:id="R0d11a653496d47d3"/>
+    <p:sldMasterId xmlns:r="http://schemas.openxmlformats.org/officeDocument/2006/relationships" id="2147483648" r:id="R21652c24a2b3485e"/>
+    <p:sldMasterId xmlns:r="http://schemas.openxmlformats.org/officeDocument/2006/relationships" id="2147483661" r:id="Rf5c5503133cd4df4"/>
   </p:sldMasterIdLst>
   <p:notesMasterIdLst>
-    <p:notesMasterId xmlns:r="http://schemas.openxmlformats.org/officeDocument/2006/relationships" r:id="R4b8a3ccd23344cf8"/>
+    <p:notesMasterId xmlns:r="http://schemas.openxmlformats.org/officeDocument/2006/relationships" r:id="Raa0952c61f644b88"/>
   </p:notesMasterIdLst>
   <p:sldIdLst>
-    <p:sldId xmlns:r="http://schemas.openxmlformats.org/officeDocument/2006/relationships" id="256" r:id="Rb0b47d9ef90e4170"/>
-    <p:sldId xmlns:r="http://schemas.openxmlformats.org/officeDocument/2006/relationships" id="257" r:id="R1be6fe2d45fb427e"/>
-    <p:sldId xmlns:r="http://schemas.openxmlformats.org/officeDocument/2006/relationships" id="258" r:id="R59880a81ab3444f8"/>
-    <p:sldId xmlns:r="http://schemas.openxmlformats.org/officeDocument/2006/relationships" id="259" r:id="Rfe07b76f99034a1f"/>
-    <p:sldId xmlns:r="http://schemas.openxmlformats.org/officeDocument/2006/relationships" id="260" r:id="Rff2de941d79847ea"/>
-    <p:sldId xmlns:r="http://schemas.openxmlformats.org/officeDocument/2006/relationships" id="261" r:id="Reab64a419eee4339"/>
-    <p:sldId xmlns:r="http://schemas.openxmlformats.org/officeDocument/2006/relationships" id="262" r:id="R1e2064110b3c40bc"/>
-    <p:sldId xmlns:r="http://schemas.openxmlformats.org/officeDocument/2006/relationships" id="263" r:id="Rb922d8afbd9848bc"/>
-    <p:sldId xmlns:r="http://schemas.openxmlformats.org/officeDocument/2006/relationships" id="264" r:id="Ref54e281e5d74b71"/>
-    <p:sldId xmlns:r="http://schemas.openxmlformats.org/officeDocument/2006/relationships" id="265" r:id="R4a1f63489d7240ff"/>
-    <p:sldId xmlns:r="http://schemas.openxmlformats.org/officeDocument/2006/relationships" id="266" r:id="Rd6da56e5d90840b4"/>
-    <p:sldId xmlns:r="http://schemas.openxmlformats.org/officeDocument/2006/relationships" id="267" r:id="R010f647577bd4174"/>
-    <p:sldId xmlns:r="http://schemas.openxmlformats.org/officeDocument/2006/relationships" id="268" r:id="R1dc9809c155e4951"/>
-    <p:sldId xmlns:r="http://schemas.openxmlformats.org/officeDocument/2006/relationships" id="269" r:id="R07c86e6f4b9a4e90"/>
+    <p:sldId xmlns:r="http://schemas.openxmlformats.org/officeDocument/2006/relationships" id="256" r:id="R0b562d231af846d9"/>
+    <p:sldId xmlns:r="http://schemas.openxmlformats.org/officeDocument/2006/relationships" id="257" r:id="R57b06066b5e84cf3"/>
+    <p:sldId xmlns:r="http://schemas.openxmlformats.org/officeDocument/2006/relationships" id="258" r:id="R5ac950ef931745fd"/>
+    <p:sldId xmlns:r="http://schemas.openxmlformats.org/officeDocument/2006/relationships" id="259" r:id="R0c6a77d642054afd"/>
+    <p:sldId xmlns:r="http://schemas.openxmlformats.org/officeDocument/2006/relationships" id="260" r:id="Rc93ebd7a13ba4439"/>
+    <p:sldId xmlns:r="http://schemas.openxmlformats.org/officeDocument/2006/relationships" id="261" r:id="R3c3dc0f8fe6540a0"/>
+    <p:sldId xmlns:r="http://schemas.openxmlformats.org/officeDocument/2006/relationships" id="262" r:id="Rcdf0eaefb4374802"/>
+    <p:sldId xmlns:r="http://schemas.openxmlformats.org/officeDocument/2006/relationships" id="263" r:id="R61b684543fa04501"/>
+    <p:sldId xmlns:r="http://schemas.openxmlformats.org/officeDocument/2006/relationships" id="264" r:id="Rfee553c8f5fe481b"/>
+    <p:sldId xmlns:r="http://schemas.openxmlformats.org/officeDocument/2006/relationships" id="265" r:id="Rdc8cde017416422f"/>
+    <p:sldId xmlns:r="http://schemas.openxmlformats.org/officeDocument/2006/relationships" id="266" r:id="R3ba053c5f390485a"/>
+    <p:sldId xmlns:r="http://schemas.openxmlformats.org/officeDocument/2006/relationships" id="267" r:id="Rd73c2dffa8a84aa3"/>
+    <p:sldId xmlns:r="http://schemas.openxmlformats.org/officeDocument/2006/relationships" id="268" r:id="R1f0b57b2052d4276"/>
+    <p:sldId xmlns:r="http://schemas.openxmlformats.org/officeDocument/2006/relationships" id="269" r:id="R31f586d47f9b496e"/>
   </p:sldIdLst>
   <p:sldSz cx="9144000" cy="5143500"/>
   <p:notesSz cx="6858000" cy="9144000"/>
   <p:embeddedFontLst>
     <p:embeddedFont>
       <p:font typeface="Roboto Mono Medium"/>
-      <p:regular xmlns:r="http://schemas.openxmlformats.org/officeDocument/2006/relationships" r:id="Re09040c686f042f1"/>
-      <p:bold xmlns:r="http://schemas.openxmlformats.org/officeDocument/2006/relationships" r:id="R0960b0c89f4340e8"/>
-      <p:italic xmlns:r="http://schemas.openxmlformats.org/officeDocument/2006/relationships" r:id="Rf27f2a5031f54034"/>
-      <p:boldItalic xmlns:r="http://schemas.openxmlformats.org/officeDocument/2006/relationships" r:id="R3ece3d2a58974aec"/>
+      <p:regular xmlns:r="http://schemas.openxmlformats.org/officeDocument/2006/relationships" r:id="Rc60efa67d81743ee"/>
+      <p:bold xmlns:r="http://schemas.openxmlformats.org/officeDocument/2006/relationships" r:id="Raab3d96778f74ff2"/>
+      <p:italic xmlns:r="http://schemas.openxmlformats.org/officeDocument/2006/relationships" r:id="R479b0283f33b48d3"/>
+      <p:boldItalic xmlns:r="http://schemas.openxmlformats.org/officeDocument/2006/relationships" r:id="R85dd1d6092a74e22"/>
     </p:embeddedFont>
     <p:embeddedFont>
       <p:font typeface="Inter SemiBold"/>
-      <p:regular xmlns:r="http://schemas.openxmlformats.org/officeDocument/2006/relationships" r:id="R4c9f8d2352344e67"/>
-      <p:bold xmlns:r="http://schemas.openxmlformats.org/officeDocument/2006/relationships" r:id="R68b6dc238ced4dcb"/>
-      <p:italic xmlns:r="http://schemas.openxmlformats.org/officeDocument/2006/relationships" r:id="R011034475262435a"/>
-      <p:boldItalic xmlns:r="http://schemas.openxmlformats.org/officeDocument/2006/relationships" r:id="R0e6c2be2ee204c72"/>
+      <p:regular xmlns:r="http://schemas.openxmlformats.org/officeDocument/2006/relationships" r:id="R4b0fb6936f1c4426"/>
+      <p:bold xmlns:r="http://schemas.openxmlformats.org/officeDocument/2006/relationships" r:id="Ref340476d70b4a11"/>
+      <p:italic xmlns:r="http://schemas.openxmlformats.org/officeDocument/2006/relationships" r:id="Ra3f84d62920b4e64"/>
+      <p:boldItalic xmlns:r="http://schemas.openxmlformats.org/officeDocument/2006/relationships" r:id="R0a2ed9dc087d4a35"/>
     </p:embeddedFont>
     <p:embeddedFont>
       <p:font typeface="Montserrat Black"/>
-      <p:bold xmlns:r="http://schemas.openxmlformats.org/officeDocument/2006/relationships" r:id="Rd3b426f8e1c847e7"/>
-      <p:boldItalic xmlns:r="http://schemas.openxmlformats.org/officeDocument/2006/relationships" r:id="R369dcff0a2ae4a76"/>
+      <p:bold xmlns:r="http://schemas.openxmlformats.org/officeDocument/2006/relationships" r:id="Rdf24b5b687c6493c"/>
+      <p:boldItalic xmlns:r="http://schemas.openxmlformats.org/officeDocument/2006/relationships" r:id="Ra7c17eefa4e04542"/>
     </p:embeddedFont>
     <p:embeddedFont>
       <p:font typeface="Montserrat"/>
-      <p:bold xmlns:r="http://schemas.openxmlformats.org/officeDocument/2006/relationships" r:id="Re8b8f48dcea64ee4"/>
-      <p:boldItalic xmlns:r="http://schemas.openxmlformats.org/officeDocument/2006/relationships" r:id="Re698ef650f5045eb"/>
+      <p:bold xmlns:r="http://schemas.openxmlformats.org/officeDocument/2006/relationships" r:id="R7cec4a7c2cf54b27"/>
+      <p:boldItalic xmlns:r="http://schemas.openxmlformats.org/officeDocument/2006/relationships" r:id="R3835143f2ac54bee"/>
     </p:embeddedFont>
     <p:embeddedFont>
       <p:font typeface="Inter"/>
-      <p:regular xmlns:r="http://schemas.openxmlformats.org/officeDocument/2006/relationships" r:id="Rb6ae8508a10444d8"/>
-      <p:bold xmlns:r="http://schemas.openxmlformats.org/officeDocument/2006/relationships" r:id="R9c5110cc03f24d53"/>
-      <p:italic xmlns:r="http://schemas.openxmlformats.org/officeDocument/2006/relationships" r:id="Re7c7a11c2268481e"/>
-      <p:boldItalic xmlns:r="http://schemas.openxmlformats.org/officeDocument/2006/relationships" r:id="Rfa7a3b0fd0a74084"/>
+      <p:regular xmlns:r="http://schemas.openxmlformats.org/officeDocument/2006/relationships" r:id="R09f15da8252040c1"/>
+      <p:bold xmlns:r="http://schemas.openxmlformats.org/officeDocument/2006/relationships" r:id="Rc59a77af749f45b5"/>
+      <p:italic xmlns:r="http://schemas.openxmlformats.org/officeDocument/2006/relationships" r:id="R1fead72e3c344fb9"/>
+      <p:boldItalic xmlns:r="http://schemas.openxmlformats.org/officeDocument/2006/relationships" r:id="Rb81459eb726d4c62"/>
     </p:embeddedFont>
     <p:embeddedFont>
       <p:font typeface="Montserrat ExtraBold"/>
-      <p:bold xmlns:r="http://schemas.openxmlformats.org/officeDocument/2006/relationships" r:id="R8cad0c3452014342"/>
-      <p:boldItalic xmlns:r="http://schemas.openxmlformats.org/officeDocument/2006/relationships" r:id="Rdbf1b5a140bd41d9"/>
+      <p:bold xmlns:r="http://schemas.openxmlformats.org/officeDocument/2006/relationships" r:id="Rb025534c149947aa"/>
+      <p:boldItalic xmlns:r="http://schemas.openxmlformats.org/officeDocument/2006/relationships" r:id="R35ee2bfe1fbc4c19"/>
     </p:embeddedFont>
     <p:embeddedFont>
       <p:font typeface="Roboto Mono"/>
-      <p:bold xmlns:r="http://schemas.openxmlformats.org/officeDocument/2006/relationships" r:id="R687e21569cbe4b1f"/>
-      <p:boldItalic xmlns:r="http://schemas.openxmlformats.org/officeDocument/2006/relationships" r:id="R3fb55581869245fd"/>
+      <p:bold xmlns:r="http://schemas.openxmlformats.org/officeDocument/2006/relationships" r:id="R543ac1b21864449d"/>
+      <p:boldItalic xmlns:r="http://schemas.openxmlformats.org/officeDocument/2006/relationships" r:id="Rd10bec77a85448cd"/>
     </p:embeddedFont>
     <p:embeddedFont>
       <p:font typeface="Inter Medium"/>
-      <p:regular xmlns:r="http://schemas.openxmlformats.org/officeDocument/2006/relationships" r:id="Rce996f5bfad94027"/>
-      <p:bold xmlns:r="http://schemas.openxmlformats.org/officeDocument/2006/relationships" r:id="R62d1214259a44dd1"/>
-      <p:italic xmlns:r="http://schemas.openxmlformats.org/officeDocument/2006/relationships" r:id="R98ef55768df9498f"/>
-      <p:boldItalic xmlns:r="http://schemas.openxmlformats.org/officeDocument/2006/relationships" r:id="R29f00211f75e4240"/>
+      <p:regular xmlns:r="http://schemas.openxmlformats.org/officeDocument/2006/relationships" r:id="R176f45e0408a45a9"/>
+      <p:bold xmlns:r="http://schemas.openxmlformats.org/officeDocument/2006/relationships" r:id="R33c901003b5c455b"/>
+      <p:italic xmlns:r="http://schemas.openxmlformats.org/officeDocument/2006/relationships" r:id="R86bb325e0d2a448c"/>
+      <p:boldItalic xmlns:r="http://schemas.openxmlformats.org/officeDocument/2006/relationships" r:id="Rd1cc28c80ab74e43"/>
     </p:embeddedFont>
   </p:embeddedFontLst>
 </p:presentation>
@@ -618,7 +618,7 @@
               <a:buNone/>
             </a:pPr>
             <a:r>
-              <a:t>This continues the code installed by step 2. The count is events delivered successfully to this application, not a count of all syscalls on the machine. This first unfiltered run sees background activity. The runner automatically executes /usr/bin/id after attachment. The generated agent also explains that individual events are not printed yet. This slide abbreviates the summary string to fit. SCAP_EOF is included for correct status handling; a live stream normally ends because the ten-second deadline expires. Source: https://github.com/falcosecurity/libs/blob/e72873882967cdd86b8753eca09ea3e9f91ccd4a/userspace/libsinsp/sinsp.h</a:t>
+              <a:t>This continues the code installed by step 2. The count is events delivered successfully to this application, not a count of all syscalls on the machine. This first unfiltered run sees background activity. The runner automatically executes /usr/bin/id after attachment. Each successful read prints the event name. Printing starts in step 2, before filtering in step 3. The final summary counts events delivered to the application. SCAP_EOF is included for correct status handling; a live stream normally ends because the ten-second deadline expires. Source: https://github.com/falcosecurity/libs/blob/e72873882967cdd86b8753eca09ea3e9f91ccd4a/userspace/libsinsp/sinsp.h</a:t>
             </a:r>
             <a:endParaRPr/>
           </a:p>
@@ -5746,18 +5746,18 @@
   </p:cSld>
   <p:clrMap bg1="lt1" tx1="dk1" bg2="dk2" tx2="lt2" accent1="accent1" accent2="accent2" accent3="accent3" accent4="accent4" accent5="accent5" accent6="accent6" hlink="hlink" folHlink="folHlink"/>
   <p:sldLayoutIdLst>
-    <p:sldLayoutId xmlns:r="http://schemas.openxmlformats.org/officeDocument/2006/relationships" id="2147483649" r:id="Ra616ffce37244e1b"/>
-    <p:sldLayoutId xmlns:r="http://schemas.openxmlformats.org/officeDocument/2006/relationships" id="2147483650" r:id="R2a514a03a9824031"/>
-    <p:sldLayoutId xmlns:r="http://schemas.openxmlformats.org/officeDocument/2006/relationships" id="2147483651" r:id="Ra7db9a43b147454d"/>
-    <p:sldLayoutId xmlns:r="http://schemas.openxmlformats.org/officeDocument/2006/relationships" id="2147483652" r:id="R8ddcb0953c874eef"/>
-    <p:sldLayoutId xmlns:r="http://schemas.openxmlformats.org/officeDocument/2006/relationships" id="2147483653" r:id="R383f74551a804eab"/>
-    <p:sldLayoutId xmlns:r="http://schemas.openxmlformats.org/officeDocument/2006/relationships" id="2147483654" r:id="Re4add2688e784cea"/>
-    <p:sldLayoutId xmlns:r="http://schemas.openxmlformats.org/officeDocument/2006/relationships" id="2147483655" r:id="R301c9059649c45c4"/>
-    <p:sldLayoutId xmlns:r="http://schemas.openxmlformats.org/officeDocument/2006/relationships" id="2147483656" r:id="Re8e84c9b78c14be9"/>
-    <p:sldLayoutId xmlns:r="http://schemas.openxmlformats.org/officeDocument/2006/relationships" id="2147483657" r:id="R7a6eb87855584b05"/>
-    <p:sldLayoutId xmlns:r="http://schemas.openxmlformats.org/officeDocument/2006/relationships" id="2147483658" r:id="Rdb1a6bc8c807424b"/>
-    <p:sldLayoutId xmlns:r="http://schemas.openxmlformats.org/officeDocument/2006/relationships" id="2147483659" r:id="R6a6d504dce4c4bab"/>
-    <p:sldLayoutId xmlns:r="http://schemas.openxmlformats.org/officeDocument/2006/relationships" id="2147483660" r:id="R386de4c90e3c4090"/>
+    <p:sldLayoutId xmlns:r="http://schemas.openxmlformats.org/officeDocument/2006/relationships" id="2147483649" r:id="R958a961fedad4d19"/>
+    <p:sldLayoutId xmlns:r="http://schemas.openxmlformats.org/officeDocument/2006/relationships" id="2147483650" r:id="Rbf0d52c28d754c00"/>
+    <p:sldLayoutId xmlns:r="http://schemas.openxmlformats.org/officeDocument/2006/relationships" id="2147483651" r:id="R1aba7f0192b548a0"/>
+    <p:sldLayoutId xmlns:r="http://schemas.openxmlformats.org/officeDocument/2006/relationships" id="2147483652" r:id="R7b7d1d8d49cb4d75"/>
+    <p:sldLayoutId xmlns:r="http://schemas.openxmlformats.org/officeDocument/2006/relationships" id="2147483653" r:id="R388e3aeb4b1749ae"/>
+    <p:sldLayoutId xmlns:r="http://schemas.openxmlformats.org/officeDocument/2006/relationships" id="2147483654" r:id="Rb6c6cbadb6824c2a"/>
+    <p:sldLayoutId xmlns:r="http://schemas.openxmlformats.org/officeDocument/2006/relationships" id="2147483655" r:id="Rb1c47666ec364c7f"/>
+    <p:sldLayoutId xmlns:r="http://schemas.openxmlformats.org/officeDocument/2006/relationships" id="2147483656" r:id="Ra271fc4b0c14460f"/>
+    <p:sldLayoutId xmlns:r="http://schemas.openxmlformats.org/officeDocument/2006/relationships" id="2147483657" r:id="R00f3443832344c1e"/>
+    <p:sldLayoutId xmlns:r="http://schemas.openxmlformats.org/officeDocument/2006/relationships" id="2147483658" r:id="R1adfdff0c9914306"/>
+    <p:sldLayoutId xmlns:r="http://schemas.openxmlformats.org/officeDocument/2006/relationships" id="2147483659" r:id="R21ac7d7df8c845ce"/>
+    <p:sldLayoutId xmlns:r="http://schemas.openxmlformats.org/officeDocument/2006/relationships" id="2147483660" r:id="Rdfaf91be90494a77"/>
   </p:sldLayoutIdLst>
   <p:hf sldNum="0" hdr="0" ftr="0" dt="0"/>
   <p:txStyles>
@@ -6442,7 +6442,7 @@
   </p:cSld>
   <p:clrMap bg1="lt1" tx1="dk1" bg2="dk2" tx2="lt2" accent1="accent1" accent2="accent2" accent3="accent3" accent4="accent4" accent5="accent5" accent6="accent6" hlink="hlink" folHlink="folHlink"/>
   <p:sldLayoutIdLst>
-    <p:sldLayoutId xmlns:r="http://schemas.openxmlformats.org/officeDocument/2006/relationships" id="2147483662" r:id="R12f422d90ebb4a68"/>
+    <p:sldLayoutId xmlns:r="http://schemas.openxmlformats.org/officeDocument/2006/relationships" id="2147483662" r:id="Ra3259ddcef174e4a"/>
   </p:sldLayoutIdLst>
   <p:hf sldNum="0" hdr="0" ftr="0" dt="0"/>
   <p:txStyles>
@@ -8291,7 +8291,7 @@
           <p:nvPr/>
         </p:nvPicPr>
         <p:blipFill rotWithShape="1">
-          <a:blip xmlns:r="http://schemas.openxmlformats.org/officeDocument/2006/relationships" xmlns:a="http://schemas.openxmlformats.org/drawingml/2006/main" r:embed="R21981d91f6bd4191">
+          <a:blip xmlns:r="http://schemas.openxmlformats.org/officeDocument/2006/relationships" xmlns:a="http://schemas.openxmlformats.org/drawingml/2006/main" r:embed="R92664d9438964990">
             <a:alphaModFix/>
           </a:blip>
           <a:srcRect xmlns:a="http://schemas.openxmlformats.org/drawingml/2006/main" l="0" t="0" r="0" b="0"/>
@@ -8319,7 +8319,7 @@
           <p:nvPr/>
         </p:nvPicPr>
         <p:blipFill rotWithShape="1">
-          <a:blip xmlns:r="http://schemas.openxmlformats.org/officeDocument/2006/relationships" xmlns:a="http://schemas.openxmlformats.org/drawingml/2006/main" r:embed="R21981d91f6bd4191">
+          <a:blip xmlns:r="http://schemas.openxmlformats.org/officeDocument/2006/relationships" xmlns:a="http://schemas.openxmlformats.org/drawingml/2006/main" r:embed="R92664d9438964990">
             <a:alphaModFix/>
           </a:blip>
           <a:srcRect xmlns:a="http://schemas.openxmlformats.org/drawingml/2006/main" l="0" t="0" r="0" b="0"/>
@@ -8347,7 +8347,7 @@
           <p:nvPr/>
         </p:nvPicPr>
         <p:blipFill rotWithShape="1">
-          <a:blip xmlns:r="http://schemas.openxmlformats.org/officeDocument/2006/relationships" xmlns:a="http://schemas.openxmlformats.org/drawingml/2006/main" r:embed="R21981d91f6bd4191">
+          <a:blip xmlns:r="http://schemas.openxmlformats.org/officeDocument/2006/relationships" xmlns:a="http://schemas.openxmlformats.org/drawingml/2006/main" r:embed="R92664d9438964990">
             <a:alphaModFix/>
           </a:blip>
           <a:srcRect xmlns:a="http://schemas.openxmlformats.org/drawingml/2006/main" l="0" t="0" r="0" b="0"/>
@@ -8375,7 +8375,7 @@
           <p:nvPr/>
         </p:nvPicPr>
         <p:blipFill rotWithShape="1">
-          <a:blip xmlns:r="http://schemas.openxmlformats.org/officeDocument/2006/relationships" xmlns:a="http://schemas.openxmlformats.org/drawingml/2006/main" r:embed="R21981d91f6bd4191">
+          <a:blip xmlns:r="http://schemas.openxmlformats.org/officeDocument/2006/relationships" xmlns:a="http://schemas.openxmlformats.org/drawingml/2006/main" r:embed="R92664d9438964990">
             <a:alphaModFix/>
           </a:blip>
           <a:srcRect xmlns:a="http://schemas.openxmlformats.org/drawingml/2006/main" l="0" t="0" r="0" b="0"/>
@@ -8403,7 +8403,7 @@
           <p:nvPr/>
         </p:nvPicPr>
         <p:blipFill rotWithShape="1">
-          <a:blip xmlns:r="http://schemas.openxmlformats.org/officeDocument/2006/relationships" xmlns:a="http://schemas.openxmlformats.org/drawingml/2006/main" r:embed="R21981d91f6bd4191">
+          <a:blip xmlns:r="http://schemas.openxmlformats.org/officeDocument/2006/relationships" xmlns:a="http://schemas.openxmlformats.org/drawingml/2006/main" r:embed="R92664d9438964990">
             <a:alphaModFix/>
           </a:blip>
           <a:srcRect xmlns:a="http://schemas.openxmlformats.org/drawingml/2006/main" l="0" t="0" r="0" b="0"/>
@@ -8431,7 +8431,7 @@
           <p:nvPr/>
         </p:nvPicPr>
         <p:blipFill rotWithShape="1">
-          <a:blip xmlns:r="http://schemas.openxmlformats.org/officeDocument/2006/relationships" xmlns:a="http://schemas.openxmlformats.org/drawingml/2006/main" r:embed="R21981d91f6bd4191">
+          <a:blip xmlns:r="http://schemas.openxmlformats.org/officeDocument/2006/relationships" xmlns:a="http://schemas.openxmlformats.org/drawingml/2006/main" r:embed="R92664d9438964990">
             <a:alphaModFix/>
           </a:blip>
           <a:srcRect xmlns:a="http://schemas.openxmlformats.org/drawingml/2006/main" l="0" t="0" r="0" b="0"/>
@@ -8459,7 +8459,7 @@
           <p:nvPr/>
         </p:nvPicPr>
         <p:blipFill rotWithShape="1">
-          <a:blip xmlns:r="http://schemas.openxmlformats.org/officeDocument/2006/relationships" xmlns:a="http://schemas.openxmlformats.org/drawingml/2006/main" r:embed="R21981d91f6bd4191">
+          <a:blip xmlns:r="http://schemas.openxmlformats.org/officeDocument/2006/relationships" xmlns:a="http://schemas.openxmlformats.org/drawingml/2006/main" r:embed="R92664d9438964990">
             <a:alphaModFix/>
           </a:blip>
           <a:srcRect xmlns:a="http://schemas.openxmlformats.org/drawingml/2006/main" l="0" t="0" r="0" b="0"/>
@@ -8487,7 +8487,7 @@
           <p:nvPr/>
         </p:nvPicPr>
         <p:blipFill rotWithShape="1">
-          <a:blip xmlns:r="http://schemas.openxmlformats.org/officeDocument/2006/relationships" xmlns:a="http://schemas.openxmlformats.org/drawingml/2006/main" r:embed="R21981d91f6bd4191">
+          <a:blip xmlns:r="http://schemas.openxmlformats.org/officeDocument/2006/relationships" xmlns:a="http://schemas.openxmlformats.org/drawingml/2006/main" r:embed="R92664d9438964990">
             <a:alphaModFix/>
           </a:blip>
           <a:srcRect xmlns:a="http://schemas.openxmlformats.org/drawingml/2006/main" l="0" t="0" r="0" b="0"/>
@@ -9091,7 +9091,7 @@
                 <a:ea typeface="Montserrat"/>
                 <a:cs typeface="Montserrat"/>
               </a:rPr>
-              <a:t>Step 2: Count the returned events</a:t>
+              <a:t>Step 2: Print the returned events</a:t>
             </a:r>
           </a:p>
         </p:txBody>
@@ -9363,7 +9363,7 @@
                 <a:ea typeface="Inter"/>
                 <a:cs typeface="Inter"/>
               </a:rPr>
-              <a:t>Events reach user space. This step prints only their count, not each event.</a:t>
+              <a:t>Print each event name. Expect lots of output before adding a filter.</a:t>
             </a:r>
           </a:p>
         </p:txBody>
@@ -10050,7 +10050,37 @@
                 <a:ea typeface="Roboto Mono"/>
                 <a:cs typeface="Roboto Mono"/>
               </a:rPr>
-              <a:t>    // STEP 4 goes here later.</a:t>
+              <a:t>    std::cout &lt;&lt; event-&gt;get_name()</a:t>
+            </a:r>
+          </a:p>
+          <a:p xmlns:a="http://schemas.openxmlformats.org/drawingml/2006/main">
+            <a:pPr marL="0" indent="0" algn="l">
+              <a:spcBef>
+                <a:spcPts val="0"/>
+              </a:spcBef>
+              <a:spcAft>
+                <a:spcPts val="0"/>
+              </a:spcAft>
+              <a:buNone/>
+              <a:defRPr sz="1200" b="0">
+                <a:solidFill>
+                  <a:srgbClr val="00E5FF"/>
+                </a:solidFill>
+                <a:latin typeface="Roboto Mono"/>
+                <a:ea typeface="Roboto Mono"/>
+                <a:cs typeface="Roboto Mono"/>
+              </a:defRPr>
+            </a:pPr>
+            <a:r>
+              <a:rPr sz="1200" b="0" i="0">
+                <a:solidFill>
+                  <a:srgbClr val="00E5FF"/>
+                </a:solidFill>
+                <a:latin typeface="Roboto Mono"/>
+                <a:ea typeface="Roboto Mono"/>
+                <a:cs typeface="Roboto Mono"/>
+              </a:rPr>
+              <a:t>              &lt;&lt; '\n';</a:t>
             </a:r>
           </a:p>
           <a:p xmlns:a="http://schemas.openxmlformats.org/drawingml/2006/main">
@@ -10081,96 +10111,6 @@
                 <a:cs typeface="Roboto Mono"/>
               </a:rPr>
               <a:t>}</a:t>
-            </a:r>
-          </a:p>
-          <a:p xmlns:a="http://schemas.openxmlformats.org/drawingml/2006/main">
-            <a:pPr marL="0" indent="0" algn="l">
-              <a:spcBef>
-                <a:spcPts val="0"/>
-              </a:spcBef>
-              <a:spcAft>
-                <a:spcPts val="0"/>
-              </a:spcAft>
-              <a:buNone/>
-              <a:defRPr sz="1200" b="0">
-                <a:solidFill>
-                  <a:srgbClr val="00E5FF"/>
-                </a:solidFill>
-                <a:latin typeface="Roboto Mono"/>
-                <a:ea typeface="Roboto Mono"/>
-                <a:cs typeface="Roboto Mono"/>
-              </a:defRPr>
-            </a:pPr>
-            <a:r>
-              <a:rPr sz="1200" b="0" i="0">
-                <a:solidFill>
-                  <a:srgbClr val="00E5FF"/>
-                </a:solidFill>
-                <a:latin typeface="Roboto Mono"/>
-                <a:ea typeface="Roboto Mono"/>
-                <a:cs typeface="Roboto Mono"/>
-              </a:rPr>
-              <a:t>std::cout &lt;&lt; "Read " &lt;&lt; received</a:t>
-            </a:r>
-          </a:p>
-          <a:p xmlns:a="http://schemas.openxmlformats.org/drawingml/2006/main">
-            <a:pPr marL="0" indent="0" algn="l">
-              <a:spcBef>
-                <a:spcPts val="0"/>
-              </a:spcBef>
-              <a:spcAft>
-                <a:spcPts val="0"/>
-              </a:spcAft>
-              <a:buNone/>
-              <a:defRPr sz="1200" b="0">
-                <a:solidFill>
-                  <a:srgbClr val="00E5FF"/>
-                </a:solidFill>
-                <a:latin typeface="Roboto Mono"/>
-                <a:ea typeface="Roboto Mono"/>
-                <a:cs typeface="Roboto Mono"/>
-              </a:defRPr>
-            </a:pPr>
-            <a:r>
-              <a:rPr sz="1200" b="0" i="0">
-                <a:solidFill>
-                  <a:srgbClr val="00E5FF"/>
-                </a:solidFill>
-                <a:latin typeface="Roboto Mono"/>
-                <a:ea typeface="Roboto Mono"/>
-                <a:cs typeface="Roboto Mono"/>
-              </a:rPr>
-              <a:t>          &lt;&lt; " events into user space."</a:t>
-            </a:r>
-          </a:p>
-          <a:p xmlns:a="http://schemas.openxmlformats.org/drawingml/2006/main">
-            <a:pPr marL="0" indent="0" algn="l">
-              <a:spcBef>
-                <a:spcPts val="0"/>
-              </a:spcBef>
-              <a:spcAft>
-                <a:spcPts val="0"/>
-              </a:spcAft>
-              <a:buNone/>
-              <a:defRPr sz="1200" b="0">
-                <a:solidFill>
-                  <a:srgbClr val="00E5FF"/>
-                </a:solidFill>
-                <a:latin typeface="Roboto Mono"/>
-                <a:ea typeface="Roboto Mono"/>
-                <a:cs typeface="Roboto Mono"/>
-              </a:defRPr>
-            </a:pPr>
-            <a:r>
-              <a:rPr sz="1200" b="0" i="0">
-                <a:solidFill>
-                  <a:srgbClr val="00E5FF"/>
-                </a:solidFill>
-                <a:latin typeface="Roboto Mono"/>
-                <a:ea typeface="Roboto Mono"/>
-                <a:cs typeface="Roboto Mono"/>
-              </a:rPr>
-              <a:t>          &lt;&lt; std::endl;</a:t>
             </a:r>
           </a:p>
         </p:txBody>
@@ -10820,7 +10760,7 @@
           <p:nvPr/>
         </p:nvPicPr>
         <p:blipFill rotWithShape="1">
-          <a:blip xmlns:r="http://schemas.openxmlformats.org/officeDocument/2006/relationships" xmlns:a="http://schemas.openxmlformats.org/drawingml/2006/main" r:embed="R1a5093503f3946c1">
+          <a:blip xmlns:r="http://schemas.openxmlformats.org/officeDocument/2006/relationships" xmlns:a="http://schemas.openxmlformats.org/drawingml/2006/main" r:embed="Rb7be19b5ae614232">
             <a:alphaModFix/>
           </a:blip>
           <a:srcRect xmlns:a="http://schemas.openxmlformats.org/drawingml/2006/main" l="0" t="0" r="0" b="0"/>
@@ -10848,7 +10788,7 @@
           <p:nvPr/>
         </p:nvPicPr>
         <p:blipFill rotWithShape="1">
-          <a:blip xmlns:r="http://schemas.openxmlformats.org/officeDocument/2006/relationships" xmlns:a="http://schemas.openxmlformats.org/drawingml/2006/main" r:embed="R1a5093503f3946c1">
+          <a:blip xmlns:r="http://schemas.openxmlformats.org/officeDocument/2006/relationships" xmlns:a="http://schemas.openxmlformats.org/drawingml/2006/main" r:embed="Rb7be19b5ae614232">
             <a:alphaModFix/>
           </a:blip>
           <a:srcRect xmlns:a="http://schemas.openxmlformats.org/drawingml/2006/main" l="0" t="0" r="0" b="0"/>
@@ -10876,7 +10816,7 @@
           <p:nvPr/>
         </p:nvPicPr>
         <p:blipFill rotWithShape="1">
-          <a:blip xmlns:r="http://schemas.openxmlformats.org/officeDocument/2006/relationships" xmlns:a="http://schemas.openxmlformats.org/drawingml/2006/main" r:embed="R1a5093503f3946c1">
+          <a:blip xmlns:r="http://schemas.openxmlformats.org/officeDocument/2006/relationships" xmlns:a="http://schemas.openxmlformats.org/drawingml/2006/main" r:embed="Rb7be19b5ae614232">
             <a:alphaModFix/>
           </a:blip>
           <a:srcRect xmlns:a="http://schemas.openxmlformats.org/drawingml/2006/main" l="0" t="0" r="0" b="0"/>
@@ -10904,7 +10844,7 @@
           <p:nvPr/>
         </p:nvPicPr>
         <p:blipFill rotWithShape="1">
-          <a:blip xmlns:r="http://schemas.openxmlformats.org/officeDocument/2006/relationships" xmlns:a="http://schemas.openxmlformats.org/drawingml/2006/main" r:embed="R1a5093503f3946c1">
+          <a:blip xmlns:r="http://schemas.openxmlformats.org/officeDocument/2006/relationships" xmlns:a="http://schemas.openxmlformats.org/drawingml/2006/main" r:embed="Rb7be19b5ae614232">
             <a:alphaModFix/>
           </a:blip>
           <a:srcRect xmlns:a="http://schemas.openxmlformats.org/drawingml/2006/main" l="0" t="0" r="0" b="0"/>
@@ -11606,7 +11546,7 @@
                 <a:ea typeface="Inter"/>
                 <a:cs typeface="Inter"/>
               </a:rPr>
-              <a:t>The count now covers execution exit events.</a:t>
+              <a:t>The output now shows only execution exit events.</a:t>
             </a:r>
           </a:p>
         </p:txBody>
@@ -12785,7 +12725,7 @@
           <p:nvPr/>
         </p:nvPicPr>
         <p:blipFill rotWithShape="1">
-          <a:blip xmlns:r="http://schemas.openxmlformats.org/officeDocument/2006/relationships" xmlns:a="http://schemas.openxmlformats.org/drawingml/2006/main" r:embed="R075c5b9751044f64">
+          <a:blip xmlns:r="http://schemas.openxmlformats.org/officeDocument/2006/relationships" xmlns:a="http://schemas.openxmlformats.org/drawingml/2006/main" r:embed="R7d28195af0d3456e">
             <a:alphaModFix/>
           </a:blip>
           <a:srcRect xmlns:a="http://schemas.openxmlformats.org/drawingml/2006/main" l="0" t="0" r="0" b="0"/>
@@ -12813,7 +12753,7 @@
           <p:nvPr/>
         </p:nvPicPr>
         <p:blipFill rotWithShape="1">
-          <a:blip xmlns:r="http://schemas.openxmlformats.org/officeDocument/2006/relationships" xmlns:a="http://schemas.openxmlformats.org/drawingml/2006/main" r:embed="R075c5b9751044f64">
+          <a:blip xmlns:r="http://schemas.openxmlformats.org/officeDocument/2006/relationships" xmlns:a="http://schemas.openxmlformats.org/drawingml/2006/main" r:embed="R7d28195af0d3456e">
             <a:alphaModFix/>
           </a:blip>
           <a:srcRect xmlns:a="http://schemas.openxmlformats.org/drawingml/2006/main" l="0" t="0" r="0" b="0"/>
@@ -12841,7 +12781,7 @@
           <p:nvPr/>
         </p:nvPicPr>
         <p:blipFill rotWithShape="1">
-          <a:blip xmlns:r="http://schemas.openxmlformats.org/officeDocument/2006/relationships" xmlns:a="http://schemas.openxmlformats.org/drawingml/2006/main" r:embed="R075c5b9751044f64">
+          <a:blip xmlns:r="http://schemas.openxmlformats.org/officeDocument/2006/relationships" xmlns:a="http://schemas.openxmlformats.org/drawingml/2006/main" r:embed="R7d28195af0d3456e">
             <a:alphaModFix/>
           </a:blip>
           <a:srcRect xmlns:a="http://schemas.openxmlformats.org/drawingml/2006/main" l="0" t="0" r="0" b="0"/>
@@ -12869,7 +12809,7 @@
           <p:nvPr/>
         </p:nvPicPr>
         <p:blipFill rotWithShape="1">
-          <a:blip xmlns:r="http://schemas.openxmlformats.org/officeDocument/2006/relationships" xmlns:a="http://schemas.openxmlformats.org/drawingml/2006/main" r:embed="R075c5b9751044f64">
+          <a:blip xmlns:r="http://schemas.openxmlformats.org/officeDocument/2006/relationships" xmlns:a="http://schemas.openxmlformats.org/drawingml/2006/main" r:embed="R7d28195af0d3456e">
             <a:alphaModFix/>
           </a:blip>
           <a:srcRect xmlns:a="http://schemas.openxmlformats.org/drawingml/2006/main" l="0" t="0" r="0" b="0"/>
@@ -13519,7 +13459,7 @@
                 <a:ea typeface="Inter"/>
                 <a:cs typeface="Inter"/>
               </a:rPr>
-              <a:t>The script adds process context to the read loop.</a:t>
+              <a:t>The script adds PID and process name to the existing event output.</a:t>
             </a:r>
           </a:p>
           <a:p xmlns:a="http://schemas.openxmlformats.org/drawingml/2006/main">
@@ -14818,7 +14758,7 @@
           <p:nvPr/>
         </p:nvPicPr>
         <p:blipFill rotWithShape="1">
-          <a:blip xmlns:r="http://schemas.openxmlformats.org/officeDocument/2006/relationships" xmlns:a="http://schemas.openxmlformats.org/drawingml/2006/main" r:embed="R0c423fc47597443e">
+          <a:blip xmlns:r="http://schemas.openxmlformats.org/officeDocument/2006/relationships" xmlns:a="http://schemas.openxmlformats.org/drawingml/2006/main" r:embed="R58b2a480d3a64910">
             <a:alphaModFix/>
           </a:blip>
           <a:srcRect xmlns:a="http://schemas.openxmlformats.org/drawingml/2006/main" l="0" t="0" r="0" b="0"/>
@@ -14846,7 +14786,7 @@
           <p:nvPr/>
         </p:nvPicPr>
         <p:blipFill rotWithShape="1">
-          <a:blip xmlns:r="http://schemas.openxmlformats.org/officeDocument/2006/relationships" xmlns:a="http://schemas.openxmlformats.org/drawingml/2006/main" r:embed="R0c423fc47597443e">
+          <a:blip xmlns:r="http://schemas.openxmlformats.org/officeDocument/2006/relationships" xmlns:a="http://schemas.openxmlformats.org/drawingml/2006/main" r:embed="R58b2a480d3a64910">
             <a:alphaModFix/>
           </a:blip>
           <a:srcRect xmlns:a="http://schemas.openxmlformats.org/drawingml/2006/main" l="0" t="0" r="0" b="0"/>
@@ -14874,7 +14814,7 @@
           <p:nvPr/>
         </p:nvPicPr>
         <p:blipFill rotWithShape="1">
-          <a:blip xmlns:r="http://schemas.openxmlformats.org/officeDocument/2006/relationships" xmlns:a="http://schemas.openxmlformats.org/drawingml/2006/main" r:embed="R0c423fc47597443e">
+          <a:blip xmlns:r="http://schemas.openxmlformats.org/officeDocument/2006/relationships" xmlns:a="http://schemas.openxmlformats.org/drawingml/2006/main" r:embed="R58b2a480d3a64910">
             <a:alphaModFix/>
           </a:blip>
           <a:srcRect xmlns:a="http://schemas.openxmlformats.org/drawingml/2006/main" l="0" t="0" r="0" b="0"/>
@@ -14902,7 +14842,7 @@
           <p:nvPr/>
         </p:nvPicPr>
         <p:blipFill rotWithShape="1">
-          <a:blip xmlns:r="http://schemas.openxmlformats.org/officeDocument/2006/relationships" xmlns:a="http://schemas.openxmlformats.org/drawingml/2006/main" r:embed="R0c423fc47597443e">
+          <a:blip xmlns:r="http://schemas.openxmlformats.org/officeDocument/2006/relationships" xmlns:a="http://schemas.openxmlformats.org/drawingml/2006/main" r:embed="R58b2a480d3a64910">
             <a:alphaModFix/>
           </a:blip>
           <a:srcRect xmlns:a="http://schemas.openxmlformats.org/drawingml/2006/main" l="0" t="0" r="0" b="0"/>
@@ -15500,7 +15440,7 @@
                 <a:ea typeface="Inter"/>
                 <a:cs typeface="Inter"/>
               </a:rPr>
-              <a:t>Attach. Read. Filter. Add context.</a:t>
+              <a:t>Attach. Print. Filter. Add context.</a:t>
             </a:r>
           </a:p>
           <a:p xmlns:a="http://schemas.openxmlformats.org/drawingml/2006/main">
@@ -16865,7 +16805,7 @@
           <p:nvPr/>
         </p:nvPicPr>
         <p:blipFill rotWithShape="1">
-          <a:blip xmlns:r="http://schemas.openxmlformats.org/officeDocument/2006/relationships" xmlns:a="http://schemas.openxmlformats.org/drawingml/2006/main" r:embed="R29e197c21410438d">
+          <a:blip xmlns:r="http://schemas.openxmlformats.org/officeDocument/2006/relationships" xmlns:a="http://schemas.openxmlformats.org/drawingml/2006/main" r:embed="Raf0d70a39fa847ed">
             <a:alphaModFix/>
           </a:blip>
           <a:srcRect xmlns:a="http://schemas.openxmlformats.org/drawingml/2006/main" l="0" t="0" r="0" b="0"/>
@@ -16893,7 +16833,7 @@
           <p:nvPr/>
         </p:nvPicPr>
         <p:blipFill rotWithShape="1">
-          <a:blip xmlns:r="http://schemas.openxmlformats.org/officeDocument/2006/relationships" xmlns:a="http://schemas.openxmlformats.org/drawingml/2006/main" r:embed="R29e197c21410438d">
+          <a:blip xmlns:r="http://schemas.openxmlformats.org/officeDocument/2006/relationships" xmlns:a="http://schemas.openxmlformats.org/drawingml/2006/main" r:embed="Raf0d70a39fa847ed">
             <a:alphaModFix/>
           </a:blip>
           <a:srcRect xmlns:a="http://schemas.openxmlformats.org/drawingml/2006/main" l="0" t="0" r="0" b="0"/>
@@ -16921,7 +16861,7 @@
           <p:nvPr/>
         </p:nvPicPr>
         <p:blipFill rotWithShape="1">
-          <a:blip xmlns:r="http://schemas.openxmlformats.org/officeDocument/2006/relationships" xmlns:a="http://schemas.openxmlformats.org/drawingml/2006/main" r:embed="R29e197c21410438d">
+          <a:blip xmlns:r="http://schemas.openxmlformats.org/officeDocument/2006/relationships" xmlns:a="http://schemas.openxmlformats.org/drawingml/2006/main" r:embed="Raf0d70a39fa847ed">
             <a:alphaModFix/>
           </a:blip>
           <a:srcRect xmlns:a="http://schemas.openxmlformats.org/drawingml/2006/main" l="0" t="0" r="0" b="0"/>
@@ -16949,7 +16889,7 @@
           <p:nvPr/>
         </p:nvPicPr>
         <p:blipFill rotWithShape="1">
-          <a:blip xmlns:r="http://schemas.openxmlformats.org/officeDocument/2006/relationships" xmlns:a="http://schemas.openxmlformats.org/drawingml/2006/main" r:embed="R29e197c21410438d">
+          <a:blip xmlns:r="http://schemas.openxmlformats.org/officeDocument/2006/relationships" xmlns:a="http://schemas.openxmlformats.org/drawingml/2006/main" r:embed="Raf0d70a39fa847ed">
             <a:alphaModFix/>
           </a:blip>
           <a:srcRect xmlns:a="http://schemas.openxmlformats.org/drawingml/2006/main" l="0" t="0" r="0" b="0"/>
@@ -18770,7 +18710,7 @@
           <p:nvPr/>
         </p:nvPicPr>
         <p:blipFill rotWithShape="1">
-          <a:blip xmlns:r="http://schemas.openxmlformats.org/officeDocument/2006/relationships" xmlns:a="http://schemas.openxmlformats.org/drawingml/2006/main" r:embed="Re3d7ef4c27834462">
+          <a:blip xmlns:r="http://schemas.openxmlformats.org/officeDocument/2006/relationships" xmlns:a="http://schemas.openxmlformats.org/drawingml/2006/main" r:embed="Ree768ddb031c4d42">
             <a:alphaModFix/>
           </a:blip>
           <a:srcRect xmlns:a="http://schemas.openxmlformats.org/drawingml/2006/main" l="0" t="0" r="0" b="0"/>
@@ -18798,7 +18738,7 @@
           <p:nvPr/>
         </p:nvPicPr>
         <p:blipFill rotWithShape="1">
-          <a:blip xmlns:r="http://schemas.openxmlformats.org/officeDocument/2006/relationships" xmlns:a="http://schemas.openxmlformats.org/drawingml/2006/main" r:embed="Re3d7ef4c27834462">
+          <a:blip xmlns:r="http://schemas.openxmlformats.org/officeDocument/2006/relationships" xmlns:a="http://schemas.openxmlformats.org/drawingml/2006/main" r:embed="Ree768ddb031c4d42">
             <a:alphaModFix/>
           </a:blip>
           <a:srcRect xmlns:a="http://schemas.openxmlformats.org/drawingml/2006/main" l="0" t="0" r="0" b="0"/>
@@ -18826,7 +18766,7 @@
           <p:nvPr/>
         </p:nvPicPr>
         <p:blipFill rotWithShape="1">
-          <a:blip xmlns:r="http://schemas.openxmlformats.org/officeDocument/2006/relationships" xmlns:a="http://schemas.openxmlformats.org/drawingml/2006/main" r:embed="Re3d7ef4c27834462">
+          <a:blip xmlns:r="http://schemas.openxmlformats.org/officeDocument/2006/relationships" xmlns:a="http://schemas.openxmlformats.org/drawingml/2006/main" r:embed="Ree768ddb031c4d42">
             <a:alphaModFix/>
           </a:blip>
           <a:srcRect xmlns:a="http://schemas.openxmlformats.org/drawingml/2006/main" l="0" t="0" r="0" b="0"/>
@@ -18854,7 +18794,7 @@
           <p:nvPr/>
         </p:nvPicPr>
         <p:blipFill rotWithShape="1">
-          <a:blip xmlns:r="http://schemas.openxmlformats.org/officeDocument/2006/relationships" xmlns:a="http://schemas.openxmlformats.org/drawingml/2006/main" r:embed="Re3d7ef4c27834462">
+          <a:blip xmlns:r="http://schemas.openxmlformats.org/officeDocument/2006/relationships" xmlns:a="http://schemas.openxmlformats.org/drawingml/2006/main" r:embed="Ree768ddb031c4d42">
             <a:alphaModFix/>
           </a:blip>
           <a:srcRect xmlns:a="http://schemas.openxmlformats.org/drawingml/2006/main" l="0" t="0" r="0" b="0"/>
@@ -19943,7 +19883,7 @@
                 <a:ea typeface="Roboto Mono"/>
                 <a:cs typeface="Roboto Mono"/>
               </a:rPr>
-              <a:t>1  Create the barebones source</a:t>
+              <a:t>Step 1: Create source</a:t>
             </a:r>
           </a:p>
           <a:p xmlns:a="http://schemas.openxmlformats.org/drawingml/2006/main">
@@ -19995,7 +19935,7 @@
                 <a:ea typeface="Roboto Mono"/>
                 <a:cs typeface="Roboto Mono"/>
               </a:rPr>
-              <a:t>2  Read and count events</a:t>
+              <a:t>Step 2: Print events</a:t>
             </a:r>
           </a:p>
           <a:p xmlns:a="http://schemas.openxmlformats.org/drawingml/2006/main">
@@ -20047,7 +19987,7 @@
                 <a:ea typeface="Roboto Mono"/>
                 <a:cs typeface="Roboto Mono"/>
               </a:rPr>
-              <a:t>3  Keep process executions</a:t>
+              <a:t>Step 3: Filter executions</a:t>
             </a:r>
           </a:p>
           <a:p xmlns:a="http://schemas.openxmlformats.org/drawingml/2006/main">
@@ -20099,7 +20039,7 @@
                 <a:ea typeface="Roboto Mono"/>
                 <a:cs typeface="Roboto Mono"/>
               </a:rPr>
-              <a:t>4  Add process name and PID</a:t>
+              <a:t>Step 4: Add name and PID</a:t>
             </a:r>
           </a:p>
         </p:txBody>
@@ -20749,7 +20689,7 @@
           <p:nvPr/>
         </p:nvPicPr>
         <p:blipFill rotWithShape="1">
-          <a:blip xmlns:r="http://schemas.openxmlformats.org/officeDocument/2006/relationships" xmlns:a="http://schemas.openxmlformats.org/drawingml/2006/main" r:embed="R3935b39f8ea14c5b">
+          <a:blip xmlns:r="http://schemas.openxmlformats.org/officeDocument/2006/relationships" xmlns:a="http://schemas.openxmlformats.org/drawingml/2006/main" r:embed="Re05fa0a8752d494b">
             <a:alphaModFix/>
           </a:blip>
           <a:srcRect xmlns:a="http://schemas.openxmlformats.org/drawingml/2006/main" l="0" t="0" r="0" b="0"/>
@@ -20777,7 +20717,7 @@
           <p:nvPr/>
         </p:nvPicPr>
         <p:blipFill rotWithShape="1">
-          <a:blip xmlns:r="http://schemas.openxmlformats.org/officeDocument/2006/relationships" xmlns:a="http://schemas.openxmlformats.org/drawingml/2006/main" r:embed="R3935b39f8ea14c5b">
+          <a:blip xmlns:r="http://schemas.openxmlformats.org/officeDocument/2006/relationships" xmlns:a="http://schemas.openxmlformats.org/drawingml/2006/main" r:embed="Re05fa0a8752d494b">
             <a:alphaModFix/>
           </a:blip>
           <a:srcRect xmlns:a="http://schemas.openxmlformats.org/drawingml/2006/main" l="0" t="0" r="0" b="0"/>
@@ -20805,7 +20745,7 @@
           <p:nvPr/>
         </p:nvPicPr>
         <p:blipFill rotWithShape="1">
-          <a:blip xmlns:r="http://schemas.openxmlformats.org/officeDocument/2006/relationships" xmlns:a="http://schemas.openxmlformats.org/drawingml/2006/main" r:embed="R3935b39f8ea14c5b">
+          <a:blip xmlns:r="http://schemas.openxmlformats.org/officeDocument/2006/relationships" xmlns:a="http://schemas.openxmlformats.org/drawingml/2006/main" r:embed="Re05fa0a8752d494b">
             <a:alphaModFix/>
           </a:blip>
           <a:srcRect xmlns:a="http://schemas.openxmlformats.org/drawingml/2006/main" l="0" t="0" r="0" b="0"/>
@@ -20833,7 +20773,7 @@
           <p:nvPr/>
         </p:nvPicPr>
         <p:blipFill rotWithShape="1">
-          <a:blip xmlns:r="http://schemas.openxmlformats.org/officeDocument/2006/relationships" xmlns:a="http://schemas.openxmlformats.org/drawingml/2006/main" r:embed="R3935b39f8ea14c5b">
+          <a:blip xmlns:r="http://schemas.openxmlformats.org/officeDocument/2006/relationships" xmlns:a="http://schemas.openxmlformats.org/drawingml/2006/main" r:embed="Re05fa0a8752d494b">
             <a:alphaModFix/>
           </a:blip>
           <a:srcRect xmlns:a="http://schemas.openxmlformats.org/drawingml/2006/main" l="0" t="0" r="0" b="0"/>
@@ -22446,7 +22386,7 @@
           <p:nvPr/>
         </p:nvPicPr>
         <p:blipFill rotWithShape="1">
-          <a:blip xmlns:r="http://schemas.openxmlformats.org/officeDocument/2006/relationships" xmlns:a="http://schemas.openxmlformats.org/drawingml/2006/main" r:embed="Racd6ce8735d943ed">
+          <a:blip xmlns:r="http://schemas.openxmlformats.org/officeDocument/2006/relationships" xmlns:a="http://schemas.openxmlformats.org/drawingml/2006/main" r:embed="Re144d3f7ce314b6e">
             <a:alphaModFix/>
           </a:blip>
           <a:srcRect xmlns:a="http://schemas.openxmlformats.org/drawingml/2006/main" l="0" t="0" r="0" b="0"/>
@@ -22474,7 +22414,7 @@
           <p:nvPr/>
         </p:nvPicPr>
         <p:blipFill rotWithShape="1">
-          <a:blip xmlns:r="http://schemas.openxmlformats.org/officeDocument/2006/relationships" xmlns:a="http://schemas.openxmlformats.org/drawingml/2006/main" r:embed="Racd6ce8735d943ed">
+          <a:blip xmlns:r="http://schemas.openxmlformats.org/officeDocument/2006/relationships" xmlns:a="http://schemas.openxmlformats.org/drawingml/2006/main" r:embed="Re144d3f7ce314b6e">
             <a:alphaModFix/>
           </a:blip>
           <a:srcRect xmlns:a="http://schemas.openxmlformats.org/drawingml/2006/main" l="0" t="0" r="0" b="0"/>
@@ -22502,7 +22442,7 @@
           <p:nvPr/>
         </p:nvPicPr>
         <p:blipFill rotWithShape="1">
-          <a:blip xmlns:r="http://schemas.openxmlformats.org/officeDocument/2006/relationships" xmlns:a="http://schemas.openxmlformats.org/drawingml/2006/main" r:embed="Racd6ce8735d943ed">
+          <a:blip xmlns:r="http://schemas.openxmlformats.org/officeDocument/2006/relationships" xmlns:a="http://schemas.openxmlformats.org/drawingml/2006/main" r:embed="Re144d3f7ce314b6e">
             <a:alphaModFix/>
           </a:blip>
           <a:srcRect xmlns:a="http://schemas.openxmlformats.org/drawingml/2006/main" l="0" t="0" r="0" b="0"/>
@@ -22530,7 +22470,7 @@
           <p:nvPr/>
         </p:nvPicPr>
         <p:blipFill rotWithShape="1">
-          <a:blip xmlns:r="http://schemas.openxmlformats.org/officeDocument/2006/relationships" xmlns:a="http://schemas.openxmlformats.org/drawingml/2006/main" r:embed="Racd6ce8735d943ed">
+          <a:blip xmlns:r="http://schemas.openxmlformats.org/officeDocument/2006/relationships" xmlns:a="http://schemas.openxmlformats.org/drawingml/2006/main" r:embed="Re144d3f7ce314b6e">
             <a:alphaModFix/>
           </a:blip>
           <a:srcRect xmlns:a="http://schemas.openxmlformats.org/drawingml/2006/main" l="0" t="0" r="0" b="0"/>
@@ -24143,7 +24083,7 @@
           <p:nvPr/>
         </p:nvPicPr>
         <p:blipFill rotWithShape="1">
-          <a:blip xmlns:r="http://schemas.openxmlformats.org/officeDocument/2006/relationships" xmlns:a="http://schemas.openxmlformats.org/drawingml/2006/main" r:embed="R22c76fe324b447f9">
+          <a:blip xmlns:r="http://schemas.openxmlformats.org/officeDocument/2006/relationships" xmlns:a="http://schemas.openxmlformats.org/drawingml/2006/main" r:embed="Red75036c0dfe4f62">
             <a:alphaModFix/>
           </a:blip>
           <a:srcRect xmlns:a="http://schemas.openxmlformats.org/drawingml/2006/main" l="0" t="0" r="0" b="0"/>
@@ -24171,7 +24111,7 @@
           <p:nvPr/>
         </p:nvPicPr>
         <p:blipFill rotWithShape="1">
-          <a:blip xmlns:r="http://schemas.openxmlformats.org/officeDocument/2006/relationships" xmlns:a="http://schemas.openxmlformats.org/drawingml/2006/main" r:embed="R22c76fe324b447f9">
+          <a:blip xmlns:r="http://schemas.openxmlformats.org/officeDocument/2006/relationships" xmlns:a="http://schemas.openxmlformats.org/drawingml/2006/main" r:embed="Red75036c0dfe4f62">
             <a:alphaModFix/>
           </a:blip>
           <a:srcRect xmlns:a="http://schemas.openxmlformats.org/drawingml/2006/main" l="0" t="0" r="0" b="0"/>
@@ -24199,7 +24139,7 @@
           <p:nvPr/>
         </p:nvPicPr>
         <p:blipFill rotWithShape="1">
-          <a:blip xmlns:r="http://schemas.openxmlformats.org/officeDocument/2006/relationships" xmlns:a="http://schemas.openxmlformats.org/drawingml/2006/main" r:embed="R22c76fe324b447f9">
+          <a:blip xmlns:r="http://schemas.openxmlformats.org/officeDocument/2006/relationships" xmlns:a="http://schemas.openxmlformats.org/drawingml/2006/main" r:embed="Red75036c0dfe4f62">
             <a:alphaModFix/>
           </a:blip>
           <a:srcRect xmlns:a="http://schemas.openxmlformats.org/drawingml/2006/main" l="0" t="0" r="0" b="0"/>
@@ -24227,7 +24167,7 @@
           <p:nvPr/>
         </p:nvPicPr>
         <p:blipFill rotWithShape="1">
-          <a:blip xmlns:r="http://schemas.openxmlformats.org/officeDocument/2006/relationships" xmlns:a="http://schemas.openxmlformats.org/drawingml/2006/main" r:embed="R22c76fe324b447f9">
+          <a:blip xmlns:r="http://schemas.openxmlformats.org/officeDocument/2006/relationships" xmlns:a="http://schemas.openxmlformats.org/drawingml/2006/main" r:embed="Red75036c0dfe4f62">
             <a:alphaModFix/>
           </a:blip>
           <a:srcRect xmlns:a="http://schemas.openxmlformats.org/drawingml/2006/main" l="0" t="0" r="0" b="0"/>
@@ -26122,7 +26062,7 @@
           <p:nvPr/>
         </p:nvPicPr>
         <p:blipFill rotWithShape="1">
-          <a:blip xmlns:r="http://schemas.openxmlformats.org/officeDocument/2006/relationships" xmlns:a="http://schemas.openxmlformats.org/drawingml/2006/main" r:embed="R922725c62fc34ad2">
+          <a:blip xmlns:r="http://schemas.openxmlformats.org/officeDocument/2006/relationships" xmlns:a="http://schemas.openxmlformats.org/drawingml/2006/main" r:embed="Re750543b898b4342">
             <a:alphaModFix/>
           </a:blip>
           <a:srcRect xmlns:a="http://schemas.openxmlformats.org/drawingml/2006/main" l="0" t="0" r="0" b="0"/>
@@ -26150,7 +26090,7 @@
           <p:nvPr/>
         </p:nvPicPr>
         <p:blipFill rotWithShape="1">
-          <a:blip xmlns:r="http://schemas.openxmlformats.org/officeDocument/2006/relationships" xmlns:a="http://schemas.openxmlformats.org/drawingml/2006/main" r:embed="R922725c62fc34ad2">
+          <a:blip xmlns:r="http://schemas.openxmlformats.org/officeDocument/2006/relationships" xmlns:a="http://schemas.openxmlformats.org/drawingml/2006/main" r:embed="Re750543b898b4342">
             <a:alphaModFix/>
           </a:blip>
           <a:srcRect xmlns:a="http://schemas.openxmlformats.org/drawingml/2006/main" l="0" t="0" r="0" b="0"/>
@@ -26178,7 +26118,7 @@
           <p:nvPr/>
         </p:nvPicPr>
         <p:blipFill rotWithShape="1">
-          <a:blip xmlns:r="http://schemas.openxmlformats.org/officeDocument/2006/relationships" xmlns:a="http://schemas.openxmlformats.org/drawingml/2006/main" r:embed="R922725c62fc34ad2">
+          <a:blip xmlns:r="http://schemas.openxmlformats.org/officeDocument/2006/relationships" xmlns:a="http://schemas.openxmlformats.org/drawingml/2006/main" r:embed="Re750543b898b4342">
             <a:alphaModFix/>
           </a:blip>
           <a:srcRect xmlns:a="http://schemas.openxmlformats.org/drawingml/2006/main" l="0" t="0" r="0" b="0"/>
@@ -26206,7 +26146,7 @@
           <p:nvPr/>
         </p:nvPicPr>
         <p:blipFill rotWithShape="1">
-          <a:blip xmlns:r="http://schemas.openxmlformats.org/officeDocument/2006/relationships" xmlns:a="http://schemas.openxmlformats.org/drawingml/2006/main" r:embed="R922725c62fc34ad2">
+          <a:blip xmlns:r="http://schemas.openxmlformats.org/officeDocument/2006/relationships" xmlns:a="http://schemas.openxmlformats.org/drawingml/2006/main" r:embed="Re750543b898b4342">
             <a:alphaModFix/>
           </a:blip>
           <a:srcRect xmlns:a="http://schemas.openxmlformats.org/drawingml/2006/main" l="0" t="0" r="0" b="0"/>
@@ -27947,7 +27887,7 @@
           <p:nvPr/>
         </p:nvPicPr>
         <p:blipFill rotWithShape="1">
-          <a:blip xmlns:r="http://schemas.openxmlformats.org/officeDocument/2006/relationships" xmlns:a="http://schemas.openxmlformats.org/drawingml/2006/main" r:embed="R16f604880191416a">
+          <a:blip xmlns:r="http://schemas.openxmlformats.org/officeDocument/2006/relationships" xmlns:a="http://schemas.openxmlformats.org/drawingml/2006/main" r:embed="Rfe64fe1f33824770">
             <a:alphaModFix/>
           </a:blip>
           <a:srcRect xmlns:a="http://schemas.openxmlformats.org/drawingml/2006/main" l="0" t="0" r="0" b="0"/>
@@ -27975,7 +27915,7 @@
           <p:nvPr/>
         </p:nvPicPr>
         <p:blipFill rotWithShape="1">
-          <a:blip xmlns:r="http://schemas.openxmlformats.org/officeDocument/2006/relationships" xmlns:a="http://schemas.openxmlformats.org/drawingml/2006/main" r:embed="R16f604880191416a">
+          <a:blip xmlns:r="http://schemas.openxmlformats.org/officeDocument/2006/relationships" xmlns:a="http://schemas.openxmlformats.org/drawingml/2006/main" r:embed="Rfe64fe1f33824770">
             <a:alphaModFix/>
           </a:blip>
           <a:srcRect xmlns:a="http://schemas.openxmlformats.org/drawingml/2006/main" l="0" t="0" r="0" b="0"/>
@@ -28003,7 +27943,7 @@
           <p:nvPr/>
         </p:nvPicPr>
         <p:blipFill rotWithShape="1">
-          <a:blip xmlns:r="http://schemas.openxmlformats.org/officeDocument/2006/relationships" xmlns:a="http://schemas.openxmlformats.org/drawingml/2006/main" r:embed="R16f604880191416a">
+          <a:blip xmlns:r="http://schemas.openxmlformats.org/officeDocument/2006/relationships" xmlns:a="http://schemas.openxmlformats.org/drawingml/2006/main" r:embed="Rfe64fe1f33824770">
             <a:alphaModFix/>
           </a:blip>
           <a:srcRect xmlns:a="http://schemas.openxmlformats.org/drawingml/2006/main" l="0" t="0" r="0" b="0"/>
@@ -28031,7 +27971,7 @@
           <p:nvPr/>
         </p:nvPicPr>
         <p:blipFill rotWithShape="1">
-          <a:blip xmlns:r="http://schemas.openxmlformats.org/officeDocument/2006/relationships" xmlns:a="http://schemas.openxmlformats.org/drawingml/2006/main" r:embed="R16f604880191416a">
+          <a:blip xmlns:r="http://schemas.openxmlformats.org/officeDocument/2006/relationships" xmlns:a="http://schemas.openxmlformats.org/drawingml/2006/main" r:embed="Rfe64fe1f33824770">
             <a:alphaModFix/>
           </a:blip>
           <a:srcRect xmlns:a="http://schemas.openxmlformats.org/drawingml/2006/main" l="0" t="0" r="0" b="0"/>
@@ -29772,7 +29712,7 @@
           <p:nvPr/>
         </p:nvPicPr>
         <p:blipFill rotWithShape="1">
-          <a:blip xmlns:r="http://schemas.openxmlformats.org/officeDocument/2006/relationships" xmlns:a="http://schemas.openxmlformats.org/drawingml/2006/main" r:embed="Ra65a966efd6f41b4">
+          <a:blip xmlns:r="http://schemas.openxmlformats.org/officeDocument/2006/relationships" xmlns:a="http://schemas.openxmlformats.org/drawingml/2006/main" r:embed="R3ca42eaad31b4411">
             <a:alphaModFix/>
           </a:blip>
           <a:srcRect xmlns:a="http://schemas.openxmlformats.org/drawingml/2006/main" l="0" t="0" r="0" b="0"/>
@@ -29800,7 +29740,7 @@
           <p:nvPr/>
         </p:nvPicPr>
         <p:blipFill rotWithShape="1">
-          <a:blip xmlns:r="http://schemas.openxmlformats.org/officeDocument/2006/relationships" xmlns:a="http://schemas.openxmlformats.org/drawingml/2006/main" r:embed="Ra65a966efd6f41b4">
+          <a:blip xmlns:r="http://schemas.openxmlformats.org/officeDocument/2006/relationships" xmlns:a="http://schemas.openxmlformats.org/drawingml/2006/main" r:embed="R3ca42eaad31b4411">
             <a:alphaModFix/>
           </a:blip>
           <a:srcRect xmlns:a="http://schemas.openxmlformats.org/drawingml/2006/main" l="0" t="0" r="0" b="0"/>
@@ -29828,7 +29768,7 @@
           <p:nvPr/>
         </p:nvPicPr>
         <p:blipFill rotWithShape="1">
-          <a:blip xmlns:r="http://schemas.openxmlformats.org/officeDocument/2006/relationships" xmlns:a="http://schemas.openxmlformats.org/drawingml/2006/main" r:embed="Ra65a966efd6f41b4">
+          <a:blip xmlns:r="http://schemas.openxmlformats.org/officeDocument/2006/relationships" xmlns:a="http://schemas.openxmlformats.org/drawingml/2006/main" r:embed="R3ca42eaad31b4411">
             <a:alphaModFix/>
           </a:blip>
           <a:srcRect xmlns:a="http://schemas.openxmlformats.org/drawingml/2006/main" l="0" t="0" r="0" b="0"/>
@@ -29856,7 +29796,7 @@
           <p:nvPr/>
         </p:nvPicPr>
         <p:blipFill rotWithShape="1">
-          <a:blip xmlns:r="http://schemas.openxmlformats.org/officeDocument/2006/relationships" xmlns:a="http://schemas.openxmlformats.org/drawingml/2006/main" r:embed="Ra65a966efd6f41b4">
+          <a:blip xmlns:r="http://schemas.openxmlformats.org/officeDocument/2006/relationships" xmlns:a="http://schemas.openxmlformats.org/drawingml/2006/main" r:embed="R3ca42eaad31b4411">
             <a:alphaModFix/>
           </a:blip>
           <a:srcRect xmlns:a="http://schemas.openxmlformats.org/drawingml/2006/main" l="0" t="0" r="0" b="0"/>
@@ -31947,7 +31887,7 @@
           <p:nvPr/>
         </p:nvPicPr>
         <p:blipFill rotWithShape="1">
-          <a:blip xmlns:r="http://schemas.openxmlformats.org/officeDocument/2006/relationships" xmlns:a="http://schemas.openxmlformats.org/drawingml/2006/main" r:embed="R73909c2681a5438d">
+          <a:blip xmlns:r="http://schemas.openxmlformats.org/officeDocument/2006/relationships" xmlns:a="http://schemas.openxmlformats.org/drawingml/2006/main" r:embed="R3b19c54216284fad">
             <a:alphaModFix/>
           </a:blip>
           <a:srcRect xmlns:a="http://schemas.openxmlformats.org/drawingml/2006/main" l="0" t="0" r="0" b="0"/>
@@ -31975,7 +31915,7 @@
           <p:nvPr/>
         </p:nvPicPr>
         <p:blipFill rotWithShape="1">
-          <a:blip xmlns:r="http://schemas.openxmlformats.org/officeDocument/2006/relationships" xmlns:a="http://schemas.openxmlformats.org/drawingml/2006/main" r:embed="R73909c2681a5438d">
+          <a:blip xmlns:r="http://schemas.openxmlformats.org/officeDocument/2006/relationships" xmlns:a="http://schemas.openxmlformats.org/drawingml/2006/main" r:embed="R3b19c54216284fad">
             <a:alphaModFix/>
           </a:blip>
           <a:srcRect xmlns:a="http://schemas.openxmlformats.org/drawingml/2006/main" l="0" t="0" r="0" b="0"/>
@@ -32003,7 +31943,7 @@
           <p:nvPr/>
         </p:nvPicPr>
         <p:blipFill rotWithShape="1">
-          <a:blip xmlns:r="http://schemas.openxmlformats.org/officeDocument/2006/relationships" xmlns:a="http://schemas.openxmlformats.org/drawingml/2006/main" r:embed="R73909c2681a5438d">
+          <a:blip xmlns:r="http://schemas.openxmlformats.org/officeDocument/2006/relationships" xmlns:a="http://schemas.openxmlformats.org/drawingml/2006/main" r:embed="R3b19c54216284fad">
             <a:alphaModFix/>
           </a:blip>
           <a:srcRect xmlns:a="http://schemas.openxmlformats.org/drawingml/2006/main" l="0" t="0" r="0" b="0"/>
@@ -32031,7 +31971,7 @@
           <p:nvPr/>
         </p:nvPicPr>
         <p:blipFill rotWithShape="1">
-          <a:blip xmlns:r="http://schemas.openxmlformats.org/officeDocument/2006/relationships" xmlns:a="http://schemas.openxmlformats.org/drawingml/2006/main" r:embed="R73909c2681a5438d">
+          <a:blip xmlns:r="http://schemas.openxmlformats.org/officeDocument/2006/relationships" xmlns:a="http://schemas.openxmlformats.org/drawingml/2006/main" r:embed="R3b19c54216284fad">
             <a:alphaModFix/>
           </a:blip>
           <a:srcRect xmlns:a="http://schemas.openxmlformats.org/drawingml/2006/main" l="0" t="0" r="0" b="0"/>
@@ -32681,7 +32621,7 @@
                 <a:ea typeface="Inter"/>
                 <a:cs typeface="Inter"/>
               </a:rPr>
-              <a:t>Step 2 adds the read loop. Run starts a ten-second capture.</a:t>
+              <a:t>Step 2 adds the read loop and prints event names. Run captures for ten seconds.</a:t>
             </a:r>
           </a:p>
           <a:p xmlns:a="http://schemas.openxmlformats.org/drawingml/2006/main">
@@ -34010,7 +33950,7 @@
           <p:nvPr/>
         </p:nvPicPr>
         <p:blipFill rotWithShape="1">
-          <a:blip xmlns:r="http://schemas.openxmlformats.org/officeDocument/2006/relationships" xmlns:a="http://schemas.openxmlformats.org/drawingml/2006/main" r:embed="Rbf390aaed5564de1">
+          <a:blip xmlns:r="http://schemas.openxmlformats.org/officeDocument/2006/relationships" xmlns:a="http://schemas.openxmlformats.org/drawingml/2006/main" r:embed="Ra3403874bc474d90">
             <a:alphaModFix/>
           </a:blip>
           <a:srcRect xmlns:a="http://schemas.openxmlformats.org/drawingml/2006/main" l="0" t="0" r="0" b="0"/>
@@ -34038,7 +33978,7 @@
           <p:nvPr/>
         </p:nvPicPr>
         <p:blipFill rotWithShape="1">
-          <a:blip xmlns:r="http://schemas.openxmlformats.org/officeDocument/2006/relationships" xmlns:a="http://schemas.openxmlformats.org/drawingml/2006/main" r:embed="Rbf390aaed5564de1">
+          <a:blip xmlns:r="http://schemas.openxmlformats.org/officeDocument/2006/relationships" xmlns:a="http://schemas.openxmlformats.org/drawingml/2006/main" r:embed="Ra3403874bc474d90">
             <a:alphaModFix/>
           </a:blip>
           <a:srcRect xmlns:a="http://schemas.openxmlformats.org/drawingml/2006/main" l="0" t="0" r="0" b="0"/>
@@ -34066,7 +34006,7 @@
           <p:nvPr/>
         </p:nvPicPr>
         <p:blipFill rotWithShape="1">
-          <a:blip xmlns:r="http://schemas.openxmlformats.org/officeDocument/2006/relationships" xmlns:a="http://schemas.openxmlformats.org/drawingml/2006/main" r:embed="Rbf390aaed5564de1">
+          <a:blip xmlns:r="http://schemas.openxmlformats.org/officeDocument/2006/relationships" xmlns:a="http://schemas.openxmlformats.org/drawingml/2006/main" r:embed="Ra3403874bc474d90">
             <a:alphaModFix/>
           </a:blip>
           <a:srcRect xmlns:a="http://schemas.openxmlformats.org/drawingml/2006/main" l="0" t="0" r="0" b="0"/>
@@ -34094,7 +34034,7 @@
           <p:nvPr/>
         </p:nvPicPr>
         <p:blipFill rotWithShape="1">
-          <a:blip xmlns:r="http://schemas.openxmlformats.org/officeDocument/2006/relationships" xmlns:a="http://schemas.openxmlformats.org/drawingml/2006/main" r:embed="Rbf390aaed5564de1">
+          <a:blip xmlns:r="http://schemas.openxmlformats.org/officeDocument/2006/relationships" xmlns:a="http://schemas.openxmlformats.org/drawingml/2006/main" r:embed="Ra3403874bc474d90">
             <a:alphaModFix/>
           </a:blip>
           <a:srcRect xmlns:a="http://schemas.openxmlformats.org/drawingml/2006/main" l="0" t="0" r="0" b="0"/>

</xml_diff>

<commit_message>
Focus slides on raw syscall capture and enrichment in three steps
</commit_message>
<xml_diff>
--- a/presentation/falco-libs-intro.pptx
+++ b/presentation/falco-libs-intro.pptx
@@ -2,78 +2,77 @@
 <file path=ppt/presentation.xml><?xml version="1.0" encoding="utf-8"?>
 <p:presentation xmlns:p="http://schemas.openxmlformats.org/presentationml/2006/main" embedTrueTypeFonts="1" saveSubsetFonts="0">
   <p:sldMasterIdLst>
-    <p:sldMasterId xmlns:r="http://schemas.openxmlformats.org/officeDocument/2006/relationships" id="2147483648" r:id="R21652c24a2b3485e"/>
-    <p:sldMasterId xmlns:r="http://schemas.openxmlformats.org/officeDocument/2006/relationships" id="2147483661" r:id="Rf5c5503133cd4df4"/>
+    <p:sldMasterId xmlns:r="http://schemas.openxmlformats.org/officeDocument/2006/relationships" id="2147483648" r:id="R02603bc921114c3c"/>
+    <p:sldMasterId xmlns:r="http://schemas.openxmlformats.org/officeDocument/2006/relationships" id="2147483661" r:id="Rfc24a86afe904045"/>
   </p:sldMasterIdLst>
   <p:notesMasterIdLst>
-    <p:notesMasterId xmlns:r="http://schemas.openxmlformats.org/officeDocument/2006/relationships" r:id="Raa0952c61f644b88"/>
+    <p:notesMasterId xmlns:r="http://schemas.openxmlformats.org/officeDocument/2006/relationships" r:id="R9588de6c75f040b3"/>
   </p:notesMasterIdLst>
   <p:sldIdLst>
-    <p:sldId xmlns:r="http://schemas.openxmlformats.org/officeDocument/2006/relationships" id="256" r:id="R0b562d231af846d9"/>
-    <p:sldId xmlns:r="http://schemas.openxmlformats.org/officeDocument/2006/relationships" id="257" r:id="R57b06066b5e84cf3"/>
-    <p:sldId xmlns:r="http://schemas.openxmlformats.org/officeDocument/2006/relationships" id="258" r:id="R5ac950ef931745fd"/>
-    <p:sldId xmlns:r="http://schemas.openxmlformats.org/officeDocument/2006/relationships" id="259" r:id="R0c6a77d642054afd"/>
-    <p:sldId xmlns:r="http://schemas.openxmlformats.org/officeDocument/2006/relationships" id="260" r:id="Rc93ebd7a13ba4439"/>
-    <p:sldId xmlns:r="http://schemas.openxmlformats.org/officeDocument/2006/relationships" id="261" r:id="R3c3dc0f8fe6540a0"/>
-    <p:sldId xmlns:r="http://schemas.openxmlformats.org/officeDocument/2006/relationships" id="262" r:id="Rcdf0eaefb4374802"/>
-    <p:sldId xmlns:r="http://schemas.openxmlformats.org/officeDocument/2006/relationships" id="263" r:id="R61b684543fa04501"/>
-    <p:sldId xmlns:r="http://schemas.openxmlformats.org/officeDocument/2006/relationships" id="264" r:id="Rfee553c8f5fe481b"/>
-    <p:sldId xmlns:r="http://schemas.openxmlformats.org/officeDocument/2006/relationships" id="265" r:id="Rdc8cde017416422f"/>
-    <p:sldId xmlns:r="http://schemas.openxmlformats.org/officeDocument/2006/relationships" id="266" r:id="R3ba053c5f390485a"/>
-    <p:sldId xmlns:r="http://schemas.openxmlformats.org/officeDocument/2006/relationships" id="267" r:id="Rd73c2dffa8a84aa3"/>
-    <p:sldId xmlns:r="http://schemas.openxmlformats.org/officeDocument/2006/relationships" id="268" r:id="R1f0b57b2052d4276"/>
-    <p:sldId xmlns:r="http://schemas.openxmlformats.org/officeDocument/2006/relationships" id="269" r:id="R31f586d47f9b496e"/>
+    <p:sldId xmlns:r="http://schemas.openxmlformats.org/officeDocument/2006/relationships" id="256" r:id="R5ca17252d80a4190"/>
+    <p:sldId xmlns:r="http://schemas.openxmlformats.org/officeDocument/2006/relationships" id="257" r:id="R8b395fb7335142a4"/>
+    <p:sldId xmlns:r="http://schemas.openxmlformats.org/officeDocument/2006/relationships" id="258" r:id="R4f3f265d0258488e"/>
+    <p:sldId xmlns:r="http://schemas.openxmlformats.org/officeDocument/2006/relationships" id="259" r:id="Rdda57af707cf455c"/>
+    <p:sldId xmlns:r="http://schemas.openxmlformats.org/officeDocument/2006/relationships" id="260" r:id="R2636ecabef8848d4"/>
+    <p:sldId xmlns:r="http://schemas.openxmlformats.org/officeDocument/2006/relationships" id="261" r:id="R62c3b62261e74b6b"/>
+    <p:sldId xmlns:r="http://schemas.openxmlformats.org/officeDocument/2006/relationships" id="262" r:id="R6d4bab84d6d7478c"/>
+    <p:sldId xmlns:r="http://schemas.openxmlformats.org/officeDocument/2006/relationships" id="263" r:id="R327751b082944c7f"/>
+    <p:sldId xmlns:r="http://schemas.openxmlformats.org/officeDocument/2006/relationships" id="264" r:id="Re44e2a088bc6448c"/>
+    <p:sldId xmlns:r="http://schemas.openxmlformats.org/officeDocument/2006/relationships" id="265" r:id="R1f0984ff512d429f"/>
+    <p:sldId xmlns:r="http://schemas.openxmlformats.org/officeDocument/2006/relationships" id="266" r:id="R02cb962b0bb14d7d"/>
+    <p:sldId xmlns:r="http://schemas.openxmlformats.org/officeDocument/2006/relationships" id="267" r:id="R40c93cb600c84cc4"/>
+    <p:sldId xmlns:r="http://schemas.openxmlformats.org/officeDocument/2006/relationships" id="268" r:id="R6de05256f17549cc"/>
   </p:sldIdLst>
   <p:sldSz cx="9144000" cy="5143500"/>
   <p:notesSz cx="6858000" cy="9144000"/>
   <p:embeddedFontLst>
     <p:embeddedFont>
       <p:font typeface="Roboto Mono Medium"/>
-      <p:regular xmlns:r="http://schemas.openxmlformats.org/officeDocument/2006/relationships" r:id="Rc60efa67d81743ee"/>
-      <p:bold xmlns:r="http://schemas.openxmlformats.org/officeDocument/2006/relationships" r:id="Raab3d96778f74ff2"/>
-      <p:italic xmlns:r="http://schemas.openxmlformats.org/officeDocument/2006/relationships" r:id="R479b0283f33b48d3"/>
-      <p:boldItalic xmlns:r="http://schemas.openxmlformats.org/officeDocument/2006/relationships" r:id="R85dd1d6092a74e22"/>
+      <p:regular xmlns:r="http://schemas.openxmlformats.org/officeDocument/2006/relationships" r:id="R735ac5b9e8614570"/>
+      <p:bold xmlns:r="http://schemas.openxmlformats.org/officeDocument/2006/relationships" r:id="R07faeb611bd942d5"/>
+      <p:italic xmlns:r="http://schemas.openxmlformats.org/officeDocument/2006/relationships" r:id="R46aabf39c6e24afe"/>
+      <p:boldItalic xmlns:r="http://schemas.openxmlformats.org/officeDocument/2006/relationships" r:id="Rf565cfe296f14224"/>
     </p:embeddedFont>
     <p:embeddedFont>
       <p:font typeface="Inter SemiBold"/>
-      <p:regular xmlns:r="http://schemas.openxmlformats.org/officeDocument/2006/relationships" r:id="R4b0fb6936f1c4426"/>
-      <p:bold xmlns:r="http://schemas.openxmlformats.org/officeDocument/2006/relationships" r:id="Ref340476d70b4a11"/>
-      <p:italic xmlns:r="http://schemas.openxmlformats.org/officeDocument/2006/relationships" r:id="Ra3f84d62920b4e64"/>
-      <p:boldItalic xmlns:r="http://schemas.openxmlformats.org/officeDocument/2006/relationships" r:id="R0a2ed9dc087d4a35"/>
+      <p:regular xmlns:r="http://schemas.openxmlformats.org/officeDocument/2006/relationships" r:id="R95e59af2b9fc4c91"/>
+      <p:bold xmlns:r="http://schemas.openxmlformats.org/officeDocument/2006/relationships" r:id="R663b2b85ead744ac"/>
+      <p:italic xmlns:r="http://schemas.openxmlformats.org/officeDocument/2006/relationships" r:id="R39050b7717134cfc"/>
+      <p:boldItalic xmlns:r="http://schemas.openxmlformats.org/officeDocument/2006/relationships" r:id="R803c7ba72f6c4c29"/>
     </p:embeddedFont>
     <p:embeddedFont>
       <p:font typeface="Montserrat Black"/>
-      <p:bold xmlns:r="http://schemas.openxmlformats.org/officeDocument/2006/relationships" r:id="Rdf24b5b687c6493c"/>
-      <p:boldItalic xmlns:r="http://schemas.openxmlformats.org/officeDocument/2006/relationships" r:id="Ra7c17eefa4e04542"/>
+      <p:bold xmlns:r="http://schemas.openxmlformats.org/officeDocument/2006/relationships" r:id="R7b7772220372416a"/>
+      <p:boldItalic xmlns:r="http://schemas.openxmlformats.org/officeDocument/2006/relationships" r:id="Rd13103b156ec4012"/>
     </p:embeddedFont>
     <p:embeddedFont>
       <p:font typeface="Montserrat"/>
-      <p:bold xmlns:r="http://schemas.openxmlformats.org/officeDocument/2006/relationships" r:id="R7cec4a7c2cf54b27"/>
-      <p:boldItalic xmlns:r="http://schemas.openxmlformats.org/officeDocument/2006/relationships" r:id="R3835143f2ac54bee"/>
+      <p:bold xmlns:r="http://schemas.openxmlformats.org/officeDocument/2006/relationships" r:id="R874d104a06c94173"/>
+      <p:boldItalic xmlns:r="http://schemas.openxmlformats.org/officeDocument/2006/relationships" r:id="R81718cbba1e84dbf"/>
     </p:embeddedFont>
     <p:embeddedFont>
       <p:font typeface="Inter"/>
-      <p:regular xmlns:r="http://schemas.openxmlformats.org/officeDocument/2006/relationships" r:id="R09f15da8252040c1"/>
-      <p:bold xmlns:r="http://schemas.openxmlformats.org/officeDocument/2006/relationships" r:id="Rc59a77af749f45b5"/>
-      <p:italic xmlns:r="http://schemas.openxmlformats.org/officeDocument/2006/relationships" r:id="R1fead72e3c344fb9"/>
-      <p:boldItalic xmlns:r="http://schemas.openxmlformats.org/officeDocument/2006/relationships" r:id="Rb81459eb726d4c62"/>
+      <p:regular xmlns:r="http://schemas.openxmlformats.org/officeDocument/2006/relationships" r:id="R0b124bd2e26243c6"/>
+      <p:bold xmlns:r="http://schemas.openxmlformats.org/officeDocument/2006/relationships" r:id="Ra81830457e2048fb"/>
+      <p:italic xmlns:r="http://schemas.openxmlformats.org/officeDocument/2006/relationships" r:id="Re08ce2638dbd4b53"/>
+      <p:boldItalic xmlns:r="http://schemas.openxmlformats.org/officeDocument/2006/relationships" r:id="R0dd6984384324a1e"/>
     </p:embeddedFont>
     <p:embeddedFont>
       <p:font typeface="Montserrat ExtraBold"/>
-      <p:bold xmlns:r="http://schemas.openxmlformats.org/officeDocument/2006/relationships" r:id="Rb025534c149947aa"/>
-      <p:boldItalic xmlns:r="http://schemas.openxmlformats.org/officeDocument/2006/relationships" r:id="R35ee2bfe1fbc4c19"/>
+      <p:bold xmlns:r="http://schemas.openxmlformats.org/officeDocument/2006/relationships" r:id="Rb274a54105634cc6"/>
+      <p:boldItalic xmlns:r="http://schemas.openxmlformats.org/officeDocument/2006/relationships" r:id="R8613bdacaa474111"/>
     </p:embeddedFont>
     <p:embeddedFont>
       <p:font typeface="Roboto Mono"/>
-      <p:bold xmlns:r="http://schemas.openxmlformats.org/officeDocument/2006/relationships" r:id="R543ac1b21864449d"/>
-      <p:boldItalic xmlns:r="http://schemas.openxmlformats.org/officeDocument/2006/relationships" r:id="Rd10bec77a85448cd"/>
+      <p:bold xmlns:r="http://schemas.openxmlformats.org/officeDocument/2006/relationships" r:id="Re2642b3a8e4b42e0"/>
+      <p:boldItalic xmlns:r="http://schemas.openxmlformats.org/officeDocument/2006/relationships" r:id="R7a80f410841543f5"/>
     </p:embeddedFont>
     <p:embeddedFont>
       <p:font typeface="Inter Medium"/>
-      <p:regular xmlns:r="http://schemas.openxmlformats.org/officeDocument/2006/relationships" r:id="R176f45e0408a45a9"/>
-      <p:bold xmlns:r="http://schemas.openxmlformats.org/officeDocument/2006/relationships" r:id="R33c901003b5c455b"/>
-      <p:italic xmlns:r="http://schemas.openxmlformats.org/officeDocument/2006/relationships" r:id="R86bb325e0d2a448c"/>
-      <p:boldItalic xmlns:r="http://schemas.openxmlformats.org/officeDocument/2006/relationships" r:id="Rd1cc28c80ab74e43"/>
+      <p:regular xmlns:r="http://schemas.openxmlformats.org/officeDocument/2006/relationships" r:id="R9ee3b1fae5034bda"/>
+      <p:bold xmlns:r="http://schemas.openxmlformats.org/officeDocument/2006/relationships" r:id="R0ce96bd268e747e5"/>
+      <p:italic xmlns:r="http://schemas.openxmlformats.org/officeDocument/2006/relationships" r:id="R9cf00e7f5ac34684"/>
+      <p:boldItalic xmlns:r="http://schemas.openxmlformats.org/officeDocument/2006/relationships" r:id="Rf151d53fe41c4123"/>
     </p:embeddedFont>
   </p:embeddedFontLst>
 </p:presentation>
@@ -538,7 +537,7 @@
               <a:buNone/>
             </a:pPr>
             <a:r>
-              <a:t>Build a barebones libscap/libsinsp collector in small steps. Following along is optional. Set up Ubuntu first, then demonstrate attachment, event reading, filtering, and process context. Workshop code: https://github.com/julianshalaby-perj/falco-libs-workshop</a:t>
+              <a:t>Build a barebones libscap/libsinsp collector in small steps. Following along is optional. Set up Ubuntu first, then demonstrate attachment, event printing, and process context. Workshop code: https://github.com/julianshalaby-perj/falco-libs-workshop</a:t>
             </a:r>
             <a:endParaRPr/>
           </a:p>
@@ -618,7 +617,7 @@
               <a:buNone/>
             </a:pPr>
             <a:r>
-              <a:t>This continues the code installed by step 2. The count is events delivered successfully to this application, not a count of all syscalls on the machine. This first unfiltered run sees background activity. The runner automatically executes /usr/bin/id after attachment. Each successful read prints the event name. Printing starts in step 2, before filtering in step 3. The final summary counts events delivered to the application. SCAP_EOF is included for correct status handling; a live stream normally ends because the ten-second deadline expires. Source: https://github.com/falcosecurity/libs/blob/e72873882967cdd86b8753eca09ea3e9f91ccd4a/userspace/libsinsp/sinsp.h</a:t>
+              <a:t>This continues the code installed by step 2. The count is events delivered successfully to this application, not a count of all syscalls on the machine. This first unfiltered run sees background activity. The runner automatically executes /usr/bin/id after attachment. Each successful read prints the event name. Step 3 enriches the same event stream without adding a filter. SCAP_FILTERED_EVENT is a library status with no event to print, not a filter configured by this example. The final summary counts events delivered to the application. SCAP_EOF is included for correct status handling; a live stream normally ends because the ten-second deadline expires. Source: https://github.com/falcosecurity/libs/blob/e72873882967cdd86b8753eca09ea3e9f91ccd4a/userspace/libsinsp/sinsp.h</a:t>
             </a:r>
             <a:endParaRPr/>
           </a:p>
@@ -698,7 +697,7 @@
               <a:buNone/>
             </a:pPr>
             <a:r>
-              <a:t>The &lt; direction is a syscall exit event, not process termination. Filtering chooses which events next() returns to the application. The default driver syscall set is unchanged, so libsinsp can still maintain its process and file state. Do not promise exactly one event; other processes may execute during the window. Source: https://github.com/falcosecurity/libs/blob/e72873882967cdd86b8753eca09ea3e9f91ccd4a/userspace/libsinsp/sinsp.h</a:t>
+              <a:t>A missing thread record is possible, so check for nullptr. Print the event name even when process context is missing. Process names are short command names, not full executable paths or command lines. Use the event and thread data immediately; the inspector maintains their lifetime. Sources: https://github.com/falcosecurity/libs/blob/e72873882967cdd86b8753eca09ea3e9f91ccd4a/userspace/libsinsp/event.h and https://github.com/falcosecurity/libs/blob/e72873882967cdd86b8753eca09ea3e9f91ccd4a/userspace/libsinsp/threadinfo.h</a:t>
             </a:r>
             <a:endParaRPr/>
           </a:p>
@@ -778,7 +777,7 @@
               <a:buNone/>
             </a:pPr>
             <a:r>
-              <a:t>A missing thread record is possible, so check for nullptr. Process names are short command names, not full executable paths or command lines. Use the event and thread data immediately; the inspector maintains their lifetime. Sources: https://github.com/falcosecurity/libs/blob/e72873882967cdd86b8753eca09ea3e9f91ccd4a/userspace/libsinsp/event.h and https://github.com/falcosecurity/libs/blob/e72873882967cdd86b8753eca09ea3e9f91ccd4a/userspace/libsinsp/threadinfo.h</a:t>
+              <a:t>The output is illustrative. The ellipsis omits other events and the final count. Event names, process names, PIDs and counts vary. Step 3 includes all previous additions and works without running steps 1 and 2 first. Step scripts overwrite main.cpp and CMakeLists.txt locally. Run then rebuilds and captures, saving output to logs/latest.log. No filter or success-only condition is applied. Both syscall directions can appear, and background activity is included. The library default capture set is used, so this is not a guarantee of capturing every syscall on the machine.</a:t>
             </a:r>
             <a:endParaRPr/>
           </a:p>
@@ -858,86 +857,6 @@
               <a:buNone/>
             </a:pPr>
             <a:r>
-              <a:t>The output is illustrative, not a promise of one event. Step 4 includes all previous additions and works without running steps 1 and 2 first. Step scripts overwrite main.cpp and CMakeLists.txt locally. Run then rebuilds and captures, saving output to logs/latest.log. Process execution exit events can include failed calls; this workshop does not add success-only conditions or detection logic.</a:t>
-            </a:r>
-            <a:endParaRPr/>
-          </a:p>
-        </p:txBody>
-      </p:sp>
-      <p:sp>
-        <p:nvSpPr>
-          <p:cNvPr id="4" name="Slide Number Placeholder 3"/>
-          <p:cNvSpPr>
-            <a:spLocks xmlns:a="http://schemas.openxmlformats.org/drawingml/2006/main" noGrp="1"/>
-          </p:cNvSpPr>
-          <p:nvPr>
-            <p:ph type="sldNum" idx="5"/>
-          </p:nvPr>
-        </p:nvSpPr>
-        <p:spPr/>
-        <p:txBody>
-          <a:bodyPr xmlns:a="http://schemas.openxmlformats.org/drawingml/2006/main"/>
-          <a:lstStyle xmlns:a="http://schemas.openxmlformats.org/drawingml/2006/main"/>
-          <a:p xmlns:a="http://schemas.openxmlformats.org/drawingml/2006/main"/>
-        </p:txBody>
-      </p:sp>
-    </p:spTree>
-  </p:cSld>
-  <p:clrMapOvr>
-    <a:masterClrMapping xmlns:a="http://schemas.openxmlformats.org/drawingml/2006/main"/>
-  </p:clrMapOvr>
-</p:notes>
-</file>
-
-<file path=ppt/notesSlides/notesSlide14.xml><?xml version="1.0" encoding="utf-8"?>
-<p:notes xmlns:p="http://schemas.openxmlformats.org/presentationml/2006/main">
-  <p:cSld>
-    <p:spTree>
-      <p:nvGrpSpPr>
-        <p:cNvPr id="1" name=""/>
-        <p:cNvGrpSpPr/>
-        <p:nvPr/>
-      </p:nvGrpSpPr>
-      <p:grpSpPr>
-        <a:xfrm xmlns:a="http://schemas.openxmlformats.org/drawingml/2006/main"/>
-      </p:grpSpPr>
-      <p:sp>
-        <p:nvSpPr>
-          <p:cNvPr id="2" name="Slide Image Placeholder 1"/>
-          <p:cNvSpPr>
-            <a:spLocks xmlns:a="http://schemas.openxmlformats.org/drawingml/2006/main" noGrp="1"/>
-          </p:cNvSpPr>
-          <p:nvPr>
-            <p:ph type="sldImg" idx="0"/>
-          </p:nvPr>
-        </p:nvSpPr>
-        <p:spPr/>
-      </p:sp>
-      <p:sp>
-        <p:nvSpPr>
-          <p:cNvPr id="3" name="Notes Placeholder 2"/>
-          <p:cNvSpPr>
-            <a:spLocks xmlns:a="http://schemas.openxmlformats.org/drawingml/2006/main" noGrp="1"/>
-          </p:cNvSpPr>
-          <p:nvPr>
-            <p:ph type="body" idx="1"/>
-          </p:nvPr>
-        </p:nvSpPr>
-        <p:spPr/>
-        <p:txBody>
-          <a:bodyPr xmlns:a="http://schemas.openxmlformats.org/drawingml/2006/main"/>
-          <a:lstStyle xmlns:a="http://schemas.openxmlformats.org/drawingml/2006/main"/>
-          <a:p xmlns:a="http://schemas.openxmlformats.org/drawingml/2006/main">
-            <a:pPr marL="0" lvl="0" indent="0" algn="l">
-              <a:spcBef>
-                <a:spcPts val="0"/>
-              </a:spcBef>
-              <a:spcAft>
-                <a:spcPts val="0"/>
-              </a:spcAft>
-              <a:buNone/>
-            </a:pPr>
-            <a:r>
               <a:t>The run script handles sudo inside Ubuntu automatically. Setup prepares the libraries. The numbered scripts create the collector source. Run builds and starts it. Before source exists, run prints No agent yet. Run step 1. If Multipass commands are missing immediately after installation, reopen the host terminal. Setup waits for the Ubuntu image catalog before launch. Windows PowerShell parsing and source generation have passed native checks. The full Windows Multipass workflow still needs a rehearsal. Code and step scripts: https://github.com/julianshalaby-perj/falco-libs-workshop</a:t>
             </a:r>
             <a:endParaRPr/>
@@ -1018,7 +937,7 @@
               <a:buNone/>
             </a:pPr>
             <a:r>
-              <a:t>Following along is optional. Demonstrate each stage from the VM. The final collector prints minimal process execution records. There are no detection rules, JSON formatting, or production deployment exercises.</a:t>
+              <a:t>Following along is optional. Demonstrate each stage from the VM. The final collector prints the library event stream with process context. It applies no application filter and uses the default capture set. There are no detection rules, JSON formatting, or production deployment exercises.</a:t>
             </a:r>
             <a:endParaRPr/>
           </a:p>
@@ -5746,18 +5665,18 @@
   </p:cSld>
   <p:clrMap bg1="lt1" tx1="dk1" bg2="dk2" tx2="lt2" accent1="accent1" accent2="accent2" accent3="accent3" accent4="accent4" accent5="accent5" accent6="accent6" hlink="hlink" folHlink="folHlink"/>
   <p:sldLayoutIdLst>
-    <p:sldLayoutId xmlns:r="http://schemas.openxmlformats.org/officeDocument/2006/relationships" id="2147483649" r:id="R958a961fedad4d19"/>
-    <p:sldLayoutId xmlns:r="http://schemas.openxmlformats.org/officeDocument/2006/relationships" id="2147483650" r:id="Rbf0d52c28d754c00"/>
-    <p:sldLayoutId xmlns:r="http://schemas.openxmlformats.org/officeDocument/2006/relationships" id="2147483651" r:id="R1aba7f0192b548a0"/>
-    <p:sldLayoutId xmlns:r="http://schemas.openxmlformats.org/officeDocument/2006/relationships" id="2147483652" r:id="R7b7d1d8d49cb4d75"/>
-    <p:sldLayoutId xmlns:r="http://schemas.openxmlformats.org/officeDocument/2006/relationships" id="2147483653" r:id="R388e3aeb4b1749ae"/>
-    <p:sldLayoutId xmlns:r="http://schemas.openxmlformats.org/officeDocument/2006/relationships" id="2147483654" r:id="Rb6c6cbadb6824c2a"/>
-    <p:sldLayoutId xmlns:r="http://schemas.openxmlformats.org/officeDocument/2006/relationships" id="2147483655" r:id="Rb1c47666ec364c7f"/>
-    <p:sldLayoutId xmlns:r="http://schemas.openxmlformats.org/officeDocument/2006/relationships" id="2147483656" r:id="Ra271fc4b0c14460f"/>
-    <p:sldLayoutId xmlns:r="http://schemas.openxmlformats.org/officeDocument/2006/relationships" id="2147483657" r:id="R00f3443832344c1e"/>
-    <p:sldLayoutId xmlns:r="http://schemas.openxmlformats.org/officeDocument/2006/relationships" id="2147483658" r:id="R1adfdff0c9914306"/>
-    <p:sldLayoutId xmlns:r="http://schemas.openxmlformats.org/officeDocument/2006/relationships" id="2147483659" r:id="R21ac7d7df8c845ce"/>
-    <p:sldLayoutId xmlns:r="http://schemas.openxmlformats.org/officeDocument/2006/relationships" id="2147483660" r:id="Rdfaf91be90494a77"/>
+    <p:sldLayoutId xmlns:r="http://schemas.openxmlformats.org/officeDocument/2006/relationships" id="2147483649" r:id="Raa75d408bcf540f6"/>
+    <p:sldLayoutId xmlns:r="http://schemas.openxmlformats.org/officeDocument/2006/relationships" id="2147483650" r:id="R22cc52514f3b4590"/>
+    <p:sldLayoutId xmlns:r="http://schemas.openxmlformats.org/officeDocument/2006/relationships" id="2147483651" r:id="R8fb56f2b72a54644"/>
+    <p:sldLayoutId xmlns:r="http://schemas.openxmlformats.org/officeDocument/2006/relationships" id="2147483652" r:id="R6eab2bde13ae48f1"/>
+    <p:sldLayoutId xmlns:r="http://schemas.openxmlformats.org/officeDocument/2006/relationships" id="2147483653" r:id="Rd1f85f9a7a544ede"/>
+    <p:sldLayoutId xmlns:r="http://schemas.openxmlformats.org/officeDocument/2006/relationships" id="2147483654" r:id="R1228294d635a4176"/>
+    <p:sldLayoutId xmlns:r="http://schemas.openxmlformats.org/officeDocument/2006/relationships" id="2147483655" r:id="R12b2b73cfceb406f"/>
+    <p:sldLayoutId xmlns:r="http://schemas.openxmlformats.org/officeDocument/2006/relationships" id="2147483656" r:id="Ra1a8892e90f44359"/>
+    <p:sldLayoutId xmlns:r="http://schemas.openxmlformats.org/officeDocument/2006/relationships" id="2147483657" r:id="R685b25fbd72d4b68"/>
+    <p:sldLayoutId xmlns:r="http://schemas.openxmlformats.org/officeDocument/2006/relationships" id="2147483658" r:id="Rd5a40167512144ec"/>
+    <p:sldLayoutId xmlns:r="http://schemas.openxmlformats.org/officeDocument/2006/relationships" id="2147483659" r:id="R13df6fdf9f694995"/>
+    <p:sldLayoutId xmlns:r="http://schemas.openxmlformats.org/officeDocument/2006/relationships" id="2147483660" r:id="R5b031f1f2855446d"/>
   </p:sldLayoutIdLst>
   <p:hf sldNum="0" hdr="0" ftr="0" dt="0"/>
   <p:txStyles>
@@ -6442,7 +6361,7 @@
   </p:cSld>
   <p:clrMap bg1="lt1" tx1="dk1" bg2="dk2" tx2="lt2" accent1="accent1" accent2="accent2" accent3="accent3" accent4="accent4" accent5="accent5" accent6="accent6" hlink="hlink" folHlink="folHlink"/>
   <p:sldLayoutIdLst>
-    <p:sldLayoutId xmlns:r="http://schemas.openxmlformats.org/officeDocument/2006/relationships" id="2147483662" r:id="Ra3259ddcef174e4a"/>
+    <p:sldLayoutId xmlns:r="http://schemas.openxmlformats.org/officeDocument/2006/relationships" id="2147483662" r:id="Re1660626561a4976"/>
   </p:sldLayoutIdLst>
   <p:hf sldNum="0" hdr="0" ftr="0" dt="0"/>
   <p:txStyles>
@@ -8291,7 +8210,7 @@
           <p:nvPr/>
         </p:nvPicPr>
         <p:blipFill rotWithShape="1">
-          <a:blip xmlns:r="http://schemas.openxmlformats.org/officeDocument/2006/relationships" xmlns:a="http://schemas.openxmlformats.org/drawingml/2006/main" r:embed="R92664d9438964990">
+          <a:blip xmlns:r="http://schemas.openxmlformats.org/officeDocument/2006/relationships" xmlns:a="http://schemas.openxmlformats.org/drawingml/2006/main" r:embed="R5a1768705d1c45d5">
             <a:alphaModFix/>
           </a:blip>
           <a:srcRect xmlns:a="http://schemas.openxmlformats.org/drawingml/2006/main" l="0" t="0" r="0" b="0"/>
@@ -8319,7 +8238,7 @@
           <p:nvPr/>
         </p:nvPicPr>
         <p:blipFill rotWithShape="1">
-          <a:blip xmlns:r="http://schemas.openxmlformats.org/officeDocument/2006/relationships" xmlns:a="http://schemas.openxmlformats.org/drawingml/2006/main" r:embed="R92664d9438964990">
+          <a:blip xmlns:r="http://schemas.openxmlformats.org/officeDocument/2006/relationships" xmlns:a="http://schemas.openxmlformats.org/drawingml/2006/main" r:embed="R5a1768705d1c45d5">
             <a:alphaModFix/>
           </a:blip>
           <a:srcRect xmlns:a="http://schemas.openxmlformats.org/drawingml/2006/main" l="0" t="0" r="0" b="0"/>
@@ -8347,7 +8266,7 @@
           <p:nvPr/>
         </p:nvPicPr>
         <p:blipFill rotWithShape="1">
-          <a:blip xmlns:r="http://schemas.openxmlformats.org/officeDocument/2006/relationships" xmlns:a="http://schemas.openxmlformats.org/drawingml/2006/main" r:embed="R92664d9438964990">
+          <a:blip xmlns:r="http://schemas.openxmlformats.org/officeDocument/2006/relationships" xmlns:a="http://schemas.openxmlformats.org/drawingml/2006/main" r:embed="R5a1768705d1c45d5">
             <a:alphaModFix/>
           </a:blip>
           <a:srcRect xmlns:a="http://schemas.openxmlformats.org/drawingml/2006/main" l="0" t="0" r="0" b="0"/>
@@ -8375,7 +8294,7 @@
           <p:nvPr/>
         </p:nvPicPr>
         <p:blipFill rotWithShape="1">
-          <a:blip xmlns:r="http://schemas.openxmlformats.org/officeDocument/2006/relationships" xmlns:a="http://schemas.openxmlformats.org/drawingml/2006/main" r:embed="R92664d9438964990">
+          <a:blip xmlns:r="http://schemas.openxmlformats.org/officeDocument/2006/relationships" xmlns:a="http://schemas.openxmlformats.org/drawingml/2006/main" r:embed="R5a1768705d1c45d5">
             <a:alphaModFix/>
           </a:blip>
           <a:srcRect xmlns:a="http://schemas.openxmlformats.org/drawingml/2006/main" l="0" t="0" r="0" b="0"/>
@@ -8403,7 +8322,7 @@
           <p:nvPr/>
         </p:nvPicPr>
         <p:blipFill rotWithShape="1">
-          <a:blip xmlns:r="http://schemas.openxmlformats.org/officeDocument/2006/relationships" xmlns:a="http://schemas.openxmlformats.org/drawingml/2006/main" r:embed="R92664d9438964990">
+          <a:blip xmlns:r="http://schemas.openxmlformats.org/officeDocument/2006/relationships" xmlns:a="http://schemas.openxmlformats.org/drawingml/2006/main" r:embed="R5a1768705d1c45d5">
             <a:alphaModFix/>
           </a:blip>
           <a:srcRect xmlns:a="http://schemas.openxmlformats.org/drawingml/2006/main" l="0" t="0" r="0" b="0"/>
@@ -8431,7 +8350,7 @@
           <p:nvPr/>
         </p:nvPicPr>
         <p:blipFill rotWithShape="1">
-          <a:blip xmlns:r="http://schemas.openxmlformats.org/officeDocument/2006/relationships" xmlns:a="http://schemas.openxmlformats.org/drawingml/2006/main" r:embed="R92664d9438964990">
+          <a:blip xmlns:r="http://schemas.openxmlformats.org/officeDocument/2006/relationships" xmlns:a="http://schemas.openxmlformats.org/drawingml/2006/main" r:embed="R5a1768705d1c45d5">
             <a:alphaModFix/>
           </a:blip>
           <a:srcRect xmlns:a="http://schemas.openxmlformats.org/drawingml/2006/main" l="0" t="0" r="0" b="0"/>
@@ -8459,7 +8378,7 @@
           <p:nvPr/>
         </p:nvPicPr>
         <p:blipFill rotWithShape="1">
-          <a:blip xmlns:r="http://schemas.openxmlformats.org/officeDocument/2006/relationships" xmlns:a="http://schemas.openxmlformats.org/drawingml/2006/main" r:embed="R92664d9438964990">
+          <a:blip xmlns:r="http://schemas.openxmlformats.org/officeDocument/2006/relationships" xmlns:a="http://schemas.openxmlformats.org/drawingml/2006/main" r:embed="R5a1768705d1c45d5">
             <a:alphaModFix/>
           </a:blip>
           <a:srcRect xmlns:a="http://schemas.openxmlformats.org/drawingml/2006/main" l="0" t="0" r="0" b="0"/>
@@ -8487,7 +8406,7 @@
           <p:nvPr/>
         </p:nvPicPr>
         <p:blipFill rotWithShape="1">
-          <a:blip xmlns:r="http://schemas.openxmlformats.org/officeDocument/2006/relationships" xmlns:a="http://schemas.openxmlformats.org/drawingml/2006/main" r:embed="R92664d9438964990">
+          <a:blip xmlns:r="http://schemas.openxmlformats.org/officeDocument/2006/relationships" xmlns:a="http://schemas.openxmlformats.org/drawingml/2006/main" r:embed="R5a1768705d1c45d5">
             <a:alphaModFix/>
           </a:blip>
           <a:srcRect xmlns:a="http://schemas.openxmlformats.org/drawingml/2006/main" l="0" t="0" r="0" b="0"/>
@@ -9259,7 +9178,7 @@
                 <a:ea typeface="Inter"/>
                 <a:cs typeface="Inter"/>
               </a:rPr>
-              <a:t>Skip timeouts and filtered events.</a:t>
+              <a:t>Skip statuses with no event.</a:t>
             </a:r>
           </a:p>
           <a:p xmlns:a="http://schemas.openxmlformats.org/drawingml/2006/main">
@@ -9363,7 +9282,7 @@
                 <a:ea typeface="Inter"/>
                 <a:cs typeface="Inter"/>
               </a:rPr>
-              <a:t>Print each event name. Expect lots of output before adding a filter.</a:t>
+              <a:t>Print each event name. File operations, process activity and other events appear together.</a:t>
             </a:r>
           </a:p>
         </p:txBody>
@@ -10760,7 +10679,7 @@
           <p:nvPr/>
         </p:nvPicPr>
         <p:blipFill rotWithShape="1">
-          <a:blip xmlns:r="http://schemas.openxmlformats.org/officeDocument/2006/relationships" xmlns:a="http://schemas.openxmlformats.org/drawingml/2006/main" r:embed="Rb7be19b5ae614232">
+          <a:blip xmlns:r="http://schemas.openxmlformats.org/officeDocument/2006/relationships" xmlns:a="http://schemas.openxmlformats.org/drawingml/2006/main" r:embed="R695841d72e2f4a71">
             <a:alphaModFix/>
           </a:blip>
           <a:srcRect xmlns:a="http://schemas.openxmlformats.org/drawingml/2006/main" l="0" t="0" r="0" b="0"/>
@@ -10788,7 +10707,7 @@
           <p:nvPr/>
         </p:nvPicPr>
         <p:blipFill rotWithShape="1">
-          <a:blip xmlns:r="http://schemas.openxmlformats.org/officeDocument/2006/relationships" xmlns:a="http://schemas.openxmlformats.org/drawingml/2006/main" r:embed="Rb7be19b5ae614232">
+          <a:blip xmlns:r="http://schemas.openxmlformats.org/officeDocument/2006/relationships" xmlns:a="http://schemas.openxmlformats.org/drawingml/2006/main" r:embed="R695841d72e2f4a71">
             <a:alphaModFix/>
           </a:blip>
           <a:srcRect xmlns:a="http://schemas.openxmlformats.org/drawingml/2006/main" l="0" t="0" r="0" b="0"/>
@@ -10816,7 +10735,7 @@
           <p:nvPr/>
         </p:nvPicPr>
         <p:blipFill rotWithShape="1">
-          <a:blip xmlns:r="http://schemas.openxmlformats.org/officeDocument/2006/relationships" xmlns:a="http://schemas.openxmlformats.org/drawingml/2006/main" r:embed="Rb7be19b5ae614232">
+          <a:blip xmlns:r="http://schemas.openxmlformats.org/officeDocument/2006/relationships" xmlns:a="http://schemas.openxmlformats.org/drawingml/2006/main" r:embed="R695841d72e2f4a71">
             <a:alphaModFix/>
           </a:blip>
           <a:srcRect xmlns:a="http://schemas.openxmlformats.org/drawingml/2006/main" l="0" t="0" r="0" b="0"/>
@@ -10844,7 +10763,7 @@
           <p:nvPr/>
         </p:nvPicPr>
         <p:blipFill rotWithShape="1">
-          <a:blip xmlns:r="http://schemas.openxmlformats.org/officeDocument/2006/relationships" xmlns:a="http://schemas.openxmlformats.org/drawingml/2006/main" r:embed="Rb7be19b5ae614232">
+          <a:blip xmlns:r="http://schemas.openxmlformats.org/officeDocument/2006/relationships" xmlns:a="http://schemas.openxmlformats.org/drawingml/2006/main" r:embed="R695841d72e2f4a71">
             <a:alphaModFix/>
           </a:blip>
           <a:srcRect xmlns:a="http://schemas.openxmlformats.org/drawingml/2006/main" l="0" t="0" r="0" b="0"/>
@@ -11274,7 +11193,7 @@
                 <a:ea typeface="Montserrat"/>
                 <a:cs typeface="Montserrat"/>
               </a:rPr>
-              <a:t>Step 3: Keep process executions</a:t>
+              <a:t>Step 3: Add process context</a:t>
             </a:r>
           </a:p>
         </p:txBody>
@@ -11494,7 +11413,7 @@
                 <a:ea typeface="Inter"/>
                 <a:cs typeface="Inter"/>
               </a:rPr>
-              <a:t>The script adds this filter before capture. Example activity runs automatically.</a:t>
+              <a:t>The script adds PID and process name to the existing event output.</a:t>
             </a:r>
           </a:p>
           <a:p xmlns:a="http://schemas.openxmlformats.org/drawingml/2006/main">
@@ -11546,7 +11465,7 @@
                 <a:ea typeface="Inter"/>
                 <a:cs typeface="Inter"/>
               </a:rPr>
-              <a:t>The output now shows only execution exit events.</a:t>
+              <a:t>Keep every returned event, even when process context is unavailable.</a:t>
             </a:r>
           </a:p>
         </p:txBody>
@@ -11816,7 +11735,7 @@
                 <a:ea typeface="Roboto Mono"/>
                 <a:cs typeface="Roboto Mono"/>
               </a:rPr>
-              <a:t>Step 3: filter added to main.cpp</a:t>
+              <a:t>Step 3: context added to main.cpp</a:t>
             </a:r>
           </a:p>
         </p:txBody>
@@ -11933,7 +11852,7 @@
                 <a:ea typeface="Roboto Mono"/>
                 <a:cs typeface="Roboto Mono"/>
               </a:rPr>
-              <a:t>inspector.set_filter(</a:t>
+              <a:t>std::cout &lt;&lt; event-&gt;get_name();</a:t>
             </a:r>
           </a:p>
           <a:p xmlns:a="http://schemas.openxmlformats.org/drawingml/2006/main">
@@ -11963,7 +11882,7 @@
                 <a:ea typeface="Roboto Mono"/>
                 <a:cs typeface="Roboto Mono"/>
               </a:rPr>
-              <a:t>  "evt.type in (execve, execveat)"</a:t>
+              <a:t>const auto* process =</a:t>
             </a:r>
           </a:p>
           <a:p xmlns:a="http://schemas.openxmlformats.org/drawingml/2006/main">
@@ -11993,18 +11912,26 @@
                 <a:ea typeface="Roboto Mono"/>
                 <a:cs typeface="Roboto Mono"/>
               </a:rPr>
-              <a:t>  " and evt.dir=&lt;");</a:t>
-            </a:r>
-          </a:p>
-          <a:p xmlns:a="http://schemas.openxmlformats.org/drawingml/2006/main">
-            <a:pPr marL="0" indent="0">
-              <a:spcBef>
-                <a:spcPts val="0"/>
-              </a:spcBef>
-              <a:spcAft>
-                <a:spcPts val="0"/>
-              </a:spcAft>
-              <a:buNone/>
+              <a:t>    event-&gt;get_thread_info();</a:t>
+            </a:r>
+          </a:p>
+          <a:p xmlns:a="http://schemas.openxmlformats.org/drawingml/2006/main">
+            <a:pPr marL="0" indent="0" algn="l">
+              <a:spcBef>
+                <a:spcPts val="0"/>
+              </a:spcBef>
+              <a:spcAft>
+                <a:spcPts val="0"/>
+              </a:spcAft>
+              <a:buNone/>
+              <a:defRPr sz="1350" b="0">
+                <a:solidFill>
+                  <a:srgbClr val="00E5FF"/>
+                </a:solidFill>
+                <a:latin typeface="Roboto Mono"/>
+                <a:ea typeface="Roboto Mono"/>
+                <a:cs typeface="Roboto Mono"/>
+              </a:defRPr>
             </a:pPr>
             <a:r>
               <a:rPr sz="1350" b="0" i="0">
@@ -12015,7 +11942,7 @@
                 <a:ea typeface="Roboto Mono"/>
                 <a:cs typeface="Roboto Mono"/>
               </a:rPr>
-              <a:t/>
+              <a:t>if(process != nullptr) {</a:t>
             </a:r>
           </a:p>
           <a:p xmlns:a="http://schemas.openxmlformats.org/drawingml/2006/main">
@@ -12045,7 +11972,7 @@
                 <a:ea typeface="Roboto Mono"/>
                 <a:cs typeface="Roboto Mono"/>
               </a:rPr>
-              <a:t>// The runner generates activity</a:t>
+              <a:t>    std::cout &lt;&lt; " pid=" &lt;&lt; process-&gt;m_pid</a:t>
             </a:r>
           </a:p>
           <a:p xmlns:a="http://schemas.openxmlformats.org/drawingml/2006/main">
@@ -12075,7 +12002,67 @@
                 <a:ea typeface="Roboto Mono"/>
                 <a:cs typeface="Roboto Mono"/>
               </a:rPr>
-              <a:t>// inside Ubuntu automatically.</a:t>
+              <a:t>              &lt;&lt; " name=" &lt;&lt; process-&gt;m_comm;</a:t>
+            </a:r>
+          </a:p>
+          <a:p xmlns:a="http://schemas.openxmlformats.org/drawingml/2006/main">
+            <a:pPr marL="0" indent="0" algn="l">
+              <a:spcBef>
+                <a:spcPts val="0"/>
+              </a:spcBef>
+              <a:spcAft>
+                <a:spcPts val="0"/>
+              </a:spcAft>
+              <a:buNone/>
+              <a:defRPr sz="1350" b="0">
+                <a:solidFill>
+                  <a:srgbClr val="00E5FF"/>
+                </a:solidFill>
+                <a:latin typeface="Roboto Mono"/>
+                <a:ea typeface="Roboto Mono"/>
+                <a:cs typeface="Roboto Mono"/>
+              </a:defRPr>
+            </a:pPr>
+            <a:r>
+              <a:rPr sz="1350" b="0" i="0">
+                <a:solidFill>
+                  <a:srgbClr val="00E5FF"/>
+                </a:solidFill>
+                <a:latin typeface="Roboto Mono"/>
+                <a:ea typeface="Roboto Mono"/>
+                <a:cs typeface="Roboto Mono"/>
+              </a:rPr>
+              <a:t>}</a:t>
+            </a:r>
+          </a:p>
+          <a:p xmlns:a="http://schemas.openxmlformats.org/drawingml/2006/main">
+            <a:pPr marL="0" indent="0" algn="l">
+              <a:spcBef>
+                <a:spcPts val="0"/>
+              </a:spcBef>
+              <a:spcAft>
+                <a:spcPts val="0"/>
+              </a:spcAft>
+              <a:buNone/>
+              <a:defRPr sz="1350" b="0">
+                <a:solidFill>
+                  <a:srgbClr val="00E5FF"/>
+                </a:solidFill>
+                <a:latin typeface="Roboto Mono"/>
+                <a:ea typeface="Roboto Mono"/>
+                <a:cs typeface="Roboto Mono"/>
+              </a:defRPr>
+            </a:pPr>
+            <a:r>
+              <a:rPr sz="1350" b="0" i="0">
+                <a:solidFill>
+                  <a:srgbClr val="00E5FF"/>
+                </a:solidFill>
+                <a:latin typeface="Roboto Mono"/>
+                <a:ea typeface="Roboto Mono"/>
+                <a:cs typeface="Roboto Mono"/>
+              </a:rPr>
+              <a:t>std::cout &lt;&lt; '\n';</a:t>
             </a:r>
           </a:p>
         </p:txBody>
@@ -12725,7 +12712,7 @@
           <p:nvPr/>
         </p:nvPicPr>
         <p:blipFill rotWithShape="1">
-          <a:blip xmlns:r="http://schemas.openxmlformats.org/officeDocument/2006/relationships" xmlns:a="http://schemas.openxmlformats.org/drawingml/2006/main" r:embed="R7d28195af0d3456e">
+          <a:blip xmlns:r="http://schemas.openxmlformats.org/officeDocument/2006/relationships" xmlns:a="http://schemas.openxmlformats.org/drawingml/2006/main" r:embed="R9cd95e0aa3154383">
             <a:alphaModFix/>
           </a:blip>
           <a:srcRect xmlns:a="http://schemas.openxmlformats.org/drawingml/2006/main" l="0" t="0" r="0" b="0"/>
@@ -12753,7 +12740,7 @@
           <p:nvPr/>
         </p:nvPicPr>
         <p:blipFill rotWithShape="1">
-          <a:blip xmlns:r="http://schemas.openxmlformats.org/officeDocument/2006/relationships" xmlns:a="http://schemas.openxmlformats.org/drawingml/2006/main" r:embed="R7d28195af0d3456e">
+          <a:blip xmlns:r="http://schemas.openxmlformats.org/officeDocument/2006/relationships" xmlns:a="http://schemas.openxmlformats.org/drawingml/2006/main" r:embed="R9cd95e0aa3154383">
             <a:alphaModFix/>
           </a:blip>
           <a:srcRect xmlns:a="http://schemas.openxmlformats.org/drawingml/2006/main" l="0" t="0" r="0" b="0"/>
@@ -12781,7 +12768,7 @@
           <p:nvPr/>
         </p:nvPicPr>
         <p:blipFill rotWithShape="1">
-          <a:blip xmlns:r="http://schemas.openxmlformats.org/officeDocument/2006/relationships" xmlns:a="http://schemas.openxmlformats.org/drawingml/2006/main" r:embed="R7d28195af0d3456e">
+          <a:blip xmlns:r="http://schemas.openxmlformats.org/officeDocument/2006/relationships" xmlns:a="http://schemas.openxmlformats.org/drawingml/2006/main" r:embed="R9cd95e0aa3154383">
             <a:alphaModFix/>
           </a:blip>
           <a:srcRect xmlns:a="http://schemas.openxmlformats.org/drawingml/2006/main" l="0" t="0" r="0" b="0"/>
@@ -12809,7 +12796,7 @@
           <p:nvPr/>
         </p:nvPicPr>
         <p:blipFill rotWithShape="1">
-          <a:blip xmlns:r="http://schemas.openxmlformats.org/officeDocument/2006/relationships" xmlns:a="http://schemas.openxmlformats.org/drawingml/2006/main" r:embed="R7d28195af0d3456e">
+          <a:blip xmlns:r="http://schemas.openxmlformats.org/officeDocument/2006/relationships" xmlns:a="http://schemas.openxmlformats.org/drawingml/2006/main" r:embed="R9cd95e0aa3154383">
             <a:alphaModFix/>
           </a:blip>
           <a:srcRect xmlns:a="http://schemas.openxmlformats.org/drawingml/2006/main" l="0" t="0" r="0" b="0"/>
@@ -13239,7 +13226,7 @@
                 <a:ea typeface="Montserrat"/>
                 <a:cs typeface="Montserrat"/>
               </a:rPr>
-              <a:t>Step 4: Add process context</a:t>
+              <a:t>The finished collector</a:t>
             </a:r>
           </a:p>
         </p:txBody>
@@ -13407,7 +13394,7 @@
                 <a:ea typeface="Inter"/>
                 <a:cs typeface="Inter"/>
               </a:rPr>
-              <a:t>Run step 4, then run.</a:t>
+              <a:t>Attach. Print. Add context.</a:t>
             </a:r>
           </a:p>
           <a:p xmlns:a="http://schemas.openxmlformats.org/drawingml/2006/main">
@@ -13459,7 +13446,7 @@
                 <a:ea typeface="Inter"/>
                 <a:cs typeface="Inter"/>
               </a:rPr>
-              <a:t>The script adds PID and process name to the existing event output.</a:t>
+              <a:t>Common syscall events with PID and process name.</a:t>
             </a:r>
           </a:p>
           <a:p xmlns:a="http://schemas.openxmlformats.org/drawingml/2006/main">
@@ -13511,7 +13498,59 @@
                 <a:ea typeface="Inter"/>
                 <a:cs typeface="Inter"/>
               </a:rPr>
-              <a:t>Look for an execution with name=id.</a:t>
+              <a:t>It stops after ten seconds.</a:t>
+            </a:r>
+          </a:p>
+          <a:p xmlns:a="http://schemas.openxmlformats.org/drawingml/2006/main">
+            <a:pPr marL="0" indent="0">
+              <a:spcBef>
+                <a:spcPts val="0"/>
+              </a:spcBef>
+              <a:spcAft>
+                <a:spcPts val="0"/>
+              </a:spcAft>
+              <a:buNone/>
+            </a:pPr>
+            <a:r>
+              <a:rPr sz="1500" b="0" i="0">
+                <a:solidFill>
+                  <a:srgbClr val="4A5568"/>
+                </a:solidFill>
+                <a:latin typeface="Inter"/>
+                <a:ea typeface="Inter"/>
+                <a:cs typeface="Inter"/>
+              </a:rPr>
+              <a:t/>
+            </a:r>
+          </a:p>
+          <a:p xmlns:a="http://schemas.openxmlformats.org/drawingml/2006/main">
+            <a:pPr marL="0" indent="0" algn="l">
+              <a:spcBef>
+                <a:spcPts val="0"/>
+              </a:spcBef>
+              <a:spcAft>
+                <a:spcPts val="0"/>
+              </a:spcAft>
+              <a:buNone/>
+              <a:defRPr sz="1500" b="0">
+                <a:solidFill>
+                  <a:srgbClr val="4A5568"/>
+                </a:solidFill>
+                <a:latin typeface="Inter"/>
+                <a:ea typeface="Inter"/>
+                <a:cs typeface="Inter"/>
+              </a:defRPr>
+            </a:pPr>
+            <a:r>
+              <a:rPr sz="1500" b="0" i="0">
+                <a:solidFill>
+                  <a:srgbClr val="4A5568"/>
+                </a:solidFill>
+                <a:latin typeface="Inter"/>
+                <a:ea typeface="Inter"/>
+                <a:cs typeface="Inter"/>
+              </a:rPr>
+              <a:t>Step 3 writes the complete collector. Run rebuilds and captures.</a:t>
             </a:r>
           </a:p>
         </p:txBody>
@@ -13781,7 +13820,7 @@
                 <a:ea typeface="Roboto Mono"/>
                 <a:cs typeface="Roboto Mono"/>
               </a:rPr>
-              <a:t>Step 4: context added to main.cpp</a:t>
+              <a:t>Example output; PID and count will vary</a:t>
             </a:r>
           </a:p>
         </p:txBody>
@@ -13898,7 +13937,7 @@
                 <a:ea typeface="Roboto Mono"/>
                 <a:cs typeface="Roboto Mono"/>
               </a:rPr>
-              <a:t>const auto* process =</a:t>
+              <a:t>Attached to the Ubuntu kernel.</a:t>
             </a:r>
           </a:p>
           <a:p xmlns:a="http://schemas.openxmlformats.org/drawingml/2006/main">
@@ -13928,7 +13967,7 @@
                 <a:ea typeface="Roboto Mono"/>
                 <a:cs typeface="Roboto Mono"/>
               </a:rPr>
-              <a:t>    event-&gt;get_thread_info();</a:t>
+              <a:t>openat pid=1234 name=id</a:t>
             </a:r>
           </a:p>
           <a:p xmlns:a="http://schemas.openxmlformats.org/drawingml/2006/main">
@@ -13958,7 +13997,7 @@
                 <a:ea typeface="Roboto Mono"/>
                 <a:cs typeface="Roboto Mono"/>
               </a:rPr>
-              <a:t>if(process != nullptr) {</a:t>
+              <a:t>read pid=1234 name=id</a:t>
             </a:r>
           </a:p>
           <a:p xmlns:a="http://schemas.openxmlformats.org/drawingml/2006/main">
@@ -13988,7 +14027,7 @@
                 <a:ea typeface="Roboto Mono"/>
                 <a:cs typeface="Roboto Mono"/>
               </a:rPr>
-              <a:t>    std::cout &lt;&lt; event-&gt;get_name()</a:t>
+              <a:t>close pid=1234 name=id</a:t>
             </a:r>
           </a:p>
           <a:p xmlns:a="http://schemas.openxmlformats.org/drawingml/2006/main">
@@ -14018,7 +14057,7 @@
                 <a:ea typeface="Roboto Mono"/>
                 <a:cs typeface="Roboto Mono"/>
               </a:rPr>
-              <a:t>              &lt;&lt; " pid=" &lt;&lt; process-&gt;m_pid</a:t>
+              <a:t>...</a:t>
             </a:r>
           </a:p>
           <a:p xmlns:a="http://schemas.openxmlformats.org/drawingml/2006/main">
@@ -14048,7 +14087,29 @@
                 <a:ea typeface="Roboto Mono"/>
                 <a:cs typeface="Roboto Mono"/>
               </a:rPr>
-              <a:t>              &lt;&lt; " name=" &lt;&lt; process-&gt;m_comm</a:t>
+              <a:t>Capture stopped.</a:t>
+            </a:r>
+          </a:p>
+          <a:p xmlns:a="http://schemas.openxmlformats.org/drawingml/2006/main">
+            <a:pPr marL="0" indent="0">
+              <a:spcBef>
+                <a:spcPts val="0"/>
+              </a:spcBef>
+              <a:spcAft>
+                <a:spcPts val="0"/>
+              </a:spcAft>
+              <a:buNone/>
+            </a:pPr>
+            <a:r>
+              <a:rPr sz="1350" b="0" i="0">
+                <a:solidFill>
+                  <a:srgbClr val="00E5FF"/>
+                </a:solidFill>
+                <a:latin typeface="Roboto Mono"/>
+                <a:ea typeface="Roboto Mono"/>
+                <a:cs typeface="Roboto Mono"/>
+              </a:rPr>
+              <a:t/>
             </a:r>
           </a:p>
           <a:p xmlns:a="http://schemas.openxmlformats.org/drawingml/2006/main">
@@ -14078,7 +14139,7 @@
                 <a:ea typeface="Roboto Mono"/>
                 <a:cs typeface="Roboto Mono"/>
               </a:rPr>
-              <a:t>              &lt;&lt; std::endl;</a:t>
+              <a:t># Saved on your laptop</a:t>
             </a:r>
           </a:p>
           <a:p xmlns:a="http://schemas.openxmlformats.org/drawingml/2006/main">
@@ -14108,7 +14169,7 @@
                 <a:ea typeface="Roboto Mono"/>
                 <a:cs typeface="Roboto Mono"/>
               </a:rPr>
-              <a:t>}</a:t>
+              <a:t>logs/latest.log</a:t>
             </a:r>
           </a:p>
         </p:txBody>
@@ -14758,7 +14819,7 @@
           <p:nvPr/>
         </p:nvPicPr>
         <p:blipFill rotWithShape="1">
-          <a:blip xmlns:r="http://schemas.openxmlformats.org/officeDocument/2006/relationships" xmlns:a="http://schemas.openxmlformats.org/drawingml/2006/main" r:embed="R58b2a480d3a64910">
+          <a:blip xmlns:r="http://schemas.openxmlformats.org/officeDocument/2006/relationships" xmlns:a="http://schemas.openxmlformats.org/drawingml/2006/main" r:embed="R8ed655c8035b4750">
             <a:alphaModFix/>
           </a:blip>
           <a:srcRect xmlns:a="http://schemas.openxmlformats.org/drawingml/2006/main" l="0" t="0" r="0" b="0"/>
@@ -14786,7 +14847,7 @@
           <p:nvPr/>
         </p:nvPicPr>
         <p:blipFill rotWithShape="1">
-          <a:blip xmlns:r="http://schemas.openxmlformats.org/officeDocument/2006/relationships" xmlns:a="http://schemas.openxmlformats.org/drawingml/2006/main" r:embed="R58b2a480d3a64910">
+          <a:blip xmlns:r="http://schemas.openxmlformats.org/officeDocument/2006/relationships" xmlns:a="http://schemas.openxmlformats.org/drawingml/2006/main" r:embed="R8ed655c8035b4750">
             <a:alphaModFix/>
           </a:blip>
           <a:srcRect xmlns:a="http://schemas.openxmlformats.org/drawingml/2006/main" l="0" t="0" r="0" b="0"/>
@@ -14814,7 +14875,7 @@
           <p:nvPr/>
         </p:nvPicPr>
         <p:blipFill rotWithShape="1">
-          <a:blip xmlns:r="http://schemas.openxmlformats.org/officeDocument/2006/relationships" xmlns:a="http://schemas.openxmlformats.org/drawingml/2006/main" r:embed="R58b2a480d3a64910">
+          <a:blip xmlns:r="http://schemas.openxmlformats.org/officeDocument/2006/relationships" xmlns:a="http://schemas.openxmlformats.org/drawingml/2006/main" r:embed="R8ed655c8035b4750">
             <a:alphaModFix/>
           </a:blip>
           <a:srcRect xmlns:a="http://schemas.openxmlformats.org/drawingml/2006/main" l="0" t="0" r="0" b="0"/>
@@ -14842,7 +14903,7 @@
           <p:nvPr/>
         </p:nvPicPr>
         <p:blipFill rotWithShape="1">
-          <a:blip xmlns:r="http://schemas.openxmlformats.org/officeDocument/2006/relationships" xmlns:a="http://schemas.openxmlformats.org/drawingml/2006/main" r:embed="R58b2a480d3a64910">
+          <a:blip xmlns:r="http://schemas.openxmlformats.org/officeDocument/2006/relationships" xmlns:a="http://schemas.openxmlformats.org/drawingml/2006/main" r:embed="R8ed655c8035b4750">
             <a:alphaModFix/>
           </a:blip>
           <a:srcRect xmlns:a="http://schemas.openxmlformats.org/drawingml/2006/main" l="0" t="0" r="0" b="0"/>
@@ -15272,7 +15333,7 @@
                 <a:ea typeface="Montserrat"/>
                 <a:cs typeface="Montserrat"/>
               </a:rPr>
-              <a:t>The finished collector</a:t>
+              <a:t>After the workshop</a:t>
             </a:r>
           </a:p>
         </p:txBody>
@@ -15440,7 +15501,7 @@
                 <a:ea typeface="Inter"/>
                 <a:cs typeface="Inter"/>
               </a:rPr>
-              <a:t>Attach. Print. Filter. Add context.</a:t>
+              <a:t>The collector monitors the Ubuntu VM.</a:t>
             </a:r>
           </a:p>
           <a:p xmlns:a="http://schemas.openxmlformats.org/drawingml/2006/main">
@@ -15492,7 +15553,7 @@
                 <a:ea typeface="Inter"/>
                 <a:cs typeface="Inter"/>
               </a:rPr>
-              <a:t>One short line per process execution.</a:t>
+              <a:t>libscap handles capture. libsinsp adds context.</a:t>
             </a:r>
           </a:p>
           <a:p xmlns:a="http://schemas.openxmlformats.org/drawingml/2006/main">
@@ -15544,59 +15605,7 @@
                 <a:ea typeface="Inter"/>
                 <a:cs typeface="Inter"/>
               </a:rPr>
-              <a:t>It stops after ten seconds.</a:t>
-            </a:r>
-          </a:p>
-          <a:p xmlns:a="http://schemas.openxmlformats.org/drawingml/2006/main">
-            <a:pPr marL="0" indent="0">
-              <a:spcBef>
-                <a:spcPts val="0"/>
-              </a:spcBef>
-              <a:spcAft>
-                <a:spcPts val="0"/>
-              </a:spcAft>
-              <a:buNone/>
-            </a:pPr>
-            <a:r>
-              <a:rPr sz="1500" b="0" i="0">
-                <a:solidFill>
-                  <a:srgbClr val="4A5568"/>
-                </a:solidFill>
-                <a:latin typeface="Inter"/>
-                <a:ea typeface="Inter"/>
-                <a:cs typeface="Inter"/>
-              </a:rPr>
-              <a:t/>
-            </a:r>
-          </a:p>
-          <a:p xmlns:a="http://schemas.openxmlformats.org/drawingml/2006/main">
-            <a:pPr marL="0" indent="0" algn="l">
-              <a:spcBef>
-                <a:spcPts val="0"/>
-              </a:spcBef>
-              <a:spcAft>
-                <a:spcPts val="0"/>
-              </a:spcAft>
-              <a:buNone/>
-              <a:defRPr sz="1500" b="0">
-                <a:solidFill>
-                  <a:srgbClr val="4A5568"/>
-                </a:solidFill>
-                <a:latin typeface="Inter"/>
-                <a:ea typeface="Inter"/>
-                <a:cs typeface="Inter"/>
-              </a:defRPr>
-            </a:pPr>
-            <a:r>
-              <a:rPr sz="1500" b="0" i="0">
-                <a:solidFill>
-                  <a:srgbClr val="4A5568"/>
-                </a:solidFill>
-                <a:latin typeface="Inter"/>
-                <a:ea typeface="Inter"/>
-                <a:cs typeface="Inter"/>
-              </a:rPr>
-              <a:t>Step 4 writes the complete collector. Run rebuilds and captures.</a:t>
+              <a:t>Stop the VM when you are done.</a:t>
             </a:r>
           </a:p>
         </p:txBody>
@@ -15866,7 +15875,7 @@
                 <a:ea typeface="Roboto Mono"/>
                 <a:cs typeface="Roboto Mono"/>
               </a:rPr>
-              <a:t>Example output; PID and count will vary</a:t>
+              <a:t>Host terminal</a:t>
             </a:r>
           </a:p>
         </p:txBody>
@@ -15983,97 +15992,7 @@
                 <a:ea typeface="Roboto Mono"/>
                 <a:cs typeface="Roboto Mono"/>
               </a:rPr>
-              <a:t>Attached to the Ubuntu kernel.</a:t>
-            </a:r>
-          </a:p>
-          <a:p xmlns:a="http://schemas.openxmlformats.org/drawingml/2006/main">
-            <a:pPr marL="0" indent="0" algn="l">
-              <a:spcBef>
-                <a:spcPts val="0"/>
-              </a:spcBef>
-              <a:spcAft>
-                <a:spcPts val="0"/>
-              </a:spcAft>
-              <a:buNone/>
-              <a:defRPr sz="1350" b="0">
-                <a:solidFill>
-                  <a:srgbClr val="00E5FF"/>
-                </a:solidFill>
-                <a:latin typeface="Roboto Mono"/>
-                <a:ea typeface="Roboto Mono"/>
-                <a:cs typeface="Roboto Mono"/>
-              </a:defRPr>
-            </a:pPr>
-            <a:r>
-              <a:rPr sz="1350" b="0" i="0">
-                <a:solidFill>
-                  <a:srgbClr val="00E5FF"/>
-                </a:solidFill>
-                <a:latin typeface="Roboto Mono"/>
-                <a:ea typeface="Roboto Mono"/>
-                <a:cs typeface="Roboto Mono"/>
-              </a:rPr>
-              <a:t>execve pid=1234 name=id</a:t>
-            </a:r>
-          </a:p>
-          <a:p xmlns:a="http://schemas.openxmlformats.org/drawingml/2006/main">
-            <a:pPr marL="0" indent="0" algn="l">
-              <a:spcBef>
-                <a:spcPts val="0"/>
-              </a:spcBef>
-              <a:spcAft>
-                <a:spcPts val="0"/>
-              </a:spcAft>
-              <a:buNone/>
-              <a:defRPr sz="1350" b="0">
-                <a:solidFill>
-                  <a:srgbClr val="00E5FF"/>
-                </a:solidFill>
-                <a:latin typeface="Roboto Mono"/>
-                <a:ea typeface="Roboto Mono"/>
-                <a:cs typeface="Roboto Mono"/>
-              </a:defRPr>
-            </a:pPr>
-            <a:r>
-              <a:rPr sz="1350" b="0" i="0">
-                <a:solidFill>
-                  <a:srgbClr val="00E5FF"/>
-                </a:solidFill>
-                <a:latin typeface="Roboto Mono"/>
-                <a:ea typeface="Roboto Mono"/>
-                <a:cs typeface="Roboto Mono"/>
-              </a:rPr>
-              <a:t>Read 1 process-execution events.</a:t>
-            </a:r>
-          </a:p>
-          <a:p xmlns:a="http://schemas.openxmlformats.org/drawingml/2006/main">
-            <a:pPr marL="0" indent="0" algn="l">
-              <a:spcBef>
-                <a:spcPts val="0"/>
-              </a:spcBef>
-              <a:spcAft>
-                <a:spcPts val="0"/>
-              </a:spcAft>
-              <a:buNone/>
-              <a:defRPr sz="1350" b="0">
-                <a:solidFill>
-                  <a:srgbClr val="00E5FF"/>
-                </a:solidFill>
-                <a:latin typeface="Roboto Mono"/>
-                <a:ea typeface="Roboto Mono"/>
-                <a:cs typeface="Roboto Mono"/>
-              </a:defRPr>
-            </a:pPr>
-            <a:r>
-              <a:rPr sz="1350" b="0" i="0">
-                <a:solidFill>
-                  <a:srgbClr val="00E5FF"/>
-                </a:solidFill>
-                <a:latin typeface="Roboto Mono"/>
-                <a:ea typeface="Roboto Mono"/>
-                <a:cs typeface="Roboto Mono"/>
-              </a:rPr>
-              <a:t>Capture stopped.</a:t>
+              <a:t>multipass stop falco-lab</a:t>
             </a:r>
           </a:p>
           <a:p xmlns:a="http://schemas.openxmlformats.org/drawingml/2006/main">
@@ -16125,7 +16044,7 @@
                 <a:ea typeface="Roboto Mono"/>
                 <a:cs typeface="Roboto Mono"/>
               </a:rPr>
-              <a:t># Saved on your laptop</a:t>
+              <a:t># Next time, use your run script.</a:t>
             </a:r>
           </a:p>
           <a:p xmlns:a="http://schemas.openxmlformats.org/drawingml/2006/main">
@@ -16155,7 +16074,7 @@
                 <a:ea typeface="Roboto Mono"/>
                 <a:cs typeface="Roboto Mono"/>
               </a:rPr>
-              <a:t>logs/latest.log</a:t>
+              <a:t># It starts the VM automatically.</a:t>
             </a:r>
           </a:p>
         </p:txBody>
@@ -16805,7 +16724,7 @@
           <p:nvPr/>
         </p:nvPicPr>
         <p:blipFill rotWithShape="1">
-          <a:blip xmlns:r="http://schemas.openxmlformats.org/officeDocument/2006/relationships" xmlns:a="http://schemas.openxmlformats.org/drawingml/2006/main" r:embed="Raf0d70a39fa847ed">
+          <a:blip xmlns:r="http://schemas.openxmlformats.org/officeDocument/2006/relationships" xmlns:a="http://schemas.openxmlformats.org/drawingml/2006/main" r:embed="Rdab58bcbee054095">
             <a:alphaModFix/>
           </a:blip>
           <a:srcRect xmlns:a="http://schemas.openxmlformats.org/drawingml/2006/main" l="0" t="0" r="0" b="0"/>
@@ -16833,7 +16752,7 @@
           <p:nvPr/>
         </p:nvPicPr>
         <p:blipFill rotWithShape="1">
-          <a:blip xmlns:r="http://schemas.openxmlformats.org/officeDocument/2006/relationships" xmlns:a="http://schemas.openxmlformats.org/drawingml/2006/main" r:embed="Raf0d70a39fa847ed">
+          <a:blip xmlns:r="http://schemas.openxmlformats.org/officeDocument/2006/relationships" xmlns:a="http://schemas.openxmlformats.org/drawingml/2006/main" r:embed="Rdab58bcbee054095">
             <a:alphaModFix/>
           </a:blip>
           <a:srcRect xmlns:a="http://schemas.openxmlformats.org/drawingml/2006/main" l="0" t="0" r="0" b="0"/>
@@ -16861,7 +16780,7 @@
           <p:nvPr/>
         </p:nvPicPr>
         <p:blipFill rotWithShape="1">
-          <a:blip xmlns:r="http://schemas.openxmlformats.org/officeDocument/2006/relationships" xmlns:a="http://schemas.openxmlformats.org/drawingml/2006/main" r:embed="Raf0d70a39fa847ed">
+          <a:blip xmlns:r="http://schemas.openxmlformats.org/officeDocument/2006/relationships" xmlns:a="http://schemas.openxmlformats.org/drawingml/2006/main" r:embed="Rdab58bcbee054095">
             <a:alphaModFix/>
           </a:blip>
           <a:srcRect xmlns:a="http://schemas.openxmlformats.org/drawingml/2006/main" l="0" t="0" r="0" b="0"/>
@@ -16889,1912 +16808,7 @@
           <p:nvPr/>
         </p:nvPicPr>
         <p:blipFill rotWithShape="1">
-          <a:blip xmlns:r="http://schemas.openxmlformats.org/officeDocument/2006/relationships" xmlns:a="http://schemas.openxmlformats.org/drawingml/2006/main" r:embed="Raf0d70a39fa847ed">
-            <a:alphaModFix/>
-          </a:blip>
-          <a:srcRect xmlns:a="http://schemas.openxmlformats.org/drawingml/2006/main" l="0" t="0" r="0" b="0"/>
-          <a:stretch xmlns:a="http://schemas.openxmlformats.org/drawingml/2006/main"/>
-        </p:blipFill>
-        <p:spPr>
-          <a:xfrm xmlns:a="http://schemas.openxmlformats.org/drawingml/2006/main" rot="0" flipH="0" flipV="0">
-            <a:off x="647700" y="5029200"/>
-            <a:ext cx="38100" cy="38100"/>
-          </a:xfrm>
-          <a:prstGeom xmlns:a="http://schemas.openxmlformats.org/drawingml/2006/main" prst="rect">
-            <a:avLst/>
-          </a:prstGeom>
-          <a:ln xmlns:a="http://schemas.openxmlformats.org/drawingml/2006/main">
-            <a:noFill/>
-          </a:ln>
-        </p:spPr>
-      </p:pic>
-      <p:sp>
-        <p:nvSpPr>
-          <p:cNvPr id="632" name="Google Shape;632;p30">
-            <a:extLst xmlns:a="http://schemas.openxmlformats.org/drawingml/2006/main">
-              <a:ext uri="{FF2B5EF4-FFF2-40B4-BE49-F238E27FC236}">
-                <a16:creationId xmlns:a16="http://schemas.microsoft.com/office/drawing/2014/main" id="{E262D8CA-B2E6-42BF-B284-8A72626B147C}"/>
-              </a:ext>
-            </a:extLst>
-          </p:cNvPr>
-          <p:cNvSpPr>
-            <a:spLocks xmlns:a="http://schemas.openxmlformats.org/drawingml/2006/main" noGrp="1"/>
-          </p:cNvSpPr>
-          <p:nvPr/>
-        </p:nvSpPr>
-        <p:spPr>
-          <a:xfrm xmlns:a="http://schemas.openxmlformats.org/drawingml/2006/main">
-            <a:off x="457200" y="228600"/>
-            <a:ext cx="4762500" cy="285900"/>
-          </a:xfrm>
-          <a:prstGeom xmlns:a="http://schemas.openxmlformats.org/drawingml/2006/main" prst="rect">
-            <a:avLst/>
-          </a:prstGeom>
-          <a:noFill xmlns:a="http://schemas.openxmlformats.org/drawingml/2006/main"/>
-          <a:ln xmlns:a="http://schemas.openxmlformats.org/drawingml/2006/main">
-            <a:noFill/>
-          </a:ln>
-        </p:spPr>
-        <p:txBody>
-          <a:bodyPr xmlns:a="http://schemas.openxmlformats.org/drawingml/2006/main" spcFirstLastPara="1" wrap="square" lIns="0" tIns="0" rIns="0" bIns="0" anchor="t">
-            <a:noAutofit/>
-          </a:bodyPr>
-          <a:lstStyle xmlns:a="http://schemas.openxmlformats.org/drawingml/2006/main"/>
-          <a:p xmlns:a="http://schemas.openxmlformats.org/drawingml/2006/main">
-            <a:pPr marL="0" lvl="0" indent="0" algn="l">
-              <a:spcBef>
-                <a:spcPts val="0"/>
-              </a:spcBef>
-              <a:spcAft>
-                <a:spcPts val="0"/>
-              </a:spcAft>
-              <a:buNone/>
-            </a:pPr>
-            <a:r>
-              <a:rPr sz="1050" b="0">
-                <a:solidFill>
-                  <a:srgbClr val="3A86FF"/>
-                </a:solidFill>
-                <a:latin typeface="Inter SemiBold"/>
-                <a:ea typeface="Inter SemiBold"/>
-                <a:cs typeface="Inter SemiBold"/>
-              </a:rPr>
-              <a:t>LINUX SYSTEM MONITORING WITH BPFTRACE</a:t>
-            </a:r>
-            <a:r>
-              <a:rPr sz="1050">
-                <a:solidFill>
-                  <a:srgbClr val="3A86FF"/>
-                </a:solidFill>
-                <a:latin typeface="Inter SemiBold"/>
-                <a:ea typeface="Inter SemiBold"/>
-                <a:cs typeface="Inter SemiBold"/>
-              </a:rPr>
-              <a:t> AND EBPF</a:t>
-            </a:r>
-            <a:endParaRPr sz="1050" b="0">
-              <a:solidFill>
-                <a:srgbClr val="3A86FF"/>
-              </a:solidFill>
-              <a:latin typeface="Inter SemiBold"/>
-              <a:ea typeface="Inter SemiBold"/>
-              <a:cs typeface="Inter SemiBold"/>
-            </a:endParaRPr>
-          </a:p>
-        </p:txBody>
-      </p:sp>
-    </p:spTree>
-    <p:extLst>
-      <p:ext uri="{BB962C8B-B14F-4D97-AF65-F5344CB8AC3E}">
-        <p14:creationId xmlns:p14="http://schemas.microsoft.com/office/powerpoint/2010/main" val="1209551683"/>
-      </p:ext>
-    </p:extLst>
-  </p:cSld>
-</p:sld>
-</file>
-
-<file path=ppt/slides/slide14.xml><?xml version="1.0" encoding="utf-8"?>
-<p:sld xmlns:p="http://schemas.openxmlformats.org/presentationml/2006/main">
-  <p:cSld>
-    <p:spTree>
-      <p:nvGrpSpPr>
-        <p:cNvPr id="1" name=""/>
-        <p:cNvGrpSpPr/>
-        <p:nvPr/>
-      </p:nvGrpSpPr>
-      <p:grpSpPr>
-        <a:xfrm xmlns:a="http://schemas.openxmlformats.org/drawingml/2006/main"/>
-      </p:grpSpPr>
-      <p:sp>
-        <p:nvSpPr>
-          <p:cNvPr id="597" name="Google Shape;597;p30">
-            <a:extLst xmlns:a="http://schemas.openxmlformats.org/drawingml/2006/main">
-              <a:ext uri="{FF2B5EF4-FFF2-40B4-BE49-F238E27FC236}">
-                <a16:creationId xmlns:a16="http://schemas.microsoft.com/office/drawing/2014/main" id="{BDE64DB8-2DF5-48AF-8D46-CB18331DACEC}"/>
-              </a:ext>
-            </a:extLst>
-          </p:cNvPr>
-          <p:cNvSpPr>
-            <a:spLocks xmlns:a="http://schemas.openxmlformats.org/drawingml/2006/main" noGrp="1"/>
-          </p:cNvSpPr>
-          <p:nvPr/>
-        </p:nvSpPr>
-        <p:spPr>
-          <a:xfrm xmlns:a="http://schemas.openxmlformats.org/drawingml/2006/main">
-            <a:off x="0" y="0"/>
-            <a:ext cx="9144000" cy="5143500"/>
-          </a:xfrm>
-          <a:prstGeom xmlns:a="http://schemas.openxmlformats.org/drawingml/2006/main" prst="rect">
-            <a:avLst/>
-          </a:prstGeom>
-          <a:solidFill xmlns:a="http://schemas.openxmlformats.org/drawingml/2006/main">
-            <a:srgbClr val="FFFFFF"/>
-          </a:solidFill>
-          <a:ln xmlns:a="http://schemas.openxmlformats.org/drawingml/2006/main">
-            <a:noFill/>
-          </a:ln>
-        </p:spPr>
-        <p:txBody>
-          <a:bodyPr xmlns:a="http://schemas.openxmlformats.org/drawingml/2006/main" spcFirstLastPara="1" wrap="square" lIns="0" tIns="0" rIns="0" bIns="0" anchor="ctr">
-            <a:noAutofit/>
-          </a:bodyPr>
-          <a:lstStyle xmlns:a="http://schemas.openxmlformats.org/drawingml/2006/main"/>
-          <a:p xmlns:a="http://schemas.openxmlformats.org/drawingml/2006/main">
-            <a:pPr marL="0" lvl="0" indent="0" algn="l">
-              <a:spcBef>
-                <a:spcPts val="0"/>
-              </a:spcBef>
-              <a:spcAft>
-                <a:spcPts val="0"/>
-              </a:spcAft>
-              <a:buNone/>
-            </a:pPr>
-            <a:r>
-              <a:t/>
-            </a:r>
-            <a:endParaRPr/>
-          </a:p>
-        </p:txBody>
-      </p:sp>
-      <p:sp>
-        <p:nvSpPr>
-          <p:cNvPr id="598" name="Google Shape;598;p30">
-            <a:extLst xmlns:a="http://schemas.openxmlformats.org/drawingml/2006/main">
-              <a:ext uri="{FF2B5EF4-FFF2-40B4-BE49-F238E27FC236}">
-                <a16:creationId xmlns:a16="http://schemas.microsoft.com/office/drawing/2014/main" id="{A502B2D6-2DA2-41FD-8D13-24E953E5EEAB}"/>
-              </a:ext>
-            </a:extLst>
-          </p:cNvPr>
-          <p:cNvSpPr>
-            <a:spLocks xmlns:a="http://schemas.openxmlformats.org/drawingml/2006/main" noGrp="1"/>
-          </p:cNvSpPr>
-          <p:nvPr/>
-        </p:nvSpPr>
-        <p:spPr>
-          <a:xfrm xmlns:a="http://schemas.openxmlformats.org/drawingml/2006/main">
-            <a:off x="0" y="0"/>
-            <a:ext cx="9144000" cy="57300"/>
-          </a:xfrm>
-          <a:prstGeom xmlns:a="http://schemas.openxmlformats.org/drawingml/2006/main" prst="rect">
-            <a:avLst/>
-          </a:prstGeom>
-          <a:solidFill xmlns:a="http://schemas.openxmlformats.org/drawingml/2006/main">
-            <a:srgbClr val="3A86FF"/>
-          </a:solidFill>
-          <a:ln xmlns:a="http://schemas.openxmlformats.org/drawingml/2006/main">
-            <a:noFill/>
-          </a:ln>
-        </p:spPr>
-        <p:txBody>
-          <a:bodyPr xmlns:a="http://schemas.openxmlformats.org/drawingml/2006/main" spcFirstLastPara="1" wrap="square" lIns="0" tIns="0" rIns="0" bIns="0" anchor="ctr">
-            <a:noAutofit/>
-          </a:bodyPr>
-          <a:lstStyle xmlns:a="http://schemas.openxmlformats.org/drawingml/2006/main"/>
-          <a:p xmlns:a="http://schemas.openxmlformats.org/drawingml/2006/main">
-            <a:pPr marL="0" lvl="0" indent="0" algn="l">
-              <a:spcBef>
-                <a:spcPts val="0"/>
-              </a:spcBef>
-              <a:spcAft>
-                <a:spcPts val="0"/>
-              </a:spcAft>
-              <a:buNone/>
-            </a:pPr>
-            <a:r>
-              <a:t/>
-            </a:r>
-            <a:endParaRPr/>
-          </a:p>
-        </p:txBody>
-      </p:sp>
-      <p:sp>
-        <p:nvSpPr>
-          <p:cNvPr id="600" name="Google Shape;600;p30">
-            <a:extLst xmlns:a="http://schemas.openxmlformats.org/drawingml/2006/main">
-              <a:ext uri="{FF2B5EF4-FFF2-40B4-BE49-F238E27FC236}">
-                <a16:creationId xmlns:a16="http://schemas.microsoft.com/office/drawing/2014/main" id="{6A70E29F-9B82-4C0E-8ED2-FFC07255D430}"/>
-              </a:ext>
-            </a:extLst>
-          </p:cNvPr>
-          <p:cNvSpPr>
-            <a:spLocks xmlns:a="http://schemas.openxmlformats.org/drawingml/2006/main" noGrp="1"/>
-          </p:cNvSpPr>
-          <p:nvPr/>
-        </p:nvSpPr>
-        <p:spPr>
-          <a:xfrm xmlns:a="http://schemas.openxmlformats.org/drawingml/2006/main" rot="0" flipH="0" flipV="0">
-            <a:off x="8534400" y="190500"/>
-            <a:ext cx="152400" cy="152400"/>
-          </a:xfrm>
-          <a:prstGeom xmlns:a="http://schemas.openxmlformats.org/drawingml/2006/main" prst="rect">
-            <a:avLst/>
-          </a:prstGeom>
-          <a:solidFill xmlns:a="http://schemas.openxmlformats.org/drawingml/2006/main">
-            <a:srgbClr val="3A86FF"/>
-          </a:solidFill>
-          <a:ln xmlns:a="http://schemas.openxmlformats.org/drawingml/2006/main">
-            <a:noFill/>
-          </a:ln>
-        </p:spPr>
-        <p:txBody>
-          <a:bodyPr xmlns:a="http://schemas.openxmlformats.org/drawingml/2006/main" spcFirstLastPara="1" wrap="square" lIns="0" tIns="0" rIns="0" bIns="0" anchor="ctr">
-            <a:noAutofit/>
-          </a:bodyPr>
-          <a:lstStyle xmlns:a="http://schemas.openxmlformats.org/drawingml/2006/main"/>
-          <a:p xmlns:a="http://schemas.openxmlformats.org/drawingml/2006/main">
-            <a:pPr marL="0" lvl="0" indent="0" algn="l">
-              <a:spcBef>
-                <a:spcPts val="0"/>
-              </a:spcBef>
-              <a:spcAft>
-                <a:spcPts val="0"/>
-              </a:spcAft>
-              <a:buNone/>
-            </a:pPr>
-            <a:r>
-              <a:t/>
-            </a:r>
-            <a:endParaRPr/>
-          </a:p>
-        </p:txBody>
-      </p:sp>
-      <p:sp>
-        <p:nvSpPr>
-          <p:cNvPr id="601" name="Google Shape;601;p30">
-            <a:extLst xmlns:a="http://schemas.openxmlformats.org/drawingml/2006/main">
-              <a:ext uri="{FF2B5EF4-FFF2-40B4-BE49-F238E27FC236}">
-                <a16:creationId xmlns:a16="http://schemas.microsoft.com/office/drawing/2014/main" id="{A7F0AEA7-0069-4EC2-A9F7-DBCF5DECF4CF}"/>
-              </a:ext>
-            </a:extLst>
-          </p:cNvPr>
-          <p:cNvSpPr>
-            <a:spLocks xmlns:a="http://schemas.openxmlformats.org/drawingml/2006/main" noGrp="1"/>
-          </p:cNvSpPr>
-          <p:nvPr/>
-        </p:nvSpPr>
-        <p:spPr>
-          <a:xfrm xmlns:a="http://schemas.openxmlformats.org/drawingml/2006/main" rot="0" flipH="0" flipV="0">
-            <a:off x="8648700" y="304800"/>
-            <a:ext cx="152400" cy="152400"/>
-          </a:xfrm>
-          <a:prstGeom xmlns:a="http://schemas.openxmlformats.org/drawingml/2006/main" prst="rect">
-            <a:avLst/>
-          </a:prstGeom>
-          <a:solidFill xmlns:a="http://schemas.openxmlformats.org/drawingml/2006/main">
-            <a:srgbClr val="FF4D4D"/>
-          </a:solidFill>
-          <a:ln xmlns:a="http://schemas.openxmlformats.org/drawingml/2006/main">
-            <a:noFill/>
-          </a:ln>
-        </p:spPr>
-        <p:txBody>
-          <a:bodyPr xmlns:a="http://schemas.openxmlformats.org/drawingml/2006/main" spcFirstLastPara="1" wrap="square" lIns="0" tIns="0" rIns="0" bIns="0" anchor="ctr">
-            <a:noAutofit/>
-          </a:bodyPr>
-          <a:lstStyle xmlns:a="http://schemas.openxmlformats.org/drawingml/2006/main"/>
-          <a:p xmlns:a="http://schemas.openxmlformats.org/drawingml/2006/main">
-            <a:pPr marL="0" lvl="0" indent="0" algn="l">
-              <a:spcBef>
-                <a:spcPts val="0"/>
-              </a:spcBef>
-              <a:spcAft>
-                <a:spcPts val="0"/>
-              </a:spcAft>
-              <a:buNone/>
-            </a:pPr>
-            <a:r>
-              <a:t/>
-            </a:r>
-            <a:endParaRPr/>
-          </a:p>
-        </p:txBody>
-      </p:sp>
-      <p:sp>
-        <p:nvSpPr>
-          <p:cNvPr id="602" name="Google Shape;602;p30">
-            <a:extLst xmlns:a="http://schemas.openxmlformats.org/drawingml/2006/main">
-              <a:ext uri="{FF2B5EF4-FFF2-40B4-BE49-F238E27FC236}">
-                <a16:creationId xmlns:a16="http://schemas.microsoft.com/office/drawing/2014/main" id="{4FCAAC77-7049-45AD-B25F-CB738F4F1316}"/>
-              </a:ext>
-            </a:extLst>
-          </p:cNvPr>
-          <p:cNvSpPr>
-            <a:spLocks xmlns:a="http://schemas.openxmlformats.org/drawingml/2006/main" noGrp="1"/>
-          </p:cNvSpPr>
-          <p:nvPr/>
-        </p:nvSpPr>
-        <p:spPr>
-          <a:xfrm xmlns:a="http://schemas.openxmlformats.org/drawingml/2006/main" rot="0" flipH="0" flipV="0">
-            <a:off x="8763000" y="190500"/>
-            <a:ext cx="152400" cy="152400"/>
-          </a:xfrm>
-          <a:prstGeom xmlns:a="http://schemas.openxmlformats.org/drawingml/2006/main" prst="rect">
-            <a:avLst/>
-          </a:prstGeom>
-          <a:solidFill xmlns:a="http://schemas.openxmlformats.org/drawingml/2006/main">
-            <a:srgbClr val="0B132B"/>
-          </a:solidFill>
-          <a:ln xmlns:a="http://schemas.openxmlformats.org/drawingml/2006/main">
-            <a:noFill/>
-          </a:ln>
-        </p:spPr>
-        <p:txBody>
-          <a:bodyPr xmlns:a="http://schemas.openxmlformats.org/drawingml/2006/main" spcFirstLastPara="1" wrap="square" lIns="0" tIns="0" rIns="0" bIns="0" anchor="ctr">
-            <a:noAutofit/>
-          </a:bodyPr>
-          <a:lstStyle xmlns:a="http://schemas.openxmlformats.org/drawingml/2006/main"/>
-          <a:p xmlns:a="http://schemas.openxmlformats.org/drawingml/2006/main">
-            <a:pPr marL="0" lvl="0" indent="0" algn="l">
-              <a:spcBef>
-                <a:spcPts val="0"/>
-              </a:spcBef>
-              <a:spcAft>
-                <a:spcPts val="0"/>
-              </a:spcAft>
-              <a:buNone/>
-            </a:pPr>
-            <a:r>
-              <a:t/>
-            </a:r>
-            <a:endParaRPr/>
-          </a:p>
-        </p:txBody>
-      </p:sp>
-      <p:sp>
-        <p:nvSpPr>
-          <p:cNvPr id="603" name="Google Shape;603;p30">
-            <a:extLst xmlns:a="http://schemas.openxmlformats.org/drawingml/2006/main">
-              <a:ext uri="{FF2B5EF4-FFF2-40B4-BE49-F238E27FC236}">
-                <a16:creationId xmlns:a16="http://schemas.microsoft.com/office/drawing/2014/main" id="{F792C37C-A96B-4A83-B7A0-59A12411F0D4}"/>
-              </a:ext>
-            </a:extLst>
-          </p:cNvPr>
-          <p:cNvSpPr>
-            <a:spLocks xmlns:a="http://schemas.openxmlformats.org/drawingml/2006/main" noGrp="1"/>
-          </p:cNvSpPr>
-          <p:nvPr/>
-        </p:nvSpPr>
-        <p:spPr>
-          <a:xfrm xmlns:a="http://schemas.openxmlformats.org/drawingml/2006/main">
-            <a:off x="457200" y="609600"/>
-            <a:ext cx="8229600" cy="533400"/>
-          </a:xfrm>
-          <a:prstGeom xmlns:a="http://schemas.openxmlformats.org/drawingml/2006/main" prst="rect">
-            <a:avLst/>
-          </a:prstGeom>
-          <a:noFill xmlns:a="http://schemas.openxmlformats.org/drawingml/2006/main"/>
-          <a:ln xmlns:a="http://schemas.openxmlformats.org/drawingml/2006/main">
-            <a:noFill/>
-          </a:ln>
-        </p:spPr>
-        <p:txBody>
-          <a:bodyPr xmlns:a="http://schemas.openxmlformats.org/drawingml/2006/main" spcFirstLastPara="1" wrap="square" lIns="0" tIns="0" rIns="0" bIns="0" anchor="t">
-            <a:noAutofit/>
-          </a:bodyPr>
-          <a:lstStyle xmlns:a="http://schemas.openxmlformats.org/drawingml/2006/main"/>
-          <a:p xmlns:a="http://schemas.openxmlformats.org/drawingml/2006/main">
-            <a:pPr marL="0" indent="0" algn="l">
-              <a:spcBef>
-                <a:spcPts val="0"/>
-              </a:spcBef>
-              <a:spcAft>
-                <a:spcPts val="0"/>
-              </a:spcAft>
-              <a:buNone/>
-              <a:defRPr sz="2400" b="1">
-                <a:solidFill>
-                  <a:srgbClr val="3A86FF"/>
-                </a:solidFill>
-                <a:latin typeface="Montserrat"/>
-                <a:ea typeface="Montserrat"/>
-                <a:cs typeface="Montserrat"/>
-              </a:defRPr>
-            </a:pPr>
-            <a:r>
-              <a:rPr sz="2400" b="1" i="0">
-                <a:solidFill>
-                  <a:srgbClr val="3A86FF"/>
-                </a:solidFill>
-                <a:latin typeface="Montserrat"/>
-                <a:ea typeface="Montserrat"/>
-                <a:cs typeface="Montserrat"/>
-              </a:rPr>
-              <a:t>After the workshop</a:t>
-            </a:r>
-          </a:p>
-        </p:txBody>
-      </p:sp>
-      <p:sp>
-        <p:nvSpPr>
-          <p:cNvPr id="604" name="Google Shape;604;p30">
-            <a:extLst xmlns:a="http://schemas.openxmlformats.org/drawingml/2006/main">
-              <a:ext uri="{FF2B5EF4-FFF2-40B4-BE49-F238E27FC236}">
-                <a16:creationId xmlns:a16="http://schemas.microsoft.com/office/drawing/2014/main" id="{CB1389F3-AE35-44FF-B13C-8FDB3606FAB8}"/>
-              </a:ext>
-            </a:extLst>
-          </p:cNvPr>
-          <p:cNvSpPr>
-            <a:spLocks xmlns:a="http://schemas.openxmlformats.org/drawingml/2006/main" noGrp="1"/>
-          </p:cNvSpPr>
-          <p:nvPr/>
-        </p:nvSpPr>
-        <p:spPr>
-          <a:xfrm xmlns:a="http://schemas.openxmlformats.org/drawingml/2006/main">
-            <a:off x="304800" y="1219200"/>
-            <a:ext cx="3013500" cy="3410100"/>
-          </a:xfrm>
-          <a:prstGeom xmlns:a="http://schemas.openxmlformats.org/drawingml/2006/main" prst="roundRect">
-            <a:avLst>
-              <a:gd name="adj" fmla="val 1117"/>
-            </a:avLst>
-          </a:prstGeom>
-          <a:solidFill xmlns:a="http://schemas.openxmlformats.org/drawingml/2006/main">
-            <a:srgbClr val="F4F7F6"/>
-          </a:solidFill>
-          <a:ln xmlns:a="http://schemas.openxmlformats.org/drawingml/2006/main">
-            <a:noFill/>
-          </a:ln>
-        </p:spPr>
-        <p:txBody>
-          <a:bodyPr xmlns:a="http://schemas.openxmlformats.org/drawingml/2006/main" spcFirstLastPara="1" wrap="square" lIns="0" tIns="0" rIns="0" bIns="0" anchor="ctr">
-            <a:noAutofit/>
-          </a:bodyPr>
-          <a:lstStyle xmlns:a="http://schemas.openxmlformats.org/drawingml/2006/main"/>
-          <a:p xmlns:a="http://schemas.openxmlformats.org/drawingml/2006/main">
-            <a:pPr marL="0" lvl="0" indent="0" algn="l">
-              <a:spcBef>
-                <a:spcPts val="0"/>
-              </a:spcBef>
-              <a:spcAft>
-                <a:spcPts val="0"/>
-              </a:spcAft>
-              <a:buNone/>
-            </a:pPr>
-            <a:r>
-              <a:t/>
-            </a:r>
-            <a:endParaRPr/>
-          </a:p>
-        </p:txBody>
-      </p:sp>
-      <p:sp>
-        <p:nvSpPr>
-          <p:cNvPr id="605" name="Google Shape;605;p30">
-            <a:extLst xmlns:a="http://schemas.openxmlformats.org/drawingml/2006/main">
-              <a:ext uri="{FF2B5EF4-FFF2-40B4-BE49-F238E27FC236}">
-                <a16:creationId xmlns:a16="http://schemas.microsoft.com/office/drawing/2014/main" id="{196A3D5B-A6C4-49B2-8ABC-B5CEE75009B4}"/>
-              </a:ext>
-            </a:extLst>
-          </p:cNvPr>
-          <p:cNvSpPr>
-            <a:spLocks xmlns:a="http://schemas.openxmlformats.org/drawingml/2006/main" noGrp="1"/>
-          </p:cNvSpPr>
-          <p:nvPr/>
-        </p:nvSpPr>
-        <p:spPr>
-          <a:xfrm xmlns:a="http://schemas.openxmlformats.org/drawingml/2006/main">
-            <a:off x="304800" y="1219200"/>
-            <a:ext cx="38100" cy="3410100"/>
-          </a:xfrm>
-          <a:prstGeom xmlns:a="http://schemas.openxmlformats.org/drawingml/2006/main" prst="rect">
-            <a:avLst/>
-          </a:prstGeom>
-          <a:solidFill xmlns:a="http://schemas.openxmlformats.org/drawingml/2006/main">
-            <a:srgbClr val="FF4D4D"/>
-          </a:solidFill>
-          <a:ln xmlns:a="http://schemas.openxmlformats.org/drawingml/2006/main">
-            <a:noFill/>
-          </a:ln>
-        </p:spPr>
-        <p:txBody>
-          <a:bodyPr xmlns:a="http://schemas.openxmlformats.org/drawingml/2006/main" spcFirstLastPara="1" wrap="square" lIns="0" tIns="0" rIns="0" bIns="0" anchor="ctr">
-            <a:noAutofit/>
-          </a:bodyPr>
-          <a:lstStyle xmlns:a="http://schemas.openxmlformats.org/drawingml/2006/main"/>
-          <a:p xmlns:a="http://schemas.openxmlformats.org/drawingml/2006/main">
-            <a:pPr marL="0" lvl="0" indent="0" algn="l">
-              <a:spcBef>
-                <a:spcPts val="0"/>
-              </a:spcBef>
-              <a:spcAft>
-                <a:spcPts val="0"/>
-              </a:spcAft>
-              <a:buNone/>
-            </a:pPr>
-            <a:r>
-              <a:t/>
-            </a:r>
-            <a:endParaRPr/>
-          </a:p>
-        </p:txBody>
-      </p:sp>
-      <p:sp>
-        <p:nvSpPr>
-          <p:cNvPr id="606" name="Google Shape;606;p30">
-            <a:extLst xmlns:a="http://schemas.openxmlformats.org/drawingml/2006/main">
-              <a:ext uri="{FF2B5EF4-FFF2-40B4-BE49-F238E27FC236}">
-                <a16:creationId xmlns:a16="http://schemas.microsoft.com/office/drawing/2014/main" id="{49F9CDAA-5631-4822-9E9D-8ECDA15ACED4}"/>
-              </a:ext>
-            </a:extLst>
-          </p:cNvPr>
-          <p:cNvSpPr>
-            <a:spLocks xmlns:a="http://schemas.openxmlformats.org/drawingml/2006/main" noGrp="1"/>
-          </p:cNvSpPr>
-          <p:nvPr/>
-        </p:nvSpPr>
-        <p:spPr>
-          <a:xfrm xmlns:a="http://schemas.openxmlformats.org/drawingml/2006/main">
-            <a:off x="571500" y="1447800"/>
-            <a:ext cx="2569500" cy="2952900"/>
-          </a:xfrm>
-          <a:prstGeom xmlns:a="http://schemas.openxmlformats.org/drawingml/2006/main" prst="rect">
-            <a:avLst/>
-          </a:prstGeom>
-          <a:noFill xmlns:a="http://schemas.openxmlformats.org/drawingml/2006/main"/>
-          <a:ln xmlns:a="http://schemas.openxmlformats.org/drawingml/2006/main">
-            <a:noFill/>
-          </a:ln>
-        </p:spPr>
-        <p:txBody>
-          <a:bodyPr xmlns:a="http://schemas.openxmlformats.org/drawingml/2006/main" spcFirstLastPara="1" wrap="square" lIns="0" tIns="0" rIns="0" bIns="0" anchor="t">
-            <a:noAutofit/>
-          </a:bodyPr>
-          <a:lstStyle xmlns:a="http://schemas.openxmlformats.org/drawingml/2006/main"/>
-          <a:p xmlns:a="http://schemas.openxmlformats.org/drawingml/2006/main">
-            <a:pPr marL="0" indent="0" algn="l">
-              <a:spcBef>
-                <a:spcPts val="0"/>
-              </a:spcBef>
-              <a:spcAft>
-                <a:spcPts val="0"/>
-              </a:spcAft>
-              <a:buNone/>
-              <a:defRPr sz="1500" b="0">
-                <a:solidFill>
-                  <a:srgbClr val="4A5568"/>
-                </a:solidFill>
-                <a:latin typeface="Inter"/>
-                <a:ea typeface="Inter"/>
-                <a:cs typeface="Inter"/>
-              </a:defRPr>
-            </a:pPr>
-            <a:r>
-              <a:rPr sz="1500" b="0" i="0">
-                <a:solidFill>
-                  <a:srgbClr val="4A5568"/>
-                </a:solidFill>
-                <a:latin typeface="Inter"/>
-                <a:ea typeface="Inter"/>
-                <a:cs typeface="Inter"/>
-              </a:rPr>
-              <a:t>The collector monitors the Ubuntu VM.</a:t>
-            </a:r>
-          </a:p>
-          <a:p xmlns:a="http://schemas.openxmlformats.org/drawingml/2006/main">
-            <a:pPr marL="0" indent="0">
-              <a:spcBef>
-                <a:spcPts val="0"/>
-              </a:spcBef>
-              <a:spcAft>
-                <a:spcPts val="0"/>
-              </a:spcAft>
-              <a:buNone/>
-            </a:pPr>
-            <a:r>
-              <a:rPr sz="1500" b="0" i="0">
-                <a:solidFill>
-                  <a:srgbClr val="4A5568"/>
-                </a:solidFill>
-                <a:latin typeface="Inter"/>
-                <a:ea typeface="Inter"/>
-                <a:cs typeface="Inter"/>
-              </a:rPr>
-              <a:t/>
-            </a:r>
-          </a:p>
-          <a:p xmlns:a="http://schemas.openxmlformats.org/drawingml/2006/main">
-            <a:pPr marL="0" indent="0" algn="l">
-              <a:spcBef>
-                <a:spcPts val="0"/>
-              </a:spcBef>
-              <a:spcAft>
-                <a:spcPts val="0"/>
-              </a:spcAft>
-              <a:buNone/>
-              <a:defRPr sz="1500" b="0">
-                <a:solidFill>
-                  <a:srgbClr val="4A5568"/>
-                </a:solidFill>
-                <a:latin typeface="Inter"/>
-                <a:ea typeface="Inter"/>
-                <a:cs typeface="Inter"/>
-              </a:defRPr>
-            </a:pPr>
-            <a:r>
-              <a:rPr sz="1500" b="0" i="0">
-                <a:solidFill>
-                  <a:srgbClr val="4A5568"/>
-                </a:solidFill>
-                <a:latin typeface="Inter"/>
-                <a:ea typeface="Inter"/>
-                <a:cs typeface="Inter"/>
-              </a:rPr>
-              <a:t>libscap handles capture. libsinsp adds context.</a:t>
-            </a:r>
-          </a:p>
-          <a:p xmlns:a="http://schemas.openxmlformats.org/drawingml/2006/main">
-            <a:pPr marL="0" indent="0">
-              <a:spcBef>
-                <a:spcPts val="0"/>
-              </a:spcBef>
-              <a:spcAft>
-                <a:spcPts val="0"/>
-              </a:spcAft>
-              <a:buNone/>
-            </a:pPr>
-            <a:r>
-              <a:rPr sz="1500" b="0" i="0">
-                <a:solidFill>
-                  <a:srgbClr val="4A5568"/>
-                </a:solidFill>
-                <a:latin typeface="Inter"/>
-                <a:ea typeface="Inter"/>
-                <a:cs typeface="Inter"/>
-              </a:rPr>
-              <a:t/>
-            </a:r>
-          </a:p>
-          <a:p xmlns:a="http://schemas.openxmlformats.org/drawingml/2006/main">
-            <a:pPr marL="0" indent="0" algn="l">
-              <a:spcBef>
-                <a:spcPts val="0"/>
-              </a:spcBef>
-              <a:spcAft>
-                <a:spcPts val="0"/>
-              </a:spcAft>
-              <a:buNone/>
-              <a:defRPr sz="1500" b="0">
-                <a:solidFill>
-                  <a:srgbClr val="4A5568"/>
-                </a:solidFill>
-                <a:latin typeface="Inter"/>
-                <a:ea typeface="Inter"/>
-                <a:cs typeface="Inter"/>
-              </a:defRPr>
-            </a:pPr>
-            <a:r>
-              <a:rPr sz="1500" b="0" i="0">
-                <a:solidFill>
-                  <a:srgbClr val="4A5568"/>
-                </a:solidFill>
-                <a:latin typeface="Inter"/>
-                <a:ea typeface="Inter"/>
-                <a:cs typeface="Inter"/>
-              </a:rPr>
-              <a:t>Stop the VM when you are done.</a:t>
-            </a:r>
-          </a:p>
-        </p:txBody>
-      </p:sp>
-      <p:sp>
-        <p:nvSpPr>
-          <p:cNvPr id="607" name="Google Shape;607;p30">
-            <a:extLst xmlns:a="http://schemas.openxmlformats.org/drawingml/2006/main">
-              <a:ext uri="{FF2B5EF4-FFF2-40B4-BE49-F238E27FC236}">
-                <a16:creationId xmlns:a16="http://schemas.microsoft.com/office/drawing/2014/main" id="{08527AFE-0E31-46B5-B2AB-894AB94A8036}"/>
-              </a:ext>
-            </a:extLst>
-          </p:cNvPr>
-          <p:cNvSpPr>
-            <a:spLocks xmlns:a="http://schemas.openxmlformats.org/drawingml/2006/main" noGrp="1"/>
-          </p:cNvSpPr>
-          <p:nvPr/>
-        </p:nvSpPr>
-        <p:spPr>
-          <a:xfrm xmlns:a="http://schemas.openxmlformats.org/drawingml/2006/main">
-            <a:off x="3482825" y="1219200"/>
-            <a:ext cx="5356500" cy="3410100"/>
-          </a:xfrm>
-          <a:prstGeom xmlns:a="http://schemas.openxmlformats.org/drawingml/2006/main" prst="roundRect">
-            <a:avLst>
-              <a:gd name="adj" fmla="val 2234"/>
-            </a:avLst>
-          </a:prstGeom>
-          <a:solidFill xmlns:a="http://schemas.openxmlformats.org/drawingml/2006/main">
-            <a:srgbClr val="0B132B"/>
-          </a:solidFill>
-          <a:ln xmlns:a="http://schemas.openxmlformats.org/drawingml/2006/main">
-            <a:noFill/>
-          </a:ln>
-        </p:spPr>
-        <p:txBody>
-          <a:bodyPr xmlns:a="http://schemas.openxmlformats.org/drawingml/2006/main" spcFirstLastPara="1" wrap="square" lIns="0" tIns="0" rIns="0" bIns="0" anchor="ctr">
-            <a:noAutofit/>
-          </a:bodyPr>
-          <a:lstStyle xmlns:a="http://schemas.openxmlformats.org/drawingml/2006/main"/>
-          <a:p xmlns:a="http://schemas.openxmlformats.org/drawingml/2006/main">
-            <a:pPr marL="0" lvl="0" indent="0" algn="l">
-              <a:spcBef>
-                <a:spcPts val="0"/>
-              </a:spcBef>
-              <a:spcAft>
-                <a:spcPts val="0"/>
-              </a:spcAft>
-              <a:buNone/>
-            </a:pPr>
-            <a:r>
-              <a:t/>
-            </a:r>
-            <a:endParaRPr/>
-          </a:p>
-        </p:txBody>
-      </p:sp>
-      <p:sp>
-        <p:nvSpPr>
-          <p:cNvPr id="609" name="Google Shape;609;p30">
-            <a:extLst xmlns:a="http://schemas.openxmlformats.org/drawingml/2006/main">
-              <a:ext uri="{FF2B5EF4-FFF2-40B4-BE49-F238E27FC236}">
-                <a16:creationId xmlns:a16="http://schemas.microsoft.com/office/drawing/2014/main" id="{2F687CFB-C301-4360-90A3-28762F09A555}"/>
-              </a:ext>
-            </a:extLst>
-          </p:cNvPr>
-          <p:cNvSpPr>
-            <a:spLocks xmlns:a="http://schemas.openxmlformats.org/drawingml/2006/main" noGrp="1"/>
-          </p:cNvSpPr>
-          <p:nvPr/>
-        </p:nvSpPr>
-        <p:spPr>
-          <a:xfrm xmlns:a="http://schemas.openxmlformats.org/drawingml/2006/main" rot="0" flipH="0" flipV="0">
-            <a:off x="3774125" y="1409700"/>
-            <a:ext cx="114300" cy="114300"/>
-          </a:xfrm>
-          <a:prstGeom xmlns:a="http://schemas.openxmlformats.org/drawingml/2006/main" prst="ellipse">
-            <a:avLst/>
-          </a:prstGeom>
-          <a:solidFill xmlns:a="http://schemas.openxmlformats.org/drawingml/2006/main">
-            <a:srgbClr val="FF4D4D"/>
-          </a:solidFill>
-          <a:ln xmlns:a="http://schemas.openxmlformats.org/drawingml/2006/main">
-            <a:noFill/>
-          </a:ln>
-        </p:spPr>
-        <p:txBody>
-          <a:bodyPr xmlns:a="http://schemas.openxmlformats.org/drawingml/2006/main" spcFirstLastPara="1" wrap="square" lIns="0" tIns="0" rIns="0" bIns="0" anchor="ctr">
-            <a:noAutofit/>
-          </a:bodyPr>
-          <a:lstStyle xmlns:a="http://schemas.openxmlformats.org/drawingml/2006/main"/>
-          <a:p xmlns:a="http://schemas.openxmlformats.org/drawingml/2006/main">
-            <a:pPr marL="0" lvl="0" indent="0" algn="l">
-              <a:spcBef>
-                <a:spcPts val="0"/>
-              </a:spcBef>
-              <a:spcAft>
-                <a:spcPts val="0"/>
-              </a:spcAft>
-              <a:buNone/>
-            </a:pPr>
-            <a:r>
-              <a:t/>
-            </a:r>
-            <a:endParaRPr/>
-          </a:p>
-        </p:txBody>
-      </p:sp>
-      <p:sp>
-        <p:nvSpPr>
-          <p:cNvPr id="610" name="Google Shape;610;p30">
-            <a:extLst xmlns:a="http://schemas.openxmlformats.org/drawingml/2006/main">
-              <a:ext uri="{FF2B5EF4-FFF2-40B4-BE49-F238E27FC236}">
-                <a16:creationId xmlns:a16="http://schemas.microsoft.com/office/drawing/2014/main" id="{8CBBACE1-B76C-4567-A2C0-B0DBA8DA312B}"/>
-              </a:ext>
-            </a:extLst>
-          </p:cNvPr>
-          <p:cNvSpPr>
-            <a:spLocks xmlns:a="http://schemas.openxmlformats.org/drawingml/2006/main" noGrp="1"/>
-          </p:cNvSpPr>
-          <p:nvPr/>
-        </p:nvSpPr>
-        <p:spPr>
-          <a:xfrm xmlns:a="http://schemas.openxmlformats.org/drawingml/2006/main" rot="0" flipH="0" flipV="0">
-            <a:off x="3945575" y="1409700"/>
-            <a:ext cx="114300" cy="114300"/>
-          </a:xfrm>
-          <a:prstGeom xmlns:a="http://schemas.openxmlformats.org/drawingml/2006/main" prst="ellipse">
-            <a:avLst/>
-          </a:prstGeom>
-          <a:solidFill xmlns:a="http://schemas.openxmlformats.org/drawingml/2006/main">
-            <a:srgbClr val="FFB703"/>
-          </a:solidFill>
-          <a:ln xmlns:a="http://schemas.openxmlformats.org/drawingml/2006/main">
-            <a:noFill/>
-          </a:ln>
-        </p:spPr>
-        <p:txBody>
-          <a:bodyPr xmlns:a="http://schemas.openxmlformats.org/drawingml/2006/main" spcFirstLastPara="1" wrap="square" lIns="0" tIns="0" rIns="0" bIns="0" anchor="ctr">
-            <a:noAutofit/>
-          </a:bodyPr>
-          <a:lstStyle xmlns:a="http://schemas.openxmlformats.org/drawingml/2006/main"/>
-          <a:p xmlns:a="http://schemas.openxmlformats.org/drawingml/2006/main">
-            <a:pPr marL="0" lvl="0" indent="0" algn="l">
-              <a:spcBef>
-                <a:spcPts val="0"/>
-              </a:spcBef>
-              <a:spcAft>
-                <a:spcPts val="0"/>
-              </a:spcAft>
-              <a:buNone/>
-            </a:pPr>
-            <a:r>
-              <a:t/>
-            </a:r>
-            <a:endParaRPr/>
-          </a:p>
-        </p:txBody>
-      </p:sp>
-      <p:sp>
-        <p:nvSpPr>
-          <p:cNvPr id="611" name="Google Shape;611;p30">
-            <a:extLst xmlns:a="http://schemas.openxmlformats.org/drawingml/2006/main">
-              <a:ext uri="{FF2B5EF4-FFF2-40B4-BE49-F238E27FC236}">
-                <a16:creationId xmlns:a16="http://schemas.microsoft.com/office/drawing/2014/main" id="{BED13D9E-80AC-400E-B885-58DBEF06DDC2}"/>
-              </a:ext>
-            </a:extLst>
-          </p:cNvPr>
-          <p:cNvSpPr>
-            <a:spLocks xmlns:a="http://schemas.openxmlformats.org/drawingml/2006/main" noGrp="1"/>
-          </p:cNvSpPr>
-          <p:nvPr/>
-        </p:nvSpPr>
-        <p:spPr>
-          <a:xfrm xmlns:a="http://schemas.openxmlformats.org/drawingml/2006/main" rot="0" flipH="0" flipV="0">
-            <a:off x="4117025" y="1409700"/>
-            <a:ext cx="114300" cy="114300"/>
-          </a:xfrm>
-          <a:prstGeom xmlns:a="http://schemas.openxmlformats.org/drawingml/2006/main" prst="ellipse">
-            <a:avLst/>
-          </a:prstGeom>
-          <a:solidFill xmlns:a="http://schemas.openxmlformats.org/drawingml/2006/main">
-            <a:srgbClr val="00E5FF"/>
-          </a:solidFill>
-          <a:ln xmlns:a="http://schemas.openxmlformats.org/drawingml/2006/main">
-            <a:noFill/>
-          </a:ln>
-        </p:spPr>
-        <p:txBody>
-          <a:bodyPr xmlns:a="http://schemas.openxmlformats.org/drawingml/2006/main" spcFirstLastPara="1" wrap="square" lIns="0" tIns="0" rIns="0" bIns="0" anchor="ctr">
-            <a:noAutofit/>
-          </a:bodyPr>
-          <a:lstStyle xmlns:a="http://schemas.openxmlformats.org/drawingml/2006/main"/>
-          <a:p xmlns:a="http://schemas.openxmlformats.org/drawingml/2006/main">
-            <a:pPr marL="0" lvl="0" indent="0" algn="l">
-              <a:spcBef>
-                <a:spcPts val="0"/>
-              </a:spcBef>
-              <a:spcAft>
-                <a:spcPts val="0"/>
-              </a:spcAft>
-              <a:buNone/>
-            </a:pPr>
-            <a:r>
-              <a:t/>
-            </a:r>
-            <a:endParaRPr/>
-          </a:p>
-        </p:txBody>
-      </p:sp>
-      <p:sp>
-        <p:nvSpPr>
-          <p:cNvPr id="612" name="Google Shape;612;p30">
-            <a:extLst xmlns:a="http://schemas.openxmlformats.org/drawingml/2006/main">
-              <a:ext uri="{FF2B5EF4-FFF2-40B4-BE49-F238E27FC236}">
-                <a16:creationId xmlns:a16="http://schemas.microsoft.com/office/drawing/2014/main" id="{BF7075FA-B03F-45F7-A401-B6F15B30BD61}"/>
-              </a:ext>
-            </a:extLst>
-          </p:cNvPr>
-          <p:cNvSpPr>
-            <a:spLocks xmlns:a="http://schemas.openxmlformats.org/drawingml/2006/main" noGrp="1"/>
-          </p:cNvSpPr>
-          <p:nvPr/>
-        </p:nvSpPr>
-        <p:spPr>
-          <a:xfrm xmlns:a="http://schemas.openxmlformats.org/drawingml/2006/main">
-            <a:off x="4394700" y="1352550"/>
-            <a:ext cx="2806200" cy="228600"/>
-          </a:xfrm>
-          <a:prstGeom xmlns:a="http://schemas.openxmlformats.org/drawingml/2006/main" prst="rect">
-            <a:avLst/>
-          </a:prstGeom>
-          <a:noFill xmlns:a="http://schemas.openxmlformats.org/drawingml/2006/main"/>
-          <a:ln xmlns:a="http://schemas.openxmlformats.org/drawingml/2006/main">
-            <a:noFill/>
-          </a:ln>
-        </p:spPr>
-        <p:txBody>
-          <a:bodyPr xmlns:a="http://schemas.openxmlformats.org/drawingml/2006/main" spcFirstLastPara="1" wrap="square" lIns="0" tIns="0" rIns="0" bIns="0" anchor="t">
-            <a:noAutofit/>
-          </a:bodyPr>
-          <a:lstStyle xmlns:a="http://schemas.openxmlformats.org/drawingml/2006/main"/>
-          <a:p xmlns:a="http://schemas.openxmlformats.org/drawingml/2006/main">
-            <a:pPr marL="0" indent="0" algn="l">
-              <a:spcBef>
-                <a:spcPts val="0"/>
-              </a:spcBef>
-              <a:spcAft>
-                <a:spcPts val="0"/>
-              </a:spcAft>
-              <a:buNone/>
-              <a:defRPr sz="900" b="0">
-                <a:solidFill>
-                  <a:srgbClr val="AAB6C8"/>
-                </a:solidFill>
-                <a:latin typeface="Roboto Mono"/>
-                <a:ea typeface="Roboto Mono"/>
-                <a:cs typeface="Roboto Mono"/>
-              </a:defRPr>
-            </a:pPr>
-            <a:r>
-              <a:rPr sz="900" b="0" i="0">
-                <a:solidFill>
-                  <a:srgbClr val="AAB6C8"/>
-                </a:solidFill>
-                <a:latin typeface="Roboto Mono"/>
-                <a:ea typeface="Roboto Mono"/>
-                <a:cs typeface="Roboto Mono"/>
-              </a:rPr>
-              <a:t>Host terminal</a:t>
-            </a:r>
-          </a:p>
-        </p:txBody>
-      </p:sp>
-      <p:sp>
-        <p:nvSpPr>
-          <p:cNvPr id="613" name="Google Shape;613;p30">
-            <a:extLst xmlns:a="http://schemas.openxmlformats.org/drawingml/2006/main">
-              <a:ext uri="{FF2B5EF4-FFF2-40B4-BE49-F238E27FC236}">
-                <a16:creationId xmlns:a16="http://schemas.microsoft.com/office/drawing/2014/main" id="{0C693F38-8BEB-4F75-AF6E-E006C85958CA}"/>
-              </a:ext>
-            </a:extLst>
-          </p:cNvPr>
-          <p:cNvSpPr>
-            <a:spLocks xmlns:a="http://schemas.openxmlformats.org/drawingml/2006/main" noGrp="1"/>
-          </p:cNvSpPr>
-          <p:nvPr/>
-        </p:nvSpPr>
-        <p:spPr>
-          <a:xfrm xmlns:a="http://schemas.openxmlformats.org/drawingml/2006/main">
-            <a:off x="4457700" y="1638300"/>
-            <a:ext cx="4381500" cy="9600"/>
-          </a:xfrm>
-          <a:prstGeom xmlns:a="http://schemas.openxmlformats.org/drawingml/2006/main" prst="rect">
-            <a:avLst/>
-          </a:prstGeom>
-          <a:solidFill xmlns:a="http://schemas.openxmlformats.org/drawingml/2006/main">
-            <a:srgbClr val="4A5568">
-              <a:alpha val="30000"/>
-            </a:srgbClr>
-          </a:solidFill>
-          <a:ln xmlns:a="http://schemas.openxmlformats.org/drawingml/2006/main">
-            <a:noFill/>
-          </a:ln>
-        </p:spPr>
-        <p:txBody>
-          <a:bodyPr xmlns:a="http://schemas.openxmlformats.org/drawingml/2006/main" spcFirstLastPara="1" wrap="square" lIns="0" tIns="0" rIns="0" bIns="0" anchor="ctr">
-            <a:noAutofit/>
-          </a:bodyPr>
-          <a:lstStyle xmlns:a="http://schemas.openxmlformats.org/drawingml/2006/main"/>
-          <a:p xmlns:a="http://schemas.openxmlformats.org/drawingml/2006/main">
-            <a:pPr marL="0" lvl="0" indent="0" algn="l">
-              <a:spcBef>
-                <a:spcPts val="0"/>
-              </a:spcBef>
-              <a:spcAft>
-                <a:spcPts val="0"/>
-              </a:spcAft>
-              <a:buNone/>
-            </a:pPr>
-            <a:r>
-              <a:t/>
-            </a:r>
-            <a:endParaRPr/>
-          </a:p>
-        </p:txBody>
-      </p:sp>
-      <p:sp>
-        <p:nvSpPr>
-          <p:cNvPr id="614" name="Google Shape;614;p30">
-            <a:extLst xmlns:a="http://schemas.openxmlformats.org/drawingml/2006/main">
-              <a:ext uri="{FF2B5EF4-FFF2-40B4-BE49-F238E27FC236}">
-                <a16:creationId xmlns:a16="http://schemas.microsoft.com/office/drawing/2014/main" id="{96139404-BB5E-4BCC-8A75-98AF7120A763}"/>
-              </a:ext>
-            </a:extLst>
-          </p:cNvPr>
-          <p:cNvSpPr>
-            <a:spLocks xmlns:a="http://schemas.openxmlformats.org/drawingml/2006/main" noGrp="1"/>
-          </p:cNvSpPr>
-          <p:nvPr/>
-        </p:nvSpPr>
-        <p:spPr>
-          <a:xfrm xmlns:a="http://schemas.openxmlformats.org/drawingml/2006/main">
-            <a:off x="3774125" y="1828800"/>
-            <a:ext cx="4836600" cy="2571900"/>
-          </a:xfrm>
-          <a:prstGeom xmlns:a="http://schemas.openxmlformats.org/drawingml/2006/main" prst="rect">
-            <a:avLst/>
-          </a:prstGeom>
-          <a:noFill xmlns:a="http://schemas.openxmlformats.org/drawingml/2006/main"/>
-          <a:ln xmlns:a="http://schemas.openxmlformats.org/drawingml/2006/main">
-            <a:noFill/>
-          </a:ln>
-        </p:spPr>
-        <p:txBody>
-          <a:bodyPr xmlns:a="http://schemas.openxmlformats.org/drawingml/2006/main" spcFirstLastPara="1" wrap="square" lIns="0" tIns="0" rIns="0" bIns="0" anchor="t">
-            <a:noAutofit/>
-          </a:bodyPr>
-          <a:lstStyle xmlns:a="http://schemas.openxmlformats.org/drawingml/2006/main"/>
-          <a:p xmlns:a="http://schemas.openxmlformats.org/drawingml/2006/main">
-            <a:pPr marL="0" indent="0" algn="l">
-              <a:spcBef>
-                <a:spcPts val="0"/>
-              </a:spcBef>
-              <a:spcAft>
-                <a:spcPts val="0"/>
-              </a:spcAft>
-              <a:buNone/>
-              <a:defRPr sz="1350" b="0">
-                <a:solidFill>
-                  <a:srgbClr val="00E5FF"/>
-                </a:solidFill>
-                <a:latin typeface="Roboto Mono"/>
-                <a:ea typeface="Roboto Mono"/>
-                <a:cs typeface="Roboto Mono"/>
-              </a:defRPr>
-            </a:pPr>
-            <a:r>
-              <a:rPr sz="1350" b="0" i="0">
-                <a:solidFill>
-                  <a:srgbClr val="00E5FF"/>
-                </a:solidFill>
-                <a:latin typeface="Roboto Mono"/>
-                <a:ea typeface="Roboto Mono"/>
-                <a:cs typeface="Roboto Mono"/>
-              </a:rPr>
-              <a:t>multipass stop falco-lab</a:t>
-            </a:r>
-          </a:p>
-          <a:p xmlns:a="http://schemas.openxmlformats.org/drawingml/2006/main">
-            <a:pPr marL="0" indent="0">
-              <a:spcBef>
-                <a:spcPts val="0"/>
-              </a:spcBef>
-              <a:spcAft>
-                <a:spcPts val="0"/>
-              </a:spcAft>
-              <a:buNone/>
-            </a:pPr>
-            <a:r>
-              <a:rPr sz="1350" b="0" i="0">
-                <a:solidFill>
-                  <a:srgbClr val="00E5FF"/>
-                </a:solidFill>
-                <a:latin typeface="Roboto Mono"/>
-                <a:ea typeface="Roboto Mono"/>
-                <a:cs typeface="Roboto Mono"/>
-              </a:rPr>
-              <a:t/>
-            </a:r>
-          </a:p>
-          <a:p xmlns:a="http://schemas.openxmlformats.org/drawingml/2006/main">
-            <a:pPr marL="0" indent="0" algn="l">
-              <a:spcBef>
-                <a:spcPts val="0"/>
-              </a:spcBef>
-              <a:spcAft>
-                <a:spcPts val="0"/>
-              </a:spcAft>
-              <a:buNone/>
-              <a:defRPr sz="1350" b="0">
-                <a:solidFill>
-                  <a:srgbClr val="00E5FF"/>
-                </a:solidFill>
-                <a:latin typeface="Roboto Mono"/>
-                <a:ea typeface="Roboto Mono"/>
-                <a:cs typeface="Roboto Mono"/>
-              </a:defRPr>
-            </a:pPr>
-            <a:r>
-              <a:rPr sz="1350" b="0" i="0">
-                <a:solidFill>
-                  <a:srgbClr val="00E5FF"/>
-                </a:solidFill>
-                <a:latin typeface="Roboto Mono"/>
-                <a:ea typeface="Roboto Mono"/>
-                <a:cs typeface="Roboto Mono"/>
-              </a:rPr>
-              <a:t># Next time, use your run script.</a:t>
-            </a:r>
-          </a:p>
-          <a:p xmlns:a="http://schemas.openxmlformats.org/drawingml/2006/main">
-            <a:pPr marL="0" indent="0" algn="l">
-              <a:spcBef>
-                <a:spcPts val="0"/>
-              </a:spcBef>
-              <a:spcAft>
-                <a:spcPts val="0"/>
-              </a:spcAft>
-              <a:buNone/>
-              <a:defRPr sz="1350" b="0">
-                <a:solidFill>
-                  <a:srgbClr val="00E5FF"/>
-                </a:solidFill>
-                <a:latin typeface="Roboto Mono"/>
-                <a:ea typeface="Roboto Mono"/>
-                <a:cs typeface="Roboto Mono"/>
-              </a:defRPr>
-            </a:pPr>
-            <a:r>
-              <a:rPr sz="1350" b="0" i="0">
-                <a:solidFill>
-                  <a:srgbClr val="00E5FF"/>
-                </a:solidFill>
-                <a:latin typeface="Roboto Mono"/>
-                <a:ea typeface="Roboto Mono"/>
-                <a:cs typeface="Roboto Mono"/>
-              </a:rPr>
-              <a:t># It starts the VM automatically.</a:t>
-            </a:r>
-          </a:p>
-        </p:txBody>
-      </p:sp>
-      <p:sp>
-        <p:nvSpPr>
-          <p:cNvPr id="616" name="Google Shape;616;p30">
-            <a:extLst xmlns:a="http://schemas.openxmlformats.org/drawingml/2006/main">
-              <a:ext uri="{FF2B5EF4-FFF2-40B4-BE49-F238E27FC236}">
-                <a16:creationId xmlns:a16="http://schemas.microsoft.com/office/drawing/2014/main" id="{938F25FE-1CEE-4D52-BA50-3E4F4A96F494}"/>
-              </a:ext>
-            </a:extLst>
-          </p:cNvPr>
-          <p:cNvSpPr>
-            <a:spLocks xmlns:a="http://schemas.openxmlformats.org/drawingml/2006/main" noGrp="1"/>
-          </p:cNvSpPr>
-          <p:nvPr/>
-        </p:nvSpPr>
-        <p:spPr>
-          <a:xfrm xmlns:a="http://schemas.openxmlformats.org/drawingml/2006/main" rot="0" flipH="0" flipV="0">
-            <a:off x="304800" y="4686300"/>
-            <a:ext cx="38100" cy="38100"/>
-          </a:xfrm>
-          <a:prstGeom xmlns:a="http://schemas.openxmlformats.org/drawingml/2006/main" prst="ellipse">
-            <a:avLst/>
-          </a:prstGeom>
-          <a:solidFill xmlns:a="http://schemas.openxmlformats.org/drawingml/2006/main">
-            <a:srgbClr val="4A5568">
-              <a:alpha val="20000"/>
-            </a:srgbClr>
-          </a:solidFill>
-          <a:ln xmlns:a="http://schemas.openxmlformats.org/drawingml/2006/main">
-            <a:noFill/>
-          </a:ln>
-        </p:spPr>
-        <p:txBody>
-          <a:bodyPr xmlns:a="http://schemas.openxmlformats.org/drawingml/2006/main" spcFirstLastPara="1" wrap="square" lIns="0" tIns="0" rIns="0" bIns="0" anchor="ctr">
-            <a:noAutofit/>
-          </a:bodyPr>
-          <a:lstStyle xmlns:a="http://schemas.openxmlformats.org/drawingml/2006/main"/>
-          <a:p xmlns:a="http://schemas.openxmlformats.org/drawingml/2006/main">
-            <a:pPr marL="0" lvl="0" indent="0" algn="l">
-              <a:spcBef>
-                <a:spcPts val="0"/>
-              </a:spcBef>
-              <a:spcAft>
-                <a:spcPts val="0"/>
-              </a:spcAft>
-              <a:buNone/>
-            </a:pPr>
-            <a:r>
-              <a:t/>
-            </a:r>
-            <a:endParaRPr/>
-          </a:p>
-        </p:txBody>
-      </p:sp>
-      <p:sp>
-        <p:nvSpPr>
-          <p:cNvPr id="617" name="Google Shape;617;p30">
-            <a:extLst xmlns:a="http://schemas.openxmlformats.org/drawingml/2006/main">
-              <a:ext uri="{FF2B5EF4-FFF2-40B4-BE49-F238E27FC236}">
-                <a16:creationId xmlns:a16="http://schemas.microsoft.com/office/drawing/2014/main" id="{BE48538D-7670-4B98-AE07-8E48DE8A0DFF}"/>
-              </a:ext>
-            </a:extLst>
-          </p:cNvPr>
-          <p:cNvSpPr>
-            <a:spLocks xmlns:a="http://schemas.openxmlformats.org/drawingml/2006/main" noGrp="1"/>
-          </p:cNvSpPr>
-          <p:nvPr/>
-        </p:nvSpPr>
-        <p:spPr>
-          <a:xfrm xmlns:a="http://schemas.openxmlformats.org/drawingml/2006/main" rot="0" flipH="0" flipV="0">
-            <a:off x="419100" y="4686300"/>
-            <a:ext cx="38100" cy="38100"/>
-          </a:xfrm>
-          <a:prstGeom xmlns:a="http://schemas.openxmlformats.org/drawingml/2006/main" prst="ellipse">
-            <a:avLst/>
-          </a:prstGeom>
-          <a:solidFill xmlns:a="http://schemas.openxmlformats.org/drawingml/2006/main">
-            <a:srgbClr val="4A5568">
-              <a:alpha val="20000"/>
-            </a:srgbClr>
-          </a:solidFill>
-          <a:ln xmlns:a="http://schemas.openxmlformats.org/drawingml/2006/main">
-            <a:noFill/>
-          </a:ln>
-        </p:spPr>
-        <p:txBody>
-          <a:bodyPr xmlns:a="http://schemas.openxmlformats.org/drawingml/2006/main" spcFirstLastPara="1" wrap="square" lIns="0" tIns="0" rIns="0" bIns="0" anchor="ctr">
-            <a:noAutofit/>
-          </a:bodyPr>
-          <a:lstStyle xmlns:a="http://schemas.openxmlformats.org/drawingml/2006/main"/>
-          <a:p xmlns:a="http://schemas.openxmlformats.org/drawingml/2006/main">
-            <a:pPr marL="0" lvl="0" indent="0" algn="l">
-              <a:spcBef>
-                <a:spcPts val="0"/>
-              </a:spcBef>
-              <a:spcAft>
-                <a:spcPts val="0"/>
-              </a:spcAft>
-              <a:buNone/>
-            </a:pPr>
-            <a:r>
-              <a:t/>
-            </a:r>
-            <a:endParaRPr/>
-          </a:p>
-        </p:txBody>
-      </p:sp>
-      <p:sp>
-        <p:nvSpPr>
-          <p:cNvPr id="618" name="Google Shape;618;p30">
-            <a:extLst xmlns:a="http://schemas.openxmlformats.org/drawingml/2006/main">
-              <a:ext uri="{FF2B5EF4-FFF2-40B4-BE49-F238E27FC236}">
-                <a16:creationId xmlns:a16="http://schemas.microsoft.com/office/drawing/2014/main" id="{973D0627-A512-4D22-AF39-3B6689222379}"/>
-              </a:ext>
-            </a:extLst>
-          </p:cNvPr>
-          <p:cNvSpPr>
-            <a:spLocks xmlns:a="http://schemas.openxmlformats.org/drawingml/2006/main" noGrp="1"/>
-          </p:cNvSpPr>
-          <p:nvPr/>
-        </p:nvSpPr>
-        <p:spPr>
-          <a:xfrm xmlns:a="http://schemas.openxmlformats.org/drawingml/2006/main" rot="0" flipH="0" flipV="0">
-            <a:off x="533400" y="4686300"/>
-            <a:ext cx="38100" cy="38100"/>
-          </a:xfrm>
-          <a:prstGeom xmlns:a="http://schemas.openxmlformats.org/drawingml/2006/main" prst="ellipse">
-            <a:avLst/>
-          </a:prstGeom>
-          <a:solidFill xmlns:a="http://schemas.openxmlformats.org/drawingml/2006/main">
-            <a:srgbClr val="4A5568">
-              <a:alpha val="20000"/>
-            </a:srgbClr>
-          </a:solidFill>
-          <a:ln xmlns:a="http://schemas.openxmlformats.org/drawingml/2006/main">
-            <a:noFill/>
-          </a:ln>
-        </p:spPr>
-        <p:txBody>
-          <a:bodyPr xmlns:a="http://schemas.openxmlformats.org/drawingml/2006/main" spcFirstLastPara="1" wrap="square" lIns="0" tIns="0" rIns="0" bIns="0" anchor="ctr">
-            <a:noAutofit/>
-          </a:bodyPr>
-          <a:lstStyle xmlns:a="http://schemas.openxmlformats.org/drawingml/2006/main"/>
-          <a:p xmlns:a="http://schemas.openxmlformats.org/drawingml/2006/main">
-            <a:pPr marL="0" lvl="0" indent="0" algn="l">
-              <a:spcBef>
-                <a:spcPts val="0"/>
-              </a:spcBef>
-              <a:spcAft>
-                <a:spcPts val="0"/>
-              </a:spcAft>
-              <a:buNone/>
-            </a:pPr>
-            <a:r>
-              <a:t/>
-            </a:r>
-            <a:endParaRPr/>
-          </a:p>
-        </p:txBody>
-      </p:sp>
-      <p:sp>
-        <p:nvSpPr>
-          <p:cNvPr id="619" name="Google Shape;619;p30">
-            <a:extLst xmlns:a="http://schemas.openxmlformats.org/drawingml/2006/main">
-              <a:ext uri="{FF2B5EF4-FFF2-40B4-BE49-F238E27FC236}">
-                <a16:creationId xmlns:a16="http://schemas.microsoft.com/office/drawing/2014/main" id="{54AEA391-4C9F-4080-8D49-5292B8785BD0}"/>
-              </a:ext>
-            </a:extLst>
-          </p:cNvPr>
-          <p:cNvSpPr>
-            <a:spLocks xmlns:a="http://schemas.openxmlformats.org/drawingml/2006/main" noGrp="1"/>
-          </p:cNvSpPr>
-          <p:nvPr/>
-        </p:nvSpPr>
-        <p:spPr>
-          <a:xfrm xmlns:a="http://schemas.openxmlformats.org/drawingml/2006/main" rot="0" flipH="0" flipV="0">
-            <a:off x="647700" y="4686300"/>
-            <a:ext cx="38100" cy="38100"/>
-          </a:xfrm>
-          <a:prstGeom xmlns:a="http://schemas.openxmlformats.org/drawingml/2006/main" prst="ellipse">
-            <a:avLst/>
-          </a:prstGeom>
-          <a:solidFill xmlns:a="http://schemas.openxmlformats.org/drawingml/2006/main">
-            <a:srgbClr val="4A5568">
-              <a:alpha val="20000"/>
-            </a:srgbClr>
-          </a:solidFill>
-          <a:ln xmlns:a="http://schemas.openxmlformats.org/drawingml/2006/main">
-            <a:noFill/>
-          </a:ln>
-        </p:spPr>
-        <p:txBody>
-          <a:bodyPr xmlns:a="http://schemas.openxmlformats.org/drawingml/2006/main" spcFirstLastPara="1" wrap="square" lIns="0" tIns="0" rIns="0" bIns="0" anchor="ctr">
-            <a:noAutofit/>
-          </a:bodyPr>
-          <a:lstStyle xmlns:a="http://schemas.openxmlformats.org/drawingml/2006/main"/>
-          <a:p xmlns:a="http://schemas.openxmlformats.org/drawingml/2006/main">
-            <a:pPr marL="0" lvl="0" indent="0" algn="l">
-              <a:spcBef>
-                <a:spcPts val="0"/>
-              </a:spcBef>
-              <a:spcAft>
-                <a:spcPts val="0"/>
-              </a:spcAft>
-              <a:buNone/>
-            </a:pPr>
-            <a:r>
-              <a:t/>
-            </a:r>
-            <a:endParaRPr/>
-          </a:p>
-        </p:txBody>
-      </p:sp>
-      <p:sp>
-        <p:nvSpPr>
-          <p:cNvPr id="620" name="Google Shape;620;p30">
-            <a:extLst xmlns:a="http://schemas.openxmlformats.org/drawingml/2006/main">
-              <a:ext uri="{FF2B5EF4-FFF2-40B4-BE49-F238E27FC236}">
-                <a16:creationId xmlns:a16="http://schemas.microsoft.com/office/drawing/2014/main" id="{4841CB6C-B213-4382-9120-31A9725344DF}"/>
-              </a:ext>
-            </a:extLst>
-          </p:cNvPr>
-          <p:cNvSpPr>
-            <a:spLocks xmlns:a="http://schemas.openxmlformats.org/drawingml/2006/main" noGrp="1"/>
-          </p:cNvSpPr>
-          <p:nvPr/>
-        </p:nvSpPr>
-        <p:spPr>
-          <a:xfrm xmlns:a="http://schemas.openxmlformats.org/drawingml/2006/main" rot="0" flipH="0" flipV="0">
-            <a:off x="304800" y="4800600"/>
-            <a:ext cx="38100" cy="38100"/>
-          </a:xfrm>
-          <a:prstGeom xmlns:a="http://schemas.openxmlformats.org/drawingml/2006/main" prst="ellipse">
-            <a:avLst/>
-          </a:prstGeom>
-          <a:solidFill xmlns:a="http://schemas.openxmlformats.org/drawingml/2006/main">
-            <a:srgbClr val="4A5568">
-              <a:alpha val="20000"/>
-            </a:srgbClr>
-          </a:solidFill>
-          <a:ln xmlns:a="http://schemas.openxmlformats.org/drawingml/2006/main">
-            <a:noFill/>
-          </a:ln>
-        </p:spPr>
-        <p:txBody>
-          <a:bodyPr xmlns:a="http://schemas.openxmlformats.org/drawingml/2006/main" spcFirstLastPara="1" wrap="square" lIns="0" tIns="0" rIns="0" bIns="0" anchor="ctr">
-            <a:noAutofit/>
-          </a:bodyPr>
-          <a:lstStyle xmlns:a="http://schemas.openxmlformats.org/drawingml/2006/main"/>
-          <a:p xmlns:a="http://schemas.openxmlformats.org/drawingml/2006/main">
-            <a:pPr marL="0" lvl="0" indent="0" algn="l">
-              <a:spcBef>
-                <a:spcPts val="0"/>
-              </a:spcBef>
-              <a:spcAft>
-                <a:spcPts val="0"/>
-              </a:spcAft>
-              <a:buNone/>
-            </a:pPr>
-            <a:r>
-              <a:t/>
-            </a:r>
-            <a:endParaRPr/>
-          </a:p>
-        </p:txBody>
-      </p:sp>
-      <p:sp>
-        <p:nvSpPr>
-          <p:cNvPr id="621" name="Google Shape;621;p30">
-            <a:extLst xmlns:a="http://schemas.openxmlformats.org/drawingml/2006/main">
-              <a:ext uri="{FF2B5EF4-FFF2-40B4-BE49-F238E27FC236}">
-                <a16:creationId xmlns:a16="http://schemas.microsoft.com/office/drawing/2014/main" id="{6BAFD878-D249-462E-81B1-15FA427A67FB}"/>
-              </a:ext>
-            </a:extLst>
-          </p:cNvPr>
-          <p:cNvSpPr>
-            <a:spLocks xmlns:a="http://schemas.openxmlformats.org/drawingml/2006/main" noGrp="1"/>
-          </p:cNvSpPr>
-          <p:nvPr/>
-        </p:nvSpPr>
-        <p:spPr>
-          <a:xfrm xmlns:a="http://schemas.openxmlformats.org/drawingml/2006/main" rot="0" flipH="0" flipV="0">
-            <a:off x="419100" y="4800600"/>
-            <a:ext cx="38100" cy="38100"/>
-          </a:xfrm>
-          <a:prstGeom xmlns:a="http://schemas.openxmlformats.org/drawingml/2006/main" prst="ellipse">
-            <a:avLst/>
-          </a:prstGeom>
-          <a:solidFill xmlns:a="http://schemas.openxmlformats.org/drawingml/2006/main">
-            <a:srgbClr val="4A5568">
-              <a:alpha val="20000"/>
-            </a:srgbClr>
-          </a:solidFill>
-          <a:ln xmlns:a="http://schemas.openxmlformats.org/drawingml/2006/main">
-            <a:noFill/>
-          </a:ln>
-        </p:spPr>
-        <p:txBody>
-          <a:bodyPr xmlns:a="http://schemas.openxmlformats.org/drawingml/2006/main" spcFirstLastPara="1" wrap="square" lIns="0" tIns="0" rIns="0" bIns="0" anchor="ctr">
-            <a:noAutofit/>
-          </a:bodyPr>
-          <a:lstStyle xmlns:a="http://schemas.openxmlformats.org/drawingml/2006/main"/>
-          <a:p xmlns:a="http://schemas.openxmlformats.org/drawingml/2006/main">
-            <a:pPr marL="0" lvl="0" indent="0" algn="l">
-              <a:spcBef>
-                <a:spcPts val="0"/>
-              </a:spcBef>
-              <a:spcAft>
-                <a:spcPts val="0"/>
-              </a:spcAft>
-              <a:buNone/>
-            </a:pPr>
-            <a:r>
-              <a:t/>
-            </a:r>
-            <a:endParaRPr/>
-          </a:p>
-        </p:txBody>
-      </p:sp>
-      <p:sp>
-        <p:nvSpPr>
-          <p:cNvPr id="622" name="Google Shape;622;p30">
-            <a:extLst xmlns:a="http://schemas.openxmlformats.org/drawingml/2006/main">
-              <a:ext uri="{FF2B5EF4-FFF2-40B4-BE49-F238E27FC236}">
-                <a16:creationId xmlns:a16="http://schemas.microsoft.com/office/drawing/2014/main" id="{320A5658-0CE0-4121-BC2D-84683E8BE481}"/>
-              </a:ext>
-            </a:extLst>
-          </p:cNvPr>
-          <p:cNvSpPr>
-            <a:spLocks xmlns:a="http://schemas.openxmlformats.org/drawingml/2006/main" noGrp="1"/>
-          </p:cNvSpPr>
-          <p:nvPr/>
-        </p:nvSpPr>
-        <p:spPr>
-          <a:xfrm xmlns:a="http://schemas.openxmlformats.org/drawingml/2006/main" rot="0" flipH="0" flipV="0">
-            <a:off x="533400" y="4800600"/>
-            <a:ext cx="38100" cy="38100"/>
-          </a:xfrm>
-          <a:prstGeom xmlns:a="http://schemas.openxmlformats.org/drawingml/2006/main" prst="ellipse">
-            <a:avLst/>
-          </a:prstGeom>
-          <a:solidFill xmlns:a="http://schemas.openxmlformats.org/drawingml/2006/main">
-            <a:srgbClr val="4A5568">
-              <a:alpha val="20000"/>
-            </a:srgbClr>
-          </a:solidFill>
-          <a:ln xmlns:a="http://schemas.openxmlformats.org/drawingml/2006/main">
-            <a:noFill/>
-          </a:ln>
-        </p:spPr>
-        <p:txBody>
-          <a:bodyPr xmlns:a="http://schemas.openxmlformats.org/drawingml/2006/main" spcFirstLastPara="1" wrap="square" lIns="0" tIns="0" rIns="0" bIns="0" anchor="ctr">
-            <a:noAutofit/>
-          </a:bodyPr>
-          <a:lstStyle xmlns:a="http://schemas.openxmlformats.org/drawingml/2006/main"/>
-          <a:p xmlns:a="http://schemas.openxmlformats.org/drawingml/2006/main">
-            <a:pPr marL="0" lvl="0" indent="0" algn="l">
-              <a:spcBef>
-                <a:spcPts val="0"/>
-              </a:spcBef>
-              <a:spcAft>
-                <a:spcPts val="0"/>
-              </a:spcAft>
-              <a:buNone/>
-            </a:pPr>
-            <a:r>
-              <a:t/>
-            </a:r>
-            <a:endParaRPr/>
-          </a:p>
-        </p:txBody>
-      </p:sp>
-      <p:sp>
-        <p:nvSpPr>
-          <p:cNvPr id="623" name="Google Shape;623;p30">
-            <a:extLst xmlns:a="http://schemas.openxmlformats.org/drawingml/2006/main">
-              <a:ext uri="{FF2B5EF4-FFF2-40B4-BE49-F238E27FC236}">
-                <a16:creationId xmlns:a16="http://schemas.microsoft.com/office/drawing/2014/main" id="{826F4E11-13A4-4FDC-A6F3-7BE2B87C1786}"/>
-              </a:ext>
-            </a:extLst>
-          </p:cNvPr>
-          <p:cNvSpPr>
-            <a:spLocks xmlns:a="http://schemas.openxmlformats.org/drawingml/2006/main" noGrp="1"/>
-          </p:cNvSpPr>
-          <p:nvPr/>
-        </p:nvSpPr>
-        <p:spPr>
-          <a:xfrm xmlns:a="http://schemas.openxmlformats.org/drawingml/2006/main" rot="0" flipH="0" flipV="0">
-            <a:off x="647700" y="4800600"/>
-            <a:ext cx="38100" cy="38100"/>
-          </a:xfrm>
-          <a:prstGeom xmlns:a="http://schemas.openxmlformats.org/drawingml/2006/main" prst="ellipse">
-            <a:avLst/>
-          </a:prstGeom>
-          <a:solidFill xmlns:a="http://schemas.openxmlformats.org/drawingml/2006/main">
-            <a:srgbClr val="4A5568">
-              <a:alpha val="20000"/>
-            </a:srgbClr>
-          </a:solidFill>
-          <a:ln xmlns:a="http://schemas.openxmlformats.org/drawingml/2006/main">
-            <a:noFill/>
-          </a:ln>
-        </p:spPr>
-        <p:txBody>
-          <a:bodyPr xmlns:a="http://schemas.openxmlformats.org/drawingml/2006/main" spcFirstLastPara="1" wrap="square" lIns="0" tIns="0" rIns="0" bIns="0" anchor="ctr">
-            <a:noAutofit/>
-          </a:bodyPr>
-          <a:lstStyle xmlns:a="http://schemas.openxmlformats.org/drawingml/2006/main"/>
-          <a:p xmlns:a="http://schemas.openxmlformats.org/drawingml/2006/main">
-            <a:pPr marL="0" lvl="0" indent="0" algn="l">
-              <a:spcBef>
-                <a:spcPts val="0"/>
-              </a:spcBef>
-              <a:spcAft>
-                <a:spcPts val="0"/>
-              </a:spcAft>
-              <a:buNone/>
-            </a:pPr>
-            <a:r>
-              <a:t/>
-            </a:r>
-            <a:endParaRPr/>
-          </a:p>
-        </p:txBody>
-      </p:sp>
-      <p:sp>
-        <p:nvSpPr>
-          <p:cNvPr id="624" name="Google Shape;624;p30">
-            <a:extLst xmlns:a="http://schemas.openxmlformats.org/drawingml/2006/main">
-              <a:ext uri="{FF2B5EF4-FFF2-40B4-BE49-F238E27FC236}">
-                <a16:creationId xmlns:a16="http://schemas.microsoft.com/office/drawing/2014/main" id="{EE5B6AB9-6207-43BB-88BD-98F83A2DC85C}"/>
-              </a:ext>
-            </a:extLst>
-          </p:cNvPr>
-          <p:cNvSpPr>
-            <a:spLocks xmlns:a="http://schemas.openxmlformats.org/drawingml/2006/main" noGrp="1"/>
-          </p:cNvSpPr>
-          <p:nvPr/>
-        </p:nvSpPr>
-        <p:spPr>
-          <a:xfrm xmlns:a="http://schemas.openxmlformats.org/drawingml/2006/main" rot="0" flipH="0" flipV="0">
-            <a:off x="304800" y="4914900"/>
-            <a:ext cx="38100" cy="38100"/>
-          </a:xfrm>
-          <a:prstGeom xmlns:a="http://schemas.openxmlformats.org/drawingml/2006/main" prst="ellipse">
-            <a:avLst/>
-          </a:prstGeom>
-          <a:solidFill xmlns:a="http://schemas.openxmlformats.org/drawingml/2006/main">
-            <a:srgbClr val="4A5568">
-              <a:alpha val="20000"/>
-            </a:srgbClr>
-          </a:solidFill>
-          <a:ln xmlns:a="http://schemas.openxmlformats.org/drawingml/2006/main">
-            <a:noFill/>
-          </a:ln>
-        </p:spPr>
-        <p:txBody>
-          <a:bodyPr xmlns:a="http://schemas.openxmlformats.org/drawingml/2006/main" spcFirstLastPara="1" wrap="square" lIns="0" tIns="0" rIns="0" bIns="0" anchor="ctr">
-            <a:noAutofit/>
-          </a:bodyPr>
-          <a:lstStyle xmlns:a="http://schemas.openxmlformats.org/drawingml/2006/main"/>
-          <a:p xmlns:a="http://schemas.openxmlformats.org/drawingml/2006/main">
-            <a:pPr marL="0" lvl="0" indent="0" algn="l">
-              <a:spcBef>
-                <a:spcPts val="0"/>
-              </a:spcBef>
-              <a:spcAft>
-                <a:spcPts val="0"/>
-              </a:spcAft>
-              <a:buNone/>
-            </a:pPr>
-            <a:r>
-              <a:t/>
-            </a:r>
-            <a:endParaRPr/>
-          </a:p>
-        </p:txBody>
-      </p:sp>
-      <p:sp>
-        <p:nvSpPr>
-          <p:cNvPr id="625" name="Google Shape;625;p30">
-            <a:extLst xmlns:a="http://schemas.openxmlformats.org/drawingml/2006/main">
-              <a:ext uri="{FF2B5EF4-FFF2-40B4-BE49-F238E27FC236}">
-                <a16:creationId xmlns:a16="http://schemas.microsoft.com/office/drawing/2014/main" id="{C2DF7D51-C402-46B7-960E-6C22BD70E859}"/>
-              </a:ext>
-            </a:extLst>
-          </p:cNvPr>
-          <p:cNvSpPr>
-            <a:spLocks xmlns:a="http://schemas.openxmlformats.org/drawingml/2006/main" noGrp="1"/>
-          </p:cNvSpPr>
-          <p:nvPr/>
-        </p:nvSpPr>
-        <p:spPr>
-          <a:xfrm xmlns:a="http://schemas.openxmlformats.org/drawingml/2006/main" rot="0" flipH="0" flipV="0">
-            <a:off x="419100" y="4914900"/>
-            <a:ext cx="38100" cy="38100"/>
-          </a:xfrm>
-          <a:prstGeom xmlns:a="http://schemas.openxmlformats.org/drawingml/2006/main" prst="ellipse">
-            <a:avLst/>
-          </a:prstGeom>
-          <a:solidFill xmlns:a="http://schemas.openxmlformats.org/drawingml/2006/main">
-            <a:srgbClr val="4A5568">
-              <a:alpha val="20000"/>
-            </a:srgbClr>
-          </a:solidFill>
-          <a:ln xmlns:a="http://schemas.openxmlformats.org/drawingml/2006/main">
-            <a:noFill/>
-          </a:ln>
-        </p:spPr>
-        <p:txBody>
-          <a:bodyPr xmlns:a="http://schemas.openxmlformats.org/drawingml/2006/main" spcFirstLastPara="1" wrap="square" lIns="0" tIns="0" rIns="0" bIns="0" anchor="ctr">
-            <a:noAutofit/>
-          </a:bodyPr>
-          <a:lstStyle xmlns:a="http://schemas.openxmlformats.org/drawingml/2006/main"/>
-          <a:p xmlns:a="http://schemas.openxmlformats.org/drawingml/2006/main">
-            <a:pPr marL="0" lvl="0" indent="0" algn="l">
-              <a:spcBef>
-                <a:spcPts val="0"/>
-              </a:spcBef>
-              <a:spcAft>
-                <a:spcPts val="0"/>
-              </a:spcAft>
-              <a:buNone/>
-            </a:pPr>
-            <a:r>
-              <a:t/>
-            </a:r>
-            <a:endParaRPr/>
-          </a:p>
-        </p:txBody>
-      </p:sp>
-      <p:sp>
-        <p:nvSpPr>
-          <p:cNvPr id="626" name="Google Shape;626;p30">
-            <a:extLst xmlns:a="http://schemas.openxmlformats.org/drawingml/2006/main">
-              <a:ext uri="{FF2B5EF4-FFF2-40B4-BE49-F238E27FC236}">
-                <a16:creationId xmlns:a16="http://schemas.microsoft.com/office/drawing/2014/main" id="{62DB0BB0-C739-46BB-BE25-D88FBACB8360}"/>
-              </a:ext>
-            </a:extLst>
-          </p:cNvPr>
-          <p:cNvSpPr>
-            <a:spLocks xmlns:a="http://schemas.openxmlformats.org/drawingml/2006/main" noGrp="1"/>
-          </p:cNvSpPr>
-          <p:nvPr/>
-        </p:nvSpPr>
-        <p:spPr>
-          <a:xfrm xmlns:a="http://schemas.openxmlformats.org/drawingml/2006/main" rot="0" flipH="0" flipV="0">
-            <a:off x="533400" y="4914900"/>
-            <a:ext cx="38100" cy="38100"/>
-          </a:xfrm>
-          <a:prstGeom xmlns:a="http://schemas.openxmlformats.org/drawingml/2006/main" prst="ellipse">
-            <a:avLst/>
-          </a:prstGeom>
-          <a:solidFill xmlns:a="http://schemas.openxmlformats.org/drawingml/2006/main">
-            <a:srgbClr val="4A5568">
-              <a:alpha val="20000"/>
-            </a:srgbClr>
-          </a:solidFill>
-          <a:ln xmlns:a="http://schemas.openxmlformats.org/drawingml/2006/main">
-            <a:noFill/>
-          </a:ln>
-        </p:spPr>
-        <p:txBody>
-          <a:bodyPr xmlns:a="http://schemas.openxmlformats.org/drawingml/2006/main" spcFirstLastPara="1" wrap="square" lIns="0" tIns="0" rIns="0" bIns="0" anchor="ctr">
-            <a:noAutofit/>
-          </a:bodyPr>
-          <a:lstStyle xmlns:a="http://schemas.openxmlformats.org/drawingml/2006/main"/>
-          <a:p xmlns:a="http://schemas.openxmlformats.org/drawingml/2006/main">
-            <a:pPr marL="0" lvl="0" indent="0" algn="l">
-              <a:spcBef>
-                <a:spcPts val="0"/>
-              </a:spcBef>
-              <a:spcAft>
-                <a:spcPts val="0"/>
-              </a:spcAft>
-              <a:buNone/>
-            </a:pPr>
-            <a:r>
-              <a:t/>
-            </a:r>
-            <a:endParaRPr/>
-          </a:p>
-        </p:txBody>
-      </p:sp>
-      <p:sp>
-        <p:nvSpPr>
-          <p:cNvPr id="627" name="Google Shape;627;p30">
-            <a:extLst xmlns:a="http://schemas.openxmlformats.org/drawingml/2006/main">
-              <a:ext uri="{FF2B5EF4-FFF2-40B4-BE49-F238E27FC236}">
-                <a16:creationId xmlns:a16="http://schemas.microsoft.com/office/drawing/2014/main" id="{B5CB37D1-1DA5-4A9C-A4BD-F5E753BFDF6A}"/>
-              </a:ext>
-            </a:extLst>
-          </p:cNvPr>
-          <p:cNvSpPr>
-            <a:spLocks xmlns:a="http://schemas.openxmlformats.org/drawingml/2006/main" noGrp="1"/>
-          </p:cNvSpPr>
-          <p:nvPr/>
-        </p:nvSpPr>
-        <p:spPr>
-          <a:xfrm xmlns:a="http://schemas.openxmlformats.org/drawingml/2006/main" rot="0" flipH="0" flipV="0">
-            <a:off x="647700" y="4914900"/>
-            <a:ext cx="38100" cy="38100"/>
-          </a:xfrm>
-          <a:prstGeom xmlns:a="http://schemas.openxmlformats.org/drawingml/2006/main" prst="ellipse">
-            <a:avLst/>
-          </a:prstGeom>
-          <a:solidFill xmlns:a="http://schemas.openxmlformats.org/drawingml/2006/main">
-            <a:srgbClr val="4A5568">
-              <a:alpha val="20000"/>
-            </a:srgbClr>
-          </a:solidFill>
-          <a:ln xmlns:a="http://schemas.openxmlformats.org/drawingml/2006/main">
-            <a:noFill/>
-          </a:ln>
-        </p:spPr>
-        <p:txBody>
-          <a:bodyPr xmlns:a="http://schemas.openxmlformats.org/drawingml/2006/main" spcFirstLastPara="1" wrap="square" lIns="0" tIns="0" rIns="0" bIns="0" anchor="ctr">
-            <a:noAutofit/>
-          </a:bodyPr>
-          <a:lstStyle xmlns:a="http://schemas.openxmlformats.org/drawingml/2006/main"/>
-          <a:p xmlns:a="http://schemas.openxmlformats.org/drawingml/2006/main">
-            <a:pPr marL="0" lvl="0" indent="0" algn="l">
-              <a:spcBef>
-                <a:spcPts val="0"/>
-              </a:spcBef>
-              <a:spcAft>
-                <a:spcPts val="0"/>
-              </a:spcAft>
-              <a:buNone/>
-            </a:pPr>
-            <a:r>
-              <a:t/>
-            </a:r>
-            <a:endParaRPr/>
-          </a:p>
-        </p:txBody>
-      </p:sp>
-      <p:pic>
-        <p:nvPicPr>
-          <p:cNvPr id="665" name="Google Shape;628;p30"/>
-          <p:cNvPicPr>
-            <a:picLocks xmlns:a="http://schemas.openxmlformats.org/drawingml/2006/main" noChangeAspect="1"/>
-          </p:cNvPicPr>
-          <p:nvPr/>
-        </p:nvPicPr>
-        <p:blipFill rotWithShape="1">
-          <a:blip xmlns:r="http://schemas.openxmlformats.org/officeDocument/2006/relationships" xmlns:a="http://schemas.openxmlformats.org/drawingml/2006/main" r:embed="Ree768ddb031c4d42">
-            <a:alphaModFix/>
-          </a:blip>
-          <a:srcRect xmlns:a="http://schemas.openxmlformats.org/drawingml/2006/main" l="0" t="0" r="0" b="0"/>
-          <a:stretch xmlns:a="http://schemas.openxmlformats.org/drawingml/2006/main"/>
-        </p:blipFill>
-        <p:spPr>
-          <a:xfrm xmlns:a="http://schemas.openxmlformats.org/drawingml/2006/main" rot="0" flipH="0" flipV="0">
-            <a:off x="304800" y="5029200"/>
-            <a:ext cx="38100" cy="38100"/>
-          </a:xfrm>
-          <a:prstGeom xmlns:a="http://schemas.openxmlformats.org/drawingml/2006/main" prst="rect">
-            <a:avLst/>
-          </a:prstGeom>
-          <a:ln xmlns:a="http://schemas.openxmlformats.org/drawingml/2006/main">
-            <a:noFill/>
-          </a:ln>
-        </p:spPr>
-      </p:pic>
-      <p:pic>
-        <p:nvPicPr>
-          <p:cNvPr id="666" name="Google Shape;629;p30"/>
-          <p:cNvPicPr>
-            <a:picLocks xmlns:a="http://schemas.openxmlformats.org/drawingml/2006/main" noChangeAspect="1"/>
-          </p:cNvPicPr>
-          <p:nvPr/>
-        </p:nvPicPr>
-        <p:blipFill rotWithShape="1">
-          <a:blip xmlns:r="http://schemas.openxmlformats.org/officeDocument/2006/relationships" xmlns:a="http://schemas.openxmlformats.org/drawingml/2006/main" r:embed="Ree768ddb031c4d42">
-            <a:alphaModFix/>
-          </a:blip>
-          <a:srcRect xmlns:a="http://schemas.openxmlformats.org/drawingml/2006/main" l="0" t="0" r="0" b="0"/>
-          <a:stretch xmlns:a="http://schemas.openxmlformats.org/drawingml/2006/main"/>
-        </p:blipFill>
-        <p:spPr>
-          <a:xfrm xmlns:a="http://schemas.openxmlformats.org/drawingml/2006/main" rot="0" flipH="0" flipV="0">
-            <a:off x="419100" y="5029200"/>
-            <a:ext cx="38100" cy="38100"/>
-          </a:xfrm>
-          <a:prstGeom xmlns:a="http://schemas.openxmlformats.org/drawingml/2006/main" prst="rect">
-            <a:avLst/>
-          </a:prstGeom>
-          <a:ln xmlns:a="http://schemas.openxmlformats.org/drawingml/2006/main">
-            <a:noFill/>
-          </a:ln>
-        </p:spPr>
-      </p:pic>
-      <p:pic>
-        <p:nvPicPr>
-          <p:cNvPr id="667" name="Google Shape;630;p30"/>
-          <p:cNvPicPr>
-            <a:picLocks xmlns:a="http://schemas.openxmlformats.org/drawingml/2006/main" noChangeAspect="1"/>
-          </p:cNvPicPr>
-          <p:nvPr/>
-        </p:nvPicPr>
-        <p:blipFill rotWithShape="1">
-          <a:blip xmlns:r="http://schemas.openxmlformats.org/officeDocument/2006/relationships" xmlns:a="http://schemas.openxmlformats.org/drawingml/2006/main" r:embed="Ree768ddb031c4d42">
-            <a:alphaModFix/>
-          </a:blip>
-          <a:srcRect xmlns:a="http://schemas.openxmlformats.org/drawingml/2006/main" l="0" t="0" r="0" b="0"/>
-          <a:stretch xmlns:a="http://schemas.openxmlformats.org/drawingml/2006/main"/>
-        </p:blipFill>
-        <p:spPr>
-          <a:xfrm xmlns:a="http://schemas.openxmlformats.org/drawingml/2006/main" rot="0" flipH="0" flipV="0">
-            <a:off x="533400" y="5029200"/>
-            <a:ext cx="38100" cy="38100"/>
-          </a:xfrm>
-          <a:prstGeom xmlns:a="http://schemas.openxmlformats.org/drawingml/2006/main" prst="rect">
-            <a:avLst/>
-          </a:prstGeom>
-          <a:ln xmlns:a="http://schemas.openxmlformats.org/drawingml/2006/main">
-            <a:noFill/>
-          </a:ln>
-        </p:spPr>
-      </p:pic>
-      <p:pic>
-        <p:nvPicPr>
-          <p:cNvPr id="668" name="Google Shape;631;p30"/>
-          <p:cNvPicPr>
-            <a:picLocks xmlns:a="http://schemas.openxmlformats.org/drawingml/2006/main" noChangeAspect="1"/>
-          </p:cNvPicPr>
-          <p:nvPr/>
-        </p:nvPicPr>
-        <p:blipFill rotWithShape="1">
-          <a:blip xmlns:r="http://schemas.openxmlformats.org/officeDocument/2006/relationships" xmlns:a="http://schemas.openxmlformats.org/drawingml/2006/main" r:embed="Ree768ddb031c4d42">
+          <a:blip xmlns:r="http://schemas.openxmlformats.org/officeDocument/2006/relationships" xmlns:a="http://schemas.openxmlformats.org/drawingml/2006/main" r:embed="Rdab58bcbee054095">
             <a:alphaModFix/>
           </a:blip>
           <a:srcRect xmlns:a="http://schemas.openxmlformats.org/drawingml/2006/main" l="0" t="0" r="0" b="0"/>
@@ -19987,59 +18001,7 @@
                 <a:ea typeface="Roboto Mono"/>
                 <a:cs typeface="Roboto Mono"/>
               </a:rPr>
-              <a:t>Step 3: Filter executions</a:t>
-            </a:r>
-          </a:p>
-          <a:p xmlns:a="http://schemas.openxmlformats.org/drawingml/2006/main">
-            <a:pPr marL="0" indent="0">
-              <a:spcBef>
-                <a:spcPts val="0"/>
-              </a:spcBef>
-              <a:spcAft>
-                <a:spcPts val="0"/>
-              </a:spcAft>
-              <a:buNone/>
-            </a:pPr>
-            <a:r>
-              <a:rPr sz="1350" b="0" i="0">
-                <a:solidFill>
-                  <a:srgbClr val="00E5FF"/>
-                </a:solidFill>
-                <a:latin typeface="Roboto Mono"/>
-                <a:ea typeface="Roboto Mono"/>
-                <a:cs typeface="Roboto Mono"/>
-              </a:rPr>
-              <a:t/>
-            </a:r>
-          </a:p>
-          <a:p xmlns:a="http://schemas.openxmlformats.org/drawingml/2006/main">
-            <a:pPr marL="0" indent="0" algn="l">
-              <a:spcBef>
-                <a:spcPts val="0"/>
-              </a:spcBef>
-              <a:spcAft>
-                <a:spcPts val="0"/>
-              </a:spcAft>
-              <a:buNone/>
-              <a:defRPr sz="1350" b="0">
-                <a:solidFill>
-                  <a:srgbClr val="00E5FF"/>
-                </a:solidFill>
-                <a:latin typeface="Roboto Mono"/>
-                <a:ea typeface="Roboto Mono"/>
-                <a:cs typeface="Roboto Mono"/>
-              </a:defRPr>
-            </a:pPr>
-            <a:r>
-              <a:rPr sz="1350" b="0" i="0">
-                <a:solidFill>
-                  <a:srgbClr val="00E5FF"/>
-                </a:solidFill>
-                <a:latin typeface="Roboto Mono"/>
-                <a:ea typeface="Roboto Mono"/>
-                <a:cs typeface="Roboto Mono"/>
-              </a:rPr>
-              <a:t>Step 4: Add name and PID</a:t>
+              <a:t>Step 3: Add name and PID</a:t>
             </a:r>
           </a:p>
         </p:txBody>
@@ -20689,7 +18651,7 @@
           <p:nvPr/>
         </p:nvPicPr>
         <p:blipFill rotWithShape="1">
-          <a:blip xmlns:r="http://schemas.openxmlformats.org/officeDocument/2006/relationships" xmlns:a="http://schemas.openxmlformats.org/drawingml/2006/main" r:embed="Re05fa0a8752d494b">
+          <a:blip xmlns:r="http://schemas.openxmlformats.org/officeDocument/2006/relationships" xmlns:a="http://schemas.openxmlformats.org/drawingml/2006/main" r:embed="R367a6dc109264d5f">
             <a:alphaModFix/>
           </a:blip>
           <a:srcRect xmlns:a="http://schemas.openxmlformats.org/drawingml/2006/main" l="0" t="0" r="0" b="0"/>
@@ -20717,7 +18679,7 @@
           <p:nvPr/>
         </p:nvPicPr>
         <p:blipFill rotWithShape="1">
-          <a:blip xmlns:r="http://schemas.openxmlformats.org/officeDocument/2006/relationships" xmlns:a="http://schemas.openxmlformats.org/drawingml/2006/main" r:embed="Re05fa0a8752d494b">
+          <a:blip xmlns:r="http://schemas.openxmlformats.org/officeDocument/2006/relationships" xmlns:a="http://schemas.openxmlformats.org/drawingml/2006/main" r:embed="R367a6dc109264d5f">
             <a:alphaModFix/>
           </a:blip>
           <a:srcRect xmlns:a="http://schemas.openxmlformats.org/drawingml/2006/main" l="0" t="0" r="0" b="0"/>
@@ -20745,7 +18707,7 @@
           <p:nvPr/>
         </p:nvPicPr>
         <p:blipFill rotWithShape="1">
-          <a:blip xmlns:r="http://schemas.openxmlformats.org/officeDocument/2006/relationships" xmlns:a="http://schemas.openxmlformats.org/drawingml/2006/main" r:embed="Re05fa0a8752d494b">
+          <a:blip xmlns:r="http://schemas.openxmlformats.org/officeDocument/2006/relationships" xmlns:a="http://schemas.openxmlformats.org/drawingml/2006/main" r:embed="R367a6dc109264d5f">
             <a:alphaModFix/>
           </a:blip>
           <a:srcRect xmlns:a="http://schemas.openxmlformats.org/drawingml/2006/main" l="0" t="0" r="0" b="0"/>
@@ -20773,7 +18735,7 @@
           <p:nvPr/>
         </p:nvPicPr>
         <p:blipFill rotWithShape="1">
-          <a:blip xmlns:r="http://schemas.openxmlformats.org/officeDocument/2006/relationships" xmlns:a="http://schemas.openxmlformats.org/drawingml/2006/main" r:embed="Re05fa0a8752d494b">
+          <a:blip xmlns:r="http://schemas.openxmlformats.org/officeDocument/2006/relationships" xmlns:a="http://schemas.openxmlformats.org/drawingml/2006/main" r:embed="R367a6dc109264d5f">
             <a:alphaModFix/>
           </a:blip>
           <a:srcRect xmlns:a="http://schemas.openxmlformats.org/drawingml/2006/main" l="0" t="0" r="0" b="0"/>
@@ -22386,7 +20348,7 @@
           <p:nvPr/>
         </p:nvPicPr>
         <p:blipFill rotWithShape="1">
-          <a:blip xmlns:r="http://schemas.openxmlformats.org/officeDocument/2006/relationships" xmlns:a="http://schemas.openxmlformats.org/drawingml/2006/main" r:embed="Re144d3f7ce314b6e">
+          <a:blip xmlns:r="http://schemas.openxmlformats.org/officeDocument/2006/relationships" xmlns:a="http://schemas.openxmlformats.org/drawingml/2006/main" r:embed="R3e93fa48acae4a62">
             <a:alphaModFix/>
           </a:blip>
           <a:srcRect xmlns:a="http://schemas.openxmlformats.org/drawingml/2006/main" l="0" t="0" r="0" b="0"/>
@@ -22414,7 +20376,7 @@
           <p:nvPr/>
         </p:nvPicPr>
         <p:blipFill rotWithShape="1">
-          <a:blip xmlns:r="http://schemas.openxmlformats.org/officeDocument/2006/relationships" xmlns:a="http://schemas.openxmlformats.org/drawingml/2006/main" r:embed="Re144d3f7ce314b6e">
+          <a:blip xmlns:r="http://schemas.openxmlformats.org/officeDocument/2006/relationships" xmlns:a="http://schemas.openxmlformats.org/drawingml/2006/main" r:embed="R3e93fa48acae4a62">
             <a:alphaModFix/>
           </a:blip>
           <a:srcRect xmlns:a="http://schemas.openxmlformats.org/drawingml/2006/main" l="0" t="0" r="0" b="0"/>
@@ -22442,7 +20404,7 @@
           <p:nvPr/>
         </p:nvPicPr>
         <p:blipFill rotWithShape="1">
-          <a:blip xmlns:r="http://schemas.openxmlformats.org/officeDocument/2006/relationships" xmlns:a="http://schemas.openxmlformats.org/drawingml/2006/main" r:embed="Re144d3f7ce314b6e">
+          <a:blip xmlns:r="http://schemas.openxmlformats.org/officeDocument/2006/relationships" xmlns:a="http://schemas.openxmlformats.org/drawingml/2006/main" r:embed="R3e93fa48acae4a62">
             <a:alphaModFix/>
           </a:blip>
           <a:srcRect xmlns:a="http://schemas.openxmlformats.org/drawingml/2006/main" l="0" t="0" r="0" b="0"/>
@@ -22470,7 +20432,7 @@
           <p:nvPr/>
         </p:nvPicPr>
         <p:blipFill rotWithShape="1">
-          <a:blip xmlns:r="http://schemas.openxmlformats.org/officeDocument/2006/relationships" xmlns:a="http://schemas.openxmlformats.org/drawingml/2006/main" r:embed="Re144d3f7ce314b6e">
+          <a:blip xmlns:r="http://schemas.openxmlformats.org/officeDocument/2006/relationships" xmlns:a="http://schemas.openxmlformats.org/drawingml/2006/main" r:embed="R3e93fa48acae4a62">
             <a:alphaModFix/>
           </a:blip>
           <a:srcRect xmlns:a="http://schemas.openxmlformats.org/drawingml/2006/main" l="0" t="0" r="0" b="0"/>
@@ -24083,7 +22045,7 @@
           <p:nvPr/>
         </p:nvPicPr>
         <p:blipFill rotWithShape="1">
-          <a:blip xmlns:r="http://schemas.openxmlformats.org/officeDocument/2006/relationships" xmlns:a="http://schemas.openxmlformats.org/drawingml/2006/main" r:embed="Red75036c0dfe4f62">
+          <a:blip xmlns:r="http://schemas.openxmlformats.org/officeDocument/2006/relationships" xmlns:a="http://schemas.openxmlformats.org/drawingml/2006/main" r:embed="R18845f38a6d343e8">
             <a:alphaModFix/>
           </a:blip>
           <a:srcRect xmlns:a="http://schemas.openxmlformats.org/drawingml/2006/main" l="0" t="0" r="0" b="0"/>
@@ -24111,7 +22073,7 @@
           <p:nvPr/>
         </p:nvPicPr>
         <p:blipFill rotWithShape="1">
-          <a:blip xmlns:r="http://schemas.openxmlformats.org/officeDocument/2006/relationships" xmlns:a="http://schemas.openxmlformats.org/drawingml/2006/main" r:embed="Red75036c0dfe4f62">
+          <a:blip xmlns:r="http://schemas.openxmlformats.org/officeDocument/2006/relationships" xmlns:a="http://schemas.openxmlformats.org/drawingml/2006/main" r:embed="R18845f38a6d343e8">
             <a:alphaModFix/>
           </a:blip>
           <a:srcRect xmlns:a="http://schemas.openxmlformats.org/drawingml/2006/main" l="0" t="0" r="0" b="0"/>
@@ -24139,7 +22101,7 @@
           <p:nvPr/>
         </p:nvPicPr>
         <p:blipFill rotWithShape="1">
-          <a:blip xmlns:r="http://schemas.openxmlformats.org/officeDocument/2006/relationships" xmlns:a="http://schemas.openxmlformats.org/drawingml/2006/main" r:embed="Red75036c0dfe4f62">
+          <a:blip xmlns:r="http://schemas.openxmlformats.org/officeDocument/2006/relationships" xmlns:a="http://schemas.openxmlformats.org/drawingml/2006/main" r:embed="R18845f38a6d343e8">
             <a:alphaModFix/>
           </a:blip>
           <a:srcRect xmlns:a="http://schemas.openxmlformats.org/drawingml/2006/main" l="0" t="0" r="0" b="0"/>
@@ -24167,7 +22129,7 @@
           <p:nvPr/>
         </p:nvPicPr>
         <p:blipFill rotWithShape="1">
-          <a:blip xmlns:r="http://schemas.openxmlformats.org/officeDocument/2006/relationships" xmlns:a="http://schemas.openxmlformats.org/drawingml/2006/main" r:embed="Red75036c0dfe4f62">
+          <a:blip xmlns:r="http://schemas.openxmlformats.org/officeDocument/2006/relationships" xmlns:a="http://schemas.openxmlformats.org/drawingml/2006/main" r:embed="R18845f38a6d343e8">
             <a:alphaModFix/>
           </a:blip>
           <a:srcRect xmlns:a="http://schemas.openxmlformats.org/drawingml/2006/main" l="0" t="0" r="0" b="0"/>
@@ -26062,7 +24024,7 @@
           <p:nvPr/>
         </p:nvPicPr>
         <p:blipFill rotWithShape="1">
-          <a:blip xmlns:r="http://schemas.openxmlformats.org/officeDocument/2006/relationships" xmlns:a="http://schemas.openxmlformats.org/drawingml/2006/main" r:embed="Re750543b898b4342">
+          <a:blip xmlns:r="http://schemas.openxmlformats.org/officeDocument/2006/relationships" xmlns:a="http://schemas.openxmlformats.org/drawingml/2006/main" r:embed="R0b431705fa464337">
             <a:alphaModFix/>
           </a:blip>
           <a:srcRect xmlns:a="http://schemas.openxmlformats.org/drawingml/2006/main" l="0" t="0" r="0" b="0"/>
@@ -26090,7 +24052,7 @@
           <p:nvPr/>
         </p:nvPicPr>
         <p:blipFill rotWithShape="1">
-          <a:blip xmlns:r="http://schemas.openxmlformats.org/officeDocument/2006/relationships" xmlns:a="http://schemas.openxmlformats.org/drawingml/2006/main" r:embed="Re750543b898b4342">
+          <a:blip xmlns:r="http://schemas.openxmlformats.org/officeDocument/2006/relationships" xmlns:a="http://schemas.openxmlformats.org/drawingml/2006/main" r:embed="R0b431705fa464337">
             <a:alphaModFix/>
           </a:blip>
           <a:srcRect xmlns:a="http://schemas.openxmlformats.org/drawingml/2006/main" l="0" t="0" r="0" b="0"/>
@@ -26118,7 +24080,7 @@
           <p:nvPr/>
         </p:nvPicPr>
         <p:blipFill rotWithShape="1">
-          <a:blip xmlns:r="http://schemas.openxmlformats.org/officeDocument/2006/relationships" xmlns:a="http://schemas.openxmlformats.org/drawingml/2006/main" r:embed="Re750543b898b4342">
+          <a:blip xmlns:r="http://schemas.openxmlformats.org/officeDocument/2006/relationships" xmlns:a="http://schemas.openxmlformats.org/drawingml/2006/main" r:embed="R0b431705fa464337">
             <a:alphaModFix/>
           </a:blip>
           <a:srcRect xmlns:a="http://schemas.openxmlformats.org/drawingml/2006/main" l="0" t="0" r="0" b="0"/>
@@ -26146,7 +24108,7 @@
           <p:nvPr/>
         </p:nvPicPr>
         <p:blipFill rotWithShape="1">
-          <a:blip xmlns:r="http://schemas.openxmlformats.org/officeDocument/2006/relationships" xmlns:a="http://schemas.openxmlformats.org/drawingml/2006/main" r:embed="Re750543b898b4342">
+          <a:blip xmlns:r="http://schemas.openxmlformats.org/officeDocument/2006/relationships" xmlns:a="http://schemas.openxmlformats.org/drawingml/2006/main" r:embed="R0b431705fa464337">
             <a:alphaModFix/>
           </a:blip>
           <a:srcRect xmlns:a="http://schemas.openxmlformats.org/drawingml/2006/main" l="0" t="0" r="0" b="0"/>
@@ -27180,66 +25142,6 @@
               <a:t>bash scripts/mac/run.sh</a:t>
             </a:r>
           </a:p>
-          <a:p xmlns:a="http://schemas.openxmlformats.org/drawingml/2006/main">
-            <a:pPr marL="0" indent="0" algn="l">
-              <a:spcBef>
-                <a:spcPts val="0"/>
-              </a:spcBef>
-              <a:spcAft>
-                <a:spcPts val="0"/>
-              </a:spcAft>
-              <a:buNone/>
-              <a:defRPr sz="1500" b="0">
-                <a:solidFill>
-                  <a:srgbClr val="00E5FF"/>
-                </a:solidFill>
-                <a:latin typeface="Roboto Mono"/>
-                <a:ea typeface="Roboto Mono"/>
-                <a:cs typeface="Roboto Mono"/>
-              </a:defRPr>
-            </a:pPr>
-            <a:r>
-              <a:rPr sz="1500" b="0" i="0">
-                <a:solidFill>
-                  <a:srgbClr val="00E5FF"/>
-                </a:solidFill>
-                <a:latin typeface="Roboto Mono"/>
-                <a:ea typeface="Roboto Mono"/>
-                <a:cs typeface="Roboto Mono"/>
-              </a:rPr>
-              <a:t>bash scripts/mac/step-4.sh</a:t>
-            </a:r>
-          </a:p>
-          <a:p xmlns:a="http://schemas.openxmlformats.org/drawingml/2006/main">
-            <a:pPr marL="0" indent="0" algn="l">
-              <a:spcBef>
-                <a:spcPts val="0"/>
-              </a:spcBef>
-              <a:spcAft>
-                <a:spcPts val="0"/>
-              </a:spcAft>
-              <a:buNone/>
-              <a:defRPr sz="1500" b="0">
-                <a:solidFill>
-                  <a:srgbClr val="00E5FF"/>
-                </a:solidFill>
-                <a:latin typeface="Roboto Mono"/>
-                <a:ea typeface="Roboto Mono"/>
-                <a:cs typeface="Roboto Mono"/>
-              </a:defRPr>
-            </a:pPr>
-            <a:r>
-              <a:rPr sz="1500" b="0" i="0">
-                <a:solidFill>
-                  <a:srgbClr val="00E5FF"/>
-                </a:solidFill>
-                <a:latin typeface="Roboto Mono"/>
-                <a:ea typeface="Roboto Mono"/>
-                <a:cs typeface="Roboto Mono"/>
-              </a:rPr>
-              <a:t>bash scripts/mac/run.sh</a:t>
-            </a:r>
-          </a:p>
         </p:txBody>
       </p:sp>
       <p:sp>
@@ -27887,7 +25789,7 @@
           <p:nvPr/>
         </p:nvPicPr>
         <p:blipFill rotWithShape="1">
-          <a:blip xmlns:r="http://schemas.openxmlformats.org/officeDocument/2006/relationships" xmlns:a="http://schemas.openxmlformats.org/drawingml/2006/main" r:embed="Rfe64fe1f33824770">
+          <a:blip xmlns:r="http://schemas.openxmlformats.org/officeDocument/2006/relationships" xmlns:a="http://schemas.openxmlformats.org/drawingml/2006/main" r:embed="R03e7ae93ba794ece">
             <a:alphaModFix/>
           </a:blip>
           <a:srcRect xmlns:a="http://schemas.openxmlformats.org/drawingml/2006/main" l="0" t="0" r="0" b="0"/>
@@ -27915,7 +25817,7 @@
           <p:nvPr/>
         </p:nvPicPr>
         <p:blipFill rotWithShape="1">
-          <a:blip xmlns:r="http://schemas.openxmlformats.org/officeDocument/2006/relationships" xmlns:a="http://schemas.openxmlformats.org/drawingml/2006/main" r:embed="Rfe64fe1f33824770">
+          <a:blip xmlns:r="http://schemas.openxmlformats.org/officeDocument/2006/relationships" xmlns:a="http://schemas.openxmlformats.org/drawingml/2006/main" r:embed="R03e7ae93ba794ece">
             <a:alphaModFix/>
           </a:blip>
           <a:srcRect xmlns:a="http://schemas.openxmlformats.org/drawingml/2006/main" l="0" t="0" r="0" b="0"/>
@@ -27943,7 +25845,7 @@
           <p:nvPr/>
         </p:nvPicPr>
         <p:blipFill rotWithShape="1">
-          <a:blip xmlns:r="http://schemas.openxmlformats.org/officeDocument/2006/relationships" xmlns:a="http://schemas.openxmlformats.org/drawingml/2006/main" r:embed="Rfe64fe1f33824770">
+          <a:blip xmlns:r="http://schemas.openxmlformats.org/officeDocument/2006/relationships" xmlns:a="http://schemas.openxmlformats.org/drawingml/2006/main" r:embed="R03e7ae93ba794ece">
             <a:alphaModFix/>
           </a:blip>
           <a:srcRect xmlns:a="http://schemas.openxmlformats.org/drawingml/2006/main" l="0" t="0" r="0" b="0"/>
@@ -27971,7 +25873,7 @@
           <p:nvPr/>
         </p:nvPicPr>
         <p:blipFill rotWithShape="1">
-          <a:blip xmlns:r="http://schemas.openxmlformats.org/officeDocument/2006/relationships" xmlns:a="http://schemas.openxmlformats.org/drawingml/2006/main" r:embed="Rfe64fe1f33824770">
+          <a:blip xmlns:r="http://schemas.openxmlformats.org/officeDocument/2006/relationships" xmlns:a="http://schemas.openxmlformats.org/drawingml/2006/main" r:embed="R03e7ae93ba794ece">
             <a:alphaModFix/>
           </a:blip>
           <a:srcRect xmlns:a="http://schemas.openxmlformats.org/drawingml/2006/main" l="0" t="0" r="0" b="0"/>
@@ -29005,66 +26907,6 @@
               <a:t>powershell -ExecutionPolicy Bypass -File scripts/windows/run.ps1</a:t>
             </a:r>
           </a:p>
-          <a:p xmlns:a="http://schemas.openxmlformats.org/drawingml/2006/main">
-            <a:pPr marL="0" indent="0" algn="l">
-              <a:spcBef>
-                <a:spcPts val="0"/>
-              </a:spcBef>
-              <a:spcAft>
-                <a:spcPts val="0"/>
-              </a:spcAft>
-              <a:buNone/>
-              <a:defRPr sz="1500" b="0">
-                <a:solidFill>
-                  <a:srgbClr val="00E5FF"/>
-                </a:solidFill>
-                <a:latin typeface="Roboto Mono"/>
-                <a:ea typeface="Roboto Mono"/>
-                <a:cs typeface="Roboto Mono"/>
-              </a:defRPr>
-            </a:pPr>
-            <a:r>
-              <a:rPr sz="1500" b="0" i="0">
-                <a:solidFill>
-                  <a:srgbClr val="00E5FF"/>
-                </a:solidFill>
-                <a:latin typeface="Roboto Mono"/>
-                <a:ea typeface="Roboto Mono"/>
-                <a:cs typeface="Roboto Mono"/>
-              </a:rPr>
-              <a:t>powershell -ExecutionPolicy Bypass -File scripts/windows/step-4.ps1</a:t>
-            </a:r>
-          </a:p>
-          <a:p xmlns:a="http://schemas.openxmlformats.org/drawingml/2006/main">
-            <a:pPr marL="0" indent="0" algn="l">
-              <a:spcBef>
-                <a:spcPts val="0"/>
-              </a:spcBef>
-              <a:spcAft>
-                <a:spcPts val="0"/>
-              </a:spcAft>
-              <a:buNone/>
-              <a:defRPr sz="1500" b="0">
-                <a:solidFill>
-                  <a:srgbClr val="00E5FF"/>
-                </a:solidFill>
-                <a:latin typeface="Roboto Mono"/>
-                <a:ea typeface="Roboto Mono"/>
-                <a:cs typeface="Roboto Mono"/>
-              </a:defRPr>
-            </a:pPr>
-            <a:r>
-              <a:rPr sz="1500" b="0" i="0">
-                <a:solidFill>
-                  <a:srgbClr val="00E5FF"/>
-                </a:solidFill>
-                <a:latin typeface="Roboto Mono"/>
-                <a:ea typeface="Roboto Mono"/>
-                <a:cs typeface="Roboto Mono"/>
-              </a:rPr>
-              <a:t>powershell -ExecutionPolicy Bypass -File scripts/windows/run.ps1</a:t>
-            </a:r>
-          </a:p>
         </p:txBody>
       </p:sp>
       <p:sp>
@@ -29712,7 +27554,7 @@
           <p:nvPr/>
         </p:nvPicPr>
         <p:blipFill rotWithShape="1">
-          <a:blip xmlns:r="http://schemas.openxmlformats.org/officeDocument/2006/relationships" xmlns:a="http://schemas.openxmlformats.org/drawingml/2006/main" r:embed="R3ca42eaad31b4411">
+          <a:blip xmlns:r="http://schemas.openxmlformats.org/officeDocument/2006/relationships" xmlns:a="http://schemas.openxmlformats.org/drawingml/2006/main" r:embed="Racc3dc9c3aaa419c">
             <a:alphaModFix/>
           </a:blip>
           <a:srcRect xmlns:a="http://schemas.openxmlformats.org/drawingml/2006/main" l="0" t="0" r="0" b="0"/>
@@ -29740,7 +27582,7 @@
           <p:nvPr/>
         </p:nvPicPr>
         <p:blipFill rotWithShape="1">
-          <a:blip xmlns:r="http://schemas.openxmlformats.org/officeDocument/2006/relationships" xmlns:a="http://schemas.openxmlformats.org/drawingml/2006/main" r:embed="R3ca42eaad31b4411">
+          <a:blip xmlns:r="http://schemas.openxmlformats.org/officeDocument/2006/relationships" xmlns:a="http://schemas.openxmlformats.org/drawingml/2006/main" r:embed="Racc3dc9c3aaa419c">
             <a:alphaModFix/>
           </a:blip>
           <a:srcRect xmlns:a="http://schemas.openxmlformats.org/drawingml/2006/main" l="0" t="0" r="0" b="0"/>
@@ -29768,7 +27610,7 @@
           <p:nvPr/>
         </p:nvPicPr>
         <p:blipFill rotWithShape="1">
-          <a:blip xmlns:r="http://schemas.openxmlformats.org/officeDocument/2006/relationships" xmlns:a="http://schemas.openxmlformats.org/drawingml/2006/main" r:embed="R3ca42eaad31b4411">
+          <a:blip xmlns:r="http://schemas.openxmlformats.org/officeDocument/2006/relationships" xmlns:a="http://schemas.openxmlformats.org/drawingml/2006/main" r:embed="Racc3dc9c3aaa419c">
             <a:alphaModFix/>
           </a:blip>
           <a:srcRect xmlns:a="http://schemas.openxmlformats.org/drawingml/2006/main" l="0" t="0" r="0" b="0"/>
@@ -29796,7 +27638,7 @@
           <p:nvPr/>
         </p:nvPicPr>
         <p:blipFill rotWithShape="1">
-          <a:blip xmlns:r="http://schemas.openxmlformats.org/officeDocument/2006/relationships" xmlns:a="http://schemas.openxmlformats.org/drawingml/2006/main" r:embed="R3ca42eaad31b4411">
+          <a:blip xmlns:r="http://schemas.openxmlformats.org/officeDocument/2006/relationships" xmlns:a="http://schemas.openxmlformats.org/drawingml/2006/main" r:embed="Racc3dc9c3aaa419c">
             <a:alphaModFix/>
           </a:blip>
           <a:srcRect xmlns:a="http://schemas.openxmlformats.org/drawingml/2006/main" l="0" t="0" r="0" b="0"/>
@@ -31887,7 +29729,7 @@
           <p:nvPr/>
         </p:nvPicPr>
         <p:blipFill rotWithShape="1">
-          <a:blip xmlns:r="http://schemas.openxmlformats.org/officeDocument/2006/relationships" xmlns:a="http://schemas.openxmlformats.org/drawingml/2006/main" r:embed="R3b19c54216284fad">
+          <a:blip xmlns:r="http://schemas.openxmlformats.org/officeDocument/2006/relationships" xmlns:a="http://schemas.openxmlformats.org/drawingml/2006/main" r:embed="R0c816cce2fa64cee">
             <a:alphaModFix/>
           </a:blip>
           <a:srcRect xmlns:a="http://schemas.openxmlformats.org/drawingml/2006/main" l="0" t="0" r="0" b="0"/>
@@ -31915,7 +29757,7 @@
           <p:nvPr/>
         </p:nvPicPr>
         <p:blipFill rotWithShape="1">
-          <a:blip xmlns:r="http://schemas.openxmlformats.org/officeDocument/2006/relationships" xmlns:a="http://schemas.openxmlformats.org/drawingml/2006/main" r:embed="R3b19c54216284fad">
+          <a:blip xmlns:r="http://schemas.openxmlformats.org/officeDocument/2006/relationships" xmlns:a="http://schemas.openxmlformats.org/drawingml/2006/main" r:embed="R0c816cce2fa64cee">
             <a:alphaModFix/>
           </a:blip>
           <a:srcRect xmlns:a="http://schemas.openxmlformats.org/drawingml/2006/main" l="0" t="0" r="0" b="0"/>
@@ -31943,7 +29785,7 @@
           <p:nvPr/>
         </p:nvPicPr>
         <p:blipFill rotWithShape="1">
-          <a:blip xmlns:r="http://schemas.openxmlformats.org/officeDocument/2006/relationships" xmlns:a="http://schemas.openxmlformats.org/drawingml/2006/main" r:embed="R3b19c54216284fad">
+          <a:blip xmlns:r="http://schemas.openxmlformats.org/officeDocument/2006/relationships" xmlns:a="http://schemas.openxmlformats.org/drawingml/2006/main" r:embed="R0c816cce2fa64cee">
             <a:alphaModFix/>
           </a:blip>
           <a:srcRect xmlns:a="http://schemas.openxmlformats.org/drawingml/2006/main" l="0" t="0" r="0" b="0"/>
@@ -31971,7 +29813,7 @@
           <p:nvPr/>
         </p:nvPicPr>
         <p:blipFill rotWithShape="1">
-          <a:blip xmlns:r="http://schemas.openxmlformats.org/officeDocument/2006/relationships" xmlns:a="http://schemas.openxmlformats.org/drawingml/2006/main" r:embed="R3b19c54216284fad">
+          <a:blip xmlns:r="http://schemas.openxmlformats.org/officeDocument/2006/relationships" xmlns:a="http://schemas.openxmlformats.org/drawingml/2006/main" r:embed="R0c816cce2fa64cee">
             <a:alphaModFix/>
           </a:blip>
           <a:srcRect xmlns:a="http://schemas.openxmlformats.org/drawingml/2006/main" l="0" t="0" r="0" b="0"/>
@@ -33950,7 +31792,7 @@
           <p:nvPr/>
         </p:nvPicPr>
         <p:blipFill rotWithShape="1">
-          <a:blip xmlns:r="http://schemas.openxmlformats.org/officeDocument/2006/relationships" xmlns:a="http://schemas.openxmlformats.org/drawingml/2006/main" r:embed="Ra3403874bc474d90">
+          <a:blip xmlns:r="http://schemas.openxmlformats.org/officeDocument/2006/relationships" xmlns:a="http://schemas.openxmlformats.org/drawingml/2006/main" r:embed="Re21bca47ee9a4a35">
             <a:alphaModFix/>
           </a:blip>
           <a:srcRect xmlns:a="http://schemas.openxmlformats.org/drawingml/2006/main" l="0" t="0" r="0" b="0"/>
@@ -33978,7 +31820,7 @@
           <p:nvPr/>
         </p:nvPicPr>
         <p:blipFill rotWithShape="1">
-          <a:blip xmlns:r="http://schemas.openxmlformats.org/officeDocument/2006/relationships" xmlns:a="http://schemas.openxmlformats.org/drawingml/2006/main" r:embed="Ra3403874bc474d90">
+          <a:blip xmlns:r="http://schemas.openxmlformats.org/officeDocument/2006/relationships" xmlns:a="http://schemas.openxmlformats.org/drawingml/2006/main" r:embed="Re21bca47ee9a4a35">
             <a:alphaModFix/>
           </a:blip>
           <a:srcRect xmlns:a="http://schemas.openxmlformats.org/drawingml/2006/main" l="0" t="0" r="0" b="0"/>
@@ -34006,7 +31848,7 @@
           <p:nvPr/>
         </p:nvPicPr>
         <p:blipFill rotWithShape="1">
-          <a:blip xmlns:r="http://schemas.openxmlformats.org/officeDocument/2006/relationships" xmlns:a="http://schemas.openxmlformats.org/drawingml/2006/main" r:embed="Ra3403874bc474d90">
+          <a:blip xmlns:r="http://schemas.openxmlformats.org/officeDocument/2006/relationships" xmlns:a="http://schemas.openxmlformats.org/drawingml/2006/main" r:embed="Re21bca47ee9a4a35">
             <a:alphaModFix/>
           </a:blip>
           <a:srcRect xmlns:a="http://schemas.openxmlformats.org/drawingml/2006/main" l="0" t="0" r="0" b="0"/>
@@ -34034,7 +31876,7 @@
           <p:nvPr/>
         </p:nvPicPr>
         <p:blipFill rotWithShape="1">
-          <a:blip xmlns:r="http://schemas.openxmlformats.org/officeDocument/2006/relationships" xmlns:a="http://schemas.openxmlformats.org/drawingml/2006/main" r:embed="Ra3403874bc474d90">
+          <a:blip xmlns:r="http://schemas.openxmlformats.org/officeDocument/2006/relationships" xmlns:a="http://schemas.openxmlformats.org/drawingml/2006/main" r:embed="Re21bca47ee9a4a35">
             <a:alphaModFix/>
           </a:blip>
           <a:srcRect xmlns:a="http://schemas.openxmlformats.org/drawingml/2006/main" l="0" t="0" r="0" b="0"/>

</xml_diff>

<commit_message>
Explain reliable log transfer and scheduler capture configuration
</commit_message>
<xml_diff>
--- a/presentation/falco-libs-intro.pptx
+++ b/presentation/falco-libs-intro.pptx
@@ -2,77 +2,77 @@
 <file path=ppt/presentation.xml><?xml version="1.0" encoding="utf-8"?>
 <p:presentation xmlns:p="http://schemas.openxmlformats.org/presentationml/2006/main" embedTrueTypeFonts="1" saveSubsetFonts="0">
   <p:sldMasterIdLst>
-    <p:sldMasterId xmlns:r="http://schemas.openxmlformats.org/officeDocument/2006/relationships" id="2147483648" r:id="R02603bc921114c3c"/>
-    <p:sldMasterId xmlns:r="http://schemas.openxmlformats.org/officeDocument/2006/relationships" id="2147483661" r:id="Rfc24a86afe904045"/>
+    <p:sldMasterId xmlns:r="http://schemas.openxmlformats.org/officeDocument/2006/relationships" id="2147483648" r:id="R9b78c402ea844052"/>
+    <p:sldMasterId xmlns:r="http://schemas.openxmlformats.org/officeDocument/2006/relationships" id="2147483661" r:id="R76c7a52c35384ad7"/>
   </p:sldMasterIdLst>
   <p:notesMasterIdLst>
-    <p:notesMasterId xmlns:r="http://schemas.openxmlformats.org/officeDocument/2006/relationships" r:id="R9588de6c75f040b3"/>
+    <p:notesMasterId xmlns:r="http://schemas.openxmlformats.org/officeDocument/2006/relationships" r:id="R8682db7f9d7348c8"/>
   </p:notesMasterIdLst>
   <p:sldIdLst>
-    <p:sldId xmlns:r="http://schemas.openxmlformats.org/officeDocument/2006/relationships" id="256" r:id="R5ca17252d80a4190"/>
-    <p:sldId xmlns:r="http://schemas.openxmlformats.org/officeDocument/2006/relationships" id="257" r:id="R8b395fb7335142a4"/>
-    <p:sldId xmlns:r="http://schemas.openxmlformats.org/officeDocument/2006/relationships" id="258" r:id="R4f3f265d0258488e"/>
-    <p:sldId xmlns:r="http://schemas.openxmlformats.org/officeDocument/2006/relationships" id="259" r:id="Rdda57af707cf455c"/>
-    <p:sldId xmlns:r="http://schemas.openxmlformats.org/officeDocument/2006/relationships" id="260" r:id="R2636ecabef8848d4"/>
-    <p:sldId xmlns:r="http://schemas.openxmlformats.org/officeDocument/2006/relationships" id="261" r:id="R62c3b62261e74b6b"/>
-    <p:sldId xmlns:r="http://schemas.openxmlformats.org/officeDocument/2006/relationships" id="262" r:id="R6d4bab84d6d7478c"/>
-    <p:sldId xmlns:r="http://schemas.openxmlformats.org/officeDocument/2006/relationships" id="263" r:id="R327751b082944c7f"/>
-    <p:sldId xmlns:r="http://schemas.openxmlformats.org/officeDocument/2006/relationships" id="264" r:id="Re44e2a088bc6448c"/>
-    <p:sldId xmlns:r="http://schemas.openxmlformats.org/officeDocument/2006/relationships" id="265" r:id="R1f0984ff512d429f"/>
-    <p:sldId xmlns:r="http://schemas.openxmlformats.org/officeDocument/2006/relationships" id="266" r:id="R02cb962b0bb14d7d"/>
-    <p:sldId xmlns:r="http://schemas.openxmlformats.org/officeDocument/2006/relationships" id="267" r:id="R40c93cb600c84cc4"/>
-    <p:sldId xmlns:r="http://schemas.openxmlformats.org/officeDocument/2006/relationships" id="268" r:id="R6de05256f17549cc"/>
+    <p:sldId xmlns:r="http://schemas.openxmlformats.org/officeDocument/2006/relationships" id="256" r:id="Rcbffb133dec641f6"/>
+    <p:sldId xmlns:r="http://schemas.openxmlformats.org/officeDocument/2006/relationships" id="257" r:id="R5df0807cbfd643c1"/>
+    <p:sldId xmlns:r="http://schemas.openxmlformats.org/officeDocument/2006/relationships" id="258" r:id="Re4eb1a06a94d4b77"/>
+    <p:sldId xmlns:r="http://schemas.openxmlformats.org/officeDocument/2006/relationships" id="259" r:id="R525f32ed50484854"/>
+    <p:sldId xmlns:r="http://schemas.openxmlformats.org/officeDocument/2006/relationships" id="260" r:id="R0bd0acb1135f4b61"/>
+    <p:sldId xmlns:r="http://schemas.openxmlformats.org/officeDocument/2006/relationships" id="261" r:id="R3bb8ee3aa1454be8"/>
+    <p:sldId xmlns:r="http://schemas.openxmlformats.org/officeDocument/2006/relationships" id="262" r:id="Rfb6e0931bf9a4c9a"/>
+    <p:sldId xmlns:r="http://schemas.openxmlformats.org/officeDocument/2006/relationships" id="263" r:id="R3a101401daba4270"/>
+    <p:sldId xmlns:r="http://schemas.openxmlformats.org/officeDocument/2006/relationships" id="264" r:id="Rb38a6abee00942bf"/>
+    <p:sldId xmlns:r="http://schemas.openxmlformats.org/officeDocument/2006/relationships" id="265" r:id="R1859891eaab0468d"/>
+    <p:sldId xmlns:r="http://schemas.openxmlformats.org/officeDocument/2006/relationships" id="266" r:id="R46ea7f3b574e4cc7"/>
+    <p:sldId xmlns:r="http://schemas.openxmlformats.org/officeDocument/2006/relationships" id="267" r:id="R4e38c202016447ce"/>
+    <p:sldId xmlns:r="http://schemas.openxmlformats.org/officeDocument/2006/relationships" id="268" r:id="R9da2e883025a4c32"/>
   </p:sldIdLst>
   <p:sldSz cx="9144000" cy="5143500"/>
   <p:notesSz cx="6858000" cy="9144000"/>
   <p:embeddedFontLst>
     <p:embeddedFont>
       <p:font typeface="Roboto Mono Medium"/>
-      <p:regular xmlns:r="http://schemas.openxmlformats.org/officeDocument/2006/relationships" r:id="R735ac5b9e8614570"/>
-      <p:bold xmlns:r="http://schemas.openxmlformats.org/officeDocument/2006/relationships" r:id="R07faeb611bd942d5"/>
-      <p:italic xmlns:r="http://schemas.openxmlformats.org/officeDocument/2006/relationships" r:id="R46aabf39c6e24afe"/>
-      <p:boldItalic xmlns:r="http://schemas.openxmlformats.org/officeDocument/2006/relationships" r:id="Rf565cfe296f14224"/>
+      <p:regular xmlns:r="http://schemas.openxmlformats.org/officeDocument/2006/relationships" r:id="R74232a7d56be4134"/>
+      <p:bold xmlns:r="http://schemas.openxmlformats.org/officeDocument/2006/relationships" r:id="R195d4373febd47fc"/>
+      <p:italic xmlns:r="http://schemas.openxmlformats.org/officeDocument/2006/relationships" r:id="R3183e21bf9734b1c"/>
+      <p:boldItalic xmlns:r="http://schemas.openxmlformats.org/officeDocument/2006/relationships" r:id="R19adb3ffa49141d4"/>
     </p:embeddedFont>
     <p:embeddedFont>
       <p:font typeface="Inter SemiBold"/>
-      <p:regular xmlns:r="http://schemas.openxmlformats.org/officeDocument/2006/relationships" r:id="R95e59af2b9fc4c91"/>
-      <p:bold xmlns:r="http://schemas.openxmlformats.org/officeDocument/2006/relationships" r:id="R663b2b85ead744ac"/>
-      <p:italic xmlns:r="http://schemas.openxmlformats.org/officeDocument/2006/relationships" r:id="R39050b7717134cfc"/>
-      <p:boldItalic xmlns:r="http://schemas.openxmlformats.org/officeDocument/2006/relationships" r:id="R803c7ba72f6c4c29"/>
+      <p:regular xmlns:r="http://schemas.openxmlformats.org/officeDocument/2006/relationships" r:id="Rbdc939423b9b4621"/>
+      <p:bold xmlns:r="http://schemas.openxmlformats.org/officeDocument/2006/relationships" r:id="R994290d77f844a17"/>
+      <p:italic xmlns:r="http://schemas.openxmlformats.org/officeDocument/2006/relationships" r:id="R175fe26055c84c10"/>
+      <p:boldItalic xmlns:r="http://schemas.openxmlformats.org/officeDocument/2006/relationships" r:id="R9ad6bae65609415d"/>
     </p:embeddedFont>
     <p:embeddedFont>
       <p:font typeface="Montserrat Black"/>
-      <p:bold xmlns:r="http://schemas.openxmlformats.org/officeDocument/2006/relationships" r:id="R7b7772220372416a"/>
-      <p:boldItalic xmlns:r="http://schemas.openxmlformats.org/officeDocument/2006/relationships" r:id="Rd13103b156ec4012"/>
+      <p:bold xmlns:r="http://schemas.openxmlformats.org/officeDocument/2006/relationships" r:id="Rb44f88740d0f405d"/>
+      <p:boldItalic xmlns:r="http://schemas.openxmlformats.org/officeDocument/2006/relationships" r:id="Raf3c9f089a324f5c"/>
     </p:embeddedFont>
     <p:embeddedFont>
       <p:font typeface="Montserrat"/>
-      <p:bold xmlns:r="http://schemas.openxmlformats.org/officeDocument/2006/relationships" r:id="R874d104a06c94173"/>
-      <p:boldItalic xmlns:r="http://schemas.openxmlformats.org/officeDocument/2006/relationships" r:id="R81718cbba1e84dbf"/>
+      <p:bold xmlns:r="http://schemas.openxmlformats.org/officeDocument/2006/relationships" r:id="R5f1de78040394698"/>
+      <p:boldItalic xmlns:r="http://schemas.openxmlformats.org/officeDocument/2006/relationships" r:id="R1182f90584284122"/>
     </p:embeddedFont>
     <p:embeddedFont>
       <p:font typeface="Inter"/>
-      <p:regular xmlns:r="http://schemas.openxmlformats.org/officeDocument/2006/relationships" r:id="R0b124bd2e26243c6"/>
-      <p:bold xmlns:r="http://schemas.openxmlformats.org/officeDocument/2006/relationships" r:id="Ra81830457e2048fb"/>
-      <p:italic xmlns:r="http://schemas.openxmlformats.org/officeDocument/2006/relationships" r:id="Re08ce2638dbd4b53"/>
-      <p:boldItalic xmlns:r="http://schemas.openxmlformats.org/officeDocument/2006/relationships" r:id="R0dd6984384324a1e"/>
+      <p:regular xmlns:r="http://schemas.openxmlformats.org/officeDocument/2006/relationships" r:id="R35c75980c271409c"/>
+      <p:bold xmlns:r="http://schemas.openxmlformats.org/officeDocument/2006/relationships" r:id="Rfd9c452d229f4829"/>
+      <p:italic xmlns:r="http://schemas.openxmlformats.org/officeDocument/2006/relationships" r:id="Rb5fede8ef0184488"/>
+      <p:boldItalic xmlns:r="http://schemas.openxmlformats.org/officeDocument/2006/relationships" r:id="Rbc7e108862ac4f1b"/>
     </p:embeddedFont>
     <p:embeddedFont>
       <p:font typeface="Montserrat ExtraBold"/>
-      <p:bold xmlns:r="http://schemas.openxmlformats.org/officeDocument/2006/relationships" r:id="Rb274a54105634cc6"/>
-      <p:boldItalic xmlns:r="http://schemas.openxmlformats.org/officeDocument/2006/relationships" r:id="R8613bdacaa474111"/>
+      <p:bold xmlns:r="http://schemas.openxmlformats.org/officeDocument/2006/relationships" r:id="R3d1b1c93dfd64b36"/>
+      <p:boldItalic xmlns:r="http://schemas.openxmlformats.org/officeDocument/2006/relationships" r:id="R6de24be1097a4983"/>
     </p:embeddedFont>
     <p:embeddedFont>
       <p:font typeface="Roboto Mono"/>
-      <p:bold xmlns:r="http://schemas.openxmlformats.org/officeDocument/2006/relationships" r:id="Re2642b3a8e4b42e0"/>
-      <p:boldItalic xmlns:r="http://schemas.openxmlformats.org/officeDocument/2006/relationships" r:id="R7a80f410841543f5"/>
+      <p:bold xmlns:r="http://schemas.openxmlformats.org/officeDocument/2006/relationships" r:id="R868c5bb8ce164dc2"/>
+      <p:boldItalic xmlns:r="http://schemas.openxmlformats.org/officeDocument/2006/relationships" r:id="R95d9db2a9b3244cb"/>
     </p:embeddedFont>
     <p:embeddedFont>
       <p:font typeface="Inter Medium"/>
-      <p:regular xmlns:r="http://schemas.openxmlformats.org/officeDocument/2006/relationships" r:id="R9ee3b1fae5034bda"/>
-      <p:bold xmlns:r="http://schemas.openxmlformats.org/officeDocument/2006/relationships" r:id="R0ce96bd268e747e5"/>
-      <p:italic xmlns:r="http://schemas.openxmlformats.org/officeDocument/2006/relationships" r:id="R9cf00e7f5ac34684"/>
-      <p:boldItalic xmlns:r="http://schemas.openxmlformats.org/officeDocument/2006/relationships" r:id="Rf151d53fe41c4123"/>
+      <p:regular xmlns:r="http://schemas.openxmlformats.org/officeDocument/2006/relationships" r:id="R454bae5fe90447be"/>
+      <p:bold xmlns:r="http://schemas.openxmlformats.org/officeDocument/2006/relationships" r:id="Rc22b5ee8142e49d5"/>
+      <p:italic xmlns:r="http://schemas.openxmlformats.org/officeDocument/2006/relationships" r:id="R307d4abd90114f1c"/>
+      <p:boldItalic xmlns:r="http://schemas.openxmlformats.org/officeDocument/2006/relationships" r:id="R4594c10dcb314a28"/>
     </p:embeddedFont>
   </p:embeddedFontLst>
 </p:presentation>
@@ -777,7 +777,7 @@
               <a:buNone/>
             </a:pPr>
             <a:r>
-              <a:t>The output is illustrative. The ellipsis omits other events and the final count. Event names, process names, PIDs and counts vary. Step 3 includes all previous additions and works without running steps 1 and 2 first. Step scripts overwrite main.cpp and CMakeLists.txt locally. Run then rebuilds and captures, saving output to logs/latest.log. No filter or success-only condition is applied. Both syscall directions can appear, and background activity is included. The library default capture set is used, so this is not a guarantee of capturing every syscall on the machine.</a:t>
+              <a:t>The output is illustrative. The ellipsis omits other events and the final count. Event names, process names, PIDs and counts vary. Step 3 includes all previous additions and works without running steps 1 and 2 first. Step scripts overwrite main.cpp and CMakeLists.txt locally. Run then rebuilds and captures, saving output to logs/latest.log. No filter or success-only condition is applied. Both syscall directions can appear, and background activity is included. The scheduler-switch tracepoint is disabled. Other capture defaults are unchanged, so this is not a guarantee of capturing every syscall on the machine.</a:t>
             </a:r>
             <a:endParaRPr/>
           </a:p>
@@ -937,7 +937,7 @@
               <a:buNone/>
             </a:pPr>
             <a:r>
-              <a:t>Following along is optional. Demonstrate each stage from the VM. The final collector prints the library event stream with process context. It applies no application filter and uses the default capture set. There are no detection rules, JSON formatting, or production deployment exercises.</a:t>
+              <a:t>Following along is optional. Demonstrate each stage from the VM. The final collector prints the library event stream with process context. It applies no application filter. Scheduler-switch events are disabled at capture because they are not syscalls. There are no detection rules, JSON formatting, or production deployment exercises.</a:t>
             </a:r>
             <a:endParaRPr/>
           </a:p>
@@ -1177,7 +1177,7 @@
               <a:buNone/>
             </a:pPr>
             <a:r>
-              <a:t>No VM shell or second terminal is needed. Run starts or reuses the VM, copies source, rebuilds, and starts the collector. After the collector reports attachment, the runner executes /usr/bin/id inside Ubuntu automatically. It waits for capture to finish, then prints and saves the output. Successful build output is hidden; build failures are displayed. The VM stays available for the next run.</a:t>
+              <a:t>No VM shell or second terminal is needed. Run starts or reuses the VM, copies source, rebuilds, and starts the collector. After the collector reports attachment, the runner executes /usr/bin/id inside Ubuntu automatically. It waits for capture to finish, transfers the complete log with multipass transfer, then prints it locally. This avoids piping bulk output through multipass exec. Successful build output is hidden; build failures are displayed. The VM stays available for the next run.</a:t>
             </a:r>
             <a:endParaRPr/>
           </a:p>
@@ -1417,7 +1417,7 @@
               <a:buNone/>
             </a:pPr>
             <a:r>
-              <a:t>The repository begins without collector source files. Step 1 creates the source directory and both files locally. Run copies them into Ubuntu and rebuilds. The full CMake file also sets C++17 and the output directory. The full main function handles exceptions and prints Attached to the Ubuntu kernel, then Capture stopped. No Enter key or manual editing is needed. The separate run script starts the collector. This initial stage waits ten seconds without draining events; the next stage adds the read loop. Source: https://github.com/falcosecurity/libs/blob/e72873882967cdd86b8753eca09ea3e9f91ccd4a/userspace/libsinsp/sinsp.h</a:t>
+              <a:t>The repository begins without collector source files. Step 1 creates the source directory and both files locally. Run copies them into Ubuntu and rebuilds. The full CMake file also sets C++17 and the output directory. After open_modern_bpf(), the full source calls inspector.mark_ppm_sc_of_interest(PPM_SC_SCHED_SWITCH, false) to disable scheduler-switch capture. The excerpt omits that configuration line for space. Syscall events are still printed without an application filter. The full main function handles exceptions and prints Attached to the Ubuntu kernel, then Capture stopped. No Enter key or manual editing is needed. The separate run script starts the collector. This initial stage waits ten seconds without draining events; the next stage adds the read loop. Source: https://github.com/falcosecurity/libs/blob/e72873882967cdd86b8753eca09ea3e9f91ccd4a/userspace/libsinsp/sinsp.h</a:t>
             </a:r>
             <a:endParaRPr/>
           </a:p>
@@ -5665,18 +5665,18 @@
   </p:cSld>
   <p:clrMap bg1="lt1" tx1="dk1" bg2="dk2" tx2="lt2" accent1="accent1" accent2="accent2" accent3="accent3" accent4="accent4" accent5="accent5" accent6="accent6" hlink="hlink" folHlink="folHlink"/>
   <p:sldLayoutIdLst>
-    <p:sldLayoutId xmlns:r="http://schemas.openxmlformats.org/officeDocument/2006/relationships" id="2147483649" r:id="Raa75d408bcf540f6"/>
-    <p:sldLayoutId xmlns:r="http://schemas.openxmlformats.org/officeDocument/2006/relationships" id="2147483650" r:id="R22cc52514f3b4590"/>
-    <p:sldLayoutId xmlns:r="http://schemas.openxmlformats.org/officeDocument/2006/relationships" id="2147483651" r:id="R8fb56f2b72a54644"/>
-    <p:sldLayoutId xmlns:r="http://schemas.openxmlformats.org/officeDocument/2006/relationships" id="2147483652" r:id="R6eab2bde13ae48f1"/>
-    <p:sldLayoutId xmlns:r="http://schemas.openxmlformats.org/officeDocument/2006/relationships" id="2147483653" r:id="Rd1f85f9a7a544ede"/>
-    <p:sldLayoutId xmlns:r="http://schemas.openxmlformats.org/officeDocument/2006/relationships" id="2147483654" r:id="R1228294d635a4176"/>
-    <p:sldLayoutId xmlns:r="http://schemas.openxmlformats.org/officeDocument/2006/relationships" id="2147483655" r:id="R12b2b73cfceb406f"/>
-    <p:sldLayoutId xmlns:r="http://schemas.openxmlformats.org/officeDocument/2006/relationships" id="2147483656" r:id="Ra1a8892e90f44359"/>
-    <p:sldLayoutId xmlns:r="http://schemas.openxmlformats.org/officeDocument/2006/relationships" id="2147483657" r:id="R685b25fbd72d4b68"/>
-    <p:sldLayoutId xmlns:r="http://schemas.openxmlformats.org/officeDocument/2006/relationships" id="2147483658" r:id="Rd5a40167512144ec"/>
-    <p:sldLayoutId xmlns:r="http://schemas.openxmlformats.org/officeDocument/2006/relationships" id="2147483659" r:id="R13df6fdf9f694995"/>
-    <p:sldLayoutId xmlns:r="http://schemas.openxmlformats.org/officeDocument/2006/relationships" id="2147483660" r:id="R5b031f1f2855446d"/>
+    <p:sldLayoutId xmlns:r="http://schemas.openxmlformats.org/officeDocument/2006/relationships" id="2147483649" r:id="Rcaca4e93cebb42b7"/>
+    <p:sldLayoutId xmlns:r="http://schemas.openxmlformats.org/officeDocument/2006/relationships" id="2147483650" r:id="R176e9955eb054645"/>
+    <p:sldLayoutId xmlns:r="http://schemas.openxmlformats.org/officeDocument/2006/relationships" id="2147483651" r:id="Rc419b05216df494b"/>
+    <p:sldLayoutId xmlns:r="http://schemas.openxmlformats.org/officeDocument/2006/relationships" id="2147483652" r:id="R7e576d70564a4c2d"/>
+    <p:sldLayoutId xmlns:r="http://schemas.openxmlformats.org/officeDocument/2006/relationships" id="2147483653" r:id="R1c53469dae00481f"/>
+    <p:sldLayoutId xmlns:r="http://schemas.openxmlformats.org/officeDocument/2006/relationships" id="2147483654" r:id="Rb3e433d833bb4c5e"/>
+    <p:sldLayoutId xmlns:r="http://schemas.openxmlformats.org/officeDocument/2006/relationships" id="2147483655" r:id="R6408f1700c8d49d4"/>
+    <p:sldLayoutId xmlns:r="http://schemas.openxmlformats.org/officeDocument/2006/relationships" id="2147483656" r:id="R64822d7aef0f48e1"/>
+    <p:sldLayoutId xmlns:r="http://schemas.openxmlformats.org/officeDocument/2006/relationships" id="2147483657" r:id="R80167a4972f142a0"/>
+    <p:sldLayoutId xmlns:r="http://schemas.openxmlformats.org/officeDocument/2006/relationships" id="2147483658" r:id="R77f3af389cff4f48"/>
+    <p:sldLayoutId xmlns:r="http://schemas.openxmlformats.org/officeDocument/2006/relationships" id="2147483659" r:id="R1717a3aecd304111"/>
+    <p:sldLayoutId xmlns:r="http://schemas.openxmlformats.org/officeDocument/2006/relationships" id="2147483660" r:id="R2e26d776eed24277"/>
   </p:sldLayoutIdLst>
   <p:hf sldNum="0" hdr="0" ftr="0" dt="0"/>
   <p:txStyles>
@@ -6361,7 +6361,7 @@
   </p:cSld>
   <p:clrMap bg1="lt1" tx1="dk1" bg2="dk2" tx2="lt2" accent1="accent1" accent2="accent2" accent3="accent3" accent4="accent4" accent5="accent5" accent6="accent6" hlink="hlink" folHlink="folHlink"/>
   <p:sldLayoutIdLst>
-    <p:sldLayoutId xmlns:r="http://schemas.openxmlformats.org/officeDocument/2006/relationships" id="2147483662" r:id="Re1660626561a4976"/>
+    <p:sldLayoutId xmlns:r="http://schemas.openxmlformats.org/officeDocument/2006/relationships" id="2147483662" r:id="Rcd35d6a8a18d43a0"/>
   </p:sldLayoutIdLst>
   <p:hf sldNum="0" hdr="0" ftr="0" dt="0"/>
   <p:txStyles>
@@ -8210,7 +8210,7 @@
           <p:nvPr/>
         </p:nvPicPr>
         <p:blipFill rotWithShape="1">
-          <a:blip xmlns:r="http://schemas.openxmlformats.org/officeDocument/2006/relationships" xmlns:a="http://schemas.openxmlformats.org/drawingml/2006/main" r:embed="R5a1768705d1c45d5">
+          <a:blip xmlns:r="http://schemas.openxmlformats.org/officeDocument/2006/relationships" xmlns:a="http://schemas.openxmlformats.org/drawingml/2006/main" r:embed="R9a8d7a2c13f947a6">
             <a:alphaModFix/>
           </a:blip>
           <a:srcRect xmlns:a="http://schemas.openxmlformats.org/drawingml/2006/main" l="0" t="0" r="0" b="0"/>
@@ -8238,7 +8238,7 @@
           <p:nvPr/>
         </p:nvPicPr>
         <p:blipFill rotWithShape="1">
-          <a:blip xmlns:r="http://schemas.openxmlformats.org/officeDocument/2006/relationships" xmlns:a="http://schemas.openxmlformats.org/drawingml/2006/main" r:embed="R5a1768705d1c45d5">
+          <a:blip xmlns:r="http://schemas.openxmlformats.org/officeDocument/2006/relationships" xmlns:a="http://schemas.openxmlformats.org/drawingml/2006/main" r:embed="R9a8d7a2c13f947a6">
             <a:alphaModFix/>
           </a:blip>
           <a:srcRect xmlns:a="http://schemas.openxmlformats.org/drawingml/2006/main" l="0" t="0" r="0" b="0"/>
@@ -8266,7 +8266,7 @@
           <p:nvPr/>
         </p:nvPicPr>
         <p:blipFill rotWithShape="1">
-          <a:blip xmlns:r="http://schemas.openxmlformats.org/officeDocument/2006/relationships" xmlns:a="http://schemas.openxmlformats.org/drawingml/2006/main" r:embed="R5a1768705d1c45d5">
+          <a:blip xmlns:r="http://schemas.openxmlformats.org/officeDocument/2006/relationships" xmlns:a="http://schemas.openxmlformats.org/drawingml/2006/main" r:embed="R9a8d7a2c13f947a6">
             <a:alphaModFix/>
           </a:blip>
           <a:srcRect xmlns:a="http://schemas.openxmlformats.org/drawingml/2006/main" l="0" t="0" r="0" b="0"/>
@@ -8294,7 +8294,7 @@
           <p:nvPr/>
         </p:nvPicPr>
         <p:blipFill rotWithShape="1">
-          <a:blip xmlns:r="http://schemas.openxmlformats.org/officeDocument/2006/relationships" xmlns:a="http://schemas.openxmlformats.org/drawingml/2006/main" r:embed="R5a1768705d1c45d5">
+          <a:blip xmlns:r="http://schemas.openxmlformats.org/officeDocument/2006/relationships" xmlns:a="http://schemas.openxmlformats.org/drawingml/2006/main" r:embed="R9a8d7a2c13f947a6">
             <a:alphaModFix/>
           </a:blip>
           <a:srcRect xmlns:a="http://schemas.openxmlformats.org/drawingml/2006/main" l="0" t="0" r="0" b="0"/>
@@ -8322,7 +8322,7 @@
           <p:nvPr/>
         </p:nvPicPr>
         <p:blipFill rotWithShape="1">
-          <a:blip xmlns:r="http://schemas.openxmlformats.org/officeDocument/2006/relationships" xmlns:a="http://schemas.openxmlformats.org/drawingml/2006/main" r:embed="R5a1768705d1c45d5">
+          <a:blip xmlns:r="http://schemas.openxmlformats.org/officeDocument/2006/relationships" xmlns:a="http://schemas.openxmlformats.org/drawingml/2006/main" r:embed="R9a8d7a2c13f947a6">
             <a:alphaModFix/>
           </a:blip>
           <a:srcRect xmlns:a="http://schemas.openxmlformats.org/drawingml/2006/main" l="0" t="0" r="0" b="0"/>
@@ -8350,7 +8350,7 @@
           <p:nvPr/>
         </p:nvPicPr>
         <p:blipFill rotWithShape="1">
-          <a:blip xmlns:r="http://schemas.openxmlformats.org/officeDocument/2006/relationships" xmlns:a="http://schemas.openxmlformats.org/drawingml/2006/main" r:embed="R5a1768705d1c45d5">
+          <a:blip xmlns:r="http://schemas.openxmlformats.org/officeDocument/2006/relationships" xmlns:a="http://schemas.openxmlformats.org/drawingml/2006/main" r:embed="R9a8d7a2c13f947a6">
             <a:alphaModFix/>
           </a:blip>
           <a:srcRect xmlns:a="http://schemas.openxmlformats.org/drawingml/2006/main" l="0" t="0" r="0" b="0"/>
@@ -8378,7 +8378,7 @@
           <p:nvPr/>
         </p:nvPicPr>
         <p:blipFill rotWithShape="1">
-          <a:blip xmlns:r="http://schemas.openxmlformats.org/officeDocument/2006/relationships" xmlns:a="http://schemas.openxmlformats.org/drawingml/2006/main" r:embed="R5a1768705d1c45d5">
+          <a:blip xmlns:r="http://schemas.openxmlformats.org/officeDocument/2006/relationships" xmlns:a="http://schemas.openxmlformats.org/drawingml/2006/main" r:embed="R9a8d7a2c13f947a6">
             <a:alphaModFix/>
           </a:blip>
           <a:srcRect xmlns:a="http://schemas.openxmlformats.org/drawingml/2006/main" l="0" t="0" r="0" b="0"/>
@@ -8406,7 +8406,7 @@
           <p:nvPr/>
         </p:nvPicPr>
         <p:blipFill rotWithShape="1">
-          <a:blip xmlns:r="http://schemas.openxmlformats.org/officeDocument/2006/relationships" xmlns:a="http://schemas.openxmlformats.org/drawingml/2006/main" r:embed="R5a1768705d1c45d5">
+          <a:blip xmlns:r="http://schemas.openxmlformats.org/officeDocument/2006/relationships" xmlns:a="http://schemas.openxmlformats.org/drawingml/2006/main" r:embed="R9a8d7a2c13f947a6">
             <a:alphaModFix/>
           </a:blip>
           <a:srcRect xmlns:a="http://schemas.openxmlformats.org/drawingml/2006/main" l="0" t="0" r="0" b="0"/>
@@ -10679,7 +10679,7 @@
           <p:nvPr/>
         </p:nvPicPr>
         <p:blipFill rotWithShape="1">
-          <a:blip xmlns:r="http://schemas.openxmlformats.org/officeDocument/2006/relationships" xmlns:a="http://schemas.openxmlformats.org/drawingml/2006/main" r:embed="R695841d72e2f4a71">
+          <a:blip xmlns:r="http://schemas.openxmlformats.org/officeDocument/2006/relationships" xmlns:a="http://schemas.openxmlformats.org/drawingml/2006/main" r:embed="R0d95b62a237e43fb">
             <a:alphaModFix/>
           </a:blip>
           <a:srcRect xmlns:a="http://schemas.openxmlformats.org/drawingml/2006/main" l="0" t="0" r="0" b="0"/>
@@ -10707,7 +10707,7 @@
           <p:nvPr/>
         </p:nvPicPr>
         <p:blipFill rotWithShape="1">
-          <a:blip xmlns:r="http://schemas.openxmlformats.org/officeDocument/2006/relationships" xmlns:a="http://schemas.openxmlformats.org/drawingml/2006/main" r:embed="R695841d72e2f4a71">
+          <a:blip xmlns:r="http://schemas.openxmlformats.org/officeDocument/2006/relationships" xmlns:a="http://schemas.openxmlformats.org/drawingml/2006/main" r:embed="R0d95b62a237e43fb">
             <a:alphaModFix/>
           </a:blip>
           <a:srcRect xmlns:a="http://schemas.openxmlformats.org/drawingml/2006/main" l="0" t="0" r="0" b="0"/>
@@ -10735,7 +10735,7 @@
           <p:nvPr/>
         </p:nvPicPr>
         <p:blipFill rotWithShape="1">
-          <a:blip xmlns:r="http://schemas.openxmlformats.org/officeDocument/2006/relationships" xmlns:a="http://schemas.openxmlformats.org/drawingml/2006/main" r:embed="R695841d72e2f4a71">
+          <a:blip xmlns:r="http://schemas.openxmlformats.org/officeDocument/2006/relationships" xmlns:a="http://schemas.openxmlformats.org/drawingml/2006/main" r:embed="R0d95b62a237e43fb">
             <a:alphaModFix/>
           </a:blip>
           <a:srcRect xmlns:a="http://schemas.openxmlformats.org/drawingml/2006/main" l="0" t="0" r="0" b="0"/>
@@ -10763,7 +10763,7 @@
           <p:nvPr/>
         </p:nvPicPr>
         <p:blipFill rotWithShape="1">
-          <a:blip xmlns:r="http://schemas.openxmlformats.org/officeDocument/2006/relationships" xmlns:a="http://schemas.openxmlformats.org/drawingml/2006/main" r:embed="R695841d72e2f4a71">
+          <a:blip xmlns:r="http://schemas.openxmlformats.org/officeDocument/2006/relationships" xmlns:a="http://schemas.openxmlformats.org/drawingml/2006/main" r:embed="R0d95b62a237e43fb">
             <a:alphaModFix/>
           </a:blip>
           <a:srcRect xmlns:a="http://schemas.openxmlformats.org/drawingml/2006/main" l="0" t="0" r="0" b="0"/>
@@ -12712,7 +12712,7 @@
           <p:nvPr/>
         </p:nvPicPr>
         <p:blipFill rotWithShape="1">
-          <a:blip xmlns:r="http://schemas.openxmlformats.org/officeDocument/2006/relationships" xmlns:a="http://schemas.openxmlformats.org/drawingml/2006/main" r:embed="R9cd95e0aa3154383">
+          <a:blip xmlns:r="http://schemas.openxmlformats.org/officeDocument/2006/relationships" xmlns:a="http://schemas.openxmlformats.org/drawingml/2006/main" r:embed="Rd5e056ec871c4ed4">
             <a:alphaModFix/>
           </a:blip>
           <a:srcRect xmlns:a="http://schemas.openxmlformats.org/drawingml/2006/main" l="0" t="0" r="0" b="0"/>
@@ -12740,7 +12740,7 @@
           <p:nvPr/>
         </p:nvPicPr>
         <p:blipFill rotWithShape="1">
-          <a:blip xmlns:r="http://schemas.openxmlformats.org/officeDocument/2006/relationships" xmlns:a="http://schemas.openxmlformats.org/drawingml/2006/main" r:embed="R9cd95e0aa3154383">
+          <a:blip xmlns:r="http://schemas.openxmlformats.org/officeDocument/2006/relationships" xmlns:a="http://schemas.openxmlformats.org/drawingml/2006/main" r:embed="Rd5e056ec871c4ed4">
             <a:alphaModFix/>
           </a:blip>
           <a:srcRect xmlns:a="http://schemas.openxmlformats.org/drawingml/2006/main" l="0" t="0" r="0" b="0"/>
@@ -12768,7 +12768,7 @@
           <p:nvPr/>
         </p:nvPicPr>
         <p:blipFill rotWithShape="1">
-          <a:blip xmlns:r="http://schemas.openxmlformats.org/officeDocument/2006/relationships" xmlns:a="http://schemas.openxmlformats.org/drawingml/2006/main" r:embed="R9cd95e0aa3154383">
+          <a:blip xmlns:r="http://schemas.openxmlformats.org/officeDocument/2006/relationships" xmlns:a="http://schemas.openxmlformats.org/drawingml/2006/main" r:embed="Rd5e056ec871c4ed4">
             <a:alphaModFix/>
           </a:blip>
           <a:srcRect xmlns:a="http://schemas.openxmlformats.org/drawingml/2006/main" l="0" t="0" r="0" b="0"/>
@@ -12796,7 +12796,7 @@
           <p:nvPr/>
         </p:nvPicPr>
         <p:blipFill rotWithShape="1">
-          <a:blip xmlns:r="http://schemas.openxmlformats.org/officeDocument/2006/relationships" xmlns:a="http://schemas.openxmlformats.org/drawingml/2006/main" r:embed="R9cd95e0aa3154383">
+          <a:blip xmlns:r="http://schemas.openxmlformats.org/officeDocument/2006/relationships" xmlns:a="http://schemas.openxmlformats.org/drawingml/2006/main" r:embed="Rd5e056ec871c4ed4">
             <a:alphaModFix/>
           </a:blip>
           <a:srcRect xmlns:a="http://schemas.openxmlformats.org/drawingml/2006/main" l="0" t="0" r="0" b="0"/>
@@ -14819,7 +14819,7 @@
           <p:nvPr/>
         </p:nvPicPr>
         <p:blipFill rotWithShape="1">
-          <a:blip xmlns:r="http://schemas.openxmlformats.org/officeDocument/2006/relationships" xmlns:a="http://schemas.openxmlformats.org/drawingml/2006/main" r:embed="R8ed655c8035b4750">
+          <a:blip xmlns:r="http://schemas.openxmlformats.org/officeDocument/2006/relationships" xmlns:a="http://schemas.openxmlformats.org/drawingml/2006/main" r:embed="R6a4a0b2788ea4010">
             <a:alphaModFix/>
           </a:blip>
           <a:srcRect xmlns:a="http://schemas.openxmlformats.org/drawingml/2006/main" l="0" t="0" r="0" b="0"/>
@@ -14847,7 +14847,7 @@
           <p:nvPr/>
         </p:nvPicPr>
         <p:blipFill rotWithShape="1">
-          <a:blip xmlns:r="http://schemas.openxmlformats.org/officeDocument/2006/relationships" xmlns:a="http://schemas.openxmlformats.org/drawingml/2006/main" r:embed="R8ed655c8035b4750">
+          <a:blip xmlns:r="http://schemas.openxmlformats.org/officeDocument/2006/relationships" xmlns:a="http://schemas.openxmlformats.org/drawingml/2006/main" r:embed="R6a4a0b2788ea4010">
             <a:alphaModFix/>
           </a:blip>
           <a:srcRect xmlns:a="http://schemas.openxmlformats.org/drawingml/2006/main" l="0" t="0" r="0" b="0"/>
@@ -14875,7 +14875,7 @@
           <p:nvPr/>
         </p:nvPicPr>
         <p:blipFill rotWithShape="1">
-          <a:blip xmlns:r="http://schemas.openxmlformats.org/officeDocument/2006/relationships" xmlns:a="http://schemas.openxmlformats.org/drawingml/2006/main" r:embed="R8ed655c8035b4750">
+          <a:blip xmlns:r="http://schemas.openxmlformats.org/officeDocument/2006/relationships" xmlns:a="http://schemas.openxmlformats.org/drawingml/2006/main" r:embed="R6a4a0b2788ea4010">
             <a:alphaModFix/>
           </a:blip>
           <a:srcRect xmlns:a="http://schemas.openxmlformats.org/drawingml/2006/main" l="0" t="0" r="0" b="0"/>
@@ -14903,7 +14903,7 @@
           <p:nvPr/>
         </p:nvPicPr>
         <p:blipFill rotWithShape="1">
-          <a:blip xmlns:r="http://schemas.openxmlformats.org/officeDocument/2006/relationships" xmlns:a="http://schemas.openxmlformats.org/drawingml/2006/main" r:embed="R8ed655c8035b4750">
+          <a:blip xmlns:r="http://schemas.openxmlformats.org/officeDocument/2006/relationships" xmlns:a="http://schemas.openxmlformats.org/drawingml/2006/main" r:embed="R6a4a0b2788ea4010">
             <a:alphaModFix/>
           </a:blip>
           <a:srcRect xmlns:a="http://schemas.openxmlformats.org/drawingml/2006/main" l="0" t="0" r="0" b="0"/>
@@ -16724,7 +16724,7 @@
           <p:nvPr/>
         </p:nvPicPr>
         <p:blipFill rotWithShape="1">
-          <a:blip xmlns:r="http://schemas.openxmlformats.org/officeDocument/2006/relationships" xmlns:a="http://schemas.openxmlformats.org/drawingml/2006/main" r:embed="Rdab58bcbee054095">
+          <a:blip xmlns:r="http://schemas.openxmlformats.org/officeDocument/2006/relationships" xmlns:a="http://schemas.openxmlformats.org/drawingml/2006/main" r:embed="R82bb0430659e4d22">
             <a:alphaModFix/>
           </a:blip>
           <a:srcRect xmlns:a="http://schemas.openxmlformats.org/drawingml/2006/main" l="0" t="0" r="0" b="0"/>
@@ -16752,7 +16752,7 @@
           <p:nvPr/>
         </p:nvPicPr>
         <p:blipFill rotWithShape="1">
-          <a:blip xmlns:r="http://schemas.openxmlformats.org/officeDocument/2006/relationships" xmlns:a="http://schemas.openxmlformats.org/drawingml/2006/main" r:embed="Rdab58bcbee054095">
+          <a:blip xmlns:r="http://schemas.openxmlformats.org/officeDocument/2006/relationships" xmlns:a="http://schemas.openxmlformats.org/drawingml/2006/main" r:embed="R82bb0430659e4d22">
             <a:alphaModFix/>
           </a:blip>
           <a:srcRect xmlns:a="http://schemas.openxmlformats.org/drawingml/2006/main" l="0" t="0" r="0" b="0"/>
@@ -16780,7 +16780,7 @@
           <p:nvPr/>
         </p:nvPicPr>
         <p:blipFill rotWithShape="1">
-          <a:blip xmlns:r="http://schemas.openxmlformats.org/officeDocument/2006/relationships" xmlns:a="http://schemas.openxmlformats.org/drawingml/2006/main" r:embed="Rdab58bcbee054095">
+          <a:blip xmlns:r="http://schemas.openxmlformats.org/officeDocument/2006/relationships" xmlns:a="http://schemas.openxmlformats.org/drawingml/2006/main" r:embed="R82bb0430659e4d22">
             <a:alphaModFix/>
           </a:blip>
           <a:srcRect xmlns:a="http://schemas.openxmlformats.org/drawingml/2006/main" l="0" t="0" r="0" b="0"/>
@@ -16808,7 +16808,7 @@
           <p:nvPr/>
         </p:nvPicPr>
         <p:blipFill rotWithShape="1">
-          <a:blip xmlns:r="http://schemas.openxmlformats.org/officeDocument/2006/relationships" xmlns:a="http://schemas.openxmlformats.org/drawingml/2006/main" r:embed="Rdab58bcbee054095">
+          <a:blip xmlns:r="http://schemas.openxmlformats.org/officeDocument/2006/relationships" xmlns:a="http://schemas.openxmlformats.org/drawingml/2006/main" r:embed="R82bb0430659e4d22">
             <a:alphaModFix/>
           </a:blip>
           <a:srcRect xmlns:a="http://schemas.openxmlformats.org/drawingml/2006/main" l="0" t="0" r="0" b="0"/>
@@ -18651,7 +18651,7 @@
           <p:nvPr/>
         </p:nvPicPr>
         <p:blipFill rotWithShape="1">
-          <a:blip xmlns:r="http://schemas.openxmlformats.org/officeDocument/2006/relationships" xmlns:a="http://schemas.openxmlformats.org/drawingml/2006/main" r:embed="R367a6dc109264d5f">
+          <a:blip xmlns:r="http://schemas.openxmlformats.org/officeDocument/2006/relationships" xmlns:a="http://schemas.openxmlformats.org/drawingml/2006/main" r:embed="R4e28017d02b14988">
             <a:alphaModFix/>
           </a:blip>
           <a:srcRect xmlns:a="http://schemas.openxmlformats.org/drawingml/2006/main" l="0" t="0" r="0" b="0"/>
@@ -18679,7 +18679,7 @@
           <p:nvPr/>
         </p:nvPicPr>
         <p:blipFill rotWithShape="1">
-          <a:blip xmlns:r="http://schemas.openxmlformats.org/officeDocument/2006/relationships" xmlns:a="http://schemas.openxmlformats.org/drawingml/2006/main" r:embed="R367a6dc109264d5f">
+          <a:blip xmlns:r="http://schemas.openxmlformats.org/officeDocument/2006/relationships" xmlns:a="http://schemas.openxmlformats.org/drawingml/2006/main" r:embed="R4e28017d02b14988">
             <a:alphaModFix/>
           </a:blip>
           <a:srcRect xmlns:a="http://schemas.openxmlformats.org/drawingml/2006/main" l="0" t="0" r="0" b="0"/>
@@ -18707,7 +18707,7 @@
           <p:nvPr/>
         </p:nvPicPr>
         <p:blipFill rotWithShape="1">
-          <a:blip xmlns:r="http://schemas.openxmlformats.org/officeDocument/2006/relationships" xmlns:a="http://schemas.openxmlformats.org/drawingml/2006/main" r:embed="R367a6dc109264d5f">
+          <a:blip xmlns:r="http://schemas.openxmlformats.org/officeDocument/2006/relationships" xmlns:a="http://schemas.openxmlformats.org/drawingml/2006/main" r:embed="R4e28017d02b14988">
             <a:alphaModFix/>
           </a:blip>
           <a:srcRect xmlns:a="http://schemas.openxmlformats.org/drawingml/2006/main" l="0" t="0" r="0" b="0"/>
@@ -18735,7 +18735,7 @@
           <p:nvPr/>
         </p:nvPicPr>
         <p:blipFill rotWithShape="1">
-          <a:blip xmlns:r="http://schemas.openxmlformats.org/officeDocument/2006/relationships" xmlns:a="http://schemas.openxmlformats.org/drawingml/2006/main" r:embed="R367a6dc109264d5f">
+          <a:blip xmlns:r="http://schemas.openxmlformats.org/officeDocument/2006/relationships" xmlns:a="http://schemas.openxmlformats.org/drawingml/2006/main" r:embed="R4e28017d02b14988">
             <a:alphaModFix/>
           </a:blip>
           <a:srcRect xmlns:a="http://schemas.openxmlformats.org/drawingml/2006/main" l="0" t="0" r="0" b="0"/>
@@ -20348,7 +20348,7 @@
           <p:nvPr/>
         </p:nvPicPr>
         <p:blipFill rotWithShape="1">
-          <a:blip xmlns:r="http://schemas.openxmlformats.org/officeDocument/2006/relationships" xmlns:a="http://schemas.openxmlformats.org/drawingml/2006/main" r:embed="R3e93fa48acae4a62">
+          <a:blip xmlns:r="http://schemas.openxmlformats.org/officeDocument/2006/relationships" xmlns:a="http://schemas.openxmlformats.org/drawingml/2006/main" r:embed="Rcf039cb733d544b6">
             <a:alphaModFix/>
           </a:blip>
           <a:srcRect xmlns:a="http://schemas.openxmlformats.org/drawingml/2006/main" l="0" t="0" r="0" b="0"/>
@@ -20376,7 +20376,7 @@
           <p:nvPr/>
         </p:nvPicPr>
         <p:blipFill rotWithShape="1">
-          <a:blip xmlns:r="http://schemas.openxmlformats.org/officeDocument/2006/relationships" xmlns:a="http://schemas.openxmlformats.org/drawingml/2006/main" r:embed="R3e93fa48acae4a62">
+          <a:blip xmlns:r="http://schemas.openxmlformats.org/officeDocument/2006/relationships" xmlns:a="http://schemas.openxmlformats.org/drawingml/2006/main" r:embed="Rcf039cb733d544b6">
             <a:alphaModFix/>
           </a:blip>
           <a:srcRect xmlns:a="http://schemas.openxmlformats.org/drawingml/2006/main" l="0" t="0" r="0" b="0"/>
@@ -20404,7 +20404,7 @@
           <p:nvPr/>
         </p:nvPicPr>
         <p:blipFill rotWithShape="1">
-          <a:blip xmlns:r="http://schemas.openxmlformats.org/officeDocument/2006/relationships" xmlns:a="http://schemas.openxmlformats.org/drawingml/2006/main" r:embed="R3e93fa48acae4a62">
+          <a:blip xmlns:r="http://schemas.openxmlformats.org/officeDocument/2006/relationships" xmlns:a="http://schemas.openxmlformats.org/drawingml/2006/main" r:embed="Rcf039cb733d544b6">
             <a:alphaModFix/>
           </a:blip>
           <a:srcRect xmlns:a="http://schemas.openxmlformats.org/drawingml/2006/main" l="0" t="0" r="0" b="0"/>
@@ -20432,7 +20432,7 @@
           <p:nvPr/>
         </p:nvPicPr>
         <p:blipFill rotWithShape="1">
-          <a:blip xmlns:r="http://schemas.openxmlformats.org/officeDocument/2006/relationships" xmlns:a="http://schemas.openxmlformats.org/drawingml/2006/main" r:embed="R3e93fa48acae4a62">
+          <a:blip xmlns:r="http://schemas.openxmlformats.org/officeDocument/2006/relationships" xmlns:a="http://schemas.openxmlformats.org/drawingml/2006/main" r:embed="Rcf039cb733d544b6">
             <a:alphaModFix/>
           </a:blip>
           <a:srcRect xmlns:a="http://schemas.openxmlformats.org/drawingml/2006/main" l="0" t="0" r="0" b="0"/>
@@ -22045,7 +22045,7 @@
           <p:nvPr/>
         </p:nvPicPr>
         <p:blipFill rotWithShape="1">
-          <a:blip xmlns:r="http://schemas.openxmlformats.org/officeDocument/2006/relationships" xmlns:a="http://schemas.openxmlformats.org/drawingml/2006/main" r:embed="R18845f38a6d343e8">
+          <a:blip xmlns:r="http://schemas.openxmlformats.org/officeDocument/2006/relationships" xmlns:a="http://schemas.openxmlformats.org/drawingml/2006/main" r:embed="R6baa8eb715204693">
             <a:alphaModFix/>
           </a:blip>
           <a:srcRect xmlns:a="http://schemas.openxmlformats.org/drawingml/2006/main" l="0" t="0" r="0" b="0"/>
@@ -22073,7 +22073,7 @@
           <p:nvPr/>
         </p:nvPicPr>
         <p:blipFill rotWithShape="1">
-          <a:blip xmlns:r="http://schemas.openxmlformats.org/officeDocument/2006/relationships" xmlns:a="http://schemas.openxmlformats.org/drawingml/2006/main" r:embed="R18845f38a6d343e8">
+          <a:blip xmlns:r="http://schemas.openxmlformats.org/officeDocument/2006/relationships" xmlns:a="http://schemas.openxmlformats.org/drawingml/2006/main" r:embed="R6baa8eb715204693">
             <a:alphaModFix/>
           </a:blip>
           <a:srcRect xmlns:a="http://schemas.openxmlformats.org/drawingml/2006/main" l="0" t="0" r="0" b="0"/>
@@ -22101,7 +22101,7 @@
           <p:nvPr/>
         </p:nvPicPr>
         <p:blipFill rotWithShape="1">
-          <a:blip xmlns:r="http://schemas.openxmlformats.org/officeDocument/2006/relationships" xmlns:a="http://schemas.openxmlformats.org/drawingml/2006/main" r:embed="R18845f38a6d343e8">
+          <a:blip xmlns:r="http://schemas.openxmlformats.org/officeDocument/2006/relationships" xmlns:a="http://schemas.openxmlformats.org/drawingml/2006/main" r:embed="R6baa8eb715204693">
             <a:alphaModFix/>
           </a:blip>
           <a:srcRect xmlns:a="http://schemas.openxmlformats.org/drawingml/2006/main" l="0" t="0" r="0" b="0"/>
@@ -22129,7 +22129,7 @@
           <p:nvPr/>
         </p:nvPicPr>
         <p:blipFill rotWithShape="1">
-          <a:blip xmlns:r="http://schemas.openxmlformats.org/officeDocument/2006/relationships" xmlns:a="http://schemas.openxmlformats.org/drawingml/2006/main" r:embed="R18845f38a6d343e8">
+          <a:blip xmlns:r="http://schemas.openxmlformats.org/officeDocument/2006/relationships" xmlns:a="http://schemas.openxmlformats.org/drawingml/2006/main" r:embed="R6baa8eb715204693">
             <a:alphaModFix/>
           </a:blip>
           <a:srcRect xmlns:a="http://schemas.openxmlformats.org/drawingml/2006/main" l="0" t="0" r="0" b="0"/>
@@ -24024,7 +24024,7 @@
           <p:nvPr/>
         </p:nvPicPr>
         <p:blipFill rotWithShape="1">
-          <a:blip xmlns:r="http://schemas.openxmlformats.org/officeDocument/2006/relationships" xmlns:a="http://schemas.openxmlformats.org/drawingml/2006/main" r:embed="R0b431705fa464337">
+          <a:blip xmlns:r="http://schemas.openxmlformats.org/officeDocument/2006/relationships" xmlns:a="http://schemas.openxmlformats.org/drawingml/2006/main" r:embed="R81e377c9c65b45ea">
             <a:alphaModFix/>
           </a:blip>
           <a:srcRect xmlns:a="http://schemas.openxmlformats.org/drawingml/2006/main" l="0" t="0" r="0" b="0"/>
@@ -24052,7 +24052,7 @@
           <p:nvPr/>
         </p:nvPicPr>
         <p:blipFill rotWithShape="1">
-          <a:blip xmlns:r="http://schemas.openxmlformats.org/officeDocument/2006/relationships" xmlns:a="http://schemas.openxmlformats.org/drawingml/2006/main" r:embed="R0b431705fa464337">
+          <a:blip xmlns:r="http://schemas.openxmlformats.org/officeDocument/2006/relationships" xmlns:a="http://schemas.openxmlformats.org/drawingml/2006/main" r:embed="R81e377c9c65b45ea">
             <a:alphaModFix/>
           </a:blip>
           <a:srcRect xmlns:a="http://schemas.openxmlformats.org/drawingml/2006/main" l="0" t="0" r="0" b="0"/>
@@ -24080,7 +24080,7 @@
           <p:nvPr/>
         </p:nvPicPr>
         <p:blipFill rotWithShape="1">
-          <a:blip xmlns:r="http://schemas.openxmlformats.org/officeDocument/2006/relationships" xmlns:a="http://schemas.openxmlformats.org/drawingml/2006/main" r:embed="R0b431705fa464337">
+          <a:blip xmlns:r="http://schemas.openxmlformats.org/officeDocument/2006/relationships" xmlns:a="http://schemas.openxmlformats.org/drawingml/2006/main" r:embed="R81e377c9c65b45ea">
             <a:alphaModFix/>
           </a:blip>
           <a:srcRect xmlns:a="http://schemas.openxmlformats.org/drawingml/2006/main" l="0" t="0" r="0" b="0"/>
@@ -24108,7 +24108,7 @@
           <p:nvPr/>
         </p:nvPicPr>
         <p:blipFill rotWithShape="1">
-          <a:blip xmlns:r="http://schemas.openxmlformats.org/officeDocument/2006/relationships" xmlns:a="http://schemas.openxmlformats.org/drawingml/2006/main" r:embed="R0b431705fa464337">
+          <a:blip xmlns:r="http://schemas.openxmlformats.org/officeDocument/2006/relationships" xmlns:a="http://schemas.openxmlformats.org/drawingml/2006/main" r:embed="R81e377c9c65b45ea">
             <a:alphaModFix/>
           </a:blip>
           <a:srcRect xmlns:a="http://schemas.openxmlformats.org/drawingml/2006/main" l="0" t="0" r="0" b="0"/>
@@ -25789,7 +25789,7 @@
           <p:nvPr/>
         </p:nvPicPr>
         <p:blipFill rotWithShape="1">
-          <a:blip xmlns:r="http://schemas.openxmlformats.org/officeDocument/2006/relationships" xmlns:a="http://schemas.openxmlformats.org/drawingml/2006/main" r:embed="R03e7ae93ba794ece">
+          <a:blip xmlns:r="http://schemas.openxmlformats.org/officeDocument/2006/relationships" xmlns:a="http://schemas.openxmlformats.org/drawingml/2006/main" r:embed="R22dedbc53ce24927">
             <a:alphaModFix/>
           </a:blip>
           <a:srcRect xmlns:a="http://schemas.openxmlformats.org/drawingml/2006/main" l="0" t="0" r="0" b="0"/>
@@ -25817,7 +25817,7 @@
           <p:nvPr/>
         </p:nvPicPr>
         <p:blipFill rotWithShape="1">
-          <a:blip xmlns:r="http://schemas.openxmlformats.org/officeDocument/2006/relationships" xmlns:a="http://schemas.openxmlformats.org/drawingml/2006/main" r:embed="R03e7ae93ba794ece">
+          <a:blip xmlns:r="http://schemas.openxmlformats.org/officeDocument/2006/relationships" xmlns:a="http://schemas.openxmlformats.org/drawingml/2006/main" r:embed="R22dedbc53ce24927">
             <a:alphaModFix/>
           </a:blip>
           <a:srcRect xmlns:a="http://schemas.openxmlformats.org/drawingml/2006/main" l="0" t="0" r="0" b="0"/>
@@ -25845,7 +25845,7 @@
           <p:nvPr/>
         </p:nvPicPr>
         <p:blipFill rotWithShape="1">
-          <a:blip xmlns:r="http://schemas.openxmlformats.org/officeDocument/2006/relationships" xmlns:a="http://schemas.openxmlformats.org/drawingml/2006/main" r:embed="R03e7ae93ba794ece">
+          <a:blip xmlns:r="http://schemas.openxmlformats.org/officeDocument/2006/relationships" xmlns:a="http://schemas.openxmlformats.org/drawingml/2006/main" r:embed="R22dedbc53ce24927">
             <a:alphaModFix/>
           </a:blip>
           <a:srcRect xmlns:a="http://schemas.openxmlformats.org/drawingml/2006/main" l="0" t="0" r="0" b="0"/>
@@ -25873,7 +25873,7 @@
           <p:nvPr/>
         </p:nvPicPr>
         <p:blipFill rotWithShape="1">
-          <a:blip xmlns:r="http://schemas.openxmlformats.org/officeDocument/2006/relationships" xmlns:a="http://schemas.openxmlformats.org/drawingml/2006/main" r:embed="R03e7ae93ba794ece">
+          <a:blip xmlns:r="http://schemas.openxmlformats.org/officeDocument/2006/relationships" xmlns:a="http://schemas.openxmlformats.org/drawingml/2006/main" r:embed="R22dedbc53ce24927">
             <a:alphaModFix/>
           </a:blip>
           <a:srcRect xmlns:a="http://schemas.openxmlformats.org/drawingml/2006/main" l="0" t="0" r="0" b="0"/>
@@ -27554,7 +27554,7 @@
           <p:nvPr/>
         </p:nvPicPr>
         <p:blipFill rotWithShape="1">
-          <a:blip xmlns:r="http://schemas.openxmlformats.org/officeDocument/2006/relationships" xmlns:a="http://schemas.openxmlformats.org/drawingml/2006/main" r:embed="Racc3dc9c3aaa419c">
+          <a:blip xmlns:r="http://schemas.openxmlformats.org/officeDocument/2006/relationships" xmlns:a="http://schemas.openxmlformats.org/drawingml/2006/main" r:embed="R91e45b17df67497f">
             <a:alphaModFix/>
           </a:blip>
           <a:srcRect xmlns:a="http://schemas.openxmlformats.org/drawingml/2006/main" l="0" t="0" r="0" b="0"/>
@@ -27582,7 +27582,7 @@
           <p:nvPr/>
         </p:nvPicPr>
         <p:blipFill rotWithShape="1">
-          <a:blip xmlns:r="http://schemas.openxmlformats.org/officeDocument/2006/relationships" xmlns:a="http://schemas.openxmlformats.org/drawingml/2006/main" r:embed="Racc3dc9c3aaa419c">
+          <a:blip xmlns:r="http://schemas.openxmlformats.org/officeDocument/2006/relationships" xmlns:a="http://schemas.openxmlformats.org/drawingml/2006/main" r:embed="R91e45b17df67497f">
             <a:alphaModFix/>
           </a:blip>
           <a:srcRect xmlns:a="http://schemas.openxmlformats.org/drawingml/2006/main" l="0" t="0" r="0" b="0"/>
@@ -27610,7 +27610,7 @@
           <p:nvPr/>
         </p:nvPicPr>
         <p:blipFill rotWithShape="1">
-          <a:blip xmlns:r="http://schemas.openxmlformats.org/officeDocument/2006/relationships" xmlns:a="http://schemas.openxmlformats.org/drawingml/2006/main" r:embed="Racc3dc9c3aaa419c">
+          <a:blip xmlns:r="http://schemas.openxmlformats.org/officeDocument/2006/relationships" xmlns:a="http://schemas.openxmlformats.org/drawingml/2006/main" r:embed="R91e45b17df67497f">
             <a:alphaModFix/>
           </a:blip>
           <a:srcRect xmlns:a="http://schemas.openxmlformats.org/drawingml/2006/main" l="0" t="0" r="0" b="0"/>
@@ -27638,7 +27638,7 @@
           <p:nvPr/>
         </p:nvPicPr>
         <p:blipFill rotWithShape="1">
-          <a:blip xmlns:r="http://schemas.openxmlformats.org/officeDocument/2006/relationships" xmlns:a="http://schemas.openxmlformats.org/drawingml/2006/main" r:embed="Racc3dc9c3aaa419c">
+          <a:blip xmlns:r="http://schemas.openxmlformats.org/officeDocument/2006/relationships" xmlns:a="http://schemas.openxmlformats.org/drawingml/2006/main" r:embed="R91e45b17df67497f">
             <a:alphaModFix/>
           </a:blip>
           <a:srcRect xmlns:a="http://schemas.openxmlformats.org/drawingml/2006/main" l="0" t="0" r="0" b="0"/>
@@ -29729,7 +29729,7 @@
           <p:nvPr/>
         </p:nvPicPr>
         <p:blipFill rotWithShape="1">
-          <a:blip xmlns:r="http://schemas.openxmlformats.org/officeDocument/2006/relationships" xmlns:a="http://schemas.openxmlformats.org/drawingml/2006/main" r:embed="R0c816cce2fa64cee">
+          <a:blip xmlns:r="http://schemas.openxmlformats.org/officeDocument/2006/relationships" xmlns:a="http://schemas.openxmlformats.org/drawingml/2006/main" r:embed="R337952a2c23e40ed">
             <a:alphaModFix/>
           </a:blip>
           <a:srcRect xmlns:a="http://schemas.openxmlformats.org/drawingml/2006/main" l="0" t="0" r="0" b="0"/>
@@ -29757,7 +29757,7 @@
           <p:nvPr/>
         </p:nvPicPr>
         <p:blipFill rotWithShape="1">
-          <a:blip xmlns:r="http://schemas.openxmlformats.org/officeDocument/2006/relationships" xmlns:a="http://schemas.openxmlformats.org/drawingml/2006/main" r:embed="R0c816cce2fa64cee">
+          <a:blip xmlns:r="http://schemas.openxmlformats.org/officeDocument/2006/relationships" xmlns:a="http://schemas.openxmlformats.org/drawingml/2006/main" r:embed="R337952a2c23e40ed">
             <a:alphaModFix/>
           </a:blip>
           <a:srcRect xmlns:a="http://schemas.openxmlformats.org/drawingml/2006/main" l="0" t="0" r="0" b="0"/>
@@ -29785,7 +29785,7 @@
           <p:nvPr/>
         </p:nvPicPr>
         <p:blipFill rotWithShape="1">
-          <a:blip xmlns:r="http://schemas.openxmlformats.org/officeDocument/2006/relationships" xmlns:a="http://schemas.openxmlformats.org/drawingml/2006/main" r:embed="R0c816cce2fa64cee">
+          <a:blip xmlns:r="http://schemas.openxmlformats.org/officeDocument/2006/relationships" xmlns:a="http://schemas.openxmlformats.org/drawingml/2006/main" r:embed="R337952a2c23e40ed">
             <a:alphaModFix/>
           </a:blip>
           <a:srcRect xmlns:a="http://schemas.openxmlformats.org/drawingml/2006/main" l="0" t="0" r="0" b="0"/>
@@ -29813,7 +29813,7 @@
           <p:nvPr/>
         </p:nvPicPr>
         <p:blipFill rotWithShape="1">
-          <a:blip xmlns:r="http://schemas.openxmlformats.org/officeDocument/2006/relationships" xmlns:a="http://schemas.openxmlformats.org/drawingml/2006/main" r:embed="R0c816cce2fa64cee">
+          <a:blip xmlns:r="http://schemas.openxmlformats.org/officeDocument/2006/relationships" xmlns:a="http://schemas.openxmlformats.org/drawingml/2006/main" r:embed="R337952a2c23e40ed">
             <a:alphaModFix/>
           </a:blip>
           <a:srcRect xmlns:a="http://schemas.openxmlformats.org/drawingml/2006/main" l="0" t="0" r="0" b="0"/>
@@ -31792,7 +31792,7 @@
           <p:nvPr/>
         </p:nvPicPr>
         <p:blipFill rotWithShape="1">
-          <a:blip xmlns:r="http://schemas.openxmlformats.org/officeDocument/2006/relationships" xmlns:a="http://schemas.openxmlformats.org/drawingml/2006/main" r:embed="Re21bca47ee9a4a35">
+          <a:blip xmlns:r="http://schemas.openxmlformats.org/officeDocument/2006/relationships" xmlns:a="http://schemas.openxmlformats.org/drawingml/2006/main" r:embed="Rf923a1115ac64ab8">
             <a:alphaModFix/>
           </a:blip>
           <a:srcRect xmlns:a="http://schemas.openxmlformats.org/drawingml/2006/main" l="0" t="0" r="0" b="0"/>
@@ -31820,7 +31820,7 @@
           <p:nvPr/>
         </p:nvPicPr>
         <p:blipFill rotWithShape="1">
-          <a:blip xmlns:r="http://schemas.openxmlformats.org/officeDocument/2006/relationships" xmlns:a="http://schemas.openxmlformats.org/drawingml/2006/main" r:embed="Re21bca47ee9a4a35">
+          <a:blip xmlns:r="http://schemas.openxmlformats.org/officeDocument/2006/relationships" xmlns:a="http://schemas.openxmlformats.org/drawingml/2006/main" r:embed="Rf923a1115ac64ab8">
             <a:alphaModFix/>
           </a:blip>
           <a:srcRect xmlns:a="http://schemas.openxmlformats.org/drawingml/2006/main" l="0" t="0" r="0" b="0"/>
@@ -31848,7 +31848,7 @@
           <p:nvPr/>
         </p:nvPicPr>
         <p:blipFill rotWithShape="1">
-          <a:blip xmlns:r="http://schemas.openxmlformats.org/officeDocument/2006/relationships" xmlns:a="http://schemas.openxmlformats.org/drawingml/2006/main" r:embed="Re21bca47ee9a4a35">
+          <a:blip xmlns:r="http://schemas.openxmlformats.org/officeDocument/2006/relationships" xmlns:a="http://schemas.openxmlformats.org/drawingml/2006/main" r:embed="Rf923a1115ac64ab8">
             <a:alphaModFix/>
           </a:blip>
           <a:srcRect xmlns:a="http://schemas.openxmlformats.org/drawingml/2006/main" l="0" t="0" r="0" b="0"/>
@@ -31876,7 +31876,7 @@
           <p:nvPr/>
         </p:nvPicPr>
         <p:blipFill rotWithShape="1">
-          <a:blip xmlns:r="http://schemas.openxmlformats.org/officeDocument/2006/relationships" xmlns:a="http://schemas.openxmlformats.org/drawingml/2006/main" r:embed="Re21bca47ee9a4a35">
+          <a:blip xmlns:r="http://schemas.openxmlformats.org/officeDocument/2006/relationships" xmlns:a="http://schemas.openxmlformats.org/drawingml/2006/main" r:embed="Rf923a1115ac64ab8">
             <a:alphaModFix/>
           </a:blip>
           <a:srcRect xmlns:a="http://schemas.openxmlformats.org/drawingml/2006/main" l="0" t="0" r="0" b="0"/>

</xml_diff>

<commit_message>
Teach JSONL capture with separate per-run status logs
</commit_message>
<xml_diff>
--- a/presentation/falco-libs-intro.pptx
+++ b/presentation/falco-libs-intro.pptx
@@ -2,77 +2,77 @@
 <file path=ppt/presentation.xml><?xml version="1.0" encoding="utf-8"?>
 <p:presentation xmlns:p="http://schemas.openxmlformats.org/presentationml/2006/main" embedTrueTypeFonts="1" saveSubsetFonts="0">
   <p:sldMasterIdLst>
-    <p:sldMasterId xmlns:r="http://schemas.openxmlformats.org/officeDocument/2006/relationships" id="2147483648" r:id="R9b78c402ea844052"/>
-    <p:sldMasterId xmlns:r="http://schemas.openxmlformats.org/officeDocument/2006/relationships" id="2147483661" r:id="R76c7a52c35384ad7"/>
+    <p:sldMasterId xmlns:r="http://schemas.openxmlformats.org/officeDocument/2006/relationships" id="2147483648" r:id="Re6d484a9b46845fc"/>
+    <p:sldMasterId xmlns:r="http://schemas.openxmlformats.org/officeDocument/2006/relationships" id="2147483661" r:id="R887c6a4e5ab548fa"/>
   </p:sldMasterIdLst>
   <p:notesMasterIdLst>
-    <p:notesMasterId xmlns:r="http://schemas.openxmlformats.org/officeDocument/2006/relationships" r:id="R8682db7f9d7348c8"/>
+    <p:notesMasterId xmlns:r="http://schemas.openxmlformats.org/officeDocument/2006/relationships" r:id="R09851ab1c3e94640"/>
   </p:notesMasterIdLst>
   <p:sldIdLst>
-    <p:sldId xmlns:r="http://schemas.openxmlformats.org/officeDocument/2006/relationships" id="256" r:id="Rcbffb133dec641f6"/>
-    <p:sldId xmlns:r="http://schemas.openxmlformats.org/officeDocument/2006/relationships" id="257" r:id="R5df0807cbfd643c1"/>
-    <p:sldId xmlns:r="http://schemas.openxmlformats.org/officeDocument/2006/relationships" id="258" r:id="Re4eb1a06a94d4b77"/>
-    <p:sldId xmlns:r="http://schemas.openxmlformats.org/officeDocument/2006/relationships" id="259" r:id="R525f32ed50484854"/>
-    <p:sldId xmlns:r="http://schemas.openxmlformats.org/officeDocument/2006/relationships" id="260" r:id="R0bd0acb1135f4b61"/>
-    <p:sldId xmlns:r="http://schemas.openxmlformats.org/officeDocument/2006/relationships" id="261" r:id="R3bb8ee3aa1454be8"/>
-    <p:sldId xmlns:r="http://schemas.openxmlformats.org/officeDocument/2006/relationships" id="262" r:id="Rfb6e0931bf9a4c9a"/>
-    <p:sldId xmlns:r="http://schemas.openxmlformats.org/officeDocument/2006/relationships" id="263" r:id="R3a101401daba4270"/>
-    <p:sldId xmlns:r="http://schemas.openxmlformats.org/officeDocument/2006/relationships" id="264" r:id="Rb38a6abee00942bf"/>
-    <p:sldId xmlns:r="http://schemas.openxmlformats.org/officeDocument/2006/relationships" id="265" r:id="R1859891eaab0468d"/>
-    <p:sldId xmlns:r="http://schemas.openxmlformats.org/officeDocument/2006/relationships" id="266" r:id="R46ea7f3b574e4cc7"/>
-    <p:sldId xmlns:r="http://schemas.openxmlformats.org/officeDocument/2006/relationships" id="267" r:id="R4e38c202016447ce"/>
-    <p:sldId xmlns:r="http://schemas.openxmlformats.org/officeDocument/2006/relationships" id="268" r:id="R9da2e883025a4c32"/>
+    <p:sldId xmlns:r="http://schemas.openxmlformats.org/officeDocument/2006/relationships" id="256" r:id="Rb4e04a6f6c2f43f3"/>
+    <p:sldId xmlns:r="http://schemas.openxmlformats.org/officeDocument/2006/relationships" id="257" r:id="R889ca1f2e52b4c98"/>
+    <p:sldId xmlns:r="http://schemas.openxmlformats.org/officeDocument/2006/relationships" id="258" r:id="Rec0d059d954b4f36"/>
+    <p:sldId xmlns:r="http://schemas.openxmlformats.org/officeDocument/2006/relationships" id="259" r:id="Rf649f5bf97004fcc"/>
+    <p:sldId xmlns:r="http://schemas.openxmlformats.org/officeDocument/2006/relationships" id="260" r:id="Rc2e1fb0cb46a4a3f"/>
+    <p:sldId xmlns:r="http://schemas.openxmlformats.org/officeDocument/2006/relationships" id="261" r:id="Ra48084b48cc1484f"/>
+    <p:sldId xmlns:r="http://schemas.openxmlformats.org/officeDocument/2006/relationships" id="262" r:id="R77f9ccde0f304d9a"/>
+    <p:sldId xmlns:r="http://schemas.openxmlformats.org/officeDocument/2006/relationships" id="263" r:id="Rad3cbb0bacc94851"/>
+    <p:sldId xmlns:r="http://schemas.openxmlformats.org/officeDocument/2006/relationships" id="264" r:id="Re386f71dea9f48ce"/>
+    <p:sldId xmlns:r="http://schemas.openxmlformats.org/officeDocument/2006/relationships" id="265" r:id="Rcabd2e90f35a4ada"/>
+    <p:sldId xmlns:r="http://schemas.openxmlformats.org/officeDocument/2006/relationships" id="266" r:id="R7eba62129ba5471d"/>
+    <p:sldId xmlns:r="http://schemas.openxmlformats.org/officeDocument/2006/relationships" id="267" r:id="R572419ae4e4e452d"/>
+    <p:sldId xmlns:r="http://schemas.openxmlformats.org/officeDocument/2006/relationships" id="268" r:id="R818bbdffce5e4006"/>
   </p:sldIdLst>
   <p:sldSz cx="9144000" cy="5143500"/>
   <p:notesSz cx="6858000" cy="9144000"/>
   <p:embeddedFontLst>
     <p:embeddedFont>
       <p:font typeface="Roboto Mono Medium"/>
-      <p:regular xmlns:r="http://schemas.openxmlformats.org/officeDocument/2006/relationships" r:id="R74232a7d56be4134"/>
-      <p:bold xmlns:r="http://schemas.openxmlformats.org/officeDocument/2006/relationships" r:id="R195d4373febd47fc"/>
-      <p:italic xmlns:r="http://schemas.openxmlformats.org/officeDocument/2006/relationships" r:id="R3183e21bf9734b1c"/>
-      <p:boldItalic xmlns:r="http://schemas.openxmlformats.org/officeDocument/2006/relationships" r:id="R19adb3ffa49141d4"/>
+      <p:regular xmlns:r="http://schemas.openxmlformats.org/officeDocument/2006/relationships" r:id="R23a4db0cdf334991"/>
+      <p:bold xmlns:r="http://schemas.openxmlformats.org/officeDocument/2006/relationships" r:id="R94630d5a4fcc469b"/>
+      <p:italic xmlns:r="http://schemas.openxmlformats.org/officeDocument/2006/relationships" r:id="R03867f54b8cc41af"/>
+      <p:boldItalic xmlns:r="http://schemas.openxmlformats.org/officeDocument/2006/relationships" r:id="R0a4d78ede0e34396"/>
     </p:embeddedFont>
     <p:embeddedFont>
       <p:font typeface="Inter SemiBold"/>
-      <p:regular xmlns:r="http://schemas.openxmlformats.org/officeDocument/2006/relationships" r:id="Rbdc939423b9b4621"/>
-      <p:bold xmlns:r="http://schemas.openxmlformats.org/officeDocument/2006/relationships" r:id="R994290d77f844a17"/>
-      <p:italic xmlns:r="http://schemas.openxmlformats.org/officeDocument/2006/relationships" r:id="R175fe26055c84c10"/>
-      <p:boldItalic xmlns:r="http://schemas.openxmlformats.org/officeDocument/2006/relationships" r:id="R9ad6bae65609415d"/>
+      <p:regular xmlns:r="http://schemas.openxmlformats.org/officeDocument/2006/relationships" r:id="Rb8e1632be6e34e24"/>
+      <p:bold xmlns:r="http://schemas.openxmlformats.org/officeDocument/2006/relationships" r:id="R7ab48bd7956e4cdb"/>
+      <p:italic xmlns:r="http://schemas.openxmlformats.org/officeDocument/2006/relationships" r:id="R0938d3fc5fde4381"/>
+      <p:boldItalic xmlns:r="http://schemas.openxmlformats.org/officeDocument/2006/relationships" r:id="R7ce4a11e38a740ec"/>
     </p:embeddedFont>
     <p:embeddedFont>
       <p:font typeface="Montserrat Black"/>
-      <p:bold xmlns:r="http://schemas.openxmlformats.org/officeDocument/2006/relationships" r:id="Rb44f88740d0f405d"/>
-      <p:boldItalic xmlns:r="http://schemas.openxmlformats.org/officeDocument/2006/relationships" r:id="Raf3c9f089a324f5c"/>
+      <p:bold xmlns:r="http://schemas.openxmlformats.org/officeDocument/2006/relationships" r:id="R36f5da471ad04bd2"/>
+      <p:boldItalic xmlns:r="http://schemas.openxmlformats.org/officeDocument/2006/relationships" r:id="R2d22aa5840564370"/>
     </p:embeddedFont>
     <p:embeddedFont>
       <p:font typeface="Montserrat"/>
-      <p:bold xmlns:r="http://schemas.openxmlformats.org/officeDocument/2006/relationships" r:id="R5f1de78040394698"/>
-      <p:boldItalic xmlns:r="http://schemas.openxmlformats.org/officeDocument/2006/relationships" r:id="R1182f90584284122"/>
+      <p:bold xmlns:r="http://schemas.openxmlformats.org/officeDocument/2006/relationships" r:id="R182dcf7a03e9445d"/>
+      <p:boldItalic xmlns:r="http://schemas.openxmlformats.org/officeDocument/2006/relationships" r:id="R03fe23029e664de2"/>
     </p:embeddedFont>
     <p:embeddedFont>
       <p:font typeface="Inter"/>
-      <p:regular xmlns:r="http://schemas.openxmlformats.org/officeDocument/2006/relationships" r:id="R35c75980c271409c"/>
-      <p:bold xmlns:r="http://schemas.openxmlformats.org/officeDocument/2006/relationships" r:id="Rfd9c452d229f4829"/>
-      <p:italic xmlns:r="http://schemas.openxmlformats.org/officeDocument/2006/relationships" r:id="Rb5fede8ef0184488"/>
-      <p:boldItalic xmlns:r="http://schemas.openxmlformats.org/officeDocument/2006/relationships" r:id="Rbc7e108862ac4f1b"/>
+      <p:regular xmlns:r="http://schemas.openxmlformats.org/officeDocument/2006/relationships" r:id="Rc4a8699ee8454d7d"/>
+      <p:bold xmlns:r="http://schemas.openxmlformats.org/officeDocument/2006/relationships" r:id="R6c7fd14e9f7b4a3f"/>
+      <p:italic xmlns:r="http://schemas.openxmlformats.org/officeDocument/2006/relationships" r:id="R4c6e187d8d9641ee"/>
+      <p:boldItalic xmlns:r="http://schemas.openxmlformats.org/officeDocument/2006/relationships" r:id="R1f6359c2dcea4742"/>
     </p:embeddedFont>
     <p:embeddedFont>
       <p:font typeface="Montserrat ExtraBold"/>
-      <p:bold xmlns:r="http://schemas.openxmlformats.org/officeDocument/2006/relationships" r:id="R3d1b1c93dfd64b36"/>
-      <p:boldItalic xmlns:r="http://schemas.openxmlformats.org/officeDocument/2006/relationships" r:id="R6de24be1097a4983"/>
+      <p:bold xmlns:r="http://schemas.openxmlformats.org/officeDocument/2006/relationships" r:id="Rb4e6b7a3b6d247db"/>
+      <p:boldItalic xmlns:r="http://schemas.openxmlformats.org/officeDocument/2006/relationships" r:id="R150cd316338840c8"/>
     </p:embeddedFont>
     <p:embeddedFont>
       <p:font typeface="Roboto Mono"/>
-      <p:bold xmlns:r="http://schemas.openxmlformats.org/officeDocument/2006/relationships" r:id="R868c5bb8ce164dc2"/>
-      <p:boldItalic xmlns:r="http://schemas.openxmlformats.org/officeDocument/2006/relationships" r:id="R95d9db2a9b3244cb"/>
+      <p:bold xmlns:r="http://schemas.openxmlformats.org/officeDocument/2006/relationships" r:id="Rf046e5b821db48f6"/>
+      <p:boldItalic xmlns:r="http://schemas.openxmlformats.org/officeDocument/2006/relationships" r:id="R86cf4ca974b949b7"/>
     </p:embeddedFont>
     <p:embeddedFont>
       <p:font typeface="Inter Medium"/>
-      <p:regular xmlns:r="http://schemas.openxmlformats.org/officeDocument/2006/relationships" r:id="R454bae5fe90447be"/>
-      <p:bold xmlns:r="http://schemas.openxmlformats.org/officeDocument/2006/relationships" r:id="Rc22b5ee8142e49d5"/>
-      <p:italic xmlns:r="http://schemas.openxmlformats.org/officeDocument/2006/relationships" r:id="R307d4abd90114f1c"/>
-      <p:boldItalic xmlns:r="http://schemas.openxmlformats.org/officeDocument/2006/relationships" r:id="R4594c10dcb314a28"/>
+      <p:regular xmlns:r="http://schemas.openxmlformats.org/officeDocument/2006/relationships" r:id="R9b66fb3424c44014"/>
+      <p:bold xmlns:r="http://schemas.openxmlformats.org/officeDocument/2006/relationships" r:id="Rca56d7f95f994edc"/>
+      <p:italic xmlns:r="http://schemas.openxmlformats.org/officeDocument/2006/relationships" r:id="Rb36a33d92f3f4f2b"/>
+      <p:boldItalic xmlns:r="http://schemas.openxmlformats.org/officeDocument/2006/relationships" r:id="Rea86aa512828426a"/>
     </p:embeddedFont>
   </p:embeddedFontLst>
 </p:presentation>
@@ -617,7 +617,7 @@
               <a:buNone/>
             </a:pPr>
             <a:r>
-              <a:t>This continues the code installed by step 2. The count is events delivered successfully to this application, not a count of all syscalls on the machine. This first unfiltered run sees background activity. The runner automatically executes /usr/bin/id after attachment. Each successful read prints the event name. Step 3 enriches the same event stream without adding a filter. SCAP_FILTERED_EVENT is a library status with no event to print, not a filter configured by this example. The final summary counts events delivered to the application. SCAP_EOF is included for correct status handling; a live stream normally ends because the ten-second deadline expires. Source: https://github.com/falcosecurity/libs/blob/e72873882967cdd86b8753eca09ea3e9f91ccd4a/userspace/libsinsp/sinsp.h</a:t>
+              <a:t>This continues the code installed by step 2. The count is events delivered successfully to this application, not a count of all syscalls on the machine. This first unfiltered run sees background activity. The runner automatically executes /usr/bin/id after attachment. Each successful read serializes one compact JSON object with jsoncpp, which Falco libs already uses. The serializer escapes quotes and other special characters. Full source handles SCAP_TIMEOUT, SCAP_FILTERED_EVENT, SCAP_EOF and errors before this excerpt. stdout contains only JSONL; attachment, summary and stop messages use stderr. Step 3 enriches the same event stream without adding a filter. SCAP_FILTERED_EVENT is a library status with no event to print, not a filter configured by this example. The final summary counts events delivered to the application. SCAP_EOF is included for correct status handling; a live stream normally ends because the ten-second deadline expires. Source: https://github.com/falcosecurity/libs/blob/e72873882967cdd86b8753eca09ea3e9f91ccd4a/userspace/libsinsp/sinsp.h</a:t>
             </a:r>
             <a:endParaRPr/>
           </a:p>
@@ -697,7 +697,7 @@
               <a:buNone/>
             </a:pPr>
             <a:r>
-              <a:t>A missing thread record is possible, so check for nullptr. Print the event name even when process context is missing. Process names are short command names, not full executable paths or command lines. Use the event and thread data immediately; the inspector maintains their lifetime. Sources: https://github.com/falcosecurity/libs/blob/e72873882967cdd86b8753eca09ea3e9f91ccd4a/userspace/libsinsp/event.h and https://github.com/falcosecurity/libs/blob/e72873882967cdd86b8753eca09ea3e9f91ccd4a/userspace/libsinsp/threadinfo.h</a:t>
+              <a:t>A missing thread record is possible, so check for nullptr. Always write the JSON record, even when process context is missing. Omit pid and name when unavailable. Process names are short command names, not full executable paths or command lines. Use the event and thread data immediately; the inspector maintains their lifetime. Sources: https://github.com/falcosecurity/libs/blob/e72873882967cdd86b8753eca09ea3e9f91ccd4a/userspace/libsinsp/event.h and https://github.com/falcosecurity/libs/blob/e72873882967cdd86b8753eca09ea3e9f91ccd4a/userspace/libsinsp/threadinfo.h</a:t>
             </a:r>
             <a:endParaRPr/>
           </a:p>
@@ -777,7 +777,7 @@
               <a:buNone/>
             </a:pPr>
             <a:r>
-              <a:t>The output is illustrative. The ellipsis omits other events and the final count. Event names, process names, PIDs and counts vary. Step 3 includes all previous additions and works without running steps 1 and 2 first. Step scripts overwrite main.cpp and CMakeLists.txt locally. Run then rebuilds and captures, saving output to logs/latest.log. No filter or success-only condition is applied. Both syscall directions can appear, and background activity is included. The scheduler-switch tracepoint is disabled. Other capture defaults are unchanged, so this is not a guarantee of capturing every syscall on the machine.</a:t>
+              <a:t>The output is illustrative. The JSONL excerpt omits timestamp_ns for space. The 582-event count is illustrative, as are PIDs and names. Event names, process names, PIDs and counts vary. Step 3 includes all previous additions and works without running steps 1 and 2 first. Step scripts overwrite main.cpp and CMakeLists.txt locally. Run then rebuilds and captures, saving status to logs/&lt;run-id&gt;.log and records to logs/&lt;run-id&gt;.jsonl. No filter or success-only condition is applied. Both syscall directions can appear, and background activity is included. The scheduler-switch tracepoint is disabled. Other capture defaults are unchanged, so this is not a guarantee of capturing every syscall on the machine.</a:t>
             </a:r>
             <a:endParaRPr/>
           </a:p>
@@ -937,7 +937,7 @@
               <a:buNone/>
             </a:pPr>
             <a:r>
-              <a:t>Following along is optional. Demonstrate each stage from the VM. The final collector prints the library event stream with process context. It applies no application filter. Scheduler-switch events are disabled at capture because they are not syscalls. There are no detection rules, JSON formatting, or production deployment exercises.</a:t>
+              <a:t>Following along is optional. Demonstrate each stage from the VM. The final collector writes the library event stream as JSONL with process context. Status messages go to stderr and syscall JSON goes to stdout. The runner redirects them to separate files. It applies no application filter. Scheduler-switch events are disabled at capture because they are not syscalls. There are no detection rules, JSON formatting, or production deployment exercises.</a:t>
             </a:r>
             <a:endParaRPr/>
           </a:p>
@@ -1177,7 +1177,7 @@
               <a:buNone/>
             </a:pPr>
             <a:r>
-              <a:t>No VM shell or second terminal is needed. Run starts or reuses the VM, copies source, rebuilds, and starts the collector. After the collector reports attachment, the runner executes /usr/bin/id inside Ubuntu automatically. It waits for capture to finish, transfers the complete log with multipass transfer, then prints it locally. This avoids piping bulk output through multipass exec. Successful build output is hidden; build failures are displayed. The VM stays available for the next run.</a:t>
+              <a:t>No VM shell or second terminal is needed. Run starts or reuses the VM, copies source, rebuilds, and starts the collector. After the collector reports attachment, the runner executes /usr/bin/id inside Ubuntu automatically. It waits for capture to finish, transfers the complete status and JSONL files with multipass transfer, then displays only the status locally. Each run has a UTC time and runner PID in its filenames, preserving earlier output. This avoids piping bulk output through multipass exec. Successful build output is hidden; build failures are displayed. The VM stays available for the next run.</a:t>
             </a:r>
             <a:endParaRPr/>
           </a:p>
@@ -1257,7 +1257,7 @@
               <a:buNone/>
             </a:pPr>
             <a:r>
-              <a:t>Run from the Mac repo folder in the same host terminal, one step at a time. Each step script writes src/main.cpp and src/CMakeLists.txt locally. Run copies them to Ubuntu, rebuilds, starts a fresh ten-second agent run, generates example activity, then displays output and saves logs/latest.log locally. The agent stops and the VM remains running. Comment blocks mark additions. Step scripts replace local edits. Run copies those current files into the VM. Steps include all earlier changes and can be rerun or skipped. Run executes /usr/bin/id inside Ubuntu automatically after attachment. No second terminal or VM shell is needed.</a:t>
+              <a:t>Run from the Mac repo folder in the same host terminal, one step at a time. Each step script writes src/main.cpp and src/CMakeLists.txt locally. Run copies them to Ubuntu, rebuilds, starts a fresh ten-second agent run, generates example activity, then displays status and saves logs/&lt;run-id&gt;.log and logs/&lt;run-id&gt;.jsonl locally. The agent stops and the VM remains running. Comment blocks mark additions. Step scripts replace local edits. Run copies those current files into the VM. Steps include all earlier changes and can be rerun or skipped. Run executes /usr/bin/id inside Ubuntu automatically after attachment. No second terminal or VM shell is needed.</a:t>
             </a:r>
             <a:endParaRPr/>
           </a:p>
@@ -1337,7 +1337,7 @@
               <a:buNone/>
             </a:pPr>
             <a:r>
-              <a:t>Run from the Windows repo folder in the same host terminal, one step at a time. Each step script writes src/main.cpp and src/CMakeLists.txt locally. Run copies them to Ubuntu, rebuilds, starts a fresh ten-second agent run, generates example activity, then displays output and saves logs/latest.log locally. The agent stops and the VM remains running. Comment blocks mark additions. Step scripts replace local edits. Run copies those current files into the VM. Steps include all earlier changes and can be rerun or skipped. Run executes /usr/bin/id inside Ubuntu automatically after attachment. No second terminal or VM shell is needed.</a:t>
+              <a:t>Run from the Windows repo folder in the same host terminal, one step at a time. Each step script writes src/main.cpp and src/CMakeLists.txt locally. Run copies them to Ubuntu, rebuilds, starts a fresh ten-second agent run, generates example activity, then displays status and saves logs/&lt;run-id&gt;.log and logs/&lt;run-id&gt;.jsonl locally. The agent stops and the VM remains running. Comment blocks mark additions. Step scripts replace local edits. Run copies those current files into the VM. Steps include all earlier changes and can be rerun or skipped. Run executes /usr/bin/id inside Ubuntu automatically after attachment. No second terminal or VM shell is needed.</a:t>
             </a:r>
             <a:endParaRPr/>
           </a:p>
@@ -5665,18 +5665,18 @@
   </p:cSld>
   <p:clrMap bg1="lt1" tx1="dk1" bg2="dk2" tx2="lt2" accent1="accent1" accent2="accent2" accent3="accent3" accent4="accent4" accent5="accent5" accent6="accent6" hlink="hlink" folHlink="folHlink"/>
   <p:sldLayoutIdLst>
-    <p:sldLayoutId xmlns:r="http://schemas.openxmlformats.org/officeDocument/2006/relationships" id="2147483649" r:id="Rcaca4e93cebb42b7"/>
-    <p:sldLayoutId xmlns:r="http://schemas.openxmlformats.org/officeDocument/2006/relationships" id="2147483650" r:id="R176e9955eb054645"/>
-    <p:sldLayoutId xmlns:r="http://schemas.openxmlformats.org/officeDocument/2006/relationships" id="2147483651" r:id="Rc419b05216df494b"/>
-    <p:sldLayoutId xmlns:r="http://schemas.openxmlformats.org/officeDocument/2006/relationships" id="2147483652" r:id="R7e576d70564a4c2d"/>
-    <p:sldLayoutId xmlns:r="http://schemas.openxmlformats.org/officeDocument/2006/relationships" id="2147483653" r:id="R1c53469dae00481f"/>
-    <p:sldLayoutId xmlns:r="http://schemas.openxmlformats.org/officeDocument/2006/relationships" id="2147483654" r:id="Rb3e433d833bb4c5e"/>
-    <p:sldLayoutId xmlns:r="http://schemas.openxmlformats.org/officeDocument/2006/relationships" id="2147483655" r:id="R6408f1700c8d49d4"/>
-    <p:sldLayoutId xmlns:r="http://schemas.openxmlformats.org/officeDocument/2006/relationships" id="2147483656" r:id="R64822d7aef0f48e1"/>
-    <p:sldLayoutId xmlns:r="http://schemas.openxmlformats.org/officeDocument/2006/relationships" id="2147483657" r:id="R80167a4972f142a0"/>
-    <p:sldLayoutId xmlns:r="http://schemas.openxmlformats.org/officeDocument/2006/relationships" id="2147483658" r:id="R77f3af389cff4f48"/>
-    <p:sldLayoutId xmlns:r="http://schemas.openxmlformats.org/officeDocument/2006/relationships" id="2147483659" r:id="R1717a3aecd304111"/>
-    <p:sldLayoutId xmlns:r="http://schemas.openxmlformats.org/officeDocument/2006/relationships" id="2147483660" r:id="R2e26d776eed24277"/>
+    <p:sldLayoutId xmlns:r="http://schemas.openxmlformats.org/officeDocument/2006/relationships" id="2147483649" r:id="R6dbcfc24053c4d94"/>
+    <p:sldLayoutId xmlns:r="http://schemas.openxmlformats.org/officeDocument/2006/relationships" id="2147483650" r:id="R83bc9f283144462c"/>
+    <p:sldLayoutId xmlns:r="http://schemas.openxmlformats.org/officeDocument/2006/relationships" id="2147483651" r:id="Rdd4643c26bfd4a1c"/>
+    <p:sldLayoutId xmlns:r="http://schemas.openxmlformats.org/officeDocument/2006/relationships" id="2147483652" r:id="Rdd66bc8872d64733"/>
+    <p:sldLayoutId xmlns:r="http://schemas.openxmlformats.org/officeDocument/2006/relationships" id="2147483653" r:id="Ra20b145a42f44f8f"/>
+    <p:sldLayoutId xmlns:r="http://schemas.openxmlformats.org/officeDocument/2006/relationships" id="2147483654" r:id="R51a83e6d23d94aaf"/>
+    <p:sldLayoutId xmlns:r="http://schemas.openxmlformats.org/officeDocument/2006/relationships" id="2147483655" r:id="R4029f4d2d8584c62"/>
+    <p:sldLayoutId xmlns:r="http://schemas.openxmlformats.org/officeDocument/2006/relationships" id="2147483656" r:id="R0c9dbda793c449b5"/>
+    <p:sldLayoutId xmlns:r="http://schemas.openxmlformats.org/officeDocument/2006/relationships" id="2147483657" r:id="Re28328efef914a23"/>
+    <p:sldLayoutId xmlns:r="http://schemas.openxmlformats.org/officeDocument/2006/relationships" id="2147483658" r:id="R4304908d53864c5d"/>
+    <p:sldLayoutId xmlns:r="http://schemas.openxmlformats.org/officeDocument/2006/relationships" id="2147483659" r:id="R992c295b64f34138"/>
+    <p:sldLayoutId xmlns:r="http://schemas.openxmlformats.org/officeDocument/2006/relationships" id="2147483660" r:id="R76a098c2170242da"/>
   </p:sldLayoutIdLst>
   <p:hf sldNum="0" hdr="0" ftr="0" dt="0"/>
   <p:txStyles>
@@ -6361,7 +6361,7 @@
   </p:cSld>
   <p:clrMap bg1="lt1" tx1="dk1" bg2="dk2" tx2="lt2" accent1="accent1" accent2="accent2" accent3="accent3" accent4="accent4" accent5="accent5" accent6="accent6" hlink="hlink" folHlink="folHlink"/>
   <p:sldLayoutIdLst>
-    <p:sldLayoutId xmlns:r="http://schemas.openxmlformats.org/officeDocument/2006/relationships" id="2147483662" r:id="Rcd35d6a8a18d43a0"/>
+    <p:sldLayoutId xmlns:r="http://schemas.openxmlformats.org/officeDocument/2006/relationships" id="2147483662" r:id="Rafe11c29ede94a2b"/>
   </p:sldLayoutIdLst>
   <p:hf sldNum="0" hdr="0" ftr="0" dt="0"/>
   <p:txStyles>
@@ -8210,7 +8210,7 @@
           <p:nvPr/>
         </p:nvPicPr>
         <p:blipFill rotWithShape="1">
-          <a:blip xmlns:r="http://schemas.openxmlformats.org/officeDocument/2006/relationships" xmlns:a="http://schemas.openxmlformats.org/drawingml/2006/main" r:embed="R9a8d7a2c13f947a6">
+          <a:blip xmlns:r="http://schemas.openxmlformats.org/officeDocument/2006/relationships" xmlns:a="http://schemas.openxmlformats.org/drawingml/2006/main" r:embed="R176bb20692a24901">
             <a:alphaModFix/>
           </a:blip>
           <a:srcRect xmlns:a="http://schemas.openxmlformats.org/drawingml/2006/main" l="0" t="0" r="0" b="0"/>
@@ -8238,7 +8238,7 @@
           <p:nvPr/>
         </p:nvPicPr>
         <p:blipFill rotWithShape="1">
-          <a:blip xmlns:r="http://schemas.openxmlformats.org/officeDocument/2006/relationships" xmlns:a="http://schemas.openxmlformats.org/drawingml/2006/main" r:embed="R9a8d7a2c13f947a6">
+          <a:blip xmlns:r="http://schemas.openxmlformats.org/officeDocument/2006/relationships" xmlns:a="http://schemas.openxmlformats.org/drawingml/2006/main" r:embed="R176bb20692a24901">
             <a:alphaModFix/>
           </a:blip>
           <a:srcRect xmlns:a="http://schemas.openxmlformats.org/drawingml/2006/main" l="0" t="0" r="0" b="0"/>
@@ -8266,7 +8266,7 @@
           <p:nvPr/>
         </p:nvPicPr>
         <p:blipFill rotWithShape="1">
-          <a:blip xmlns:r="http://schemas.openxmlformats.org/officeDocument/2006/relationships" xmlns:a="http://schemas.openxmlformats.org/drawingml/2006/main" r:embed="R9a8d7a2c13f947a6">
+          <a:blip xmlns:r="http://schemas.openxmlformats.org/officeDocument/2006/relationships" xmlns:a="http://schemas.openxmlformats.org/drawingml/2006/main" r:embed="R176bb20692a24901">
             <a:alphaModFix/>
           </a:blip>
           <a:srcRect xmlns:a="http://schemas.openxmlformats.org/drawingml/2006/main" l="0" t="0" r="0" b="0"/>
@@ -8294,7 +8294,7 @@
           <p:nvPr/>
         </p:nvPicPr>
         <p:blipFill rotWithShape="1">
-          <a:blip xmlns:r="http://schemas.openxmlformats.org/officeDocument/2006/relationships" xmlns:a="http://schemas.openxmlformats.org/drawingml/2006/main" r:embed="R9a8d7a2c13f947a6">
+          <a:blip xmlns:r="http://schemas.openxmlformats.org/officeDocument/2006/relationships" xmlns:a="http://schemas.openxmlformats.org/drawingml/2006/main" r:embed="R176bb20692a24901">
             <a:alphaModFix/>
           </a:blip>
           <a:srcRect xmlns:a="http://schemas.openxmlformats.org/drawingml/2006/main" l="0" t="0" r="0" b="0"/>
@@ -8322,7 +8322,7 @@
           <p:nvPr/>
         </p:nvPicPr>
         <p:blipFill rotWithShape="1">
-          <a:blip xmlns:r="http://schemas.openxmlformats.org/officeDocument/2006/relationships" xmlns:a="http://schemas.openxmlformats.org/drawingml/2006/main" r:embed="R9a8d7a2c13f947a6">
+          <a:blip xmlns:r="http://schemas.openxmlformats.org/officeDocument/2006/relationships" xmlns:a="http://schemas.openxmlformats.org/drawingml/2006/main" r:embed="R176bb20692a24901">
             <a:alphaModFix/>
           </a:blip>
           <a:srcRect xmlns:a="http://schemas.openxmlformats.org/drawingml/2006/main" l="0" t="0" r="0" b="0"/>
@@ -8350,7 +8350,7 @@
           <p:nvPr/>
         </p:nvPicPr>
         <p:blipFill rotWithShape="1">
-          <a:blip xmlns:r="http://schemas.openxmlformats.org/officeDocument/2006/relationships" xmlns:a="http://schemas.openxmlformats.org/drawingml/2006/main" r:embed="R9a8d7a2c13f947a6">
+          <a:blip xmlns:r="http://schemas.openxmlformats.org/officeDocument/2006/relationships" xmlns:a="http://schemas.openxmlformats.org/drawingml/2006/main" r:embed="R176bb20692a24901">
             <a:alphaModFix/>
           </a:blip>
           <a:srcRect xmlns:a="http://schemas.openxmlformats.org/drawingml/2006/main" l="0" t="0" r="0" b="0"/>
@@ -8378,7 +8378,7 @@
           <p:nvPr/>
         </p:nvPicPr>
         <p:blipFill rotWithShape="1">
-          <a:blip xmlns:r="http://schemas.openxmlformats.org/officeDocument/2006/relationships" xmlns:a="http://schemas.openxmlformats.org/drawingml/2006/main" r:embed="R9a8d7a2c13f947a6">
+          <a:blip xmlns:r="http://schemas.openxmlformats.org/officeDocument/2006/relationships" xmlns:a="http://schemas.openxmlformats.org/drawingml/2006/main" r:embed="R176bb20692a24901">
             <a:alphaModFix/>
           </a:blip>
           <a:srcRect xmlns:a="http://schemas.openxmlformats.org/drawingml/2006/main" l="0" t="0" r="0" b="0"/>
@@ -8406,7 +8406,7 @@
           <p:nvPr/>
         </p:nvPicPr>
         <p:blipFill rotWithShape="1">
-          <a:blip xmlns:r="http://schemas.openxmlformats.org/officeDocument/2006/relationships" xmlns:a="http://schemas.openxmlformats.org/drawingml/2006/main" r:embed="R9a8d7a2c13f947a6">
+          <a:blip xmlns:r="http://schemas.openxmlformats.org/officeDocument/2006/relationships" xmlns:a="http://schemas.openxmlformats.org/drawingml/2006/main" r:embed="R176bb20692a24901">
             <a:alphaModFix/>
           </a:blip>
           <a:srcRect xmlns:a="http://schemas.openxmlformats.org/drawingml/2006/main" l="0" t="0" r="0" b="0"/>
@@ -9010,7 +9010,7 @@
                 <a:ea typeface="Montserrat"/>
                 <a:cs typeface="Montserrat"/>
               </a:rPr>
-              <a:t>Step 2: Print the returned events</a:t>
+              <a:t>Step 2: Write JSONL events</a:t>
             </a:r>
           </a:p>
         </p:txBody>
@@ -9178,7 +9178,7 @@
                 <a:ea typeface="Inter"/>
                 <a:cs typeface="Inter"/>
               </a:rPr>
-              <a:t>Skip statuses with no event.</a:t>
+              <a:t>Write one JSON object per event.</a:t>
             </a:r>
           </a:p>
           <a:p xmlns:a="http://schemas.openxmlformats.org/drawingml/2006/main">
@@ -9230,7 +9230,7 @@
                 <a:ea typeface="Inter"/>
                 <a:cs typeface="Inter"/>
               </a:rPr>
-              <a:t>Report errors instead of treating them as events.</a:t>
+              <a:t>Each record starts with the event name and timestamp.</a:t>
             </a:r>
           </a:p>
           <a:p xmlns:a="http://schemas.openxmlformats.org/drawingml/2006/main">
@@ -9282,7 +9282,7 @@
                 <a:ea typeface="Inter"/>
                 <a:cs typeface="Inter"/>
               </a:rPr>
-              <a:t>Print each event name. File operations, process activity and other events appear together.</a:t>
+              <a:t>Status messages go to the .log file. Event records go to .jsonl.</a:t>
             </a:r>
           </a:p>
         </p:txBody>
@@ -9669,7 +9669,7 @@
                 <a:ea typeface="Roboto Mono"/>
                 <a:cs typeface="Roboto Mono"/>
               </a:rPr>
-              <a:t>    if(result == SCAP_TIMEOUT ||</a:t>
+              <a:t>// After a successful next() call:</a:t>
             </a:r>
           </a:p>
           <a:p xmlns:a="http://schemas.openxmlformats.org/drawingml/2006/main">
@@ -9699,7 +9699,7 @@
                 <a:ea typeface="Roboto Mono"/>
                 <a:cs typeface="Roboto Mono"/>
               </a:rPr>
-              <a:t>       result == SCAP_FILTERED_EVENT) {</a:t>
+              <a:t>Json::Value record;</a:t>
             </a:r>
           </a:p>
           <a:p xmlns:a="http://schemas.openxmlformats.org/drawingml/2006/main">
@@ -9729,7 +9729,7 @@
                 <a:ea typeface="Roboto Mono"/>
                 <a:cs typeface="Roboto Mono"/>
               </a:rPr>
-              <a:t>        continue;</a:t>
+              <a:t>record["event"] = event-&gt;get_name();</a:t>
             </a:r>
           </a:p>
           <a:p xmlns:a="http://schemas.openxmlformats.org/drawingml/2006/main">
@@ -9759,7 +9759,7 @@
                 <a:ea typeface="Roboto Mono"/>
                 <a:cs typeface="Roboto Mono"/>
               </a:rPr>
-              <a:t>    }</a:t>
+              <a:t>record["timestamp_ns"] =</a:t>
             </a:r>
           </a:p>
           <a:p xmlns:a="http://schemas.openxmlformats.org/drawingml/2006/main">
@@ -9789,7 +9789,7 @@
                 <a:ea typeface="Roboto Mono"/>
                 <a:cs typeface="Roboto Mono"/>
               </a:rPr>
-              <a:t>    if(result == SCAP_EOF) { break; }</a:t>
+              <a:t>    Json::UInt64(event-&gt;get_ts());</a:t>
             </a:r>
           </a:p>
           <a:p xmlns:a="http://schemas.openxmlformats.org/drawingml/2006/main">
@@ -9819,7 +9819,7 @@
                 <a:ea typeface="Roboto Mono"/>
                 <a:cs typeface="Roboto Mono"/>
               </a:rPr>
-              <a:t>    if(result != SCAP_SUCCESS) {</a:t>
+              <a:t>std::cout &lt;&lt; Json::writeString(json, record)</a:t>
             </a:r>
           </a:p>
           <a:p xmlns:a="http://schemas.openxmlformats.org/drawingml/2006/main">
@@ -9849,187 +9849,7 @@
                 <a:ea typeface="Roboto Mono"/>
                 <a:cs typeface="Roboto Mono"/>
               </a:rPr>
-              <a:t>        throw std::runtime_error(</a:t>
-            </a:r>
-          </a:p>
-          <a:p xmlns:a="http://schemas.openxmlformats.org/drawingml/2006/main">
-            <a:pPr marL="0" indent="0" algn="l">
-              <a:spcBef>
-                <a:spcPts val="0"/>
-              </a:spcBef>
-              <a:spcAft>
-                <a:spcPts val="0"/>
-              </a:spcAft>
-              <a:buNone/>
-              <a:defRPr sz="1200" b="0">
-                <a:solidFill>
-                  <a:srgbClr val="00E5FF"/>
-                </a:solidFill>
-                <a:latin typeface="Roboto Mono"/>
-                <a:ea typeface="Roboto Mono"/>
-                <a:cs typeface="Roboto Mono"/>
-              </a:defRPr>
-            </a:pPr>
-            <a:r>
-              <a:rPr sz="1200" b="0" i="0">
-                <a:solidFill>
-                  <a:srgbClr val="00E5FF"/>
-                </a:solidFill>
-                <a:latin typeface="Roboto Mono"/>
-                <a:ea typeface="Roboto Mono"/>
-                <a:cs typeface="Roboto Mono"/>
-              </a:rPr>
-              <a:t>            inspector.getlasterr());</a:t>
-            </a:r>
-          </a:p>
-          <a:p xmlns:a="http://schemas.openxmlformats.org/drawingml/2006/main">
-            <a:pPr marL="0" indent="0" algn="l">
-              <a:spcBef>
-                <a:spcPts val="0"/>
-              </a:spcBef>
-              <a:spcAft>
-                <a:spcPts val="0"/>
-              </a:spcAft>
-              <a:buNone/>
-              <a:defRPr sz="1200" b="0">
-                <a:solidFill>
-                  <a:srgbClr val="00E5FF"/>
-                </a:solidFill>
-                <a:latin typeface="Roboto Mono"/>
-                <a:ea typeface="Roboto Mono"/>
-                <a:cs typeface="Roboto Mono"/>
-              </a:defRPr>
-            </a:pPr>
-            <a:r>
-              <a:rPr sz="1200" b="0" i="0">
-                <a:solidFill>
-                  <a:srgbClr val="00E5FF"/>
-                </a:solidFill>
-                <a:latin typeface="Roboto Mono"/>
-                <a:ea typeface="Roboto Mono"/>
-                <a:cs typeface="Roboto Mono"/>
-              </a:rPr>
-              <a:t>    }</a:t>
-            </a:r>
-          </a:p>
-          <a:p xmlns:a="http://schemas.openxmlformats.org/drawingml/2006/main">
-            <a:pPr marL="0" indent="0" algn="l">
-              <a:spcBef>
-                <a:spcPts val="0"/>
-              </a:spcBef>
-              <a:spcAft>
-                <a:spcPts val="0"/>
-              </a:spcAft>
-              <a:buNone/>
-              <a:defRPr sz="1200" b="0">
-                <a:solidFill>
-                  <a:srgbClr val="00E5FF"/>
-                </a:solidFill>
-                <a:latin typeface="Roboto Mono"/>
-                <a:ea typeface="Roboto Mono"/>
-                <a:cs typeface="Roboto Mono"/>
-              </a:defRPr>
-            </a:pPr>
-            <a:r>
-              <a:rPr sz="1200" b="0" i="0">
-                <a:solidFill>
-                  <a:srgbClr val="00E5FF"/>
-                </a:solidFill>
-                <a:latin typeface="Roboto Mono"/>
-                <a:ea typeface="Roboto Mono"/>
-                <a:cs typeface="Roboto Mono"/>
-              </a:rPr>
-              <a:t>    ++received;</a:t>
-            </a:r>
-          </a:p>
-          <a:p xmlns:a="http://schemas.openxmlformats.org/drawingml/2006/main">
-            <a:pPr marL="0" indent="0" algn="l">
-              <a:spcBef>
-                <a:spcPts val="0"/>
-              </a:spcBef>
-              <a:spcAft>
-                <a:spcPts val="0"/>
-              </a:spcAft>
-              <a:buNone/>
-              <a:defRPr sz="1200" b="0">
-                <a:solidFill>
-                  <a:srgbClr val="00E5FF"/>
-                </a:solidFill>
-                <a:latin typeface="Roboto Mono"/>
-                <a:ea typeface="Roboto Mono"/>
-                <a:cs typeface="Roboto Mono"/>
-              </a:defRPr>
-            </a:pPr>
-            <a:r>
-              <a:rPr sz="1200" b="0" i="0">
-                <a:solidFill>
-                  <a:srgbClr val="00E5FF"/>
-                </a:solidFill>
-                <a:latin typeface="Roboto Mono"/>
-                <a:ea typeface="Roboto Mono"/>
-                <a:cs typeface="Roboto Mono"/>
-              </a:rPr>
-              <a:t>    std::cout &lt;&lt; event-&gt;get_name()</a:t>
-            </a:r>
-          </a:p>
-          <a:p xmlns:a="http://schemas.openxmlformats.org/drawingml/2006/main">
-            <a:pPr marL="0" indent="0" algn="l">
-              <a:spcBef>
-                <a:spcPts val="0"/>
-              </a:spcBef>
-              <a:spcAft>
-                <a:spcPts val="0"/>
-              </a:spcAft>
-              <a:buNone/>
-              <a:defRPr sz="1200" b="0">
-                <a:solidFill>
-                  <a:srgbClr val="00E5FF"/>
-                </a:solidFill>
-                <a:latin typeface="Roboto Mono"/>
-                <a:ea typeface="Roboto Mono"/>
-                <a:cs typeface="Roboto Mono"/>
-              </a:defRPr>
-            </a:pPr>
-            <a:r>
-              <a:rPr sz="1200" b="0" i="0">
-                <a:solidFill>
-                  <a:srgbClr val="00E5FF"/>
-                </a:solidFill>
-                <a:latin typeface="Roboto Mono"/>
-                <a:ea typeface="Roboto Mono"/>
-                <a:cs typeface="Roboto Mono"/>
-              </a:rPr>
-              <a:t>              &lt;&lt; '\n';</a:t>
-            </a:r>
-          </a:p>
-          <a:p xmlns:a="http://schemas.openxmlformats.org/drawingml/2006/main">
-            <a:pPr marL="0" indent="0" algn="l">
-              <a:spcBef>
-                <a:spcPts val="0"/>
-              </a:spcBef>
-              <a:spcAft>
-                <a:spcPts val="0"/>
-              </a:spcAft>
-              <a:buNone/>
-              <a:defRPr sz="1200" b="0">
-                <a:solidFill>
-                  <a:srgbClr val="00E5FF"/>
-                </a:solidFill>
-                <a:latin typeface="Roboto Mono"/>
-                <a:ea typeface="Roboto Mono"/>
-                <a:cs typeface="Roboto Mono"/>
-              </a:defRPr>
-            </a:pPr>
-            <a:r>
-              <a:rPr sz="1200" b="0" i="0">
-                <a:solidFill>
-                  <a:srgbClr val="00E5FF"/>
-                </a:solidFill>
-                <a:latin typeface="Roboto Mono"/>
-                <a:ea typeface="Roboto Mono"/>
-                <a:cs typeface="Roboto Mono"/>
-              </a:rPr>
-              <a:t>}</a:t>
+              <a:t>          &lt;&lt; '\n';</a:t>
             </a:r>
           </a:p>
         </p:txBody>
@@ -10679,7 +10499,7 @@
           <p:nvPr/>
         </p:nvPicPr>
         <p:blipFill rotWithShape="1">
-          <a:blip xmlns:r="http://schemas.openxmlformats.org/officeDocument/2006/relationships" xmlns:a="http://schemas.openxmlformats.org/drawingml/2006/main" r:embed="R0d95b62a237e43fb">
+          <a:blip xmlns:r="http://schemas.openxmlformats.org/officeDocument/2006/relationships" xmlns:a="http://schemas.openxmlformats.org/drawingml/2006/main" r:embed="R2163356993584ba4">
             <a:alphaModFix/>
           </a:blip>
           <a:srcRect xmlns:a="http://schemas.openxmlformats.org/drawingml/2006/main" l="0" t="0" r="0" b="0"/>
@@ -10707,7 +10527,7 @@
           <p:nvPr/>
         </p:nvPicPr>
         <p:blipFill rotWithShape="1">
-          <a:blip xmlns:r="http://schemas.openxmlformats.org/officeDocument/2006/relationships" xmlns:a="http://schemas.openxmlformats.org/drawingml/2006/main" r:embed="R0d95b62a237e43fb">
+          <a:blip xmlns:r="http://schemas.openxmlformats.org/officeDocument/2006/relationships" xmlns:a="http://schemas.openxmlformats.org/drawingml/2006/main" r:embed="R2163356993584ba4">
             <a:alphaModFix/>
           </a:blip>
           <a:srcRect xmlns:a="http://schemas.openxmlformats.org/drawingml/2006/main" l="0" t="0" r="0" b="0"/>
@@ -10735,7 +10555,7 @@
           <p:nvPr/>
         </p:nvPicPr>
         <p:blipFill rotWithShape="1">
-          <a:blip xmlns:r="http://schemas.openxmlformats.org/officeDocument/2006/relationships" xmlns:a="http://schemas.openxmlformats.org/drawingml/2006/main" r:embed="R0d95b62a237e43fb">
+          <a:blip xmlns:r="http://schemas.openxmlformats.org/officeDocument/2006/relationships" xmlns:a="http://schemas.openxmlformats.org/drawingml/2006/main" r:embed="R2163356993584ba4">
             <a:alphaModFix/>
           </a:blip>
           <a:srcRect xmlns:a="http://schemas.openxmlformats.org/drawingml/2006/main" l="0" t="0" r="0" b="0"/>
@@ -10763,7 +10583,7 @@
           <p:nvPr/>
         </p:nvPicPr>
         <p:blipFill rotWithShape="1">
-          <a:blip xmlns:r="http://schemas.openxmlformats.org/officeDocument/2006/relationships" xmlns:a="http://schemas.openxmlformats.org/drawingml/2006/main" r:embed="R0d95b62a237e43fb">
+          <a:blip xmlns:r="http://schemas.openxmlformats.org/officeDocument/2006/relationships" xmlns:a="http://schemas.openxmlformats.org/drawingml/2006/main" r:embed="R2163356993584ba4">
             <a:alphaModFix/>
           </a:blip>
           <a:srcRect xmlns:a="http://schemas.openxmlformats.org/drawingml/2006/main" l="0" t="0" r="0" b="0"/>
@@ -11413,7 +11233,7 @@
                 <a:ea typeface="Inter"/>
                 <a:cs typeface="Inter"/>
               </a:rPr>
-              <a:t>The script adds PID and process name to the existing event output.</a:t>
+              <a:t>The script adds PID and process name to each JSON record.</a:t>
             </a:r>
           </a:p>
           <a:p xmlns:a="http://schemas.openxmlformats.org/drawingml/2006/main">
@@ -11465,7 +11285,7 @@
                 <a:ea typeface="Inter"/>
                 <a:cs typeface="Inter"/>
               </a:rPr>
-              <a:t>Keep every returned event, even when process context is unavailable.</a:t>
+              <a:t>Records still appear when process context is unavailable.</a:t>
             </a:r>
           </a:p>
         </p:txBody>
@@ -11852,7 +11672,7 @@
                 <a:ea typeface="Roboto Mono"/>
                 <a:cs typeface="Roboto Mono"/>
               </a:rPr>
-              <a:t>std::cout &lt;&lt; event-&gt;get_name();</a:t>
+              <a:t>// Add fields before writing the record.</a:t>
             </a:r>
           </a:p>
           <a:p xmlns:a="http://schemas.openxmlformats.org/drawingml/2006/main">
@@ -11972,7 +11792,7 @@
                 <a:ea typeface="Roboto Mono"/>
                 <a:cs typeface="Roboto Mono"/>
               </a:rPr>
-              <a:t>    std::cout &lt;&lt; " pid=" &lt;&lt; process-&gt;m_pid</a:t>
+              <a:t>    record["pid"] =</a:t>
             </a:r>
           </a:p>
           <a:p xmlns:a="http://schemas.openxmlformats.org/drawingml/2006/main">
@@ -12002,7 +11822,37 @@
                 <a:ea typeface="Roboto Mono"/>
                 <a:cs typeface="Roboto Mono"/>
               </a:rPr>
-              <a:t>              &lt;&lt; " name=" &lt;&lt; process-&gt;m_comm;</a:t>
+              <a:t>        Json::Int64(process-&gt;m_pid);</a:t>
+            </a:r>
+          </a:p>
+          <a:p xmlns:a="http://schemas.openxmlformats.org/drawingml/2006/main">
+            <a:pPr marL="0" indent="0" algn="l">
+              <a:spcBef>
+                <a:spcPts val="0"/>
+              </a:spcBef>
+              <a:spcAft>
+                <a:spcPts val="0"/>
+              </a:spcAft>
+              <a:buNone/>
+              <a:defRPr sz="1350" b="0">
+                <a:solidFill>
+                  <a:srgbClr val="00E5FF"/>
+                </a:solidFill>
+                <a:latin typeface="Roboto Mono"/>
+                <a:ea typeface="Roboto Mono"/>
+                <a:cs typeface="Roboto Mono"/>
+              </a:defRPr>
+            </a:pPr>
+            <a:r>
+              <a:rPr sz="1350" b="0" i="0">
+                <a:solidFill>
+                  <a:srgbClr val="00E5FF"/>
+                </a:solidFill>
+                <a:latin typeface="Roboto Mono"/>
+                <a:ea typeface="Roboto Mono"/>
+                <a:cs typeface="Roboto Mono"/>
+              </a:rPr>
+              <a:t>    record["name"] = process-&gt;m_comm;</a:t>
             </a:r>
           </a:p>
           <a:p xmlns:a="http://schemas.openxmlformats.org/drawingml/2006/main">
@@ -12062,7 +11912,37 @@
                 <a:ea typeface="Roboto Mono"/>
                 <a:cs typeface="Roboto Mono"/>
               </a:rPr>
-              <a:t>std::cout &lt;&lt; '\n';</a:t>
+              <a:t>std::cout &lt;&lt; Json::writeString(json, record)</a:t>
+            </a:r>
+          </a:p>
+          <a:p xmlns:a="http://schemas.openxmlformats.org/drawingml/2006/main">
+            <a:pPr marL="0" indent="0" algn="l">
+              <a:spcBef>
+                <a:spcPts val="0"/>
+              </a:spcBef>
+              <a:spcAft>
+                <a:spcPts val="0"/>
+              </a:spcAft>
+              <a:buNone/>
+              <a:defRPr sz="1350" b="0">
+                <a:solidFill>
+                  <a:srgbClr val="00E5FF"/>
+                </a:solidFill>
+                <a:latin typeface="Roboto Mono"/>
+                <a:ea typeface="Roboto Mono"/>
+                <a:cs typeface="Roboto Mono"/>
+              </a:defRPr>
+            </a:pPr>
+            <a:r>
+              <a:rPr sz="1350" b="0" i="0">
+                <a:solidFill>
+                  <a:srgbClr val="00E5FF"/>
+                </a:solidFill>
+                <a:latin typeface="Roboto Mono"/>
+                <a:ea typeface="Roboto Mono"/>
+                <a:cs typeface="Roboto Mono"/>
+              </a:rPr>
+              <a:t>          &lt;&lt; '\n';</a:t>
             </a:r>
           </a:p>
         </p:txBody>
@@ -12712,7 +12592,7 @@
           <p:nvPr/>
         </p:nvPicPr>
         <p:blipFill rotWithShape="1">
-          <a:blip xmlns:r="http://schemas.openxmlformats.org/officeDocument/2006/relationships" xmlns:a="http://schemas.openxmlformats.org/drawingml/2006/main" r:embed="Rd5e056ec871c4ed4">
+          <a:blip xmlns:r="http://schemas.openxmlformats.org/officeDocument/2006/relationships" xmlns:a="http://schemas.openxmlformats.org/drawingml/2006/main" r:embed="R657b5b9231b84ae1">
             <a:alphaModFix/>
           </a:blip>
           <a:srcRect xmlns:a="http://schemas.openxmlformats.org/drawingml/2006/main" l="0" t="0" r="0" b="0"/>
@@ -12740,7 +12620,7 @@
           <p:nvPr/>
         </p:nvPicPr>
         <p:blipFill rotWithShape="1">
-          <a:blip xmlns:r="http://schemas.openxmlformats.org/officeDocument/2006/relationships" xmlns:a="http://schemas.openxmlformats.org/drawingml/2006/main" r:embed="Rd5e056ec871c4ed4">
+          <a:blip xmlns:r="http://schemas.openxmlformats.org/officeDocument/2006/relationships" xmlns:a="http://schemas.openxmlformats.org/drawingml/2006/main" r:embed="R657b5b9231b84ae1">
             <a:alphaModFix/>
           </a:blip>
           <a:srcRect xmlns:a="http://schemas.openxmlformats.org/drawingml/2006/main" l="0" t="0" r="0" b="0"/>
@@ -12768,7 +12648,7 @@
           <p:nvPr/>
         </p:nvPicPr>
         <p:blipFill rotWithShape="1">
-          <a:blip xmlns:r="http://schemas.openxmlformats.org/officeDocument/2006/relationships" xmlns:a="http://schemas.openxmlformats.org/drawingml/2006/main" r:embed="Rd5e056ec871c4ed4">
+          <a:blip xmlns:r="http://schemas.openxmlformats.org/officeDocument/2006/relationships" xmlns:a="http://schemas.openxmlformats.org/drawingml/2006/main" r:embed="R657b5b9231b84ae1">
             <a:alphaModFix/>
           </a:blip>
           <a:srcRect xmlns:a="http://schemas.openxmlformats.org/drawingml/2006/main" l="0" t="0" r="0" b="0"/>
@@ -12796,7 +12676,7 @@
           <p:nvPr/>
         </p:nvPicPr>
         <p:blipFill rotWithShape="1">
-          <a:blip xmlns:r="http://schemas.openxmlformats.org/officeDocument/2006/relationships" xmlns:a="http://schemas.openxmlformats.org/drawingml/2006/main" r:embed="Rd5e056ec871c4ed4">
+          <a:blip xmlns:r="http://schemas.openxmlformats.org/officeDocument/2006/relationships" xmlns:a="http://schemas.openxmlformats.org/drawingml/2006/main" r:embed="R657b5b9231b84ae1">
             <a:alphaModFix/>
           </a:blip>
           <a:srcRect xmlns:a="http://schemas.openxmlformats.org/drawingml/2006/main" l="0" t="0" r="0" b="0"/>
@@ -13394,7 +13274,7 @@
                 <a:ea typeface="Inter"/>
                 <a:cs typeface="Inter"/>
               </a:rPr>
-              <a:t>Attach. Print. Add context.</a:t>
+              <a:t>Attach. Capture. Add context.</a:t>
             </a:r>
           </a:p>
           <a:p xmlns:a="http://schemas.openxmlformats.org/drawingml/2006/main">
@@ -13446,7 +13326,7 @@
                 <a:ea typeface="Inter"/>
                 <a:cs typeface="Inter"/>
               </a:rPr>
-              <a:t>Common syscall events with PID and process name.</a:t>
+              <a:t>Each run keeps a status log and a syscall JSONL file.</a:t>
             </a:r>
           </a:p>
           <a:p xmlns:a="http://schemas.openxmlformats.org/drawingml/2006/main">
@@ -13550,7 +13430,7 @@
                 <a:ea typeface="Inter"/>
                 <a:cs typeface="Inter"/>
               </a:rPr>
-              <a:t>Step 3 writes the complete collector. Run rebuilds and captures.</a:t>
+              <a:t>Step 3 writes the complete collector.</a:t>
             </a:r>
           </a:p>
         </p:txBody>
@@ -13820,7 +13700,7 @@
                 <a:ea typeface="Roboto Mono"/>
                 <a:cs typeface="Roboto Mono"/>
               </a:rPr>
-              <a:t>Example output; PID and count will vary</a:t>
+              <a:t>Output excerpts; JSON timestamps omitted</a:t>
             </a:r>
           </a:p>
         </p:txBody>
@@ -13910,6 +13790,36 @@
             <a:noAutofit/>
           </a:bodyPr>
           <a:lstStyle xmlns:a="http://schemas.openxmlformats.org/drawingml/2006/main"/>
+          <a:p xmlns:a="http://schemas.openxmlformats.org/drawingml/2006/main">
+            <a:pPr marL="0" indent="0" algn="l">
+              <a:spcBef>
+                <a:spcPts val="0"/>
+              </a:spcBef>
+              <a:spcAft>
+                <a:spcPts val="0"/>
+              </a:spcAft>
+              <a:buNone/>
+              <a:defRPr sz="1350" b="0">
+                <a:solidFill>
+                  <a:srgbClr val="00E5FF"/>
+                </a:solidFill>
+                <a:latin typeface="Roboto Mono"/>
+                <a:ea typeface="Roboto Mono"/>
+                <a:cs typeface="Roboto Mono"/>
+              </a:defRPr>
+            </a:pPr>
+            <a:r>
+              <a:rPr sz="1350" b="0" i="0">
+                <a:solidFill>
+                  <a:srgbClr val="00E5FF"/>
+                </a:solidFill>
+                <a:latin typeface="Roboto Mono"/>
+                <a:ea typeface="Roboto Mono"/>
+                <a:cs typeface="Roboto Mono"/>
+              </a:rPr>
+              <a:t># logs/&lt;run-id&gt;.log</a:t>
+            </a:r>
+          </a:p>
           <a:p xmlns:a="http://schemas.openxmlformats.org/drawingml/2006/main">
             <a:pPr marL="0" indent="0" algn="l">
               <a:spcBef>
@@ -13967,97 +13877,7 @@
                 <a:ea typeface="Roboto Mono"/>
                 <a:cs typeface="Roboto Mono"/>
               </a:rPr>
-              <a:t>openat pid=1234 name=id</a:t>
-            </a:r>
-          </a:p>
-          <a:p xmlns:a="http://schemas.openxmlformats.org/drawingml/2006/main">
-            <a:pPr marL="0" indent="0" algn="l">
-              <a:spcBef>
-                <a:spcPts val="0"/>
-              </a:spcBef>
-              <a:spcAft>
-                <a:spcPts val="0"/>
-              </a:spcAft>
-              <a:buNone/>
-              <a:defRPr sz="1350" b="0">
-                <a:solidFill>
-                  <a:srgbClr val="00E5FF"/>
-                </a:solidFill>
-                <a:latin typeface="Roboto Mono"/>
-                <a:ea typeface="Roboto Mono"/>
-                <a:cs typeface="Roboto Mono"/>
-              </a:defRPr>
-            </a:pPr>
-            <a:r>
-              <a:rPr sz="1350" b="0" i="0">
-                <a:solidFill>
-                  <a:srgbClr val="00E5FF"/>
-                </a:solidFill>
-                <a:latin typeface="Roboto Mono"/>
-                <a:ea typeface="Roboto Mono"/>
-                <a:cs typeface="Roboto Mono"/>
-              </a:rPr>
-              <a:t>read pid=1234 name=id</a:t>
-            </a:r>
-          </a:p>
-          <a:p xmlns:a="http://schemas.openxmlformats.org/drawingml/2006/main">
-            <a:pPr marL="0" indent="0" algn="l">
-              <a:spcBef>
-                <a:spcPts val="0"/>
-              </a:spcBef>
-              <a:spcAft>
-                <a:spcPts val="0"/>
-              </a:spcAft>
-              <a:buNone/>
-              <a:defRPr sz="1350" b="0">
-                <a:solidFill>
-                  <a:srgbClr val="00E5FF"/>
-                </a:solidFill>
-                <a:latin typeface="Roboto Mono"/>
-                <a:ea typeface="Roboto Mono"/>
-                <a:cs typeface="Roboto Mono"/>
-              </a:defRPr>
-            </a:pPr>
-            <a:r>
-              <a:rPr sz="1350" b="0" i="0">
-                <a:solidFill>
-                  <a:srgbClr val="00E5FF"/>
-                </a:solidFill>
-                <a:latin typeface="Roboto Mono"/>
-                <a:ea typeface="Roboto Mono"/>
-                <a:cs typeface="Roboto Mono"/>
-              </a:rPr>
-              <a:t>close pid=1234 name=id</a:t>
-            </a:r>
-          </a:p>
-          <a:p xmlns:a="http://schemas.openxmlformats.org/drawingml/2006/main">
-            <a:pPr marL="0" indent="0" algn="l">
-              <a:spcBef>
-                <a:spcPts val="0"/>
-              </a:spcBef>
-              <a:spcAft>
-                <a:spcPts val="0"/>
-              </a:spcAft>
-              <a:buNone/>
-              <a:defRPr sz="1350" b="0">
-                <a:solidFill>
-                  <a:srgbClr val="00E5FF"/>
-                </a:solidFill>
-                <a:latin typeface="Roboto Mono"/>
-                <a:ea typeface="Roboto Mono"/>
-                <a:cs typeface="Roboto Mono"/>
-              </a:defRPr>
-            </a:pPr>
-            <a:r>
-              <a:rPr sz="1350" b="0" i="0">
-                <a:solidFill>
-                  <a:srgbClr val="00E5FF"/>
-                </a:solidFill>
-                <a:latin typeface="Roboto Mono"/>
-                <a:ea typeface="Roboto Mono"/>
-                <a:cs typeface="Roboto Mono"/>
-              </a:rPr>
-              <a:t>...</a:t>
+              <a:t>Read 582 events into user space.</a:t>
             </a:r>
           </a:p>
           <a:p xmlns:a="http://schemas.openxmlformats.org/drawingml/2006/main">
@@ -14139,7 +13959,7 @@
                 <a:ea typeface="Roboto Mono"/>
                 <a:cs typeface="Roboto Mono"/>
               </a:rPr>
-              <a:t># Saved on your laptop</a:t>
+              <a:t># logs/&lt;run-id&gt;.jsonl</a:t>
             </a:r>
           </a:p>
           <a:p xmlns:a="http://schemas.openxmlformats.org/drawingml/2006/main">
@@ -14169,7 +13989,37 @@
                 <a:ea typeface="Roboto Mono"/>
                 <a:cs typeface="Roboto Mono"/>
               </a:rPr>
-              <a:t>logs/latest.log</a:t>
+              <a:t>{"event":"openat","pid":1234,"name":"id"}</a:t>
+            </a:r>
+          </a:p>
+          <a:p xmlns:a="http://schemas.openxmlformats.org/drawingml/2006/main">
+            <a:pPr marL="0" indent="0" algn="l">
+              <a:spcBef>
+                <a:spcPts val="0"/>
+              </a:spcBef>
+              <a:spcAft>
+                <a:spcPts val="0"/>
+              </a:spcAft>
+              <a:buNone/>
+              <a:defRPr sz="1350" b="0">
+                <a:solidFill>
+                  <a:srgbClr val="00E5FF"/>
+                </a:solidFill>
+                <a:latin typeface="Roboto Mono"/>
+                <a:ea typeface="Roboto Mono"/>
+                <a:cs typeface="Roboto Mono"/>
+              </a:defRPr>
+            </a:pPr>
+            <a:r>
+              <a:rPr sz="1350" b="0" i="0">
+                <a:solidFill>
+                  <a:srgbClr val="00E5FF"/>
+                </a:solidFill>
+                <a:latin typeface="Roboto Mono"/>
+                <a:ea typeface="Roboto Mono"/>
+                <a:cs typeface="Roboto Mono"/>
+              </a:rPr>
+              <a:t>{"event":"read","pid":1234,"name":"id"}</a:t>
             </a:r>
           </a:p>
         </p:txBody>
@@ -14819,7 +14669,7 @@
           <p:nvPr/>
         </p:nvPicPr>
         <p:blipFill rotWithShape="1">
-          <a:blip xmlns:r="http://schemas.openxmlformats.org/officeDocument/2006/relationships" xmlns:a="http://schemas.openxmlformats.org/drawingml/2006/main" r:embed="R6a4a0b2788ea4010">
+          <a:blip xmlns:r="http://schemas.openxmlformats.org/officeDocument/2006/relationships" xmlns:a="http://schemas.openxmlformats.org/drawingml/2006/main" r:embed="Rcf71b97f2dbb4bd8">
             <a:alphaModFix/>
           </a:blip>
           <a:srcRect xmlns:a="http://schemas.openxmlformats.org/drawingml/2006/main" l="0" t="0" r="0" b="0"/>
@@ -14847,7 +14697,7 @@
           <p:nvPr/>
         </p:nvPicPr>
         <p:blipFill rotWithShape="1">
-          <a:blip xmlns:r="http://schemas.openxmlformats.org/officeDocument/2006/relationships" xmlns:a="http://schemas.openxmlformats.org/drawingml/2006/main" r:embed="R6a4a0b2788ea4010">
+          <a:blip xmlns:r="http://schemas.openxmlformats.org/officeDocument/2006/relationships" xmlns:a="http://schemas.openxmlformats.org/drawingml/2006/main" r:embed="Rcf71b97f2dbb4bd8">
             <a:alphaModFix/>
           </a:blip>
           <a:srcRect xmlns:a="http://schemas.openxmlformats.org/drawingml/2006/main" l="0" t="0" r="0" b="0"/>
@@ -14875,7 +14725,7 @@
           <p:nvPr/>
         </p:nvPicPr>
         <p:blipFill rotWithShape="1">
-          <a:blip xmlns:r="http://schemas.openxmlformats.org/officeDocument/2006/relationships" xmlns:a="http://schemas.openxmlformats.org/drawingml/2006/main" r:embed="R6a4a0b2788ea4010">
+          <a:blip xmlns:r="http://schemas.openxmlformats.org/officeDocument/2006/relationships" xmlns:a="http://schemas.openxmlformats.org/drawingml/2006/main" r:embed="Rcf71b97f2dbb4bd8">
             <a:alphaModFix/>
           </a:blip>
           <a:srcRect xmlns:a="http://schemas.openxmlformats.org/drawingml/2006/main" l="0" t="0" r="0" b="0"/>
@@ -14903,7 +14753,7 @@
           <p:nvPr/>
         </p:nvPicPr>
         <p:blipFill rotWithShape="1">
-          <a:blip xmlns:r="http://schemas.openxmlformats.org/officeDocument/2006/relationships" xmlns:a="http://schemas.openxmlformats.org/drawingml/2006/main" r:embed="R6a4a0b2788ea4010">
+          <a:blip xmlns:r="http://schemas.openxmlformats.org/officeDocument/2006/relationships" xmlns:a="http://schemas.openxmlformats.org/drawingml/2006/main" r:embed="Rcf71b97f2dbb4bd8">
             <a:alphaModFix/>
           </a:blip>
           <a:srcRect xmlns:a="http://schemas.openxmlformats.org/drawingml/2006/main" l="0" t="0" r="0" b="0"/>
@@ -16724,7 +16574,7 @@
           <p:nvPr/>
         </p:nvPicPr>
         <p:blipFill rotWithShape="1">
-          <a:blip xmlns:r="http://schemas.openxmlformats.org/officeDocument/2006/relationships" xmlns:a="http://schemas.openxmlformats.org/drawingml/2006/main" r:embed="R82bb0430659e4d22">
+          <a:blip xmlns:r="http://schemas.openxmlformats.org/officeDocument/2006/relationships" xmlns:a="http://schemas.openxmlformats.org/drawingml/2006/main" r:embed="Rcb7022011ba54e17">
             <a:alphaModFix/>
           </a:blip>
           <a:srcRect xmlns:a="http://schemas.openxmlformats.org/drawingml/2006/main" l="0" t="0" r="0" b="0"/>
@@ -16752,7 +16602,7 @@
           <p:nvPr/>
         </p:nvPicPr>
         <p:blipFill rotWithShape="1">
-          <a:blip xmlns:r="http://schemas.openxmlformats.org/officeDocument/2006/relationships" xmlns:a="http://schemas.openxmlformats.org/drawingml/2006/main" r:embed="R82bb0430659e4d22">
+          <a:blip xmlns:r="http://schemas.openxmlformats.org/officeDocument/2006/relationships" xmlns:a="http://schemas.openxmlformats.org/drawingml/2006/main" r:embed="Rcb7022011ba54e17">
             <a:alphaModFix/>
           </a:blip>
           <a:srcRect xmlns:a="http://schemas.openxmlformats.org/drawingml/2006/main" l="0" t="0" r="0" b="0"/>
@@ -16780,7 +16630,7 @@
           <p:nvPr/>
         </p:nvPicPr>
         <p:blipFill rotWithShape="1">
-          <a:blip xmlns:r="http://schemas.openxmlformats.org/officeDocument/2006/relationships" xmlns:a="http://schemas.openxmlformats.org/drawingml/2006/main" r:embed="R82bb0430659e4d22">
+          <a:blip xmlns:r="http://schemas.openxmlformats.org/officeDocument/2006/relationships" xmlns:a="http://schemas.openxmlformats.org/drawingml/2006/main" r:embed="Rcb7022011ba54e17">
             <a:alphaModFix/>
           </a:blip>
           <a:srcRect xmlns:a="http://schemas.openxmlformats.org/drawingml/2006/main" l="0" t="0" r="0" b="0"/>
@@ -16808,7 +16658,7 @@
           <p:nvPr/>
         </p:nvPicPr>
         <p:blipFill rotWithShape="1">
-          <a:blip xmlns:r="http://schemas.openxmlformats.org/officeDocument/2006/relationships" xmlns:a="http://schemas.openxmlformats.org/drawingml/2006/main" r:embed="R82bb0430659e4d22">
+          <a:blip xmlns:r="http://schemas.openxmlformats.org/officeDocument/2006/relationships" xmlns:a="http://schemas.openxmlformats.org/drawingml/2006/main" r:embed="Rcb7022011ba54e17">
             <a:alphaModFix/>
           </a:blip>
           <a:srcRect xmlns:a="http://schemas.openxmlformats.org/drawingml/2006/main" l="0" t="0" r="0" b="0"/>
@@ -17949,7 +17799,7 @@
                 <a:ea typeface="Roboto Mono"/>
                 <a:cs typeface="Roboto Mono"/>
               </a:rPr>
-              <a:t>Step 2: Print events</a:t>
+              <a:t>Step 2: Write JSONL events</a:t>
             </a:r>
           </a:p>
           <a:p xmlns:a="http://schemas.openxmlformats.org/drawingml/2006/main">
@@ -18651,7 +18501,7 @@
           <p:nvPr/>
         </p:nvPicPr>
         <p:blipFill rotWithShape="1">
-          <a:blip xmlns:r="http://schemas.openxmlformats.org/officeDocument/2006/relationships" xmlns:a="http://schemas.openxmlformats.org/drawingml/2006/main" r:embed="R4e28017d02b14988">
+          <a:blip xmlns:r="http://schemas.openxmlformats.org/officeDocument/2006/relationships" xmlns:a="http://schemas.openxmlformats.org/drawingml/2006/main" r:embed="R1a3a015c918441d4">
             <a:alphaModFix/>
           </a:blip>
           <a:srcRect xmlns:a="http://schemas.openxmlformats.org/drawingml/2006/main" l="0" t="0" r="0" b="0"/>
@@ -18679,7 +18529,7 @@
           <p:nvPr/>
         </p:nvPicPr>
         <p:blipFill rotWithShape="1">
-          <a:blip xmlns:r="http://schemas.openxmlformats.org/officeDocument/2006/relationships" xmlns:a="http://schemas.openxmlformats.org/drawingml/2006/main" r:embed="R4e28017d02b14988">
+          <a:blip xmlns:r="http://schemas.openxmlformats.org/officeDocument/2006/relationships" xmlns:a="http://schemas.openxmlformats.org/drawingml/2006/main" r:embed="R1a3a015c918441d4">
             <a:alphaModFix/>
           </a:blip>
           <a:srcRect xmlns:a="http://schemas.openxmlformats.org/drawingml/2006/main" l="0" t="0" r="0" b="0"/>
@@ -18707,7 +18557,7 @@
           <p:nvPr/>
         </p:nvPicPr>
         <p:blipFill rotWithShape="1">
-          <a:blip xmlns:r="http://schemas.openxmlformats.org/officeDocument/2006/relationships" xmlns:a="http://schemas.openxmlformats.org/drawingml/2006/main" r:embed="R4e28017d02b14988">
+          <a:blip xmlns:r="http://schemas.openxmlformats.org/officeDocument/2006/relationships" xmlns:a="http://schemas.openxmlformats.org/drawingml/2006/main" r:embed="R1a3a015c918441d4">
             <a:alphaModFix/>
           </a:blip>
           <a:srcRect xmlns:a="http://schemas.openxmlformats.org/drawingml/2006/main" l="0" t="0" r="0" b="0"/>
@@ -18735,7 +18585,7 @@
           <p:nvPr/>
         </p:nvPicPr>
         <p:blipFill rotWithShape="1">
-          <a:blip xmlns:r="http://schemas.openxmlformats.org/officeDocument/2006/relationships" xmlns:a="http://schemas.openxmlformats.org/drawingml/2006/main" r:embed="R4e28017d02b14988">
+          <a:blip xmlns:r="http://schemas.openxmlformats.org/officeDocument/2006/relationships" xmlns:a="http://schemas.openxmlformats.org/drawingml/2006/main" r:embed="R1a3a015c918441d4">
             <a:alphaModFix/>
           </a:blip>
           <a:srcRect xmlns:a="http://schemas.openxmlformats.org/drawingml/2006/main" l="0" t="0" r="0" b="0"/>
@@ -20348,7 +20198,7 @@
           <p:nvPr/>
         </p:nvPicPr>
         <p:blipFill rotWithShape="1">
-          <a:blip xmlns:r="http://schemas.openxmlformats.org/officeDocument/2006/relationships" xmlns:a="http://schemas.openxmlformats.org/drawingml/2006/main" r:embed="Rcf039cb733d544b6">
+          <a:blip xmlns:r="http://schemas.openxmlformats.org/officeDocument/2006/relationships" xmlns:a="http://schemas.openxmlformats.org/drawingml/2006/main" r:embed="Rc778226c81b54cd4">
             <a:alphaModFix/>
           </a:blip>
           <a:srcRect xmlns:a="http://schemas.openxmlformats.org/drawingml/2006/main" l="0" t="0" r="0" b="0"/>
@@ -20376,7 +20226,7 @@
           <p:nvPr/>
         </p:nvPicPr>
         <p:blipFill rotWithShape="1">
-          <a:blip xmlns:r="http://schemas.openxmlformats.org/officeDocument/2006/relationships" xmlns:a="http://schemas.openxmlformats.org/drawingml/2006/main" r:embed="Rcf039cb733d544b6">
+          <a:blip xmlns:r="http://schemas.openxmlformats.org/officeDocument/2006/relationships" xmlns:a="http://schemas.openxmlformats.org/drawingml/2006/main" r:embed="Rc778226c81b54cd4">
             <a:alphaModFix/>
           </a:blip>
           <a:srcRect xmlns:a="http://schemas.openxmlformats.org/drawingml/2006/main" l="0" t="0" r="0" b="0"/>
@@ -20404,7 +20254,7 @@
           <p:nvPr/>
         </p:nvPicPr>
         <p:blipFill rotWithShape="1">
-          <a:blip xmlns:r="http://schemas.openxmlformats.org/officeDocument/2006/relationships" xmlns:a="http://schemas.openxmlformats.org/drawingml/2006/main" r:embed="Rcf039cb733d544b6">
+          <a:blip xmlns:r="http://schemas.openxmlformats.org/officeDocument/2006/relationships" xmlns:a="http://schemas.openxmlformats.org/drawingml/2006/main" r:embed="Rc778226c81b54cd4">
             <a:alphaModFix/>
           </a:blip>
           <a:srcRect xmlns:a="http://schemas.openxmlformats.org/drawingml/2006/main" l="0" t="0" r="0" b="0"/>
@@ -20432,7 +20282,7 @@
           <p:nvPr/>
         </p:nvPicPr>
         <p:blipFill rotWithShape="1">
-          <a:blip xmlns:r="http://schemas.openxmlformats.org/officeDocument/2006/relationships" xmlns:a="http://schemas.openxmlformats.org/drawingml/2006/main" r:embed="Rcf039cb733d544b6">
+          <a:blip xmlns:r="http://schemas.openxmlformats.org/officeDocument/2006/relationships" xmlns:a="http://schemas.openxmlformats.org/drawingml/2006/main" r:embed="Rc778226c81b54cd4">
             <a:alphaModFix/>
           </a:blip>
           <a:srcRect xmlns:a="http://schemas.openxmlformats.org/drawingml/2006/main" l="0" t="0" r="0" b="0"/>
@@ -22045,7 +21895,7 @@
           <p:nvPr/>
         </p:nvPicPr>
         <p:blipFill rotWithShape="1">
-          <a:blip xmlns:r="http://schemas.openxmlformats.org/officeDocument/2006/relationships" xmlns:a="http://schemas.openxmlformats.org/drawingml/2006/main" r:embed="R6baa8eb715204693">
+          <a:blip xmlns:r="http://schemas.openxmlformats.org/officeDocument/2006/relationships" xmlns:a="http://schemas.openxmlformats.org/drawingml/2006/main" r:embed="R4fb6647da8e84e31">
             <a:alphaModFix/>
           </a:blip>
           <a:srcRect xmlns:a="http://schemas.openxmlformats.org/drawingml/2006/main" l="0" t="0" r="0" b="0"/>
@@ -22073,7 +21923,7 @@
           <p:nvPr/>
         </p:nvPicPr>
         <p:blipFill rotWithShape="1">
-          <a:blip xmlns:r="http://schemas.openxmlformats.org/officeDocument/2006/relationships" xmlns:a="http://schemas.openxmlformats.org/drawingml/2006/main" r:embed="R6baa8eb715204693">
+          <a:blip xmlns:r="http://schemas.openxmlformats.org/officeDocument/2006/relationships" xmlns:a="http://schemas.openxmlformats.org/drawingml/2006/main" r:embed="R4fb6647da8e84e31">
             <a:alphaModFix/>
           </a:blip>
           <a:srcRect xmlns:a="http://schemas.openxmlformats.org/drawingml/2006/main" l="0" t="0" r="0" b="0"/>
@@ -22101,7 +21951,7 @@
           <p:nvPr/>
         </p:nvPicPr>
         <p:blipFill rotWithShape="1">
-          <a:blip xmlns:r="http://schemas.openxmlformats.org/officeDocument/2006/relationships" xmlns:a="http://schemas.openxmlformats.org/drawingml/2006/main" r:embed="R6baa8eb715204693">
+          <a:blip xmlns:r="http://schemas.openxmlformats.org/officeDocument/2006/relationships" xmlns:a="http://schemas.openxmlformats.org/drawingml/2006/main" r:embed="R4fb6647da8e84e31">
             <a:alphaModFix/>
           </a:blip>
           <a:srcRect xmlns:a="http://schemas.openxmlformats.org/drawingml/2006/main" l="0" t="0" r="0" b="0"/>
@@ -22129,7 +21979,7 @@
           <p:nvPr/>
         </p:nvPicPr>
         <p:blipFill rotWithShape="1">
-          <a:blip xmlns:r="http://schemas.openxmlformats.org/officeDocument/2006/relationships" xmlns:a="http://schemas.openxmlformats.org/drawingml/2006/main" r:embed="R6baa8eb715204693">
+          <a:blip xmlns:r="http://schemas.openxmlformats.org/officeDocument/2006/relationships" xmlns:a="http://schemas.openxmlformats.org/drawingml/2006/main" r:embed="R4fb6647da8e84e31">
             <a:alphaModFix/>
           </a:blip>
           <a:srcRect xmlns:a="http://schemas.openxmlformats.org/drawingml/2006/main" l="0" t="0" r="0" b="0"/>
@@ -23322,7 +23172,7 @@
                 <a:ea typeface="Roboto Mono"/>
                 <a:cs typeface="Roboto Mono"/>
               </a:rPr>
-              <a:t>Show the result and stop the agent</a:t>
+              <a:t>Show status and stop the agent</a:t>
             </a:r>
           </a:p>
           <a:p xmlns:a="http://schemas.openxmlformats.org/drawingml/2006/main">
@@ -23374,7 +23224,37 @@
                 <a:ea typeface="Roboto Mono"/>
                 <a:cs typeface="Roboto Mono"/>
               </a:rPr>
-              <a:t>Save output to logs/latest.log</a:t>
+              <a:t>Save logs/&lt;run-id&gt;.log</a:t>
+            </a:r>
+          </a:p>
+          <a:p xmlns:a="http://schemas.openxmlformats.org/drawingml/2006/main">
+            <a:pPr marL="0" indent="0" algn="l">
+              <a:spcBef>
+                <a:spcPts val="0"/>
+              </a:spcBef>
+              <a:spcAft>
+                <a:spcPts val="0"/>
+              </a:spcAft>
+              <a:buNone/>
+              <a:defRPr sz="1350" b="0">
+                <a:solidFill>
+                  <a:srgbClr val="00E5FF"/>
+                </a:solidFill>
+                <a:latin typeface="Roboto Mono"/>
+                <a:ea typeface="Roboto Mono"/>
+                <a:cs typeface="Roboto Mono"/>
+              </a:defRPr>
+            </a:pPr>
+            <a:r>
+              <a:rPr sz="1350" b="0" i="0">
+                <a:solidFill>
+                  <a:srgbClr val="00E5FF"/>
+                </a:solidFill>
+                <a:latin typeface="Roboto Mono"/>
+                <a:ea typeface="Roboto Mono"/>
+                <a:cs typeface="Roboto Mono"/>
+              </a:rPr>
+              <a:t>and logs/&lt;run-id&gt;.jsonl</a:t>
             </a:r>
           </a:p>
         </p:txBody>
@@ -24024,7 +23904,7 @@
           <p:nvPr/>
         </p:nvPicPr>
         <p:blipFill rotWithShape="1">
-          <a:blip xmlns:r="http://schemas.openxmlformats.org/officeDocument/2006/relationships" xmlns:a="http://schemas.openxmlformats.org/drawingml/2006/main" r:embed="R81e377c9c65b45ea">
+          <a:blip xmlns:r="http://schemas.openxmlformats.org/officeDocument/2006/relationships" xmlns:a="http://schemas.openxmlformats.org/drawingml/2006/main" r:embed="Ra121ccf1f9c74981">
             <a:alphaModFix/>
           </a:blip>
           <a:srcRect xmlns:a="http://schemas.openxmlformats.org/drawingml/2006/main" l="0" t="0" r="0" b="0"/>
@@ -24052,7 +23932,7 @@
           <p:nvPr/>
         </p:nvPicPr>
         <p:blipFill rotWithShape="1">
-          <a:blip xmlns:r="http://schemas.openxmlformats.org/officeDocument/2006/relationships" xmlns:a="http://schemas.openxmlformats.org/drawingml/2006/main" r:embed="R81e377c9c65b45ea">
+          <a:blip xmlns:r="http://schemas.openxmlformats.org/officeDocument/2006/relationships" xmlns:a="http://schemas.openxmlformats.org/drawingml/2006/main" r:embed="Ra121ccf1f9c74981">
             <a:alphaModFix/>
           </a:blip>
           <a:srcRect xmlns:a="http://schemas.openxmlformats.org/drawingml/2006/main" l="0" t="0" r="0" b="0"/>
@@ -24080,7 +23960,7 @@
           <p:nvPr/>
         </p:nvPicPr>
         <p:blipFill rotWithShape="1">
-          <a:blip xmlns:r="http://schemas.openxmlformats.org/officeDocument/2006/relationships" xmlns:a="http://schemas.openxmlformats.org/drawingml/2006/main" r:embed="R81e377c9c65b45ea">
+          <a:blip xmlns:r="http://schemas.openxmlformats.org/officeDocument/2006/relationships" xmlns:a="http://schemas.openxmlformats.org/drawingml/2006/main" r:embed="Ra121ccf1f9c74981">
             <a:alphaModFix/>
           </a:blip>
           <a:srcRect xmlns:a="http://schemas.openxmlformats.org/drawingml/2006/main" l="0" t="0" r="0" b="0"/>
@@ -24108,7 +23988,7 @@
           <p:nvPr/>
         </p:nvPicPr>
         <p:blipFill rotWithShape="1">
-          <a:blip xmlns:r="http://schemas.openxmlformats.org/officeDocument/2006/relationships" xmlns:a="http://schemas.openxmlformats.org/drawingml/2006/main" r:embed="R81e377c9c65b45ea">
+          <a:blip xmlns:r="http://schemas.openxmlformats.org/officeDocument/2006/relationships" xmlns:a="http://schemas.openxmlformats.org/drawingml/2006/main" r:embed="Ra121ccf1f9c74981">
             <a:alphaModFix/>
           </a:blip>
           <a:srcRect xmlns:a="http://schemas.openxmlformats.org/drawingml/2006/main" l="0" t="0" r="0" b="0"/>
@@ -25789,7 +25669,7 @@
           <p:nvPr/>
         </p:nvPicPr>
         <p:blipFill rotWithShape="1">
-          <a:blip xmlns:r="http://schemas.openxmlformats.org/officeDocument/2006/relationships" xmlns:a="http://schemas.openxmlformats.org/drawingml/2006/main" r:embed="R22dedbc53ce24927">
+          <a:blip xmlns:r="http://schemas.openxmlformats.org/officeDocument/2006/relationships" xmlns:a="http://schemas.openxmlformats.org/drawingml/2006/main" r:embed="Ra53d69afc62642db">
             <a:alphaModFix/>
           </a:blip>
           <a:srcRect xmlns:a="http://schemas.openxmlformats.org/drawingml/2006/main" l="0" t="0" r="0" b="0"/>
@@ -25817,7 +25697,7 @@
           <p:nvPr/>
         </p:nvPicPr>
         <p:blipFill rotWithShape="1">
-          <a:blip xmlns:r="http://schemas.openxmlformats.org/officeDocument/2006/relationships" xmlns:a="http://schemas.openxmlformats.org/drawingml/2006/main" r:embed="R22dedbc53ce24927">
+          <a:blip xmlns:r="http://schemas.openxmlformats.org/officeDocument/2006/relationships" xmlns:a="http://schemas.openxmlformats.org/drawingml/2006/main" r:embed="Ra53d69afc62642db">
             <a:alphaModFix/>
           </a:blip>
           <a:srcRect xmlns:a="http://schemas.openxmlformats.org/drawingml/2006/main" l="0" t="0" r="0" b="0"/>
@@ -25845,7 +25725,7 @@
           <p:nvPr/>
         </p:nvPicPr>
         <p:blipFill rotWithShape="1">
-          <a:blip xmlns:r="http://schemas.openxmlformats.org/officeDocument/2006/relationships" xmlns:a="http://schemas.openxmlformats.org/drawingml/2006/main" r:embed="R22dedbc53ce24927">
+          <a:blip xmlns:r="http://schemas.openxmlformats.org/officeDocument/2006/relationships" xmlns:a="http://schemas.openxmlformats.org/drawingml/2006/main" r:embed="Ra53d69afc62642db">
             <a:alphaModFix/>
           </a:blip>
           <a:srcRect xmlns:a="http://schemas.openxmlformats.org/drawingml/2006/main" l="0" t="0" r="0" b="0"/>
@@ -25873,7 +25753,7 @@
           <p:nvPr/>
         </p:nvPicPr>
         <p:blipFill rotWithShape="1">
-          <a:blip xmlns:r="http://schemas.openxmlformats.org/officeDocument/2006/relationships" xmlns:a="http://schemas.openxmlformats.org/drawingml/2006/main" r:embed="R22dedbc53ce24927">
+          <a:blip xmlns:r="http://schemas.openxmlformats.org/officeDocument/2006/relationships" xmlns:a="http://schemas.openxmlformats.org/drawingml/2006/main" r:embed="Ra53d69afc62642db">
             <a:alphaModFix/>
           </a:blip>
           <a:srcRect xmlns:a="http://schemas.openxmlformats.org/drawingml/2006/main" l="0" t="0" r="0" b="0"/>
@@ -27554,7 +27434,7 @@
           <p:nvPr/>
         </p:nvPicPr>
         <p:blipFill rotWithShape="1">
-          <a:blip xmlns:r="http://schemas.openxmlformats.org/officeDocument/2006/relationships" xmlns:a="http://schemas.openxmlformats.org/drawingml/2006/main" r:embed="R91e45b17df67497f">
+          <a:blip xmlns:r="http://schemas.openxmlformats.org/officeDocument/2006/relationships" xmlns:a="http://schemas.openxmlformats.org/drawingml/2006/main" r:embed="Rc5ba3053f6314db1">
             <a:alphaModFix/>
           </a:blip>
           <a:srcRect xmlns:a="http://schemas.openxmlformats.org/drawingml/2006/main" l="0" t="0" r="0" b="0"/>
@@ -27582,7 +27462,7 @@
           <p:nvPr/>
         </p:nvPicPr>
         <p:blipFill rotWithShape="1">
-          <a:blip xmlns:r="http://schemas.openxmlformats.org/officeDocument/2006/relationships" xmlns:a="http://schemas.openxmlformats.org/drawingml/2006/main" r:embed="R91e45b17df67497f">
+          <a:blip xmlns:r="http://schemas.openxmlformats.org/officeDocument/2006/relationships" xmlns:a="http://schemas.openxmlformats.org/drawingml/2006/main" r:embed="Rc5ba3053f6314db1">
             <a:alphaModFix/>
           </a:blip>
           <a:srcRect xmlns:a="http://schemas.openxmlformats.org/drawingml/2006/main" l="0" t="0" r="0" b="0"/>
@@ -27610,7 +27490,7 @@
           <p:nvPr/>
         </p:nvPicPr>
         <p:blipFill rotWithShape="1">
-          <a:blip xmlns:r="http://schemas.openxmlformats.org/officeDocument/2006/relationships" xmlns:a="http://schemas.openxmlformats.org/drawingml/2006/main" r:embed="R91e45b17df67497f">
+          <a:blip xmlns:r="http://schemas.openxmlformats.org/officeDocument/2006/relationships" xmlns:a="http://schemas.openxmlformats.org/drawingml/2006/main" r:embed="Rc5ba3053f6314db1">
             <a:alphaModFix/>
           </a:blip>
           <a:srcRect xmlns:a="http://schemas.openxmlformats.org/drawingml/2006/main" l="0" t="0" r="0" b="0"/>
@@ -27638,7 +27518,7 @@
           <p:nvPr/>
         </p:nvPicPr>
         <p:blipFill rotWithShape="1">
-          <a:blip xmlns:r="http://schemas.openxmlformats.org/officeDocument/2006/relationships" xmlns:a="http://schemas.openxmlformats.org/drawingml/2006/main" r:embed="R91e45b17df67497f">
+          <a:blip xmlns:r="http://schemas.openxmlformats.org/officeDocument/2006/relationships" xmlns:a="http://schemas.openxmlformats.org/drawingml/2006/main" r:embed="Rc5ba3053f6314db1">
             <a:alphaModFix/>
           </a:blip>
           <a:srcRect xmlns:a="http://schemas.openxmlformats.org/drawingml/2006/main" l="0" t="0" r="0" b="0"/>
@@ -28959,7 +28839,7 @@
                 <a:ea typeface="Roboto Mono"/>
                 <a:cs typeface="Roboto Mono"/>
               </a:rPr>
-              <a:t>std::cout &lt;&lt; "Attached." &lt;&lt; std::endl;</a:t>
+              <a:t>std::cerr &lt;&lt; "Attached." &lt;&lt; std::endl;</a:t>
             </a:r>
           </a:p>
           <a:p xmlns:a="http://schemas.openxmlformats.org/drawingml/2006/main">
@@ -29729,7 +29609,7 @@
           <p:nvPr/>
         </p:nvPicPr>
         <p:blipFill rotWithShape="1">
-          <a:blip xmlns:r="http://schemas.openxmlformats.org/officeDocument/2006/relationships" xmlns:a="http://schemas.openxmlformats.org/drawingml/2006/main" r:embed="R337952a2c23e40ed">
+          <a:blip xmlns:r="http://schemas.openxmlformats.org/officeDocument/2006/relationships" xmlns:a="http://schemas.openxmlformats.org/drawingml/2006/main" r:embed="R9101883c3dff4cd5">
             <a:alphaModFix/>
           </a:blip>
           <a:srcRect xmlns:a="http://schemas.openxmlformats.org/drawingml/2006/main" l="0" t="0" r="0" b="0"/>
@@ -29757,7 +29637,7 @@
           <p:nvPr/>
         </p:nvPicPr>
         <p:blipFill rotWithShape="1">
-          <a:blip xmlns:r="http://schemas.openxmlformats.org/officeDocument/2006/relationships" xmlns:a="http://schemas.openxmlformats.org/drawingml/2006/main" r:embed="R337952a2c23e40ed">
+          <a:blip xmlns:r="http://schemas.openxmlformats.org/officeDocument/2006/relationships" xmlns:a="http://schemas.openxmlformats.org/drawingml/2006/main" r:embed="R9101883c3dff4cd5">
             <a:alphaModFix/>
           </a:blip>
           <a:srcRect xmlns:a="http://schemas.openxmlformats.org/drawingml/2006/main" l="0" t="0" r="0" b="0"/>
@@ -29785,7 +29665,7 @@
           <p:nvPr/>
         </p:nvPicPr>
         <p:blipFill rotWithShape="1">
-          <a:blip xmlns:r="http://schemas.openxmlformats.org/officeDocument/2006/relationships" xmlns:a="http://schemas.openxmlformats.org/drawingml/2006/main" r:embed="R337952a2c23e40ed">
+          <a:blip xmlns:r="http://schemas.openxmlformats.org/officeDocument/2006/relationships" xmlns:a="http://schemas.openxmlformats.org/drawingml/2006/main" r:embed="R9101883c3dff4cd5">
             <a:alphaModFix/>
           </a:blip>
           <a:srcRect xmlns:a="http://schemas.openxmlformats.org/drawingml/2006/main" l="0" t="0" r="0" b="0"/>
@@ -29813,7 +29693,7 @@
           <p:nvPr/>
         </p:nvPicPr>
         <p:blipFill rotWithShape="1">
-          <a:blip xmlns:r="http://schemas.openxmlformats.org/officeDocument/2006/relationships" xmlns:a="http://schemas.openxmlformats.org/drawingml/2006/main" r:embed="R337952a2c23e40ed">
+          <a:blip xmlns:r="http://schemas.openxmlformats.org/officeDocument/2006/relationships" xmlns:a="http://schemas.openxmlformats.org/drawingml/2006/main" r:embed="R9101883c3dff4cd5">
             <a:alphaModFix/>
           </a:blip>
           <a:srcRect xmlns:a="http://schemas.openxmlformats.org/drawingml/2006/main" l="0" t="0" r="0" b="0"/>
@@ -30463,7 +30343,7 @@
                 <a:ea typeface="Inter"/>
                 <a:cs typeface="Inter"/>
               </a:rPr>
-              <a:t>Step 2 adds the read loop and prints event names. Run captures for ten seconds.</a:t>
+              <a:t>Step 2 adds the read loop and writes JSONL records. Run captures for ten seconds.</a:t>
             </a:r>
           </a:p>
           <a:p xmlns:a="http://schemas.openxmlformats.org/drawingml/2006/main">
@@ -30875,6 +30755,66 @@
             <a:noAutofit/>
           </a:bodyPr>
           <a:lstStyle xmlns:a="http://schemas.openxmlformats.org/drawingml/2006/main"/>
+          <a:p xmlns:a="http://schemas.openxmlformats.org/drawingml/2006/main">
+            <a:pPr marL="0" indent="0" algn="l">
+              <a:spcBef>
+                <a:spcPts val="0"/>
+              </a:spcBef>
+              <a:spcAft>
+                <a:spcPts val="0"/>
+              </a:spcAft>
+              <a:buNone/>
+              <a:defRPr sz="1350" b="0">
+                <a:solidFill>
+                  <a:srgbClr val="00E5FF"/>
+                </a:solidFill>
+                <a:latin typeface="Roboto Mono"/>
+                <a:ea typeface="Roboto Mono"/>
+                <a:cs typeface="Roboto Mono"/>
+              </a:defRPr>
+            </a:pPr>
+            <a:r>
+              <a:rPr sz="1350" b="0" i="0">
+                <a:solidFill>
+                  <a:srgbClr val="00E5FF"/>
+                </a:solidFill>
+                <a:latin typeface="Roboto Mono"/>
+                <a:ea typeface="Roboto Mono"/>
+                <a:cs typeface="Roboto Mono"/>
+              </a:rPr>
+              <a:t>Json::StreamWriterBuilder json;</a:t>
+            </a:r>
+          </a:p>
+          <a:p xmlns:a="http://schemas.openxmlformats.org/drawingml/2006/main">
+            <a:pPr marL="0" indent="0" algn="l">
+              <a:spcBef>
+                <a:spcPts val="0"/>
+              </a:spcBef>
+              <a:spcAft>
+                <a:spcPts val="0"/>
+              </a:spcAft>
+              <a:buNone/>
+              <a:defRPr sz="1350" b="0">
+                <a:solidFill>
+                  <a:srgbClr val="00E5FF"/>
+                </a:solidFill>
+                <a:latin typeface="Roboto Mono"/>
+                <a:ea typeface="Roboto Mono"/>
+                <a:cs typeface="Roboto Mono"/>
+              </a:defRPr>
+            </a:pPr>
+            <a:r>
+              <a:rPr sz="1350" b="0" i="0">
+                <a:solidFill>
+                  <a:srgbClr val="00E5FF"/>
+                </a:solidFill>
+                <a:latin typeface="Roboto Mono"/>
+                <a:ea typeface="Roboto Mono"/>
+                <a:cs typeface="Roboto Mono"/>
+              </a:rPr>
+              <a:t>json["indentation"] = "";</a:t>
+            </a:r>
+          </a:p>
           <a:p xmlns:a="http://schemas.openxmlformats.org/drawingml/2006/main">
             <a:pPr marL="0" indent="0" algn="l">
               <a:spcBef>
@@ -31792,7 +31732,7 @@
           <p:nvPr/>
         </p:nvPicPr>
         <p:blipFill rotWithShape="1">
-          <a:blip xmlns:r="http://schemas.openxmlformats.org/officeDocument/2006/relationships" xmlns:a="http://schemas.openxmlformats.org/drawingml/2006/main" r:embed="Rf923a1115ac64ab8">
+          <a:blip xmlns:r="http://schemas.openxmlformats.org/officeDocument/2006/relationships" xmlns:a="http://schemas.openxmlformats.org/drawingml/2006/main" r:embed="R8b9a851c2c864597">
             <a:alphaModFix/>
           </a:blip>
           <a:srcRect xmlns:a="http://schemas.openxmlformats.org/drawingml/2006/main" l="0" t="0" r="0" b="0"/>
@@ -31820,7 +31760,7 @@
           <p:nvPr/>
         </p:nvPicPr>
         <p:blipFill rotWithShape="1">
-          <a:blip xmlns:r="http://schemas.openxmlformats.org/officeDocument/2006/relationships" xmlns:a="http://schemas.openxmlformats.org/drawingml/2006/main" r:embed="Rf923a1115ac64ab8">
+          <a:blip xmlns:r="http://schemas.openxmlformats.org/officeDocument/2006/relationships" xmlns:a="http://schemas.openxmlformats.org/drawingml/2006/main" r:embed="R8b9a851c2c864597">
             <a:alphaModFix/>
           </a:blip>
           <a:srcRect xmlns:a="http://schemas.openxmlformats.org/drawingml/2006/main" l="0" t="0" r="0" b="0"/>
@@ -31848,7 +31788,7 @@
           <p:nvPr/>
         </p:nvPicPr>
         <p:blipFill rotWithShape="1">
-          <a:blip xmlns:r="http://schemas.openxmlformats.org/officeDocument/2006/relationships" xmlns:a="http://schemas.openxmlformats.org/drawingml/2006/main" r:embed="Rf923a1115ac64ab8">
+          <a:blip xmlns:r="http://schemas.openxmlformats.org/officeDocument/2006/relationships" xmlns:a="http://schemas.openxmlformats.org/drawingml/2006/main" r:embed="R8b9a851c2c864597">
             <a:alphaModFix/>
           </a:blip>
           <a:srcRect xmlns:a="http://schemas.openxmlformats.org/drawingml/2006/main" l="0" t="0" r="0" b="0"/>
@@ -31876,7 +31816,7 @@
           <p:nvPr/>
         </p:nvPicPr>
         <p:blipFill rotWithShape="1">
-          <a:blip xmlns:r="http://schemas.openxmlformats.org/officeDocument/2006/relationships" xmlns:a="http://schemas.openxmlformats.org/drawingml/2006/main" r:embed="Rf923a1115ac64ab8">
+          <a:blip xmlns:r="http://schemas.openxmlformats.org/officeDocument/2006/relationships" xmlns:a="http://schemas.openxmlformats.org/drawingml/2006/main" r:embed="R8b9a851c2c864597">
             <a:alphaModFix/>
           </a:blip>
           <a:srcRect xmlns:a="http://schemas.openxmlformats.org/drawingml/2006/main" l="0" t="0" r="0" b="0"/>

</xml_diff>

<commit_message>
Finish workshop slides with VM teardown commands
</commit_message>
<xml_diff>
--- a/presentation/falco-libs-intro.pptx
+++ b/presentation/falco-libs-intro.pptx
@@ -2,77 +2,77 @@
 <file path=ppt/presentation.xml><?xml version="1.0" encoding="utf-8"?>
 <p:presentation xmlns:p="http://schemas.openxmlformats.org/presentationml/2006/main" embedTrueTypeFonts="1" saveSubsetFonts="0">
   <p:sldMasterIdLst>
-    <p:sldMasterId xmlns:r="http://schemas.openxmlformats.org/officeDocument/2006/relationships" id="2147483648" r:id="Re6d484a9b46845fc"/>
-    <p:sldMasterId xmlns:r="http://schemas.openxmlformats.org/officeDocument/2006/relationships" id="2147483661" r:id="R887c6a4e5ab548fa"/>
+    <p:sldMasterId xmlns:r="http://schemas.openxmlformats.org/officeDocument/2006/relationships" id="2147483648" r:id="R0d4d352cc9b94e76"/>
+    <p:sldMasterId xmlns:r="http://schemas.openxmlformats.org/officeDocument/2006/relationships" id="2147483661" r:id="Re2b209ded4f64feb"/>
   </p:sldMasterIdLst>
   <p:notesMasterIdLst>
-    <p:notesMasterId xmlns:r="http://schemas.openxmlformats.org/officeDocument/2006/relationships" r:id="R09851ab1c3e94640"/>
+    <p:notesMasterId xmlns:r="http://schemas.openxmlformats.org/officeDocument/2006/relationships" r:id="Rda3d6c5a5c704272"/>
   </p:notesMasterIdLst>
   <p:sldIdLst>
-    <p:sldId xmlns:r="http://schemas.openxmlformats.org/officeDocument/2006/relationships" id="256" r:id="Rb4e04a6f6c2f43f3"/>
-    <p:sldId xmlns:r="http://schemas.openxmlformats.org/officeDocument/2006/relationships" id="257" r:id="R889ca1f2e52b4c98"/>
-    <p:sldId xmlns:r="http://schemas.openxmlformats.org/officeDocument/2006/relationships" id="258" r:id="Rec0d059d954b4f36"/>
-    <p:sldId xmlns:r="http://schemas.openxmlformats.org/officeDocument/2006/relationships" id="259" r:id="Rf649f5bf97004fcc"/>
-    <p:sldId xmlns:r="http://schemas.openxmlformats.org/officeDocument/2006/relationships" id="260" r:id="Rc2e1fb0cb46a4a3f"/>
-    <p:sldId xmlns:r="http://schemas.openxmlformats.org/officeDocument/2006/relationships" id="261" r:id="Ra48084b48cc1484f"/>
-    <p:sldId xmlns:r="http://schemas.openxmlformats.org/officeDocument/2006/relationships" id="262" r:id="R77f9ccde0f304d9a"/>
-    <p:sldId xmlns:r="http://schemas.openxmlformats.org/officeDocument/2006/relationships" id="263" r:id="Rad3cbb0bacc94851"/>
-    <p:sldId xmlns:r="http://schemas.openxmlformats.org/officeDocument/2006/relationships" id="264" r:id="Re386f71dea9f48ce"/>
-    <p:sldId xmlns:r="http://schemas.openxmlformats.org/officeDocument/2006/relationships" id="265" r:id="Rcabd2e90f35a4ada"/>
-    <p:sldId xmlns:r="http://schemas.openxmlformats.org/officeDocument/2006/relationships" id="266" r:id="R7eba62129ba5471d"/>
-    <p:sldId xmlns:r="http://schemas.openxmlformats.org/officeDocument/2006/relationships" id="267" r:id="R572419ae4e4e452d"/>
-    <p:sldId xmlns:r="http://schemas.openxmlformats.org/officeDocument/2006/relationships" id="268" r:id="R818bbdffce5e4006"/>
+    <p:sldId xmlns:r="http://schemas.openxmlformats.org/officeDocument/2006/relationships" id="256" r:id="R529aa0f75a9c4cb8"/>
+    <p:sldId xmlns:r="http://schemas.openxmlformats.org/officeDocument/2006/relationships" id="257" r:id="R88283c45ff21483e"/>
+    <p:sldId xmlns:r="http://schemas.openxmlformats.org/officeDocument/2006/relationships" id="258" r:id="Re41d58fbda484a0b"/>
+    <p:sldId xmlns:r="http://schemas.openxmlformats.org/officeDocument/2006/relationships" id="259" r:id="R5d6d42b938134709"/>
+    <p:sldId xmlns:r="http://schemas.openxmlformats.org/officeDocument/2006/relationships" id="260" r:id="Rb1fd21e8d9d440c5"/>
+    <p:sldId xmlns:r="http://schemas.openxmlformats.org/officeDocument/2006/relationships" id="261" r:id="Rb3e70b05ab20437c"/>
+    <p:sldId xmlns:r="http://schemas.openxmlformats.org/officeDocument/2006/relationships" id="262" r:id="R0fac9e42c1944811"/>
+    <p:sldId xmlns:r="http://schemas.openxmlformats.org/officeDocument/2006/relationships" id="263" r:id="R58cd032e757a4647"/>
+    <p:sldId xmlns:r="http://schemas.openxmlformats.org/officeDocument/2006/relationships" id="264" r:id="R9ba94a813ca246d2"/>
+    <p:sldId xmlns:r="http://schemas.openxmlformats.org/officeDocument/2006/relationships" id="265" r:id="Rfd19382e3b334eb3"/>
+    <p:sldId xmlns:r="http://schemas.openxmlformats.org/officeDocument/2006/relationships" id="266" r:id="R8f25c5e4547e44ac"/>
+    <p:sldId xmlns:r="http://schemas.openxmlformats.org/officeDocument/2006/relationships" id="267" r:id="R54a0bf22f0ec41dc"/>
+    <p:sldId xmlns:r="http://schemas.openxmlformats.org/officeDocument/2006/relationships" id="268" r:id="R211a38c18469431c"/>
   </p:sldIdLst>
   <p:sldSz cx="9144000" cy="5143500"/>
   <p:notesSz cx="6858000" cy="9144000"/>
   <p:embeddedFontLst>
     <p:embeddedFont>
       <p:font typeface="Roboto Mono Medium"/>
-      <p:regular xmlns:r="http://schemas.openxmlformats.org/officeDocument/2006/relationships" r:id="R23a4db0cdf334991"/>
-      <p:bold xmlns:r="http://schemas.openxmlformats.org/officeDocument/2006/relationships" r:id="R94630d5a4fcc469b"/>
-      <p:italic xmlns:r="http://schemas.openxmlformats.org/officeDocument/2006/relationships" r:id="R03867f54b8cc41af"/>
-      <p:boldItalic xmlns:r="http://schemas.openxmlformats.org/officeDocument/2006/relationships" r:id="R0a4d78ede0e34396"/>
+      <p:regular xmlns:r="http://schemas.openxmlformats.org/officeDocument/2006/relationships" r:id="Rb36a4724e5dd4325"/>
+      <p:bold xmlns:r="http://schemas.openxmlformats.org/officeDocument/2006/relationships" r:id="Rdc97bf16fcaa4449"/>
+      <p:italic xmlns:r="http://schemas.openxmlformats.org/officeDocument/2006/relationships" r:id="Rd0225c66cdf74c77"/>
+      <p:boldItalic xmlns:r="http://schemas.openxmlformats.org/officeDocument/2006/relationships" r:id="R8fe89b4002a24846"/>
     </p:embeddedFont>
     <p:embeddedFont>
       <p:font typeface="Inter SemiBold"/>
-      <p:regular xmlns:r="http://schemas.openxmlformats.org/officeDocument/2006/relationships" r:id="Rb8e1632be6e34e24"/>
-      <p:bold xmlns:r="http://schemas.openxmlformats.org/officeDocument/2006/relationships" r:id="R7ab48bd7956e4cdb"/>
-      <p:italic xmlns:r="http://schemas.openxmlformats.org/officeDocument/2006/relationships" r:id="R0938d3fc5fde4381"/>
-      <p:boldItalic xmlns:r="http://schemas.openxmlformats.org/officeDocument/2006/relationships" r:id="R7ce4a11e38a740ec"/>
+      <p:regular xmlns:r="http://schemas.openxmlformats.org/officeDocument/2006/relationships" r:id="R28d8822c446e40e6"/>
+      <p:bold xmlns:r="http://schemas.openxmlformats.org/officeDocument/2006/relationships" r:id="R5707513e015249dd"/>
+      <p:italic xmlns:r="http://schemas.openxmlformats.org/officeDocument/2006/relationships" r:id="R0ee9f79c4b3445d5"/>
+      <p:boldItalic xmlns:r="http://schemas.openxmlformats.org/officeDocument/2006/relationships" r:id="R463093049a5642c0"/>
     </p:embeddedFont>
     <p:embeddedFont>
       <p:font typeface="Montserrat Black"/>
-      <p:bold xmlns:r="http://schemas.openxmlformats.org/officeDocument/2006/relationships" r:id="R36f5da471ad04bd2"/>
-      <p:boldItalic xmlns:r="http://schemas.openxmlformats.org/officeDocument/2006/relationships" r:id="R2d22aa5840564370"/>
+      <p:bold xmlns:r="http://schemas.openxmlformats.org/officeDocument/2006/relationships" r:id="R079ca3921ece4ca7"/>
+      <p:boldItalic xmlns:r="http://schemas.openxmlformats.org/officeDocument/2006/relationships" r:id="Re1c0e9b6355f4a69"/>
     </p:embeddedFont>
     <p:embeddedFont>
       <p:font typeface="Montserrat"/>
-      <p:bold xmlns:r="http://schemas.openxmlformats.org/officeDocument/2006/relationships" r:id="R182dcf7a03e9445d"/>
-      <p:boldItalic xmlns:r="http://schemas.openxmlformats.org/officeDocument/2006/relationships" r:id="R03fe23029e664de2"/>
+      <p:bold xmlns:r="http://schemas.openxmlformats.org/officeDocument/2006/relationships" r:id="R3ca3ba5c49c049b9"/>
+      <p:boldItalic xmlns:r="http://schemas.openxmlformats.org/officeDocument/2006/relationships" r:id="Rea59cf80e5854b12"/>
     </p:embeddedFont>
     <p:embeddedFont>
       <p:font typeface="Inter"/>
-      <p:regular xmlns:r="http://schemas.openxmlformats.org/officeDocument/2006/relationships" r:id="Rc4a8699ee8454d7d"/>
-      <p:bold xmlns:r="http://schemas.openxmlformats.org/officeDocument/2006/relationships" r:id="R6c7fd14e9f7b4a3f"/>
-      <p:italic xmlns:r="http://schemas.openxmlformats.org/officeDocument/2006/relationships" r:id="R4c6e187d8d9641ee"/>
-      <p:boldItalic xmlns:r="http://schemas.openxmlformats.org/officeDocument/2006/relationships" r:id="R1f6359c2dcea4742"/>
+      <p:regular xmlns:r="http://schemas.openxmlformats.org/officeDocument/2006/relationships" r:id="R27c97f697eac4bcc"/>
+      <p:bold xmlns:r="http://schemas.openxmlformats.org/officeDocument/2006/relationships" r:id="Rc1b44cdab5c04416"/>
+      <p:italic xmlns:r="http://schemas.openxmlformats.org/officeDocument/2006/relationships" r:id="Raddf13061f8c4525"/>
+      <p:boldItalic xmlns:r="http://schemas.openxmlformats.org/officeDocument/2006/relationships" r:id="R73fa0e6f5a264723"/>
     </p:embeddedFont>
     <p:embeddedFont>
       <p:font typeface="Montserrat ExtraBold"/>
-      <p:bold xmlns:r="http://schemas.openxmlformats.org/officeDocument/2006/relationships" r:id="Rb4e6b7a3b6d247db"/>
-      <p:boldItalic xmlns:r="http://schemas.openxmlformats.org/officeDocument/2006/relationships" r:id="R150cd316338840c8"/>
+      <p:bold xmlns:r="http://schemas.openxmlformats.org/officeDocument/2006/relationships" r:id="R1d3b116e3adc427e"/>
+      <p:boldItalic xmlns:r="http://schemas.openxmlformats.org/officeDocument/2006/relationships" r:id="R5ce2059d40a34bbf"/>
     </p:embeddedFont>
     <p:embeddedFont>
       <p:font typeface="Roboto Mono"/>
-      <p:bold xmlns:r="http://schemas.openxmlformats.org/officeDocument/2006/relationships" r:id="Rf046e5b821db48f6"/>
-      <p:boldItalic xmlns:r="http://schemas.openxmlformats.org/officeDocument/2006/relationships" r:id="R86cf4ca974b949b7"/>
+      <p:bold xmlns:r="http://schemas.openxmlformats.org/officeDocument/2006/relationships" r:id="R4f5b85ad4e5747a4"/>
+      <p:boldItalic xmlns:r="http://schemas.openxmlformats.org/officeDocument/2006/relationships" r:id="R6e59c31a7a47450f"/>
     </p:embeddedFont>
     <p:embeddedFont>
       <p:font typeface="Inter Medium"/>
-      <p:regular xmlns:r="http://schemas.openxmlformats.org/officeDocument/2006/relationships" r:id="R9b66fb3424c44014"/>
-      <p:bold xmlns:r="http://schemas.openxmlformats.org/officeDocument/2006/relationships" r:id="Rca56d7f95f994edc"/>
-      <p:italic xmlns:r="http://schemas.openxmlformats.org/officeDocument/2006/relationships" r:id="Rb36a33d92f3f4f2b"/>
-      <p:boldItalic xmlns:r="http://schemas.openxmlformats.org/officeDocument/2006/relationships" r:id="Rea86aa512828426a"/>
+      <p:regular xmlns:r="http://schemas.openxmlformats.org/officeDocument/2006/relationships" r:id="R86f1e85634d345bc"/>
+      <p:bold xmlns:r="http://schemas.openxmlformats.org/officeDocument/2006/relationships" r:id="Reff6d545be3a404d"/>
+      <p:italic xmlns:r="http://schemas.openxmlformats.org/officeDocument/2006/relationships" r:id="R45d6a302398d4deb"/>
+      <p:boldItalic xmlns:r="http://schemas.openxmlformats.org/officeDocument/2006/relationships" r:id="R85ac008eebe24eb3"/>
     </p:embeddedFont>
   </p:embeddedFontLst>
 </p:presentation>
@@ -857,7 +857,7 @@
               <a:buNone/>
             </a:pPr>
             <a:r>
-              <a:t>The run script handles sudo inside Ubuntu automatically. Setup prepares the libraries. The numbered scripts create the collector source. Run builds and starts it. Before source exists, run prints No agent yet. Run step 1. If Multipass commands are missing immediately after installation, reopen the host terminal. Setup waits for the Ubuntu image catalog before launch. Windows PowerShell parsing and source generation have passed native checks. The full Windows Multipass workflow still needs a rehearsal. Code and step scripts: https://github.com/julianshalaby-perj/falco-libs-workshop</a:t>
+              <a:t>Run the teardown script for your platform from the same host terminal. It asks for confirmation, then permanently deletes only falco-lab and its disk using multipass delete --purge falco-lab. This ends all activity inside that VM. Local source and logs remain. Other VMs and the Multipass installation remain. Rerun setup to recreate the VM and dependencies. Do not use the global multipass purge command, which affects other deleted VMs. Workshop code: https://github.com/julianshalaby-perj/falco-libs-workshop</a:t>
             </a:r>
             <a:endParaRPr/>
           </a:p>
@@ -5665,18 +5665,18 @@
   </p:cSld>
   <p:clrMap bg1="lt1" tx1="dk1" bg2="dk2" tx2="lt2" accent1="accent1" accent2="accent2" accent3="accent3" accent4="accent4" accent5="accent5" accent6="accent6" hlink="hlink" folHlink="folHlink"/>
   <p:sldLayoutIdLst>
-    <p:sldLayoutId xmlns:r="http://schemas.openxmlformats.org/officeDocument/2006/relationships" id="2147483649" r:id="R6dbcfc24053c4d94"/>
-    <p:sldLayoutId xmlns:r="http://schemas.openxmlformats.org/officeDocument/2006/relationships" id="2147483650" r:id="R83bc9f283144462c"/>
-    <p:sldLayoutId xmlns:r="http://schemas.openxmlformats.org/officeDocument/2006/relationships" id="2147483651" r:id="Rdd4643c26bfd4a1c"/>
-    <p:sldLayoutId xmlns:r="http://schemas.openxmlformats.org/officeDocument/2006/relationships" id="2147483652" r:id="Rdd66bc8872d64733"/>
-    <p:sldLayoutId xmlns:r="http://schemas.openxmlformats.org/officeDocument/2006/relationships" id="2147483653" r:id="Ra20b145a42f44f8f"/>
-    <p:sldLayoutId xmlns:r="http://schemas.openxmlformats.org/officeDocument/2006/relationships" id="2147483654" r:id="R51a83e6d23d94aaf"/>
-    <p:sldLayoutId xmlns:r="http://schemas.openxmlformats.org/officeDocument/2006/relationships" id="2147483655" r:id="R4029f4d2d8584c62"/>
-    <p:sldLayoutId xmlns:r="http://schemas.openxmlformats.org/officeDocument/2006/relationships" id="2147483656" r:id="R0c9dbda793c449b5"/>
-    <p:sldLayoutId xmlns:r="http://schemas.openxmlformats.org/officeDocument/2006/relationships" id="2147483657" r:id="Re28328efef914a23"/>
-    <p:sldLayoutId xmlns:r="http://schemas.openxmlformats.org/officeDocument/2006/relationships" id="2147483658" r:id="R4304908d53864c5d"/>
-    <p:sldLayoutId xmlns:r="http://schemas.openxmlformats.org/officeDocument/2006/relationships" id="2147483659" r:id="R992c295b64f34138"/>
-    <p:sldLayoutId xmlns:r="http://schemas.openxmlformats.org/officeDocument/2006/relationships" id="2147483660" r:id="R76a098c2170242da"/>
+    <p:sldLayoutId xmlns:r="http://schemas.openxmlformats.org/officeDocument/2006/relationships" id="2147483649" r:id="R407108247ff54294"/>
+    <p:sldLayoutId xmlns:r="http://schemas.openxmlformats.org/officeDocument/2006/relationships" id="2147483650" r:id="Rf6ba331ea6ff41ff"/>
+    <p:sldLayoutId xmlns:r="http://schemas.openxmlformats.org/officeDocument/2006/relationships" id="2147483651" r:id="Re136a5e94e4544d9"/>
+    <p:sldLayoutId xmlns:r="http://schemas.openxmlformats.org/officeDocument/2006/relationships" id="2147483652" r:id="Rdb9b92fb16554ef4"/>
+    <p:sldLayoutId xmlns:r="http://schemas.openxmlformats.org/officeDocument/2006/relationships" id="2147483653" r:id="Rc9799ff28ad04177"/>
+    <p:sldLayoutId xmlns:r="http://schemas.openxmlformats.org/officeDocument/2006/relationships" id="2147483654" r:id="R9151c8ce1b0d4df3"/>
+    <p:sldLayoutId xmlns:r="http://schemas.openxmlformats.org/officeDocument/2006/relationships" id="2147483655" r:id="Ra44c1fdf492c4914"/>
+    <p:sldLayoutId xmlns:r="http://schemas.openxmlformats.org/officeDocument/2006/relationships" id="2147483656" r:id="R36e87f1b46d74aaf"/>
+    <p:sldLayoutId xmlns:r="http://schemas.openxmlformats.org/officeDocument/2006/relationships" id="2147483657" r:id="R60a81417e3844df6"/>
+    <p:sldLayoutId xmlns:r="http://schemas.openxmlformats.org/officeDocument/2006/relationships" id="2147483658" r:id="Rbf53c9990a8748e7"/>
+    <p:sldLayoutId xmlns:r="http://schemas.openxmlformats.org/officeDocument/2006/relationships" id="2147483659" r:id="R15bc2348dcee4f90"/>
+    <p:sldLayoutId xmlns:r="http://schemas.openxmlformats.org/officeDocument/2006/relationships" id="2147483660" r:id="R8e5e2739aac1468c"/>
   </p:sldLayoutIdLst>
   <p:hf sldNum="0" hdr="0" ftr="0" dt="0"/>
   <p:txStyles>
@@ -6361,7 +6361,7 @@
   </p:cSld>
   <p:clrMap bg1="lt1" tx1="dk1" bg2="dk2" tx2="lt2" accent1="accent1" accent2="accent2" accent3="accent3" accent4="accent4" accent5="accent5" accent6="accent6" hlink="hlink" folHlink="folHlink"/>
   <p:sldLayoutIdLst>
-    <p:sldLayoutId xmlns:r="http://schemas.openxmlformats.org/officeDocument/2006/relationships" id="2147483662" r:id="Rafe11c29ede94a2b"/>
+    <p:sldLayoutId xmlns:r="http://schemas.openxmlformats.org/officeDocument/2006/relationships" id="2147483662" r:id="R8e7198cc9e81475e"/>
   </p:sldLayoutIdLst>
   <p:hf sldNum="0" hdr="0" ftr="0" dt="0"/>
   <p:txStyles>
@@ -8210,7 +8210,7 @@
           <p:nvPr/>
         </p:nvPicPr>
         <p:blipFill rotWithShape="1">
-          <a:blip xmlns:r="http://schemas.openxmlformats.org/officeDocument/2006/relationships" xmlns:a="http://schemas.openxmlformats.org/drawingml/2006/main" r:embed="R176bb20692a24901">
+          <a:blip xmlns:r="http://schemas.openxmlformats.org/officeDocument/2006/relationships" xmlns:a="http://schemas.openxmlformats.org/drawingml/2006/main" r:embed="R1346af1622e94cd8">
             <a:alphaModFix/>
           </a:blip>
           <a:srcRect xmlns:a="http://schemas.openxmlformats.org/drawingml/2006/main" l="0" t="0" r="0" b="0"/>
@@ -8238,7 +8238,7 @@
           <p:nvPr/>
         </p:nvPicPr>
         <p:blipFill rotWithShape="1">
-          <a:blip xmlns:r="http://schemas.openxmlformats.org/officeDocument/2006/relationships" xmlns:a="http://schemas.openxmlformats.org/drawingml/2006/main" r:embed="R176bb20692a24901">
+          <a:blip xmlns:r="http://schemas.openxmlformats.org/officeDocument/2006/relationships" xmlns:a="http://schemas.openxmlformats.org/drawingml/2006/main" r:embed="R1346af1622e94cd8">
             <a:alphaModFix/>
           </a:blip>
           <a:srcRect xmlns:a="http://schemas.openxmlformats.org/drawingml/2006/main" l="0" t="0" r="0" b="0"/>
@@ -8266,7 +8266,7 @@
           <p:nvPr/>
         </p:nvPicPr>
         <p:blipFill rotWithShape="1">
-          <a:blip xmlns:r="http://schemas.openxmlformats.org/officeDocument/2006/relationships" xmlns:a="http://schemas.openxmlformats.org/drawingml/2006/main" r:embed="R176bb20692a24901">
+          <a:blip xmlns:r="http://schemas.openxmlformats.org/officeDocument/2006/relationships" xmlns:a="http://schemas.openxmlformats.org/drawingml/2006/main" r:embed="R1346af1622e94cd8">
             <a:alphaModFix/>
           </a:blip>
           <a:srcRect xmlns:a="http://schemas.openxmlformats.org/drawingml/2006/main" l="0" t="0" r="0" b="0"/>
@@ -8294,7 +8294,7 @@
           <p:nvPr/>
         </p:nvPicPr>
         <p:blipFill rotWithShape="1">
-          <a:blip xmlns:r="http://schemas.openxmlformats.org/officeDocument/2006/relationships" xmlns:a="http://schemas.openxmlformats.org/drawingml/2006/main" r:embed="R176bb20692a24901">
+          <a:blip xmlns:r="http://schemas.openxmlformats.org/officeDocument/2006/relationships" xmlns:a="http://schemas.openxmlformats.org/drawingml/2006/main" r:embed="R1346af1622e94cd8">
             <a:alphaModFix/>
           </a:blip>
           <a:srcRect xmlns:a="http://schemas.openxmlformats.org/drawingml/2006/main" l="0" t="0" r="0" b="0"/>
@@ -8322,7 +8322,7 @@
           <p:nvPr/>
         </p:nvPicPr>
         <p:blipFill rotWithShape="1">
-          <a:blip xmlns:r="http://schemas.openxmlformats.org/officeDocument/2006/relationships" xmlns:a="http://schemas.openxmlformats.org/drawingml/2006/main" r:embed="R176bb20692a24901">
+          <a:blip xmlns:r="http://schemas.openxmlformats.org/officeDocument/2006/relationships" xmlns:a="http://schemas.openxmlformats.org/drawingml/2006/main" r:embed="R1346af1622e94cd8">
             <a:alphaModFix/>
           </a:blip>
           <a:srcRect xmlns:a="http://schemas.openxmlformats.org/drawingml/2006/main" l="0" t="0" r="0" b="0"/>
@@ -8350,7 +8350,7 @@
           <p:nvPr/>
         </p:nvPicPr>
         <p:blipFill rotWithShape="1">
-          <a:blip xmlns:r="http://schemas.openxmlformats.org/officeDocument/2006/relationships" xmlns:a="http://schemas.openxmlformats.org/drawingml/2006/main" r:embed="R176bb20692a24901">
+          <a:blip xmlns:r="http://schemas.openxmlformats.org/officeDocument/2006/relationships" xmlns:a="http://schemas.openxmlformats.org/drawingml/2006/main" r:embed="R1346af1622e94cd8">
             <a:alphaModFix/>
           </a:blip>
           <a:srcRect xmlns:a="http://schemas.openxmlformats.org/drawingml/2006/main" l="0" t="0" r="0" b="0"/>
@@ -8378,7 +8378,7 @@
           <p:nvPr/>
         </p:nvPicPr>
         <p:blipFill rotWithShape="1">
-          <a:blip xmlns:r="http://schemas.openxmlformats.org/officeDocument/2006/relationships" xmlns:a="http://schemas.openxmlformats.org/drawingml/2006/main" r:embed="R176bb20692a24901">
+          <a:blip xmlns:r="http://schemas.openxmlformats.org/officeDocument/2006/relationships" xmlns:a="http://schemas.openxmlformats.org/drawingml/2006/main" r:embed="R1346af1622e94cd8">
             <a:alphaModFix/>
           </a:blip>
           <a:srcRect xmlns:a="http://schemas.openxmlformats.org/drawingml/2006/main" l="0" t="0" r="0" b="0"/>
@@ -8406,7 +8406,7 @@
           <p:nvPr/>
         </p:nvPicPr>
         <p:blipFill rotWithShape="1">
-          <a:blip xmlns:r="http://schemas.openxmlformats.org/officeDocument/2006/relationships" xmlns:a="http://schemas.openxmlformats.org/drawingml/2006/main" r:embed="R176bb20692a24901">
+          <a:blip xmlns:r="http://schemas.openxmlformats.org/officeDocument/2006/relationships" xmlns:a="http://schemas.openxmlformats.org/drawingml/2006/main" r:embed="R1346af1622e94cd8">
             <a:alphaModFix/>
           </a:blip>
           <a:srcRect xmlns:a="http://schemas.openxmlformats.org/drawingml/2006/main" l="0" t="0" r="0" b="0"/>
@@ -10499,7 +10499,7 @@
           <p:nvPr/>
         </p:nvPicPr>
         <p:blipFill rotWithShape="1">
-          <a:blip xmlns:r="http://schemas.openxmlformats.org/officeDocument/2006/relationships" xmlns:a="http://schemas.openxmlformats.org/drawingml/2006/main" r:embed="R2163356993584ba4">
+          <a:blip xmlns:r="http://schemas.openxmlformats.org/officeDocument/2006/relationships" xmlns:a="http://schemas.openxmlformats.org/drawingml/2006/main" r:embed="R97de0e3900a4491f">
             <a:alphaModFix/>
           </a:blip>
           <a:srcRect xmlns:a="http://schemas.openxmlformats.org/drawingml/2006/main" l="0" t="0" r="0" b="0"/>
@@ -10527,7 +10527,7 @@
           <p:nvPr/>
         </p:nvPicPr>
         <p:blipFill rotWithShape="1">
-          <a:blip xmlns:r="http://schemas.openxmlformats.org/officeDocument/2006/relationships" xmlns:a="http://schemas.openxmlformats.org/drawingml/2006/main" r:embed="R2163356993584ba4">
+          <a:blip xmlns:r="http://schemas.openxmlformats.org/officeDocument/2006/relationships" xmlns:a="http://schemas.openxmlformats.org/drawingml/2006/main" r:embed="R97de0e3900a4491f">
             <a:alphaModFix/>
           </a:blip>
           <a:srcRect xmlns:a="http://schemas.openxmlformats.org/drawingml/2006/main" l="0" t="0" r="0" b="0"/>
@@ -10555,7 +10555,7 @@
           <p:nvPr/>
         </p:nvPicPr>
         <p:blipFill rotWithShape="1">
-          <a:blip xmlns:r="http://schemas.openxmlformats.org/officeDocument/2006/relationships" xmlns:a="http://schemas.openxmlformats.org/drawingml/2006/main" r:embed="R2163356993584ba4">
+          <a:blip xmlns:r="http://schemas.openxmlformats.org/officeDocument/2006/relationships" xmlns:a="http://schemas.openxmlformats.org/drawingml/2006/main" r:embed="R97de0e3900a4491f">
             <a:alphaModFix/>
           </a:blip>
           <a:srcRect xmlns:a="http://schemas.openxmlformats.org/drawingml/2006/main" l="0" t="0" r="0" b="0"/>
@@ -10583,7 +10583,7 @@
           <p:nvPr/>
         </p:nvPicPr>
         <p:blipFill rotWithShape="1">
-          <a:blip xmlns:r="http://schemas.openxmlformats.org/officeDocument/2006/relationships" xmlns:a="http://schemas.openxmlformats.org/drawingml/2006/main" r:embed="R2163356993584ba4">
+          <a:blip xmlns:r="http://schemas.openxmlformats.org/officeDocument/2006/relationships" xmlns:a="http://schemas.openxmlformats.org/drawingml/2006/main" r:embed="R97de0e3900a4491f">
             <a:alphaModFix/>
           </a:blip>
           <a:srcRect xmlns:a="http://schemas.openxmlformats.org/drawingml/2006/main" l="0" t="0" r="0" b="0"/>
@@ -12592,7 +12592,7 @@
           <p:nvPr/>
         </p:nvPicPr>
         <p:blipFill rotWithShape="1">
-          <a:blip xmlns:r="http://schemas.openxmlformats.org/officeDocument/2006/relationships" xmlns:a="http://schemas.openxmlformats.org/drawingml/2006/main" r:embed="R657b5b9231b84ae1">
+          <a:blip xmlns:r="http://schemas.openxmlformats.org/officeDocument/2006/relationships" xmlns:a="http://schemas.openxmlformats.org/drawingml/2006/main" r:embed="Rc01cc3123fb848b1">
             <a:alphaModFix/>
           </a:blip>
           <a:srcRect xmlns:a="http://schemas.openxmlformats.org/drawingml/2006/main" l="0" t="0" r="0" b="0"/>
@@ -12620,7 +12620,7 @@
           <p:nvPr/>
         </p:nvPicPr>
         <p:blipFill rotWithShape="1">
-          <a:blip xmlns:r="http://schemas.openxmlformats.org/officeDocument/2006/relationships" xmlns:a="http://schemas.openxmlformats.org/drawingml/2006/main" r:embed="R657b5b9231b84ae1">
+          <a:blip xmlns:r="http://schemas.openxmlformats.org/officeDocument/2006/relationships" xmlns:a="http://schemas.openxmlformats.org/drawingml/2006/main" r:embed="Rc01cc3123fb848b1">
             <a:alphaModFix/>
           </a:blip>
           <a:srcRect xmlns:a="http://schemas.openxmlformats.org/drawingml/2006/main" l="0" t="0" r="0" b="0"/>
@@ -12648,7 +12648,7 @@
           <p:nvPr/>
         </p:nvPicPr>
         <p:blipFill rotWithShape="1">
-          <a:blip xmlns:r="http://schemas.openxmlformats.org/officeDocument/2006/relationships" xmlns:a="http://schemas.openxmlformats.org/drawingml/2006/main" r:embed="R657b5b9231b84ae1">
+          <a:blip xmlns:r="http://schemas.openxmlformats.org/officeDocument/2006/relationships" xmlns:a="http://schemas.openxmlformats.org/drawingml/2006/main" r:embed="Rc01cc3123fb848b1">
             <a:alphaModFix/>
           </a:blip>
           <a:srcRect xmlns:a="http://schemas.openxmlformats.org/drawingml/2006/main" l="0" t="0" r="0" b="0"/>
@@ -12676,7 +12676,7 @@
           <p:nvPr/>
         </p:nvPicPr>
         <p:blipFill rotWithShape="1">
-          <a:blip xmlns:r="http://schemas.openxmlformats.org/officeDocument/2006/relationships" xmlns:a="http://schemas.openxmlformats.org/drawingml/2006/main" r:embed="R657b5b9231b84ae1">
+          <a:blip xmlns:r="http://schemas.openxmlformats.org/officeDocument/2006/relationships" xmlns:a="http://schemas.openxmlformats.org/drawingml/2006/main" r:embed="Rc01cc3123fb848b1">
             <a:alphaModFix/>
           </a:blip>
           <a:srcRect xmlns:a="http://schemas.openxmlformats.org/drawingml/2006/main" l="0" t="0" r="0" b="0"/>
@@ -14669,7 +14669,7 @@
           <p:nvPr/>
         </p:nvPicPr>
         <p:blipFill rotWithShape="1">
-          <a:blip xmlns:r="http://schemas.openxmlformats.org/officeDocument/2006/relationships" xmlns:a="http://schemas.openxmlformats.org/drawingml/2006/main" r:embed="Rcf71b97f2dbb4bd8">
+          <a:blip xmlns:r="http://schemas.openxmlformats.org/officeDocument/2006/relationships" xmlns:a="http://schemas.openxmlformats.org/drawingml/2006/main" r:embed="R93b488a8eb544957">
             <a:alphaModFix/>
           </a:blip>
           <a:srcRect xmlns:a="http://schemas.openxmlformats.org/drawingml/2006/main" l="0" t="0" r="0" b="0"/>
@@ -14697,7 +14697,7 @@
           <p:nvPr/>
         </p:nvPicPr>
         <p:blipFill rotWithShape="1">
-          <a:blip xmlns:r="http://schemas.openxmlformats.org/officeDocument/2006/relationships" xmlns:a="http://schemas.openxmlformats.org/drawingml/2006/main" r:embed="Rcf71b97f2dbb4bd8">
+          <a:blip xmlns:r="http://schemas.openxmlformats.org/officeDocument/2006/relationships" xmlns:a="http://schemas.openxmlformats.org/drawingml/2006/main" r:embed="R93b488a8eb544957">
             <a:alphaModFix/>
           </a:blip>
           <a:srcRect xmlns:a="http://schemas.openxmlformats.org/drawingml/2006/main" l="0" t="0" r="0" b="0"/>
@@ -14725,7 +14725,7 @@
           <p:nvPr/>
         </p:nvPicPr>
         <p:blipFill rotWithShape="1">
-          <a:blip xmlns:r="http://schemas.openxmlformats.org/officeDocument/2006/relationships" xmlns:a="http://schemas.openxmlformats.org/drawingml/2006/main" r:embed="Rcf71b97f2dbb4bd8">
+          <a:blip xmlns:r="http://schemas.openxmlformats.org/officeDocument/2006/relationships" xmlns:a="http://schemas.openxmlformats.org/drawingml/2006/main" r:embed="R93b488a8eb544957">
             <a:alphaModFix/>
           </a:blip>
           <a:srcRect xmlns:a="http://schemas.openxmlformats.org/drawingml/2006/main" l="0" t="0" r="0" b="0"/>
@@ -14753,7 +14753,7 @@
           <p:nvPr/>
         </p:nvPicPr>
         <p:blipFill rotWithShape="1">
-          <a:blip xmlns:r="http://schemas.openxmlformats.org/officeDocument/2006/relationships" xmlns:a="http://schemas.openxmlformats.org/drawingml/2006/main" r:embed="Rcf71b97f2dbb4bd8">
+          <a:blip xmlns:r="http://schemas.openxmlformats.org/officeDocument/2006/relationships" xmlns:a="http://schemas.openxmlformats.org/drawingml/2006/main" r:embed="R93b488a8eb544957">
             <a:alphaModFix/>
           </a:blip>
           <a:srcRect xmlns:a="http://schemas.openxmlformats.org/drawingml/2006/main" l="0" t="0" r="0" b="0"/>
@@ -15351,7 +15351,7 @@
                 <a:ea typeface="Inter"/>
                 <a:cs typeface="Inter"/>
               </a:rPr>
-              <a:t>The collector monitors the Ubuntu VM.</a:t>
+              <a:t>Teardown deletes the workshop VM and its disk after confirmation.</a:t>
             </a:r>
           </a:p>
           <a:p xmlns:a="http://schemas.openxmlformats.org/drawingml/2006/main">
@@ -15403,7 +15403,7 @@
                 <a:ea typeface="Inter"/>
                 <a:cs typeface="Inter"/>
               </a:rPr>
-              <a:t>libscap handles capture. libsinsp adds context.</a:t>
+              <a:t>Your local source and logs stay.</a:t>
             </a:r>
           </a:p>
           <a:p xmlns:a="http://schemas.openxmlformats.org/drawingml/2006/main">
@@ -15455,7 +15455,7 @@
                 <a:ea typeface="Inter"/>
                 <a:cs typeface="Inter"/>
               </a:rPr>
-              <a:t>Stop the VM when you are done.</a:t>
+              <a:t>Run setup again to repeat the workshop.</a:t>
             </a:r>
           </a:p>
         </p:txBody>
@@ -15842,7 +15842,37 @@
                 <a:ea typeface="Roboto Mono"/>
                 <a:cs typeface="Roboto Mono"/>
               </a:rPr>
-              <a:t>multipass stop falco-lab</a:t>
+              <a:t># Mac</a:t>
+            </a:r>
+          </a:p>
+          <a:p xmlns:a="http://schemas.openxmlformats.org/drawingml/2006/main">
+            <a:pPr marL="0" indent="0" algn="l">
+              <a:spcBef>
+                <a:spcPts val="0"/>
+              </a:spcBef>
+              <a:spcAft>
+                <a:spcPts val="0"/>
+              </a:spcAft>
+              <a:buNone/>
+              <a:defRPr sz="1350" b="0">
+                <a:solidFill>
+                  <a:srgbClr val="00E5FF"/>
+                </a:solidFill>
+                <a:latin typeface="Roboto Mono"/>
+                <a:ea typeface="Roboto Mono"/>
+                <a:cs typeface="Roboto Mono"/>
+              </a:defRPr>
+            </a:pPr>
+            <a:r>
+              <a:rPr sz="1350" b="0" i="0">
+                <a:solidFill>
+                  <a:srgbClr val="00E5FF"/>
+                </a:solidFill>
+                <a:latin typeface="Roboto Mono"/>
+                <a:ea typeface="Roboto Mono"/>
+                <a:cs typeface="Roboto Mono"/>
+              </a:rPr>
+              <a:t>bash scripts/mac/teardown.sh</a:t>
             </a:r>
           </a:p>
           <a:p xmlns:a="http://schemas.openxmlformats.org/drawingml/2006/main">
@@ -15894,7 +15924,7 @@
                 <a:ea typeface="Roboto Mono"/>
                 <a:cs typeface="Roboto Mono"/>
               </a:rPr>
-              <a:t># Next time, use your run script.</a:t>
+              <a:t># Windows PowerShell</a:t>
             </a:r>
           </a:p>
           <a:p xmlns:a="http://schemas.openxmlformats.org/drawingml/2006/main">
@@ -15924,7 +15954,37 @@
                 <a:ea typeface="Roboto Mono"/>
                 <a:cs typeface="Roboto Mono"/>
               </a:rPr>
-              <a:t># It starts the VM automatically.</a:t>
+              <a:t>powershell -ExecutionPolicy Bypass `</a:t>
+            </a:r>
+          </a:p>
+          <a:p xmlns:a="http://schemas.openxmlformats.org/drawingml/2006/main">
+            <a:pPr marL="0" indent="0" algn="l">
+              <a:spcBef>
+                <a:spcPts val="0"/>
+              </a:spcBef>
+              <a:spcAft>
+                <a:spcPts val="0"/>
+              </a:spcAft>
+              <a:buNone/>
+              <a:defRPr sz="1350" b="0">
+                <a:solidFill>
+                  <a:srgbClr val="00E5FF"/>
+                </a:solidFill>
+                <a:latin typeface="Roboto Mono"/>
+                <a:ea typeface="Roboto Mono"/>
+                <a:cs typeface="Roboto Mono"/>
+              </a:defRPr>
+            </a:pPr>
+            <a:r>
+              <a:rPr sz="1350" b="0" i="0">
+                <a:solidFill>
+                  <a:srgbClr val="00E5FF"/>
+                </a:solidFill>
+                <a:latin typeface="Roboto Mono"/>
+                <a:ea typeface="Roboto Mono"/>
+                <a:cs typeface="Roboto Mono"/>
+              </a:rPr>
+              <a:t>  -File scripts/windows/teardown.ps1</a:t>
             </a:r>
           </a:p>
         </p:txBody>
@@ -16574,7 +16634,7 @@
           <p:nvPr/>
         </p:nvPicPr>
         <p:blipFill rotWithShape="1">
-          <a:blip xmlns:r="http://schemas.openxmlformats.org/officeDocument/2006/relationships" xmlns:a="http://schemas.openxmlformats.org/drawingml/2006/main" r:embed="Rcb7022011ba54e17">
+          <a:blip xmlns:r="http://schemas.openxmlformats.org/officeDocument/2006/relationships" xmlns:a="http://schemas.openxmlformats.org/drawingml/2006/main" r:embed="R95e8927c2fa843ef">
             <a:alphaModFix/>
           </a:blip>
           <a:srcRect xmlns:a="http://schemas.openxmlformats.org/drawingml/2006/main" l="0" t="0" r="0" b="0"/>
@@ -16602,7 +16662,7 @@
           <p:nvPr/>
         </p:nvPicPr>
         <p:blipFill rotWithShape="1">
-          <a:blip xmlns:r="http://schemas.openxmlformats.org/officeDocument/2006/relationships" xmlns:a="http://schemas.openxmlformats.org/drawingml/2006/main" r:embed="Rcb7022011ba54e17">
+          <a:blip xmlns:r="http://schemas.openxmlformats.org/officeDocument/2006/relationships" xmlns:a="http://schemas.openxmlformats.org/drawingml/2006/main" r:embed="R95e8927c2fa843ef">
             <a:alphaModFix/>
           </a:blip>
           <a:srcRect xmlns:a="http://schemas.openxmlformats.org/drawingml/2006/main" l="0" t="0" r="0" b="0"/>
@@ -16630,7 +16690,7 @@
           <p:nvPr/>
         </p:nvPicPr>
         <p:blipFill rotWithShape="1">
-          <a:blip xmlns:r="http://schemas.openxmlformats.org/officeDocument/2006/relationships" xmlns:a="http://schemas.openxmlformats.org/drawingml/2006/main" r:embed="Rcb7022011ba54e17">
+          <a:blip xmlns:r="http://schemas.openxmlformats.org/officeDocument/2006/relationships" xmlns:a="http://schemas.openxmlformats.org/drawingml/2006/main" r:embed="R95e8927c2fa843ef">
             <a:alphaModFix/>
           </a:blip>
           <a:srcRect xmlns:a="http://schemas.openxmlformats.org/drawingml/2006/main" l="0" t="0" r="0" b="0"/>
@@ -16658,7 +16718,7 @@
           <p:nvPr/>
         </p:nvPicPr>
         <p:blipFill rotWithShape="1">
-          <a:blip xmlns:r="http://schemas.openxmlformats.org/officeDocument/2006/relationships" xmlns:a="http://schemas.openxmlformats.org/drawingml/2006/main" r:embed="Rcb7022011ba54e17">
+          <a:blip xmlns:r="http://schemas.openxmlformats.org/officeDocument/2006/relationships" xmlns:a="http://schemas.openxmlformats.org/drawingml/2006/main" r:embed="R95e8927c2fa843ef">
             <a:alphaModFix/>
           </a:blip>
           <a:srcRect xmlns:a="http://schemas.openxmlformats.org/drawingml/2006/main" l="0" t="0" r="0" b="0"/>
@@ -18501,7 +18561,7 @@
           <p:nvPr/>
         </p:nvPicPr>
         <p:blipFill rotWithShape="1">
-          <a:blip xmlns:r="http://schemas.openxmlformats.org/officeDocument/2006/relationships" xmlns:a="http://schemas.openxmlformats.org/drawingml/2006/main" r:embed="R1a3a015c918441d4">
+          <a:blip xmlns:r="http://schemas.openxmlformats.org/officeDocument/2006/relationships" xmlns:a="http://schemas.openxmlformats.org/drawingml/2006/main" r:embed="R3d11910e22f04b4e">
             <a:alphaModFix/>
           </a:blip>
           <a:srcRect xmlns:a="http://schemas.openxmlformats.org/drawingml/2006/main" l="0" t="0" r="0" b="0"/>
@@ -18529,7 +18589,7 @@
           <p:nvPr/>
         </p:nvPicPr>
         <p:blipFill rotWithShape="1">
-          <a:blip xmlns:r="http://schemas.openxmlformats.org/officeDocument/2006/relationships" xmlns:a="http://schemas.openxmlformats.org/drawingml/2006/main" r:embed="R1a3a015c918441d4">
+          <a:blip xmlns:r="http://schemas.openxmlformats.org/officeDocument/2006/relationships" xmlns:a="http://schemas.openxmlformats.org/drawingml/2006/main" r:embed="R3d11910e22f04b4e">
             <a:alphaModFix/>
           </a:blip>
           <a:srcRect xmlns:a="http://schemas.openxmlformats.org/drawingml/2006/main" l="0" t="0" r="0" b="0"/>
@@ -18557,7 +18617,7 @@
           <p:nvPr/>
         </p:nvPicPr>
         <p:blipFill rotWithShape="1">
-          <a:blip xmlns:r="http://schemas.openxmlformats.org/officeDocument/2006/relationships" xmlns:a="http://schemas.openxmlformats.org/drawingml/2006/main" r:embed="R1a3a015c918441d4">
+          <a:blip xmlns:r="http://schemas.openxmlformats.org/officeDocument/2006/relationships" xmlns:a="http://schemas.openxmlformats.org/drawingml/2006/main" r:embed="R3d11910e22f04b4e">
             <a:alphaModFix/>
           </a:blip>
           <a:srcRect xmlns:a="http://schemas.openxmlformats.org/drawingml/2006/main" l="0" t="0" r="0" b="0"/>
@@ -18585,7 +18645,7 @@
           <p:nvPr/>
         </p:nvPicPr>
         <p:blipFill rotWithShape="1">
-          <a:blip xmlns:r="http://schemas.openxmlformats.org/officeDocument/2006/relationships" xmlns:a="http://schemas.openxmlformats.org/drawingml/2006/main" r:embed="R1a3a015c918441d4">
+          <a:blip xmlns:r="http://schemas.openxmlformats.org/officeDocument/2006/relationships" xmlns:a="http://schemas.openxmlformats.org/drawingml/2006/main" r:embed="R3d11910e22f04b4e">
             <a:alphaModFix/>
           </a:blip>
           <a:srcRect xmlns:a="http://schemas.openxmlformats.org/drawingml/2006/main" l="0" t="0" r="0" b="0"/>
@@ -20198,7 +20258,7 @@
           <p:nvPr/>
         </p:nvPicPr>
         <p:blipFill rotWithShape="1">
-          <a:blip xmlns:r="http://schemas.openxmlformats.org/officeDocument/2006/relationships" xmlns:a="http://schemas.openxmlformats.org/drawingml/2006/main" r:embed="Rc778226c81b54cd4">
+          <a:blip xmlns:r="http://schemas.openxmlformats.org/officeDocument/2006/relationships" xmlns:a="http://schemas.openxmlformats.org/drawingml/2006/main" r:embed="Re9c964f4b468455c">
             <a:alphaModFix/>
           </a:blip>
           <a:srcRect xmlns:a="http://schemas.openxmlformats.org/drawingml/2006/main" l="0" t="0" r="0" b="0"/>
@@ -20226,7 +20286,7 @@
           <p:nvPr/>
         </p:nvPicPr>
         <p:blipFill rotWithShape="1">
-          <a:blip xmlns:r="http://schemas.openxmlformats.org/officeDocument/2006/relationships" xmlns:a="http://schemas.openxmlformats.org/drawingml/2006/main" r:embed="Rc778226c81b54cd4">
+          <a:blip xmlns:r="http://schemas.openxmlformats.org/officeDocument/2006/relationships" xmlns:a="http://schemas.openxmlformats.org/drawingml/2006/main" r:embed="Re9c964f4b468455c">
             <a:alphaModFix/>
           </a:blip>
           <a:srcRect xmlns:a="http://schemas.openxmlformats.org/drawingml/2006/main" l="0" t="0" r="0" b="0"/>
@@ -20254,7 +20314,7 @@
           <p:nvPr/>
         </p:nvPicPr>
         <p:blipFill rotWithShape="1">
-          <a:blip xmlns:r="http://schemas.openxmlformats.org/officeDocument/2006/relationships" xmlns:a="http://schemas.openxmlformats.org/drawingml/2006/main" r:embed="Rc778226c81b54cd4">
+          <a:blip xmlns:r="http://schemas.openxmlformats.org/officeDocument/2006/relationships" xmlns:a="http://schemas.openxmlformats.org/drawingml/2006/main" r:embed="Re9c964f4b468455c">
             <a:alphaModFix/>
           </a:blip>
           <a:srcRect xmlns:a="http://schemas.openxmlformats.org/drawingml/2006/main" l="0" t="0" r="0" b="0"/>
@@ -20282,7 +20342,7 @@
           <p:nvPr/>
         </p:nvPicPr>
         <p:blipFill rotWithShape="1">
-          <a:blip xmlns:r="http://schemas.openxmlformats.org/officeDocument/2006/relationships" xmlns:a="http://schemas.openxmlformats.org/drawingml/2006/main" r:embed="Rc778226c81b54cd4">
+          <a:blip xmlns:r="http://schemas.openxmlformats.org/officeDocument/2006/relationships" xmlns:a="http://schemas.openxmlformats.org/drawingml/2006/main" r:embed="Re9c964f4b468455c">
             <a:alphaModFix/>
           </a:blip>
           <a:srcRect xmlns:a="http://schemas.openxmlformats.org/drawingml/2006/main" l="0" t="0" r="0" b="0"/>
@@ -21895,7 +21955,7 @@
           <p:nvPr/>
         </p:nvPicPr>
         <p:blipFill rotWithShape="1">
-          <a:blip xmlns:r="http://schemas.openxmlformats.org/officeDocument/2006/relationships" xmlns:a="http://schemas.openxmlformats.org/drawingml/2006/main" r:embed="R4fb6647da8e84e31">
+          <a:blip xmlns:r="http://schemas.openxmlformats.org/officeDocument/2006/relationships" xmlns:a="http://schemas.openxmlformats.org/drawingml/2006/main" r:embed="R0bc2eb91ef434ad8">
             <a:alphaModFix/>
           </a:blip>
           <a:srcRect xmlns:a="http://schemas.openxmlformats.org/drawingml/2006/main" l="0" t="0" r="0" b="0"/>
@@ -21923,7 +21983,7 @@
           <p:nvPr/>
         </p:nvPicPr>
         <p:blipFill rotWithShape="1">
-          <a:blip xmlns:r="http://schemas.openxmlformats.org/officeDocument/2006/relationships" xmlns:a="http://schemas.openxmlformats.org/drawingml/2006/main" r:embed="R4fb6647da8e84e31">
+          <a:blip xmlns:r="http://schemas.openxmlformats.org/officeDocument/2006/relationships" xmlns:a="http://schemas.openxmlformats.org/drawingml/2006/main" r:embed="R0bc2eb91ef434ad8">
             <a:alphaModFix/>
           </a:blip>
           <a:srcRect xmlns:a="http://schemas.openxmlformats.org/drawingml/2006/main" l="0" t="0" r="0" b="0"/>
@@ -21951,7 +22011,7 @@
           <p:nvPr/>
         </p:nvPicPr>
         <p:blipFill rotWithShape="1">
-          <a:blip xmlns:r="http://schemas.openxmlformats.org/officeDocument/2006/relationships" xmlns:a="http://schemas.openxmlformats.org/drawingml/2006/main" r:embed="R4fb6647da8e84e31">
+          <a:blip xmlns:r="http://schemas.openxmlformats.org/officeDocument/2006/relationships" xmlns:a="http://schemas.openxmlformats.org/drawingml/2006/main" r:embed="R0bc2eb91ef434ad8">
             <a:alphaModFix/>
           </a:blip>
           <a:srcRect xmlns:a="http://schemas.openxmlformats.org/drawingml/2006/main" l="0" t="0" r="0" b="0"/>
@@ -21979,7 +22039,7 @@
           <p:nvPr/>
         </p:nvPicPr>
         <p:blipFill rotWithShape="1">
-          <a:blip xmlns:r="http://schemas.openxmlformats.org/officeDocument/2006/relationships" xmlns:a="http://schemas.openxmlformats.org/drawingml/2006/main" r:embed="R4fb6647da8e84e31">
+          <a:blip xmlns:r="http://schemas.openxmlformats.org/officeDocument/2006/relationships" xmlns:a="http://schemas.openxmlformats.org/drawingml/2006/main" r:embed="R0bc2eb91ef434ad8">
             <a:alphaModFix/>
           </a:blip>
           <a:srcRect xmlns:a="http://schemas.openxmlformats.org/drawingml/2006/main" l="0" t="0" r="0" b="0"/>
@@ -23904,7 +23964,7 @@
           <p:nvPr/>
         </p:nvPicPr>
         <p:blipFill rotWithShape="1">
-          <a:blip xmlns:r="http://schemas.openxmlformats.org/officeDocument/2006/relationships" xmlns:a="http://schemas.openxmlformats.org/drawingml/2006/main" r:embed="Ra121ccf1f9c74981">
+          <a:blip xmlns:r="http://schemas.openxmlformats.org/officeDocument/2006/relationships" xmlns:a="http://schemas.openxmlformats.org/drawingml/2006/main" r:embed="R4b021072fd8344db">
             <a:alphaModFix/>
           </a:blip>
           <a:srcRect xmlns:a="http://schemas.openxmlformats.org/drawingml/2006/main" l="0" t="0" r="0" b="0"/>
@@ -23932,7 +23992,7 @@
           <p:nvPr/>
         </p:nvPicPr>
         <p:blipFill rotWithShape="1">
-          <a:blip xmlns:r="http://schemas.openxmlformats.org/officeDocument/2006/relationships" xmlns:a="http://schemas.openxmlformats.org/drawingml/2006/main" r:embed="Ra121ccf1f9c74981">
+          <a:blip xmlns:r="http://schemas.openxmlformats.org/officeDocument/2006/relationships" xmlns:a="http://schemas.openxmlformats.org/drawingml/2006/main" r:embed="R4b021072fd8344db">
             <a:alphaModFix/>
           </a:blip>
           <a:srcRect xmlns:a="http://schemas.openxmlformats.org/drawingml/2006/main" l="0" t="0" r="0" b="0"/>
@@ -23960,7 +24020,7 @@
           <p:nvPr/>
         </p:nvPicPr>
         <p:blipFill rotWithShape="1">
-          <a:blip xmlns:r="http://schemas.openxmlformats.org/officeDocument/2006/relationships" xmlns:a="http://schemas.openxmlformats.org/drawingml/2006/main" r:embed="Ra121ccf1f9c74981">
+          <a:blip xmlns:r="http://schemas.openxmlformats.org/officeDocument/2006/relationships" xmlns:a="http://schemas.openxmlformats.org/drawingml/2006/main" r:embed="R4b021072fd8344db">
             <a:alphaModFix/>
           </a:blip>
           <a:srcRect xmlns:a="http://schemas.openxmlformats.org/drawingml/2006/main" l="0" t="0" r="0" b="0"/>
@@ -23988,7 +24048,7 @@
           <p:nvPr/>
         </p:nvPicPr>
         <p:blipFill rotWithShape="1">
-          <a:blip xmlns:r="http://schemas.openxmlformats.org/officeDocument/2006/relationships" xmlns:a="http://schemas.openxmlformats.org/drawingml/2006/main" r:embed="Ra121ccf1f9c74981">
+          <a:blip xmlns:r="http://schemas.openxmlformats.org/officeDocument/2006/relationships" xmlns:a="http://schemas.openxmlformats.org/drawingml/2006/main" r:embed="R4b021072fd8344db">
             <a:alphaModFix/>
           </a:blip>
           <a:srcRect xmlns:a="http://schemas.openxmlformats.org/drawingml/2006/main" l="0" t="0" r="0" b="0"/>
@@ -25669,7 +25729,7 @@
           <p:nvPr/>
         </p:nvPicPr>
         <p:blipFill rotWithShape="1">
-          <a:blip xmlns:r="http://schemas.openxmlformats.org/officeDocument/2006/relationships" xmlns:a="http://schemas.openxmlformats.org/drawingml/2006/main" r:embed="Ra53d69afc62642db">
+          <a:blip xmlns:r="http://schemas.openxmlformats.org/officeDocument/2006/relationships" xmlns:a="http://schemas.openxmlformats.org/drawingml/2006/main" r:embed="Rf67f2248ac1a4a5f">
             <a:alphaModFix/>
           </a:blip>
           <a:srcRect xmlns:a="http://schemas.openxmlformats.org/drawingml/2006/main" l="0" t="0" r="0" b="0"/>
@@ -25697,7 +25757,7 @@
           <p:nvPr/>
         </p:nvPicPr>
         <p:blipFill rotWithShape="1">
-          <a:blip xmlns:r="http://schemas.openxmlformats.org/officeDocument/2006/relationships" xmlns:a="http://schemas.openxmlformats.org/drawingml/2006/main" r:embed="Ra53d69afc62642db">
+          <a:blip xmlns:r="http://schemas.openxmlformats.org/officeDocument/2006/relationships" xmlns:a="http://schemas.openxmlformats.org/drawingml/2006/main" r:embed="Rf67f2248ac1a4a5f">
             <a:alphaModFix/>
           </a:blip>
           <a:srcRect xmlns:a="http://schemas.openxmlformats.org/drawingml/2006/main" l="0" t="0" r="0" b="0"/>
@@ -25725,7 +25785,7 @@
           <p:nvPr/>
         </p:nvPicPr>
         <p:blipFill rotWithShape="1">
-          <a:blip xmlns:r="http://schemas.openxmlformats.org/officeDocument/2006/relationships" xmlns:a="http://schemas.openxmlformats.org/drawingml/2006/main" r:embed="Ra53d69afc62642db">
+          <a:blip xmlns:r="http://schemas.openxmlformats.org/officeDocument/2006/relationships" xmlns:a="http://schemas.openxmlformats.org/drawingml/2006/main" r:embed="Rf67f2248ac1a4a5f">
             <a:alphaModFix/>
           </a:blip>
           <a:srcRect xmlns:a="http://schemas.openxmlformats.org/drawingml/2006/main" l="0" t="0" r="0" b="0"/>
@@ -25753,7 +25813,7 @@
           <p:nvPr/>
         </p:nvPicPr>
         <p:blipFill rotWithShape="1">
-          <a:blip xmlns:r="http://schemas.openxmlformats.org/officeDocument/2006/relationships" xmlns:a="http://schemas.openxmlformats.org/drawingml/2006/main" r:embed="Ra53d69afc62642db">
+          <a:blip xmlns:r="http://schemas.openxmlformats.org/officeDocument/2006/relationships" xmlns:a="http://schemas.openxmlformats.org/drawingml/2006/main" r:embed="Rf67f2248ac1a4a5f">
             <a:alphaModFix/>
           </a:blip>
           <a:srcRect xmlns:a="http://schemas.openxmlformats.org/drawingml/2006/main" l="0" t="0" r="0" b="0"/>
@@ -27434,7 +27494,7 @@
           <p:nvPr/>
         </p:nvPicPr>
         <p:blipFill rotWithShape="1">
-          <a:blip xmlns:r="http://schemas.openxmlformats.org/officeDocument/2006/relationships" xmlns:a="http://schemas.openxmlformats.org/drawingml/2006/main" r:embed="Rc5ba3053f6314db1">
+          <a:blip xmlns:r="http://schemas.openxmlformats.org/officeDocument/2006/relationships" xmlns:a="http://schemas.openxmlformats.org/drawingml/2006/main" r:embed="R7d06e26a20f54a55">
             <a:alphaModFix/>
           </a:blip>
           <a:srcRect xmlns:a="http://schemas.openxmlformats.org/drawingml/2006/main" l="0" t="0" r="0" b="0"/>
@@ -27462,7 +27522,7 @@
           <p:nvPr/>
         </p:nvPicPr>
         <p:blipFill rotWithShape="1">
-          <a:blip xmlns:r="http://schemas.openxmlformats.org/officeDocument/2006/relationships" xmlns:a="http://schemas.openxmlformats.org/drawingml/2006/main" r:embed="Rc5ba3053f6314db1">
+          <a:blip xmlns:r="http://schemas.openxmlformats.org/officeDocument/2006/relationships" xmlns:a="http://schemas.openxmlformats.org/drawingml/2006/main" r:embed="R7d06e26a20f54a55">
             <a:alphaModFix/>
           </a:blip>
           <a:srcRect xmlns:a="http://schemas.openxmlformats.org/drawingml/2006/main" l="0" t="0" r="0" b="0"/>
@@ -27490,7 +27550,7 @@
           <p:nvPr/>
         </p:nvPicPr>
         <p:blipFill rotWithShape="1">
-          <a:blip xmlns:r="http://schemas.openxmlformats.org/officeDocument/2006/relationships" xmlns:a="http://schemas.openxmlformats.org/drawingml/2006/main" r:embed="Rc5ba3053f6314db1">
+          <a:blip xmlns:r="http://schemas.openxmlformats.org/officeDocument/2006/relationships" xmlns:a="http://schemas.openxmlformats.org/drawingml/2006/main" r:embed="R7d06e26a20f54a55">
             <a:alphaModFix/>
           </a:blip>
           <a:srcRect xmlns:a="http://schemas.openxmlformats.org/drawingml/2006/main" l="0" t="0" r="0" b="0"/>
@@ -27518,7 +27578,7 @@
           <p:nvPr/>
         </p:nvPicPr>
         <p:blipFill rotWithShape="1">
-          <a:blip xmlns:r="http://schemas.openxmlformats.org/officeDocument/2006/relationships" xmlns:a="http://schemas.openxmlformats.org/drawingml/2006/main" r:embed="Rc5ba3053f6314db1">
+          <a:blip xmlns:r="http://schemas.openxmlformats.org/officeDocument/2006/relationships" xmlns:a="http://schemas.openxmlformats.org/drawingml/2006/main" r:embed="R7d06e26a20f54a55">
             <a:alphaModFix/>
           </a:blip>
           <a:srcRect xmlns:a="http://schemas.openxmlformats.org/drawingml/2006/main" l="0" t="0" r="0" b="0"/>
@@ -29609,7 +29669,7 @@
           <p:nvPr/>
         </p:nvPicPr>
         <p:blipFill rotWithShape="1">
-          <a:blip xmlns:r="http://schemas.openxmlformats.org/officeDocument/2006/relationships" xmlns:a="http://schemas.openxmlformats.org/drawingml/2006/main" r:embed="R9101883c3dff4cd5">
+          <a:blip xmlns:r="http://schemas.openxmlformats.org/officeDocument/2006/relationships" xmlns:a="http://schemas.openxmlformats.org/drawingml/2006/main" r:embed="Rc83f271572404157">
             <a:alphaModFix/>
           </a:blip>
           <a:srcRect xmlns:a="http://schemas.openxmlformats.org/drawingml/2006/main" l="0" t="0" r="0" b="0"/>
@@ -29637,7 +29697,7 @@
           <p:nvPr/>
         </p:nvPicPr>
         <p:blipFill rotWithShape="1">
-          <a:blip xmlns:r="http://schemas.openxmlformats.org/officeDocument/2006/relationships" xmlns:a="http://schemas.openxmlformats.org/drawingml/2006/main" r:embed="R9101883c3dff4cd5">
+          <a:blip xmlns:r="http://schemas.openxmlformats.org/officeDocument/2006/relationships" xmlns:a="http://schemas.openxmlformats.org/drawingml/2006/main" r:embed="Rc83f271572404157">
             <a:alphaModFix/>
           </a:blip>
           <a:srcRect xmlns:a="http://schemas.openxmlformats.org/drawingml/2006/main" l="0" t="0" r="0" b="0"/>
@@ -29665,7 +29725,7 @@
           <p:nvPr/>
         </p:nvPicPr>
         <p:blipFill rotWithShape="1">
-          <a:blip xmlns:r="http://schemas.openxmlformats.org/officeDocument/2006/relationships" xmlns:a="http://schemas.openxmlformats.org/drawingml/2006/main" r:embed="R9101883c3dff4cd5">
+          <a:blip xmlns:r="http://schemas.openxmlformats.org/officeDocument/2006/relationships" xmlns:a="http://schemas.openxmlformats.org/drawingml/2006/main" r:embed="Rc83f271572404157">
             <a:alphaModFix/>
           </a:blip>
           <a:srcRect xmlns:a="http://schemas.openxmlformats.org/drawingml/2006/main" l="0" t="0" r="0" b="0"/>
@@ -29693,7 +29753,7 @@
           <p:nvPr/>
         </p:nvPicPr>
         <p:blipFill rotWithShape="1">
-          <a:blip xmlns:r="http://schemas.openxmlformats.org/officeDocument/2006/relationships" xmlns:a="http://schemas.openxmlformats.org/drawingml/2006/main" r:embed="R9101883c3dff4cd5">
+          <a:blip xmlns:r="http://schemas.openxmlformats.org/officeDocument/2006/relationships" xmlns:a="http://schemas.openxmlformats.org/drawingml/2006/main" r:embed="Rc83f271572404157">
             <a:alphaModFix/>
           </a:blip>
           <a:srcRect xmlns:a="http://schemas.openxmlformats.org/drawingml/2006/main" l="0" t="0" r="0" b="0"/>
@@ -31732,7 +31792,7 @@
           <p:nvPr/>
         </p:nvPicPr>
         <p:blipFill rotWithShape="1">
-          <a:blip xmlns:r="http://schemas.openxmlformats.org/officeDocument/2006/relationships" xmlns:a="http://schemas.openxmlformats.org/drawingml/2006/main" r:embed="R8b9a851c2c864597">
+          <a:blip xmlns:r="http://schemas.openxmlformats.org/officeDocument/2006/relationships" xmlns:a="http://schemas.openxmlformats.org/drawingml/2006/main" r:embed="Rb2952828c72c4c41">
             <a:alphaModFix/>
           </a:blip>
           <a:srcRect xmlns:a="http://schemas.openxmlformats.org/drawingml/2006/main" l="0" t="0" r="0" b="0"/>
@@ -31760,7 +31820,7 @@
           <p:nvPr/>
         </p:nvPicPr>
         <p:blipFill rotWithShape="1">
-          <a:blip xmlns:r="http://schemas.openxmlformats.org/officeDocument/2006/relationships" xmlns:a="http://schemas.openxmlformats.org/drawingml/2006/main" r:embed="R8b9a851c2c864597">
+          <a:blip xmlns:r="http://schemas.openxmlformats.org/officeDocument/2006/relationships" xmlns:a="http://schemas.openxmlformats.org/drawingml/2006/main" r:embed="Rb2952828c72c4c41">
             <a:alphaModFix/>
           </a:blip>
           <a:srcRect xmlns:a="http://schemas.openxmlformats.org/drawingml/2006/main" l="0" t="0" r="0" b="0"/>
@@ -31788,7 +31848,7 @@
           <p:nvPr/>
         </p:nvPicPr>
         <p:blipFill rotWithShape="1">
-          <a:blip xmlns:r="http://schemas.openxmlformats.org/officeDocument/2006/relationships" xmlns:a="http://schemas.openxmlformats.org/drawingml/2006/main" r:embed="R8b9a851c2c864597">
+          <a:blip xmlns:r="http://schemas.openxmlformats.org/officeDocument/2006/relationships" xmlns:a="http://schemas.openxmlformats.org/drawingml/2006/main" r:embed="Rb2952828c72c4c41">
             <a:alphaModFix/>
           </a:blip>
           <a:srcRect xmlns:a="http://schemas.openxmlformats.org/drawingml/2006/main" l="0" t="0" r="0" b="0"/>
@@ -31816,7 +31876,7 @@
           <p:nvPr/>
         </p:nvPicPr>
         <p:blipFill rotWithShape="1">
-          <a:blip xmlns:r="http://schemas.openxmlformats.org/officeDocument/2006/relationships" xmlns:a="http://schemas.openxmlformats.org/drawingml/2006/main" r:embed="R8b9a851c2c864597">
+          <a:blip xmlns:r="http://schemas.openxmlformats.org/officeDocument/2006/relationships" xmlns:a="http://schemas.openxmlformats.org/drawingml/2006/main" r:embed="Rb2952828c72c4c41">
             <a:alphaModFix/>
           </a:blip>
           <a:srcRect xmlns:a="http://schemas.openxmlformats.org/drawingml/2006/main" l="0" t="0" r="0" b="0"/>

</xml_diff>

<commit_message>
Use stage filenames in workshop slides
</commit_message>
<xml_diff>
--- a/presentation/falco-libs-intro.pptx
+++ b/presentation/falco-libs-intro.pptx
@@ -2,77 +2,77 @@
 <file path=ppt/presentation.xml><?xml version="1.0" encoding="utf-8"?>
 <p:presentation xmlns:p="http://schemas.openxmlformats.org/presentationml/2006/main" embedTrueTypeFonts="1" saveSubsetFonts="0">
   <p:sldMasterIdLst>
-    <p:sldMasterId xmlns:r="http://schemas.openxmlformats.org/officeDocument/2006/relationships" id="2147483648" r:id="R0d4d352cc9b94e76"/>
-    <p:sldMasterId xmlns:r="http://schemas.openxmlformats.org/officeDocument/2006/relationships" id="2147483661" r:id="Re2b209ded4f64feb"/>
+    <p:sldMasterId xmlns:r="http://schemas.openxmlformats.org/officeDocument/2006/relationships" id="2147483648" r:id="Rd767e1453b764cfb"/>
+    <p:sldMasterId xmlns:r="http://schemas.openxmlformats.org/officeDocument/2006/relationships" id="2147483661" r:id="Rf1c57cfe3cca4d85"/>
   </p:sldMasterIdLst>
   <p:notesMasterIdLst>
-    <p:notesMasterId xmlns:r="http://schemas.openxmlformats.org/officeDocument/2006/relationships" r:id="Rda3d6c5a5c704272"/>
+    <p:notesMasterId xmlns:r="http://schemas.openxmlformats.org/officeDocument/2006/relationships" r:id="Rff21f5453e5e41d7"/>
   </p:notesMasterIdLst>
   <p:sldIdLst>
-    <p:sldId xmlns:r="http://schemas.openxmlformats.org/officeDocument/2006/relationships" id="256" r:id="R529aa0f75a9c4cb8"/>
-    <p:sldId xmlns:r="http://schemas.openxmlformats.org/officeDocument/2006/relationships" id="257" r:id="R88283c45ff21483e"/>
-    <p:sldId xmlns:r="http://schemas.openxmlformats.org/officeDocument/2006/relationships" id="258" r:id="Re41d58fbda484a0b"/>
-    <p:sldId xmlns:r="http://schemas.openxmlformats.org/officeDocument/2006/relationships" id="259" r:id="R5d6d42b938134709"/>
-    <p:sldId xmlns:r="http://schemas.openxmlformats.org/officeDocument/2006/relationships" id="260" r:id="Rb1fd21e8d9d440c5"/>
-    <p:sldId xmlns:r="http://schemas.openxmlformats.org/officeDocument/2006/relationships" id="261" r:id="Rb3e70b05ab20437c"/>
-    <p:sldId xmlns:r="http://schemas.openxmlformats.org/officeDocument/2006/relationships" id="262" r:id="R0fac9e42c1944811"/>
-    <p:sldId xmlns:r="http://schemas.openxmlformats.org/officeDocument/2006/relationships" id="263" r:id="R58cd032e757a4647"/>
-    <p:sldId xmlns:r="http://schemas.openxmlformats.org/officeDocument/2006/relationships" id="264" r:id="R9ba94a813ca246d2"/>
-    <p:sldId xmlns:r="http://schemas.openxmlformats.org/officeDocument/2006/relationships" id="265" r:id="Rfd19382e3b334eb3"/>
-    <p:sldId xmlns:r="http://schemas.openxmlformats.org/officeDocument/2006/relationships" id="266" r:id="R8f25c5e4547e44ac"/>
-    <p:sldId xmlns:r="http://schemas.openxmlformats.org/officeDocument/2006/relationships" id="267" r:id="R54a0bf22f0ec41dc"/>
-    <p:sldId xmlns:r="http://schemas.openxmlformats.org/officeDocument/2006/relationships" id="268" r:id="R211a38c18469431c"/>
+    <p:sldId xmlns:r="http://schemas.openxmlformats.org/officeDocument/2006/relationships" id="256" r:id="Rd21ad40f79444b2b"/>
+    <p:sldId xmlns:r="http://schemas.openxmlformats.org/officeDocument/2006/relationships" id="257" r:id="Rd782929480fa4b03"/>
+    <p:sldId xmlns:r="http://schemas.openxmlformats.org/officeDocument/2006/relationships" id="258" r:id="Rd77d6fa71cf0463c"/>
+    <p:sldId xmlns:r="http://schemas.openxmlformats.org/officeDocument/2006/relationships" id="259" r:id="Rfc1bb14a26874535"/>
+    <p:sldId xmlns:r="http://schemas.openxmlformats.org/officeDocument/2006/relationships" id="260" r:id="R6bc593d77c4d453c"/>
+    <p:sldId xmlns:r="http://schemas.openxmlformats.org/officeDocument/2006/relationships" id="261" r:id="R60f5ee6d424f4140"/>
+    <p:sldId xmlns:r="http://schemas.openxmlformats.org/officeDocument/2006/relationships" id="262" r:id="R63bb3d7ae89b4b10"/>
+    <p:sldId xmlns:r="http://schemas.openxmlformats.org/officeDocument/2006/relationships" id="263" r:id="Rd466ba76941f4b3d"/>
+    <p:sldId xmlns:r="http://schemas.openxmlformats.org/officeDocument/2006/relationships" id="264" r:id="R5e63c144eee64a01"/>
+    <p:sldId xmlns:r="http://schemas.openxmlformats.org/officeDocument/2006/relationships" id="265" r:id="Rf53edce4de4d46b0"/>
+    <p:sldId xmlns:r="http://schemas.openxmlformats.org/officeDocument/2006/relationships" id="266" r:id="R34972aafff354578"/>
+    <p:sldId xmlns:r="http://schemas.openxmlformats.org/officeDocument/2006/relationships" id="267" r:id="R34937a84bc094e9d"/>
+    <p:sldId xmlns:r="http://schemas.openxmlformats.org/officeDocument/2006/relationships" id="268" r:id="R8c34bfdf8ec148ab"/>
   </p:sldIdLst>
   <p:sldSz cx="9144000" cy="5143500"/>
   <p:notesSz cx="6858000" cy="9144000"/>
   <p:embeddedFontLst>
     <p:embeddedFont>
       <p:font typeface="Roboto Mono Medium"/>
-      <p:regular xmlns:r="http://schemas.openxmlformats.org/officeDocument/2006/relationships" r:id="Rb36a4724e5dd4325"/>
-      <p:bold xmlns:r="http://schemas.openxmlformats.org/officeDocument/2006/relationships" r:id="Rdc97bf16fcaa4449"/>
-      <p:italic xmlns:r="http://schemas.openxmlformats.org/officeDocument/2006/relationships" r:id="Rd0225c66cdf74c77"/>
-      <p:boldItalic xmlns:r="http://schemas.openxmlformats.org/officeDocument/2006/relationships" r:id="R8fe89b4002a24846"/>
+      <p:regular xmlns:r="http://schemas.openxmlformats.org/officeDocument/2006/relationships" r:id="R2fcaf8aa99894d69"/>
+      <p:bold xmlns:r="http://schemas.openxmlformats.org/officeDocument/2006/relationships" r:id="R979d7a4ddd8e4a4c"/>
+      <p:italic xmlns:r="http://schemas.openxmlformats.org/officeDocument/2006/relationships" r:id="R3e94bf33b68c4b6f"/>
+      <p:boldItalic xmlns:r="http://schemas.openxmlformats.org/officeDocument/2006/relationships" r:id="R0f273da18cff4a3f"/>
     </p:embeddedFont>
     <p:embeddedFont>
       <p:font typeface="Inter SemiBold"/>
-      <p:regular xmlns:r="http://schemas.openxmlformats.org/officeDocument/2006/relationships" r:id="R28d8822c446e40e6"/>
-      <p:bold xmlns:r="http://schemas.openxmlformats.org/officeDocument/2006/relationships" r:id="R5707513e015249dd"/>
-      <p:italic xmlns:r="http://schemas.openxmlformats.org/officeDocument/2006/relationships" r:id="R0ee9f79c4b3445d5"/>
-      <p:boldItalic xmlns:r="http://schemas.openxmlformats.org/officeDocument/2006/relationships" r:id="R463093049a5642c0"/>
+      <p:regular xmlns:r="http://schemas.openxmlformats.org/officeDocument/2006/relationships" r:id="R1a9cee82416546ea"/>
+      <p:bold xmlns:r="http://schemas.openxmlformats.org/officeDocument/2006/relationships" r:id="R825c87dbf9a742d9"/>
+      <p:italic xmlns:r="http://schemas.openxmlformats.org/officeDocument/2006/relationships" r:id="R7eba149d4b4345c5"/>
+      <p:boldItalic xmlns:r="http://schemas.openxmlformats.org/officeDocument/2006/relationships" r:id="R79de0287b5284cd3"/>
     </p:embeddedFont>
     <p:embeddedFont>
       <p:font typeface="Montserrat Black"/>
-      <p:bold xmlns:r="http://schemas.openxmlformats.org/officeDocument/2006/relationships" r:id="R079ca3921ece4ca7"/>
-      <p:boldItalic xmlns:r="http://schemas.openxmlformats.org/officeDocument/2006/relationships" r:id="Re1c0e9b6355f4a69"/>
+      <p:bold xmlns:r="http://schemas.openxmlformats.org/officeDocument/2006/relationships" r:id="Rbbba64fbc449448f"/>
+      <p:boldItalic xmlns:r="http://schemas.openxmlformats.org/officeDocument/2006/relationships" r:id="Rb9cf92d4e5fe416c"/>
     </p:embeddedFont>
     <p:embeddedFont>
       <p:font typeface="Montserrat"/>
-      <p:bold xmlns:r="http://schemas.openxmlformats.org/officeDocument/2006/relationships" r:id="R3ca3ba5c49c049b9"/>
-      <p:boldItalic xmlns:r="http://schemas.openxmlformats.org/officeDocument/2006/relationships" r:id="Rea59cf80e5854b12"/>
+      <p:bold xmlns:r="http://schemas.openxmlformats.org/officeDocument/2006/relationships" r:id="Rad088502440c49da"/>
+      <p:boldItalic xmlns:r="http://schemas.openxmlformats.org/officeDocument/2006/relationships" r:id="Rcc348cbf75664633"/>
     </p:embeddedFont>
     <p:embeddedFont>
       <p:font typeface="Inter"/>
-      <p:regular xmlns:r="http://schemas.openxmlformats.org/officeDocument/2006/relationships" r:id="R27c97f697eac4bcc"/>
-      <p:bold xmlns:r="http://schemas.openxmlformats.org/officeDocument/2006/relationships" r:id="Rc1b44cdab5c04416"/>
-      <p:italic xmlns:r="http://schemas.openxmlformats.org/officeDocument/2006/relationships" r:id="Raddf13061f8c4525"/>
-      <p:boldItalic xmlns:r="http://schemas.openxmlformats.org/officeDocument/2006/relationships" r:id="R73fa0e6f5a264723"/>
+      <p:regular xmlns:r="http://schemas.openxmlformats.org/officeDocument/2006/relationships" r:id="Rada431b5ce4040b3"/>
+      <p:bold xmlns:r="http://schemas.openxmlformats.org/officeDocument/2006/relationships" r:id="R486b077860c94167"/>
+      <p:italic xmlns:r="http://schemas.openxmlformats.org/officeDocument/2006/relationships" r:id="R3e936ba16ccd4e5f"/>
+      <p:boldItalic xmlns:r="http://schemas.openxmlformats.org/officeDocument/2006/relationships" r:id="R0757d40ebb164c73"/>
     </p:embeddedFont>
     <p:embeddedFont>
       <p:font typeface="Montserrat ExtraBold"/>
-      <p:bold xmlns:r="http://schemas.openxmlformats.org/officeDocument/2006/relationships" r:id="R1d3b116e3adc427e"/>
-      <p:boldItalic xmlns:r="http://schemas.openxmlformats.org/officeDocument/2006/relationships" r:id="R5ce2059d40a34bbf"/>
+      <p:bold xmlns:r="http://schemas.openxmlformats.org/officeDocument/2006/relationships" r:id="Rb12897db0a8e44c4"/>
+      <p:boldItalic xmlns:r="http://schemas.openxmlformats.org/officeDocument/2006/relationships" r:id="Rabfaf4cc86864ba5"/>
     </p:embeddedFont>
     <p:embeddedFont>
       <p:font typeface="Roboto Mono"/>
-      <p:bold xmlns:r="http://schemas.openxmlformats.org/officeDocument/2006/relationships" r:id="R4f5b85ad4e5747a4"/>
-      <p:boldItalic xmlns:r="http://schemas.openxmlformats.org/officeDocument/2006/relationships" r:id="R6e59c31a7a47450f"/>
+      <p:bold xmlns:r="http://schemas.openxmlformats.org/officeDocument/2006/relationships" r:id="Rc82d78d02ab7466a"/>
+      <p:boldItalic xmlns:r="http://schemas.openxmlformats.org/officeDocument/2006/relationships" r:id="Rf3cc02b8dab14621"/>
     </p:embeddedFont>
     <p:embeddedFont>
       <p:font typeface="Inter Medium"/>
-      <p:regular xmlns:r="http://schemas.openxmlformats.org/officeDocument/2006/relationships" r:id="R86f1e85634d345bc"/>
-      <p:bold xmlns:r="http://schemas.openxmlformats.org/officeDocument/2006/relationships" r:id="Reff6d545be3a404d"/>
-      <p:italic xmlns:r="http://schemas.openxmlformats.org/officeDocument/2006/relationships" r:id="R45d6a302398d4deb"/>
-      <p:boldItalic xmlns:r="http://schemas.openxmlformats.org/officeDocument/2006/relationships" r:id="R85ac008eebe24eb3"/>
+      <p:regular xmlns:r="http://schemas.openxmlformats.org/officeDocument/2006/relationships" r:id="R62913fb7faea420b"/>
+      <p:bold xmlns:r="http://schemas.openxmlformats.org/officeDocument/2006/relationships" r:id="Rca7fdd7b200b4502"/>
+      <p:italic xmlns:r="http://schemas.openxmlformats.org/officeDocument/2006/relationships" r:id="R510b0a35110d4301"/>
+      <p:boldItalic xmlns:r="http://schemas.openxmlformats.org/officeDocument/2006/relationships" r:id="R87a7c11ba5224df7"/>
     </p:embeddedFont>
   </p:embeddedFontLst>
 </p:presentation>
@@ -777,7 +777,7 @@
               <a:buNone/>
             </a:pPr>
             <a:r>
-              <a:t>The output is illustrative. The JSONL excerpt omits timestamp_ns for space. The 582-event count is illustrative, as are PIDs and names. Event names, process names, PIDs and counts vary. Step 3 includes all previous additions and works without running steps 1 and 2 first. Step scripts overwrite main.cpp and CMakeLists.txt locally. Run then rebuilds and captures, saving status to logs/&lt;run-id&gt;.log and records to logs/&lt;run-id&gt;.jsonl. No filter or success-only condition is applied. Both syscall directions can appear, and background activity is included. The scheduler-switch tracepoint is disabled. Other capture defaults are unchanged, so this is not a guarantee of capturing every syscall on the machine.</a:t>
+              <a:t>The output is illustrative. The JSONL excerpt omits timestamp_ns for space. The 582-event count is illustrative, as are PIDs and names. Event names, process names, PIDs and counts vary. Step 3 includes all previous additions and works without running steps 1 and 2 first. Step scripts overwrite main.cpp and CMakeLists.txt locally. Run then rebuilds and captures, saving status to logs/stage-N.log and records to logs/stage-N.jsonl. No filter or success-only condition is applied. Both syscall directions can appear, and background activity is included. The scheduler-switch tracepoint is disabled. Other capture defaults are unchanged, so this is not a guarantee of capturing every syscall on the machine.</a:t>
             </a:r>
             <a:endParaRPr/>
           </a:p>
@@ -1177,7 +1177,7 @@
               <a:buNone/>
             </a:pPr>
             <a:r>
-              <a:t>No VM shell or second terminal is needed. Run starts or reuses the VM, copies source, rebuilds, and starts the collector. After the collector reports attachment, the runner executes /usr/bin/id inside Ubuntu automatically. It waits for capture to finish, transfers the complete status and JSONL files with multipass transfer, then displays only the status locally. Each run has a UTC time and runner PID in its filenames, preserving earlier output. This avoids piping bulk output through multipass exec. Successful build output is hidden; build failures are displayed. The VM stays available for the next run.</a:t>
+              <a:t>No VM shell or second terminal is needed. Run starts or reuses the VM, copies source, rebuilds, and starts the collector. After the collector reports attachment, the runner executes /usr/bin/id inside Ubuntu automatically. It waits for capture to finish, transfers the complete status and JSONL files with multipass transfer, then displays only the status locally. The first source comment identifies the stage. Filenames are stage-1.log and stage-1.jsonl, and likewise for stages 2 and 3. Rerunning a stage replaces its files, preserving other stages. Before source exists, the runner uses stage-0. This avoids piping bulk output through multipass exec. Successful build output is hidden; build failures are displayed. The VM stays available for the next run.</a:t>
             </a:r>
             <a:endParaRPr/>
           </a:p>
@@ -1257,7 +1257,7 @@
               <a:buNone/>
             </a:pPr>
             <a:r>
-              <a:t>Run from the Mac repo folder in the same host terminal, one step at a time. Each step script writes src/main.cpp and src/CMakeLists.txt locally. Run copies them to Ubuntu, rebuilds, starts a fresh ten-second agent run, generates example activity, then displays status and saves logs/&lt;run-id&gt;.log and logs/&lt;run-id&gt;.jsonl locally. The agent stops and the VM remains running. Comment blocks mark additions. Step scripts replace local edits. Run copies those current files into the VM. Steps include all earlier changes and can be rerun or skipped. Run executes /usr/bin/id inside Ubuntu automatically after attachment. No second terminal or VM shell is needed.</a:t>
+              <a:t>Run from the Mac repo folder in the same host terminal, one step at a time. Each step script writes src/main.cpp and src/CMakeLists.txt locally. Run copies them to Ubuntu, rebuilds, starts a fresh ten-second agent run, generates example activity, then displays status and saves logs/stage-N.log and logs/stage-N.jsonl locally. The agent stops and the VM remains running. Comment blocks mark additions. Step scripts replace local edits. Run copies those current files into the VM. Steps include all earlier changes and can be rerun or skipped. Run executes /usr/bin/id inside Ubuntu automatically after attachment. No second terminal or VM shell is needed.</a:t>
             </a:r>
             <a:endParaRPr/>
           </a:p>
@@ -1337,7 +1337,7 @@
               <a:buNone/>
             </a:pPr>
             <a:r>
-              <a:t>Run from the Windows repo folder in the same host terminal, one step at a time. Each step script writes src/main.cpp and src/CMakeLists.txt locally. Run copies them to Ubuntu, rebuilds, starts a fresh ten-second agent run, generates example activity, then displays status and saves logs/&lt;run-id&gt;.log and logs/&lt;run-id&gt;.jsonl locally. The agent stops and the VM remains running. Comment blocks mark additions. Step scripts replace local edits. Run copies those current files into the VM. Steps include all earlier changes and can be rerun or skipped. Run executes /usr/bin/id inside Ubuntu automatically after attachment. No second terminal or VM shell is needed.</a:t>
+              <a:t>Run from the Windows repo folder in the same host terminal, one step at a time. Each step script writes src/main.cpp and src/CMakeLists.txt locally. Run copies them to Ubuntu, rebuilds, starts a fresh ten-second agent run, generates example activity, then displays status and saves logs/stage-N.log and logs/stage-N.jsonl locally. The agent stops and the VM remains running. Comment blocks mark additions. Step scripts replace local edits. Run copies those current files into the VM. Steps include all earlier changes and can be rerun or skipped. Run executes /usr/bin/id inside Ubuntu automatically after attachment. No second terminal or VM shell is needed.</a:t>
             </a:r>
             <a:endParaRPr/>
           </a:p>
@@ -5665,18 +5665,18 @@
   </p:cSld>
   <p:clrMap bg1="lt1" tx1="dk1" bg2="dk2" tx2="lt2" accent1="accent1" accent2="accent2" accent3="accent3" accent4="accent4" accent5="accent5" accent6="accent6" hlink="hlink" folHlink="folHlink"/>
   <p:sldLayoutIdLst>
-    <p:sldLayoutId xmlns:r="http://schemas.openxmlformats.org/officeDocument/2006/relationships" id="2147483649" r:id="R407108247ff54294"/>
-    <p:sldLayoutId xmlns:r="http://schemas.openxmlformats.org/officeDocument/2006/relationships" id="2147483650" r:id="Rf6ba331ea6ff41ff"/>
-    <p:sldLayoutId xmlns:r="http://schemas.openxmlformats.org/officeDocument/2006/relationships" id="2147483651" r:id="Re136a5e94e4544d9"/>
-    <p:sldLayoutId xmlns:r="http://schemas.openxmlformats.org/officeDocument/2006/relationships" id="2147483652" r:id="Rdb9b92fb16554ef4"/>
-    <p:sldLayoutId xmlns:r="http://schemas.openxmlformats.org/officeDocument/2006/relationships" id="2147483653" r:id="Rc9799ff28ad04177"/>
-    <p:sldLayoutId xmlns:r="http://schemas.openxmlformats.org/officeDocument/2006/relationships" id="2147483654" r:id="R9151c8ce1b0d4df3"/>
-    <p:sldLayoutId xmlns:r="http://schemas.openxmlformats.org/officeDocument/2006/relationships" id="2147483655" r:id="Ra44c1fdf492c4914"/>
-    <p:sldLayoutId xmlns:r="http://schemas.openxmlformats.org/officeDocument/2006/relationships" id="2147483656" r:id="R36e87f1b46d74aaf"/>
-    <p:sldLayoutId xmlns:r="http://schemas.openxmlformats.org/officeDocument/2006/relationships" id="2147483657" r:id="R60a81417e3844df6"/>
-    <p:sldLayoutId xmlns:r="http://schemas.openxmlformats.org/officeDocument/2006/relationships" id="2147483658" r:id="Rbf53c9990a8748e7"/>
-    <p:sldLayoutId xmlns:r="http://schemas.openxmlformats.org/officeDocument/2006/relationships" id="2147483659" r:id="R15bc2348dcee4f90"/>
-    <p:sldLayoutId xmlns:r="http://schemas.openxmlformats.org/officeDocument/2006/relationships" id="2147483660" r:id="R8e5e2739aac1468c"/>
+    <p:sldLayoutId xmlns:r="http://schemas.openxmlformats.org/officeDocument/2006/relationships" id="2147483649" r:id="Rc82f69ab6c7f4312"/>
+    <p:sldLayoutId xmlns:r="http://schemas.openxmlformats.org/officeDocument/2006/relationships" id="2147483650" r:id="R320d29c593f04b56"/>
+    <p:sldLayoutId xmlns:r="http://schemas.openxmlformats.org/officeDocument/2006/relationships" id="2147483651" r:id="Rdf53aee855e6494b"/>
+    <p:sldLayoutId xmlns:r="http://schemas.openxmlformats.org/officeDocument/2006/relationships" id="2147483652" r:id="R0cc1502ae0aa4714"/>
+    <p:sldLayoutId xmlns:r="http://schemas.openxmlformats.org/officeDocument/2006/relationships" id="2147483653" r:id="R4561d0d615144a4a"/>
+    <p:sldLayoutId xmlns:r="http://schemas.openxmlformats.org/officeDocument/2006/relationships" id="2147483654" r:id="R1076af88943e4671"/>
+    <p:sldLayoutId xmlns:r="http://schemas.openxmlformats.org/officeDocument/2006/relationships" id="2147483655" r:id="R31a825233d1540df"/>
+    <p:sldLayoutId xmlns:r="http://schemas.openxmlformats.org/officeDocument/2006/relationships" id="2147483656" r:id="Rc666c6f37d144c33"/>
+    <p:sldLayoutId xmlns:r="http://schemas.openxmlformats.org/officeDocument/2006/relationships" id="2147483657" r:id="Rfdf71c9d8a9b46f6"/>
+    <p:sldLayoutId xmlns:r="http://schemas.openxmlformats.org/officeDocument/2006/relationships" id="2147483658" r:id="Rab05487845384af6"/>
+    <p:sldLayoutId xmlns:r="http://schemas.openxmlformats.org/officeDocument/2006/relationships" id="2147483659" r:id="R613540de7bcf4516"/>
+    <p:sldLayoutId xmlns:r="http://schemas.openxmlformats.org/officeDocument/2006/relationships" id="2147483660" r:id="Rc19ae71143e2464e"/>
   </p:sldLayoutIdLst>
   <p:hf sldNum="0" hdr="0" ftr="0" dt="0"/>
   <p:txStyles>
@@ -6361,7 +6361,7 @@
   </p:cSld>
   <p:clrMap bg1="lt1" tx1="dk1" bg2="dk2" tx2="lt2" accent1="accent1" accent2="accent2" accent3="accent3" accent4="accent4" accent5="accent5" accent6="accent6" hlink="hlink" folHlink="folHlink"/>
   <p:sldLayoutIdLst>
-    <p:sldLayoutId xmlns:r="http://schemas.openxmlformats.org/officeDocument/2006/relationships" id="2147483662" r:id="R8e7198cc9e81475e"/>
+    <p:sldLayoutId xmlns:r="http://schemas.openxmlformats.org/officeDocument/2006/relationships" id="2147483662" r:id="R70eba5c8f2fb4466"/>
   </p:sldLayoutIdLst>
   <p:hf sldNum="0" hdr="0" ftr="0" dt="0"/>
   <p:txStyles>
@@ -8210,7 +8210,7 @@
           <p:nvPr/>
         </p:nvPicPr>
         <p:blipFill rotWithShape="1">
-          <a:blip xmlns:r="http://schemas.openxmlformats.org/officeDocument/2006/relationships" xmlns:a="http://schemas.openxmlformats.org/drawingml/2006/main" r:embed="R1346af1622e94cd8">
+          <a:blip xmlns:r="http://schemas.openxmlformats.org/officeDocument/2006/relationships" xmlns:a="http://schemas.openxmlformats.org/drawingml/2006/main" r:embed="R5dd35cd9af594239">
             <a:alphaModFix/>
           </a:blip>
           <a:srcRect xmlns:a="http://schemas.openxmlformats.org/drawingml/2006/main" l="0" t="0" r="0" b="0"/>
@@ -8238,7 +8238,7 @@
           <p:nvPr/>
         </p:nvPicPr>
         <p:blipFill rotWithShape="1">
-          <a:blip xmlns:r="http://schemas.openxmlformats.org/officeDocument/2006/relationships" xmlns:a="http://schemas.openxmlformats.org/drawingml/2006/main" r:embed="R1346af1622e94cd8">
+          <a:blip xmlns:r="http://schemas.openxmlformats.org/officeDocument/2006/relationships" xmlns:a="http://schemas.openxmlformats.org/drawingml/2006/main" r:embed="R5dd35cd9af594239">
             <a:alphaModFix/>
           </a:blip>
           <a:srcRect xmlns:a="http://schemas.openxmlformats.org/drawingml/2006/main" l="0" t="0" r="0" b="0"/>
@@ -8266,7 +8266,7 @@
           <p:nvPr/>
         </p:nvPicPr>
         <p:blipFill rotWithShape="1">
-          <a:blip xmlns:r="http://schemas.openxmlformats.org/officeDocument/2006/relationships" xmlns:a="http://schemas.openxmlformats.org/drawingml/2006/main" r:embed="R1346af1622e94cd8">
+          <a:blip xmlns:r="http://schemas.openxmlformats.org/officeDocument/2006/relationships" xmlns:a="http://schemas.openxmlformats.org/drawingml/2006/main" r:embed="R5dd35cd9af594239">
             <a:alphaModFix/>
           </a:blip>
           <a:srcRect xmlns:a="http://schemas.openxmlformats.org/drawingml/2006/main" l="0" t="0" r="0" b="0"/>
@@ -8294,7 +8294,7 @@
           <p:nvPr/>
         </p:nvPicPr>
         <p:blipFill rotWithShape="1">
-          <a:blip xmlns:r="http://schemas.openxmlformats.org/officeDocument/2006/relationships" xmlns:a="http://schemas.openxmlformats.org/drawingml/2006/main" r:embed="R1346af1622e94cd8">
+          <a:blip xmlns:r="http://schemas.openxmlformats.org/officeDocument/2006/relationships" xmlns:a="http://schemas.openxmlformats.org/drawingml/2006/main" r:embed="R5dd35cd9af594239">
             <a:alphaModFix/>
           </a:blip>
           <a:srcRect xmlns:a="http://schemas.openxmlformats.org/drawingml/2006/main" l="0" t="0" r="0" b="0"/>
@@ -8322,7 +8322,7 @@
           <p:nvPr/>
         </p:nvPicPr>
         <p:blipFill rotWithShape="1">
-          <a:blip xmlns:r="http://schemas.openxmlformats.org/officeDocument/2006/relationships" xmlns:a="http://schemas.openxmlformats.org/drawingml/2006/main" r:embed="R1346af1622e94cd8">
+          <a:blip xmlns:r="http://schemas.openxmlformats.org/officeDocument/2006/relationships" xmlns:a="http://schemas.openxmlformats.org/drawingml/2006/main" r:embed="R5dd35cd9af594239">
             <a:alphaModFix/>
           </a:blip>
           <a:srcRect xmlns:a="http://schemas.openxmlformats.org/drawingml/2006/main" l="0" t="0" r="0" b="0"/>
@@ -8350,7 +8350,7 @@
           <p:nvPr/>
         </p:nvPicPr>
         <p:blipFill rotWithShape="1">
-          <a:blip xmlns:r="http://schemas.openxmlformats.org/officeDocument/2006/relationships" xmlns:a="http://schemas.openxmlformats.org/drawingml/2006/main" r:embed="R1346af1622e94cd8">
+          <a:blip xmlns:r="http://schemas.openxmlformats.org/officeDocument/2006/relationships" xmlns:a="http://schemas.openxmlformats.org/drawingml/2006/main" r:embed="R5dd35cd9af594239">
             <a:alphaModFix/>
           </a:blip>
           <a:srcRect xmlns:a="http://schemas.openxmlformats.org/drawingml/2006/main" l="0" t="0" r="0" b="0"/>
@@ -8378,7 +8378,7 @@
           <p:nvPr/>
         </p:nvPicPr>
         <p:blipFill rotWithShape="1">
-          <a:blip xmlns:r="http://schemas.openxmlformats.org/officeDocument/2006/relationships" xmlns:a="http://schemas.openxmlformats.org/drawingml/2006/main" r:embed="R1346af1622e94cd8">
+          <a:blip xmlns:r="http://schemas.openxmlformats.org/officeDocument/2006/relationships" xmlns:a="http://schemas.openxmlformats.org/drawingml/2006/main" r:embed="R5dd35cd9af594239">
             <a:alphaModFix/>
           </a:blip>
           <a:srcRect xmlns:a="http://schemas.openxmlformats.org/drawingml/2006/main" l="0" t="0" r="0" b="0"/>
@@ -8406,7 +8406,7 @@
           <p:nvPr/>
         </p:nvPicPr>
         <p:blipFill rotWithShape="1">
-          <a:blip xmlns:r="http://schemas.openxmlformats.org/officeDocument/2006/relationships" xmlns:a="http://schemas.openxmlformats.org/drawingml/2006/main" r:embed="R1346af1622e94cd8">
+          <a:blip xmlns:r="http://schemas.openxmlformats.org/officeDocument/2006/relationships" xmlns:a="http://schemas.openxmlformats.org/drawingml/2006/main" r:embed="R5dd35cd9af594239">
             <a:alphaModFix/>
           </a:blip>
           <a:srcRect xmlns:a="http://schemas.openxmlformats.org/drawingml/2006/main" l="0" t="0" r="0" b="0"/>
@@ -10499,7 +10499,7 @@
           <p:nvPr/>
         </p:nvPicPr>
         <p:blipFill rotWithShape="1">
-          <a:blip xmlns:r="http://schemas.openxmlformats.org/officeDocument/2006/relationships" xmlns:a="http://schemas.openxmlformats.org/drawingml/2006/main" r:embed="R97de0e3900a4491f">
+          <a:blip xmlns:r="http://schemas.openxmlformats.org/officeDocument/2006/relationships" xmlns:a="http://schemas.openxmlformats.org/drawingml/2006/main" r:embed="R97c2a84deddc4435">
             <a:alphaModFix/>
           </a:blip>
           <a:srcRect xmlns:a="http://schemas.openxmlformats.org/drawingml/2006/main" l="0" t="0" r="0" b="0"/>
@@ -10527,7 +10527,7 @@
           <p:nvPr/>
         </p:nvPicPr>
         <p:blipFill rotWithShape="1">
-          <a:blip xmlns:r="http://schemas.openxmlformats.org/officeDocument/2006/relationships" xmlns:a="http://schemas.openxmlformats.org/drawingml/2006/main" r:embed="R97de0e3900a4491f">
+          <a:blip xmlns:r="http://schemas.openxmlformats.org/officeDocument/2006/relationships" xmlns:a="http://schemas.openxmlformats.org/drawingml/2006/main" r:embed="R97c2a84deddc4435">
             <a:alphaModFix/>
           </a:blip>
           <a:srcRect xmlns:a="http://schemas.openxmlformats.org/drawingml/2006/main" l="0" t="0" r="0" b="0"/>
@@ -10555,7 +10555,7 @@
           <p:nvPr/>
         </p:nvPicPr>
         <p:blipFill rotWithShape="1">
-          <a:blip xmlns:r="http://schemas.openxmlformats.org/officeDocument/2006/relationships" xmlns:a="http://schemas.openxmlformats.org/drawingml/2006/main" r:embed="R97de0e3900a4491f">
+          <a:blip xmlns:r="http://schemas.openxmlformats.org/officeDocument/2006/relationships" xmlns:a="http://schemas.openxmlformats.org/drawingml/2006/main" r:embed="R97c2a84deddc4435">
             <a:alphaModFix/>
           </a:blip>
           <a:srcRect xmlns:a="http://schemas.openxmlformats.org/drawingml/2006/main" l="0" t="0" r="0" b="0"/>
@@ -10583,7 +10583,7 @@
           <p:nvPr/>
         </p:nvPicPr>
         <p:blipFill rotWithShape="1">
-          <a:blip xmlns:r="http://schemas.openxmlformats.org/officeDocument/2006/relationships" xmlns:a="http://schemas.openxmlformats.org/drawingml/2006/main" r:embed="R97de0e3900a4491f">
+          <a:blip xmlns:r="http://schemas.openxmlformats.org/officeDocument/2006/relationships" xmlns:a="http://schemas.openxmlformats.org/drawingml/2006/main" r:embed="R97c2a84deddc4435">
             <a:alphaModFix/>
           </a:blip>
           <a:srcRect xmlns:a="http://schemas.openxmlformats.org/drawingml/2006/main" l="0" t="0" r="0" b="0"/>
@@ -12592,7 +12592,7 @@
           <p:nvPr/>
         </p:nvPicPr>
         <p:blipFill rotWithShape="1">
-          <a:blip xmlns:r="http://schemas.openxmlformats.org/officeDocument/2006/relationships" xmlns:a="http://schemas.openxmlformats.org/drawingml/2006/main" r:embed="Rc01cc3123fb848b1">
+          <a:blip xmlns:r="http://schemas.openxmlformats.org/officeDocument/2006/relationships" xmlns:a="http://schemas.openxmlformats.org/drawingml/2006/main" r:embed="Raf578b26b033473e">
             <a:alphaModFix/>
           </a:blip>
           <a:srcRect xmlns:a="http://schemas.openxmlformats.org/drawingml/2006/main" l="0" t="0" r="0" b="0"/>
@@ -12620,7 +12620,7 @@
           <p:nvPr/>
         </p:nvPicPr>
         <p:blipFill rotWithShape="1">
-          <a:blip xmlns:r="http://schemas.openxmlformats.org/officeDocument/2006/relationships" xmlns:a="http://schemas.openxmlformats.org/drawingml/2006/main" r:embed="Rc01cc3123fb848b1">
+          <a:blip xmlns:r="http://schemas.openxmlformats.org/officeDocument/2006/relationships" xmlns:a="http://schemas.openxmlformats.org/drawingml/2006/main" r:embed="Raf578b26b033473e">
             <a:alphaModFix/>
           </a:blip>
           <a:srcRect xmlns:a="http://schemas.openxmlformats.org/drawingml/2006/main" l="0" t="0" r="0" b="0"/>
@@ -12648,7 +12648,7 @@
           <p:nvPr/>
         </p:nvPicPr>
         <p:blipFill rotWithShape="1">
-          <a:blip xmlns:r="http://schemas.openxmlformats.org/officeDocument/2006/relationships" xmlns:a="http://schemas.openxmlformats.org/drawingml/2006/main" r:embed="Rc01cc3123fb848b1">
+          <a:blip xmlns:r="http://schemas.openxmlformats.org/officeDocument/2006/relationships" xmlns:a="http://schemas.openxmlformats.org/drawingml/2006/main" r:embed="Raf578b26b033473e">
             <a:alphaModFix/>
           </a:blip>
           <a:srcRect xmlns:a="http://schemas.openxmlformats.org/drawingml/2006/main" l="0" t="0" r="0" b="0"/>
@@ -12676,7 +12676,7 @@
           <p:nvPr/>
         </p:nvPicPr>
         <p:blipFill rotWithShape="1">
-          <a:blip xmlns:r="http://schemas.openxmlformats.org/officeDocument/2006/relationships" xmlns:a="http://schemas.openxmlformats.org/drawingml/2006/main" r:embed="Rc01cc3123fb848b1">
+          <a:blip xmlns:r="http://schemas.openxmlformats.org/officeDocument/2006/relationships" xmlns:a="http://schemas.openxmlformats.org/drawingml/2006/main" r:embed="Raf578b26b033473e">
             <a:alphaModFix/>
           </a:blip>
           <a:srcRect xmlns:a="http://schemas.openxmlformats.org/drawingml/2006/main" l="0" t="0" r="0" b="0"/>
@@ -13326,7 +13326,7 @@
                 <a:ea typeface="Inter"/>
                 <a:cs typeface="Inter"/>
               </a:rPr>
-              <a:t>Each run keeps a status log and a syscall JSONL file.</a:t>
+              <a:t>Each stage keeps a status log and a syscall JSONL file.</a:t>
             </a:r>
           </a:p>
           <a:p xmlns:a="http://schemas.openxmlformats.org/drawingml/2006/main">
@@ -13817,7 +13817,7 @@
                 <a:ea typeface="Roboto Mono"/>
                 <a:cs typeface="Roboto Mono"/>
               </a:rPr>
-              <a:t># logs/&lt;run-id&gt;.log</a:t>
+              <a:t># logs/stage-3.log</a:t>
             </a:r>
           </a:p>
           <a:p xmlns:a="http://schemas.openxmlformats.org/drawingml/2006/main">
@@ -13959,7 +13959,7 @@
                 <a:ea typeface="Roboto Mono"/>
                 <a:cs typeface="Roboto Mono"/>
               </a:rPr>
-              <a:t># logs/&lt;run-id&gt;.jsonl</a:t>
+              <a:t># logs/stage-3.jsonl</a:t>
             </a:r>
           </a:p>
           <a:p xmlns:a="http://schemas.openxmlformats.org/drawingml/2006/main">
@@ -14669,7 +14669,7 @@
           <p:nvPr/>
         </p:nvPicPr>
         <p:blipFill rotWithShape="1">
-          <a:blip xmlns:r="http://schemas.openxmlformats.org/officeDocument/2006/relationships" xmlns:a="http://schemas.openxmlformats.org/drawingml/2006/main" r:embed="R93b488a8eb544957">
+          <a:blip xmlns:r="http://schemas.openxmlformats.org/officeDocument/2006/relationships" xmlns:a="http://schemas.openxmlformats.org/drawingml/2006/main" r:embed="R9d36992469c74461">
             <a:alphaModFix/>
           </a:blip>
           <a:srcRect xmlns:a="http://schemas.openxmlformats.org/drawingml/2006/main" l="0" t="0" r="0" b="0"/>
@@ -14697,7 +14697,7 @@
           <p:nvPr/>
         </p:nvPicPr>
         <p:blipFill rotWithShape="1">
-          <a:blip xmlns:r="http://schemas.openxmlformats.org/officeDocument/2006/relationships" xmlns:a="http://schemas.openxmlformats.org/drawingml/2006/main" r:embed="R93b488a8eb544957">
+          <a:blip xmlns:r="http://schemas.openxmlformats.org/officeDocument/2006/relationships" xmlns:a="http://schemas.openxmlformats.org/drawingml/2006/main" r:embed="R9d36992469c74461">
             <a:alphaModFix/>
           </a:blip>
           <a:srcRect xmlns:a="http://schemas.openxmlformats.org/drawingml/2006/main" l="0" t="0" r="0" b="0"/>
@@ -14725,7 +14725,7 @@
           <p:nvPr/>
         </p:nvPicPr>
         <p:blipFill rotWithShape="1">
-          <a:blip xmlns:r="http://schemas.openxmlformats.org/officeDocument/2006/relationships" xmlns:a="http://schemas.openxmlformats.org/drawingml/2006/main" r:embed="R93b488a8eb544957">
+          <a:blip xmlns:r="http://schemas.openxmlformats.org/officeDocument/2006/relationships" xmlns:a="http://schemas.openxmlformats.org/drawingml/2006/main" r:embed="R9d36992469c74461">
             <a:alphaModFix/>
           </a:blip>
           <a:srcRect xmlns:a="http://schemas.openxmlformats.org/drawingml/2006/main" l="0" t="0" r="0" b="0"/>
@@ -14753,7 +14753,7 @@
           <p:nvPr/>
         </p:nvPicPr>
         <p:blipFill rotWithShape="1">
-          <a:blip xmlns:r="http://schemas.openxmlformats.org/officeDocument/2006/relationships" xmlns:a="http://schemas.openxmlformats.org/drawingml/2006/main" r:embed="R93b488a8eb544957">
+          <a:blip xmlns:r="http://schemas.openxmlformats.org/officeDocument/2006/relationships" xmlns:a="http://schemas.openxmlformats.org/drawingml/2006/main" r:embed="R9d36992469c74461">
             <a:alphaModFix/>
           </a:blip>
           <a:srcRect xmlns:a="http://schemas.openxmlformats.org/drawingml/2006/main" l="0" t="0" r="0" b="0"/>
@@ -16634,7 +16634,7 @@
           <p:nvPr/>
         </p:nvPicPr>
         <p:blipFill rotWithShape="1">
-          <a:blip xmlns:r="http://schemas.openxmlformats.org/officeDocument/2006/relationships" xmlns:a="http://schemas.openxmlformats.org/drawingml/2006/main" r:embed="R95e8927c2fa843ef">
+          <a:blip xmlns:r="http://schemas.openxmlformats.org/officeDocument/2006/relationships" xmlns:a="http://schemas.openxmlformats.org/drawingml/2006/main" r:embed="Re84c4ac7619d4f79">
             <a:alphaModFix/>
           </a:blip>
           <a:srcRect xmlns:a="http://schemas.openxmlformats.org/drawingml/2006/main" l="0" t="0" r="0" b="0"/>
@@ -16662,7 +16662,7 @@
           <p:nvPr/>
         </p:nvPicPr>
         <p:blipFill rotWithShape="1">
-          <a:blip xmlns:r="http://schemas.openxmlformats.org/officeDocument/2006/relationships" xmlns:a="http://schemas.openxmlformats.org/drawingml/2006/main" r:embed="R95e8927c2fa843ef">
+          <a:blip xmlns:r="http://schemas.openxmlformats.org/officeDocument/2006/relationships" xmlns:a="http://schemas.openxmlformats.org/drawingml/2006/main" r:embed="Re84c4ac7619d4f79">
             <a:alphaModFix/>
           </a:blip>
           <a:srcRect xmlns:a="http://schemas.openxmlformats.org/drawingml/2006/main" l="0" t="0" r="0" b="0"/>
@@ -16690,7 +16690,7 @@
           <p:nvPr/>
         </p:nvPicPr>
         <p:blipFill rotWithShape="1">
-          <a:blip xmlns:r="http://schemas.openxmlformats.org/officeDocument/2006/relationships" xmlns:a="http://schemas.openxmlformats.org/drawingml/2006/main" r:embed="R95e8927c2fa843ef">
+          <a:blip xmlns:r="http://schemas.openxmlformats.org/officeDocument/2006/relationships" xmlns:a="http://schemas.openxmlformats.org/drawingml/2006/main" r:embed="Re84c4ac7619d4f79">
             <a:alphaModFix/>
           </a:blip>
           <a:srcRect xmlns:a="http://schemas.openxmlformats.org/drawingml/2006/main" l="0" t="0" r="0" b="0"/>
@@ -16718,7 +16718,7 @@
           <p:nvPr/>
         </p:nvPicPr>
         <p:blipFill rotWithShape="1">
-          <a:blip xmlns:r="http://schemas.openxmlformats.org/officeDocument/2006/relationships" xmlns:a="http://schemas.openxmlformats.org/drawingml/2006/main" r:embed="R95e8927c2fa843ef">
+          <a:blip xmlns:r="http://schemas.openxmlformats.org/officeDocument/2006/relationships" xmlns:a="http://schemas.openxmlformats.org/drawingml/2006/main" r:embed="Re84c4ac7619d4f79">
             <a:alphaModFix/>
           </a:blip>
           <a:srcRect xmlns:a="http://schemas.openxmlformats.org/drawingml/2006/main" l="0" t="0" r="0" b="0"/>
@@ -18561,7 +18561,7 @@
           <p:nvPr/>
         </p:nvPicPr>
         <p:blipFill rotWithShape="1">
-          <a:blip xmlns:r="http://schemas.openxmlformats.org/officeDocument/2006/relationships" xmlns:a="http://schemas.openxmlformats.org/drawingml/2006/main" r:embed="R3d11910e22f04b4e">
+          <a:blip xmlns:r="http://schemas.openxmlformats.org/officeDocument/2006/relationships" xmlns:a="http://schemas.openxmlformats.org/drawingml/2006/main" r:embed="R3b96f6c899134fcf">
             <a:alphaModFix/>
           </a:blip>
           <a:srcRect xmlns:a="http://schemas.openxmlformats.org/drawingml/2006/main" l="0" t="0" r="0" b="0"/>
@@ -18589,7 +18589,7 @@
           <p:nvPr/>
         </p:nvPicPr>
         <p:blipFill rotWithShape="1">
-          <a:blip xmlns:r="http://schemas.openxmlformats.org/officeDocument/2006/relationships" xmlns:a="http://schemas.openxmlformats.org/drawingml/2006/main" r:embed="R3d11910e22f04b4e">
+          <a:blip xmlns:r="http://schemas.openxmlformats.org/officeDocument/2006/relationships" xmlns:a="http://schemas.openxmlformats.org/drawingml/2006/main" r:embed="R3b96f6c899134fcf">
             <a:alphaModFix/>
           </a:blip>
           <a:srcRect xmlns:a="http://schemas.openxmlformats.org/drawingml/2006/main" l="0" t="0" r="0" b="0"/>
@@ -18617,7 +18617,7 @@
           <p:nvPr/>
         </p:nvPicPr>
         <p:blipFill rotWithShape="1">
-          <a:blip xmlns:r="http://schemas.openxmlformats.org/officeDocument/2006/relationships" xmlns:a="http://schemas.openxmlformats.org/drawingml/2006/main" r:embed="R3d11910e22f04b4e">
+          <a:blip xmlns:r="http://schemas.openxmlformats.org/officeDocument/2006/relationships" xmlns:a="http://schemas.openxmlformats.org/drawingml/2006/main" r:embed="R3b96f6c899134fcf">
             <a:alphaModFix/>
           </a:blip>
           <a:srcRect xmlns:a="http://schemas.openxmlformats.org/drawingml/2006/main" l="0" t="0" r="0" b="0"/>
@@ -18645,7 +18645,7 @@
           <p:nvPr/>
         </p:nvPicPr>
         <p:blipFill rotWithShape="1">
-          <a:blip xmlns:r="http://schemas.openxmlformats.org/officeDocument/2006/relationships" xmlns:a="http://schemas.openxmlformats.org/drawingml/2006/main" r:embed="R3d11910e22f04b4e">
+          <a:blip xmlns:r="http://schemas.openxmlformats.org/officeDocument/2006/relationships" xmlns:a="http://schemas.openxmlformats.org/drawingml/2006/main" r:embed="R3b96f6c899134fcf">
             <a:alphaModFix/>
           </a:blip>
           <a:srcRect xmlns:a="http://schemas.openxmlformats.org/drawingml/2006/main" l="0" t="0" r="0" b="0"/>
@@ -20258,7 +20258,7 @@
           <p:nvPr/>
         </p:nvPicPr>
         <p:blipFill rotWithShape="1">
-          <a:blip xmlns:r="http://schemas.openxmlformats.org/officeDocument/2006/relationships" xmlns:a="http://schemas.openxmlformats.org/drawingml/2006/main" r:embed="Re9c964f4b468455c">
+          <a:blip xmlns:r="http://schemas.openxmlformats.org/officeDocument/2006/relationships" xmlns:a="http://schemas.openxmlformats.org/drawingml/2006/main" r:embed="Rb61d9a434bb54168">
             <a:alphaModFix/>
           </a:blip>
           <a:srcRect xmlns:a="http://schemas.openxmlformats.org/drawingml/2006/main" l="0" t="0" r="0" b="0"/>
@@ -20286,7 +20286,7 @@
           <p:nvPr/>
         </p:nvPicPr>
         <p:blipFill rotWithShape="1">
-          <a:blip xmlns:r="http://schemas.openxmlformats.org/officeDocument/2006/relationships" xmlns:a="http://schemas.openxmlformats.org/drawingml/2006/main" r:embed="Re9c964f4b468455c">
+          <a:blip xmlns:r="http://schemas.openxmlformats.org/officeDocument/2006/relationships" xmlns:a="http://schemas.openxmlformats.org/drawingml/2006/main" r:embed="Rb61d9a434bb54168">
             <a:alphaModFix/>
           </a:blip>
           <a:srcRect xmlns:a="http://schemas.openxmlformats.org/drawingml/2006/main" l="0" t="0" r="0" b="0"/>
@@ -20314,7 +20314,7 @@
           <p:nvPr/>
         </p:nvPicPr>
         <p:blipFill rotWithShape="1">
-          <a:blip xmlns:r="http://schemas.openxmlformats.org/officeDocument/2006/relationships" xmlns:a="http://schemas.openxmlformats.org/drawingml/2006/main" r:embed="Re9c964f4b468455c">
+          <a:blip xmlns:r="http://schemas.openxmlformats.org/officeDocument/2006/relationships" xmlns:a="http://schemas.openxmlformats.org/drawingml/2006/main" r:embed="Rb61d9a434bb54168">
             <a:alphaModFix/>
           </a:blip>
           <a:srcRect xmlns:a="http://schemas.openxmlformats.org/drawingml/2006/main" l="0" t="0" r="0" b="0"/>
@@ -20342,7 +20342,7 @@
           <p:nvPr/>
         </p:nvPicPr>
         <p:blipFill rotWithShape="1">
-          <a:blip xmlns:r="http://schemas.openxmlformats.org/officeDocument/2006/relationships" xmlns:a="http://schemas.openxmlformats.org/drawingml/2006/main" r:embed="Re9c964f4b468455c">
+          <a:blip xmlns:r="http://schemas.openxmlformats.org/officeDocument/2006/relationships" xmlns:a="http://schemas.openxmlformats.org/drawingml/2006/main" r:embed="Rb61d9a434bb54168">
             <a:alphaModFix/>
           </a:blip>
           <a:srcRect xmlns:a="http://schemas.openxmlformats.org/drawingml/2006/main" l="0" t="0" r="0" b="0"/>
@@ -21955,7 +21955,7 @@
           <p:nvPr/>
         </p:nvPicPr>
         <p:blipFill rotWithShape="1">
-          <a:blip xmlns:r="http://schemas.openxmlformats.org/officeDocument/2006/relationships" xmlns:a="http://schemas.openxmlformats.org/drawingml/2006/main" r:embed="R0bc2eb91ef434ad8">
+          <a:blip xmlns:r="http://schemas.openxmlformats.org/officeDocument/2006/relationships" xmlns:a="http://schemas.openxmlformats.org/drawingml/2006/main" r:embed="Ra8e79946fb8f47d2">
             <a:alphaModFix/>
           </a:blip>
           <a:srcRect xmlns:a="http://schemas.openxmlformats.org/drawingml/2006/main" l="0" t="0" r="0" b="0"/>
@@ -21983,7 +21983,7 @@
           <p:nvPr/>
         </p:nvPicPr>
         <p:blipFill rotWithShape="1">
-          <a:blip xmlns:r="http://schemas.openxmlformats.org/officeDocument/2006/relationships" xmlns:a="http://schemas.openxmlformats.org/drawingml/2006/main" r:embed="R0bc2eb91ef434ad8">
+          <a:blip xmlns:r="http://schemas.openxmlformats.org/officeDocument/2006/relationships" xmlns:a="http://schemas.openxmlformats.org/drawingml/2006/main" r:embed="Ra8e79946fb8f47d2">
             <a:alphaModFix/>
           </a:blip>
           <a:srcRect xmlns:a="http://schemas.openxmlformats.org/drawingml/2006/main" l="0" t="0" r="0" b="0"/>
@@ -22011,7 +22011,7 @@
           <p:nvPr/>
         </p:nvPicPr>
         <p:blipFill rotWithShape="1">
-          <a:blip xmlns:r="http://schemas.openxmlformats.org/officeDocument/2006/relationships" xmlns:a="http://schemas.openxmlformats.org/drawingml/2006/main" r:embed="R0bc2eb91ef434ad8">
+          <a:blip xmlns:r="http://schemas.openxmlformats.org/officeDocument/2006/relationships" xmlns:a="http://schemas.openxmlformats.org/drawingml/2006/main" r:embed="Ra8e79946fb8f47d2">
             <a:alphaModFix/>
           </a:blip>
           <a:srcRect xmlns:a="http://schemas.openxmlformats.org/drawingml/2006/main" l="0" t="0" r="0" b="0"/>
@@ -22039,7 +22039,7 @@
           <p:nvPr/>
         </p:nvPicPr>
         <p:blipFill rotWithShape="1">
-          <a:blip xmlns:r="http://schemas.openxmlformats.org/officeDocument/2006/relationships" xmlns:a="http://schemas.openxmlformats.org/drawingml/2006/main" r:embed="R0bc2eb91ef434ad8">
+          <a:blip xmlns:r="http://schemas.openxmlformats.org/officeDocument/2006/relationships" xmlns:a="http://schemas.openxmlformats.org/drawingml/2006/main" r:embed="Ra8e79946fb8f47d2">
             <a:alphaModFix/>
           </a:blip>
           <a:srcRect xmlns:a="http://schemas.openxmlformats.org/drawingml/2006/main" l="0" t="0" r="0" b="0"/>
@@ -23284,7 +23284,7 @@
                 <a:ea typeface="Roboto Mono"/>
                 <a:cs typeface="Roboto Mono"/>
               </a:rPr>
-              <a:t>Save logs/&lt;run-id&gt;.log</a:t>
+              <a:t>Save logs/stage-N.log</a:t>
             </a:r>
           </a:p>
           <a:p xmlns:a="http://schemas.openxmlformats.org/drawingml/2006/main">
@@ -23314,7 +23314,7 @@
                 <a:ea typeface="Roboto Mono"/>
                 <a:cs typeface="Roboto Mono"/>
               </a:rPr>
-              <a:t>and logs/&lt;run-id&gt;.jsonl</a:t>
+              <a:t>and logs/stage-N.jsonl</a:t>
             </a:r>
           </a:p>
         </p:txBody>
@@ -23964,7 +23964,7 @@
           <p:nvPr/>
         </p:nvPicPr>
         <p:blipFill rotWithShape="1">
-          <a:blip xmlns:r="http://schemas.openxmlformats.org/officeDocument/2006/relationships" xmlns:a="http://schemas.openxmlformats.org/drawingml/2006/main" r:embed="R4b021072fd8344db">
+          <a:blip xmlns:r="http://schemas.openxmlformats.org/officeDocument/2006/relationships" xmlns:a="http://schemas.openxmlformats.org/drawingml/2006/main" r:embed="R4062f1fc873b4653">
             <a:alphaModFix/>
           </a:blip>
           <a:srcRect xmlns:a="http://schemas.openxmlformats.org/drawingml/2006/main" l="0" t="0" r="0" b="0"/>
@@ -23992,7 +23992,7 @@
           <p:nvPr/>
         </p:nvPicPr>
         <p:blipFill rotWithShape="1">
-          <a:blip xmlns:r="http://schemas.openxmlformats.org/officeDocument/2006/relationships" xmlns:a="http://schemas.openxmlformats.org/drawingml/2006/main" r:embed="R4b021072fd8344db">
+          <a:blip xmlns:r="http://schemas.openxmlformats.org/officeDocument/2006/relationships" xmlns:a="http://schemas.openxmlformats.org/drawingml/2006/main" r:embed="R4062f1fc873b4653">
             <a:alphaModFix/>
           </a:blip>
           <a:srcRect xmlns:a="http://schemas.openxmlformats.org/drawingml/2006/main" l="0" t="0" r="0" b="0"/>
@@ -24020,7 +24020,7 @@
           <p:nvPr/>
         </p:nvPicPr>
         <p:blipFill rotWithShape="1">
-          <a:blip xmlns:r="http://schemas.openxmlformats.org/officeDocument/2006/relationships" xmlns:a="http://schemas.openxmlformats.org/drawingml/2006/main" r:embed="R4b021072fd8344db">
+          <a:blip xmlns:r="http://schemas.openxmlformats.org/officeDocument/2006/relationships" xmlns:a="http://schemas.openxmlformats.org/drawingml/2006/main" r:embed="R4062f1fc873b4653">
             <a:alphaModFix/>
           </a:blip>
           <a:srcRect xmlns:a="http://schemas.openxmlformats.org/drawingml/2006/main" l="0" t="0" r="0" b="0"/>
@@ -24048,7 +24048,7 @@
           <p:nvPr/>
         </p:nvPicPr>
         <p:blipFill rotWithShape="1">
-          <a:blip xmlns:r="http://schemas.openxmlformats.org/officeDocument/2006/relationships" xmlns:a="http://schemas.openxmlformats.org/drawingml/2006/main" r:embed="R4b021072fd8344db">
+          <a:blip xmlns:r="http://schemas.openxmlformats.org/officeDocument/2006/relationships" xmlns:a="http://schemas.openxmlformats.org/drawingml/2006/main" r:embed="R4062f1fc873b4653">
             <a:alphaModFix/>
           </a:blip>
           <a:srcRect xmlns:a="http://schemas.openxmlformats.org/drawingml/2006/main" l="0" t="0" r="0" b="0"/>
@@ -25729,7 +25729,7 @@
           <p:nvPr/>
         </p:nvPicPr>
         <p:blipFill rotWithShape="1">
-          <a:blip xmlns:r="http://schemas.openxmlformats.org/officeDocument/2006/relationships" xmlns:a="http://schemas.openxmlformats.org/drawingml/2006/main" r:embed="Rf67f2248ac1a4a5f">
+          <a:blip xmlns:r="http://schemas.openxmlformats.org/officeDocument/2006/relationships" xmlns:a="http://schemas.openxmlformats.org/drawingml/2006/main" r:embed="Rf2dd41ece0bb4771">
             <a:alphaModFix/>
           </a:blip>
           <a:srcRect xmlns:a="http://schemas.openxmlformats.org/drawingml/2006/main" l="0" t="0" r="0" b="0"/>
@@ -25757,7 +25757,7 @@
           <p:nvPr/>
         </p:nvPicPr>
         <p:blipFill rotWithShape="1">
-          <a:blip xmlns:r="http://schemas.openxmlformats.org/officeDocument/2006/relationships" xmlns:a="http://schemas.openxmlformats.org/drawingml/2006/main" r:embed="Rf67f2248ac1a4a5f">
+          <a:blip xmlns:r="http://schemas.openxmlformats.org/officeDocument/2006/relationships" xmlns:a="http://schemas.openxmlformats.org/drawingml/2006/main" r:embed="Rf2dd41ece0bb4771">
             <a:alphaModFix/>
           </a:blip>
           <a:srcRect xmlns:a="http://schemas.openxmlformats.org/drawingml/2006/main" l="0" t="0" r="0" b="0"/>
@@ -25785,7 +25785,7 @@
           <p:nvPr/>
         </p:nvPicPr>
         <p:blipFill rotWithShape="1">
-          <a:blip xmlns:r="http://schemas.openxmlformats.org/officeDocument/2006/relationships" xmlns:a="http://schemas.openxmlformats.org/drawingml/2006/main" r:embed="Rf67f2248ac1a4a5f">
+          <a:blip xmlns:r="http://schemas.openxmlformats.org/officeDocument/2006/relationships" xmlns:a="http://schemas.openxmlformats.org/drawingml/2006/main" r:embed="Rf2dd41ece0bb4771">
             <a:alphaModFix/>
           </a:blip>
           <a:srcRect xmlns:a="http://schemas.openxmlformats.org/drawingml/2006/main" l="0" t="0" r="0" b="0"/>
@@ -25813,7 +25813,7 @@
           <p:nvPr/>
         </p:nvPicPr>
         <p:blipFill rotWithShape="1">
-          <a:blip xmlns:r="http://schemas.openxmlformats.org/officeDocument/2006/relationships" xmlns:a="http://schemas.openxmlformats.org/drawingml/2006/main" r:embed="Rf67f2248ac1a4a5f">
+          <a:blip xmlns:r="http://schemas.openxmlformats.org/officeDocument/2006/relationships" xmlns:a="http://schemas.openxmlformats.org/drawingml/2006/main" r:embed="Rf2dd41ece0bb4771">
             <a:alphaModFix/>
           </a:blip>
           <a:srcRect xmlns:a="http://schemas.openxmlformats.org/drawingml/2006/main" l="0" t="0" r="0" b="0"/>
@@ -27494,7 +27494,7 @@
           <p:nvPr/>
         </p:nvPicPr>
         <p:blipFill rotWithShape="1">
-          <a:blip xmlns:r="http://schemas.openxmlformats.org/officeDocument/2006/relationships" xmlns:a="http://schemas.openxmlformats.org/drawingml/2006/main" r:embed="R7d06e26a20f54a55">
+          <a:blip xmlns:r="http://schemas.openxmlformats.org/officeDocument/2006/relationships" xmlns:a="http://schemas.openxmlformats.org/drawingml/2006/main" r:embed="R360801152d124ece">
             <a:alphaModFix/>
           </a:blip>
           <a:srcRect xmlns:a="http://schemas.openxmlformats.org/drawingml/2006/main" l="0" t="0" r="0" b="0"/>
@@ -27522,7 +27522,7 @@
           <p:nvPr/>
         </p:nvPicPr>
         <p:blipFill rotWithShape="1">
-          <a:blip xmlns:r="http://schemas.openxmlformats.org/officeDocument/2006/relationships" xmlns:a="http://schemas.openxmlformats.org/drawingml/2006/main" r:embed="R7d06e26a20f54a55">
+          <a:blip xmlns:r="http://schemas.openxmlformats.org/officeDocument/2006/relationships" xmlns:a="http://schemas.openxmlformats.org/drawingml/2006/main" r:embed="R360801152d124ece">
             <a:alphaModFix/>
           </a:blip>
           <a:srcRect xmlns:a="http://schemas.openxmlformats.org/drawingml/2006/main" l="0" t="0" r="0" b="0"/>
@@ -27550,7 +27550,7 @@
           <p:nvPr/>
         </p:nvPicPr>
         <p:blipFill rotWithShape="1">
-          <a:blip xmlns:r="http://schemas.openxmlformats.org/officeDocument/2006/relationships" xmlns:a="http://schemas.openxmlformats.org/drawingml/2006/main" r:embed="R7d06e26a20f54a55">
+          <a:blip xmlns:r="http://schemas.openxmlformats.org/officeDocument/2006/relationships" xmlns:a="http://schemas.openxmlformats.org/drawingml/2006/main" r:embed="R360801152d124ece">
             <a:alphaModFix/>
           </a:blip>
           <a:srcRect xmlns:a="http://schemas.openxmlformats.org/drawingml/2006/main" l="0" t="0" r="0" b="0"/>
@@ -27578,7 +27578,7 @@
           <p:nvPr/>
         </p:nvPicPr>
         <p:blipFill rotWithShape="1">
-          <a:blip xmlns:r="http://schemas.openxmlformats.org/officeDocument/2006/relationships" xmlns:a="http://schemas.openxmlformats.org/drawingml/2006/main" r:embed="R7d06e26a20f54a55">
+          <a:blip xmlns:r="http://schemas.openxmlformats.org/officeDocument/2006/relationships" xmlns:a="http://schemas.openxmlformats.org/drawingml/2006/main" r:embed="R360801152d124ece">
             <a:alphaModFix/>
           </a:blip>
           <a:srcRect xmlns:a="http://schemas.openxmlformats.org/drawingml/2006/main" l="0" t="0" r="0" b="0"/>
@@ -29669,7 +29669,7 @@
           <p:nvPr/>
         </p:nvPicPr>
         <p:blipFill rotWithShape="1">
-          <a:blip xmlns:r="http://schemas.openxmlformats.org/officeDocument/2006/relationships" xmlns:a="http://schemas.openxmlformats.org/drawingml/2006/main" r:embed="Rc83f271572404157">
+          <a:blip xmlns:r="http://schemas.openxmlformats.org/officeDocument/2006/relationships" xmlns:a="http://schemas.openxmlformats.org/drawingml/2006/main" r:embed="R18575ce5d9d843b3">
             <a:alphaModFix/>
           </a:blip>
           <a:srcRect xmlns:a="http://schemas.openxmlformats.org/drawingml/2006/main" l="0" t="0" r="0" b="0"/>
@@ -29697,7 +29697,7 @@
           <p:nvPr/>
         </p:nvPicPr>
         <p:blipFill rotWithShape="1">
-          <a:blip xmlns:r="http://schemas.openxmlformats.org/officeDocument/2006/relationships" xmlns:a="http://schemas.openxmlformats.org/drawingml/2006/main" r:embed="Rc83f271572404157">
+          <a:blip xmlns:r="http://schemas.openxmlformats.org/officeDocument/2006/relationships" xmlns:a="http://schemas.openxmlformats.org/drawingml/2006/main" r:embed="R18575ce5d9d843b3">
             <a:alphaModFix/>
           </a:blip>
           <a:srcRect xmlns:a="http://schemas.openxmlformats.org/drawingml/2006/main" l="0" t="0" r="0" b="0"/>
@@ -29725,7 +29725,7 @@
           <p:nvPr/>
         </p:nvPicPr>
         <p:blipFill rotWithShape="1">
-          <a:blip xmlns:r="http://schemas.openxmlformats.org/officeDocument/2006/relationships" xmlns:a="http://schemas.openxmlformats.org/drawingml/2006/main" r:embed="Rc83f271572404157">
+          <a:blip xmlns:r="http://schemas.openxmlformats.org/officeDocument/2006/relationships" xmlns:a="http://schemas.openxmlformats.org/drawingml/2006/main" r:embed="R18575ce5d9d843b3">
             <a:alphaModFix/>
           </a:blip>
           <a:srcRect xmlns:a="http://schemas.openxmlformats.org/drawingml/2006/main" l="0" t="0" r="0" b="0"/>
@@ -29753,7 +29753,7 @@
           <p:nvPr/>
         </p:nvPicPr>
         <p:blipFill rotWithShape="1">
-          <a:blip xmlns:r="http://schemas.openxmlformats.org/officeDocument/2006/relationships" xmlns:a="http://schemas.openxmlformats.org/drawingml/2006/main" r:embed="Rc83f271572404157">
+          <a:blip xmlns:r="http://schemas.openxmlformats.org/officeDocument/2006/relationships" xmlns:a="http://schemas.openxmlformats.org/drawingml/2006/main" r:embed="R18575ce5d9d843b3">
             <a:alphaModFix/>
           </a:blip>
           <a:srcRect xmlns:a="http://schemas.openxmlformats.org/drawingml/2006/main" l="0" t="0" r="0" b="0"/>
@@ -31792,7 +31792,7 @@
           <p:nvPr/>
         </p:nvPicPr>
         <p:blipFill rotWithShape="1">
-          <a:blip xmlns:r="http://schemas.openxmlformats.org/officeDocument/2006/relationships" xmlns:a="http://schemas.openxmlformats.org/drawingml/2006/main" r:embed="Rb2952828c72c4c41">
+          <a:blip xmlns:r="http://schemas.openxmlformats.org/officeDocument/2006/relationships" xmlns:a="http://schemas.openxmlformats.org/drawingml/2006/main" r:embed="Recaf872d318c49ae">
             <a:alphaModFix/>
           </a:blip>
           <a:srcRect xmlns:a="http://schemas.openxmlformats.org/drawingml/2006/main" l="0" t="0" r="0" b="0"/>
@@ -31820,7 +31820,7 @@
           <p:nvPr/>
         </p:nvPicPr>
         <p:blipFill rotWithShape="1">
-          <a:blip xmlns:r="http://schemas.openxmlformats.org/officeDocument/2006/relationships" xmlns:a="http://schemas.openxmlformats.org/drawingml/2006/main" r:embed="Rb2952828c72c4c41">
+          <a:blip xmlns:r="http://schemas.openxmlformats.org/officeDocument/2006/relationships" xmlns:a="http://schemas.openxmlformats.org/drawingml/2006/main" r:embed="Recaf872d318c49ae">
             <a:alphaModFix/>
           </a:blip>
           <a:srcRect xmlns:a="http://schemas.openxmlformats.org/drawingml/2006/main" l="0" t="0" r="0" b="0"/>
@@ -31848,7 +31848,7 @@
           <p:nvPr/>
         </p:nvPicPr>
         <p:blipFill rotWithShape="1">
-          <a:blip xmlns:r="http://schemas.openxmlformats.org/officeDocument/2006/relationships" xmlns:a="http://schemas.openxmlformats.org/drawingml/2006/main" r:embed="Rb2952828c72c4c41">
+          <a:blip xmlns:r="http://schemas.openxmlformats.org/officeDocument/2006/relationships" xmlns:a="http://schemas.openxmlformats.org/drawingml/2006/main" r:embed="Recaf872d318c49ae">
             <a:alphaModFix/>
           </a:blip>
           <a:srcRect xmlns:a="http://schemas.openxmlformats.org/drawingml/2006/main" l="0" t="0" r="0" b="0"/>
@@ -31876,7 +31876,7 @@
           <p:nvPr/>
         </p:nvPicPr>
         <p:blipFill rotWithShape="1">
-          <a:blip xmlns:r="http://schemas.openxmlformats.org/officeDocument/2006/relationships" xmlns:a="http://schemas.openxmlformats.org/drawingml/2006/main" r:embed="Rb2952828c72c4c41">
+          <a:blip xmlns:r="http://schemas.openxmlformats.org/officeDocument/2006/relationships" xmlns:a="http://schemas.openxmlformats.org/drawingml/2006/main" r:embed="Recaf872d318c49ae">
             <a:alphaModFix/>
           </a:blip>
           <a:srcRect xmlns:a="http://schemas.openxmlformats.org/drawingml/2006/main" l="0" t="0" r="0" b="0"/>

</xml_diff>